<commit_message>
Add business map and chapters on more internet business types
New chapters 22-29: a six-axis map for classifying internet
businesses, marketplace sellers (consignment, buying agents,
crowdfunding), creator businesses, mobile apps, knowledge products
and freelance services, matching and booking platforms, AI
services, and a map of regulated industries and banned online
products. README, glossary, quiz and the deck (now 37 slides) are
updated to match.

Co-Authored-By: Claude Opus 5.5 <noreply@anthropic.com>
Claude-Session: https://claude.ai/code/session_01Tuz8P5EzhzAFozhesRbd5A
</commit_message>
<xml_diff>
--- a/slides/internet-business-101.pptx
+++ b/slides/internet-business-101.pptx
@@ -35,9 +35,16 @@
     <p:sldId id="283" r:id="rId29"/>
     <p:sldId id="284" r:id="rId30"/>
     <p:sldId id="285" r:id="rId31"/>
+    <p:sldId id="286" r:id="rId32"/>
+    <p:sldId id="287" r:id="rId33"/>
+    <p:sldId id="288" r:id="rId34"/>
+    <p:sldId id="289" r:id="rId35"/>
+    <p:sldId id="290" r:id="rId36"/>
+    <p:sldId id="291" r:id="rId37"/>
+    <p:sldId id="292" r:id="rId38"/>
   </p:sldIdLst>
   <p:notesMasterIdLst>
-    <p:notesMasterId r:id="rId32"/>
+    <p:notesMasterId r:id="rId39"/>
   </p:notesMasterIdLst>
   <p:sldSz cx="9144000" cy="5143500"/>
   <p:notesSz cx="5143500" cy="9144000"/>
@@ -136,13 +143,13 @@
   <p:extLst>
     <p:ext uri="{521415D9-36F7-43E2-AB2F-B90AF26B5E84}">
       <p14:sectionLst xmlns:p14="http://schemas.microsoft.com/office/powerpoint/2010/main">
-        <p14:section name="시작" id="{993be9e3-f1eb-c74b-f90c-648158245bd9}">
+        <p14:section name="시작" id="{718abb55-2b60-5903-dabc-f92c232a3ef0}">
           <p14:sldIdLst>
             <p14:sldId id="256"/>
             <p14:sldId id="257"/>
           </p14:sldIdLst>
         </p14:section>
-        <p14:section name="큰 그림" id="{3b2796d0-1d60-e3ae-b2a1-8f0bed7188ea}">
+        <p14:section name="큰 그림" id="{b1918885-5800-00e5-b090-3093ad1b94d9}">
           <p14:sldIdLst>
             <p14:sldId id="258"/>
             <p14:sldId id="259"/>
@@ -151,13 +158,13 @@
             <p14:sldId id="262"/>
           </p14:sldIdLst>
         </p14:section>
-        <p14:section name="만들기" id="{e3221399-a844-e0e1-e7fc-6766a838d3df}">
+        <p14:section name="만들기" id="{838c3b18-ad49-08a3-d5bc-ab5344cb1a1e}">
           <p14:sldIdLst>
             <p14:sldId id="263"/>
             <p14:sldId id="264"/>
           </p14:sldIdLst>
         </p14:section>
-        <p14:section name="운영하기" id="{361b6f21-d1fd-abf4-55ba-dabb88201665}">
+        <p14:section name="운영하기" id="{c0bcc65a-2691-dd52-5d6e-7c47c9412fbb}">
           <p14:sldIdLst>
             <p14:sldId id="265"/>
             <p14:sldId id="266"/>
@@ -171,18 +178,18 @@
             <p14:sldId id="274"/>
           </p14:sldIdLst>
         </p14:section>
-        <p14:section name="키우기" id="{152c18dd-6f3f-757d-3988-9141e2c5503b}">
+        <p14:section name="키우기" id="{890df497-0bd3-61b4-8889-25dd9b6edc47}">
           <p14:sldIdLst>
             <p14:sldId id="275"/>
             <p14:sldId id="276"/>
           </p14:sldIdLst>
         </p14:section>
-        <p14:section name="실전" id="{e65bb268-4382-fd84-8c78-f1fd68ab2e99}">
+        <p14:section name="실전" id="{72f7af09-f111-c1ea-02b8-98601458f034}">
           <p14:sldIdLst>
             <p14:sldId id="277"/>
           </p14:sldIdLst>
         </p14:section>
-        <p14:section name="여러 가지 사이트 사업" id="{ab389907-d15c-6da8-c312-9f40bb87336d}">
+        <p14:section name="여러 가지 사이트 사업" id="{b41d8c00-72d6-b21d-7f92-56a159d3a210}">
           <p14:sldIdLst>
             <p14:sldId id="278"/>
             <p14:sldId id="279"/>
@@ -191,7 +198,18 @@
             <p14:sldId id="282"/>
             <p14:sldId id="283"/>
             <p14:sldId id="284"/>
+          </p14:sldIdLst>
+        </p14:section>
+        <p14:section name="더 넓은 분류" id="{e8f1588e-68d9-f72e-d53d-d652945b55e1}">
+          <p14:sldIdLst>
             <p14:sldId id="285"/>
+            <p14:sldId id="286"/>
+            <p14:sldId id="287"/>
+            <p14:sldId id="288"/>
+            <p14:sldId id="289"/>
+            <p14:sldId id="290"/>
+            <p14:sldId id="291"/>
+            <p14:sldId id="292"/>
           </p14:sldIdLst>
         </p14:section>
       </p14:sectionLst>
@@ -855,6 +873,298 @@
 </c:chartSpace>
 </file>
 
+<file path=ppt/charts/chart3.xml><?xml version="1.0" encoding="utf-8"?>
+<c:chartSpace xmlns:c="http://schemas.openxmlformats.org/drawingml/2006/chart" xmlns:a="http://schemas.openxmlformats.org/drawingml/2006/main" xmlns:r="http://schemas.openxmlformats.org/officeDocument/2006/relationships">
+  <c:date1904 val="0"/>
+  <c:roundedCorners val="1"/>
+  <c:chart>
+    <c:title>
+      <c:tx>
+        <c:rich>
+          <a:bodyPr/>
+          <a:lstStyle/>
+          <a:p>
+            <a:pPr>
+              <a:defRPr sz="1300" b="0" i="0" u="none" strike="noStrike">
+                <a:solidFill>
+                  <a:srgbClr val="1B2B2E"/>
+                </a:solidFill>
+                <a:latin typeface="+mn-lt"/>
+              </a:defRPr>
+            </a:pPr>
+            <a:r>
+              <a:rPr sz="1300" b="0" i="0" u="none" strike="noStrike">
+                <a:solidFill>
+                  <a:srgbClr val="1B2B2E"/>
+                </a:solidFill>
+                <a:latin typeface="+mn-lt"/>
+              </a:rPr>
+              <a:t>월 1만 원 구독 서비스 (예시)</a:t>
+            </a:r>
+          </a:p>
+        </c:rich>
+      </c:tx>
+      <c:layout/>
+      <c:overlay val="0"/>
+    </c:title>
+    <c:autoTitleDeleted val="0"/>
+    <c:plotArea>
+      <c:layout/>
+      <c:barChart>
+        <c:barDir val="bar"/>
+        <c:grouping val="clustered"/>
+        <c:varyColors val="0"/>
+        <c:ser>
+          <c:idx val="0"/>
+          <c:order val="0"/>
+          <c:tx>
+            <c:strRef>
+              <c:f>Sheet1!$B$1</c:f>
+              <c:strCache>
+                <c:ptCount val="1"/>
+                <c:pt idx="0">
+                  <c:v>원</c:v>
+                </c:pt>
+              </c:strCache>
+            </c:strRef>
+          </c:tx>
+          <c:spPr>
+            <a:solidFill>
+              <a:srgbClr val="1F4E4A"/>
+            </a:solidFill>
+            <a:effectLst/>
+          </c:spPr>
+          <c:invertIfNegative val="0"/>
+          <c:dLbls>
+            <c:numFmt formatCode="#,##0" sourceLinked="0"/>
+            <c:txPr>
+              <a:bodyPr/>
+              <a:lstStyle/>
+              <a:p>
+                <a:pPr>
+                  <a:defRPr b="0" i="0" strike="noStrike" sz="1100" u="none">
+                    <a:solidFill>
+                      <a:srgbClr val="1B2B2E"/>
+                    </a:solidFill>
+                    <a:latin typeface="+mn-lt"/>
+                  </a:defRPr>
+                </a:pPr>
+              </a:p>
+            </c:txPr>
+            <c:showLegendKey val="0"/>
+            <c:showVal val="1"/>
+            <c:showCatName val="0"/>
+            <c:showSerName val="0"/>
+            <c:showPercent val="0"/>
+            <c:showBubbleSize val="0"/>
+            <c:showLeaderLines val="0"/>
+          </c:dLbls>
+          <c:dPt>
+            <c:idx val="0"/>
+            <c:invertIfNegative val="0"/>
+            <c:bubble3D val="0"/>
+            <c:spPr>
+              <a:solidFill>
+                <a:srgbClr val="1F4E4A"/>
+              </a:solidFill>
+              <a:effectLst/>
+            </c:spPr>
+          </c:dPt>
+          <c:dPt>
+            <c:idx val="1"/>
+            <c:invertIfNegative val="0"/>
+            <c:bubble3D val="0"/>
+            <c:spPr>
+              <a:solidFill>
+                <a:srgbClr val="2E9C8F"/>
+              </a:solidFill>
+              <a:effectLst/>
+            </c:spPr>
+          </c:dPt>
+          <c:dPt>
+            <c:idx val="2"/>
+            <c:invertIfNegative val="0"/>
+            <c:bubble3D val="0"/>
+            <c:spPr>
+              <a:solidFill>
+                <a:srgbClr val="D9534F"/>
+              </a:solidFill>
+              <a:effectLst/>
+            </c:spPr>
+          </c:dPt>
+          <c:cat>
+            <c:multiLvlStrRef>
+              <c:f>Sheet1!$A$2:$A$4</c:f>
+              <c:multiLvlStrCache>
+                <c:ptCount val="3"/>
+                <c:lvl>
+                  <c:pt idx="0">
+                    <c:v>구독료</c:v>
+                  </c:pt>
+                  <c:pt idx="1">
+                    <c:v>적게 쓰는 손님 AI 비용</c:v>
+                  </c:pt>
+                  <c:pt idx="2">
+                    <c:v>많이 쓰는 손님 AI 비용</c:v>
+                  </c:pt>
+                </c:lvl>
+              </c:multiLvlStrCache>
+            </c:multiLvlStrRef>
+          </c:cat>
+          <c:val>
+            <c:numRef>
+              <c:f>Sheet1!$B$2:$B$4</c:f>
+              <c:numCache>
+                <c:formatCode>General</c:formatCode>
+                <c:ptCount val="3"/>
+                <c:pt idx="0">
+                  <c:v>10000</c:v>
+                </c:pt>
+                <c:pt idx="1">
+                  <c:v>3000</c:v>
+                </c:pt>
+                <c:pt idx="2">
+                  <c:v>15000</c:v>
+                </c:pt>
+              </c:numCache>
+            </c:numRef>
+          </c:val>
+        </c:ser>
+        <c:dLbls>
+          <c:numFmt formatCode="#,##0" sourceLinked="0"/>
+          <c:txPr>
+            <a:bodyPr/>
+            <a:lstStyle/>
+            <a:p>
+              <a:pPr>
+                <a:defRPr b="0" i="0" strike="noStrike" sz="1100" u="none">
+                  <a:solidFill>
+                    <a:srgbClr val="1B2B2E"/>
+                  </a:solidFill>
+                  <a:latin typeface="+mn-lt"/>
+                </a:defRPr>
+              </a:pPr>
+            </a:p>
+          </c:txPr>
+          <c:showLegendKey val="0"/>
+          <c:showVal val="1"/>
+          <c:showCatName val="0"/>
+          <c:showSerName val="0"/>
+          <c:showPercent val="0"/>
+          <c:showBubbleSize val="0"/>
+          <c:showLeaderLines val="0"/>
+        </c:dLbls>
+        <c:gapWidth val="150"/>
+        <c:overlap val="0"/>
+        <c:axId val="2094734554"/>
+        <c:axId val="2094734552"/>
+        <c:axId val="2094734556"/>
+      </c:barChart>
+      <c:catAx>
+        <c:axId val="2094734554"/>
+        <c:scaling>
+          <c:orientation val="maxMin"/>
+        </c:scaling>
+        <c:delete val="0"/>
+        <c:axPos val="l"/>
+        <c:numFmt formatCode="General" sourceLinked="1"/>
+        <c:majorTickMark val="out"/>
+        <c:minorTickMark val="none"/>
+        <c:tickLblPos val="nextTo"/>
+        <c:spPr>
+          <a:ln w="12700" cap="flat">
+            <a:solidFill>
+              <a:srgbClr val="888888"/>
+            </a:solidFill>
+            <a:prstDash val="solid"/>
+            <a:round/>
+          </a:ln>
+        </c:spPr>
+        <c:txPr>
+          <a:bodyPr/>
+          <a:lstStyle/>
+          <a:p>
+            <a:pPr>
+              <a:defRPr sz="1100" b="0" i="0" u="none" strike="noStrike">
+                <a:solidFill>
+                  <a:srgbClr val="1B2B2E"/>
+                </a:solidFill>
+                <a:latin typeface="+mn-lt"/>
+              </a:defRPr>
+            </a:pPr>
+            <a:endParaRPr lang="en-US"/>
+          </a:p>
+        </c:txPr>
+        <c:crossAx val="2094734552"/>
+        <c:crosses val="autoZero"/>
+        <c:auto val="1"/>
+        <c:lblAlgn val="ctr"/>
+        <c:noMultiLvlLbl val="1"/>
+      </c:catAx>
+      <c:valAx>
+        <c:axId val="2094734552"/>
+        <c:scaling>
+          <c:orientation val="minMax"/>
+          <c:max val="19000"/>
+        </c:scaling>
+        <c:delete val="1"/>
+        <c:axPos val="b"/>
+        <c:numFmt formatCode="General" sourceLinked="0"/>
+        <c:majorTickMark val="out"/>
+        <c:minorTickMark val="none"/>
+        <c:tickLblPos val="low"/>
+        <c:spPr>
+          <a:ln w="12700" cap="flat">
+            <a:solidFill>
+              <a:srgbClr val="888888"/>
+            </a:solidFill>
+            <a:prstDash val="solid"/>
+            <a:round/>
+          </a:ln>
+        </c:spPr>
+        <c:txPr>
+          <a:bodyPr/>
+          <a:lstStyle/>
+          <a:p>
+            <a:pPr>
+              <a:defRPr sz="1200" b="0" i="0" u="none" strike="noStrike">
+                <a:solidFill>
+                  <a:srgbClr val="000000"/>
+                </a:solidFill>
+                <a:latin typeface="Arial"/>
+              </a:defRPr>
+            </a:pPr>
+            <a:endParaRPr lang="en-US"/>
+          </a:p>
+        </c:txPr>
+        <c:crossAx val="2094734554"/>
+        <c:crosses val="autoZero"/>
+        <c:crossBetween val="between"/>
+      </c:valAx>
+      <c:spPr>
+        <a:noFill/>
+        <a:ln>
+          <a:noFill/>
+        </a:ln>
+        <a:effectLst/>
+      </c:spPr>
+    </c:plotArea>
+    <c:plotVisOnly val="1"/>
+    <c:dispBlanksAs val="span"/>
+  </c:chart>
+  <c:spPr>
+    <a:noFill/>
+    <a:ln>
+      <a:noFill/>
+    </a:ln>
+    <a:effectLst/>
+  </c:spPr>
+  <c:externalData r:id="rId1">
+    <c:autoUpdate val="0"/>
+  </c:externalData>
+</c:chartSpace>
+</file>
+
 <file path=ppt/notesMasters/notesMaster1.xml><?xml version="1.0" encoding="utf-8"?>
 <p:notesMaster xmlns:a="http://schemas.openxmlformats.org/drawingml/2006/main" xmlns:r="http://schemas.openxmlformats.org/officeDocument/2006/relationships" xmlns:p="http://schemas.openxmlformats.org/presentationml/2006/main">
   <p:cSld>
@@ -3298,6 +3608,622 @@
             <a:fld id="{F7021451-1387-4CA6-816F-3879F97B5CBC}" type="slidenum">
               <a:rPr lang="en-US"/>
               <a:t>30</a:t>
+            </a:fld>
+            <a:endParaRPr lang="en-US"/>
+          </a:p>
+        </p:txBody>
+      </p:sp>
+    </p:spTree>
+    <p:extLst>
+      <p:ext uri="{BB962C8B-B14F-4D97-AF65-F5344CB8AC3E}">
+        <p14:creationId xmlns:p14="http://schemas.microsoft.com/office/powerpoint/2010/main" val="1024086991"/>
+      </p:ext>
+    </p:extLst>
+  </p:cSld>
+  <p:clrMapOvr>
+    <a:masterClrMapping/>
+  </p:clrMapOvr>
+</p:notes>
+</file>
+
+<file path=ppt/notesSlides/notesSlide31.xml><?xml version="1.0" encoding="utf-8"?>
+<p:notes xmlns:a="http://schemas.openxmlformats.org/drawingml/2006/main" xmlns:r="http://schemas.openxmlformats.org/officeDocument/2006/relationships" xmlns:p="http://schemas.openxmlformats.org/presentationml/2006/main">
+  <p:cSld>
+    <p:spTree>
+      <p:nvGrpSpPr>
+        <p:cNvPr id="1" name=""/>
+        <p:cNvGrpSpPr/>
+        <p:nvPr/>
+      </p:nvGrpSpPr>
+      <p:grpSpPr>
+        <a:xfrm>
+          <a:off x="0" y="0"/>
+          <a:ext cx="0" cy="0"/>
+          <a:chOff x="0" y="0"/>
+          <a:chExt cx="0" cy="0"/>
+        </a:xfrm>
+      </p:grpSpPr>
+      <p:sp>
+        <p:nvSpPr>
+          <p:cNvPr id="2" name="Slide Image Placeholder 1"/>
+          <p:cNvSpPr>
+            <a:spLocks noGrp="1" noRot="1" noChangeAspect="1"/>
+          </p:cNvSpPr>
+          <p:nvPr>
+            <p:ph type="sldImg"/>
+          </p:nvPr>
+        </p:nvSpPr>
+        <p:spPr/>
+      </p:sp>
+      <p:sp>
+        <p:nvSpPr>
+          <p:cNvPr id="3" name="Notes Placeholder 2"/>
+          <p:cNvSpPr>
+            <a:spLocks noGrp="1"/>
+          </p:cNvSpPr>
+          <p:nvPr>
+            <p:ph type="body" idx="1"/>
+          </p:nvPr>
+        </p:nvSpPr>
+        <p:spPr/>
+        <p:txBody>
+          <a:bodyPr/>
+          <a:lstStyle/>
+          <a:p>
+            <a:r>
+              <a:rPr lang="en-US" dirty="0"/>
+              <a:t/>
+            </a:r>
+            <a:endParaRPr lang="en-US" dirty="0"/>
+          </a:p>
+        </p:txBody>
+      </p:sp>
+      <p:sp>
+        <p:nvSpPr>
+          <p:cNvPr id="4" name="Slide Number Placeholder 3"/>
+          <p:cNvSpPr>
+            <a:spLocks noGrp="1"/>
+          </p:cNvSpPr>
+          <p:nvPr>
+            <p:ph type="sldNum" sz="quarter" idx="10"/>
+          </p:nvPr>
+        </p:nvSpPr>
+        <p:spPr/>
+        <p:txBody>
+          <a:bodyPr/>
+          <a:lstStyle/>
+          <a:p>
+            <a:fld id="{F7021451-1387-4CA6-816F-3879F97B5CBC}" type="slidenum">
+              <a:rPr lang="en-US"/>
+              <a:t>31</a:t>
+            </a:fld>
+            <a:endParaRPr lang="en-US"/>
+          </a:p>
+        </p:txBody>
+      </p:sp>
+    </p:spTree>
+    <p:extLst>
+      <p:ext uri="{BB962C8B-B14F-4D97-AF65-F5344CB8AC3E}">
+        <p14:creationId xmlns:p14="http://schemas.microsoft.com/office/powerpoint/2010/main" val="1024086991"/>
+      </p:ext>
+    </p:extLst>
+  </p:cSld>
+  <p:clrMapOvr>
+    <a:masterClrMapping/>
+  </p:clrMapOvr>
+</p:notes>
+</file>
+
+<file path=ppt/notesSlides/notesSlide32.xml><?xml version="1.0" encoding="utf-8"?>
+<p:notes xmlns:a="http://schemas.openxmlformats.org/drawingml/2006/main" xmlns:r="http://schemas.openxmlformats.org/officeDocument/2006/relationships" xmlns:p="http://schemas.openxmlformats.org/presentationml/2006/main">
+  <p:cSld>
+    <p:spTree>
+      <p:nvGrpSpPr>
+        <p:cNvPr id="1" name=""/>
+        <p:cNvGrpSpPr/>
+        <p:nvPr/>
+      </p:nvGrpSpPr>
+      <p:grpSpPr>
+        <a:xfrm>
+          <a:off x="0" y="0"/>
+          <a:ext cx="0" cy="0"/>
+          <a:chOff x="0" y="0"/>
+          <a:chExt cx="0" cy="0"/>
+        </a:xfrm>
+      </p:grpSpPr>
+      <p:sp>
+        <p:nvSpPr>
+          <p:cNvPr id="2" name="Slide Image Placeholder 1"/>
+          <p:cNvSpPr>
+            <a:spLocks noGrp="1" noRot="1" noChangeAspect="1"/>
+          </p:cNvSpPr>
+          <p:nvPr>
+            <p:ph type="sldImg"/>
+          </p:nvPr>
+        </p:nvSpPr>
+        <p:spPr/>
+      </p:sp>
+      <p:sp>
+        <p:nvSpPr>
+          <p:cNvPr id="3" name="Notes Placeholder 2"/>
+          <p:cNvSpPr>
+            <a:spLocks noGrp="1"/>
+          </p:cNvSpPr>
+          <p:nvPr>
+            <p:ph type="body" idx="1"/>
+          </p:nvPr>
+        </p:nvSpPr>
+        <p:spPr/>
+        <p:txBody>
+          <a:bodyPr/>
+          <a:lstStyle/>
+          <a:p>
+            <a:r>
+              <a:rPr lang="en-US" dirty="0"/>
+              <a:t/>
+            </a:r>
+            <a:endParaRPr lang="en-US" dirty="0"/>
+          </a:p>
+        </p:txBody>
+      </p:sp>
+      <p:sp>
+        <p:nvSpPr>
+          <p:cNvPr id="4" name="Slide Number Placeholder 3"/>
+          <p:cNvSpPr>
+            <a:spLocks noGrp="1"/>
+          </p:cNvSpPr>
+          <p:nvPr>
+            <p:ph type="sldNum" sz="quarter" idx="10"/>
+          </p:nvPr>
+        </p:nvSpPr>
+        <p:spPr/>
+        <p:txBody>
+          <a:bodyPr/>
+          <a:lstStyle/>
+          <a:p>
+            <a:fld id="{F7021451-1387-4CA6-816F-3879F97B5CBC}" type="slidenum">
+              <a:rPr lang="en-US"/>
+              <a:t>32</a:t>
+            </a:fld>
+            <a:endParaRPr lang="en-US"/>
+          </a:p>
+        </p:txBody>
+      </p:sp>
+    </p:spTree>
+    <p:extLst>
+      <p:ext uri="{BB962C8B-B14F-4D97-AF65-F5344CB8AC3E}">
+        <p14:creationId xmlns:p14="http://schemas.microsoft.com/office/powerpoint/2010/main" val="1024086991"/>
+      </p:ext>
+    </p:extLst>
+  </p:cSld>
+  <p:clrMapOvr>
+    <a:masterClrMapping/>
+  </p:clrMapOvr>
+</p:notes>
+</file>
+
+<file path=ppt/notesSlides/notesSlide33.xml><?xml version="1.0" encoding="utf-8"?>
+<p:notes xmlns:a="http://schemas.openxmlformats.org/drawingml/2006/main" xmlns:r="http://schemas.openxmlformats.org/officeDocument/2006/relationships" xmlns:p="http://schemas.openxmlformats.org/presentationml/2006/main">
+  <p:cSld>
+    <p:spTree>
+      <p:nvGrpSpPr>
+        <p:cNvPr id="1" name=""/>
+        <p:cNvGrpSpPr/>
+        <p:nvPr/>
+      </p:nvGrpSpPr>
+      <p:grpSpPr>
+        <a:xfrm>
+          <a:off x="0" y="0"/>
+          <a:ext cx="0" cy="0"/>
+          <a:chOff x="0" y="0"/>
+          <a:chExt cx="0" cy="0"/>
+        </a:xfrm>
+      </p:grpSpPr>
+      <p:sp>
+        <p:nvSpPr>
+          <p:cNvPr id="2" name="Slide Image Placeholder 1"/>
+          <p:cNvSpPr>
+            <a:spLocks noGrp="1" noRot="1" noChangeAspect="1"/>
+          </p:cNvSpPr>
+          <p:nvPr>
+            <p:ph type="sldImg"/>
+          </p:nvPr>
+        </p:nvSpPr>
+        <p:spPr/>
+      </p:sp>
+      <p:sp>
+        <p:nvSpPr>
+          <p:cNvPr id="3" name="Notes Placeholder 2"/>
+          <p:cNvSpPr>
+            <a:spLocks noGrp="1"/>
+          </p:cNvSpPr>
+          <p:nvPr>
+            <p:ph type="body" idx="1"/>
+          </p:nvPr>
+        </p:nvSpPr>
+        <p:spPr/>
+        <p:txBody>
+          <a:bodyPr/>
+          <a:lstStyle/>
+          <a:p>
+            <a:r>
+              <a:rPr lang="en-US" dirty="0"/>
+              <a:t/>
+            </a:r>
+            <a:endParaRPr lang="en-US" dirty="0"/>
+          </a:p>
+        </p:txBody>
+      </p:sp>
+      <p:sp>
+        <p:nvSpPr>
+          <p:cNvPr id="4" name="Slide Number Placeholder 3"/>
+          <p:cNvSpPr>
+            <a:spLocks noGrp="1"/>
+          </p:cNvSpPr>
+          <p:nvPr>
+            <p:ph type="sldNum" sz="quarter" idx="10"/>
+          </p:nvPr>
+        </p:nvSpPr>
+        <p:spPr/>
+        <p:txBody>
+          <a:bodyPr/>
+          <a:lstStyle/>
+          <a:p>
+            <a:fld id="{F7021451-1387-4CA6-816F-3879F97B5CBC}" type="slidenum">
+              <a:rPr lang="en-US"/>
+              <a:t>33</a:t>
+            </a:fld>
+            <a:endParaRPr lang="en-US"/>
+          </a:p>
+        </p:txBody>
+      </p:sp>
+    </p:spTree>
+    <p:extLst>
+      <p:ext uri="{BB962C8B-B14F-4D97-AF65-F5344CB8AC3E}">
+        <p14:creationId xmlns:p14="http://schemas.microsoft.com/office/powerpoint/2010/main" val="1024086991"/>
+      </p:ext>
+    </p:extLst>
+  </p:cSld>
+  <p:clrMapOvr>
+    <a:masterClrMapping/>
+  </p:clrMapOvr>
+</p:notes>
+</file>
+
+<file path=ppt/notesSlides/notesSlide34.xml><?xml version="1.0" encoding="utf-8"?>
+<p:notes xmlns:a="http://schemas.openxmlformats.org/drawingml/2006/main" xmlns:r="http://schemas.openxmlformats.org/officeDocument/2006/relationships" xmlns:p="http://schemas.openxmlformats.org/presentationml/2006/main">
+  <p:cSld>
+    <p:spTree>
+      <p:nvGrpSpPr>
+        <p:cNvPr id="1" name=""/>
+        <p:cNvGrpSpPr/>
+        <p:nvPr/>
+      </p:nvGrpSpPr>
+      <p:grpSpPr>
+        <a:xfrm>
+          <a:off x="0" y="0"/>
+          <a:ext cx="0" cy="0"/>
+          <a:chOff x="0" y="0"/>
+          <a:chExt cx="0" cy="0"/>
+        </a:xfrm>
+      </p:grpSpPr>
+      <p:sp>
+        <p:nvSpPr>
+          <p:cNvPr id="2" name="Slide Image Placeholder 1"/>
+          <p:cNvSpPr>
+            <a:spLocks noGrp="1" noRot="1" noChangeAspect="1"/>
+          </p:cNvSpPr>
+          <p:nvPr>
+            <p:ph type="sldImg"/>
+          </p:nvPr>
+        </p:nvSpPr>
+        <p:spPr/>
+      </p:sp>
+      <p:sp>
+        <p:nvSpPr>
+          <p:cNvPr id="3" name="Notes Placeholder 2"/>
+          <p:cNvSpPr>
+            <a:spLocks noGrp="1"/>
+          </p:cNvSpPr>
+          <p:nvPr>
+            <p:ph type="body" idx="1"/>
+          </p:nvPr>
+        </p:nvSpPr>
+        <p:spPr/>
+        <p:txBody>
+          <a:bodyPr/>
+          <a:lstStyle/>
+          <a:p>
+            <a:r>
+              <a:rPr lang="en-US" dirty="0"/>
+              <a:t/>
+            </a:r>
+            <a:endParaRPr lang="en-US" dirty="0"/>
+          </a:p>
+        </p:txBody>
+      </p:sp>
+      <p:sp>
+        <p:nvSpPr>
+          <p:cNvPr id="4" name="Slide Number Placeholder 3"/>
+          <p:cNvSpPr>
+            <a:spLocks noGrp="1"/>
+          </p:cNvSpPr>
+          <p:nvPr>
+            <p:ph type="sldNum" sz="quarter" idx="10"/>
+          </p:nvPr>
+        </p:nvSpPr>
+        <p:spPr/>
+        <p:txBody>
+          <a:bodyPr/>
+          <a:lstStyle/>
+          <a:p>
+            <a:fld id="{F7021451-1387-4CA6-816F-3879F97B5CBC}" type="slidenum">
+              <a:rPr lang="en-US"/>
+              <a:t>34</a:t>
+            </a:fld>
+            <a:endParaRPr lang="en-US"/>
+          </a:p>
+        </p:txBody>
+      </p:sp>
+    </p:spTree>
+    <p:extLst>
+      <p:ext uri="{BB962C8B-B14F-4D97-AF65-F5344CB8AC3E}">
+        <p14:creationId xmlns:p14="http://schemas.microsoft.com/office/powerpoint/2010/main" val="1024086991"/>
+      </p:ext>
+    </p:extLst>
+  </p:cSld>
+  <p:clrMapOvr>
+    <a:masterClrMapping/>
+  </p:clrMapOvr>
+</p:notes>
+</file>
+
+<file path=ppt/notesSlides/notesSlide35.xml><?xml version="1.0" encoding="utf-8"?>
+<p:notes xmlns:a="http://schemas.openxmlformats.org/drawingml/2006/main" xmlns:r="http://schemas.openxmlformats.org/officeDocument/2006/relationships" xmlns:p="http://schemas.openxmlformats.org/presentationml/2006/main">
+  <p:cSld>
+    <p:spTree>
+      <p:nvGrpSpPr>
+        <p:cNvPr id="1" name=""/>
+        <p:cNvGrpSpPr/>
+        <p:nvPr/>
+      </p:nvGrpSpPr>
+      <p:grpSpPr>
+        <a:xfrm>
+          <a:off x="0" y="0"/>
+          <a:ext cx="0" cy="0"/>
+          <a:chOff x="0" y="0"/>
+          <a:chExt cx="0" cy="0"/>
+        </a:xfrm>
+      </p:grpSpPr>
+      <p:sp>
+        <p:nvSpPr>
+          <p:cNvPr id="2" name="Slide Image Placeholder 1"/>
+          <p:cNvSpPr>
+            <a:spLocks noGrp="1" noRot="1" noChangeAspect="1"/>
+          </p:cNvSpPr>
+          <p:nvPr>
+            <p:ph type="sldImg"/>
+          </p:nvPr>
+        </p:nvSpPr>
+        <p:spPr/>
+      </p:sp>
+      <p:sp>
+        <p:nvSpPr>
+          <p:cNvPr id="3" name="Notes Placeholder 2"/>
+          <p:cNvSpPr>
+            <a:spLocks noGrp="1"/>
+          </p:cNvSpPr>
+          <p:nvPr>
+            <p:ph type="body" idx="1"/>
+          </p:nvPr>
+        </p:nvSpPr>
+        <p:spPr/>
+        <p:txBody>
+          <a:bodyPr/>
+          <a:lstStyle/>
+          <a:p>
+            <a:r>
+              <a:rPr lang="en-US" dirty="0"/>
+              <a:t/>
+            </a:r>
+            <a:endParaRPr lang="en-US" dirty="0"/>
+          </a:p>
+        </p:txBody>
+      </p:sp>
+      <p:sp>
+        <p:nvSpPr>
+          <p:cNvPr id="4" name="Slide Number Placeholder 3"/>
+          <p:cNvSpPr>
+            <a:spLocks noGrp="1"/>
+          </p:cNvSpPr>
+          <p:nvPr>
+            <p:ph type="sldNum" sz="quarter" idx="10"/>
+          </p:nvPr>
+        </p:nvSpPr>
+        <p:spPr/>
+        <p:txBody>
+          <a:bodyPr/>
+          <a:lstStyle/>
+          <a:p>
+            <a:fld id="{F7021451-1387-4CA6-816F-3879F97B5CBC}" type="slidenum">
+              <a:rPr lang="en-US"/>
+              <a:t>35</a:t>
+            </a:fld>
+            <a:endParaRPr lang="en-US"/>
+          </a:p>
+        </p:txBody>
+      </p:sp>
+    </p:spTree>
+    <p:extLst>
+      <p:ext uri="{BB962C8B-B14F-4D97-AF65-F5344CB8AC3E}">
+        <p14:creationId xmlns:p14="http://schemas.microsoft.com/office/powerpoint/2010/main" val="1024086991"/>
+      </p:ext>
+    </p:extLst>
+  </p:cSld>
+  <p:clrMapOvr>
+    <a:masterClrMapping/>
+  </p:clrMapOvr>
+</p:notes>
+</file>
+
+<file path=ppt/notesSlides/notesSlide36.xml><?xml version="1.0" encoding="utf-8"?>
+<p:notes xmlns:a="http://schemas.openxmlformats.org/drawingml/2006/main" xmlns:r="http://schemas.openxmlformats.org/officeDocument/2006/relationships" xmlns:p="http://schemas.openxmlformats.org/presentationml/2006/main">
+  <p:cSld>
+    <p:spTree>
+      <p:nvGrpSpPr>
+        <p:cNvPr id="1" name=""/>
+        <p:cNvGrpSpPr/>
+        <p:nvPr/>
+      </p:nvGrpSpPr>
+      <p:grpSpPr>
+        <a:xfrm>
+          <a:off x="0" y="0"/>
+          <a:ext cx="0" cy="0"/>
+          <a:chOff x="0" y="0"/>
+          <a:chExt cx="0" cy="0"/>
+        </a:xfrm>
+      </p:grpSpPr>
+      <p:sp>
+        <p:nvSpPr>
+          <p:cNvPr id="2" name="Slide Image Placeholder 1"/>
+          <p:cNvSpPr>
+            <a:spLocks noGrp="1" noRot="1" noChangeAspect="1"/>
+          </p:cNvSpPr>
+          <p:nvPr>
+            <p:ph type="sldImg"/>
+          </p:nvPr>
+        </p:nvSpPr>
+        <p:spPr/>
+      </p:sp>
+      <p:sp>
+        <p:nvSpPr>
+          <p:cNvPr id="3" name="Notes Placeholder 2"/>
+          <p:cNvSpPr>
+            <a:spLocks noGrp="1"/>
+          </p:cNvSpPr>
+          <p:nvPr>
+            <p:ph type="body" idx="1"/>
+          </p:nvPr>
+        </p:nvSpPr>
+        <p:spPr/>
+        <p:txBody>
+          <a:bodyPr/>
+          <a:lstStyle/>
+          <a:p>
+            <a:r>
+              <a:rPr lang="en-US" dirty="0"/>
+              <a:t/>
+            </a:r>
+            <a:endParaRPr lang="en-US" dirty="0"/>
+          </a:p>
+        </p:txBody>
+      </p:sp>
+      <p:sp>
+        <p:nvSpPr>
+          <p:cNvPr id="4" name="Slide Number Placeholder 3"/>
+          <p:cNvSpPr>
+            <a:spLocks noGrp="1"/>
+          </p:cNvSpPr>
+          <p:nvPr>
+            <p:ph type="sldNum" sz="quarter" idx="10"/>
+          </p:nvPr>
+        </p:nvSpPr>
+        <p:spPr/>
+        <p:txBody>
+          <a:bodyPr/>
+          <a:lstStyle/>
+          <a:p>
+            <a:fld id="{F7021451-1387-4CA6-816F-3879F97B5CBC}" type="slidenum">
+              <a:rPr lang="en-US"/>
+              <a:t>36</a:t>
+            </a:fld>
+            <a:endParaRPr lang="en-US"/>
+          </a:p>
+        </p:txBody>
+      </p:sp>
+    </p:spTree>
+    <p:extLst>
+      <p:ext uri="{BB962C8B-B14F-4D97-AF65-F5344CB8AC3E}">
+        <p14:creationId xmlns:p14="http://schemas.microsoft.com/office/powerpoint/2010/main" val="1024086991"/>
+      </p:ext>
+    </p:extLst>
+  </p:cSld>
+  <p:clrMapOvr>
+    <a:masterClrMapping/>
+  </p:clrMapOvr>
+</p:notes>
+</file>
+
+<file path=ppt/notesSlides/notesSlide37.xml><?xml version="1.0" encoding="utf-8"?>
+<p:notes xmlns:a="http://schemas.openxmlformats.org/drawingml/2006/main" xmlns:r="http://schemas.openxmlformats.org/officeDocument/2006/relationships" xmlns:p="http://schemas.openxmlformats.org/presentationml/2006/main">
+  <p:cSld>
+    <p:spTree>
+      <p:nvGrpSpPr>
+        <p:cNvPr id="1" name=""/>
+        <p:cNvGrpSpPr/>
+        <p:nvPr/>
+      </p:nvGrpSpPr>
+      <p:grpSpPr>
+        <a:xfrm>
+          <a:off x="0" y="0"/>
+          <a:ext cx="0" cy="0"/>
+          <a:chOff x="0" y="0"/>
+          <a:chExt cx="0" cy="0"/>
+        </a:xfrm>
+      </p:grpSpPr>
+      <p:sp>
+        <p:nvSpPr>
+          <p:cNvPr id="2" name="Slide Image Placeholder 1"/>
+          <p:cNvSpPr>
+            <a:spLocks noGrp="1" noRot="1" noChangeAspect="1"/>
+          </p:cNvSpPr>
+          <p:nvPr>
+            <p:ph type="sldImg"/>
+          </p:nvPr>
+        </p:nvSpPr>
+        <p:spPr/>
+      </p:sp>
+      <p:sp>
+        <p:nvSpPr>
+          <p:cNvPr id="3" name="Notes Placeholder 2"/>
+          <p:cNvSpPr>
+            <a:spLocks noGrp="1"/>
+          </p:cNvSpPr>
+          <p:nvPr>
+            <p:ph type="body" idx="1"/>
+          </p:nvPr>
+        </p:nvSpPr>
+        <p:spPr/>
+        <p:txBody>
+          <a:bodyPr/>
+          <a:lstStyle/>
+          <a:p>
+            <a:r>
+              <a:rPr lang="en-US" dirty="0"/>
+              <a:t/>
+            </a:r>
+            <a:endParaRPr lang="en-US" dirty="0"/>
+          </a:p>
+        </p:txBody>
+      </p:sp>
+      <p:sp>
+        <p:nvSpPr>
+          <p:cNvPr id="4" name="Slide Number Placeholder 3"/>
+          <p:cNvSpPr>
+            <a:spLocks noGrp="1"/>
+          </p:cNvSpPr>
+          <p:nvPr>
+            <p:ph type="sldNum" sz="quarter" idx="10"/>
+          </p:nvPr>
+        </p:nvSpPr>
+        <p:spPr/>
+        <p:txBody>
+          <a:bodyPr/>
+          <a:lstStyle/>
+          <a:p>
+            <a:fld id="{F7021451-1387-4CA6-816F-3879F97B5CBC}" type="slidenum">
+              <a:rPr lang="en-US"/>
+              <a:t>37</a:t>
             </a:fld>
             <a:endParaRPr lang="en-US"/>
           </a:p>
@@ -23429,6 +24355,3853 @@
                   <a:schemeClr val="bg1"/>
                 </a:solidFill>
               </a:rPr>
+              <a:t>더 넓은 분류</a:t>
+            </a:r>
+            <a:endParaRPr lang="en-US" sz="4000" dirty="0"/>
+          </a:p>
+        </p:txBody>
+      </p:sp>
+      <p:sp>
+        <p:nvSpPr>
+          <p:cNvPr id="3" name="Text 0"/>
+          <p:cNvSpPr/>
+          <p:nvPr>
+            <p:ph idx="101" type="body" hasCustomPrompt="1"/>
+          </p:nvPr>
+        </p:nvSpPr>
+        <p:spPr>
+          <a:xfrm>
+            <a:off x="548640" y="2788920"/>
+            <a:ext cx="8046720" cy="1097280"/>
+          </a:xfrm>
+          <a:prstGeom prst="rect">
+            <a:avLst/>
+          </a:prstGeom>
+          <a:noFill/>
+          <a:ln/>
+        </p:spPr>
+        <p:txBody>
+          <a:bodyPr wrap="square" lIns="0" tIns="0" rIns="0" bIns="0" rtlCol="0" anchor="t"/>
+          <a:lstStyle/>
+          <a:p>
+            <a:pPr algn="l" indent="0" marL="0">
+              <a:buNone/>
+            </a:pPr>
+            <a:r>
+              <a:rPr lang="en-US" sz="1800" dirty="0">
+                <a:solidFill>
+                  <a:schemeClr val="bg2"/>
+                </a:solidFill>
+              </a:rPr>
+              <a:t>분류 지도 · 셀러 · 크리에이터 · 앱 · 지식·외주 · 중개 플랫폼 · AI · 규제 업종 — 22–29장</a:t>
+            </a:r>
+            <a:endParaRPr lang="en-US" sz="1800" dirty="0"/>
+          </a:p>
+        </p:txBody>
+      </p:sp>
+    </p:spTree>
+  </p:cSld>
+  <p:clrMapOvr>
+    <a:masterClrMapping/>
+  </p:clrMapOvr>
+</p:sld>
+</file>
+
+<file path=ppt/slides/slide31.xml><?xml version="1.0" encoding="utf-8"?>
+<p:sld xmlns:a="http://schemas.openxmlformats.org/drawingml/2006/main" xmlns:r="http://schemas.openxmlformats.org/officeDocument/2006/relationships" xmlns:p="http://schemas.openxmlformats.org/presentationml/2006/main">
+  <p:cSld name="Slide 31">
+    <p:spTree>
+      <p:nvGrpSpPr>
+        <p:cNvPr id="1" name=""/>
+        <p:cNvGrpSpPr/>
+        <p:nvPr/>
+      </p:nvGrpSpPr>
+      <p:grpSpPr>
+        <a:xfrm>
+          <a:off x="0" y="0"/>
+          <a:ext cx="0" cy="0"/>
+          <a:chOff x="0" y="0"/>
+          <a:chExt cx="0" cy="0"/>
+        </a:xfrm>
+      </p:grpSpPr>
+      <p:sp>
+        <p:nvSpPr>
+          <p:cNvPr id="2" name="Text 0"/>
+          <p:cNvSpPr/>
+          <p:nvPr>
+            <p:ph idx="100" type="title" hasCustomPrompt="1"/>
+          </p:nvPr>
+        </p:nvSpPr>
+        <p:spPr>
+          <a:xfrm>
+            <a:off x="457200" y="274320"/>
+            <a:ext cx="8229600" cy="685800"/>
+          </a:xfrm>
+          <a:prstGeom prst="rect">
+            <a:avLst/>
+          </a:prstGeom>
+          <a:noFill/>
+          <a:ln/>
+        </p:spPr>
+        <p:txBody>
+          <a:bodyPr wrap="square" lIns="0" tIns="0" rIns="0" bIns="0" rtlCol="0" anchor="ctr"/>
+          <a:lstStyle/>
+          <a:p>
+            <a:pPr indent="0" marL="0">
+              <a:buNone/>
+            </a:pPr>
+            <a:r>
+              <a:rPr lang="en-US" sz="2800" b="1" dirty="0">
+                <a:solidFill>
+                  <a:schemeClr val="tx2"/>
+                </a:solidFill>
+              </a:rPr>
+              <a:t>사업을 나누는 6가지 기준</a:t>
+            </a:r>
+            <a:endParaRPr lang="en-US" sz="2800" dirty="0"/>
+          </a:p>
+        </p:txBody>
+      </p:sp>
+      <p:sp>
+        <p:nvSpPr>
+          <p:cNvPr id="3" name="card"/>
+          <p:cNvSpPr/>
+          <p:nvPr/>
+        </p:nvSpPr>
+        <p:spPr>
+          <a:xfrm>
+            <a:off x="457200" y="1188720"/>
+            <a:ext cx="2606040" cy="1234440"/>
+          </a:xfrm>
+          <a:prstGeom prst="roundRect">
+            <a:avLst>
+              <a:gd name="adj" fmla="val 5926"/>
+            </a:avLst>
+          </a:prstGeom>
+          <a:solidFill>
+            <a:schemeClr val="bg2"/>
+          </a:solidFill>
+          <a:ln/>
+        </p:spPr>
+      </p:sp>
+      <p:sp>
+        <p:nvSpPr>
+          <p:cNvPr id="4" name="badge1"/>
+          <p:cNvSpPr/>
+          <p:nvPr/>
+        </p:nvSpPr>
+        <p:spPr>
+          <a:xfrm>
+            <a:off x="640080" y="1371600"/>
+            <a:ext cx="384048" cy="384048"/>
+          </a:xfrm>
+          <a:prstGeom prst="ellipse">
+            <a:avLst/>
+          </a:prstGeom>
+          <a:solidFill>
+            <a:schemeClr val="tx2"/>
+          </a:solidFill>
+          <a:ln/>
+        </p:spPr>
+      </p:sp>
+      <p:sp>
+        <p:nvSpPr>
+          <p:cNvPr id="5" name="Text 3"/>
+          <p:cNvSpPr txBox="1"/>
+          <p:nvPr/>
+        </p:nvSpPr>
+        <p:spPr>
+          <a:xfrm>
+            <a:off x="640080" y="1371600"/>
+            <a:ext cx="384048" cy="384048"/>
+          </a:xfrm>
+          <a:prstGeom prst="rect">
+            <a:avLst/>
+          </a:prstGeom>
+          <a:noFill/>
+          <a:ln/>
+        </p:spPr>
+        <p:txBody>
+          <a:bodyPr wrap="square" lIns="0" tIns="0" rIns="0" bIns="0" rtlCol="0" anchor="ctr"/>
+          <a:lstStyle/>
+          <a:p>
+            <a:pPr algn="ctr" indent="0" marL="0">
+              <a:buNone/>
+            </a:pPr>
+            <a:r>
+              <a:rPr lang="en-US" sz="1400" b="1" dirty="0">
+                <a:solidFill>
+                  <a:schemeClr val="bg1"/>
+                </a:solidFill>
+              </a:rPr>
+              <a:t>1</a:t>
+            </a:r>
+            <a:endParaRPr lang="en-US" sz="1400" dirty="0"/>
+          </a:p>
+        </p:txBody>
+      </p:sp>
+      <p:sp>
+        <p:nvSpPr>
+          <p:cNvPr id="6" name="Text 4"/>
+          <p:cNvSpPr txBox="1"/>
+          <p:nvPr/>
+        </p:nvSpPr>
+        <p:spPr>
+          <a:xfrm>
+            <a:off x="1143000" y="1371600"/>
+            <a:ext cx="1828800" cy="384048"/>
+          </a:xfrm>
+          <a:prstGeom prst="rect">
+            <a:avLst/>
+          </a:prstGeom>
+          <a:noFill/>
+          <a:ln/>
+        </p:spPr>
+        <p:txBody>
+          <a:bodyPr wrap="square" lIns="0" tIns="0" rIns="0" bIns="0" rtlCol="0" anchor="ctr"/>
+          <a:lstStyle/>
+          <a:p>
+            <a:pPr indent="0" marL="0">
+              <a:buNone/>
+            </a:pPr>
+            <a:r>
+              <a:rPr lang="en-US" sz="1700" b="1" dirty="0">
+                <a:solidFill>
+                  <a:schemeClr val="tx2"/>
+                </a:solidFill>
+              </a:rPr>
+              <a:t>누구에게</a:t>
+            </a:r>
+            <a:endParaRPr lang="en-US" sz="1700" dirty="0"/>
+          </a:p>
+        </p:txBody>
+      </p:sp>
+      <p:sp>
+        <p:nvSpPr>
+          <p:cNvPr id="7" name="Text 5"/>
+          <p:cNvSpPr txBox="1"/>
+          <p:nvPr/>
+        </p:nvSpPr>
+        <p:spPr>
+          <a:xfrm>
+            <a:off x="640080" y="1874520"/>
+            <a:ext cx="2286000" cy="457200"/>
+          </a:xfrm>
+          <a:prstGeom prst="rect">
+            <a:avLst/>
+          </a:prstGeom>
+          <a:noFill/>
+          <a:ln/>
+        </p:spPr>
+        <p:txBody>
+          <a:bodyPr wrap="square" lIns="0" tIns="0" rIns="0" bIns="0" rtlCol="0" anchor="t"/>
+          <a:lstStyle/>
+          <a:p>
+            <a:pPr indent="0" marL="0">
+              <a:buNone/>
+            </a:pPr>
+            <a:r>
+              <a:rPr lang="en-US" sz="1200" dirty="0">
+                <a:solidFill>
+                  <a:schemeClr val="accent4"/>
+                </a:solidFill>
+              </a:rPr>
+              <a:t>B2C · B2B · C2C · B2G</a:t>
+            </a:r>
+            <a:endParaRPr lang="en-US" sz="1200" dirty="0"/>
+          </a:p>
+        </p:txBody>
+      </p:sp>
+      <p:sp>
+        <p:nvSpPr>
+          <p:cNvPr id="8" name="card"/>
+          <p:cNvSpPr/>
+          <p:nvPr/>
+        </p:nvSpPr>
+        <p:spPr>
+          <a:xfrm>
+            <a:off x="3246120" y="1188720"/>
+            <a:ext cx="2606040" cy="1234440"/>
+          </a:xfrm>
+          <a:prstGeom prst="roundRect">
+            <a:avLst>
+              <a:gd name="adj" fmla="val 5926"/>
+            </a:avLst>
+          </a:prstGeom>
+          <a:solidFill>
+            <a:schemeClr val="bg2"/>
+          </a:solidFill>
+          <a:ln/>
+        </p:spPr>
+      </p:sp>
+      <p:sp>
+        <p:nvSpPr>
+          <p:cNvPr id="9" name="badge2"/>
+          <p:cNvSpPr/>
+          <p:nvPr/>
+        </p:nvSpPr>
+        <p:spPr>
+          <a:xfrm>
+            <a:off x="3429000" y="1371600"/>
+            <a:ext cx="384048" cy="384048"/>
+          </a:xfrm>
+          <a:prstGeom prst="ellipse">
+            <a:avLst/>
+          </a:prstGeom>
+          <a:solidFill>
+            <a:schemeClr val="tx2"/>
+          </a:solidFill>
+          <a:ln/>
+        </p:spPr>
+      </p:sp>
+      <p:sp>
+        <p:nvSpPr>
+          <p:cNvPr id="10" name="Text 8"/>
+          <p:cNvSpPr txBox="1"/>
+          <p:nvPr/>
+        </p:nvSpPr>
+        <p:spPr>
+          <a:xfrm>
+            <a:off x="3429000" y="1371600"/>
+            <a:ext cx="384048" cy="384048"/>
+          </a:xfrm>
+          <a:prstGeom prst="rect">
+            <a:avLst/>
+          </a:prstGeom>
+          <a:noFill/>
+          <a:ln/>
+        </p:spPr>
+        <p:txBody>
+          <a:bodyPr wrap="square" lIns="0" tIns="0" rIns="0" bIns="0" rtlCol="0" anchor="ctr"/>
+          <a:lstStyle/>
+          <a:p>
+            <a:pPr algn="ctr" indent="0" marL="0">
+              <a:buNone/>
+            </a:pPr>
+            <a:r>
+              <a:rPr lang="en-US" sz="1400" b="1" dirty="0">
+                <a:solidFill>
+                  <a:schemeClr val="bg1"/>
+                </a:solidFill>
+              </a:rPr>
+              <a:t>2</a:t>
+            </a:r>
+            <a:endParaRPr lang="en-US" sz="1400" dirty="0"/>
+          </a:p>
+        </p:txBody>
+      </p:sp>
+      <p:sp>
+        <p:nvSpPr>
+          <p:cNvPr id="11" name="Text 9"/>
+          <p:cNvSpPr txBox="1"/>
+          <p:nvPr/>
+        </p:nvSpPr>
+        <p:spPr>
+          <a:xfrm>
+            <a:off x="3931920" y="1371600"/>
+            <a:ext cx="1828800" cy="384048"/>
+          </a:xfrm>
+          <a:prstGeom prst="rect">
+            <a:avLst/>
+          </a:prstGeom>
+          <a:noFill/>
+          <a:ln/>
+        </p:spPr>
+        <p:txBody>
+          <a:bodyPr wrap="square" lIns="0" tIns="0" rIns="0" bIns="0" rtlCol="0" anchor="ctr"/>
+          <a:lstStyle/>
+          <a:p>
+            <a:pPr indent="0" marL="0">
+              <a:buNone/>
+            </a:pPr>
+            <a:r>
+              <a:rPr lang="en-US" sz="1700" b="1" dirty="0">
+                <a:solidFill>
+                  <a:schemeClr val="tx2"/>
+                </a:solidFill>
+              </a:rPr>
+              <a:t>무엇을</a:t>
+            </a:r>
+            <a:endParaRPr lang="en-US" sz="1700" dirty="0"/>
+          </a:p>
+        </p:txBody>
+      </p:sp>
+      <p:sp>
+        <p:nvSpPr>
+          <p:cNvPr id="12" name="Text 10"/>
+          <p:cNvSpPr txBox="1"/>
+          <p:nvPr/>
+        </p:nvSpPr>
+        <p:spPr>
+          <a:xfrm>
+            <a:off x="3429000" y="1874520"/>
+            <a:ext cx="2286000" cy="457200"/>
+          </a:xfrm>
+          <a:prstGeom prst="rect">
+            <a:avLst/>
+          </a:prstGeom>
+          <a:noFill/>
+          <a:ln/>
+        </p:spPr>
+        <p:txBody>
+          <a:bodyPr wrap="square" lIns="0" tIns="0" rIns="0" bIns="0" rtlCol="0" anchor="t"/>
+          <a:lstStyle/>
+          <a:p>
+            <a:pPr indent="0" marL="0">
+              <a:buNone/>
+            </a:pPr>
+            <a:r>
+              <a:rPr lang="en-US" sz="1200" dirty="0">
+                <a:solidFill>
+                  <a:schemeClr val="accent4"/>
+                </a:solidFill>
+              </a:rPr>
+              <a:t>실물 · 디지털 · 서비스 · 소프트웨어 · 콘텐츠</a:t>
+            </a:r>
+            <a:endParaRPr lang="en-US" sz="1200" dirty="0"/>
+          </a:p>
+        </p:txBody>
+      </p:sp>
+      <p:sp>
+        <p:nvSpPr>
+          <p:cNvPr id="13" name="card"/>
+          <p:cNvSpPr/>
+          <p:nvPr/>
+        </p:nvSpPr>
+        <p:spPr>
+          <a:xfrm>
+            <a:off x="6035040" y="1188720"/>
+            <a:ext cx="2606040" cy="1234440"/>
+          </a:xfrm>
+          <a:prstGeom prst="roundRect">
+            <a:avLst>
+              <a:gd name="adj" fmla="val 5926"/>
+            </a:avLst>
+          </a:prstGeom>
+          <a:solidFill>
+            <a:schemeClr val="bg2"/>
+          </a:solidFill>
+          <a:ln/>
+        </p:spPr>
+      </p:sp>
+      <p:sp>
+        <p:nvSpPr>
+          <p:cNvPr id="14" name="badge3"/>
+          <p:cNvSpPr/>
+          <p:nvPr/>
+        </p:nvSpPr>
+        <p:spPr>
+          <a:xfrm>
+            <a:off x="6217920" y="1371600"/>
+            <a:ext cx="384048" cy="384048"/>
+          </a:xfrm>
+          <a:prstGeom prst="ellipse">
+            <a:avLst/>
+          </a:prstGeom>
+          <a:solidFill>
+            <a:schemeClr val="tx2"/>
+          </a:solidFill>
+          <a:ln/>
+        </p:spPr>
+      </p:sp>
+      <p:sp>
+        <p:nvSpPr>
+          <p:cNvPr id="15" name="Text 13"/>
+          <p:cNvSpPr txBox="1"/>
+          <p:nvPr/>
+        </p:nvSpPr>
+        <p:spPr>
+          <a:xfrm>
+            <a:off x="6217920" y="1371600"/>
+            <a:ext cx="384048" cy="384048"/>
+          </a:xfrm>
+          <a:prstGeom prst="rect">
+            <a:avLst/>
+          </a:prstGeom>
+          <a:noFill/>
+          <a:ln/>
+        </p:spPr>
+        <p:txBody>
+          <a:bodyPr wrap="square" lIns="0" tIns="0" rIns="0" bIns="0" rtlCol="0" anchor="ctr"/>
+          <a:lstStyle/>
+          <a:p>
+            <a:pPr algn="ctr" indent="0" marL="0">
+              <a:buNone/>
+            </a:pPr>
+            <a:r>
+              <a:rPr lang="en-US" sz="1400" b="1" dirty="0">
+                <a:solidFill>
+                  <a:schemeClr val="bg1"/>
+                </a:solidFill>
+              </a:rPr>
+              <a:t>3</a:t>
+            </a:r>
+            <a:endParaRPr lang="en-US" sz="1400" dirty="0"/>
+          </a:p>
+        </p:txBody>
+      </p:sp>
+      <p:sp>
+        <p:nvSpPr>
+          <p:cNvPr id="16" name="Text 14"/>
+          <p:cNvSpPr txBox="1"/>
+          <p:nvPr/>
+        </p:nvSpPr>
+        <p:spPr>
+          <a:xfrm>
+            <a:off x="6720840" y="1371600"/>
+            <a:ext cx="1828800" cy="384048"/>
+          </a:xfrm>
+          <a:prstGeom prst="rect">
+            <a:avLst/>
+          </a:prstGeom>
+          <a:noFill/>
+          <a:ln/>
+        </p:spPr>
+        <p:txBody>
+          <a:bodyPr wrap="square" lIns="0" tIns="0" rIns="0" bIns="0" rtlCol="0" anchor="ctr"/>
+          <a:lstStyle/>
+          <a:p>
+            <a:pPr indent="0" marL="0">
+              <a:buNone/>
+            </a:pPr>
+            <a:r>
+              <a:rPr lang="en-US" sz="1700" b="1" dirty="0">
+                <a:solidFill>
+                  <a:schemeClr val="tx2"/>
+                </a:solidFill>
+              </a:rPr>
+              <a:t>어떻게 버나</a:t>
+            </a:r>
+            <a:endParaRPr lang="en-US" sz="1700" dirty="0"/>
+          </a:p>
+        </p:txBody>
+      </p:sp>
+      <p:sp>
+        <p:nvSpPr>
+          <p:cNvPr id="17" name="Text 15"/>
+          <p:cNvSpPr txBox="1"/>
+          <p:nvPr/>
+        </p:nvSpPr>
+        <p:spPr>
+          <a:xfrm>
+            <a:off x="6217920" y="1874520"/>
+            <a:ext cx="2286000" cy="457200"/>
+          </a:xfrm>
+          <a:prstGeom prst="rect">
+            <a:avLst/>
+          </a:prstGeom>
+          <a:noFill/>
+          <a:ln/>
+        </p:spPr>
+        <p:txBody>
+          <a:bodyPr wrap="square" lIns="0" tIns="0" rIns="0" bIns="0" rtlCol="0" anchor="t"/>
+          <a:lstStyle/>
+          <a:p>
+            <a:pPr indent="0" marL="0">
+              <a:buNone/>
+            </a:pPr>
+            <a:r>
+              <a:rPr lang="en-US" sz="1200" dirty="0">
+                <a:solidFill>
+                  <a:schemeClr val="accent4"/>
+                </a:solidFill>
+              </a:rPr>
+              <a:t>판매 · 구독 · 수수료 · 광고 · 후원</a:t>
+            </a:r>
+            <a:endParaRPr lang="en-US" sz="1200" dirty="0"/>
+          </a:p>
+        </p:txBody>
+      </p:sp>
+      <p:sp>
+        <p:nvSpPr>
+          <p:cNvPr id="18" name="card"/>
+          <p:cNvSpPr/>
+          <p:nvPr/>
+        </p:nvSpPr>
+        <p:spPr>
+          <a:xfrm>
+            <a:off x="457200" y="2606040"/>
+            <a:ext cx="2606040" cy="1234440"/>
+          </a:xfrm>
+          <a:prstGeom prst="roundRect">
+            <a:avLst>
+              <a:gd name="adj" fmla="val 5926"/>
+            </a:avLst>
+          </a:prstGeom>
+          <a:solidFill>
+            <a:schemeClr val="bg2"/>
+          </a:solidFill>
+          <a:ln/>
+        </p:spPr>
+      </p:sp>
+      <p:sp>
+        <p:nvSpPr>
+          <p:cNvPr id="19" name="badge4"/>
+          <p:cNvSpPr/>
+          <p:nvPr/>
+        </p:nvSpPr>
+        <p:spPr>
+          <a:xfrm>
+            <a:off x="640080" y="2788920"/>
+            <a:ext cx="384048" cy="384048"/>
+          </a:xfrm>
+          <a:prstGeom prst="ellipse">
+            <a:avLst/>
+          </a:prstGeom>
+          <a:solidFill>
+            <a:schemeClr val="tx2"/>
+          </a:solidFill>
+          <a:ln/>
+        </p:spPr>
+      </p:sp>
+      <p:sp>
+        <p:nvSpPr>
+          <p:cNvPr id="20" name="Text 18"/>
+          <p:cNvSpPr txBox="1"/>
+          <p:nvPr/>
+        </p:nvSpPr>
+        <p:spPr>
+          <a:xfrm>
+            <a:off x="640080" y="2788920"/>
+            <a:ext cx="384048" cy="384048"/>
+          </a:xfrm>
+          <a:prstGeom prst="rect">
+            <a:avLst/>
+          </a:prstGeom>
+          <a:noFill/>
+          <a:ln/>
+        </p:spPr>
+        <p:txBody>
+          <a:bodyPr wrap="square" lIns="0" tIns="0" rIns="0" bIns="0" rtlCol="0" anchor="ctr"/>
+          <a:lstStyle/>
+          <a:p>
+            <a:pPr algn="ctr" indent="0" marL="0">
+              <a:buNone/>
+            </a:pPr>
+            <a:r>
+              <a:rPr lang="en-US" sz="1400" b="1" dirty="0">
+                <a:solidFill>
+                  <a:schemeClr val="bg1"/>
+                </a:solidFill>
+              </a:rPr>
+              <a:t>4</a:t>
+            </a:r>
+            <a:endParaRPr lang="en-US" sz="1400" dirty="0"/>
+          </a:p>
+        </p:txBody>
+      </p:sp>
+      <p:sp>
+        <p:nvSpPr>
+          <p:cNvPr id="21" name="Text 19"/>
+          <p:cNvSpPr txBox="1"/>
+          <p:nvPr/>
+        </p:nvSpPr>
+        <p:spPr>
+          <a:xfrm>
+            <a:off x="1143000" y="2788920"/>
+            <a:ext cx="1828800" cy="384048"/>
+          </a:xfrm>
+          <a:prstGeom prst="rect">
+            <a:avLst/>
+          </a:prstGeom>
+          <a:noFill/>
+          <a:ln/>
+        </p:spPr>
+        <p:txBody>
+          <a:bodyPr wrap="square" lIns="0" tIns="0" rIns="0" bIns="0" rtlCol="0" anchor="ctr"/>
+          <a:lstStyle/>
+          <a:p>
+            <a:pPr indent="0" marL="0">
+              <a:buNone/>
+            </a:pPr>
+            <a:r>
+              <a:rPr lang="en-US" sz="1700" b="1" dirty="0">
+                <a:solidFill>
+                  <a:schemeClr val="tx2"/>
+                </a:solidFill>
+              </a:rPr>
+              <a:t>누가 만드나</a:t>
+            </a:r>
+            <a:endParaRPr lang="en-US" sz="1700" dirty="0"/>
+          </a:p>
+        </p:txBody>
+      </p:sp>
+      <p:sp>
+        <p:nvSpPr>
+          <p:cNvPr id="22" name="Text 20"/>
+          <p:cNvSpPr txBox="1"/>
+          <p:nvPr/>
+        </p:nvSpPr>
+        <p:spPr>
+          <a:xfrm>
+            <a:off x="640080" y="3291840"/>
+            <a:ext cx="2286000" cy="457200"/>
+          </a:xfrm>
+          <a:prstGeom prst="rect">
+            <a:avLst/>
+          </a:prstGeom>
+          <a:noFill/>
+          <a:ln/>
+        </p:spPr>
+        <p:txBody>
+          <a:bodyPr wrap="square" lIns="0" tIns="0" rIns="0" bIns="0" rtlCol="0" anchor="t"/>
+          <a:lstStyle/>
+          <a:p>
+            <a:pPr indent="0" marL="0">
+              <a:buNone/>
+            </a:pPr>
+            <a:r>
+              <a:rPr lang="en-US" sz="1200" dirty="0">
+                <a:solidFill>
+                  <a:schemeClr val="accent4"/>
+                </a:solidFill>
+              </a:rPr>
+              <a:t>운영자 · 회원 · 판매자 · AI</a:t>
+            </a:r>
+            <a:endParaRPr lang="en-US" sz="1200" dirty="0"/>
+          </a:p>
+        </p:txBody>
+      </p:sp>
+      <p:sp>
+        <p:nvSpPr>
+          <p:cNvPr id="23" name="card"/>
+          <p:cNvSpPr/>
+          <p:nvPr/>
+        </p:nvSpPr>
+        <p:spPr>
+          <a:xfrm>
+            <a:off x="3246120" y="2606040"/>
+            <a:ext cx="2606040" cy="1234440"/>
+          </a:xfrm>
+          <a:prstGeom prst="roundRect">
+            <a:avLst>
+              <a:gd name="adj" fmla="val 5926"/>
+            </a:avLst>
+          </a:prstGeom>
+          <a:solidFill>
+            <a:schemeClr val="bg2"/>
+          </a:solidFill>
+          <a:ln/>
+        </p:spPr>
+      </p:sp>
+      <p:sp>
+        <p:nvSpPr>
+          <p:cNvPr id="24" name="badge5"/>
+          <p:cNvSpPr/>
+          <p:nvPr/>
+        </p:nvSpPr>
+        <p:spPr>
+          <a:xfrm>
+            <a:off x="3429000" y="2788920"/>
+            <a:ext cx="384048" cy="384048"/>
+          </a:xfrm>
+          <a:prstGeom prst="ellipse">
+            <a:avLst/>
+          </a:prstGeom>
+          <a:solidFill>
+            <a:schemeClr val="tx2"/>
+          </a:solidFill>
+          <a:ln/>
+        </p:spPr>
+      </p:sp>
+      <p:sp>
+        <p:nvSpPr>
+          <p:cNvPr id="25" name="Text 23"/>
+          <p:cNvSpPr txBox="1"/>
+          <p:nvPr/>
+        </p:nvSpPr>
+        <p:spPr>
+          <a:xfrm>
+            <a:off x="3429000" y="2788920"/>
+            <a:ext cx="384048" cy="384048"/>
+          </a:xfrm>
+          <a:prstGeom prst="rect">
+            <a:avLst/>
+          </a:prstGeom>
+          <a:noFill/>
+          <a:ln/>
+        </p:spPr>
+        <p:txBody>
+          <a:bodyPr wrap="square" lIns="0" tIns="0" rIns="0" bIns="0" rtlCol="0" anchor="ctr"/>
+          <a:lstStyle/>
+          <a:p>
+            <a:pPr algn="ctr" indent="0" marL="0">
+              <a:buNone/>
+            </a:pPr>
+            <a:r>
+              <a:rPr lang="en-US" sz="1400" b="1" dirty="0">
+                <a:solidFill>
+                  <a:schemeClr val="bg1"/>
+                </a:solidFill>
+              </a:rPr>
+              <a:t>5</a:t>
+            </a:r>
+            <a:endParaRPr lang="en-US" sz="1400" dirty="0"/>
+          </a:p>
+        </p:txBody>
+      </p:sp>
+      <p:sp>
+        <p:nvSpPr>
+          <p:cNvPr id="26" name="Text 24"/>
+          <p:cNvSpPr txBox="1"/>
+          <p:nvPr/>
+        </p:nvSpPr>
+        <p:spPr>
+          <a:xfrm>
+            <a:off x="3931920" y="2788920"/>
+            <a:ext cx="1828800" cy="384048"/>
+          </a:xfrm>
+          <a:prstGeom prst="rect">
+            <a:avLst/>
+          </a:prstGeom>
+          <a:noFill/>
+          <a:ln/>
+        </p:spPr>
+        <p:txBody>
+          <a:bodyPr wrap="square" lIns="0" tIns="0" rIns="0" bIns="0" rtlCol="0" anchor="ctr"/>
+          <a:lstStyle/>
+          <a:p>
+            <a:pPr indent="0" marL="0">
+              <a:buNone/>
+            </a:pPr>
+            <a:r>
+              <a:rPr lang="en-US" sz="1700" b="1" dirty="0">
+                <a:solidFill>
+                  <a:schemeClr val="tx2"/>
+                </a:solidFill>
+              </a:rPr>
+              <a:t>어디서</a:t>
+            </a:r>
+            <a:endParaRPr lang="en-US" sz="1700" dirty="0"/>
+          </a:p>
+        </p:txBody>
+      </p:sp>
+      <p:sp>
+        <p:nvSpPr>
+          <p:cNvPr id="27" name="Text 25"/>
+          <p:cNvSpPr txBox="1"/>
+          <p:nvPr/>
+        </p:nvSpPr>
+        <p:spPr>
+          <a:xfrm>
+            <a:off x="3429000" y="3291840"/>
+            <a:ext cx="2286000" cy="457200"/>
+          </a:xfrm>
+          <a:prstGeom prst="rect">
+            <a:avLst/>
+          </a:prstGeom>
+          <a:noFill/>
+          <a:ln/>
+        </p:spPr>
+        <p:txBody>
+          <a:bodyPr wrap="square" lIns="0" tIns="0" rIns="0" bIns="0" rtlCol="0" anchor="t"/>
+          <a:lstStyle/>
+          <a:p>
+            <a:pPr indent="0" marL="0">
+              <a:buNone/>
+            </a:pPr>
+            <a:r>
+              <a:rPr lang="en-US" sz="1200" dirty="0">
+                <a:solidFill>
+                  <a:schemeClr val="accent4"/>
+                </a:solidFill>
+              </a:rPr>
+              <a:t>내 사이트 / 남의 플랫폼</a:t>
+            </a:r>
+            <a:endParaRPr lang="en-US" sz="1200" dirty="0"/>
+          </a:p>
+        </p:txBody>
+      </p:sp>
+      <p:sp>
+        <p:nvSpPr>
+          <p:cNvPr id="28" name="card"/>
+          <p:cNvSpPr/>
+          <p:nvPr/>
+        </p:nvSpPr>
+        <p:spPr>
+          <a:xfrm>
+            <a:off x="6035040" y="2606040"/>
+            <a:ext cx="2606040" cy="1234440"/>
+          </a:xfrm>
+          <a:prstGeom prst="roundRect">
+            <a:avLst>
+              <a:gd name="adj" fmla="val 5926"/>
+            </a:avLst>
+          </a:prstGeom>
+          <a:solidFill>
+            <a:schemeClr val="tx2"/>
+          </a:solidFill>
+          <a:ln/>
+        </p:spPr>
+      </p:sp>
+      <p:sp>
+        <p:nvSpPr>
+          <p:cNvPr id="29" name="badge6"/>
+          <p:cNvSpPr/>
+          <p:nvPr/>
+        </p:nvSpPr>
+        <p:spPr>
+          <a:xfrm>
+            <a:off x="6217920" y="2788920"/>
+            <a:ext cx="384048" cy="384048"/>
+          </a:xfrm>
+          <a:prstGeom prst="ellipse">
+            <a:avLst/>
+          </a:prstGeom>
+          <a:solidFill>
+            <a:schemeClr val="accent2"/>
+          </a:solidFill>
+          <a:ln/>
+        </p:spPr>
+      </p:sp>
+      <p:sp>
+        <p:nvSpPr>
+          <p:cNvPr id="30" name="Text 28"/>
+          <p:cNvSpPr txBox="1"/>
+          <p:nvPr/>
+        </p:nvSpPr>
+        <p:spPr>
+          <a:xfrm>
+            <a:off x="6217920" y="2788920"/>
+            <a:ext cx="384048" cy="384048"/>
+          </a:xfrm>
+          <a:prstGeom prst="rect">
+            <a:avLst/>
+          </a:prstGeom>
+          <a:noFill/>
+          <a:ln/>
+        </p:spPr>
+        <p:txBody>
+          <a:bodyPr wrap="square" lIns="0" tIns="0" rIns="0" bIns="0" rtlCol="0" anchor="ctr"/>
+          <a:lstStyle/>
+          <a:p>
+            <a:pPr algn="ctr" indent="0" marL="0">
+              <a:buNone/>
+            </a:pPr>
+            <a:r>
+              <a:rPr lang="en-US" sz="1400" b="1" dirty="0">
+                <a:solidFill>
+                  <a:schemeClr val="bg1"/>
+                </a:solidFill>
+              </a:rPr>
+              <a:t>6</a:t>
+            </a:r>
+            <a:endParaRPr lang="en-US" sz="1400" dirty="0"/>
+          </a:p>
+        </p:txBody>
+      </p:sp>
+      <p:sp>
+        <p:nvSpPr>
+          <p:cNvPr id="31" name="Text 29"/>
+          <p:cNvSpPr txBox="1"/>
+          <p:nvPr/>
+        </p:nvSpPr>
+        <p:spPr>
+          <a:xfrm>
+            <a:off x="6720840" y="2788920"/>
+            <a:ext cx="1828800" cy="384048"/>
+          </a:xfrm>
+          <a:prstGeom prst="rect">
+            <a:avLst/>
+          </a:prstGeom>
+          <a:noFill/>
+          <a:ln/>
+        </p:spPr>
+        <p:txBody>
+          <a:bodyPr wrap="square" lIns="0" tIns="0" rIns="0" bIns="0" rtlCol="0" anchor="ctr"/>
+          <a:lstStyle/>
+          <a:p>
+            <a:pPr indent="0" marL="0">
+              <a:buNone/>
+            </a:pPr>
+            <a:r>
+              <a:rPr lang="en-US" sz="1700" b="1" dirty="0">
+                <a:solidFill>
+                  <a:schemeClr val="bg1"/>
+                </a:solidFill>
+              </a:rPr>
+              <a:t>규제</a:t>
+            </a:r>
+            <a:endParaRPr lang="en-US" sz="1700" dirty="0"/>
+          </a:p>
+        </p:txBody>
+      </p:sp>
+      <p:sp>
+        <p:nvSpPr>
+          <p:cNvPr id="32" name="Text 30"/>
+          <p:cNvSpPr txBox="1"/>
+          <p:nvPr/>
+        </p:nvSpPr>
+        <p:spPr>
+          <a:xfrm>
+            <a:off x="6217920" y="3291840"/>
+            <a:ext cx="2286000" cy="457200"/>
+          </a:xfrm>
+          <a:prstGeom prst="rect">
+            <a:avLst/>
+          </a:prstGeom>
+          <a:noFill/>
+          <a:ln/>
+        </p:spPr>
+        <p:txBody>
+          <a:bodyPr wrap="square" lIns="0" tIns="0" rIns="0" bIns="0" rtlCol="0" anchor="t"/>
+          <a:lstStyle/>
+          <a:p>
+            <a:pPr indent="0" marL="0">
+              <a:buNone/>
+            </a:pPr>
+            <a:r>
+              <a:rPr lang="en-US" sz="1200" dirty="0">
+                <a:solidFill>
+                  <a:schemeClr val="bg2"/>
+                </a:solidFill>
+              </a:rPr>
+              <a:t>신고만 / 등록·허가 / 금지</a:t>
+            </a:r>
+            <a:endParaRPr lang="en-US" sz="1200" dirty="0"/>
+          </a:p>
+        </p:txBody>
+      </p:sp>
+      <p:sp>
+        <p:nvSpPr>
+          <p:cNvPr id="33" name="Text 31"/>
+          <p:cNvSpPr txBox="1"/>
+          <p:nvPr/>
+        </p:nvSpPr>
+        <p:spPr>
+          <a:xfrm>
+            <a:off x="457200" y="4645152"/>
+            <a:ext cx="7680960" cy="274320"/>
+          </a:xfrm>
+          <a:prstGeom prst="rect">
+            <a:avLst/>
+          </a:prstGeom>
+          <a:noFill/>
+          <a:ln/>
+        </p:spPr>
+        <p:txBody>
+          <a:bodyPr wrap="square" lIns="0" tIns="0" rIns="0" bIns="0" rtlCol="0" anchor="t"/>
+          <a:lstStyle/>
+          <a:p>
+            <a:pPr indent="0" marL="0">
+              <a:buNone/>
+            </a:pPr>
+            <a:r>
+              <a:rPr lang="en-US" sz="1000" dirty="0">
+                <a:solidFill>
+                  <a:schemeClr val="accent4"/>
+                </a:solidFill>
+              </a:rPr>
+              <a:t>새 아이디어는 6칸을 채워 보며 위험을 찾는다 (22장)</a:t>
+            </a:r>
+            <a:endParaRPr lang="en-US" sz="1000" dirty="0"/>
+          </a:p>
+        </p:txBody>
+      </p:sp>
+      <p:sp>
+        <p:nvSpPr>
+          <p:cNvPr id="25" name="Slide Number Placeholder 0"/>
+          <p:cNvSpPr>
+            <a:spLocks noGrp="1"/>
+          </p:cNvSpPr>
+          <p:nvPr>
+            <p:ph type="sldNum" sz="quarter" idx="4294967295"/>
+          </p:nvPr>
+        </p:nvSpPr>
+        <p:spPr>
+          <a:xfrm>
+            <a:off x="8321040" y="4754880"/>
+            <a:ext cx="457200" cy="274320"/>
+          </a:xfrm>
+          <a:prstGeom prst="rect">
+            <a:avLst/>
+          </a:prstGeom>
+          <a:extLst>
+            <a:ext uri="{C572A759-6A51-4108-AA02-DFA0A04FC94B}">
+              <ma14:wrappingTextBoxFlag xmlns:ma14="http://schemas.microsoft.com/office/mac/drawingml/2011/main" val="0"/>
+            </a:ext>
+          </a:extLst>
+        </p:spPr>
+        <p:txBody>
+          <a:bodyPr/>
+          <a:lstStyle>
+            <a:lvl1pPr>
+              <a:defRPr sz="1000">
+                <a:solidFill>
+                  <a:schemeClr val="accent4"/>
+                </a:solidFill>
+              </a:defRPr>
+            </a:lvl1pPr>
+          </a:lstStyle>
+          <a:p>
+            <a:pPr algn="r"/>
+            <a:fld id="{F7021451-1387-4CA6-816F-3879F97B5CBC}" type="slidenum">
+              <a:rPr b="0" lang="en-US"/>
+              <a:t>31</a:t>
+            </a:fld>
+            <a:endParaRPr lang="en-US"/>
+          </a:p>
+        </p:txBody>
+      </p:sp>
+    </p:spTree>
+  </p:cSld>
+  <p:clrMapOvr>
+    <a:masterClrMapping/>
+  </p:clrMapOvr>
+</p:sld>
+</file>
+
+<file path=ppt/slides/slide32.xml><?xml version="1.0" encoding="utf-8"?>
+<p:sld xmlns:a="http://schemas.openxmlformats.org/drawingml/2006/main" xmlns:r="http://schemas.openxmlformats.org/officeDocument/2006/relationships" xmlns:p="http://schemas.openxmlformats.org/presentationml/2006/main">
+  <p:cSld name="Slide 32">
+    <p:spTree>
+      <p:nvGrpSpPr>
+        <p:cNvPr id="1" name=""/>
+        <p:cNvGrpSpPr/>
+        <p:nvPr/>
+      </p:nvGrpSpPr>
+      <p:grpSpPr>
+        <a:xfrm>
+          <a:off x="0" y="0"/>
+          <a:ext cx="0" cy="0"/>
+          <a:chOff x="0" y="0"/>
+          <a:chExt cx="0" cy="0"/>
+        </a:xfrm>
+      </p:grpSpPr>
+      <p:sp>
+        <p:nvSpPr>
+          <p:cNvPr id="2" name="Text 0"/>
+          <p:cNvSpPr/>
+          <p:nvPr>
+            <p:ph idx="100" type="title" hasCustomPrompt="1"/>
+          </p:nvPr>
+        </p:nvSpPr>
+        <p:spPr>
+          <a:xfrm>
+            <a:off x="457200" y="274320"/>
+            <a:ext cx="8229600" cy="685800"/>
+          </a:xfrm>
+          <a:prstGeom prst="rect">
+            <a:avLst/>
+          </a:prstGeom>
+          <a:noFill/>
+          <a:ln/>
+        </p:spPr>
+        <p:txBody>
+          <a:bodyPr wrap="square" lIns="0" tIns="0" rIns="0" bIns="0" rtlCol="0" anchor="ctr"/>
+          <a:lstStyle/>
+          <a:p>
+            <a:pPr indent="0" marL="0">
+              <a:buNone/>
+            </a:pPr>
+            <a:r>
+              <a:rPr lang="en-US" sz="2800" b="1" dirty="0">
+                <a:solidFill>
+                  <a:schemeClr val="tx2"/>
+                </a:solidFill>
+              </a:rPr>
+              <a:t>오픈마켓 셀러와 크리에이터</a:t>
+            </a:r>
+            <a:endParaRPr lang="en-US" sz="2800" dirty="0"/>
+          </a:p>
+        </p:txBody>
+      </p:sp>
+      <p:sp>
+        <p:nvSpPr>
+          <p:cNvPr id="3" name="card"/>
+          <p:cNvSpPr/>
+          <p:nvPr/>
+        </p:nvSpPr>
+        <p:spPr>
+          <a:xfrm>
+            <a:off x="457200" y="1188720"/>
+            <a:ext cx="4023360" cy="3200400"/>
+          </a:xfrm>
+          <a:prstGeom prst="roundRect">
+            <a:avLst>
+              <a:gd name="adj" fmla="val 2286"/>
+            </a:avLst>
+          </a:prstGeom>
+          <a:solidFill>
+            <a:schemeClr val="bg2"/>
+          </a:solidFill>
+          <a:ln/>
+        </p:spPr>
+      </p:sp>
+      <p:sp>
+        <p:nvSpPr>
+          <p:cNvPr id="4" name="sc0"/>
+          <p:cNvSpPr/>
+          <p:nvPr/>
+        </p:nvSpPr>
+        <p:spPr>
+          <a:xfrm>
+            <a:off x="457200" y="1188720"/>
+            <a:ext cx="4023360" cy="640080"/>
+          </a:xfrm>
+          <a:prstGeom prst="roundRect">
+            <a:avLst>
+              <a:gd name="adj" fmla="val 11429"/>
+            </a:avLst>
+          </a:prstGeom>
+          <a:solidFill>
+            <a:schemeClr val="tx2"/>
+          </a:solidFill>
+          <a:ln/>
+        </p:spPr>
+      </p:sp>
+      <p:sp>
+        <p:nvSpPr>
+          <p:cNvPr id="5" name="Text 3"/>
+          <p:cNvSpPr txBox="1"/>
+          <p:nvPr/>
+        </p:nvSpPr>
+        <p:spPr>
+          <a:xfrm>
+            <a:off x="685800" y="1188720"/>
+            <a:ext cx="2743200" cy="640080"/>
+          </a:xfrm>
+          <a:prstGeom prst="rect">
+            <a:avLst/>
+          </a:prstGeom>
+          <a:noFill/>
+          <a:ln/>
+        </p:spPr>
+        <p:txBody>
+          <a:bodyPr wrap="square" lIns="0" tIns="0" rIns="0" bIns="0" rtlCol="0" anchor="ctr"/>
+          <a:lstStyle/>
+          <a:p>
+            <a:pPr indent="0" marL="0">
+              <a:buNone/>
+            </a:pPr>
+            <a:r>
+              <a:rPr lang="en-US" sz="1900" b="1" dirty="0">
+                <a:solidFill>
+                  <a:schemeClr val="bg1"/>
+                </a:solidFill>
+              </a:rPr>
+              <a:t>오픈마켓 셀러</a:t>
+            </a:r>
+            <a:endParaRPr lang="en-US" sz="1900" dirty="0"/>
+          </a:p>
+        </p:txBody>
+      </p:sp>
+      <p:sp>
+        <p:nvSpPr>
+          <p:cNvPr id="6" name="Text 4"/>
+          <p:cNvSpPr txBox="1"/>
+          <p:nvPr/>
+        </p:nvSpPr>
+        <p:spPr>
+          <a:xfrm>
+            <a:off x="3383280" y="1188720"/>
+            <a:ext cx="914400" cy="640080"/>
+          </a:xfrm>
+          <a:prstGeom prst="rect">
+            <a:avLst/>
+          </a:prstGeom>
+          <a:noFill/>
+          <a:ln/>
+        </p:spPr>
+        <p:txBody>
+          <a:bodyPr wrap="square" lIns="0" tIns="0" rIns="0" bIns="0" rtlCol="0" anchor="ctr"/>
+          <a:lstStyle/>
+          <a:p>
+            <a:pPr algn="r" indent="0" marL="0">
+              <a:buNone/>
+            </a:pPr>
+            <a:r>
+              <a:rPr lang="en-US" sz="1200" dirty="0">
+                <a:solidFill>
+                  <a:schemeClr val="bg1"/>
+                </a:solidFill>
+              </a:rPr>
+              <a:t>23장</a:t>
+            </a:r>
+            <a:endParaRPr lang="en-US" sz="1200" dirty="0"/>
+          </a:p>
+        </p:txBody>
+      </p:sp>
+      <p:sp>
+        <p:nvSpPr>
+          <p:cNvPr id="7" name="Text 5"/>
+          <p:cNvSpPr txBox="1"/>
+          <p:nvPr/>
+        </p:nvSpPr>
+        <p:spPr>
+          <a:xfrm>
+            <a:off x="685800" y="2011680"/>
+            <a:ext cx="3611880" cy="2194560"/>
+          </a:xfrm>
+          <a:prstGeom prst="rect">
+            <a:avLst/>
+          </a:prstGeom>
+          <a:noFill/>
+          <a:ln/>
+        </p:spPr>
+        <p:txBody>
+          <a:bodyPr wrap="square" lIns="0" tIns="0" rIns="0" bIns="0" rtlCol="0" anchor="t"/>
+          <a:lstStyle/>
+          <a:p>
+            <a:pPr marL="342900" indent="-342900">
+              <a:spcAft>
+                <a:spcPts val="1000"/>
+              </a:spcAft>
+              <a:buSzPct val="100000"/>
+              <a:buChar char="•"/>
+            </a:pPr>
+            <a:r>
+              <a:rPr lang="en-US" sz="1400" dirty="0">
+                <a:solidFill>
+                  <a:schemeClr val="tx1"/>
+                </a:solidFill>
+              </a:rPr>
+              <a:t>손님은 이미 있음, 대신 수수료·경쟁</a:t>
+            </a:r>
+            <a:endParaRPr lang="en-US" sz="1400" dirty="0"/>
+          </a:p>
+          <a:p>
+            <a:pPr marL="342900" indent="-342900">
+              <a:spcAft>
+                <a:spcPts val="1000"/>
+              </a:spcAft>
+              <a:buSzPct val="100000"/>
+              <a:buChar char="•"/>
+            </a:pPr>
+            <a:r>
+              <a:rPr lang="en-US" sz="1400" dirty="0">
+                <a:solidFill>
+                  <a:schemeClr val="tx1"/>
+                </a:solidFill>
+              </a:rPr>
+              <a:t>사입 · 위탁판매 · 구매대행 · 내 브랜드</a:t>
+            </a:r>
+            <a:endParaRPr lang="en-US" sz="1400" dirty="0"/>
+          </a:p>
+          <a:p>
+            <a:pPr marL="342900" indent="-342900">
+              <a:spcAft>
+                <a:spcPts val="1000"/>
+              </a:spcAft>
+              <a:buSzPct val="100000"/>
+              <a:buChar char="•"/>
+            </a:pPr>
+            <a:r>
+              <a:rPr lang="en-US" sz="1400" dirty="0">
+                <a:solidFill>
+                  <a:schemeClr val="tx1"/>
+                </a:solidFill>
+              </a:rPr>
+              <a:t>마켓 안 검색 최적화 + 수수료 뺀 마진</a:t>
+            </a:r>
+            <a:endParaRPr lang="en-US" sz="1400" dirty="0"/>
+          </a:p>
+          <a:p>
+            <a:pPr marL="342900" indent="-342900">
+              <a:spcAft>
+                <a:spcPts val="1000"/>
+              </a:spcAft>
+              <a:buSzPct val="100000"/>
+              <a:buChar char="•"/>
+            </a:pPr>
+            <a:r>
+              <a:rPr lang="en-US" sz="1400" dirty="0">
+                <a:solidFill>
+                  <a:schemeClr val="tx1"/>
+                </a:solidFill>
+              </a:rPr>
+              <a:t>배송 기한·CS 점수 관리</a:t>
+            </a:r>
+            <a:endParaRPr lang="en-US" sz="1400" dirty="0"/>
+          </a:p>
+        </p:txBody>
+      </p:sp>
+      <p:sp>
+        <p:nvSpPr>
+          <p:cNvPr id="8" name="card"/>
+          <p:cNvSpPr/>
+          <p:nvPr/>
+        </p:nvSpPr>
+        <p:spPr>
+          <a:xfrm>
+            <a:off x="4663440" y="1188720"/>
+            <a:ext cx="4023360" cy="3200400"/>
+          </a:xfrm>
+          <a:prstGeom prst="roundRect">
+            <a:avLst>
+              <a:gd name="adj" fmla="val 2286"/>
+            </a:avLst>
+          </a:prstGeom>
+          <a:solidFill>
+            <a:schemeClr val="bg2"/>
+          </a:solidFill>
+          <a:ln/>
+        </p:spPr>
+      </p:sp>
+      <p:sp>
+        <p:nvSpPr>
+          <p:cNvPr id="9" name="sc1"/>
+          <p:cNvSpPr/>
+          <p:nvPr/>
+        </p:nvSpPr>
+        <p:spPr>
+          <a:xfrm>
+            <a:off x="4663440" y="1188720"/>
+            <a:ext cx="4023360" cy="640080"/>
+          </a:xfrm>
+          <a:prstGeom prst="roundRect">
+            <a:avLst>
+              <a:gd name="adj" fmla="val 11429"/>
+            </a:avLst>
+          </a:prstGeom>
+          <a:solidFill>
+            <a:schemeClr val="accent2"/>
+          </a:solidFill>
+          <a:ln/>
+        </p:spPr>
+      </p:sp>
+      <p:sp>
+        <p:nvSpPr>
+          <p:cNvPr id="10" name="Text 8"/>
+          <p:cNvSpPr txBox="1"/>
+          <p:nvPr/>
+        </p:nvSpPr>
+        <p:spPr>
+          <a:xfrm>
+            <a:off x="4892040" y="1188720"/>
+            <a:ext cx="2743200" cy="640080"/>
+          </a:xfrm>
+          <a:prstGeom prst="rect">
+            <a:avLst/>
+          </a:prstGeom>
+          <a:noFill/>
+          <a:ln/>
+        </p:spPr>
+        <p:txBody>
+          <a:bodyPr wrap="square" lIns="0" tIns="0" rIns="0" bIns="0" rtlCol="0" anchor="ctr"/>
+          <a:lstStyle/>
+          <a:p>
+            <a:pPr indent="0" marL="0">
+              <a:buNone/>
+            </a:pPr>
+            <a:r>
+              <a:rPr lang="en-US" sz="1900" b="1" dirty="0">
+                <a:solidFill>
+                  <a:schemeClr val="bg1"/>
+                </a:solidFill>
+              </a:rPr>
+              <a:t>크리에이터</a:t>
+            </a:r>
+            <a:endParaRPr lang="en-US" sz="1900" dirty="0"/>
+          </a:p>
+        </p:txBody>
+      </p:sp>
+      <p:sp>
+        <p:nvSpPr>
+          <p:cNvPr id="11" name="Text 9"/>
+          <p:cNvSpPr txBox="1"/>
+          <p:nvPr/>
+        </p:nvSpPr>
+        <p:spPr>
+          <a:xfrm>
+            <a:off x="7589520" y="1188720"/>
+            <a:ext cx="914400" cy="640080"/>
+          </a:xfrm>
+          <a:prstGeom prst="rect">
+            <a:avLst/>
+          </a:prstGeom>
+          <a:noFill/>
+          <a:ln/>
+        </p:spPr>
+        <p:txBody>
+          <a:bodyPr wrap="square" lIns="0" tIns="0" rIns="0" bIns="0" rtlCol="0" anchor="ctr"/>
+          <a:lstStyle/>
+          <a:p>
+            <a:pPr algn="r" indent="0" marL="0">
+              <a:buNone/>
+            </a:pPr>
+            <a:r>
+              <a:rPr lang="en-US" sz="1200" dirty="0">
+                <a:solidFill>
+                  <a:schemeClr val="bg1"/>
+                </a:solidFill>
+              </a:rPr>
+              <a:t>24장</a:t>
+            </a:r>
+            <a:endParaRPr lang="en-US" sz="1200" dirty="0"/>
+          </a:p>
+        </p:txBody>
+      </p:sp>
+      <p:sp>
+        <p:nvSpPr>
+          <p:cNvPr id="12" name="Text 10"/>
+          <p:cNvSpPr txBox="1"/>
+          <p:nvPr/>
+        </p:nvSpPr>
+        <p:spPr>
+          <a:xfrm>
+            <a:off x="4892040" y="2011680"/>
+            <a:ext cx="3611880" cy="2194560"/>
+          </a:xfrm>
+          <a:prstGeom prst="rect">
+            <a:avLst/>
+          </a:prstGeom>
+          <a:noFill/>
+          <a:ln/>
+        </p:spPr>
+        <p:txBody>
+          <a:bodyPr wrap="square" lIns="0" tIns="0" rIns="0" bIns="0" rtlCol="0" anchor="t"/>
+          <a:lstStyle/>
+          <a:p>
+            <a:pPr marL="342900" indent="-342900">
+              <a:spcAft>
+                <a:spcPts val="1000"/>
+              </a:spcAft>
+              <a:buSzPct val="100000"/>
+              <a:buChar char="•"/>
+            </a:pPr>
+            <a:r>
+              <a:rPr lang="en-US" sz="1400" dirty="0">
+                <a:solidFill>
+                  <a:schemeClr val="tx1"/>
+                </a:solidFill>
+              </a:rPr>
+              <a:t>콘텐츠 = 제품, 업로드 = 배포</a:t>
+            </a:r>
+            <a:endParaRPr lang="en-US" sz="1400" dirty="0"/>
+          </a:p>
+          <a:p>
+            <a:pPr marL="342900" indent="-342900">
+              <a:spcAft>
+                <a:spcPts val="1000"/>
+              </a:spcAft>
+              <a:buSzPct val="100000"/>
+              <a:buChar char="•"/>
+            </a:pPr>
+            <a:r>
+              <a:rPr lang="en-US" sz="1400" dirty="0">
+                <a:solidFill>
+                  <a:schemeClr val="tx1"/>
+                </a:solidFill>
+              </a:rPr>
+              <a:t>광고 배분 + 후원·멤버십 + 협찬</a:t>
+            </a:r>
+            <a:endParaRPr lang="en-US" sz="1400" dirty="0"/>
+          </a:p>
+          <a:p>
+            <a:pPr marL="342900" indent="-342900">
+              <a:spcAft>
+                <a:spcPts val="1000"/>
+              </a:spcAft>
+              <a:buSzPct val="100000"/>
+              <a:buChar char="•"/>
+            </a:pPr>
+            <a:r>
+              <a:rPr lang="en-US" sz="1400" dirty="0">
+                <a:solidFill>
+                  <a:schemeClr val="tx1"/>
+                </a:solidFill>
+              </a:rPr>
+              <a:t>협찬은 반드시 광고 표시</a:t>
+            </a:r>
+            <a:endParaRPr lang="en-US" sz="1400" dirty="0"/>
+          </a:p>
+          <a:p>
+            <a:pPr marL="342900" indent="-342900">
+              <a:spcAft>
+                <a:spcPts val="1000"/>
+              </a:spcAft>
+              <a:buSzPct val="100000"/>
+              <a:buChar char="•"/>
+            </a:pPr>
+            <a:r>
+              <a:rPr lang="en-US" sz="1400" dirty="0">
+                <a:solidFill>
+                  <a:schemeClr val="tx1"/>
+                </a:solidFill>
+              </a:rPr>
+              <a:t>원본 백업 · 2단계 인증 · 팬을 내 채널로</a:t>
+            </a:r>
+            <a:endParaRPr lang="en-US" sz="1400" dirty="0"/>
+          </a:p>
+        </p:txBody>
+      </p:sp>
+      <p:sp>
+        <p:nvSpPr>
+          <p:cNvPr id="25" name="Slide Number Placeholder 0"/>
+          <p:cNvSpPr>
+            <a:spLocks noGrp="1"/>
+          </p:cNvSpPr>
+          <p:nvPr>
+            <p:ph type="sldNum" sz="quarter" idx="4294967295"/>
+          </p:nvPr>
+        </p:nvSpPr>
+        <p:spPr>
+          <a:xfrm>
+            <a:off x="8321040" y="4754880"/>
+            <a:ext cx="457200" cy="274320"/>
+          </a:xfrm>
+          <a:prstGeom prst="rect">
+            <a:avLst/>
+          </a:prstGeom>
+          <a:extLst>
+            <a:ext uri="{C572A759-6A51-4108-AA02-DFA0A04FC94B}">
+              <ma14:wrappingTextBoxFlag xmlns:ma14="http://schemas.microsoft.com/office/mac/drawingml/2011/main" val="0"/>
+            </a:ext>
+          </a:extLst>
+        </p:spPr>
+        <p:txBody>
+          <a:bodyPr/>
+          <a:lstStyle>
+            <a:lvl1pPr>
+              <a:defRPr sz="1000">
+                <a:solidFill>
+                  <a:schemeClr val="accent4"/>
+                </a:solidFill>
+              </a:defRPr>
+            </a:lvl1pPr>
+          </a:lstStyle>
+          <a:p>
+            <a:pPr algn="r"/>
+            <a:fld id="{F7021451-1387-4CA6-816F-3879F97B5CBC}" type="slidenum">
+              <a:rPr b="0" lang="en-US"/>
+              <a:t>32</a:t>
+            </a:fld>
+            <a:endParaRPr lang="en-US"/>
+          </a:p>
+        </p:txBody>
+      </p:sp>
+    </p:spTree>
+  </p:cSld>
+  <p:clrMapOvr>
+    <a:masterClrMapping/>
+  </p:clrMapOvr>
+</p:sld>
+</file>
+
+<file path=ppt/slides/slide33.xml><?xml version="1.0" encoding="utf-8"?>
+<p:sld xmlns:a="http://schemas.openxmlformats.org/drawingml/2006/main" xmlns:r="http://schemas.openxmlformats.org/officeDocument/2006/relationships" xmlns:p="http://schemas.openxmlformats.org/presentationml/2006/main">
+  <p:cSld name="Slide 33">
+    <p:spTree>
+      <p:nvGrpSpPr>
+        <p:cNvPr id="1" name=""/>
+        <p:cNvGrpSpPr/>
+        <p:nvPr/>
+      </p:nvGrpSpPr>
+      <p:grpSpPr>
+        <a:xfrm>
+          <a:off x="0" y="0"/>
+          <a:ext cx="0" cy="0"/>
+          <a:chOff x="0" y="0"/>
+          <a:chExt cx="0" cy="0"/>
+        </a:xfrm>
+      </p:grpSpPr>
+      <p:sp>
+        <p:nvSpPr>
+          <p:cNvPr id="2" name="Text 0"/>
+          <p:cNvSpPr/>
+          <p:nvPr>
+            <p:ph idx="100" type="title" hasCustomPrompt="1"/>
+          </p:nvPr>
+        </p:nvSpPr>
+        <p:spPr>
+          <a:xfrm>
+            <a:off x="457200" y="274320"/>
+            <a:ext cx="8229600" cy="685800"/>
+          </a:xfrm>
+          <a:prstGeom prst="rect">
+            <a:avLst/>
+          </a:prstGeom>
+          <a:noFill/>
+          <a:ln/>
+        </p:spPr>
+        <p:txBody>
+          <a:bodyPr wrap="square" lIns="0" tIns="0" rIns="0" bIns="0" rtlCol="0" anchor="ctr"/>
+          <a:lstStyle/>
+          <a:p>
+            <a:pPr indent="0" marL="0">
+              <a:buNone/>
+            </a:pPr>
+            <a:r>
+              <a:rPr lang="en-US" sz="2800" b="1" dirty="0">
+                <a:solidFill>
+                  <a:schemeClr val="tx2"/>
+                </a:solidFill>
+              </a:rPr>
+              <a:t>앱은 웹보다 업데이트가 어렵다</a:t>
+            </a:r>
+            <a:endParaRPr lang="en-US" sz="2800" dirty="0"/>
+          </a:p>
+        </p:txBody>
+      </p:sp>
+      <p:sp>
+        <p:nvSpPr>
+          <p:cNvPr id="3" name="card"/>
+          <p:cNvSpPr/>
+          <p:nvPr/>
+        </p:nvSpPr>
+        <p:spPr>
+          <a:xfrm>
+            <a:off x="457200" y="1188720"/>
+            <a:ext cx="2606040" cy="1463040"/>
+          </a:xfrm>
+          <a:prstGeom prst="roundRect">
+            <a:avLst>
+              <a:gd name="adj" fmla="val 5000"/>
+            </a:avLst>
+          </a:prstGeom>
+          <a:solidFill>
+            <a:schemeClr val="bg2"/>
+          </a:solidFill>
+          <a:ln/>
+        </p:spPr>
+      </p:sp>
+      <p:sp>
+        <p:nvSpPr>
+          <p:cNvPr id="4" name="badge1"/>
+          <p:cNvSpPr/>
+          <p:nvPr/>
+        </p:nvSpPr>
+        <p:spPr>
+          <a:xfrm>
+            <a:off x="640080" y="1353312"/>
+            <a:ext cx="384048" cy="384048"/>
+          </a:xfrm>
+          <a:prstGeom prst="ellipse">
+            <a:avLst/>
+          </a:prstGeom>
+          <a:solidFill>
+            <a:schemeClr val="accent5"/>
+          </a:solidFill>
+          <a:ln/>
+        </p:spPr>
+      </p:sp>
+      <p:sp>
+        <p:nvSpPr>
+          <p:cNvPr id="5" name="Text 3"/>
+          <p:cNvSpPr txBox="1"/>
+          <p:nvPr/>
+        </p:nvSpPr>
+        <p:spPr>
+          <a:xfrm>
+            <a:off x="640080" y="1353312"/>
+            <a:ext cx="384048" cy="384048"/>
+          </a:xfrm>
+          <a:prstGeom prst="rect">
+            <a:avLst/>
+          </a:prstGeom>
+          <a:noFill/>
+          <a:ln/>
+        </p:spPr>
+        <p:txBody>
+          <a:bodyPr wrap="square" lIns="0" tIns="0" rIns="0" bIns="0" rtlCol="0" anchor="ctr"/>
+          <a:lstStyle/>
+          <a:p>
+            <a:pPr algn="ctr" indent="0" marL="0">
+              <a:buNone/>
+            </a:pPr>
+            <a:r>
+              <a:rPr lang="en-US" sz="1400" b="1" dirty="0">
+                <a:solidFill>
+                  <a:schemeClr val="bg1"/>
+                </a:solidFill>
+              </a:rPr>
+              <a:t>1</a:t>
+            </a:r>
+            <a:endParaRPr lang="en-US" sz="1400" dirty="0"/>
+          </a:p>
+        </p:txBody>
+      </p:sp>
+      <p:sp>
+        <p:nvSpPr>
+          <p:cNvPr id="6" name="Text 4"/>
+          <p:cNvSpPr txBox="1"/>
+          <p:nvPr/>
+        </p:nvSpPr>
+        <p:spPr>
+          <a:xfrm>
+            <a:off x="1143000" y="1353312"/>
+            <a:ext cx="1828800" cy="384048"/>
+          </a:xfrm>
+          <a:prstGeom prst="rect">
+            <a:avLst/>
+          </a:prstGeom>
+          <a:noFill/>
+          <a:ln/>
+        </p:spPr>
+        <p:txBody>
+          <a:bodyPr wrap="square" lIns="0" tIns="0" rIns="0" bIns="0" rtlCol="0" anchor="ctr"/>
+          <a:lstStyle/>
+          <a:p>
+            <a:pPr indent="0" marL="0">
+              <a:buNone/>
+            </a:pPr>
+            <a:r>
+              <a:rPr lang="en-US" sz="1600" b="1" dirty="0">
+                <a:solidFill>
+                  <a:schemeClr val="tx1"/>
+                </a:solidFill>
+              </a:rPr>
+              <a:t>심사</a:t>
+            </a:r>
+            <a:endParaRPr lang="en-US" sz="1600" dirty="0"/>
+          </a:p>
+        </p:txBody>
+      </p:sp>
+      <p:sp>
+        <p:nvSpPr>
+          <p:cNvPr id="7" name="Text 5"/>
+          <p:cNvSpPr txBox="1"/>
+          <p:nvPr/>
+        </p:nvSpPr>
+        <p:spPr>
+          <a:xfrm>
+            <a:off x="640080" y="1920240"/>
+            <a:ext cx="2286000" cy="548640"/>
+          </a:xfrm>
+          <a:prstGeom prst="rect">
+            <a:avLst/>
+          </a:prstGeom>
+          <a:noFill/>
+          <a:ln/>
+        </p:spPr>
+        <p:txBody>
+          <a:bodyPr wrap="square" lIns="0" tIns="0" rIns="0" bIns="0" rtlCol="0" anchor="t"/>
+          <a:lstStyle/>
+          <a:p>
+            <a:pPr indent="0" marL="0">
+              <a:buNone/>
+            </a:pPr>
+            <a:r>
+              <a:rPr lang="en-US" sz="1300" dirty="0">
+                <a:solidFill>
+                  <a:schemeClr val="accent4"/>
+                </a:solidFill>
+              </a:rPr>
+              <a:t>올려도 마켓 심사를 통과해야 나감</a:t>
+            </a:r>
+            <a:endParaRPr lang="en-US" sz="1300" dirty="0"/>
+          </a:p>
+        </p:txBody>
+      </p:sp>
+      <p:sp>
+        <p:nvSpPr>
+          <p:cNvPr id="8" name="card"/>
+          <p:cNvSpPr/>
+          <p:nvPr/>
+        </p:nvSpPr>
+        <p:spPr>
+          <a:xfrm>
+            <a:off x="3246120" y="1188720"/>
+            <a:ext cx="2606040" cy="1463040"/>
+          </a:xfrm>
+          <a:prstGeom prst="roundRect">
+            <a:avLst>
+              <a:gd name="adj" fmla="val 5000"/>
+            </a:avLst>
+          </a:prstGeom>
+          <a:solidFill>
+            <a:schemeClr val="bg2"/>
+          </a:solidFill>
+          <a:ln/>
+        </p:spPr>
+      </p:sp>
+      <p:sp>
+        <p:nvSpPr>
+          <p:cNvPr id="9" name="badge2"/>
+          <p:cNvSpPr/>
+          <p:nvPr/>
+        </p:nvSpPr>
+        <p:spPr>
+          <a:xfrm>
+            <a:off x="3429000" y="1353312"/>
+            <a:ext cx="384048" cy="384048"/>
+          </a:xfrm>
+          <a:prstGeom prst="ellipse">
+            <a:avLst/>
+          </a:prstGeom>
+          <a:solidFill>
+            <a:schemeClr val="accent5"/>
+          </a:solidFill>
+          <a:ln/>
+        </p:spPr>
+      </p:sp>
+      <p:sp>
+        <p:nvSpPr>
+          <p:cNvPr id="10" name="Text 8"/>
+          <p:cNvSpPr txBox="1"/>
+          <p:nvPr/>
+        </p:nvSpPr>
+        <p:spPr>
+          <a:xfrm>
+            <a:off x="3429000" y="1353312"/>
+            <a:ext cx="384048" cy="384048"/>
+          </a:xfrm>
+          <a:prstGeom prst="rect">
+            <a:avLst/>
+          </a:prstGeom>
+          <a:noFill/>
+          <a:ln/>
+        </p:spPr>
+        <p:txBody>
+          <a:bodyPr wrap="square" lIns="0" tIns="0" rIns="0" bIns="0" rtlCol="0" anchor="ctr"/>
+          <a:lstStyle/>
+          <a:p>
+            <a:pPr algn="ctr" indent="0" marL="0">
+              <a:buNone/>
+            </a:pPr>
+            <a:r>
+              <a:rPr lang="en-US" sz="1400" b="1" dirty="0">
+                <a:solidFill>
+                  <a:schemeClr val="bg1"/>
+                </a:solidFill>
+              </a:rPr>
+              <a:t>2</a:t>
+            </a:r>
+            <a:endParaRPr lang="en-US" sz="1400" dirty="0"/>
+          </a:p>
+        </p:txBody>
+      </p:sp>
+      <p:sp>
+        <p:nvSpPr>
+          <p:cNvPr id="11" name="Text 9"/>
+          <p:cNvSpPr txBox="1"/>
+          <p:nvPr/>
+        </p:nvSpPr>
+        <p:spPr>
+          <a:xfrm>
+            <a:off x="3931920" y="1353312"/>
+            <a:ext cx="1828800" cy="384048"/>
+          </a:xfrm>
+          <a:prstGeom prst="rect">
+            <a:avLst/>
+          </a:prstGeom>
+          <a:noFill/>
+          <a:ln/>
+        </p:spPr>
+        <p:txBody>
+          <a:bodyPr wrap="square" lIns="0" tIns="0" rIns="0" bIns="0" rtlCol="0" anchor="ctr"/>
+          <a:lstStyle/>
+          <a:p>
+            <a:pPr indent="0" marL="0">
+              <a:buNone/>
+            </a:pPr>
+            <a:r>
+              <a:rPr lang="en-US" sz="1600" b="1" dirty="0">
+                <a:solidFill>
+                  <a:schemeClr val="tx1"/>
+                </a:solidFill>
+              </a:rPr>
+              <a:t>되돌리기 불가</a:t>
+            </a:r>
+            <a:endParaRPr lang="en-US" sz="1600" dirty="0"/>
+          </a:p>
+        </p:txBody>
+      </p:sp>
+      <p:sp>
+        <p:nvSpPr>
+          <p:cNvPr id="12" name="Text 10"/>
+          <p:cNvSpPr txBox="1"/>
+          <p:nvPr/>
+        </p:nvSpPr>
+        <p:spPr>
+          <a:xfrm>
+            <a:off x="3429000" y="1920240"/>
+            <a:ext cx="2286000" cy="548640"/>
+          </a:xfrm>
+          <a:prstGeom prst="rect">
+            <a:avLst/>
+          </a:prstGeom>
+          <a:noFill/>
+          <a:ln/>
+        </p:spPr>
+        <p:txBody>
+          <a:bodyPr wrap="square" lIns="0" tIns="0" rIns="0" bIns="0" rtlCol="0" anchor="t"/>
+          <a:lstStyle/>
+          <a:p>
+            <a:pPr indent="0" marL="0">
+              <a:buNone/>
+            </a:pPr>
+            <a:r>
+              <a:rPr lang="en-US" sz="1300" dirty="0">
+                <a:solidFill>
+                  <a:schemeClr val="accent4"/>
+                </a:solidFill>
+              </a:rPr>
+              <a:t>이미 깔린 버전은 되돌릴 수 없음</a:t>
+            </a:r>
+            <a:endParaRPr lang="en-US" sz="1300" dirty="0"/>
+          </a:p>
+        </p:txBody>
+      </p:sp>
+      <p:sp>
+        <p:nvSpPr>
+          <p:cNvPr id="13" name="card"/>
+          <p:cNvSpPr/>
+          <p:nvPr/>
+        </p:nvSpPr>
+        <p:spPr>
+          <a:xfrm>
+            <a:off x="6035040" y="1188720"/>
+            <a:ext cx="2606040" cy="1463040"/>
+          </a:xfrm>
+          <a:prstGeom prst="roundRect">
+            <a:avLst>
+              <a:gd name="adj" fmla="val 5000"/>
+            </a:avLst>
+          </a:prstGeom>
+          <a:solidFill>
+            <a:schemeClr val="bg2"/>
+          </a:solidFill>
+          <a:ln/>
+        </p:spPr>
+      </p:sp>
+      <p:sp>
+        <p:nvSpPr>
+          <p:cNvPr id="14" name="badge3"/>
+          <p:cNvSpPr/>
+          <p:nvPr/>
+        </p:nvSpPr>
+        <p:spPr>
+          <a:xfrm>
+            <a:off x="6217920" y="1353312"/>
+            <a:ext cx="384048" cy="384048"/>
+          </a:xfrm>
+          <a:prstGeom prst="ellipse">
+            <a:avLst/>
+          </a:prstGeom>
+          <a:solidFill>
+            <a:schemeClr val="accent5"/>
+          </a:solidFill>
+          <a:ln/>
+        </p:spPr>
+      </p:sp>
+      <p:sp>
+        <p:nvSpPr>
+          <p:cNvPr id="15" name="Text 13"/>
+          <p:cNvSpPr txBox="1"/>
+          <p:nvPr/>
+        </p:nvSpPr>
+        <p:spPr>
+          <a:xfrm>
+            <a:off x="6217920" y="1353312"/>
+            <a:ext cx="384048" cy="384048"/>
+          </a:xfrm>
+          <a:prstGeom prst="rect">
+            <a:avLst/>
+          </a:prstGeom>
+          <a:noFill/>
+          <a:ln/>
+        </p:spPr>
+        <p:txBody>
+          <a:bodyPr wrap="square" lIns="0" tIns="0" rIns="0" bIns="0" rtlCol="0" anchor="ctr"/>
+          <a:lstStyle/>
+          <a:p>
+            <a:pPr algn="ctr" indent="0" marL="0">
+              <a:buNone/>
+            </a:pPr>
+            <a:r>
+              <a:rPr lang="en-US" sz="1400" b="1" dirty="0">
+                <a:solidFill>
+                  <a:schemeClr val="bg1"/>
+                </a:solidFill>
+              </a:rPr>
+              <a:t>3</a:t>
+            </a:r>
+            <a:endParaRPr lang="en-US" sz="1400" dirty="0"/>
+          </a:p>
+        </p:txBody>
+      </p:sp>
+      <p:sp>
+        <p:nvSpPr>
+          <p:cNvPr id="16" name="Text 14"/>
+          <p:cNvSpPr txBox="1"/>
+          <p:nvPr/>
+        </p:nvSpPr>
+        <p:spPr>
+          <a:xfrm>
+            <a:off x="6720840" y="1353312"/>
+            <a:ext cx="1828800" cy="384048"/>
+          </a:xfrm>
+          <a:prstGeom prst="rect">
+            <a:avLst/>
+          </a:prstGeom>
+          <a:noFill/>
+          <a:ln/>
+        </p:spPr>
+        <p:txBody>
+          <a:bodyPr wrap="square" lIns="0" tIns="0" rIns="0" bIns="0" rtlCol="0" anchor="ctr"/>
+          <a:lstStyle/>
+          <a:p>
+            <a:pPr indent="0" marL="0">
+              <a:buNone/>
+            </a:pPr>
+            <a:r>
+              <a:rPr lang="en-US" sz="1600" b="1" dirty="0">
+                <a:solidFill>
+                  <a:schemeClr val="tx1"/>
+                </a:solidFill>
+              </a:rPr>
+              <a:t>옛 버전 공존</a:t>
+            </a:r>
+            <a:endParaRPr lang="en-US" sz="1600" dirty="0"/>
+          </a:p>
+        </p:txBody>
+      </p:sp>
+      <p:sp>
+        <p:nvSpPr>
+          <p:cNvPr id="17" name="Text 15"/>
+          <p:cNvSpPr txBox="1"/>
+          <p:nvPr/>
+        </p:nvSpPr>
+        <p:spPr>
+          <a:xfrm>
+            <a:off x="6217920" y="1920240"/>
+            <a:ext cx="2286000" cy="548640"/>
+          </a:xfrm>
+          <a:prstGeom prst="rect">
+            <a:avLst/>
+          </a:prstGeom>
+          <a:noFill/>
+          <a:ln/>
+        </p:spPr>
+        <p:txBody>
+          <a:bodyPr wrap="square" lIns="0" tIns="0" rIns="0" bIns="0" rtlCol="0" anchor="t"/>
+          <a:lstStyle/>
+          <a:p>
+            <a:pPr indent="0" marL="0">
+              <a:buNone/>
+            </a:pPr>
+            <a:r>
+              <a:rPr lang="en-US" sz="1300" dirty="0">
+                <a:solidFill>
+                  <a:schemeClr val="accent4"/>
+                </a:solidFill>
+              </a:rPr>
+              <a:t>업데이트 안 한 사람이 계속 남음</a:t>
+            </a:r>
+            <a:endParaRPr lang="en-US" sz="1300" dirty="0"/>
+          </a:p>
+        </p:txBody>
+      </p:sp>
+      <p:sp>
+        <p:nvSpPr>
+          <p:cNvPr id="18" name="card"/>
+          <p:cNvSpPr/>
+          <p:nvPr/>
+        </p:nvSpPr>
+        <p:spPr>
+          <a:xfrm>
+            <a:off x="457200" y="2880360"/>
+            <a:ext cx="8229600" cy="1508760"/>
+          </a:xfrm>
+          <a:prstGeom prst="roundRect">
+            <a:avLst>
+              <a:gd name="adj" fmla="val 4848"/>
+            </a:avLst>
+          </a:prstGeom>
+          <a:solidFill>
+            <a:schemeClr val="tx2"/>
+          </a:solidFill>
+          <a:ln/>
+        </p:spPr>
+      </p:sp>
+      <p:sp>
+        <p:nvSpPr>
+          <p:cNvPr id="19" name="Text 17"/>
+          <p:cNvSpPr txBox="1"/>
+          <p:nvPr/>
+        </p:nvSpPr>
+        <p:spPr>
+          <a:xfrm>
+            <a:off x="731520" y="3017520"/>
+            <a:ext cx="7680960" cy="365760"/>
+          </a:xfrm>
+          <a:prstGeom prst="rect">
+            <a:avLst/>
+          </a:prstGeom>
+          <a:noFill/>
+          <a:ln/>
+        </p:spPr>
+        <p:txBody>
+          <a:bodyPr wrap="square" lIns="0" tIns="0" rIns="0" bIns="0" rtlCol="0" anchor="t"/>
+          <a:lstStyle/>
+          <a:p>
+            <a:pPr indent="0" marL="0">
+              <a:buNone/>
+            </a:pPr>
+            <a:r>
+              <a:rPr lang="en-US" sz="1600" b="1" dirty="0">
+                <a:solidFill>
+                  <a:schemeClr val="accent6"/>
+                </a:solidFill>
+              </a:rPr>
+              <a:t>그래서 쓰는 장치</a:t>
+            </a:r>
+            <a:endParaRPr lang="en-US" sz="1600" dirty="0"/>
+          </a:p>
+        </p:txBody>
+      </p:sp>
+      <p:sp>
+        <p:nvSpPr>
+          <p:cNvPr id="20" name="Text 18"/>
+          <p:cNvSpPr txBox="1"/>
+          <p:nvPr/>
+        </p:nvSpPr>
+        <p:spPr>
+          <a:xfrm>
+            <a:off x="731520" y="3429000"/>
+            <a:ext cx="7680960" cy="822960"/>
+          </a:xfrm>
+          <a:prstGeom prst="rect">
+            <a:avLst/>
+          </a:prstGeom>
+          <a:noFill/>
+          <a:ln/>
+        </p:spPr>
+        <p:txBody>
+          <a:bodyPr wrap="square" lIns="0" tIns="0" rIns="0" bIns="0" rtlCol="0" anchor="t"/>
+          <a:lstStyle/>
+          <a:p>
+            <a:pPr indent="0" marL="0">
+              <a:buNone/>
+            </a:pPr>
+            <a:r>
+              <a:rPr lang="en-US" sz="1300" dirty="0">
+                <a:solidFill>
+                  <a:schemeClr val="bg1"/>
+                </a:solidFill>
+              </a:rPr>
+              <a:t>단계적 출시 · 베타 테스트 · 기능 플래그 · 서버에서 설정 바꾸기 · 강제 업데이트 · 크래시 리포트</a:t>
+            </a:r>
+            <a:endParaRPr lang="en-US" sz="1300" dirty="0"/>
+          </a:p>
+          <a:p>
+            <a:pPr indent="0" marL="0">
+              <a:buNone/>
+            </a:pPr>
+            <a:r>
+              <a:rPr lang="en-US" sz="1300" dirty="0">
+                <a:solidFill>
+                  <a:schemeClr val="bg1"/>
+                </a:solidFill>
+              </a:rPr>
+              <a:t>디지털 상품 결제엔 앱 마켓 수수료 15–30% (조건에 따라)</a:t>
+            </a:r>
+            <a:endParaRPr lang="en-US" sz="1300" dirty="0"/>
+          </a:p>
+        </p:txBody>
+      </p:sp>
+      <p:sp>
+        <p:nvSpPr>
+          <p:cNvPr id="25" name="Slide Number Placeholder 0"/>
+          <p:cNvSpPr>
+            <a:spLocks noGrp="1"/>
+          </p:cNvSpPr>
+          <p:nvPr>
+            <p:ph type="sldNum" sz="quarter" idx="4294967295"/>
+          </p:nvPr>
+        </p:nvSpPr>
+        <p:spPr>
+          <a:xfrm>
+            <a:off x="8321040" y="4754880"/>
+            <a:ext cx="457200" cy="274320"/>
+          </a:xfrm>
+          <a:prstGeom prst="rect">
+            <a:avLst/>
+          </a:prstGeom>
+          <a:extLst>
+            <a:ext uri="{C572A759-6A51-4108-AA02-DFA0A04FC94B}">
+              <ma14:wrappingTextBoxFlag xmlns:ma14="http://schemas.microsoft.com/office/mac/drawingml/2011/main" val="0"/>
+            </a:ext>
+          </a:extLst>
+        </p:spPr>
+        <p:txBody>
+          <a:bodyPr/>
+          <a:lstStyle>
+            <a:lvl1pPr>
+              <a:defRPr sz="1000">
+                <a:solidFill>
+                  <a:schemeClr val="accent4"/>
+                </a:solidFill>
+              </a:defRPr>
+            </a:lvl1pPr>
+          </a:lstStyle>
+          <a:p>
+            <a:pPr algn="r"/>
+            <a:fld id="{F7021451-1387-4CA6-816F-3879F97B5CBC}" type="slidenum">
+              <a:rPr b="0" lang="en-US"/>
+              <a:t>33</a:t>
+            </a:fld>
+            <a:endParaRPr lang="en-US"/>
+          </a:p>
+        </p:txBody>
+      </p:sp>
+    </p:spTree>
+  </p:cSld>
+  <p:clrMapOvr>
+    <a:masterClrMapping/>
+  </p:clrMapOvr>
+</p:sld>
+</file>
+
+<file path=ppt/slides/slide34.xml><?xml version="1.0" encoding="utf-8"?>
+<p:sld xmlns:a="http://schemas.openxmlformats.org/drawingml/2006/main" xmlns:r="http://schemas.openxmlformats.org/officeDocument/2006/relationships" xmlns:p="http://schemas.openxmlformats.org/presentationml/2006/main">
+  <p:cSld name="Slide 34">
+    <p:spTree>
+      <p:nvGrpSpPr>
+        <p:cNvPr id="1" name=""/>
+        <p:cNvGrpSpPr/>
+        <p:nvPr/>
+      </p:nvGrpSpPr>
+      <p:grpSpPr>
+        <a:xfrm>
+          <a:off x="0" y="0"/>
+          <a:ext cx="0" cy="0"/>
+          <a:chOff x="0" y="0"/>
+          <a:chExt cx="0" cy="0"/>
+        </a:xfrm>
+      </p:grpSpPr>
+      <p:sp>
+        <p:nvSpPr>
+          <p:cNvPr id="2" name="Text 0"/>
+          <p:cNvSpPr/>
+          <p:nvPr>
+            <p:ph idx="100" type="title" hasCustomPrompt="1"/>
+          </p:nvPr>
+        </p:nvSpPr>
+        <p:spPr>
+          <a:xfrm>
+            <a:off x="457200" y="274320"/>
+            <a:ext cx="8229600" cy="685800"/>
+          </a:xfrm>
+          <a:prstGeom prst="rect">
+            <a:avLst/>
+          </a:prstGeom>
+          <a:noFill/>
+          <a:ln/>
+        </p:spPr>
+        <p:txBody>
+          <a:bodyPr wrap="square" lIns="0" tIns="0" rIns="0" bIns="0" rtlCol="0" anchor="ctr"/>
+          <a:lstStyle/>
+          <a:p>
+            <a:pPr indent="0" marL="0">
+              <a:buNone/>
+            </a:pPr>
+            <a:r>
+              <a:rPr lang="en-US" sz="2800" b="1" dirty="0">
+                <a:solidFill>
+                  <a:schemeClr val="tx2"/>
+                </a:solidFill>
+              </a:rPr>
+              <a:t>지식·외주 판매와 중개 플랫폼</a:t>
+            </a:r>
+            <a:endParaRPr lang="en-US" sz="2800" dirty="0"/>
+          </a:p>
+        </p:txBody>
+      </p:sp>
+      <p:sp>
+        <p:nvSpPr>
+          <p:cNvPr id="3" name="Text 1"/>
+          <p:cNvSpPr txBox="1"/>
+          <p:nvPr/>
+        </p:nvSpPr>
+        <p:spPr>
+          <a:xfrm>
+            <a:off x="457200" y="1188720"/>
+            <a:ext cx="3840480" cy="365760"/>
+          </a:xfrm>
+          <a:prstGeom prst="rect">
+            <a:avLst/>
+          </a:prstGeom>
+          <a:noFill/>
+          <a:ln/>
+        </p:spPr>
+        <p:txBody>
+          <a:bodyPr wrap="square" lIns="0" tIns="0" rIns="0" bIns="0" rtlCol="0" anchor="t"/>
+          <a:lstStyle/>
+          <a:p>
+            <a:pPr indent="0" marL="0">
+              <a:buNone/>
+            </a:pPr>
+            <a:r>
+              <a:rPr lang="en-US" sz="1600" b="1" dirty="0">
+                <a:solidFill>
+                  <a:schemeClr val="accent2"/>
+                </a:solidFill>
+              </a:rPr>
+              <a:t>지식·외주 (26장)</a:t>
+            </a:r>
+            <a:endParaRPr lang="en-US" sz="1600" dirty="0"/>
+          </a:p>
+        </p:txBody>
+      </p:sp>
+      <p:sp>
+        <p:nvSpPr>
+          <p:cNvPr id="4" name="badge1"/>
+          <p:cNvSpPr/>
+          <p:nvPr/>
+        </p:nvSpPr>
+        <p:spPr>
+          <a:xfrm>
+            <a:off x="457200" y="1691640"/>
+            <a:ext cx="384048" cy="384048"/>
+          </a:xfrm>
+          <a:prstGeom prst="ellipse">
+            <a:avLst/>
+          </a:prstGeom>
+          <a:solidFill>
+            <a:schemeClr val="tx2"/>
+          </a:solidFill>
+          <a:ln/>
+        </p:spPr>
+      </p:sp>
+      <p:sp>
+        <p:nvSpPr>
+          <p:cNvPr id="5" name="Text 3"/>
+          <p:cNvSpPr txBox="1"/>
+          <p:nvPr/>
+        </p:nvSpPr>
+        <p:spPr>
+          <a:xfrm>
+            <a:off x="457200" y="1691640"/>
+            <a:ext cx="384048" cy="384048"/>
+          </a:xfrm>
+          <a:prstGeom prst="rect">
+            <a:avLst/>
+          </a:prstGeom>
+          <a:noFill/>
+          <a:ln/>
+        </p:spPr>
+        <p:txBody>
+          <a:bodyPr wrap="square" lIns="0" tIns="0" rIns="0" bIns="0" rtlCol="0" anchor="ctr"/>
+          <a:lstStyle/>
+          <a:p>
+            <a:pPr algn="ctr" indent="0" marL="0">
+              <a:buNone/>
+            </a:pPr>
+            <a:r>
+              <a:rPr lang="en-US" sz="1400" b="1" dirty="0">
+                <a:solidFill>
+                  <a:schemeClr val="bg1"/>
+                </a:solidFill>
+              </a:rPr>
+              <a:t>1</a:t>
+            </a:r>
+            <a:endParaRPr lang="en-US" sz="1400" dirty="0"/>
+          </a:p>
+        </p:txBody>
+      </p:sp>
+      <p:sp>
+        <p:nvSpPr>
+          <p:cNvPr id="6" name="Text 4"/>
+          <p:cNvSpPr txBox="1"/>
+          <p:nvPr/>
+        </p:nvSpPr>
+        <p:spPr>
+          <a:xfrm>
+            <a:off x="960120" y="1645920"/>
+            <a:ext cx="3383280" cy="731520"/>
+          </a:xfrm>
+          <a:prstGeom prst="rect">
+            <a:avLst/>
+          </a:prstGeom>
+          <a:noFill/>
+          <a:ln/>
+        </p:spPr>
+        <p:txBody>
+          <a:bodyPr wrap="square" lIns="0" tIns="0" rIns="0" bIns="0" rtlCol="0" anchor="t"/>
+          <a:lstStyle/>
+          <a:p>
+            <a:pPr indent="0" marL="0">
+              <a:buNone/>
+            </a:pPr>
+            <a:r>
+              <a:rPr lang="en-US" sz="1500" b="1" dirty="0">
+                <a:solidFill>
+                  <a:schemeClr val="tx1"/>
+                </a:solidFill>
+              </a:rPr>
+              <a:t>디지털 상품</a:t>
+            </a:r>
+            <a:endParaRPr lang="en-US" sz="1500" dirty="0"/>
+          </a:p>
+          <a:p>
+            <a:pPr indent="0" marL="0">
+              <a:buNone/>
+            </a:pPr>
+            <a:r>
+              <a:rPr lang="en-US" sz="1200" dirty="0">
+                <a:solidFill>
+                  <a:schemeClr val="accent4"/>
+                </a:solidFill>
+              </a:rPr>
+              <a:t>한 번 만들어 계속 판매</a:t>
+            </a:r>
+            <a:endParaRPr lang="en-US" sz="1500" dirty="0"/>
+          </a:p>
+        </p:txBody>
+      </p:sp>
+      <p:sp>
+        <p:nvSpPr>
+          <p:cNvPr id="7" name="badge2"/>
+          <p:cNvSpPr/>
+          <p:nvPr/>
+        </p:nvSpPr>
+        <p:spPr>
+          <a:xfrm>
+            <a:off x="457200" y="2560320"/>
+            <a:ext cx="384048" cy="384048"/>
+          </a:xfrm>
+          <a:prstGeom prst="ellipse">
+            <a:avLst/>
+          </a:prstGeom>
+          <a:solidFill>
+            <a:schemeClr val="tx2"/>
+          </a:solidFill>
+          <a:ln/>
+        </p:spPr>
+      </p:sp>
+      <p:sp>
+        <p:nvSpPr>
+          <p:cNvPr id="8" name="Text 6"/>
+          <p:cNvSpPr txBox="1"/>
+          <p:nvPr/>
+        </p:nvSpPr>
+        <p:spPr>
+          <a:xfrm>
+            <a:off x="457200" y="2560320"/>
+            <a:ext cx="384048" cy="384048"/>
+          </a:xfrm>
+          <a:prstGeom prst="rect">
+            <a:avLst/>
+          </a:prstGeom>
+          <a:noFill/>
+          <a:ln/>
+        </p:spPr>
+        <p:txBody>
+          <a:bodyPr wrap="square" lIns="0" tIns="0" rIns="0" bIns="0" rtlCol="0" anchor="ctr"/>
+          <a:lstStyle/>
+          <a:p>
+            <a:pPr algn="ctr" indent="0" marL="0">
+              <a:buNone/>
+            </a:pPr>
+            <a:r>
+              <a:rPr lang="en-US" sz="1400" b="1" dirty="0">
+                <a:solidFill>
+                  <a:schemeClr val="bg1"/>
+                </a:solidFill>
+              </a:rPr>
+              <a:t>2</a:t>
+            </a:r>
+            <a:endParaRPr lang="en-US" sz="1400" dirty="0"/>
+          </a:p>
+        </p:txBody>
+      </p:sp>
+      <p:sp>
+        <p:nvSpPr>
+          <p:cNvPr id="9" name="Text 7"/>
+          <p:cNvSpPr txBox="1"/>
+          <p:nvPr/>
+        </p:nvSpPr>
+        <p:spPr>
+          <a:xfrm>
+            <a:off x="960120" y="2514600"/>
+            <a:ext cx="3383280" cy="731520"/>
+          </a:xfrm>
+          <a:prstGeom prst="rect">
+            <a:avLst/>
+          </a:prstGeom>
+          <a:noFill/>
+          <a:ln/>
+        </p:spPr>
+        <p:txBody>
+          <a:bodyPr wrap="square" lIns="0" tIns="0" rIns="0" bIns="0" rtlCol="0" anchor="t"/>
+          <a:lstStyle/>
+          <a:p>
+            <a:pPr indent="0" marL="0">
+              <a:buNone/>
+            </a:pPr>
+            <a:r>
+              <a:rPr lang="en-US" sz="1500" b="1" dirty="0">
+                <a:solidFill>
+                  <a:schemeClr val="tx1"/>
+                </a:solidFill>
+              </a:rPr>
+              <a:t>강의·코칭</a:t>
+            </a:r>
+            <a:endParaRPr lang="en-US" sz="1500" dirty="0"/>
+          </a:p>
+          <a:p>
+            <a:pPr indent="0" marL="0">
+              <a:buNone/>
+            </a:pPr>
+            <a:r>
+              <a:rPr lang="en-US" sz="1200" dirty="0">
+                <a:solidFill>
+                  <a:schemeClr val="accent4"/>
+                </a:solidFill>
+              </a:rPr>
+              <a:t>만들기 전 사전 신청으로 수요 확인</a:t>
+            </a:r>
+            <a:endParaRPr lang="en-US" sz="1500" dirty="0"/>
+          </a:p>
+        </p:txBody>
+      </p:sp>
+      <p:sp>
+        <p:nvSpPr>
+          <p:cNvPr id="10" name="badge3"/>
+          <p:cNvSpPr/>
+          <p:nvPr/>
+        </p:nvSpPr>
+        <p:spPr>
+          <a:xfrm>
+            <a:off x="457200" y="3429000"/>
+            <a:ext cx="384048" cy="384048"/>
+          </a:xfrm>
+          <a:prstGeom prst="ellipse">
+            <a:avLst/>
+          </a:prstGeom>
+          <a:solidFill>
+            <a:schemeClr val="tx2"/>
+          </a:solidFill>
+          <a:ln/>
+        </p:spPr>
+      </p:sp>
+      <p:sp>
+        <p:nvSpPr>
+          <p:cNvPr id="11" name="Text 9"/>
+          <p:cNvSpPr txBox="1"/>
+          <p:nvPr/>
+        </p:nvSpPr>
+        <p:spPr>
+          <a:xfrm>
+            <a:off x="457200" y="3429000"/>
+            <a:ext cx="384048" cy="384048"/>
+          </a:xfrm>
+          <a:prstGeom prst="rect">
+            <a:avLst/>
+          </a:prstGeom>
+          <a:noFill/>
+          <a:ln/>
+        </p:spPr>
+        <p:txBody>
+          <a:bodyPr wrap="square" lIns="0" tIns="0" rIns="0" bIns="0" rtlCol="0" anchor="ctr"/>
+          <a:lstStyle/>
+          <a:p>
+            <a:pPr algn="ctr" indent="0" marL="0">
+              <a:buNone/>
+            </a:pPr>
+            <a:r>
+              <a:rPr lang="en-US" sz="1400" b="1" dirty="0">
+                <a:solidFill>
+                  <a:schemeClr val="bg1"/>
+                </a:solidFill>
+              </a:rPr>
+              <a:t>3</a:t>
+            </a:r>
+            <a:endParaRPr lang="en-US" sz="1400" dirty="0"/>
+          </a:p>
+        </p:txBody>
+      </p:sp>
+      <p:sp>
+        <p:nvSpPr>
+          <p:cNvPr id="12" name="Text 10"/>
+          <p:cNvSpPr txBox="1"/>
+          <p:nvPr/>
+        </p:nvSpPr>
+        <p:spPr>
+          <a:xfrm>
+            <a:off x="960120" y="3383280"/>
+            <a:ext cx="3383280" cy="731520"/>
+          </a:xfrm>
+          <a:prstGeom prst="rect">
+            <a:avLst/>
+          </a:prstGeom>
+          <a:noFill/>
+          <a:ln/>
+        </p:spPr>
+        <p:txBody>
+          <a:bodyPr wrap="square" lIns="0" tIns="0" rIns="0" bIns="0" rtlCol="0" anchor="t"/>
+          <a:lstStyle/>
+          <a:p>
+            <a:pPr indent="0" marL="0">
+              <a:buNone/>
+            </a:pPr>
+            <a:r>
+              <a:rPr lang="en-US" sz="1500" b="1" dirty="0">
+                <a:solidFill>
+                  <a:schemeClr val="tx1"/>
+                </a:solidFill>
+              </a:rPr>
+              <a:t>외주</a:t>
+            </a:r>
+            <a:endParaRPr lang="en-US" sz="1500" dirty="0"/>
+          </a:p>
+          <a:p>
+            <a:pPr indent="0" marL="0">
+              <a:buNone/>
+            </a:pPr>
+            <a:r>
+              <a:rPr lang="en-US" sz="1200" dirty="0">
+                <a:solidFill>
+                  <a:schemeClr val="accent4"/>
+                </a:solidFill>
+              </a:rPr>
+              <a:t>계약서: 범위·수정 횟수·저작권</a:t>
+            </a:r>
+            <a:endParaRPr lang="en-US" sz="1500" dirty="0"/>
+          </a:p>
+        </p:txBody>
+      </p:sp>
+      <p:sp>
+        <p:nvSpPr>
+          <p:cNvPr id="13" name="card"/>
+          <p:cNvSpPr/>
+          <p:nvPr/>
+        </p:nvSpPr>
+        <p:spPr>
+          <a:xfrm>
+            <a:off x="4572000" y="1188720"/>
+            <a:ext cx="4114800" cy="3200400"/>
+          </a:xfrm>
+          <a:prstGeom prst="roundRect">
+            <a:avLst>
+              <a:gd name="adj" fmla="val 2286"/>
+            </a:avLst>
+          </a:prstGeom>
+          <a:solidFill>
+            <a:schemeClr val="bg2"/>
+          </a:solidFill>
+          <a:ln/>
+        </p:spPr>
+      </p:sp>
+      <p:sp>
+        <p:nvSpPr>
+          <p:cNvPr id="14" name="Text 12"/>
+          <p:cNvSpPr txBox="1"/>
+          <p:nvPr/>
+        </p:nvSpPr>
+        <p:spPr>
+          <a:xfrm>
+            <a:off x="4800600" y="1325880"/>
+            <a:ext cx="3657600" cy="365760"/>
+          </a:xfrm>
+          <a:prstGeom prst="rect">
+            <a:avLst/>
+          </a:prstGeom>
+          <a:noFill/>
+          <a:ln/>
+        </p:spPr>
+        <p:txBody>
+          <a:bodyPr wrap="square" lIns="0" tIns="0" rIns="0" bIns="0" rtlCol="0" anchor="t"/>
+          <a:lstStyle/>
+          <a:p>
+            <a:pPr indent="0" marL="0">
+              <a:buNone/>
+            </a:pPr>
+            <a:r>
+              <a:rPr lang="en-US" sz="1600" b="1" dirty="0">
+                <a:solidFill>
+                  <a:schemeClr val="tx2"/>
+                </a:solidFill>
+              </a:rPr>
+              <a:t>중개 플랫폼 (27장)</a:t>
+            </a:r>
+            <a:endParaRPr lang="en-US" sz="1600" dirty="0"/>
+          </a:p>
+        </p:txBody>
+      </p:sp>
+      <p:sp>
+        <p:nvSpPr>
+          <p:cNvPr id="15" name="Text 13"/>
+          <p:cNvSpPr txBox="1"/>
+          <p:nvPr/>
+        </p:nvSpPr>
+        <p:spPr>
+          <a:xfrm>
+            <a:off x="4800600" y="1783080"/>
+            <a:ext cx="3703320" cy="2468880"/>
+          </a:xfrm>
+          <a:prstGeom prst="rect">
+            <a:avLst/>
+          </a:prstGeom>
+          <a:noFill/>
+          <a:ln/>
+        </p:spPr>
+        <p:txBody>
+          <a:bodyPr wrap="square" lIns="0" tIns="0" rIns="0" bIns="0" rtlCol="0" anchor="t"/>
+          <a:lstStyle/>
+          <a:p>
+            <a:pPr marL="342900" indent="-342900">
+              <a:spcAft>
+                <a:spcPts val="800"/>
+              </a:spcAft>
+              <a:buSzPct val="100000"/>
+              <a:buChar char="•"/>
+            </a:pPr>
+            <a:r>
+              <a:rPr lang="en-US" sz="1400" dirty="0">
+                <a:solidFill>
+                  <a:schemeClr val="tx1"/>
+                </a:solidFill>
+              </a:rPr>
+              <a:t>한쪽 먼저, 좁은 지역·분야부터</a:t>
+            </a:r>
+            <a:endParaRPr lang="en-US" sz="1400" dirty="0"/>
+          </a:p>
+          <a:p>
+            <a:pPr marL="342900" indent="-342900">
+              <a:spcAft>
+                <a:spcPts val="800"/>
+              </a:spcAft>
+              <a:buSzPct val="100000"/>
+              <a:buChar char="•"/>
+            </a:pPr>
+            <a:r>
+              <a:rPr lang="en-US" sz="1400" dirty="0">
+                <a:solidFill>
+                  <a:schemeClr val="tx1"/>
+                </a:solidFill>
+              </a:rPr>
+              <a:t>신뢰 장치: 본인 확인·리뷰·안전결제</a:t>
+            </a:r>
+            <a:endParaRPr lang="en-US" sz="1400" dirty="0"/>
+          </a:p>
+          <a:p>
+            <a:pPr marL="342900" indent="-342900">
+              <a:spcAft>
+                <a:spcPts val="800"/>
+              </a:spcAft>
+              <a:buSzPct val="100000"/>
+              <a:buChar char="•"/>
+            </a:pPr>
+            <a:r>
+              <a:rPr lang="en-US" sz="1400" dirty="0">
+                <a:solidFill>
+                  <a:schemeClr val="tx1"/>
+                </a:solidFill>
+              </a:rPr>
+              <a:t>탈중개(직거래) 막을 혜택 만들기</a:t>
+            </a:r>
+            <a:endParaRPr lang="en-US" sz="1400" dirty="0"/>
+          </a:p>
+          <a:p>
+            <a:pPr marL="342900" indent="-342900">
+              <a:spcAft>
+                <a:spcPts val="800"/>
+              </a:spcAft>
+              <a:buSzPct val="100000"/>
+              <a:buChar char="•"/>
+            </a:pPr>
+            <a:r>
+              <a:rPr lang="en-US" sz="1400" dirty="0">
+                <a:solidFill>
+                  <a:schemeClr val="tx1"/>
+                </a:solidFill>
+              </a:rPr>
+              <a:t>구인구직·결혼중개·숙박·의료는 업종별 신고·등록 확인</a:t>
+            </a:r>
+            <a:endParaRPr lang="en-US" sz="1400" dirty="0"/>
+          </a:p>
+        </p:txBody>
+      </p:sp>
+      <p:sp>
+        <p:nvSpPr>
+          <p:cNvPr id="25" name="Slide Number Placeholder 0"/>
+          <p:cNvSpPr>
+            <a:spLocks noGrp="1"/>
+          </p:cNvSpPr>
+          <p:nvPr>
+            <p:ph type="sldNum" sz="quarter" idx="4294967295"/>
+          </p:nvPr>
+        </p:nvSpPr>
+        <p:spPr>
+          <a:xfrm>
+            <a:off x="8321040" y="4754880"/>
+            <a:ext cx="457200" cy="274320"/>
+          </a:xfrm>
+          <a:prstGeom prst="rect">
+            <a:avLst/>
+          </a:prstGeom>
+          <a:extLst>
+            <a:ext uri="{C572A759-6A51-4108-AA02-DFA0A04FC94B}">
+              <ma14:wrappingTextBoxFlag xmlns:ma14="http://schemas.microsoft.com/office/mac/drawingml/2011/main" val="0"/>
+            </a:ext>
+          </a:extLst>
+        </p:spPr>
+        <p:txBody>
+          <a:bodyPr/>
+          <a:lstStyle>
+            <a:lvl1pPr>
+              <a:defRPr sz="1000">
+                <a:solidFill>
+                  <a:schemeClr val="accent4"/>
+                </a:solidFill>
+              </a:defRPr>
+            </a:lvl1pPr>
+          </a:lstStyle>
+          <a:p>
+            <a:pPr algn="r"/>
+            <a:fld id="{F7021451-1387-4CA6-816F-3879F97B5CBC}" type="slidenum">
+              <a:rPr b="0" lang="en-US"/>
+              <a:t>34</a:t>
+            </a:fld>
+            <a:endParaRPr lang="en-US"/>
+          </a:p>
+        </p:txBody>
+      </p:sp>
+    </p:spTree>
+  </p:cSld>
+  <p:clrMapOvr>
+    <a:masterClrMapping/>
+  </p:clrMapOvr>
+</p:sld>
+</file>
+
+<file path=ppt/slides/slide35.xml><?xml version="1.0" encoding="utf-8"?>
+<p:sld xmlns:a="http://schemas.openxmlformats.org/drawingml/2006/main" xmlns:r="http://schemas.openxmlformats.org/officeDocument/2006/relationships" xmlns:p="http://schemas.openxmlformats.org/presentationml/2006/main">
+  <p:cSld name="Slide 35">
+    <p:spTree>
+      <p:nvGrpSpPr>
+        <p:cNvPr id="1" name=""/>
+        <p:cNvGrpSpPr/>
+        <p:nvPr/>
+      </p:nvGrpSpPr>
+      <p:grpSpPr>
+        <a:xfrm>
+          <a:off x="0" y="0"/>
+          <a:ext cx="0" cy="0"/>
+          <a:chOff x="0" y="0"/>
+          <a:chExt cx="0" cy="0"/>
+        </a:xfrm>
+      </p:grpSpPr>
+      <p:sp>
+        <p:nvSpPr>
+          <p:cNvPr id="2" name="Text 0"/>
+          <p:cNvSpPr/>
+          <p:nvPr>
+            <p:ph idx="100" type="title" hasCustomPrompt="1"/>
+          </p:nvPr>
+        </p:nvSpPr>
+        <p:spPr>
+          <a:xfrm>
+            <a:off x="457200" y="274320"/>
+            <a:ext cx="8229600" cy="685800"/>
+          </a:xfrm>
+          <a:prstGeom prst="rect">
+            <a:avLst/>
+          </a:prstGeom>
+          <a:noFill/>
+          <a:ln/>
+        </p:spPr>
+        <p:txBody>
+          <a:bodyPr wrap="square" lIns="0" tIns="0" rIns="0" bIns="0" rtlCol="0" anchor="ctr"/>
+          <a:lstStyle/>
+          <a:p>
+            <a:pPr indent="0" marL="0">
+              <a:buNone/>
+            </a:pPr>
+            <a:r>
+              <a:rPr lang="en-US" sz="2800" b="1" dirty="0">
+                <a:solidFill>
+                  <a:schemeClr val="tx2"/>
+                </a:solidFill>
+              </a:rPr>
+              <a:t>AI 서비스: 쓸 때마다 원가가 나간다</a:t>
+            </a:r>
+            <a:endParaRPr lang="en-US" sz="2800" dirty="0"/>
+          </a:p>
+        </p:txBody>
+      </p:sp>
+      <p:graphicFrame>
+        <p:nvGraphicFramePr>
+          <p:cNvPr id="3" name="Chart 0" descr=""/>
+          <p:cNvGraphicFramePr/>
+          <p:nvPr/>
+        </p:nvGraphicFramePr>
+        <p:xfrm>
+          <a:off x="365760" y="1097280"/>
+          <a:ext cx="5120640" cy="3291840"/>
+        </p:xfrm>
+        <a:graphic xmlns:a="http://schemas.openxmlformats.org/drawingml/2006/main">
+          <a:graphicData uri="http://schemas.openxmlformats.org/drawingml/2006/chart">
+            <c:chart xmlns:c="http://schemas.openxmlformats.org/drawingml/2006/chart" r:id="rId1"/>
+          </a:graphicData>
+        </a:graphic>
+      </p:graphicFrame>
+      <p:sp>
+        <p:nvSpPr>
+          <p:cNvPr id="4" name="card"/>
+          <p:cNvSpPr/>
+          <p:nvPr/>
+        </p:nvSpPr>
+        <p:spPr>
+          <a:xfrm>
+            <a:off x="5760720" y="1188720"/>
+            <a:ext cx="2926080" cy="3200400"/>
+          </a:xfrm>
+          <a:prstGeom prst="roundRect">
+            <a:avLst>
+              <a:gd name="adj" fmla="val 2500"/>
+            </a:avLst>
+          </a:prstGeom>
+          <a:solidFill>
+            <a:schemeClr val="bg2"/>
+          </a:solidFill>
+          <a:ln/>
+        </p:spPr>
+      </p:sp>
+      <p:sp>
+        <p:nvSpPr>
+          <p:cNvPr id="5" name="Text 2"/>
+          <p:cNvSpPr txBox="1"/>
+          <p:nvPr/>
+        </p:nvSpPr>
+        <p:spPr>
+          <a:xfrm>
+            <a:off x="5943600" y="1325880"/>
+            <a:ext cx="2560320" cy="365760"/>
+          </a:xfrm>
+          <a:prstGeom prst="rect">
+            <a:avLst/>
+          </a:prstGeom>
+          <a:noFill/>
+          <a:ln/>
+        </p:spPr>
+        <p:txBody>
+          <a:bodyPr wrap="square" lIns="0" tIns="0" rIns="0" bIns="0" rtlCol="0" anchor="t"/>
+          <a:lstStyle/>
+          <a:p>
+            <a:pPr indent="0" marL="0">
+              <a:buNone/>
+            </a:pPr>
+            <a:r>
+              <a:rPr lang="en-US" sz="1500" b="1" dirty="0">
+                <a:solidFill>
+                  <a:schemeClr val="accent2"/>
+                </a:solidFill>
+              </a:rPr>
+              <a:t>운영 체크</a:t>
+            </a:r>
+            <a:endParaRPr lang="en-US" sz="1500" dirty="0"/>
+          </a:p>
+        </p:txBody>
+      </p:sp>
+      <p:sp>
+        <p:nvSpPr>
+          <p:cNvPr id="6" name="Text 3"/>
+          <p:cNvSpPr txBox="1"/>
+          <p:nvPr/>
+        </p:nvSpPr>
+        <p:spPr>
+          <a:xfrm>
+            <a:off x="5943600" y="1783080"/>
+            <a:ext cx="2606040" cy="2468880"/>
+          </a:xfrm>
+          <a:prstGeom prst="rect">
+            <a:avLst/>
+          </a:prstGeom>
+          <a:noFill/>
+          <a:ln/>
+        </p:spPr>
+        <p:txBody>
+          <a:bodyPr wrap="square" lIns="0" tIns="0" rIns="0" bIns="0" rtlCol="0" anchor="t"/>
+          <a:lstStyle/>
+          <a:p>
+            <a:pPr marL="342900" indent="-342900">
+              <a:spcAft>
+                <a:spcPts val="800"/>
+              </a:spcAft>
+              <a:buSzPct val="100000"/>
+              <a:buChar char="•"/>
+            </a:pPr>
+            <a:r>
+              <a:rPr lang="en-US" sz="1300" dirty="0">
+                <a:solidFill>
+                  <a:schemeClr val="tx1"/>
+                </a:solidFill>
+              </a:rPr>
+              <a:t>사용량 제한·과금</a:t>
+            </a:r>
+            <a:endParaRPr lang="en-US" sz="1300" dirty="0"/>
+          </a:p>
+          <a:p>
+            <a:pPr marL="342900" indent="-342900">
+              <a:spcAft>
+                <a:spcPts val="800"/>
+              </a:spcAft>
+              <a:buSzPct val="100000"/>
+              <a:buChar char="•"/>
+            </a:pPr>
+            <a:r>
+              <a:rPr lang="en-US" sz="1300" dirty="0">
+                <a:solidFill>
+                  <a:schemeClr val="tx1"/>
+                </a:solidFill>
+              </a:rPr>
+              <a:t>틀린 답(환각) 안내</a:t>
+            </a:r>
+            <a:endParaRPr lang="en-US" sz="1300" dirty="0"/>
+          </a:p>
+          <a:p>
+            <a:pPr marL="342900" indent="-342900">
+              <a:spcAft>
+                <a:spcPts val="800"/>
+              </a:spcAft>
+              <a:buSzPct val="100000"/>
+              <a:buChar char="•"/>
+            </a:pPr>
+            <a:r>
+              <a:rPr lang="en-US" sz="1300" dirty="0">
+                <a:solidFill>
+                  <a:schemeClr val="tx1"/>
+                </a:solidFill>
+              </a:rPr>
+              <a:t>모델 바뀌면 테스트</a:t>
+            </a:r>
+            <a:endParaRPr lang="en-US" sz="1300" dirty="0"/>
+          </a:p>
+          <a:p>
+            <a:pPr marL="342900" indent="-342900">
+              <a:spcAft>
+                <a:spcPts val="800"/>
+              </a:spcAft>
+              <a:buSzPct val="100000"/>
+              <a:buChar char="•"/>
+            </a:pPr>
+            <a:r>
+              <a:rPr lang="en-US" sz="1300" dirty="0">
+                <a:solidFill>
+                  <a:schemeClr val="tx1"/>
+                </a:solidFill>
+              </a:rPr>
+              <a:t>입력 정보 외부 전송 고지</a:t>
+            </a:r>
+            <a:endParaRPr lang="en-US" sz="1300" dirty="0"/>
+          </a:p>
+          <a:p>
+            <a:pPr marL="342900" indent="-342900">
+              <a:spcAft>
+                <a:spcPts val="800"/>
+              </a:spcAft>
+              <a:buSzPct val="100000"/>
+              <a:buChar char="•"/>
+            </a:pPr>
+            <a:r>
+              <a:rPr lang="en-US" sz="1300" dirty="0">
+                <a:solidFill>
+                  <a:schemeClr val="tx1"/>
+                </a:solidFill>
+              </a:rPr>
+              <a:t>AI 생성물 표시 (AI 기본법)</a:t>
+            </a:r>
+            <a:endParaRPr lang="en-US" sz="1300" dirty="0"/>
+          </a:p>
+        </p:txBody>
+      </p:sp>
+      <p:sp>
+        <p:nvSpPr>
+          <p:cNvPr id="25" name="Slide Number Placeholder 0"/>
+          <p:cNvSpPr>
+            <a:spLocks noGrp="1"/>
+          </p:cNvSpPr>
+          <p:nvPr>
+            <p:ph type="sldNum" sz="quarter" idx="4294967295"/>
+          </p:nvPr>
+        </p:nvSpPr>
+        <p:spPr>
+          <a:xfrm>
+            <a:off x="8321040" y="4754880"/>
+            <a:ext cx="457200" cy="274320"/>
+          </a:xfrm>
+          <a:prstGeom prst="rect">
+            <a:avLst/>
+          </a:prstGeom>
+          <a:extLst>
+            <a:ext uri="{C572A759-6A51-4108-AA02-DFA0A04FC94B}">
+              <ma14:wrappingTextBoxFlag xmlns:ma14="http://schemas.microsoft.com/office/mac/drawingml/2011/main" val="0"/>
+            </a:ext>
+          </a:extLst>
+        </p:spPr>
+        <p:txBody>
+          <a:bodyPr/>
+          <a:lstStyle>
+            <a:lvl1pPr>
+              <a:defRPr sz="1000">
+                <a:solidFill>
+                  <a:schemeClr val="accent4"/>
+                </a:solidFill>
+              </a:defRPr>
+            </a:lvl1pPr>
+          </a:lstStyle>
+          <a:p>
+            <a:pPr algn="r"/>
+            <a:fld id="{F7021451-1387-4CA6-816F-3879F97B5CBC}" type="slidenum">
+              <a:rPr b="0" lang="en-US"/>
+              <a:t>35</a:t>
+            </a:fld>
+            <a:endParaRPr lang="en-US"/>
+          </a:p>
+        </p:txBody>
+      </p:sp>
+    </p:spTree>
+  </p:cSld>
+  <p:clrMapOvr>
+    <a:masterClrMapping/>
+  </p:clrMapOvr>
+</p:sld>
+</file>
+
+<file path=ppt/slides/slide36.xml><?xml version="1.0" encoding="utf-8"?>
+<p:sld xmlns:a="http://schemas.openxmlformats.org/drawingml/2006/main" xmlns:r="http://schemas.openxmlformats.org/officeDocument/2006/relationships" xmlns:p="http://schemas.openxmlformats.org/presentationml/2006/main">
+  <p:cSld name="Slide 36">
+    <p:spTree>
+      <p:nvGrpSpPr>
+        <p:cNvPr id="1" name=""/>
+        <p:cNvGrpSpPr/>
+        <p:nvPr/>
+      </p:nvGrpSpPr>
+      <p:grpSpPr>
+        <a:xfrm>
+          <a:off x="0" y="0"/>
+          <a:ext cx="0" cy="0"/>
+          <a:chOff x="0" y="0"/>
+          <a:chExt cx="0" cy="0"/>
+        </a:xfrm>
+      </p:grpSpPr>
+      <p:sp>
+        <p:nvSpPr>
+          <p:cNvPr id="2" name="Text 0"/>
+          <p:cNvSpPr/>
+          <p:nvPr>
+            <p:ph idx="100" type="title" hasCustomPrompt="1"/>
+          </p:nvPr>
+        </p:nvSpPr>
+        <p:spPr>
+          <a:xfrm>
+            <a:off x="457200" y="274320"/>
+            <a:ext cx="8229600" cy="685800"/>
+          </a:xfrm>
+          <a:prstGeom prst="rect">
+            <a:avLst/>
+          </a:prstGeom>
+          <a:noFill/>
+          <a:ln/>
+        </p:spPr>
+        <p:txBody>
+          <a:bodyPr wrap="square" lIns="0" tIns="0" rIns="0" bIns="0" rtlCol="0" anchor="ctr"/>
+          <a:lstStyle/>
+          <a:p>
+            <a:pPr indent="0" marL="0">
+              <a:buNone/>
+            </a:pPr>
+            <a:r>
+              <a:rPr lang="en-US" sz="2800" b="1" dirty="0">
+                <a:solidFill>
+                  <a:schemeClr val="tx2"/>
+                </a:solidFill>
+              </a:rPr>
+              <a:t>시작 전에 확인할 규제 업종</a:t>
+            </a:r>
+            <a:endParaRPr lang="en-US" sz="2800" dirty="0"/>
+          </a:p>
+        </p:txBody>
+      </p:sp>
+      <p:sp>
+        <p:nvSpPr>
+          <p:cNvPr id="3" name="card"/>
+          <p:cNvSpPr/>
+          <p:nvPr/>
+        </p:nvSpPr>
+        <p:spPr>
+          <a:xfrm>
+            <a:off x="457200" y="1188720"/>
+            <a:ext cx="8229600" cy="685800"/>
+          </a:xfrm>
+          <a:prstGeom prst="roundRect">
+            <a:avLst>
+              <a:gd name="adj" fmla="val 10667"/>
+            </a:avLst>
+          </a:prstGeom>
+          <a:solidFill>
+            <a:schemeClr val="bg2"/>
+          </a:solidFill>
+          <a:ln/>
+        </p:spPr>
+      </p:sp>
+      <p:sp>
+        <p:nvSpPr>
+          <p:cNvPr id="4" name="reg0"/>
+          <p:cNvSpPr/>
+          <p:nvPr/>
+        </p:nvSpPr>
+        <p:spPr>
+          <a:xfrm>
+            <a:off x="640080" y="1344168"/>
+            <a:ext cx="365760" cy="365760"/>
+          </a:xfrm>
+          <a:prstGeom prst="ellipse">
+            <a:avLst/>
+          </a:prstGeom>
+          <a:solidFill>
+            <a:srgbClr val="3E9B6B"/>
+          </a:solidFill>
+          <a:ln/>
+        </p:spPr>
+      </p:sp>
+      <p:sp>
+        <p:nvSpPr>
+          <p:cNvPr id="5" name="Text 3"/>
+          <p:cNvSpPr txBox="1"/>
+          <p:nvPr/>
+        </p:nvSpPr>
+        <p:spPr>
+          <a:xfrm>
+            <a:off x="1188720" y="1188720"/>
+            <a:ext cx="2377440" cy="685800"/>
+          </a:xfrm>
+          <a:prstGeom prst="rect">
+            <a:avLst/>
+          </a:prstGeom>
+          <a:noFill/>
+          <a:ln/>
+        </p:spPr>
+        <p:txBody>
+          <a:bodyPr wrap="square" lIns="0" tIns="0" rIns="0" bIns="0" rtlCol="0" anchor="ctr"/>
+          <a:lstStyle/>
+          <a:p>
+            <a:pPr indent="0" marL="0">
+              <a:buNone/>
+            </a:pPr>
+            <a:r>
+              <a:rPr lang="en-US" sz="1500" b="1" dirty="0">
+                <a:solidFill>
+                  <a:schemeClr val="tx1"/>
+                </a:solidFill>
+              </a:rPr>
+              <a:t>신고 정도면 시작</a:t>
+            </a:r>
+            <a:endParaRPr lang="en-US" sz="1500" dirty="0"/>
+          </a:p>
+        </p:txBody>
+      </p:sp>
+      <p:sp>
+        <p:nvSpPr>
+          <p:cNvPr id="6" name="Text 4"/>
+          <p:cNvSpPr txBox="1"/>
+          <p:nvPr/>
+        </p:nvSpPr>
+        <p:spPr>
+          <a:xfrm>
+            <a:off x="3657600" y="1188720"/>
+            <a:ext cx="4846320" cy="685800"/>
+          </a:xfrm>
+          <a:prstGeom prst="rect">
+            <a:avLst/>
+          </a:prstGeom>
+          <a:noFill/>
+          <a:ln/>
+        </p:spPr>
+        <p:txBody>
+          <a:bodyPr wrap="square" lIns="0" tIns="0" rIns="0" bIns="0" rtlCol="0" anchor="ctr"/>
+          <a:lstStyle/>
+          <a:p>
+            <a:pPr indent="0" marL="0">
+              <a:buNone/>
+            </a:pPr>
+            <a:r>
+              <a:rPr lang="en-US" sz="1300" dirty="0">
+                <a:solidFill>
+                  <a:schemeClr val="accent4"/>
+                </a:solidFill>
+              </a:rPr>
+              <a:t>일반 쇼핑몰 · 정보 사이트 · 템플릿</a:t>
+            </a:r>
+            <a:endParaRPr lang="en-US" sz="1300" dirty="0"/>
+          </a:p>
+        </p:txBody>
+      </p:sp>
+      <p:sp>
+        <p:nvSpPr>
+          <p:cNvPr id="7" name="card"/>
+          <p:cNvSpPr/>
+          <p:nvPr/>
+        </p:nvSpPr>
+        <p:spPr>
+          <a:xfrm>
+            <a:off x="457200" y="1993392"/>
+            <a:ext cx="8229600" cy="685800"/>
+          </a:xfrm>
+          <a:prstGeom prst="roundRect">
+            <a:avLst>
+              <a:gd name="adj" fmla="val 10667"/>
+            </a:avLst>
+          </a:prstGeom>
+          <a:solidFill>
+            <a:schemeClr val="bg2"/>
+          </a:solidFill>
+          <a:ln/>
+        </p:spPr>
+      </p:sp>
+      <p:sp>
+        <p:nvSpPr>
+          <p:cNvPr id="8" name="reg1"/>
+          <p:cNvSpPr/>
+          <p:nvPr/>
+        </p:nvSpPr>
+        <p:spPr>
+          <a:xfrm>
+            <a:off x="640080" y="2148840"/>
+            <a:ext cx="365760" cy="365760"/>
+          </a:xfrm>
+          <a:prstGeom prst="ellipse">
+            <a:avLst/>
+          </a:prstGeom>
+          <a:solidFill>
+            <a:srgbClr val="E0A526"/>
+          </a:solidFill>
+          <a:ln/>
+        </p:spPr>
+      </p:sp>
+      <p:sp>
+        <p:nvSpPr>
+          <p:cNvPr id="9" name="Text 7"/>
+          <p:cNvSpPr txBox="1"/>
+          <p:nvPr/>
+        </p:nvSpPr>
+        <p:spPr>
+          <a:xfrm>
+            <a:off x="1188720" y="1993392"/>
+            <a:ext cx="2377440" cy="685800"/>
+          </a:xfrm>
+          <a:prstGeom prst="rect">
+            <a:avLst/>
+          </a:prstGeom>
+          <a:noFill/>
+          <a:ln/>
+        </p:spPr>
+        <p:txBody>
+          <a:bodyPr wrap="square" lIns="0" tIns="0" rIns="0" bIns="0" rtlCol="0" anchor="ctr"/>
+          <a:lstStyle/>
+          <a:p>
+            <a:pPr indent="0" marL="0">
+              <a:buNone/>
+            </a:pPr>
+            <a:r>
+              <a:rPr lang="en-US" sz="1500" b="1" dirty="0">
+                <a:solidFill>
+                  <a:schemeClr val="tx1"/>
+                </a:solidFill>
+              </a:rPr>
+              <a:t>추가 신고·등록</a:t>
+            </a:r>
+            <a:endParaRPr lang="en-US" sz="1500" dirty="0"/>
+          </a:p>
+        </p:txBody>
+      </p:sp>
+      <p:sp>
+        <p:nvSpPr>
+          <p:cNvPr id="10" name="Text 8"/>
+          <p:cNvSpPr txBox="1"/>
+          <p:nvPr/>
+        </p:nvSpPr>
+        <p:spPr>
+          <a:xfrm>
+            <a:off x="3657600" y="1993392"/>
+            <a:ext cx="4846320" cy="685800"/>
+          </a:xfrm>
+          <a:prstGeom prst="rect">
+            <a:avLst/>
+          </a:prstGeom>
+          <a:noFill/>
+          <a:ln/>
+        </p:spPr>
+        <p:txBody>
+          <a:bodyPr wrap="square" lIns="0" tIns="0" rIns="0" bIns="0" rtlCol="0" anchor="ctr"/>
+          <a:lstStyle/>
+          <a:p>
+            <a:pPr indent="0" marL="0">
+              <a:buNone/>
+            </a:pPr>
+            <a:r>
+              <a:rPr lang="en-US" sz="1300" dirty="0">
+                <a:solidFill>
+                  <a:schemeClr val="accent4"/>
+                </a:solidFill>
+              </a:rPr>
+              <a:t>건강기능식품 · 직업소개 · 위치정보 · 게임</a:t>
+            </a:r>
+            <a:endParaRPr lang="en-US" sz="1300" dirty="0"/>
+          </a:p>
+        </p:txBody>
+      </p:sp>
+      <p:sp>
+        <p:nvSpPr>
+          <p:cNvPr id="11" name="card"/>
+          <p:cNvSpPr/>
+          <p:nvPr/>
+        </p:nvSpPr>
+        <p:spPr>
+          <a:xfrm>
+            <a:off x="457200" y="2798064"/>
+            <a:ext cx="8229600" cy="685800"/>
+          </a:xfrm>
+          <a:prstGeom prst="roundRect">
+            <a:avLst>
+              <a:gd name="adj" fmla="val 10667"/>
+            </a:avLst>
+          </a:prstGeom>
+          <a:solidFill>
+            <a:schemeClr val="bg2"/>
+          </a:solidFill>
+          <a:ln/>
+        </p:spPr>
+      </p:sp>
+      <p:sp>
+        <p:nvSpPr>
+          <p:cNvPr id="12" name="reg2"/>
+          <p:cNvSpPr/>
+          <p:nvPr/>
+        </p:nvSpPr>
+        <p:spPr>
+          <a:xfrm>
+            <a:off x="640080" y="2953512"/>
+            <a:ext cx="365760" cy="365760"/>
+          </a:xfrm>
+          <a:prstGeom prst="ellipse">
+            <a:avLst/>
+          </a:prstGeom>
+          <a:solidFill>
+            <a:srgbClr val="D9534F"/>
+          </a:solidFill>
+          <a:ln/>
+        </p:spPr>
+      </p:sp>
+      <p:sp>
+        <p:nvSpPr>
+          <p:cNvPr id="13" name="Text 11"/>
+          <p:cNvSpPr txBox="1"/>
+          <p:nvPr/>
+        </p:nvSpPr>
+        <p:spPr>
+          <a:xfrm>
+            <a:off x="1188720" y="2798064"/>
+            <a:ext cx="2377440" cy="685800"/>
+          </a:xfrm>
+          <a:prstGeom prst="rect">
+            <a:avLst/>
+          </a:prstGeom>
+          <a:noFill/>
+          <a:ln/>
+        </p:spPr>
+        <p:txBody>
+          <a:bodyPr wrap="square" lIns="0" tIns="0" rIns="0" bIns="0" rtlCol="0" anchor="ctr"/>
+          <a:lstStyle/>
+          <a:p>
+            <a:pPr indent="0" marL="0">
+              <a:buNone/>
+            </a:pPr>
+            <a:r>
+              <a:rPr lang="en-US" sz="1500" b="1" dirty="0">
+                <a:solidFill>
+                  <a:schemeClr val="tx1"/>
+                </a:solidFill>
+              </a:rPr>
+              <a:t>허가·라이선스</a:t>
+            </a:r>
+            <a:endParaRPr lang="en-US" sz="1500" dirty="0"/>
+          </a:p>
+        </p:txBody>
+      </p:sp>
+      <p:sp>
+        <p:nvSpPr>
+          <p:cNvPr id="14" name="Text 12"/>
+          <p:cNvSpPr txBox="1"/>
+          <p:nvPr/>
+        </p:nvSpPr>
+        <p:spPr>
+          <a:xfrm>
+            <a:off x="3657600" y="2798064"/>
+            <a:ext cx="4846320" cy="685800"/>
+          </a:xfrm>
+          <a:prstGeom prst="rect">
+            <a:avLst/>
+          </a:prstGeom>
+          <a:noFill/>
+          <a:ln/>
+        </p:spPr>
+        <p:txBody>
+          <a:bodyPr wrap="square" lIns="0" tIns="0" rIns="0" bIns="0" rtlCol="0" anchor="ctr"/>
+          <a:lstStyle/>
+          <a:p>
+            <a:pPr indent="0" marL="0">
+              <a:buNone/>
+            </a:pPr>
+            <a:r>
+              <a:rPr lang="en-US" sz="1300" dirty="0">
+                <a:solidFill>
+                  <a:schemeClr val="accent4"/>
+                </a:solidFill>
+              </a:rPr>
+              <a:t>결제·송금 · 투자자문 · 가상자산 · 의료</a:t>
+            </a:r>
+            <a:endParaRPr lang="en-US" sz="1300" dirty="0"/>
+          </a:p>
+        </p:txBody>
+      </p:sp>
+      <p:sp>
+        <p:nvSpPr>
+          <p:cNvPr id="15" name="card"/>
+          <p:cNvSpPr/>
+          <p:nvPr/>
+        </p:nvSpPr>
+        <p:spPr>
+          <a:xfrm>
+            <a:off x="457200" y="3602736"/>
+            <a:ext cx="8229600" cy="685800"/>
+          </a:xfrm>
+          <a:prstGeom prst="roundRect">
+            <a:avLst>
+              <a:gd name="adj" fmla="val 10667"/>
+            </a:avLst>
+          </a:prstGeom>
+          <a:solidFill>
+            <a:schemeClr val="bg2"/>
+          </a:solidFill>
+          <a:ln/>
+        </p:spPr>
+      </p:sp>
+      <p:sp>
+        <p:nvSpPr>
+          <p:cNvPr id="16" name="reg3"/>
+          <p:cNvSpPr/>
+          <p:nvPr/>
+        </p:nvSpPr>
+        <p:spPr>
+          <a:xfrm>
+            <a:off x="640080" y="3758184"/>
+            <a:ext cx="365760" cy="365760"/>
+          </a:xfrm>
+          <a:prstGeom prst="ellipse">
+            <a:avLst/>
+          </a:prstGeom>
+          <a:solidFill>
+            <a:srgbClr val="1B2B2E"/>
+          </a:solidFill>
+          <a:ln/>
+        </p:spPr>
+      </p:sp>
+      <p:sp>
+        <p:nvSpPr>
+          <p:cNvPr id="17" name="Text 15"/>
+          <p:cNvSpPr txBox="1"/>
+          <p:nvPr/>
+        </p:nvSpPr>
+        <p:spPr>
+          <a:xfrm>
+            <a:off x="1188720" y="3602736"/>
+            <a:ext cx="2377440" cy="685800"/>
+          </a:xfrm>
+          <a:prstGeom prst="rect">
+            <a:avLst/>
+          </a:prstGeom>
+          <a:noFill/>
+          <a:ln/>
+        </p:spPr>
+        <p:txBody>
+          <a:bodyPr wrap="square" lIns="0" tIns="0" rIns="0" bIns="0" rtlCol="0" anchor="ctr"/>
+          <a:lstStyle/>
+          <a:p>
+            <a:pPr indent="0" marL="0">
+              <a:buNone/>
+            </a:pPr>
+            <a:r>
+              <a:rPr lang="en-US" sz="1500" b="1" dirty="0">
+                <a:solidFill>
+                  <a:schemeClr val="tx1"/>
+                </a:solidFill>
+              </a:rPr>
+              <a:t>온라인 판매 금지·제한</a:t>
+            </a:r>
+            <a:endParaRPr lang="en-US" sz="1500" dirty="0"/>
+          </a:p>
+        </p:txBody>
+      </p:sp>
+      <p:sp>
+        <p:nvSpPr>
+          <p:cNvPr id="18" name="Text 16"/>
+          <p:cNvSpPr txBox="1"/>
+          <p:nvPr/>
+        </p:nvSpPr>
+        <p:spPr>
+          <a:xfrm>
+            <a:off x="3657600" y="3602736"/>
+            <a:ext cx="4846320" cy="685800"/>
+          </a:xfrm>
+          <a:prstGeom prst="rect">
+            <a:avLst/>
+          </a:prstGeom>
+          <a:noFill/>
+          <a:ln/>
+        </p:spPr>
+        <p:txBody>
+          <a:bodyPr wrap="square" lIns="0" tIns="0" rIns="0" bIns="0" rtlCol="0" anchor="ctr"/>
+          <a:lstStyle/>
+          <a:p>
+            <a:pPr indent="0" marL="0">
+              <a:buNone/>
+            </a:pPr>
+            <a:r>
+              <a:rPr lang="en-US" sz="1300" dirty="0">
+                <a:solidFill>
+                  <a:schemeClr val="accent4"/>
+                </a:solidFill>
+              </a:rPr>
+              <a:t>의약품 · 담배 · 주류(일부 예외) · 도수 렌즈</a:t>
+            </a:r>
+            <a:endParaRPr lang="en-US" sz="1300" dirty="0"/>
+          </a:p>
+        </p:txBody>
+      </p:sp>
+      <p:sp>
+        <p:nvSpPr>
+          <p:cNvPr id="19" name="Text 17"/>
+          <p:cNvSpPr txBox="1"/>
+          <p:nvPr/>
+        </p:nvSpPr>
+        <p:spPr>
+          <a:xfrm>
+            <a:off x="457200" y="4645152"/>
+            <a:ext cx="7680960" cy="274320"/>
+          </a:xfrm>
+          <a:prstGeom prst="rect">
+            <a:avLst/>
+          </a:prstGeom>
+          <a:noFill/>
+          <a:ln/>
+        </p:spPr>
+        <p:txBody>
+          <a:bodyPr wrap="square" lIns="0" tIns="0" rIns="0" bIns="0" rtlCol="0" anchor="t"/>
+          <a:lstStyle/>
+          <a:p>
+            <a:pPr indent="0" marL="0">
+              <a:buNone/>
+            </a:pPr>
+            <a:r>
+              <a:rPr lang="en-US" sz="1000" dirty="0">
+                <a:solidFill>
+                  <a:schemeClr val="accent4"/>
+                </a:solidFill>
+              </a:rPr>
+              <a:t>애매하면 정부24에서 업종 인허가 검색, 관계 기관·전문가에게 확인 (29장)</a:t>
+            </a:r>
+            <a:endParaRPr lang="en-US" sz="1000" dirty="0"/>
+          </a:p>
+        </p:txBody>
+      </p:sp>
+      <p:sp>
+        <p:nvSpPr>
+          <p:cNvPr id="25" name="Slide Number Placeholder 0"/>
+          <p:cNvSpPr>
+            <a:spLocks noGrp="1"/>
+          </p:cNvSpPr>
+          <p:nvPr>
+            <p:ph type="sldNum" sz="quarter" idx="4294967295"/>
+          </p:nvPr>
+        </p:nvSpPr>
+        <p:spPr>
+          <a:xfrm>
+            <a:off x="8321040" y="4754880"/>
+            <a:ext cx="457200" cy="274320"/>
+          </a:xfrm>
+          <a:prstGeom prst="rect">
+            <a:avLst/>
+          </a:prstGeom>
+          <a:extLst>
+            <a:ext uri="{C572A759-6A51-4108-AA02-DFA0A04FC94B}">
+              <ma14:wrappingTextBoxFlag xmlns:ma14="http://schemas.microsoft.com/office/mac/drawingml/2011/main" val="0"/>
+            </a:ext>
+          </a:extLst>
+        </p:spPr>
+        <p:txBody>
+          <a:bodyPr/>
+          <a:lstStyle>
+            <a:lvl1pPr>
+              <a:defRPr sz="1000">
+                <a:solidFill>
+                  <a:schemeClr val="accent4"/>
+                </a:solidFill>
+              </a:defRPr>
+            </a:lvl1pPr>
+          </a:lstStyle>
+          <a:p>
+            <a:pPr algn="r"/>
+            <a:fld id="{F7021451-1387-4CA6-816F-3879F97B5CBC}" type="slidenum">
+              <a:rPr b="0" lang="en-US"/>
+              <a:t>36</a:t>
+            </a:fld>
+            <a:endParaRPr lang="en-US"/>
+          </a:p>
+        </p:txBody>
+      </p:sp>
+    </p:spTree>
+  </p:cSld>
+  <p:clrMapOvr>
+    <a:masterClrMapping/>
+  </p:clrMapOvr>
+</p:sld>
+</file>
+
+<file path=ppt/slides/slide37.xml><?xml version="1.0" encoding="utf-8"?>
+<p:sld xmlns:a="http://schemas.openxmlformats.org/drawingml/2006/main" xmlns:r="http://schemas.openxmlformats.org/officeDocument/2006/relationships" xmlns:p="http://schemas.openxmlformats.org/presentationml/2006/main">
+  <p:cSld name="Slide 37">
+    <p:spTree>
+      <p:nvGrpSpPr>
+        <p:cNvPr id="1" name=""/>
+        <p:cNvGrpSpPr/>
+        <p:nvPr/>
+      </p:nvGrpSpPr>
+      <p:grpSpPr>
+        <a:xfrm>
+          <a:off x="0" y="0"/>
+          <a:ext cx="0" cy="0"/>
+          <a:chOff x="0" y="0"/>
+          <a:chExt cx="0" cy="0"/>
+        </a:xfrm>
+      </p:grpSpPr>
+      <p:sp>
+        <p:nvSpPr>
+          <p:cNvPr id="2" name="Text 0"/>
+          <p:cNvSpPr/>
+          <p:nvPr>
+            <p:ph idx="100" type="title" hasCustomPrompt="1"/>
+          </p:nvPr>
+        </p:nvSpPr>
+        <p:spPr>
+          <a:xfrm>
+            <a:off x="548640" y="1371600"/>
+            <a:ext cx="8046720" cy="1280160"/>
+          </a:xfrm>
+          <a:prstGeom prst="rect">
+            <a:avLst/>
+          </a:prstGeom>
+          <a:noFill/>
+          <a:ln/>
+        </p:spPr>
+        <p:txBody>
+          <a:bodyPr wrap="square" lIns="0" tIns="0" rIns="0" bIns="0" rtlCol="0" anchor="b"/>
+          <a:lstStyle/>
+          <a:p>
+            <a:pPr algn="l" indent="0" marL="0">
+              <a:buNone/>
+            </a:pPr>
+            <a:r>
+              <a:rPr lang="en-US" sz="4000" b="1" dirty="0">
+                <a:solidFill>
+                  <a:schemeClr val="bg1"/>
+                </a:solidFill>
+              </a:rPr>
               <a:t>안전하게, 자주 반복하기</a:t>
             </a:r>
             <a:endParaRPr lang="en-US" sz="4000" dirty="0"/>

</xml_diff>

<commit_message>
Add chapters on inquiry channels, business email and ad inquiries
Chapter 30 covers inquiry channels, role-based addresses, setting up
a domain email (MX, SPF, DKIM, DMARC), transactional vs marketing
mail and Korean ad-mail consent rules, contact forms, helpdesk
workflows, required contact disclosures, and a per-field summary.
Chapter 31 covers ad and partnership inquiries: media kits,
pricing, the deal process, labeling, and ads to refuse. README,
checklists, glossary, quiz and the deck (now 42 slides) are
updated.

Co-Authored-By: Claude Opus 5.5 <noreply@anthropic.com>
Claude-Session: https://claude.ai/code/session_01Tuz8P5EzhzAFozhesRbd5A
</commit_message>
<xml_diff>
--- a/slides/internet-business-101.pptx
+++ b/slides/internet-business-101.pptx
@@ -42,9 +42,14 @@
     <p:sldId id="290" r:id="rId36"/>
     <p:sldId id="291" r:id="rId37"/>
     <p:sldId id="292" r:id="rId38"/>
+    <p:sldId id="293" r:id="rId39"/>
+    <p:sldId id="294" r:id="rId40"/>
+    <p:sldId id="295" r:id="rId41"/>
+    <p:sldId id="296" r:id="rId42"/>
+    <p:sldId id="297" r:id="rId43"/>
   </p:sldIdLst>
   <p:notesMasterIdLst>
-    <p:notesMasterId r:id="rId39"/>
+    <p:notesMasterId r:id="rId44"/>
   </p:notesMasterIdLst>
   <p:sldSz cx="9144000" cy="5143500"/>
   <p:notesSz cx="5143500" cy="9144000"/>
@@ -143,13 +148,13 @@
   <p:extLst>
     <p:ext uri="{521415D9-36F7-43E2-AB2F-B90AF26B5E84}">
       <p14:sectionLst xmlns:p14="http://schemas.microsoft.com/office/powerpoint/2010/main">
-        <p14:section name="시작" id="{718abb55-2b60-5903-dabc-f92c232a3ef0}">
+        <p14:section name="시작" id="{10e2940f-c33a-d474-aa37-fa31966246c9}">
           <p14:sldIdLst>
             <p14:sldId id="256"/>
             <p14:sldId id="257"/>
           </p14:sldIdLst>
         </p14:section>
-        <p14:section name="큰 그림" id="{b1918885-5800-00e5-b090-3093ad1b94d9}">
+        <p14:section name="큰 그림" id="{d07508c2-be9a-d2d1-f51a-7dccbe0421ce}">
           <p14:sldIdLst>
             <p14:sldId id="258"/>
             <p14:sldId id="259"/>
@@ -158,13 +163,13 @@
             <p14:sldId id="262"/>
           </p14:sldIdLst>
         </p14:section>
-        <p14:section name="만들기" id="{838c3b18-ad49-08a3-d5bc-ab5344cb1a1e}">
+        <p14:section name="만들기" id="{f7fc37d8-9336-246f-5dc1-b8165271ebd5}">
           <p14:sldIdLst>
             <p14:sldId id="263"/>
             <p14:sldId id="264"/>
           </p14:sldIdLst>
         </p14:section>
-        <p14:section name="운영하기" id="{c0bcc65a-2691-dd52-5d6e-7c47c9412fbb}">
+        <p14:section name="운영하기" id="{b92e6db4-1192-d4f6-f3cd-f30ad2a7ee03}">
           <p14:sldIdLst>
             <p14:sldId id="265"/>
             <p14:sldId id="266"/>
@@ -178,18 +183,18 @@
             <p14:sldId id="274"/>
           </p14:sldIdLst>
         </p14:section>
-        <p14:section name="키우기" id="{890df497-0bd3-61b4-8889-25dd9b6edc47}">
+        <p14:section name="키우기" id="{739c3264-c882-085d-bfe1-dc5a738132b0}">
           <p14:sldIdLst>
             <p14:sldId id="275"/>
             <p14:sldId id="276"/>
           </p14:sldIdLst>
         </p14:section>
-        <p14:section name="실전" id="{72f7af09-f111-c1ea-02b8-98601458f034}">
+        <p14:section name="실전" id="{4906123d-c906-4cb5-7674-cdf334ca36d3}">
           <p14:sldIdLst>
             <p14:sldId id="277"/>
           </p14:sldIdLst>
         </p14:section>
-        <p14:section name="여러 가지 사이트 사업" id="{b41d8c00-72d6-b21d-7f92-56a159d3a210}">
+        <p14:section name="여러 가지 사이트 사업" id="{ffa65975-0998-bb64-9284-d47561e1ea04}">
           <p14:sldIdLst>
             <p14:sldId id="278"/>
             <p14:sldId id="279"/>
@@ -200,7 +205,7 @@
             <p14:sldId id="284"/>
           </p14:sldIdLst>
         </p14:section>
-        <p14:section name="더 넓은 분류" id="{e8f1588e-68d9-f72e-d53d-d652945b55e1}">
+        <p14:section name="더 넓은 분류" id="{eea227fe-7526-e5dc-dd1d-e6fae17eab13}">
           <p14:sldIdLst>
             <p14:sldId id="285"/>
             <p14:sldId id="286"/>
@@ -209,7 +214,16 @@
             <p14:sldId id="289"/>
             <p14:sldId id="290"/>
             <p14:sldId id="291"/>
+          </p14:sldIdLst>
+        </p14:section>
+        <p14:section name="문의·광고 받기" id="{2f74dd51-0644-9677-747c-d49b0f225536}">
+          <p14:sldIdLst>
             <p14:sldId id="292"/>
+            <p14:sldId id="293"/>
+            <p14:sldId id="294"/>
+            <p14:sldId id="295"/>
+            <p14:sldId id="296"/>
+            <p14:sldId id="297"/>
           </p14:sldIdLst>
         </p14:section>
       </p14:sectionLst>
@@ -4242,6 +4256,182 @@
 </p:notes>
 </file>
 
+<file path=ppt/notesSlides/notesSlide38.xml><?xml version="1.0" encoding="utf-8"?>
+<p:notes xmlns:a="http://schemas.openxmlformats.org/drawingml/2006/main" xmlns:r="http://schemas.openxmlformats.org/officeDocument/2006/relationships" xmlns:p="http://schemas.openxmlformats.org/presentationml/2006/main">
+  <p:cSld>
+    <p:spTree>
+      <p:nvGrpSpPr>
+        <p:cNvPr id="1" name=""/>
+        <p:cNvGrpSpPr/>
+        <p:nvPr/>
+      </p:nvGrpSpPr>
+      <p:grpSpPr>
+        <a:xfrm>
+          <a:off x="0" y="0"/>
+          <a:ext cx="0" cy="0"/>
+          <a:chOff x="0" y="0"/>
+          <a:chExt cx="0" cy="0"/>
+        </a:xfrm>
+      </p:grpSpPr>
+      <p:sp>
+        <p:nvSpPr>
+          <p:cNvPr id="2" name="Slide Image Placeholder 1"/>
+          <p:cNvSpPr>
+            <a:spLocks noGrp="1" noRot="1" noChangeAspect="1"/>
+          </p:cNvSpPr>
+          <p:nvPr>
+            <p:ph type="sldImg"/>
+          </p:nvPr>
+        </p:nvSpPr>
+        <p:spPr/>
+      </p:sp>
+      <p:sp>
+        <p:nvSpPr>
+          <p:cNvPr id="3" name="Notes Placeholder 2"/>
+          <p:cNvSpPr>
+            <a:spLocks noGrp="1"/>
+          </p:cNvSpPr>
+          <p:nvPr>
+            <p:ph type="body" idx="1"/>
+          </p:nvPr>
+        </p:nvSpPr>
+        <p:spPr/>
+        <p:txBody>
+          <a:bodyPr/>
+          <a:lstStyle/>
+          <a:p>
+            <a:r>
+              <a:rPr lang="en-US" dirty="0"/>
+              <a:t/>
+            </a:r>
+            <a:endParaRPr lang="en-US" dirty="0"/>
+          </a:p>
+        </p:txBody>
+      </p:sp>
+      <p:sp>
+        <p:nvSpPr>
+          <p:cNvPr id="4" name="Slide Number Placeholder 3"/>
+          <p:cNvSpPr>
+            <a:spLocks noGrp="1"/>
+          </p:cNvSpPr>
+          <p:nvPr>
+            <p:ph type="sldNum" sz="quarter" idx="10"/>
+          </p:nvPr>
+        </p:nvSpPr>
+        <p:spPr/>
+        <p:txBody>
+          <a:bodyPr/>
+          <a:lstStyle/>
+          <a:p>
+            <a:fld id="{F7021451-1387-4CA6-816F-3879F97B5CBC}" type="slidenum">
+              <a:rPr lang="en-US"/>
+              <a:t>38</a:t>
+            </a:fld>
+            <a:endParaRPr lang="en-US"/>
+          </a:p>
+        </p:txBody>
+      </p:sp>
+    </p:spTree>
+    <p:extLst>
+      <p:ext uri="{BB962C8B-B14F-4D97-AF65-F5344CB8AC3E}">
+        <p14:creationId xmlns:p14="http://schemas.microsoft.com/office/powerpoint/2010/main" val="1024086991"/>
+      </p:ext>
+    </p:extLst>
+  </p:cSld>
+  <p:clrMapOvr>
+    <a:masterClrMapping/>
+  </p:clrMapOvr>
+</p:notes>
+</file>
+
+<file path=ppt/notesSlides/notesSlide39.xml><?xml version="1.0" encoding="utf-8"?>
+<p:notes xmlns:a="http://schemas.openxmlformats.org/drawingml/2006/main" xmlns:r="http://schemas.openxmlformats.org/officeDocument/2006/relationships" xmlns:p="http://schemas.openxmlformats.org/presentationml/2006/main">
+  <p:cSld>
+    <p:spTree>
+      <p:nvGrpSpPr>
+        <p:cNvPr id="1" name=""/>
+        <p:cNvGrpSpPr/>
+        <p:nvPr/>
+      </p:nvGrpSpPr>
+      <p:grpSpPr>
+        <a:xfrm>
+          <a:off x="0" y="0"/>
+          <a:ext cx="0" cy="0"/>
+          <a:chOff x="0" y="0"/>
+          <a:chExt cx="0" cy="0"/>
+        </a:xfrm>
+      </p:grpSpPr>
+      <p:sp>
+        <p:nvSpPr>
+          <p:cNvPr id="2" name="Slide Image Placeholder 1"/>
+          <p:cNvSpPr>
+            <a:spLocks noGrp="1" noRot="1" noChangeAspect="1"/>
+          </p:cNvSpPr>
+          <p:nvPr>
+            <p:ph type="sldImg"/>
+          </p:nvPr>
+        </p:nvSpPr>
+        <p:spPr/>
+      </p:sp>
+      <p:sp>
+        <p:nvSpPr>
+          <p:cNvPr id="3" name="Notes Placeholder 2"/>
+          <p:cNvSpPr>
+            <a:spLocks noGrp="1"/>
+          </p:cNvSpPr>
+          <p:nvPr>
+            <p:ph type="body" idx="1"/>
+          </p:nvPr>
+        </p:nvSpPr>
+        <p:spPr/>
+        <p:txBody>
+          <a:bodyPr/>
+          <a:lstStyle/>
+          <a:p>
+            <a:r>
+              <a:rPr lang="en-US" dirty="0"/>
+              <a:t/>
+            </a:r>
+            <a:endParaRPr lang="en-US" dirty="0"/>
+          </a:p>
+        </p:txBody>
+      </p:sp>
+      <p:sp>
+        <p:nvSpPr>
+          <p:cNvPr id="4" name="Slide Number Placeholder 3"/>
+          <p:cNvSpPr>
+            <a:spLocks noGrp="1"/>
+          </p:cNvSpPr>
+          <p:nvPr>
+            <p:ph type="sldNum" sz="quarter" idx="10"/>
+          </p:nvPr>
+        </p:nvSpPr>
+        <p:spPr/>
+        <p:txBody>
+          <a:bodyPr/>
+          <a:lstStyle/>
+          <a:p>
+            <a:fld id="{F7021451-1387-4CA6-816F-3879F97B5CBC}" type="slidenum">
+              <a:rPr lang="en-US"/>
+              <a:t>39</a:t>
+            </a:fld>
+            <a:endParaRPr lang="en-US"/>
+          </a:p>
+        </p:txBody>
+      </p:sp>
+    </p:spTree>
+    <p:extLst>
+      <p:ext uri="{BB962C8B-B14F-4D97-AF65-F5344CB8AC3E}">
+        <p14:creationId xmlns:p14="http://schemas.microsoft.com/office/powerpoint/2010/main" val="1024086991"/>
+      </p:ext>
+    </p:extLst>
+  </p:cSld>
+  <p:clrMapOvr>
+    <a:masterClrMapping/>
+  </p:clrMapOvr>
+</p:notes>
+</file>
+
 <file path=ppt/notesSlides/notesSlide4.xml><?xml version="1.0" encoding="utf-8"?>
 <p:notes xmlns:a="http://schemas.openxmlformats.org/drawingml/2006/main" xmlns:r="http://schemas.openxmlformats.org/officeDocument/2006/relationships" xmlns:p="http://schemas.openxmlformats.org/presentationml/2006/main">
   <p:cSld>
@@ -4312,6 +4502,270 @@
             <a:fld id="{F7021451-1387-4CA6-816F-3879F97B5CBC}" type="slidenum">
               <a:rPr lang="en-US"/>
               <a:t>4</a:t>
+            </a:fld>
+            <a:endParaRPr lang="en-US"/>
+          </a:p>
+        </p:txBody>
+      </p:sp>
+    </p:spTree>
+    <p:extLst>
+      <p:ext uri="{BB962C8B-B14F-4D97-AF65-F5344CB8AC3E}">
+        <p14:creationId xmlns:p14="http://schemas.microsoft.com/office/powerpoint/2010/main" val="1024086991"/>
+      </p:ext>
+    </p:extLst>
+  </p:cSld>
+  <p:clrMapOvr>
+    <a:masterClrMapping/>
+  </p:clrMapOvr>
+</p:notes>
+</file>
+
+<file path=ppt/notesSlides/notesSlide40.xml><?xml version="1.0" encoding="utf-8"?>
+<p:notes xmlns:a="http://schemas.openxmlformats.org/drawingml/2006/main" xmlns:r="http://schemas.openxmlformats.org/officeDocument/2006/relationships" xmlns:p="http://schemas.openxmlformats.org/presentationml/2006/main">
+  <p:cSld>
+    <p:spTree>
+      <p:nvGrpSpPr>
+        <p:cNvPr id="1" name=""/>
+        <p:cNvGrpSpPr/>
+        <p:nvPr/>
+      </p:nvGrpSpPr>
+      <p:grpSpPr>
+        <a:xfrm>
+          <a:off x="0" y="0"/>
+          <a:ext cx="0" cy="0"/>
+          <a:chOff x="0" y="0"/>
+          <a:chExt cx="0" cy="0"/>
+        </a:xfrm>
+      </p:grpSpPr>
+      <p:sp>
+        <p:nvSpPr>
+          <p:cNvPr id="2" name="Slide Image Placeholder 1"/>
+          <p:cNvSpPr>
+            <a:spLocks noGrp="1" noRot="1" noChangeAspect="1"/>
+          </p:cNvSpPr>
+          <p:nvPr>
+            <p:ph type="sldImg"/>
+          </p:nvPr>
+        </p:nvSpPr>
+        <p:spPr/>
+      </p:sp>
+      <p:sp>
+        <p:nvSpPr>
+          <p:cNvPr id="3" name="Notes Placeholder 2"/>
+          <p:cNvSpPr>
+            <a:spLocks noGrp="1"/>
+          </p:cNvSpPr>
+          <p:nvPr>
+            <p:ph type="body" idx="1"/>
+          </p:nvPr>
+        </p:nvSpPr>
+        <p:spPr/>
+        <p:txBody>
+          <a:bodyPr/>
+          <a:lstStyle/>
+          <a:p>
+            <a:r>
+              <a:rPr lang="en-US" dirty="0"/>
+              <a:t/>
+            </a:r>
+            <a:endParaRPr lang="en-US" dirty="0"/>
+          </a:p>
+        </p:txBody>
+      </p:sp>
+      <p:sp>
+        <p:nvSpPr>
+          <p:cNvPr id="4" name="Slide Number Placeholder 3"/>
+          <p:cNvSpPr>
+            <a:spLocks noGrp="1"/>
+          </p:cNvSpPr>
+          <p:nvPr>
+            <p:ph type="sldNum" sz="quarter" idx="10"/>
+          </p:nvPr>
+        </p:nvSpPr>
+        <p:spPr/>
+        <p:txBody>
+          <a:bodyPr/>
+          <a:lstStyle/>
+          <a:p>
+            <a:fld id="{F7021451-1387-4CA6-816F-3879F97B5CBC}" type="slidenum">
+              <a:rPr lang="en-US"/>
+              <a:t>40</a:t>
+            </a:fld>
+            <a:endParaRPr lang="en-US"/>
+          </a:p>
+        </p:txBody>
+      </p:sp>
+    </p:spTree>
+    <p:extLst>
+      <p:ext uri="{BB962C8B-B14F-4D97-AF65-F5344CB8AC3E}">
+        <p14:creationId xmlns:p14="http://schemas.microsoft.com/office/powerpoint/2010/main" val="1024086991"/>
+      </p:ext>
+    </p:extLst>
+  </p:cSld>
+  <p:clrMapOvr>
+    <a:masterClrMapping/>
+  </p:clrMapOvr>
+</p:notes>
+</file>
+
+<file path=ppt/notesSlides/notesSlide41.xml><?xml version="1.0" encoding="utf-8"?>
+<p:notes xmlns:a="http://schemas.openxmlformats.org/drawingml/2006/main" xmlns:r="http://schemas.openxmlformats.org/officeDocument/2006/relationships" xmlns:p="http://schemas.openxmlformats.org/presentationml/2006/main">
+  <p:cSld>
+    <p:spTree>
+      <p:nvGrpSpPr>
+        <p:cNvPr id="1" name=""/>
+        <p:cNvGrpSpPr/>
+        <p:nvPr/>
+      </p:nvGrpSpPr>
+      <p:grpSpPr>
+        <a:xfrm>
+          <a:off x="0" y="0"/>
+          <a:ext cx="0" cy="0"/>
+          <a:chOff x="0" y="0"/>
+          <a:chExt cx="0" cy="0"/>
+        </a:xfrm>
+      </p:grpSpPr>
+      <p:sp>
+        <p:nvSpPr>
+          <p:cNvPr id="2" name="Slide Image Placeholder 1"/>
+          <p:cNvSpPr>
+            <a:spLocks noGrp="1" noRot="1" noChangeAspect="1"/>
+          </p:cNvSpPr>
+          <p:nvPr>
+            <p:ph type="sldImg"/>
+          </p:nvPr>
+        </p:nvSpPr>
+        <p:spPr/>
+      </p:sp>
+      <p:sp>
+        <p:nvSpPr>
+          <p:cNvPr id="3" name="Notes Placeholder 2"/>
+          <p:cNvSpPr>
+            <a:spLocks noGrp="1"/>
+          </p:cNvSpPr>
+          <p:nvPr>
+            <p:ph type="body" idx="1"/>
+          </p:nvPr>
+        </p:nvSpPr>
+        <p:spPr/>
+        <p:txBody>
+          <a:bodyPr/>
+          <a:lstStyle/>
+          <a:p>
+            <a:r>
+              <a:rPr lang="en-US" dirty="0"/>
+              <a:t/>
+            </a:r>
+            <a:endParaRPr lang="en-US" dirty="0"/>
+          </a:p>
+        </p:txBody>
+      </p:sp>
+      <p:sp>
+        <p:nvSpPr>
+          <p:cNvPr id="4" name="Slide Number Placeholder 3"/>
+          <p:cNvSpPr>
+            <a:spLocks noGrp="1"/>
+          </p:cNvSpPr>
+          <p:nvPr>
+            <p:ph type="sldNum" sz="quarter" idx="10"/>
+          </p:nvPr>
+        </p:nvSpPr>
+        <p:spPr/>
+        <p:txBody>
+          <a:bodyPr/>
+          <a:lstStyle/>
+          <a:p>
+            <a:fld id="{F7021451-1387-4CA6-816F-3879F97B5CBC}" type="slidenum">
+              <a:rPr lang="en-US"/>
+              <a:t>41</a:t>
+            </a:fld>
+            <a:endParaRPr lang="en-US"/>
+          </a:p>
+        </p:txBody>
+      </p:sp>
+    </p:spTree>
+    <p:extLst>
+      <p:ext uri="{BB962C8B-B14F-4D97-AF65-F5344CB8AC3E}">
+        <p14:creationId xmlns:p14="http://schemas.microsoft.com/office/powerpoint/2010/main" val="1024086991"/>
+      </p:ext>
+    </p:extLst>
+  </p:cSld>
+  <p:clrMapOvr>
+    <a:masterClrMapping/>
+  </p:clrMapOvr>
+</p:notes>
+</file>
+
+<file path=ppt/notesSlides/notesSlide42.xml><?xml version="1.0" encoding="utf-8"?>
+<p:notes xmlns:a="http://schemas.openxmlformats.org/drawingml/2006/main" xmlns:r="http://schemas.openxmlformats.org/officeDocument/2006/relationships" xmlns:p="http://schemas.openxmlformats.org/presentationml/2006/main">
+  <p:cSld>
+    <p:spTree>
+      <p:nvGrpSpPr>
+        <p:cNvPr id="1" name=""/>
+        <p:cNvGrpSpPr/>
+        <p:nvPr/>
+      </p:nvGrpSpPr>
+      <p:grpSpPr>
+        <a:xfrm>
+          <a:off x="0" y="0"/>
+          <a:ext cx="0" cy="0"/>
+          <a:chOff x="0" y="0"/>
+          <a:chExt cx="0" cy="0"/>
+        </a:xfrm>
+      </p:grpSpPr>
+      <p:sp>
+        <p:nvSpPr>
+          <p:cNvPr id="2" name="Slide Image Placeholder 1"/>
+          <p:cNvSpPr>
+            <a:spLocks noGrp="1" noRot="1" noChangeAspect="1"/>
+          </p:cNvSpPr>
+          <p:nvPr>
+            <p:ph type="sldImg"/>
+          </p:nvPr>
+        </p:nvSpPr>
+        <p:spPr/>
+      </p:sp>
+      <p:sp>
+        <p:nvSpPr>
+          <p:cNvPr id="3" name="Notes Placeholder 2"/>
+          <p:cNvSpPr>
+            <a:spLocks noGrp="1"/>
+          </p:cNvSpPr>
+          <p:nvPr>
+            <p:ph type="body" idx="1"/>
+          </p:nvPr>
+        </p:nvSpPr>
+        <p:spPr/>
+        <p:txBody>
+          <a:bodyPr/>
+          <a:lstStyle/>
+          <a:p>
+            <a:r>
+              <a:rPr lang="en-US" dirty="0"/>
+              <a:t/>
+            </a:r>
+            <a:endParaRPr lang="en-US" dirty="0"/>
+          </a:p>
+        </p:txBody>
+      </p:sp>
+      <p:sp>
+        <p:nvSpPr>
+          <p:cNvPr id="4" name="Slide Number Placeholder 3"/>
+          <p:cNvSpPr>
+            <a:spLocks noGrp="1"/>
+          </p:cNvSpPr>
+          <p:nvPr>
+            <p:ph type="sldNum" sz="quarter" idx="10"/>
+          </p:nvPr>
+        </p:nvSpPr>
+        <p:spPr/>
+        <p:txBody>
+          <a:bodyPr/>
+          <a:lstStyle/>
+          <a:p>
+            <a:fld id="{F7021451-1387-4CA6-816F-3879F97B5CBC}" type="slidenum">
+              <a:rPr lang="en-US"/>
+              <a:t>42</a:t>
             </a:fld>
             <a:endParaRPr lang="en-US"/>
           </a:p>
@@ -28202,7 +28656,7 @@
                   <a:schemeClr val="bg1"/>
                 </a:solidFill>
               </a:rPr>
-              <a:t>안전하게, 자주 반복하기</a:t>
+              <a:t>문의·광고 받기</a:t>
             </a:r>
             <a:endParaRPr lang="en-US" sz="4000" dirty="0"/>
           </a:p>
@@ -28240,23 +28694,1410 @@
                   <a:schemeClr val="bg2"/>
                 </a:solidFill>
               </a:rPr>
-              <a:t>기획 → 백업 → 연습용 사이트에서 수정 → 확인 → 배포 → 감시 → 숫자 보기 → 다시 기획</a:t>
+              <a:t>문의 창구 · 도메인 이메일 · 스팸함 피하기 · 광고 메일 규칙 · 광고·제휴 문의 — 30–31장</a:t>
             </a:r>
             <a:endParaRPr lang="en-US" sz="1800" dirty="0"/>
           </a:p>
-          <a:p>
-            <a:pPr algn="l" indent="0" marL="0">
-              <a:buNone/>
-            </a:pPr>
-            <a:r>
-              <a:rPr lang="en-US" sz="1800" dirty="0">
+        </p:txBody>
+      </p:sp>
+    </p:spTree>
+  </p:cSld>
+  <p:clrMapOvr>
+    <a:masterClrMapping/>
+  </p:clrMapOvr>
+</p:sld>
+</file>
+
+<file path=ppt/slides/slide38.xml><?xml version="1.0" encoding="utf-8"?>
+<p:sld xmlns:a="http://schemas.openxmlformats.org/drawingml/2006/main" xmlns:r="http://schemas.openxmlformats.org/officeDocument/2006/relationships" xmlns:p="http://schemas.openxmlformats.org/presentationml/2006/main">
+  <p:cSld name="Slide 38">
+    <p:spTree>
+      <p:nvGrpSpPr>
+        <p:cNvPr id="1" name=""/>
+        <p:cNvGrpSpPr/>
+        <p:nvPr/>
+      </p:nvGrpSpPr>
+      <p:grpSpPr>
+        <a:xfrm>
+          <a:off x="0" y="0"/>
+          <a:ext cx="0" cy="0"/>
+          <a:chOff x="0" y="0"/>
+          <a:chExt cx="0" cy="0"/>
+        </a:xfrm>
+      </p:grpSpPr>
+      <p:sp>
+        <p:nvSpPr>
+          <p:cNvPr id="2" name="Text 0"/>
+          <p:cNvSpPr/>
+          <p:nvPr>
+            <p:ph idx="100" type="title" hasCustomPrompt="1"/>
+          </p:nvPr>
+        </p:nvSpPr>
+        <p:spPr>
+          <a:xfrm>
+            <a:off x="457200" y="274320"/>
+            <a:ext cx="8229600" cy="685800"/>
+          </a:xfrm>
+          <a:prstGeom prst="rect">
+            <a:avLst/>
+          </a:prstGeom>
+          <a:noFill/>
+          <a:ln/>
+        </p:spPr>
+        <p:txBody>
+          <a:bodyPr wrap="square" lIns="0" tIns="0" rIns="0" bIns="0" rtlCol="0" anchor="ctr"/>
+          <a:lstStyle/>
+          <a:p>
+            <a:pPr indent="0" marL="0">
+              <a:buNone/>
+            </a:pPr>
+            <a:r>
+              <a:rPr lang="en-US" sz="2800" b="1" dirty="0">
+                <a:solidFill>
+                  <a:schemeClr val="tx2"/>
+                </a:solidFill>
+              </a:rPr>
+              <a:t>시작은 도메인 이메일 1개 + 문의 폼 1개</a:t>
+            </a:r>
+            <a:endParaRPr lang="en-US" sz="2800" dirty="0"/>
+          </a:p>
+        </p:txBody>
+      </p:sp>
+      <p:sp>
+        <p:nvSpPr>
+          <p:cNvPr id="3" name="Text 1"/>
+          <p:cNvSpPr txBox="1"/>
+          <p:nvPr/>
+        </p:nvSpPr>
+        <p:spPr>
+          <a:xfrm>
+            <a:off x="457200" y="1188720"/>
+            <a:ext cx="3840480" cy="365760"/>
+          </a:xfrm>
+          <a:prstGeom prst="rect">
+            <a:avLst/>
+          </a:prstGeom>
+          <a:noFill/>
+          <a:ln/>
+        </p:spPr>
+        <p:txBody>
+          <a:bodyPr wrap="square" lIns="0" tIns="0" rIns="0" bIns="0" rtlCol="0" anchor="t"/>
+          <a:lstStyle/>
+          <a:p>
+            <a:pPr indent="0" marL="0">
+              <a:buNone/>
+            </a:pPr>
+            <a:r>
+              <a:rPr lang="en-US" sz="1600" b="1" dirty="0">
+                <a:solidFill>
+                  <a:schemeClr val="accent2"/>
+                </a:solidFill>
+              </a:rPr>
+              <a:t>문의 창구</a:t>
+            </a:r>
+            <a:endParaRPr lang="en-US" sz="1600" dirty="0"/>
+          </a:p>
+        </p:txBody>
+      </p:sp>
+      <p:sp>
+        <p:nvSpPr>
+          <p:cNvPr id="4" name="Text 2"/>
+          <p:cNvSpPr txBox="1"/>
+          <p:nvPr/>
+        </p:nvSpPr>
+        <p:spPr>
+          <a:xfrm>
+            <a:off x="457200" y="1645920"/>
+            <a:ext cx="3931920" cy="2651760"/>
+          </a:xfrm>
+          <a:prstGeom prst="rect">
+            <a:avLst/>
+          </a:prstGeom>
+          <a:noFill/>
+          <a:ln/>
+        </p:spPr>
+        <p:txBody>
+          <a:bodyPr wrap="square" lIns="0" tIns="0" rIns="0" bIns="0" rtlCol="0" anchor="t"/>
+          <a:lstStyle/>
+          <a:p>
+            <a:pPr marL="342900" indent="-342900">
+              <a:spcAft>
+                <a:spcPts val="800"/>
+              </a:spcAft>
+              <a:buSzPct val="100000"/>
+              <a:buChar char="•"/>
+            </a:pPr>
+            <a:r>
+              <a:rPr lang="en-US" sz="1400" dirty="0">
+                <a:solidFill>
+                  <a:schemeClr val="tx1"/>
+                </a:solidFill>
+              </a:rPr>
+              <a:t>이메일 — 모든 사업의 기본</a:t>
+            </a:r>
+            <a:endParaRPr lang="en-US" sz="1400" dirty="0"/>
+          </a:p>
+          <a:p>
+            <a:pPr marL="342900" indent="-342900">
+              <a:spcAft>
+                <a:spcPts val="800"/>
+              </a:spcAft>
+              <a:buSzPct val="100000"/>
+              <a:buChar char="•"/>
+            </a:pPr>
+            <a:r>
+              <a:rPr lang="en-US" sz="1400" dirty="0">
+                <a:solidFill>
+                  <a:schemeClr val="tx1"/>
+                </a:solidFill>
+              </a:rPr>
+              <a:t>문의 폼 — 필요한 정보만, 스팸 막기 쉬움</a:t>
+            </a:r>
+            <a:endParaRPr lang="en-US" sz="1400" dirty="0"/>
+          </a:p>
+          <a:p>
+            <a:pPr marL="342900" indent="-342900">
+              <a:spcAft>
+                <a:spcPts val="800"/>
+              </a:spcAft>
+              <a:buSzPct val="100000"/>
+              <a:buChar char="•"/>
+            </a:pPr>
+            <a:r>
+              <a:rPr lang="en-US" sz="1400" dirty="0">
+                <a:solidFill>
+                  <a:schemeClr val="tx1"/>
+                </a:solidFill>
+              </a:rPr>
+              <a:t>1:1 게시판 · 카카오톡 채널 · 채팅</a:t>
+            </a:r>
+            <a:endParaRPr lang="en-US" sz="1400" dirty="0"/>
+          </a:p>
+          <a:p>
+            <a:pPr marL="342900" indent="-342900">
+              <a:spcAft>
+                <a:spcPts val="800"/>
+              </a:spcAft>
+              <a:buSzPct val="100000"/>
+              <a:buChar char="•"/>
+            </a:pPr>
+            <a:r>
+              <a:rPr lang="en-US" sz="1400" dirty="0">
+                <a:solidFill>
+                  <a:schemeClr val="tx1"/>
+                </a:solidFill>
+              </a:rPr>
+              <a:t>앱 안 문의 · 마켓 문의 기능</a:t>
+            </a:r>
+            <a:endParaRPr lang="en-US" sz="1400" dirty="0"/>
+          </a:p>
+          <a:p>
+            <a:pPr marL="342900" indent="-342900">
+              <a:spcAft>
+                <a:spcPts val="800"/>
+              </a:spcAft>
+              <a:buSzPct val="100000"/>
+              <a:buChar char="•"/>
+            </a:pPr>
+            <a:r>
+              <a:rPr lang="en-US" sz="1400" dirty="0">
+                <a:solidFill>
+                  <a:schemeClr val="tx1"/>
+                </a:solidFill>
+              </a:rPr>
+              <a:t>창구가 많을수록 놓치는 문의도 늘어남</a:t>
+            </a:r>
+            <a:endParaRPr lang="en-US" sz="1400" dirty="0"/>
+          </a:p>
+        </p:txBody>
+      </p:sp>
+      <p:sp>
+        <p:nvSpPr>
+          <p:cNvPr id="5" name="card"/>
+          <p:cNvSpPr/>
+          <p:nvPr/>
+        </p:nvSpPr>
+        <p:spPr>
+          <a:xfrm>
+            <a:off x="4572000" y="1188720"/>
+            <a:ext cx="4114800" cy="3200400"/>
+          </a:xfrm>
+          <a:prstGeom prst="roundRect">
+            <a:avLst>
+              <a:gd name="adj" fmla="val 2286"/>
+            </a:avLst>
+          </a:prstGeom>
+          <a:solidFill>
+            <a:schemeClr val="bg2"/>
+          </a:solidFill>
+          <a:ln/>
+        </p:spPr>
+      </p:sp>
+      <p:sp>
+        <p:nvSpPr>
+          <p:cNvPr id="6" name="Text 4"/>
+          <p:cNvSpPr txBox="1"/>
+          <p:nvPr/>
+        </p:nvSpPr>
+        <p:spPr>
+          <a:xfrm>
+            <a:off x="4800600" y="1325880"/>
+            <a:ext cx="3749040" cy="365760"/>
+          </a:xfrm>
+          <a:prstGeom prst="rect">
+            <a:avLst/>
+          </a:prstGeom>
+          <a:noFill/>
+          <a:ln/>
+        </p:spPr>
+        <p:txBody>
+          <a:bodyPr wrap="square" lIns="0" tIns="0" rIns="0" bIns="0" rtlCol="0" anchor="t"/>
+          <a:lstStyle/>
+          <a:p>
+            <a:pPr indent="0" marL="0">
+              <a:buNone/>
+            </a:pPr>
+            <a:r>
+              <a:rPr lang="en-US" sz="1400" b="1" dirty="0">
+                <a:solidFill>
+                  <a:schemeClr val="tx2"/>
+                </a:solidFill>
+              </a:rPr>
+              <a:t>용도별 주소 (한 메일함으로 모으기)</a:t>
+            </a:r>
+            <a:endParaRPr lang="en-US" sz="1400" dirty="0"/>
+          </a:p>
+        </p:txBody>
+      </p:sp>
+      <p:sp>
+        <p:nvSpPr>
+          <p:cNvPr id="7" name="Text 5"/>
+          <p:cNvSpPr txBox="1"/>
+          <p:nvPr/>
+        </p:nvSpPr>
+        <p:spPr>
+          <a:xfrm>
+            <a:off x="4800600" y="1783080"/>
+            <a:ext cx="1280160" cy="411480"/>
+          </a:xfrm>
+          <a:prstGeom prst="rect">
+            <a:avLst/>
+          </a:prstGeom>
+          <a:noFill/>
+          <a:ln/>
+        </p:spPr>
+        <p:txBody>
+          <a:bodyPr wrap="square" lIns="0" tIns="0" rIns="0" bIns="0" rtlCol="0" anchor="ctr"/>
+          <a:lstStyle/>
+          <a:p>
+            <a:pPr indent="0" marL="0">
+              <a:buNone/>
+            </a:pPr>
+            <a:r>
+              <a:rPr lang="en-US" sz="1400" b="1" dirty="0">
+                <a:solidFill>
+                  <a:schemeClr val="accent2"/>
+                </a:solidFill>
+                <a:latin typeface="Courier New" pitchFamily="34" charset="0"/>
+                <a:ea typeface="Courier New" pitchFamily="34" charset="-122"/>
+                <a:cs typeface="Courier New" pitchFamily="34" charset="-120"/>
+              </a:rPr>
+              <a:t>help@</a:t>
+            </a:r>
+            <a:endParaRPr lang="en-US" sz="1400" dirty="0"/>
+          </a:p>
+        </p:txBody>
+      </p:sp>
+      <p:sp>
+        <p:nvSpPr>
+          <p:cNvPr id="8" name="Text 6"/>
+          <p:cNvSpPr txBox="1"/>
+          <p:nvPr/>
+        </p:nvSpPr>
+        <p:spPr>
+          <a:xfrm>
+            <a:off x="6126480" y="1783080"/>
+            <a:ext cx="2377440" cy="411480"/>
+          </a:xfrm>
+          <a:prstGeom prst="rect">
+            <a:avLst/>
+          </a:prstGeom>
+          <a:noFill/>
+          <a:ln/>
+        </p:spPr>
+        <p:txBody>
+          <a:bodyPr wrap="square" lIns="0" tIns="0" rIns="0" bIns="0" rtlCol="0" anchor="ctr"/>
+          <a:lstStyle/>
+          <a:p>
+            <a:pPr indent="0" marL="0">
+              <a:buNone/>
+            </a:pPr>
+            <a:r>
+              <a:rPr lang="en-US" sz="1400" dirty="0">
+                <a:solidFill>
+                  <a:schemeClr val="tx1"/>
+                </a:solidFill>
+              </a:rPr>
+              <a:t>일반 문의</a:t>
+            </a:r>
+            <a:endParaRPr lang="en-US" sz="1400" dirty="0"/>
+          </a:p>
+        </p:txBody>
+      </p:sp>
+      <p:sp>
+        <p:nvSpPr>
+          <p:cNvPr id="9" name="Text 7"/>
+          <p:cNvSpPr txBox="1"/>
+          <p:nvPr/>
+        </p:nvSpPr>
+        <p:spPr>
+          <a:xfrm>
+            <a:off x="4800600" y="2286000"/>
+            <a:ext cx="1280160" cy="411480"/>
+          </a:xfrm>
+          <a:prstGeom prst="rect">
+            <a:avLst/>
+          </a:prstGeom>
+          <a:noFill/>
+          <a:ln/>
+        </p:spPr>
+        <p:txBody>
+          <a:bodyPr wrap="square" lIns="0" tIns="0" rIns="0" bIns="0" rtlCol="0" anchor="ctr"/>
+          <a:lstStyle/>
+          <a:p>
+            <a:pPr indent="0" marL="0">
+              <a:buNone/>
+            </a:pPr>
+            <a:r>
+              <a:rPr lang="en-US" sz="1400" b="1" dirty="0">
+                <a:solidFill>
+                  <a:schemeClr val="accent2"/>
+                </a:solidFill>
+                <a:latin typeface="Courier New" pitchFamily="34" charset="0"/>
+                <a:ea typeface="Courier New" pitchFamily="34" charset="-122"/>
+                <a:cs typeface="Courier New" pitchFamily="34" charset="-120"/>
+              </a:rPr>
+              <a:t>ads@</a:t>
+            </a:r>
+            <a:endParaRPr lang="en-US" sz="1400" dirty="0"/>
+          </a:p>
+        </p:txBody>
+      </p:sp>
+      <p:sp>
+        <p:nvSpPr>
+          <p:cNvPr id="10" name="Text 8"/>
+          <p:cNvSpPr txBox="1"/>
+          <p:nvPr/>
+        </p:nvSpPr>
+        <p:spPr>
+          <a:xfrm>
+            <a:off x="6126480" y="2286000"/>
+            <a:ext cx="2377440" cy="411480"/>
+          </a:xfrm>
+          <a:prstGeom prst="rect">
+            <a:avLst/>
+          </a:prstGeom>
+          <a:noFill/>
+          <a:ln/>
+        </p:spPr>
+        <p:txBody>
+          <a:bodyPr wrap="square" lIns="0" tIns="0" rIns="0" bIns="0" rtlCol="0" anchor="ctr"/>
+          <a:lstStyle/>
+          <a:p>
+            <a:pPr indent="0" marL="0">
+              <a:buNone/>
+            </a:pPr>
+            <a:r>
+              <a:rPr lang="en-US" sz="1400" dirty="0">
+                <a:solidFill>
+                  <a:schemeClr val="tx1"/>
+                </a:solidFill>
+              </a:rPr>
+              <a:t>광고·제휴</a:t>
+            </a:r>
+            <a:endParaRPr lang="en-US" sz="1400" dirty="0"/>
+          </a:p>
+        </p:txBody>
+      </p:sp>
+      <p:sp>
+        <p:nvSpPr>
+          <p:cNvPr id="11" name="Text 9"/>
+          <p:cNvSpPr txBox="1"/>
+          <p:nvPr/>
+        </p:nvSpPr>
+        <p:spPr>
+          <a:xfrm>
+            <a:off x="4800600" y="2788920"/>
+            <a:ext cx="1280160" cy="411480"/>
+          </a:xfrm>
+          <a:prstGeom prst="rect">
+            <a:avLst/>
+          </a:prstGeom>
+          <a:noFill/>
+          <a:ln/>
+        </p:spPr>
+        <p:txBody>
+          <a:bodyPr wrap="square" lIns="0" tIns="0" rIns="0" bIns="0" rtlCol="0" anchor="ctr"/>
+          <a:lstStyle/>
+          <a:p>
+            <a:pPr indent="0" marL="0">
+              <a:buNone/>
+            </a:pPr>
+            <a:r>
+              <a:rPr lang="en-US" sz="1400" b="1" dirty="0">
+                <a:solidFill>
+                  <a:schemeClr val="accent2"/>
+                </a:solidFill>
+                <a:latin typeface="Courier New" pitchFamily="34" charset="0"/>
+                <a:ea typeface="Courier New" pitchFamily="34" charset="-122"/>
+                <a:cs typeface="Courier New" pitchFamily="34" charset="-120"/>
+              </a:rPr>
+              <a:t>privacy@</a:t>
+            </a:r>
+            <a:endParaRPr lang="en-US" sz="1400" dirty="0"/>
+          </a:p>
+        </p:txBody>
+      </p:sp>
+      <p:sp>
+        <p:nvSpPr>
+          <p:cNvPr id="12" name="Text 10"/>
+          <p:cNvSpPr txBox="1"/>
+          <p:nvPr/>
+        </p:nvSpPr>
+        <p:spPr>
+          <a:xfrm>
+            <a:off x="6126480" y="2788920"/>
+            <a:ext cx="2377440" cy="411480"/>
+          </a:xfrm>
+          <a:prstGeom prst="rect">
+            <a:avLst/>
+          </a:prstGeom>
+          <a:noFill/>
+          <a:ln/>
+        </p:spPr>
+        <p:txBody>
+          <a:bodyPr wrap="square" lIns="0" tIns="0" rIns="0" bIns="0" rtlCol="0" anchor="ctr"/>
+          <a:lstStyle/>
+          <a:p>
+            <a:pPr indent="0" marL="0">
+              <a:buNone/>
+            </a:pPr>
+            <a:r>
+              <a:rPr lang="en-US" sz="1400" dirty="0">
+                <a:solidFill>
+                  <a:schemeClr val="tx1"/>
+                </a:solidFill>
+              </a:rPr>
+              <a:t>개인정보 요청</a:t>
+            </a:r>
+            <a:endParaRPr lang="en-US" sz="1400" dirty="0"/>
+          </a:p>
+        </p:txBody>
+      </p:sp>
+      <p:sp>
+        <p:nvSpPr>
+          <p:cNvPr id="13" name="Text 11"/>
+          <p:cNvSpPr txBox="1"/>
+          <p:nvPr/>
+        </p:nvSpPr>
+        <p:spPr>
+          <a:xfrm>
+            <a:off x="4800600" y="3291840"/>
+            <a:ext cx="1280160" cy="411480"/>
+          </a:xfrm>
+          <a:prstGeom prst="rect">
+            <a:avLst/>
+          </a:prstGeom>
+          <a:noFill/>
+          <a:ln/>
+        </p:spPr>
+        <p:txBody>
+          <a:bodyPr wrap="square" lIns="0" tIns="0" rIns="0" bIns="0" rtlCol="0" anchor="ctr"/>
+          <a:lstStyle/>
+          <a:p>
+            <a:pPr indent="0" marL="0">
+              <a:buNone/>
+            </a:pPr>
+            <a:r>
+              <a:rPr lang="en-US" sz="1400" b="1" dirty="0">
+                <a:solidFill>
+                  <a:schemeClr val="accent2"/>
+                </a:solidFill>
+                <a:latin typeface="Courier New" pitchFamily="34" charset="0"/>
+                <a:ea typeface="Courier New" pitchFamily="34" charset="-122"/>
+                <a:cs typeface="Courier New" pitchFamily="34" charset="-120"/>
+              </a:rPr>
+              <a:t>report@</a:t>
+            </a:r>
+            <a:endParaRPr lang="en-US" sz="1400" dirty="0"/>
+          </a:p>
+        </p:txBody>
+      </p:sp>
+      <p:sp>
+        <p:nvSpPr>
+          <p:cNvPr id="14" name="Text 12"/>
+          <p:cNvSpPr txBox="1"/>
+          <p:nvPr/>
+        </p:nvSpPr>
+        <p:spPr>
+          <a:xfrm>
+            <a:off x="6126480" y="3291840"/>
+            <a:ext cx="2377440" cy="411480"/>
+          </a:xfrm>
+          <a:prstGeom prst="rect">
+            <a:avLst/>
+          </a:prstGeom>
+          <a:noFill/>
+          <a:ln/>
+        </p:spPr>
+        <p:txBody>
+          <a:bodyPr wrap="square" lIns="0" tIns="0" rIns="0" bIns="0" rtlCol="0" anchor="ctr"/>
+          <a:lstStyle/>
+          <a:p>
+            <a:pPr indent="0" marL="0">
+              <a:buNone/>
+            </a:pPr>
+            <a:r>
+              <a:rPr lang="en-US" sz="1400" dirty="0">
+                <a:solidFill>
+                  <a:schemeClr val="tx1"/>
+                </a:solidFill>
+              </a:rPr>
+              <a:t>불법 게시물 신고</a:t>
+            </a:r>
+            <a:endParaRPr lang="en-US" sz="1400" dirty="0"/>
+          </a:p>
+        </p:txBody>
+      </p:sp>
+      <p:sp>
+        <p:nvSpPr>
+          <p:cNvPr id="15" name="Text 13"/>
+          <p:cNvSpPr txBox="1"/>
+          <p:nvPr/>
+        </p:nvSpPr>
+        <p:spPr>
+          <a:xfrm>
+            <a:off x="4800600" y="3794760"/>
+            <a:ext cx="1280160" cy="411480"/>
+          </a:xfrm>
+          <a:prstGeom prst="rect">
+            <a:avLst/>
+          </a:prstGeom>
+          <a:noFill/>
+          <a:ln/>
+        </p:spPr>
+        <p:txBody>
+          <a:bodyPr wrap="square" lIns="0" tIns="0" rIns="0" bIns="0" rtlCol="0" anchor="ctr"/>
+          <a:lstStyle/>
+          <a:p>
+            <a:pPr indent="0" marL="0">
+              <a:buNone/>
+            </a:pPr>
+            <a:r>
+              <a:rPr lang="en-US" sz="1400" b="1" dirty="0">
+                <a:solidFill>
+                  <a:schemeClr val="accent2"/>
+                </a:solidFill>
+                <a:latin typeface="Courier New" pitchFamily="34" charset="0"/>
+                <a:ea typeface="Courier New" pitchFamily="34" charset="-122"/>
+                <a:cs typeface="Courier New" pitchFamily="34" charset="-120"/>
+              </a:rPr>
+              <a:t>billing@</a:t>
+            </a:r>
+            <a:endParaRPr lang="en-US" sz="1400" dirty="0"/>
+          </a:p>
+        </p:txBody>
+      </p:sp>
+      <p:sp>
+        <p:nvSpPr>
+          <p:cNvPr id="16" name="Text 14"/>
+          <p:cNvSpPr txBox="1"/>
+          <p:nvPr/>
+        </p:nvSpPr>
+        <p:spPr>
+          <a:xfrm>
+            <a:off x="6126480" y="3794760"/>
+            <a:ext cx="2377440" cy="411480"/>
+          </a:xfrm>
+          <a:prstGeom prst="rect">
+            <a:avLst/>
+          </a:prstGeom>
+          <a:noFill/>
+          <a:ln/>
+        </p:spPr>
+        <p:txBody>
+          <a:bodyPr wrap="square" lIns="0" tIns="0" rIns="0" bIns="0" rtlCol="0" anchor="ctr"/>
+          <a:lstStyle/>
+          <a:p>
+            <a:pPr indent="0" marL="0">
+              <a:buNone/>
+            </a:pPr>
+            <a:r>
+              <a:rPr lang="en-US" sz="1400" dirty="0">
+                <a:solidFill>
+                  <a:schemeClr val="tx1"/>
+                </a:solidFill>
+              </a:rPr>
+              <a:t>결제·환불</a:t>
+            </a:r>
+            <a:endParaRPr lang="en-US" sz="1400" dirty="0"/>
+          </a:p>
+        </p:txBody>
+      </p:sp>
+      <p:sp>
+        <p:nvSpPr>
+          <p:cNvPr id="25" name="Slide Number Placeholder 0"/>
+          <p:cNvSpPr>
+            <a:spLocks noGrp="1"/>
+          </p:cNvSpPr>
+          <p:nvPr>
+            <p:ph type="sldNum" sz="quarter" idx="4294967295"/>
+          </p:nvPr>
+        </p:nvSpPr>
+        <p:spPr>
+          <a:xfrm>
+            <a:off x="8321040" y="4754880"/>
+            <a:ext cx="457200" cy="274320"/>
+          </a:xfrm>
+          <a:prstGeom prst="rect">
+            <a:avLst/>
+          </a:prstGeom>
+          <a:extLst>
+            <a:ext uri="{C572A759-6A51-4108-AA02-DFA0A04FC94B}">
+              <ma14:wrappingTextBoxFlag xmlns:ma14="http://schemas.microsoft.com/office/mac/drawingml/2011/main" val="0"/>
+            </a:ext>
+          </a:extLst>
+        </p:spPr>
+        <p:txBody>
+          <a:bodyPr/>
+          <a:lstStyle>
+            <a:lvl1pPr>
+              <a:defRPr sz="1000">
+                <a:solidFill>
+                  <a:schemeClr val="accent4"/>
+                </a:solidFill>
+              </a:defRPr>
+            </a:lvl1pPr>
+          </a:lstStyle>
+          <a:p>
+            <a:pPr algn="r"/>
+            <a:fld id="{F7021451-1387-4CA6-816F-3879F97B5CBC}" type="slidenum">
+              <a:rPr b="0" lang="en-US"/>
+              <a:t>38</a:t>
+            </a:fld>
+            <a:endParaRPr lang="en-US"/>
+          </a:p>
+        </p:txBody>
+      </p:sp>
+    </p:spTree>
+  </p:cSld>
+  <p:clrMapOvr>
+    <a:masterClrMapping/>
+  </p:clrMapOvr>
+</p:sld>
+</file>
+
+<file path=ppt/slides/slide39.xml><?xml version="1.0" encoding="utf-8"?>
+<p:sld xmlns:a="http://schemas.openxmlformats.org/drawingml/2006/main" xmlns:r="http://schemas.openxmlformats.org/officeDocument/2006/relationships" xmlns:p="http://schemas.openxmlformats.org/presentationml/2006/main">
+  <p:cSld name="Slide 39">
+    <p:spTree>
+      <p:nvGrpSpPr>
+        <p:cNvPr id="1" name=""/>
+        <p:cNvGrpSpPr/>
+        <p:nvPr/>
+      </p:nvGrpSpPr>
+      <p:grpSpPr>
+        <a:xfrm>
+          <a:off x="0" y="0"/>
+          <a:ext cx="0" cy="0"/>
+          <a:chOff x="0" y="0"/>
+          <a:chExt cx="0" cy="0"/>
+        </a:xfrm>
+      </p:grpSpPr>
+      <p:sp>
+        <p:nvSpPr>
+          <p:cNvPr id="2" name="Text 0"/>
+          <p:cNvSpPr/>
+          <p:nvPr>
+            <p:ph idx="100" type="title" hasCustomPrompt="1"/>
+          </p:nvPr>
+        </p:nvSpPr>
+        <p:spPr>
+          <a:xfrm>
+            <a:off x="457200" y="274320"/>
+            <a:ext cx="8229600" cy="685800"/>
+          </a:xfrm>
+          <a:prstGeom prst="rect">
+            <a:avLst/>
+          </a:prstGeom>
+          <a:noFill/>
+          <a:ln/>
+        </p:spPr>
+        <p:txBody>
+          <a:bodyPr wrap="square" lIns="0" tIns="0" rIns="0" bIns="0" rtlCol="0" anchor="ctr"/>
+          <a:lstStyle/>
+          <a:p>
+            <a:pPr indent="0" marL="0">
+              <a:buNone/>
+            </a:pPr>
+            <a:r>
+              <a:rPr lang="en-US" sz="2800" b="1" dirty="0">
+                <a:solidFill>
+                  <a:schemeClr val="tx2"/>
+                </a:solidFill>
+              </a:rPr>
+              <a:t>스팸함에 안 빠지게: SPF · DKIM · DMARC</a:t>
+            </a:r>
+            <a:endParaRPr lang="en-US" sz="2800" dirty="0"/>
+          </a:p>
+        </p:txBody>
+      </p:sp>
+      <p:sp>
+        <p:nvSpPr>
+          <p:cNvPr id="3" name="card"/>
+          <p:cNvSpPr/>
+          <p:nvPr/>
+        </p:nvSpPr>
+        <p:spPr>
+          <a:xfrm>
+            <a:off x="457200" y="1188720"/>
+            <a:ext cx="1920240" cy="1920240"/>
+          </a:xfrm>
+          <a:prstGeom prst="roundRect">
+            <a:avLst>
+              <a:gd name="adj" fmla="val 3810"/>
+            </a:avLst>
+          </a:prstGeom>
+          <a:solidFill>
+            <a:schemeClr val="bg2"/>
+          </a:solidFill>
+          <a:ln/>
+        </p:spPr>
+      </p:sp>
+      <p:sp>
+        <p:nvSpPr>
+          <p:cNvPr id="4" name="Text 2"/>
+          <p:cNvSpPr txBox="1"/>
+          <p:nvPr/>
+        </p:nvSpPr>
+        <p:spPr>
+          <a:xfrm>
+            <a:off x="640080" y="1325880"/>
+            <a:ext cx="1554480" cy="502920"/>
+          </a:xfrm>
+          <a:prstGeom prst="rect">
+            <a:avLst/>
+          </a:prstGeom>
+          <a:noFill/>
+          <a:ln/>
+        </p:spPr>
+        <p:txBody>
+          <a:bodyPr wrap="square" lIns="0" tIns="0" rIns="0" bIns="0" rtlCol="0" anchor="t"/>
+          <a:lstStyle/>
+          <a:p>
+            <a:pPr indent="0" marL="0">
+              <a:buNone/>
+            </a:pPr>
+            <a:r>
+              <a:rPr lang="en-US" sz="2200" b="1" dirty="0">
+                <a:solidFill>
+                  <a:schemeClr val="tx2"/>
+                </a:solidFill>
+              </a:rPr>
+              <a:t>MX</a:t>
+            </a:r>
+            <a:endParaRPr lang="en-US" sz="2200" dirty="0"/>
+          </a:p>
+        </p:txBody>
+      </p:sp>
+      <p:sp>
+        <p:nvSpPr>
+          <p:cNvPr id="5" name="Text 3"/>
+          <p:cNvSpPr txBox="1"/>
+          <p:nvPr/>
+        </p:nvSpPr>
+        <p:spPr>
+          <a:xfrm>
+            <a:off x="640080" y="1874520"/>
+            <a:ext cx="1645920" cy="365760"/>
+          </a:xfrm>
+          <a:prstGeom prst="rect">
+            <a:avLst/>
+          </a:prstGeom>
+          <a:noFill/>
+          <a:ln/>
+        </p:spPr>
+        <p:txBody>
+          <a:bodyPr wrap="square" lIns="0" tIns="0" rIns="0" bIns="0" rtlCol="0" anchor="t"/>
+          <a:lstStyle/>
+          <a:p>
+            <a:pPr indent="0" marL="0">
+              <a:buNone/>
+            </a:pPr>
+            <a:r>
+              <a:rPr lang="en-US" sz="1300" b="1" dirty="0">
+                <a:solidFill>
+                  <a:schemeClr val="accent2"/>
+                </a:solidFill>
+              </a:rPr>
+              <a:t>우편함 위치</a:t>
+            </a:r>
+            <a:endParaRPr lang="en-US" sz="1300" dirty="0"/>
+          </a:p>
+        </p:txBody>
+      </p:sp>
+      <p:sp>
+        <p:nvSpPr>
+          <p:cNvPr id="6" name="Text 4"/>
+          <p:cNvSpPr txBox="1"/>
+          <p:nvPr/>
+        </p:nvSpPr>
+        <p:spPr>
+          <a:xfrm>
+            <a:off x="640080" y="2286000"/>
+            <a:ext cx="1645920" cy="685800"/>
+          </a:xfrm>
+          <a:prstGeom prst="rect">
+            <a:avLst/>
+          </a:prstGeom>
+          <a:noFill/>
+          <a:ln/>
+        </p:spPr>
+        <p:txBody>
+          <a:bodyPr wrap="square" lIns="0" tIns="0" rIns="0" bIns="0" rtlCol="0" anchor="t"/>
+          <a:lstStyle/>
+          <a:p>
+            <a:pPr indent="0" marL="0">
+              <a:buNone/>
+            </a:pPr>
+            <a:r>
+              <a:rPr lang="en-US" sz="1200" dirty="0">
+                <a:solidFill>
+                  <a:schemeClr val="tx1"/>
+                </a:solidFill>
+              </a:rPr>
+              <a:t>어느 서버가 메일을 받나</a:t>
+            </a:r>
+            <a:endParaRPr lang="en-US" sz="1200" dirty="0"/>
+          </a:p>
+        </p:txBody>
+      </p:sp>
+      <p:sp>
+        <p:nvSpPr>
+          <p:cNvPr id="7" name="card"/>
+          <p:cNvSpPr/>
+          <p:nvPr/>
+        </p:nvSpPr>
+        <p:spPr>
+          <a:xfrm>
+            <a:off x="2560320" y="1188720"/>
+            <a:ext cx="1920240" cy="1920240"/>
+          </a:xfrm>
+          <a:prstGeom prst="roundRect">
+            <a:avLst>
+              <a:gd name="adj" fmla="val 3810"/>
+            </a:avLst>
+          </a:prstGeom>
+          <a:solidFill>
+            <a:schemeClr val="tx2"/>
+          </a:solidFill>
+          <a:ln/>
+        </p:spPr>
+      </p:sp>
+      <p:sp>
+        <p:nvSpPr>
+          <p:cNvPr id="8" name="Text 6"/>
+          <p:cNvSpPr txBox="1"/>
+          <p:nvPr/>
+        </p:nvSpPr>
+        <p:spPr>
+          <a:xfrm>
+            <a:off x="2743200" y="1325880"/>
+            <a:ext cx="1554480" cy="502920"/>
+          </a:xfrm>
+          <a:prstGeom prst="rect">
+            <a:avLst/>
+          </a:prstGeom>
+          <a:noFill/>
+          <a:ln/>
+        </p:spPr>
+        <p:txBody>
+          <a:bodyPr wrap="square" lIns="0" tIns="0" rIns="0" bIns="0" rtlCol="0" anchor="t"/>
+          <a:lstStyle/>
+          <a:p>
+            <a:pPr indent="0" marL="0">
+              <a:buNone/>
+            </a:pPr>
+            <a:r>
+              <a:rPr lang="en-US" sz="2200" b="1" dirty="0">
+                <a:solidFill>
+                  <a:schemeClr val="accent6"/>
+                </a:solidFill>
+              </a:rPr>
+              <a:t>SPF</a:t>
+            </a:r>
+            <a:endParaRPr lang="en-US" sz="2200" dirty="0"/>
+          </a:p>
+        </p:txBody>
+      </p:sp>
+      <p:sp>
+        <p:nvSpPr>
+          <p:cNvPr id="9" name="Text 7"/>
+          <p:cNvSpPr txBox="1"/>
+          <p:nvPr/>
+        </p:nvSpPr>
+        <p:spPr>
+          <a:xfrm>
+            <a:off x="2743200" y="1874520"/>
+            <a:ext cx="1645920" cy="365760"/>
+          </a:xfrm>
+          <a:prstGeom prst="rect">
+            <a:avLst/>
+          </a:prstGeom>
+          <a:noFill/>
+          <a:ln/>
+        </p:spPr>
+        <p:txBody>
+          <a:bodyPr wrap="square" lIns="0" tIns="0" rIns="0" bIns="0" rtlCol="0" anchor="t"/>
+          <a:lstStyle/>
+          <a:p>
+            <a:pPr indent="0" marL="0">
+              <a:buNone/>
+            </a:pPr>
+            <a:r>
+              <a:rPr lang="en-US" sz="1300" b="1" dirty="0">
+                <a:solidFill>
+                  <a:schemeClr val="bg1"/>
+                </a:solidFill>
+              </a:rPr>
+              <a:t>보내는 우체국 명단</a:t>
+            </a:r>
+            <a:endParaRPr lang="en-US" sz="1300" dirty="0"/>
+          </a:p>
+        </p:txBody>
+      </p:sp>
+      <p:sp>
+        <p:nvSpPr>
+          <p:cNvPr id="10" name="Text 8"/>
+          <p:cNvSpPr txBox="1"/>
+          <p:nvPr/>
+        </p:nvSpPr>
+        <p:spPr>
+          <a:xfrm>
+            <a:off x="2743200" y="2286000"/>
+            <a:ext cx="1645920" cy="685800"/>
+          </a:xfrm>
+          <a:prstGeom prst="rect">
+            <a:avLst/>
+          </a:prstGeom>
+          <a:noFill/>
+          <a:ln/>
+        </p:spPr>
+        <p:txBody>
+          <a:bodyPr wrap="square" lIns="0" tIns="0" rIns="0" bIns="0" rtlCol="0" anchor="t"/>
+          <a:lstStyle/>
+          <a:p>
+            <a:pPr indent="0" marL="0">
+              <a:buNone/>
+            </a:pPr>
+            <a:r>
+              <a:rPr lang="en-US" sz="1200" dirty="0">
                 <a:solidFill>
                   <a:schemeClr val="bg2"/>
                 </a:solidFill>
               </a:rPr>
-              <a:t>다음 할 일: docs/13-practice-scenario.md 를 읽고 15장 퀴즈 풀기</a:t>
-            </a:r>
-            <a:endParaRPr lang="en-US" sz="1800" dirty="0"/>
+              <a:t>내 이름으로 보내도 되는 서버</a:t>
+            </a:r>
+            <a:endParaRPr lang="en-US" sz="1200" dirty="0"/>
+          </a:p>
+        </p:txBody>
+      </p:sp>
+      <p:sp>
+        <p:nvSpPr>
+          <p:cNvPr id="11" name="card"/>
+          <p:cNvSpPr/>
+          <p:nvPr/>
+        </p:nvSpPr>
+        <p:spPr>
+          <a:xfrm>
+            <a:off x="4663440" y="1188720"/>
+            <a:ext cx="1920240" cy="1920240"/>
+          </a:xfrm>
+          <a:prstGeom prst="roundRect">
+            <a:avLst>
+              <a:gd name="adj" fmla="val 3810"/>
+            </a:avLst>
+          </a:prstGeom>
+          <a:solidFill>
+            <a:schemeClr val="tx2"/>
+          </a:solidFill>
+          <a:ln/>
+        </p:spPr>
+      </p:sp>
+      <p:sp>
+        <p:nvSpPr>
+          <p:cNvPr id="12" name="Text 10"/>
+          <p:cNvSpPr txBox="1"/>
+          <p:nvPr/>
+        </p:nvSpPr>
+        <p:spPr>
+          <a:xfrm>
+            <a:off x="4846320" y="1325880"/>
+            <a:ext cx="1554480" cy="502920"/>
+          </a:xfrm>
+          <a:prstGeom prst="rect">
+            <a:avLst/>
+          </a:prstGeom>
+          <a:noFill/>
+          <a:ln/>
+        </p:spPr>
+        <p:txBody>
+          <a:bodyPr wrap="square" lIns="0" tIns="0" rIns="0" bIns="0" rtlCol="0" anchor="t"/>
+          <a:lstStyle/>
+          <a:p>
+            <a:pPr indent="0" marL="0">
+              <a:buNone/>
+            </a:pPr>
+            <a:r>
+              <a:rPr lang="en-US" sz="2200" b="1" dirty="0">
+                <a:solidFill>
+                  <a:schemeClr val="accent6"/>
+                </a:solidFill>
+              </a:rPr>
+              <a:t>DKIM</a:t>
+            </a:r>
+            <a:endParaRPr lang="en-US" sz="2200" dirty="0"/>
+          </a:p>
+        </p:txBody>
+      </p:sp>
+      <p:sp>
+        <p:nvSpPr>
+          <p:cNvPr id="13" name="Text 11"/>
+          <p:cNvSpPr txBox="1"/>
+          <p:nvPr/>
+        </p:nvSpPr>
+        <p:spPr>
+          <a:xfrm>
+            <a:off x="4846320" y="1874520"/>
+            <a:ext cx="1645920" cy="365760"/>
+          </a:xfrm>
+          <a:prstGeom prst="rect">
+            <a:avLst/>
+          </a:prstGeom>
+          <a:noFill/>
+          <a:ln/>
+        </p:spPr>
+        <p:txBody>
+          <a:bodyPr wrap="square" lIns="0" tIns="0" rIns="0" bIns="0" rtlCol="0" anchor="t"/>
+          <a:lstStyle/>
+          <a:p>
+            <a:pPr indent="0" marL="0">
+              <a:buNone/>
+            </a:pPr>
+            <a:r>
+              <a:rPr lang="en-US" sz="1300" b="1" dirty="0">
+                <a:solidFill>
+                  <a:schemeClr val="bg1"/>
+                </a:solidFill>
+              </a:rPr>
+              <a:t>봉투의 도장</a:t>
+            </a:r>
+            <a:endParaRPr lang="en-US" sz="1300" dirty="0"/>
+          </a:p>
+        </p:txBody>
+      </p:sp>
+      <p:sp>
+        <p:nvSpPr>
+          <p:cNvPr id="14" name="Text 12"/>
+          <p:cNvSpPr txBox="1"/>
+          <p:nvPr/>
+        </p:nvSpPr>
+        <p:spPr>
+          <a:xfrm>
+            <a:off x="4846320" y="2286000"/>
+            <a:ext cx="1645920" cy="685800"/>
+          </a:xfrm>
+          <a:prstGeom prst="rect">
+            <a:avLst/>
+          </a:prstGeom>
+          <a:noFill/>
+          <a:ln/>
+        </p:spPr>
+        <p:txBody>
+          <a:bodyPr wrap="square" lIns="0" tIns="0" rIns="0" bIns="0" rtlCol="0" anchor="t"/>
+          <a:lstStyle/>
+          <a:p>
+            <a:pPr indent="0" marL="0">
+              <a:buNone/>
+            </a:pPr>
+            <a:r>
+              <a:rPr lang="en-US" sz="1200" dirty="0">
+                <a:solidFill>
+                  <a:schemeClr val="bg2"/>
+                </a:solidFill>
+              </a:rPr>
+              <a:t>중간에 안 바뀌었다는 서명</a:t>
+            </a:r>
+            <a:endParaRPr lang="en-US" sz="1200" dirty="0"/>
+          </a:p>
+        </p:txBody>
+      </p:sp>
+      <p:sp>
+        <p:nvSpPr>
+          <p:cNvPr id="15" name="card"/>
+          <p:cNvSpPr/>
+          <p:nvPr/>
+        </p:nvSpPr>
+        <p:spPr>
+          <a:xfrm>
+            <a:off x="6766560" y="1188720"/>
+            <a:ext cx="1920240" cy="1920240"/>
+          </a:xfrm>
+          <a:prstGeom prst="roundRect">
+            <a:avLst>
+              <a:gd name="adj" fmla="val 3810"/>
+            </a:avLst>
+          </a:prstGeom>
+          <a:solidFill>
+            <a:schemeClr val="tx2"/>
+          </a:solidFill>
+          <a:ln/>
+        </p:spPr>
+      </p:sp>
+      <p:sp>
+        <p:nvSpPr>
+          <p:cNvPr id="16" name="Text 14"/>
+          <p:cNvSpPr txBox="1"/>
+          <p:nvPr/>
+        </p:nvSpPr>
+        <p:spPr>
+          <a:xfrm>
+            <a:off x="6949440" y="1325880"/>
+            <a:ext cx="1554480" cy="502920"/>
+          </a:xfrm>
+          <a:prstGeom prst="rect">
+            <a:avLst/>
+          </a:prstGeom>
+          <a:noFill/>
+          <a:ln/>
+        </p:spPr>
+        <p:txBody>
+          <a:bodyPr wrap="square" lIns="0" tIns="0" rIns="0" bIns="0" rtlCol="0" anchor="t"/>
+          <a:lstStyle/>
+          <a:p>
+            <a:pPr indent="0" marL="0">
+              <a:buNone/>
+            </a:pPr>
+            <a:r>
+              <a:rPr lang="en-US" sz="2200" b="1" dirty="0">
+                <a:solidFill>
+                  <a:schemeClr val="accent6"/>
+                </a:solidFill>
+              </a:rPr>
+              <a:t>DMARC</a:t>
+            </a:r>
+            <a:endParaRPr lang="en-US" sz="2200" dirty="0"/>
+          </a:p>
+        </p:txBody>
+      </p:sp>
+      <p:sp>
+        <p:nvSpPr>
+          <p:cNvPr id="17" name="Text 15"/>
+          <p:cNvSpPr txBox="1"/>
+          <p:nvPr/>
+        </p:nvSpPr>
+        <p:spPr>
+          <a:xfrm>
+            <a:off x="6949440" y="1874520"/>
+            <a:ext cx="1645920" cy="365760"/>
+          </a:xfrm>
+          <a:prstGeom prst="rect">
+            <a:avLst/>
+          </a:prstGeom>
+          <a:noFill/>
+          <a:ln/>
+        </p:spPr>
+        <p:txBody>
+          <a:bodyPr wrap="square" lIns="0" tIns="0" rIns="0" bIns="0" rtlCol="0" anchor="t"/>
+          <a:lstStyle/>
+          <a:p>
+            <a:pPr indent="0" marL="0">
+              <a:buNone/>
+            </a:pPr>
+            <a:r>
+              <a:rPr lang="en-US" sz="1300" b="1" dirty="0">
+                <a:solidFill>
+                  <a:schemeClr val="bg1"/>
+                </a:solidFill>
+              </a:rPr>
+              <a:t>처리 지침</a:t>
+            </a:r>
+            <a:endParaRPr lang="en-US" sz="1300" dirty="0"/>
+          </a:p>
+        </p:txBody>
+      </p:sp>
+      <p:sp>
+        <p:nvSpPr>
+          <p:cNvPr id="18" name="Text 16"/>
+          <p:cNvSpPr txBox="1"/>
+          <p:nvPr/>
+        </p:nvSpPr>
+        <p:spPr>
+          <a:xfrm>
+            <a:off x="6949440" y="2286000"/>
+            <a:ext cx="1645920" cy="685800"/>
+          </a:xfrm>
+          <a:prstGeom prst="rect">
+            <a:avLst/>
+          </a:prstGeom>
+          <a:noFill/>
+          <a:ln/>
+        </p:spPr>
+        <p:txBody>
+          <a:bodyPr wrap="square" lIns="0" tIns="0" rIns="0" bIns="0" rtlCol="0" anchor="t"/>
+          <a:lstStyle/>
+          <a:p>
+            <a:pPr indent="0" marL="0">
+              <a:buNone/>
+            </a:pPr>
+            <a:r>
+              <a:rPr lang="en-US" sz="1200" dirty="0">
+                <a:solidFill>
+                  <a:schemeClr val="bg2"/>
+                </a:solidFill>
+              </a:rPr>
+              <a:t>검사 실패 메일을 어떻게 할지</a:t>
+            </a:r>
+            <a:endParaRPr lang="en-US" sz="1200" dirty="0"/>
+          </a:p>
+        </p:txBody>
+      </p:sp>
+      <p:sp>
+        <p:nvSpPr>
+          <p:cNvPr id="19" name="Text 17"/>
+          <p:cNvSpPr txBox="1"/>
+          <p:nvPr/>
+        </p:nvSpPr>
+        <p:spPr>
+          <a:xfrm>
+            <a:off x="457200" y="3337560"/>
+            <a:ext cx="8229600" cy="1097280"/>
+          </a:xfrm>
+          <a:prstGeom prst="rect">
+            <a:avLst/>
+          </a:prstGeom>
+          <a:noFill/>
+          <a:ln/>
+        </p:spPr>
+        <p:txBody>
+          <a:bodyPr wrap="square" lIns="0" tIns="0" rIns="0" bIns="0" rtlCol="0" anchor="t"/>
+          <a:lstStyle/>
+          <a:p>
+            <a:pPr indent="0" marL="0">
+              <a:spcAft>
+                <a:spcPts val="800"/>
+              </a:spcAft>
+              <a:buNone/>
+            </a:pPr>
+            <a:r>
+              <a:rPr lang="en-US" sz="1300" b="1" dirty="0">
+                <a:solidFill>
+                  <a:schemeClr val="accent2"/>
+                </a:solidFill>
+              </a:rPr>
+              <a:t>설정 팁  </a:t>
+            </a:r>
+            <a:pPr indent="0" marL="0">
+              <a:spcAft>
+                <a:spcPts val="800"/>
+              </a:spcAft>
+              <a:buNone/>
+            </a:pPr>
+            <a:r>
+              <a:rPr lang="en-US" sz="1300" dirty="0">
+                <a:solidFill>
+                  <a:schemeClr val="tx1"/>
+                </a:solidFill>
+              </a:rPr>
+              <a:t>값은 내 메일 서비스가 알려 주는 그대로 · SPF는 도메인당 하나(합치기) · DMARC는 p=none으로 시작해 단계적으로</a:t>
+            </a:r>
+            <a:endParaRPr lang="en-US" sz="1300" dirty="0"/>
+          </a:p>
+          <a:p>
+            <a:pPr indent="0" marL="0">
+              <a:spcAft>
+                <a:spcPts val="800"/>
+              </a:spcAft>
+              <a:buNone/>
+            </a:pPr>
+            <a:r>
+              <a:rPr lang="en-US" sz="1300" b="1" dirty="0">
+                <a:solidFill>
+                  <a:schemeClr val="accent2"/>
+                </a:solidFill>
+              </a:rPr>
+              <a:t>대량 발송 규칙  </a:t>
+            </a:r>
+            <a:pPr indent="0" marL="0">
+              <a:spcAft>
+                <a:spcPts val="800"/>
+              </a:spcAft>
+              <a:buNone/>
+            </a:pPr>
+            <a:r>
+              <a:rPr lang="en-US" sz="1300" dirty="0">
+                <a:solidFill>
+                  <a:schemeClr val="tx1"/>
+                </a:solidFill>
+              </a:rPr>
+              <a:t>하루 약 5,000통 이상이면 세 가지 모두 + 원클릭 수신거부 + 스팸 신고율 0.3% 미만 (Gmail·Yahoo)</a:t>
+            </a:r>
+            <a:endParaRPr lang="en-US" sz="1300" dirty="0"/>
+          </a:p>
+        </p:txBody>
+      </p:sp>
+      <p:sp>
+        <p:nvSpPr>
+          <p:cNvPr id="25" name="Slide Number Placeholder 0"/>
+          <p:cNvSpPr>
+            <a:spLocks noGrp="1"/>
+          </p:cNvSpPr>
+          <p:nvPr>
+            <p:ph type="sldNum" sz="quarter" idx="4294967295"/>
+          </p:nvPr>
+        </p:nvSpPr>
+        <p:spPr>
+          <a:xfrm>
+            <a:off x="8321040" y="4754880"/>
+            <a:ext cx="457200" cy="274320"/>
+          </a:xfrm>
+          <a:prstGeom prst="rect">
+            <a:avLst/>
+          </a:prstGeom>
+          <a:extLst>
+            <a:ext uri="{C572A759-6A51-4108-AA02-DFA0A04FC94B}">
+              <ma14:wrappingTextBoxFlag xmlns:ma14="http://schemas.microsoft.com/office/mac/drawingml/2011/main" val="0"/>
+            </a:ext>
+          </a:extLst>
+        </p:spPr>
+        <p:txBody>
+          <a:bodyPr/>
+          <a:lstStyle>
+            <a:lvl1pPr>
+              <a:defRPr sz="1000">
+                <a:solidFill>
+                  <a:schemeClr val="accent4"/>
+                </a:solidFill>
+              </a:defRPr>
+            </a:lvl1pPr>
+          </a:lstStyle>
+          <a:p>
+            <a:pPr algn="r"/>
+            <a:fld id="{F7021451-1387-4CA6-816F-3879F97B5CBC}" type="slidenum">
+              <a:rPr b="0" lang="en-US"/>
+              <a:t>39</a:t>
+            </a:fld>
+            <a:endParaRPr lang="en-US"/>
           </a:p>
         </p:txBody>
       </p:sp>
@@ -28749,6 +30590,2011 @@
               <a:t>4</a:t>
             </a:fld>
             <a:endParaRPr lang="en-US"/>
+          </a:p>
+        </p:txBody>
+      </p:sp>
+    </p:spTree>
+  </p:cSld>
+  <p:clrMapOvr>
+    <a:masterClrMapping/>
+  </p:clrMapOvr>
+</p:sld>
+</file>
+
+<file path=ppt/slides/slide40.xml><?xml version="1.0" encoding="utf-8"?>
+<p:sld xmlns:a="http://schemas.openxmlformats.org/drawingml/2006/main" xmlns:r="http://schemas.openxmlformats.org/officeDocument/2006/relationships" xmlns:p="http://schemas.openxmlformats.org/presentationml/2006/main">
+  <p:cSld name="Slide 40">
+    <p:spTree>
+      <p:nvGrpSpPr>
+        <p:cNvPr id="1" name=""/>
+        <p:cNvGrpSpPr/>
+        <p:nvPr/>
+      </p:nvGrpSpPr>
+      <p:grpSpPr>
+        <a:xfrm>
+          <a:off x="0" y="0"/>
+          <a:ext cx="0" cy="0"/>
+          <a:chOff x="0" y="0"/>
+          <a:chExt cx="0" cy="0"/>
+        </a:xfrm>
+      </p:grpSpPr>
+      <p:sp>
+        <p:nvSpPr>
+          <p:cNvPr id="2" name="Text 0"/>
+          <p:cNvSpPr/>
+          <p:nvPr>
+            <p:ph idx="100" type="title" hasCustomPrompt="1"/>
+          </p:nvPr>
+        </p:nvSpPr>
+        <p:spPr>
+          <a:xfrm>
+            <a:off x="457200" y="274320"/>
+            <a:ext cx="8229600" cy="685800"/>
+          </a:xfrm>
+          <a:prstGeom prst="rect">
+            <a:avLst/>
+          </a:prstGeom>
+          <a:noFill/>
+          <a:ln/>
+        </p:spPr>
+        <p:txBody>
+          <a:bodyPr wrap="square" lIns="0" tIns="0" rIns="0" bIns="0" rtlCol="0" anchor="ctr"/>
+          <a:lstStyle/>
+          <a:p>
+            <a:pPr indent="0" marL="0">
+              <a:buNone/>
+            </a:pPr>
+            <a:r>
+              <a:rPr lang="en-US" sz="2800" b="1" dirty="0">
+                <a:solidFill>
+                  <a:schemeClr val="tx2"/>
+                </a:solidFill>
+              </a:rPr>
+              <a:t>광고 메일·문자를 보낼 때 5가지 규칙</a:t>
+            </a:r>
+            <a:endParaRPr lang="en-US" sz="2800" dirty="0"/>
+          </a:p>
+        </p:txBody>
+      </p:sp>
+      <p:sp>
+        <p:nvSpPr>
+          <p:cNvPr id="3" name="card"/>
+          <p:cNvSpPr/>
+          <p:nvPr/>
+        </p:nvSpPr>
+        <p:spPr>
+          <a:xfrm>
+            <a:off x="457200" y="1143000"/>
+            <a:ext cx="8229600" cy="566928"/>
+          </a:xfrm>
+          <a:prstGeom prst="roundRect">
+            <a:avLst>
+              <a:gd name="adj" fmla="val 12903"/>
+            </a:avLst>
+          </a:prstGeom>
+          <a:solidFill>
+            <a:schemeClr val="bg2"/>
+          </a:solidFill>
+          <a:ln/>
+        </p:spPr>
+      </p:sp>
+      <p:sp>
+        <p:nvSpPr>
+          <p:cNvPr id="4" name="badge1"/>
+          <p:cNvSpPr/>
+          <p:nvPr/>
+        </p:nvSpPr>
+        <p:spPr>
+          <a:xfrm>
+            <a:off x="594360" y="1234440"/>
+            <a:ext cx="384048" cy="384048"/>
+          </a:xfrm>
+          <a:prstGeom prst="ellipse">
+            <a:avLst/>
+          </a:prstGeom>
+          <a:solidFill>
+            <a:schemeClr val="accent2"/>
+          </a:solidFill>
+          <a:ln/>
+        </p:spPr>
+      </p:sp>
+      <p:sp>
+        <p:nvSpPr>
+          <p:cNvPr id="5" name="Text 3"/>
+          <p:cNvSpPr txBox="1"/>
+          <p:nvPr/>
+        </p:nvSpPr>
+        <p:spPr>
+          <a:xfrm>
+            <a:off x="594360" y="1234440"/>
+            <a:ext cx="384048" cy="384048"/>
+          </a:xfrm>
+          <a:prstGeom prst="rect">
+            <a:avLst/>
+          </a:prstGeom>
+          <a:noFill/>
+          <a:ln/>
+        </p:spPr>
+        <p:txBody>
+          <a:bodyPr wrap="square" lIns="0" tIns="0" rIns="0" bIns="0" rtlCol="0" anchor="ctr"/>
+          <a:lstStyle/>
+          <a:p>
+            <a:pPr algn="ctr" indent="0" marL="0">
+              <a:buNone/>
+            </a:pPr>
+            <a:r>
+              <a:rPr lang="en-US" sz="1400" b="1" dirty="0">
+                <a:solidFill>
+                  <a:schemeClr val="bg1"/>
+                </a:solidFill>
+              </a:rPr>
+              <a:t>1</a:t>
+            </a:r>
+            <a:endParaRPr lang="en-US" sz="1400" dirty="0"/>
+          </a:p>
+        </p:txBody>
+      </p:sp>
+      <p:sp>
+        <p:nvSpPr>
+          <p:cNvPr id="6" name="Text 4"/>
+          <p:cNvSpPr txBox="1"/>
+          <p:nvPr/>
+        </p:nvSpPr>
+        <p:spPr>
+          <a:xfrm>
+            <a:off x="1143000" y="1143000"/>
+            <a:ext cx="2377440" cy="566928"/>
+          </a:xfrm>
+          <a:prstGeom prst="rect">
+            <a:avLst/>
+          </a:prstGeom>
+          <a:noFill/>
+          <a:ln/>
+        </p:spPr>
+        <p:txBody>
+          <a:bodyPr wrap="square" lIns="0" tIns="0" rIns="0" bIns="0" rtlCol="0" anchor="ctr"/>
+          <a:lstStyle/>
+          <a:p>
+            <a:pPr indent="0" marL="0">
+              <a:buNone/>
+            </a:pPr>
+            <a:r>
+              <a:rPr lang="en-US" sz="1500" b="1" dirty="0">
+                <a:solidFill>
+                  <a:schemeClr val="tx1"/>
+                </a:solidFill>
+              </a:rPr>
+              <a:t>사전 동의</a:t>
+            </a:r>
+            <a:endParaRPr lang="en-US" sz="1500" dirty="0"/>
+          </a:p>
+        </p:txBody>
+      </p:sp>
+      <p:sp>
+        <p:nvSpPr>
+          <p:cNvPr id="7" name="Text 5"/>
+          <p:cNvSpPr txBox="1"/>
+          <p:nvPr/>
+        </p:nvSpPr>
+        <p:spPr>
+          <a:xfrm>
+            <a:off x="3566160" y="1143000"/>
+            <a:ext cx="4937760" cy="566928"/>
+          </a:xfrm>
+          <a:prstGeom prst="rect">
+            <a:avLst/>
+          </a:prstGeom>
+          <a:noFill/>
+          <a:ln/>
+        </p:spPr>
+        <p:txBody>
+          <a:bodyPr wrap="square" lIns="0" tIns="0" rIns="0" bIns="0" rtlCol="0" anchor="ctr"/>
+          <a:lstStyle/>
+          <a:p>
+            <a:pPr indent="0" marL="0">
+              <a:buNone/>
+            </a:pPr>
+            <a:r>
+              <a:rPr lang="en-US" sz="1300" dirty="0">
+                <a:solidFill>
+                  <a:schemeClr val="accent4"/>
+                </a:solidFill>
+              </a:rPr>
+              <a:t>약관에 섞지 말고 선택 항목으로 따로</a:t>
+            </a:r>
+            <a:endParaRPr lang="en-US" sz="1300" dirty="0"/>
+          </a:p>
+        </p:txBody>
+      </p:sp>
+      <p:sp>
+        <p:nvSpPr>
+          <p:cNvPr id="8" name="card"/>
+          <p:cNvSpPr/>
+          <p:nvPr/>
+        </p:nvSpPr>
+        <p:spPr>
+          <a:xfrm>
+            <a:off x="457200" y="1801368"/>
+            <a:ext cx="8229600" cy="566928"/>
+          </a:xfrm>
+          <a:prstGeom prst="roundRect">
+            <a:avLst>
+              <a:gd name="adj" fmla="val 12903"/>
+            </a:avLst>
+          </a:prstGeom>
+          <a:solidFill>
+            <a:schemeClr val="bg2"/>
+          </a:solidFill>
+          <a:ln/>
+        </p:spPr>
+      </p:sp>
+      <p:sp>
+        <p:nvSpPr>
+          <p:cNvPr id="9" name="badge2"/>
+          <p:cNvSpPr/>
+          <p:nvPr/>
+        </p:nvSpPr>
+        <p:spPr>
+          <a:xfrm>
+            <a:off x="594360" y="1892808"/>
+            <a:ext cx="384048" cy="384048"/>
+          </a:xfrm>
+          <a:prstGeom prst="ellipse">
+            <a:avLst/>
+          </a:prstGeom>
+          <a:solidFill>
+            <a:schemeClr val="accent2"/>
+          </a:solidFill>
+          <a:ln/>
+        </p:spPr>
+      </p:sp>
+      <p:sp>
+        <p:nvSpPr>
+          <p:cNvPr id="10" name="Text 8"/>
+          <p:cNvSpPr txBox="1"/>
+          <p:nvPr/>
+        </p:nvSpPr>
+        <p:spPr>
+          <a:xfrm>
+            <a:off x="594360" y="1892808"/>
+            <a:ext cx="384048" cy="384048"/>
+          </a:xfrm>
+          <a:prstGeom prst="rect">
+            <a:avLst/>
+          </a:prstGeom>
+          <a:noFill/>
+          <a:ln/>
+        </p:spPr>
+        <p:txBody>
+          <a:bodyPr wrap="square" lIns="0" tIns="0" rIns="0" bIns="0" rtlCol="0" anchor="ctr"/>
+          <a:lstStyle/>
+          <a:p>
+            <a:pPr algn="ctr" indent="0" marL="0">
+              <a:buNone/>
+            </a:pPr>
+            <a:r>
+              <a:rPr lang="en-US" sz="1400" b="1" dirty="0">
+                <a:solidFill>
+                  <a:schemeClr val="bg1"/>
+                </a:solidFill>
+              </a:rPr>
+              <a:t>2</a:t>
+            </a:r>
+            <a:endParaRPr lang="en-US" sz="1400" dirty="0"/>
+          </a:p>
+        </p:txBody>
+      </p:sp>
+      <p:sp>
+        <p:nvSpPr>
+          <p:cNvPr id="11" name="Text 9"/>
+          <p:cNvSpPr txBox="1"/>
+          <p:nvPr/>
+        </p:nvSpPr>
+        <p:spPr>
+          <a:xfrm>
+            <a:off x="1143000" y="1801368"/>
+            <a:ext cx="2377440" cy="566928"/>
+          </a:xfrm>
+          <a:prstGeom prst="rect">
+            <a:avLst/>
+          </a:prstGeom>
+          <a:noFill/>
+          <a:ln/>
+        </p:spPr>
+        <p:txBody>
+          <a:bodyPr wrap="square" lIns="0" tIns="0" rIns="0" bIns="0" rtlCol="0" anchor="ctr"/>
+          <a:lstStyle/>
+          <a:p>
+            <a:pPr indent="0" marL="0">
+              <a:buNone/>
+            </a:pPr>
+            <a:r>
+              <a:rPr lang="en-US" sz="1500" b="1" dirty="0">
+                <a:solidFill>
+                  <a:schemeClr val="tx1"/>
+                </a:solidFill>
+              </a:rPr>
+              <a:t>(광고) 표시</a:t>
+            </a:r>
+            <a:endParaRPr lang="en-US" sz="1500" dirty="0"/>
+          </a:p>
+        </p:txBody>
+      </p:sp>
+      <p:sp>
+        <p:nvSpPr>
+          <p:cNvPr id="12" name="Text 10"/>
+          <p:cNvSpPr txBox="1"/>
+          <p:nvPr/>
+        </p:nvSpPr>
+        <p:spPr>
+          <a:xfrm>
+            <a:off x="3566160" y="1801368"/>
+            <a:ext cx="4937760" cy="566928"/>
+          </a:xfrm>
+          <a:prstGeom prst="rect">
+            <a:avLst/>
+          </a:prstGeom>
+          <a:noFill/>
+          <a:ln/>
+        </p:spPr>
+        <p:txBody>
+          <a:bodyPr wrap="square" lIns="0" tIns="0" rIns="0" bIns="0" rtlCol="0" anchor="ctr"/>
+          <a:lstStyle/>
+          <a:p>
+            <a:pPr indent="0" marL="0">
+              <a:buNone/>
+            </a:pPr>
+            <a:r>
+              <a:rPr lang="en-US" sz="1300" dirty="0">
+                <a:solidFill>
+                  <a:schemeClr val="accent4"/>
+                </a:solidFill>
+              </a:rPr>
+              <a:t>제목·문자 맨 앞에</a:t>
+            </a:r>
+            <a:endParaRPr lang="en-US" sz="1300" dirty="0"/>
+          </a:p>
+        </p:txBody>
+      </p:sp>
+      <p:sp>
+        <p:nvSpPr>
+          <p:cNvPr id="13" name="card"/>
+          <p:cNvSpPr/>
+          <p:nvPr/>
+        </p:nvSpPr>
+        <p:spPr>
+          <a:xfrm>
+            <a:off x="457200" y="2459736"/>
+            <a:ext cx="8229600" cy="566928"/>
+          </a:xfrm>
+          <a:prstGeom prst="roundRect">
+            <a:avLst>
+              <a:gd name="adj" fmla="val 12903"/>
+            </a:avLst>
+          </a:prstGeom>
+          <a:solidFill>
+            <a:schemeClr val="bg2"/>
+          </a:solidFill>
+          <a:ln/>
+        </p:spPr>
+      </p:sp>
+      <p:sp>
+        <p:nvSpPr>
+          <p:cNvPr id="14" name="badge3"/>
+          <p:cNvSpPr/>
+          <p:nvPr/>
+        </p:nvSpPr>
+        <p:spPr>
+          <a:xfrm>
+            <a:off x="594360" y="2551176"/>
+            <a:ext cx="384048" cy="384048"/>
+          </a:xfrm>
+          <a:prstGeom prst="ellipse">
+            <a:avLst/>
+          </a:prstGeom>
+          <a:solidFill>
+            <a:schemeClr val="accent2"/>
+          </a:solidFill>
+          <a:ln/>
+        </p:spPr>
+      </p:sp>
+      <p:sp>
+        <p:nvSpPr>
+          <p:cNvPr id="15" name="Text 13"/>
+          <p:cNvSpPr txBox="1"/>
+          <p:nvPr/>
+        </p:nvSpPr>
+        <p:spPr>
+          <a:xfrm>
+            <a:off x="594360" y="2551176"/>
+            <a:ext cx="384048" cy="384048"/>
+          </a:xfrm>
+          <a:prstGeom prst="rect">
+            <a:avLst/>
+          </a:prstGeom>
+          <a:noFill/>
+          <a:ln/>
+        </p:spPr>
+        <p:txBody>
+          <a:bodyPr wrap="square" lIns="0" tIns="0" rIns="0" bIns="0" rtlCol="0" anchor="ctr"/>
+          <a:lstStyle/>
+          <a:p>
+            <a:pPr algn="ctr" indent="0" marL="0">
+              <a:buNone/>
+            </a:pPr>
+            <a:r>
+              <a:rPr lang="en-US" sz="1400" b="1" dirty="0">
+                <a:solidFill>
+                  <a:schemeClr val="bg1"/>
+                </a:solidFill>
+              </a:rPr>
+              <a:t>3</a:t>
+            </a:r>
+            <a:endParaRPr lang="en-US" sz="1400" dirty="0"/>
+          </a:p>
+        </p:txBody>
+      </p:sp>
+      <p:sp>
+        <p:nvSpPr>
+          <p:cNvPr id="16" name="Text 14"/>
+          <p:cNvSpPr txBox="1"/>
+          <p:nvPr/>
+        </p:nvSpPr>
+        <p:spPr>
+          <a:xfrm>
+            <a:off x="1143000" y="2459736"/>
+            <a:ext cx="2377440" cy="566928"/>
+          </a:xfrm>
+          <a:prstGeom prst="rect">
+            <a:avLst/>
+          </a:prstGeom>
+          <a:noFill/>
+          <a:ln/>
+        </p:spPr>
+        <p:txBody>
+          <a:bodyPr wrap="square" lIns="0" tIns="0" rIns="0" bIns="0" rtlCol="0" anchor="ctr"/>
+          <a:lstStyle/>
+          <a:p>
+            <a:pPr indent="0" marL="0">
+              <a:buNone/>
+            </a:pPr>
+            <a:r>
+              <a:rPr lang="en-US" sz="1500" b="1" dirty="0">
+                <a:solidFill>
+                  <a:schemeClr val="tx1"/>
+                </a:solidFill>
+              </a:rPr>
+              <a:t>쉬운 수신거부</a:t>
+            </a:r>
+            <a:endParaRPr lang="en-US" sz="1500" dirty="0"/>
+          </a:p>
+        </p:txBody>
+      </p:sp>
+      <p:sp>
+        <p:nvSpPr>
+          <p:cNvPr id="17" name="Text 15"/>
+          <p:cNvSpPr txBox="1"/>
+          <p:nvPr/>
+        </p:nvSpPr>
+        <p:spPr>
+          <a:xfrm>
+            <a:off x="3566160" y="2459736"/>
+            <a:ext cx="4937760" cy="566928"/>
+          </a:xfrm>
+          <a:prstGeom prst="rect">
+            <a:avLst/>
+          </a:prstGeom>
+          <a:noFill/>
+          <a:ln/>
+        </p:spPr>
+        <p:txBody>
+          <a:bodyPr wrap="square" lIns="0" tIns="0" rIns="0" bIns="0" rtlCol="0" anchor="ctr"/>
+          <a:lstStyle/>
+          <a:p>
+            <a:pPr indent="0" marL="0">
+              <a:buNone/>
+            </a:pPr>
+            <a:r>
+              <a:rPr lang="en-US" sz="1300" dirty="0">
+                <a:solidFill>
+                  <a:schemeClr val="accent4"/>
+                </a:solidFill>
+              </a:rPr>
+              <a:t>로그인 요구 등 방해 금지</a:t>
+            </a:r>
+            <a:endParaRPr lang="en-US" sz="1300" dirty="0"/>
+          </a:p>
+        </p:txBody>
+      </p:sp>
+      <p:sp>
+        <p:nvSpPr>
+          <p:cNvPr id="18" name="card"/>
+          <p:cNvSpPr/>
+          <p:nvPr/>
+        </p:nvSpPr>
+        <p:spPr>
+          <a:xfrm>
+            <a:off x="457200" y="3118104"/>
+            <a:ext cx="8229600" cy="566928"/>
+          </a:xfrm>
+          <a:prstGeom prst="roundRect">
+            <a:avLst>
+              <a:gd name="adj" fmla="val 12903"/>
+            </a:avLst>
+          </a:prstGeom>
+          <a:solidFill>
+            <a:schemeClr val="bg2"/>
+          </a:solidFill>
+          <a:ln/>
+        </p:spPr>
+      </p:sp>
+      <p:sp>
+        <p:nvSpPr>
+          <p:cNvPr id="19" name="badge4"/>
+          <p:cNvSpPr/>
+          <p:nvPr/>
+        </p:nvSpPr>
+        <p:spPr>
+          <a:xfrm>
+            <a:off x="594360" y="3209544"/>
+            <a:ext cx="384048" cy="384048"/>
+          </a:xfrm>
+          <a:prstGeom prst="ellipse">
+            <a:avLst/>
+          </a:prstGeom>
+          <a:solidFill>
+            <a:schemeClr val="accent2"/>
+          </a:solidFill>
+          <a:ln/>
+        </p:spPr>
+      </p:sp>
+      <p:sp>
+        <p:nvSpPr>
+          <p:cNvPr id="20" name="Text 18"/>
+          <p:cNvSpPr txBox="1"/>
+          <p:nvPr/>
+        </p:nvSpPr>
+        <p:spPr>
+          <a:xfrm>
+            <a:off x="594360" y="3209544"/>
+            <a:ext cx="384048" cy="384048"/>
+          </a:xfrm>
+          <a:prstGeom prst="rect">
+            <a:avLst/>
+          </a:prstGeom>
+          <a:noFill/>
+          <a:ln/>
+        </p:spPr>
+        <p:txBody>
+          <a:bodyPr wrap="square" lIns="0" tIns="0" rIns="0" bIns="0" rtlCol="0" anchor="ctr"/>
+          <a:lstStyle/>
+          <a:p>
+            <a:pPr algn="ctr" indent="0" marL="0">
+              <a:buNone/>
+            </a:pPr>
+            <a:r>
+              <a:rPr lang="en-US" sz="1400" b="1" dirty="0">
+                <a:solidFill>
+                  <a:schemeClr val="bg1"/>
+                </a:solidFill>
+              </a:rPr>
+              <a:t>4</a:t>
+            </a:r>
+            <a:endParaRPr lang="en-US" sz="1400" dirty="0"/>
+          </a:p>
+        </p:txBody>
+      </p:sp>
+      <p:sp>
+        <p:nvSpPr>
+          <p:cNvPr id="21" name="Text 19"/>
+          <p:cNvSpPr txBox="1"/>
+          <p:nvPr/>
+        </p:nvSpPr>
+        <p:spPr>
+          <a:xfrm>
+            <a:off x="1143000" y="3118104"/>
+            <a:ext cx="2377440" cy="566928"/>
+          </a:xfrm>
+          <a:prstGeom prst="rect">
+            <a:avLst/>
+          </a:prstGeom>
+          <a:noFill/>
+          <a:ln/>
+        </p:spPr>
+        <p:txBody>
+          <a:bodyPr wrap="square" lIns="0" tIns="0" rIns="0" bIns="0" rtlCol="0" anchor="ctr"/>
+          <a:lstStyle/>
+          <a:p>
+            <a:pPr indent="0" marL="0">
+              <a:buNone/>
+            </a:pPr>
+            <a:r>
+              <a:rPr lang="en-US" sz="1500" b="1" dirty="0">
+                <a:solidFill>
+                  <a:schemeClr val="tx1"/>
+                </a:solidFill>
+              </a:rPr>
+              <a:t>야간 별도 동의</a:t>
+            </a:r>
+            <a:endParaRPr lang="en-US" sz="1500" dirty="0"/>
+          </a:p>
+        </p:txBody>
+      </p:sp>
+      <p:sp>
+        <p:nvSpPr>
+          <p:cNvPr id="22" name="Text 20"/>
+          <p:cNvSpPr txBox="1"/>
+          <p:nvPr/>
+        </p:nvSpPr>
+        <p:spPr>
+          <a:xfrm>
+            <a:off x="3566160" y="3118104"/>
+            <a:ext cx="4937760" cy="566928"/>
+          </a:xfrm>
+          <a:prstGeom prst="rect">
+            <a:avLst/>
+          </a:prstGeom>
+          <a:noFill/>
+          <a:ln/>
+        </p:spPr>
+        <p:txBody>
+          <a:bodyPr wrap="square" lIns="0" tIns="0" rIns="0" bIns="0" rtlCol="0" anchor="ctr"/>
+          <a:lstStyle/>
+          <a:p>
+            <a:pPr indent="0" marL="0">
+              <a:buNone/>
+            </a:pPr>
+            <a:r>
+              <a:rPr lang="en-US" sz="1300" dirty="0">
+                <a:solidFill>
+                  <a:schemeClr val="accent4"/>
+                </a:solidFill>
+              </a:rPr>
+              <a:t>흔히 21시~다음 날 8시</a:t>
+            </a:r>
+            <a:endParaRPr lang="en-US" sz="1300" dirty="0"/>
+          </a:p>
+        </p:txBody>
+      </p:sp>
+      <p:sp>
+        <p:nvSpPr>
+          <p:cNvPr id="23" name="card"/>
+          <p:cNvSpPr/>
+          <p:nvPr/>
+        </p:nvSpPr>
+        <p:spPr>
+          <a:xfrm>
+            <a:off x="457200" y="3776472"/>
+            <a:ext cx="8229600" cy="566928"/>
+          </a:xfrm>
+          <a:prstGeom prst="roundRect">
+            <a:avLst>
+              <a:gd name="adj" fmla="val 12903"/>
+            </a:avLst>
+          </a:prstGeom>
+          <a:solidFill>
+            <a:schemeClr val="bg2"/>
+          </a:solidFill>
+          <a:ln/>
+        </p:spPr>
+      </p:sp>
+      <p:sp>
+        <p:nvSpPr>
+          <p:cNvPr id="24" name="badge5"/>
+          <p:cNvSpPr/>
+          <p:nvPr/>
+        </p:nvSpPr>
+        <p:spPr>
+          <a:xfrm>
+            <a:off x="594360" y="3867912"/>
+            <a:ext cx="384048" cy="384048"/>
+          </a:xfrm>
+          <a:prstGeom prst="ellipse">
+            <a:avLst/>
+          </a:prstGeom>
+          <a:solidFill>
+            <a:schemeClr val="accent2"/>
+          </a:solidFill>
+          <a:ln/>
+        </p:spPr>
+      </p:sp>
+      <p:sp>
+        <p:nvSpPr>
+          <p:cNvPr id="25" name="Text 23"/>
+          <p:cNvSpPr txBox="1"/>
+          <p:nvPr/>
+        </p:nvSpPr>
+        <p:spPr>
+          <a:xfrm>
+            <a:off x="594360" y="3867912"/>
+            <a:ext cx="384048" cy="384048"/>
+          </a:xfrm>
+          <a:prstGeom prst="rect">
+            <a:avLst/>
+          </a:prstGeom>
+          <a:noFill/>
+          <a:ln/>
+        </p:spPr>
+        <p:txBody>
+          <a:bodyPr wrap="square" lIns="0" tIns="0" rIns="0" bIns="0" rtlCol="0" anchor="ctr"/>
+          <a:lstStyle/>
+          <a:p>
+            <a:pPr algn="ctr" indent="0" marL="0">
+              <a:buNone/>
+            </a:pPr>
+            <a:r>
+              <a:rPr lang="en-US" sz="1400" b="1" dirty="0">
+                <a:solidFill>
+                  <a:schemeClr val="bg1"/>
+                </a:solidFill>
+              </a:rPr>
+              <a:t>5</a:t>
+            </a:r>
+            <a:endParaRPr lang="en-US" sz="1400" dirty="0"/>
+          </a:p>
+        </p:txBody>
+      </p:sp>
+      <p:sp>
+        <p:nvSpPr>
+          <p:cNvPr id="26" name="Text 24"/>
+          <p:cNvSpPr txBox="1"/>
+          <p:nvPr/>
+        </p:nvSpPr>
+        <p:spPr>
+          <a:xfrm>
+            <a:off x="1143000" y="3776472"/>
+            <a:ext cx="2377440" cy="566928"/>
+          </a:xfrm>
+          <a:prstGeom prst="rect">
+            <a:avLst/>
+          </a:prstGeom>
+          <a:noFill/>
+          <a:ln/>
+        </p:spPr>
+        <p:txBody>
+          <a:bodyPr wrap="square" lIns="0" tIns="0" rIns="0" bIns="0" rtlCol="0" anchor="ctr"/>
+          <a:lstStyle/>
+          <a:p>
+            <a:pPr indent="0" marL="0">
+              <a:buNone/>
+            </a:pPr>
+            <a:r>
+              <a:rPr lang="en-US" sz="1500" b="1" dirty="0">
+                <a:solidFill>
+                  <a:schemeClr val="tx1"/>
+                </a:solidFill>
+              </a:rPr>
+              <a:t>2년마다 확인</a:t>
+            </a:r>
+            <a:endParaRPr lang="en-US" sz="1500" dirty="0"/>
+          </a:p>
+        </p:txBody>
+      </p:sp>
+      <p:sp>
+        <p:nvSpPr>
+          <p:cNvPr id="27" name="Text 25"/>
+          <p:cNvSpPr txBox="1"/>
+          <p:nvPr/>
+        </p:nvSpPr>
+        <p:spPr>
+          <a:xfrm>
+            <a:off x="3566160" y="3776472"/>
+            <a:ext cx="4937760" cy="566928"/>
+          </a:xfrm>
+          <a:prstGeom prst="rect">
+            <a:avLst/>
+          </a:prstGeom>
+          <a:noFill/>
+          <a:ln/>
+        </p:spPr>
+        <p:txBody>
+          <a:bodyPr wrap="square" lIns="0" tIns="0" rIns="0" bIns="0" rtlCol="0" anchor="ctr"/>
+          <a:lstStyle/>
+          <a:p>
+            <a:pPr indent="0" marL="0">
+              <a:buNone/>
+            </a:pPr>
+            <a:r>
+              <a:rPr lang="en-US" sz="1300" dirty="0">
+                <a:solidFill>
+                  <a:schemeClr val="accent4"/>
+                </a:solidFill>
+              </a:rPr>
+              <a:t>계속 받을지 다시 묻기</a:t>
+            </a:r>
+            <a:endParaRPr lang="en-US" sz="1300" dirty="0"/>
+          </a:p>
+        </p:txBody>
+      </p:sp>
+      <p:sp>
+        <p:nvSpPr>
+          <p:cNvPr id="28" name="Text 26"/>
+          <p:cNvSpPr txBox="1"/>
+          <p:nvPr/>
+        </p:nvSpPr>
+        <p:spPr>
+          <a:xfrm>
+            <a:off x="457200" y="4645152"/>
+            <a:ext cx="7680960" cy="274320"/>
+          </a:xfrm>
+          <a:prstGeom prst="rect">
+            <a:avLst/>
+          </a:prstGeom>
+          <a:noFill/>
+          <a:ln/>
+        </p:spPr>
+        <p:txBody>
+          <a:bodyPr wrap="square" lIns="0" tIns="0" rIns="0" bIns="0" rtlCol="0" anchor="t"/>
+          <a:lstStyle/>
+          <a:p>
+            <a:pPr indent="0" marL="0">
+              <a:buNone/>
+            </a:pPr>
+            <a:r>
+              <a:rPr lang="en-US" sz="1000" dirty="0">
+                <a:solidFill>
+                  <a:schemeClr val="accent4"/>
+                </a:solidFill>
+              </a:rPr>
+              <a:t>주문 안내 같은 거래 메일에 광고를 섞지 않기 — 정보통신망법 제50조 (30장)</a:t>
+            </a:r>
+            <a:endParaRPr lang="en-US" sz="1000" dirty="0"/>
+          </a:p>
+        </p:txBody>
+      </p:sp>
+      <p:sp>
+        <p:nvSpPr>
+          <p:cNvPr id="25" name="Slide Number Placeholder 0"/>
+          <p:cNvSpPr>
+            <a:spLocks noGrp="1"/>
+          </p:cNvSpPr>
+          <p:nvPr>
+            <p:ph type="sldNum" sz="quarter" idx="4294967295"/>
+          </p:nvPr>
+        </p:nvSpPr>
+        <p:spPr>
+          <a:xfrm>
+            <a:off x="8321040" y="4754880"/>
+            <a:ext cx="457200" cy="274320"/>
+          </a:xfrm>
+          <a:prstGeom prst="rect">
+            <a:avLst/>
+          </a:prstGeom>
+          <a:extLst>
+            <a:ext uri="{C572A759-6A51-4108-AA02-DFA0A04FC94B}">
+              <ma14:wrappingTextBoxFlag xmlns:ma14="http://schemas.microsoft.com/office/mac/drawingml/2011/main" val="0"/>
+            </a:ext>
+          </a:extLst>
+        </p:spPr>
+        <p:txBody>
+          <a:bodyPr/>
+          <a:lstStyle>
+            <a:lvl1pPr>
+              <a:defRPr sz="1000">
+                <a:solidFill>
+                  <a:schemeClr val="accent4"/>
+                </a:solidFill>
+              </a:defRPr>
+            </a:lvl1pPr>
+          </a:lstStyle>
+          <a:p>
+            <a:pPr algn="r"/>
+            <a:fld id="{F7021451-1387-4CA6-816F-3879F97B5CBC}" type="slidenum">
+              <a:rPr b="0" lang="en-US"/>
+              <a:t>40</a:t>
+            </a:fld>
+            <a:endParaRPr lang="en-US"/>
+          </a:p>
+        </p:txBody>
+      </p:sp>
+    </p:spTree>
+  </p:cSld>
+  <p:clrMapOvr>
+    <a:masterClrMapping/>
+  </p:clrMapOvr>
+</p:sld>
+</file>
+
+<file path=ppt/slides/slide41.xml><?xml version="1.0" encoding="utf-8"?>
+<p:sld xmlns:a="http://schemas.openxmlformats.org/drawingml/2006/main" xmlns:r="http://schemas.openxmlformats.org/officeDocument/2006/relationships" xmlns:p="http://schemas.openxmlformats.org/presentationml/2006/main">
+  <p:cSld name="Slide 41">
+    <p:spTree>
+      <p:nvGrpSpPr>
+        <p:cNvPr id="1" name=""/>
+        <p:cNvGrpSpPr/>
+        <p:nvPr/>
+      </p:nvGrpSpPr>
+      <p:grpSpPr>
+        <a:xfrm>
+          <a:off x="0" y="0"/>
+          <a:ext cx="0" cy="0"/>
+          <a:chOff x="0" y="0"/>
+          <a:chExt cx="0" cy="0"/>
+        </a:xfrm>
+      </p:grpSpPr>
+      <p:sp>
+        <p:nvSpPr>
+          <p:cNvPr id="2" name="Text 0"/>
+          <p:cNvSpPr/>
+          <p:nvPr>
+            <p:ph idx="100" type="title" hasCustomPrompt="1"/>
+          </p:nvPr>
+        </p:nvSpPr>
+        <p:spPr>
+          <a:xfrm>
+            <a:off x="457200" y="274320"/>
+            <a:ext cx="8229600" cy="685800"/>
+          </a:xfrm>
+          <a:prstGeom prst="rect">
+            <a:avLst/>
+          </a:prstGeom>
+          <a:noFill/>
+          <a:ln/>
+        </p:spPr>
+        <p:txBody>
+          <a:bodyPr wrap="square" lIns="0" tIns="0" rIns="0" bIns="0" rtlCol="0" anchor="ctr"/>
+          <a:lstStyle/>
+          <a:p>
+            <a:pPr indent="0" marL="0">
+              <a:buNone/>
+            </a:pPr>
+            <a:r>
+              <a:rPr lang="en-US" sz="2800" b="1" dirty="0">
+                <a:solidFill>
+                  <a:schemeClr val="tx2"/>
+                </a:solidFill>
+              </a:rPr>
+              <a:t>광고·제휴 문의 받기</a:t>
+            </a:r>
+            <a:endParaRPr lang="en-US" sz="2800" dirty="0"/>
+          </a:p>
+        </p:txBody>
+      </p:sp>
+      <p:sp>
+        <p:nvSpPr>
+          <p:cNvPr id="3" name="Text 1"/>
+          <p:cNvSpPr txBox="1"/>
+          <p:nvPr/>
+        </p:nvSpPr>
+        <p:spPr>
+          <a:xfrm>
+            <a:off x="457200" y="1188720"/>
+            <a:ext cx="2560320" cy="365760"/>
+          </a:xfrm>
+          <a:prstGeom prst="rect">
+            <a:avLst/>
+          </a:prstGeom>
+          <a:noFill/>
+          <a:ln/>
+        </p:spPr>
+        <p:txBody>
+          <a:bodyPr wrap="square" lIns="0" tIns="0" rIns="0" bIns="0" rtlCol="0" anchor="t"/>
+          <a:lstStyle/>
+          <a:p>
+            <a:pPr indent="0" marL="0">
+              <a:buNone/>
+            </a:pPr>
+            <a:r>
+              <a:rPr lang="en-US" sz="1600" b="1" dirty="0">
+                <a:solidFill>
+                  <a:schemeClr val="accent2"/>
+                </a:solidFill>
+              </a:rPr>
+              <a:t>준비물</a:t>
+            </a:r>
+            <a:endParaRPr lang="en-US" sz="1600" dirty="0"/>
+          </a:p>
+        </p:txBody>
+      </p:sp>
+      <p:sp>
+        <p:nvSpPr>
+          <p:cNvPr id="4" name="Text 2"/>
+          <p:cNvSpPr txBox="1"/>
+          <p:nvPr/>
+        </p:nvSpPr>
+        <p:spPr>
+          <a:xfrm>
+            <a:off x="457200" y="1645920"/>
+            <a:ext cx="2651760" cy="2194560"/>
+          </a:xfrm>
+          <a:prstGeom prst="rect">
+            <a:avLst/>
+          </a:prstGeom>
+          <a:noFill/>
+          <a:ln/>
+        </p:spPr>
+        <p:txBody>
+          <a:bodyPr wrap="square" lIns="0" tIns="0" rIns="0" bIns="0" rtlCol="0" anchor="t"/>
+          <a:lstStyle/>
+          <a:p>
+            <a:pPr marL="342900" indent="-342900">
+              <a:spcAft>
+                <a:spcPts val="800"/>
+              </a:spcAft>
+              <a:buSzPct val="100000"/>
+              <a:buChar char="•"/>
+            </a:pPr>
+            <a:r>
+              <a:rPr lang="en-US" sz="1300" dirty="0">
+                <a:solidFill>
+                  <a:schemeClr val="tx1"/>
+                </a:solidFill>
+              </a:rPr>
+              <a:t>광고 문의 페이지</a:t>
+            </a:r>
+            <a:endParaRPr lang="en-US" sz="1300" dirty="0"/>
+          </a:p>
+          <a:p>
+            <a:pPr marL="342900" indent="-342900">
+              <a:spcAft>
+                <a:spcPts val="800"/>
+              </a:spcAft>
+              <a:buSzPct val="100000"/>
+              <a:buChar char="•"/>
+            </a:pPr>
+            <a:r>
+              <a:rPr lang="en-US" sz="1300" dirty="0">
+                <a:solidFill>
+                  <a:schemeClr val="tx1"/>
+                </a:solidFill>
+              </a:rPr>
+              <a:t>ads@ 전용 주소</a:t>
+            </a:r>
+            <a:endParaRPr lang="en-US" sz="1300" dirty="0"/>
+          </a:p>
+          <a:p>
+            <a:pPr marL="342900" indent="-342900">
+              <a:spcAft>
+                <a:spcPts val="800"/>
+              </a:spcAft>
+              <a:buSzPct val="100000"/>
+              <a:buChar char="•"/>
+            </a:pPr>
+            <a:r>
+              <a:rPr lang="en-US" sz="1300" dirty="0">
+                <a:solidFill>
+                  <a:schemeClr val="tx1"/>
+                </a:solidFill>
+              </a:rPr>
+              <a:t>미디어킷: 방문자 숫자 · 독자 특징 · 상품 · 가격 · 원칙</a:t>
+            </a:r>
+            <a:endParaRPr lang="en-US" sz="1300" dirty="0"/>
+          </a:p>
+        </p:txBody>
+      </p:sp>
+      <p:sp>
+        <p:nvSpPr>
+          <p:cNvPr id="5" name="Text 3"/>
+          <p:cNvSpPr txBox="1"/>
+          <p:nvPr/>
+        </p:nvSpPr>
+        <p:spPr>
+          <a:xfrm>
+            <a:off x="3291840" y="1188720"/>
+            <a:ext cx="2377440" cy="365760"/>
+          </a:xfrm>
+          <a:prstGeom prst="rect">
+            <a:avLst/>
+          </a:prstGeom>
+          <a:noFill/>
+          <a:ln/>
+        </p:spPr>
+        <p:txBody>
+          <a:bodyPr wrap="square" lIns="0" tIns="0" rIns="0" bIns="0" rtlCol="0" anchor="t"/>
+          <a:lstStyle/>
+          <a:p>
+            <a:pPr indent="0" marL="0">
+              <a:buNone/>
+            </a:pPr>
+            <a:r>
+              <a:rPr lang="en-US" sz="1600" b="1" dirty="0">
+                <a:solidFill>
+                  <a:schemeClr val="tx2"/>
+                </a:solidFill>
+              </a:rPr>
+              <a:t>진행 순서</a:t>
+            </a:r>
+            <a:endParaRPr lang="en-US" sz="1600" dirty="0"/>
+          </a:p>
+        </p:txBody>
+      </p:sp>
+      <p:sp>
+        <p:nvSpPr>
+          <p:cNvPr id="6" name="badge1"/>
+          <p:cNvSpPr/>
+          <p:nvPr/>
+        </p:nvSpPr>
+        <p:spPr>
+          <a:xfrm>
+            <a:off x="3291840" y="1645920"/>
+            <a:ext cx="329184" cy="329184"/>
+          </a:xfrm>
+          <a:prstGeom prst="ellipse">
+            <a:avLst/>
+          </a:prstGeom>
+          <a:solidFill>
+            <a:schemeClr val="tx2"/>
+          </a:solidFill>
+          <a:ln/>
+        </p:spPr>
+      </p:sp>
+      <p:sp>
+        <p:nvSpPr>
+          <p:cNvPr id="7" name="Text 5"/>
+          <p:cNvSpPr txBox="1"/>
+          <p:nvPr/>
+        </p:nvSpPr>
+        <p:spPr>
+          <a:xfrm>
+            <a:off x="3291840" y="1645920"/>
+            <a:ext cx="329184" cy="329184"/>
+          </a:xfrm>
+          <a:prstGeom prst="rect">
+            <a:avLst/>
+          </a:prstGeom>
+          <a:noFill/>
+          <a:ln/>
+        </p:spPr>
+        <p:txBody>
+          <a:bodyPr wrap="square" lIns="0" tIns="0" rIns="0" bIns="0" rtlCol="0" anchor="ctr"/>
+          <a:lstStyle/>
+          <a:p>
+            <a:pPr algn="ctr" indent="0" marL="0">
+              <a:buNone/>
+            </a:pPr>
+            <a:r>
+              <a:rPr lang="en-US" sz="1400" b="1" dirty="0">
+                <a:solidFill>
+                  <a:schemeClr val="bg1"/>
+                </a:solidFill>
+              </a:rPr>
+              <a:t>1</a:t>
+            </a:r>
+            <a:endParaRPr lang="en-US" sz="1400" dirty="0"/>
+          </a:p>
+        </p:txBody>
+      </p:sp>
+      <p:sp>
+        <p:nvSpPr>
+          <p:cNvPr id="8" name="Text 6"/>
+          <p:cNvSpPr txBox="1"/>
+          <p:nvPr/>
+        </p:nvSpPr>
+        <p:spPr>
+          <a:xfrm>
+            <a:off x="3703320" y="1627632"/>
+            <a:ext cx="1828800" cy="365760"/>
+          </a:xfrm>
+          <a:prstGeom prst="rect">
+            <a:avLst/>
+          </a:prstGeom>
+          <a:noFill/>
+          <a:ln/>
+        </p:spPr>
+        <p:txBody>
+          <a:bodyPr wrap="square" lIns="0" tIns="0" rIns="0" bIns="0" rtlCol="0" anchor="ctr"/>
+          <a:lstStyle/>
+          <a:p>
+            <a:pPr indent="0" marL="0">
+              <a:buNone/>
+            </a:pPr>
+            <a:r>
+              <a:rPr lang="en-US" sz="1300" dirty="0">
+                <a:solidFill>
+                  <a:schemeClr val="tx1"/>
+                </a:solidFill>
+              </a:rPr>
+              <a:t>광고주 확인</a:t>
+            </a:r>
+            <a:endParaRPr lang="en-US" sz="1300" dirty="0"/>
+          </a:p>
+        </p:txBody>
+      </p:sp>
+      <p:sp>
+        <p:nvSpPr>
+          <p:cNvPr id="9" name="badge2"/>
+          <p:cNvSpPr/>
+          <p:nvPr/>
+        </p:nvSpPr>
+        <p:spPr>
+          <a:xfrm>
+            <a:off x="3291840" y="2075688"/>
+            <a:ext cx="329184" cy="329184"/>
+          </a:xfrm>
+          <a:prstGeom prst="ellipse">
+            <a:avLst/>
+          </a:prstGeom>
+          <a:solidFill>
+            <a:schemeClr val="tx2"/>
+          </a:solidFill>
+          <a:ln/>
+        </p:spPr>
+      </p:sp>
+      <p:sp>
+        <p:nvSpPr>
+          <p:cNvPr id="10" name="Text 8"/>
+          <p:cNvSpPr txBox="1"/>
+          <p:nvPr/>
+        </p:nvSpPr>
+        <p:spPr>
+          <a:xfrm>
+            <a:off x="3291840" y="2075688"/>
+            <a:ext cx="329184" cy="329184"/>
+          </a:xfrm>
+          <a:prstGeom prst="rect">
+            <a:avLst/>
+          </a:prstGeom>
+          <a:noFill/>
+          <a:ln/>
+        </p:spPr>
+        <p:txBody>
+          <a:bodyPr wrap="square" lIns="0" tIns="0" rIns="0" bIns="0" rtlCol="0" anchor="ctr"/>
+          <a:lstStyle/>
+          <a:p>
+            <a:pPr algn="ctr" indent="0" marL="0">
+              <a:buNone/>
+            </a:pPr>
+            <a:r>
+              <a:rPr lang="en-US" sz="1400" b="1" dirty="0">
+                <a:solidFill>
+                  <a:schemeClr val="bg1"/>
+                </a:solidFill>
+              </a:rPr>
+              <a:t>2</a:t>
+            </a:r>
+            <a:endParaRPr lang="en-US" sz="1400" dirty="0"/>
+          </a:p>
+        </p:txBody>
+      </p:sp>
+      <p:sp>
+        <p:nvSpPr>
+          <p:cNvPr id="11" name="Text 9"/>
+          <p:cNvSpPr txBox="1"/>
+          <p:nvPr/>
+        </p:nvSpPr>
+        <p:spPr>
+          <a:xfrm>
+            <a:off x="3703320" y="2057400"/>
+            <a:ext cx="1828800" cy="365760"/>
+          </a:xfrm>
+          <a:prstGeom prst="rect">
+            <a:avLst/>
+          </a:prstGeom>
+          <a:noFill/>
+          <a:ln/>
+        </p:spPr>
+        <p:txBody>
+          <a:bodyPr wrap="square" lIns="0" tIns="0" rIns="0" bIns="0" rtlCol="0" anchor="ctr"/>
+          <a:lstStyle/>
+          <a:p>
+            <a:pPr indent="0" marL="0">
+              <a:buNone/>
+            </a:pPr>
+            <a:r>
+              <a:rPr lang="en-US" sz="1300" dirty="0">
+                <a:solidFill>
+                  <a:schemeClr val="tx1"/>
+                </a:solidFill>
+              </a:rPr>
+              <a:t>견적 · 계약</a:t>
+            </a:r>
+            <a:endParaRPr lang="en-US" sz="1300" dirty="0"/>
+          </a:p>
+        </p:txBody>
+      </p:sp>
+      <p:sp>
+        <p:nvSpPr>
+          <p:cNvPr id="12" name="badge3"/>
+          <p:cNvSpPr/>
+          <p:nvPr/>
+        </p:nvSpPr>
+        <p:spPr>
+          <a:xfrm>
+            <a:off x="3291840" y="2505456"/>
+            <a:ext cx="329184" cy="329184"/>
+          </a:xfrm>
+          <a:prstGeom prst="ellipse">
+            <a:avLst/>
+          </a:prstGeom>
+          <a:solidFill>
+            <a:schemeClr val="tx2"/>
+          </a:solidFill>
+          <a:ln/>
+        </p:spPr>
+      </p:sp>
+      <p:sp>
+        <p:nvSpPr>
+          <p:cNvPr id="13" name="Text 11"/>
+          <p:cNvSpPr txBox="1"/>
+          <p:nvPr/>
+        </p:nvSpPr>
+        <p:spPr>
+          <a:xfrm>
+            <a:off x="3291840" y="2505456"/>
+            <a:ext cx="329184" cy="329184"/>
+          </a:xfrm>
+          <a:prstGeom prst="rect">
+            <a:avLst/>
+          </a:prstGeom>
+          <a:noFill/>
+          <a:ln/>
+        </p:spPr>
+        <p:txBody>
+          <a:bodyPr wrap="square" lIns="0" tIns="0" rIns="0" bIns="0" rtlCol="0" anchor="ctr"/>
+          <a:lstStyle/>
+          <a:p>
+            <a:pPr algn="ctr" indent="0" marL="0">
+              <a:buNone/>
+            </a:pPr>
+            <a:r>
+              <a:rPr lang="en-US" sz="1400" b="1" dirty="0">
+                <a:solidFill>
+                  <a:schemeClr val="bg1"/>
+                </a:solidFill>
+              </a:rPr>
+              <a:t>3</a:t>
+            </a:r>
+            <a:endParaRPr lang="en-US" sz="1400" dirty="0"/>
+          </a:p>
+        </p:txBody>
+      </p:sp>
+      <p:sp>
+        <p:nvSpPr>
+          <p:cNvPr id="14" name="Text 12"/>
+          <p:cNvSpPr txBox="1"/>
+          <p:nvPr/>
+        </p:nvSpPr>
+        <p:spPr>
+          <a:xfrm>
+            <a:off x="3703320" y="2487168"/>
+            <a:ext cx="1828800" cy="365760"/>
+          </a:xfrm>
+          <a:prstGeom prst="rect">
+            <a:avLst/>
+          </a:prstGeom>
+          <a:noFill/>
+          <a:ln/>
+        </p:spPr>
+        <p:txBody>
+          <a:bodyPr wrap="square" lIns="0" tIns="0" rIns="0" bIns="0" rtlCol="0" anchor="ctr"/>
+          <a:lstStyle/>
+          <a:p>
+            <a:pPr indent="0" marL="0">
+              <a:buNone/>
+            </a:pPr>
+            <a:r>
+              <a:rPr lang="en-US" sz="1300" dirty="0">
+                <a:solidFill>
+                  <a:schemeClr val="tx1"/>
+                </a:solidFill>
+              </a:rPr>
+              <a:t>선불 결제</a:t>
+            </a:r>
+            <a:endParaRPr lang="en-US" sz="1300" dirty="0"/>
+          </a:p>
+        </p:txBody>
+      </p:sp>
+      <p:sp>
+        <p:nvSpPr>
+          <p:cNvPr id="15" name="badge4"/>
+          <p:cNvSpPr/>
+          <p:nvPr/>
+        </p:nvSpPr>
+        <p:spPr>
+          <a:xfrm>
+            <a:off x="3291840" y="2935224"/>
+            <a:ext cx="329184" cy="329184"/>
+          </a:xfrm>
+          <a:prstGeom prst="ellipse">
+            <a:avLst/>
+          </a:prstGeom>
+          <a:solidFill>
+            <a:schemeClr val="tx2"/>
+          </a:solidFill>
+          <a:ln/>
+        </p:spPr>
+      </p:sp>
+      <p:sp>
+        <p:nvSpPr>
+          <p:cNvPr id="16" name="Text 14"/>
+          <p:cNvSpPr txBox="1"/>
+          <p:nvPr/>
+        </p:nvSpPr>
+        <p:spPr>
+          <a:xfrm>
+            <a:off x="3291840" y="2935224"/>
+            <a:ext cx="329184" cy="329184"/>
+          </a:xfrm>
+          <a:prstGeom prst="rect">
+            <a:avLst/>
+          </a:prstGeom>
+          <a:noFill/>
+          <a:ln/>
+        </p:spPr>
+        <p:txBody>
+          <a:bodyPr wrap="square" lIns="0" tIns="0" rIns="0" bIns="0" rtlCol="0" anchor="ctr"/>
+          <a:lstStyle/>
+          <a:p>
+            <a:pPr algn="ctr" indent="0" marL="0">
+              <a:buNone/>
+            </a:pPr>
+            <a:r>
+              <a:rPr lang="en-US" sz="1400" b="1" dirty="0">
+                <a:solidFill>
+                  <a:schemeClr val="bg1"/>
+                </a:solidFill>
+              </a:rPr>
+              <a:t>4</a:t>
+            </a:r>
+            <a:endParaRPr lang="en-US" sz="1400" dirty="0"/>
+          </a:p>
+        </p:txBody>
+      </p:sp>
+      <p:sp>
+        <p:nvSpPr>
+          <p:cNvPr id="17" name="Text 15"/>
+          <p:cNvSpPr txBox="1"/>
+          <p:nvPr/>
+        </p:nvSpPr>
+        <p:spPr>
+          <a:xfrm>
+            <a:off x="3703320" y="2916936"/>
+            <a:ext cx="1828800" cy="365760"/>
+          </a:xfrm>
+          <a:prstGeom prst="rect">
+            <a:avLst/>
+          </a:prstGeom>
+          <a:noFill/>
+          <a:ln/>
+        </p:spPr>
+        <p:txBody>
+          <a:bodyPr wrap="square" lIns="0" tIns="0" rIns="0" bIns="0" rtlCol="0" anchor="ctr"/>
+          <a:lstStyle/>
+          <a:p>
+            <a:pPr indent="0" marL="0">
+              <a:buNone/>
+            </a:pPr>
+            <a:r>
+              <a:rPr lang="en-US" sz="1300" dirty="0">
+                <a:solidFill>
+                  <a:schemeClr val="tx1"/>
+                </a:solidFill>
+              </a:rPr>
+              <a:t>소재 검수</a:t>
+            </a:r>
+            <a:endParaRPr lang="en-US" sz="1300" dirty="0"/>
+          </a:p>
+        </p:txBody>
+      </p:sp>
+      <p:sp>
+        <p:nvSpPr>
+          <p:cNvPr id="18" name="badge5"/>
+          <p:cNvSpPr/>
+          <p:nvPr/>
+        </p:nvSpPr>
+        <p:spPr>
+          <a:xfrm>
+            <a:off x="3291840" y="3364992"/>
+            <a:ext cx="329184" cy="329184"/>
+          </a:xfrm>
+          <a:prstGeom prst="ellipse">
+            <a:avLst/>
+          </a:prstGeom>
+          <a:solidFill>
+            <a:schemeClr val="tx2"/>
+          </a:solidFill>
+          <a:ln/>
+        </p:spPr>
+      </p:sp>
+      <p:sp>
+        <p:nvSpPr>
+          <p:cNvPr id="19" name="Text 17"/>
+          <p:cNvSpPr txBox="1"/>
+          <p:nvPr/>
+        </p:nvSpPr>
+        <p:spPr>
+          <a:xfrm>
+            <a:off x="3291840" y="3364992"/>
+            <a:ext cx="329184" cy="329184"/>
+          </a:xfrm>
+          <a:prstGeom prst="rect">
+            <a:avLst/>
+          </a:prstGeom>
+          <a:noFill/>
+          <a:ln/>
+        </p:spPr>
+        <p:txBody>
+          <a:bodyPr wrap="square" lIns="0" tIns="0" rIns="0" bIns="0" rtlCol="0" anchor="ctr"/>
+          <a:lstStyle/>
+          <a:p>
+            <a:pPr algn="ctr" indent="0" marL="0">
+              <a:buNone/>
+            </a:pPr>
+            <a:r>
+              <a:rPr lang="en-US" sz="1400" b="1" dirty="0">
+                <a:solidFill>
+                  <a:schemeClr val="bg1"/>
+                </a:solidFill>
+              </a:rPr>
+              <a:t>5</a:t>
+            </a:r>
+            <a:endParaRPr lang="en-US" sz="1400" dirty="0"/>
+          </a:p>
+        </p:txBody>
+      </p:sp>
+      <p:sp>
+        <p:nvSpPr>
+          <p:cNvPr id="20" name="Text 18"/>
+          <p:cNvSpPr txBox="1"/>
+          <p:nvPr/>
+        </p:nvSpPr>
+        <p:spPr>
+          <a:xfrm>
+            <a:off x="3703320" y="3346704"/>
+            <a:ext cx="1828800" cy="365760"/>
+          </a:xfrm>
+          <a:prstGeom prst="rect">
+            <a:avLst/>
+          </a:prstGeom>
+          <a:noFill/>
+          <a:ln/>
+        </p:spPr>
+        <p:txBody>
+          <a:bodyPr wrap="square" lIns="0" tIns="0" rIns="0" bIns="0" rtlCol="0" anchor="ctr"/>
+          <a:lstStyle/>
+          <a:p>
+            <a:pPr indent="0" marL="0">
+              <a:buNone/>
+            </a:pPr>
+            <a:r>
+              <a:rPr lang="en-US" sz="1300" dirty="0">
+                <a:solidFill>
+                  <a:schemeClr val="tx1"/>
+                </a:solidFill>
+              </a:rPr>
+              <a:t>광고 표시 게재</a:t>
+            </a:r>
+            <a:endParaRPr lang="en-US" sz="1300" dirty="0"/>
+          </a:p>
+        </p:txBody>
+      </p:sp>
+      <p:sp>
+        <p:nvSpPr>
+          <p:cNvPr id="21" name="badge6"/>
+          <p:cNvSpPr/>
+          <p:nvPr/>
+        </p:nvSpPr>
+        <p:spPr>
+          <a:xfrm>
+            <a:off x="3291840" y="3794760"/>
+            <a:ext cx="329184" cy="329184"/>
+          </a:xfrm>
+          <a:prstGeom prst="ellipse">
+            <a:avLst/>
+          </a:prstGeom>
+          <a:solidFill>
+            <a:schemeClr val="tx2"/>
+          </a:solidFill>
+          <a:ln/>
+        </p:spPr>
+      </p:sp>
+      <p:sp>
+        <p:nvSpPr>
+          <p:cNvPr id="22" name="Text 20"/>
+          <p:cNvSpPr txBox="1"/>
+          <p:nvPr/>
+        </p:nvSpPr>
+        <p:spPr>
+          <a:xfrm>
+            <a:off x="3291840" y="3794760"/>
+            <a:ext cx="329184" cy="329184"/>
+          </a:xfrm>
+          <a:prstGeom prst="rect">
+            <a:avLst/>
+          </a:prstGeom>
+          <a:noFill/>
+          <a:ln/>
+        </p:spPr>
+        <p:txBody>
+          <a:bodyPr wrap="square" lIns="0" tIns="0" rIns="0" bIns="0" rtlCol="0" anchor="ctr"/>
+          <a:lstStyle/>
+          <a:p>
+            <a:pPr algn="ctr" indent="0" marL="0">
+              <a:buNone/>
+            </a:pPr>
+            <a:r>
+              <a:rPr lang="en-US" sz="1400" b="1" dirty="0">
+                <a:solidFill>
+                  <a:schemeClr val="bg1"/>
+                </a:solidFill>
+              </a:rPr>
+              <a:t>6</a:t>
+            </a:r>
+            <a:endParaRPr lang="en-US" sz="1400" dirty="0"/>
+          </a:p>
+        </p:txBody>
+      </p:sp>
+      <p:sp>
+        <p:nvSpPr>
+          <p:cNvPr id="23" name="Text 21"/>
+          <p:cNvSpPr txBox="1"/>
+          <p:nvPr/>
+        </p:nvSpPr>
+        <p:spPr>
+          <a:xfrm>
+            <a:off x="3703320" y="3776472"/>
+            <a:ext cx="1828800" cy="365760"/>
+          </a:xfrm>
+          <a:prstGeom prst="rect">
+            <a:avLst/>
+          </a:prstGeom>
+          <a:noFill/>
+          <a:ln/>
+        </p:spPr>
+        <p:txBody>
+          <a:bodyPr wrap="square" lIns="0" tIns="0" rIns="0" bIns="0" rtlCol="0" anchor="ctr"/>
+          <a:lstStyle/>
+          <a:p>
+            <a:pPr indent="0" marL="0">
+              <a:buNone/>
+            </a:pPr>
+            <a:r>
+              <a:rPr lang="en-US" sz="1300" dirty="0">
+                <a:solidFill>
+                  <a:schemeClr val="tx1"/>
+                </a:solidFill>
+              </a:rPr>
+              <a:t>결과 보고</a:t>
+            </a:r>
+            <a:endParaRPr lang="en-US" sz="1300" dirty="0"/>
+          </a:p>
+        </p:txBody>
+      </p:sp>
+      <p:sp>
+        <p:nvSpPr>
+          <p:cNvPr id="24" name="card"/>
+          <p:cNvSpPr/>
+          <p:nvPr/>
+        </p:nvSpPr>
+        <p:spPr>
+          <a:xfrm>
+            <a:off x="5852160" y="1188720"/>
+            <a:ext cx="2834640" cy="3200400"/>
+          </a:xfrm>
+          <a:prstGeom prst="roundRect">
+            <a:avLst>
+              <a:gd name="adj" fmla="val 2581"/>
+            </a:avLst>
+          </a:prstGeom>
+          <a:solidFill>
+            <a:schemeClr val="tx2"/>
+          </a:solidFill>
+          <a:ln/>
+        </p:spPr>
+      </p:sp>
+      <p:sp>
+        <p:nvSpPr>
+          <p:cNvPr id="25" name="Text 23"/>
+          <p:cNvSpPr txBox="1"/>
+          <p:nvPr/>
+        </p:nvSpPr>
+        <p:spPr>
+          <a:xfrm>
+            <a:off x="6035040" y="1325880"/>
+            <a:ext cx="2468880" cy="365760"/>
+          </a:xfrm>
+          <a:prstGeom prst="rect">
+            <a:avLst/>
+          </a:prstGeom>
+          <a:noFill/>
+          <a:ln/>
+        </p:spPr>
+        <p:txBody>
+          <a:bodyPr wrap="square" lIns="0" tIns="0" rIns="0" bIns="0" rtlCol="0" anchor="t"/>
+          <a:lstStyle/>
+          <a:p>
+            <a:pPr indent="0" marL="0">
+              <a:buNone/>
+            </a:pPr>
+            <a:r>
+              <a:rPr lang="en-US" sz="1600" b="1" dirty="0">
+                <a:solidFill>
+                  <a:schemeClr val="accent6"/>
+                </a:solidFill>
+              </a:rPr>
+              <a:t>거절할 광고</a:t>
+            </a:r>
+            <a:endParaRPr lang="en-US" sz="1600" dirty="0"/>
+          </a:p>
+        </p:txBody>
+      </p:sp>
+      <p:sp>
+        <p:nvSpPr>
+          <p:cNvPr id="26" name="Text 24"/>
+          <p:cNvSpPr txBox="1"/>
+          <p:nvPr/>
+        </p:nvSpPr>
+        <p:spPr>
+          <a:xfrm>
+            <a:off x="6035040" y="1783080"/>
+            <a:ext cx="2560320" cy="2468880"/>
+          </a:xfrm>
+          <a:prstGeom prst="rect">
+            <a:avLst/>
+          </a:prstGeom>
+          <a:noFill/>
+          <a:ln/>
+        </p:spPr>
+        <p:txBody>
+          <a:bodyPr wrap="square" lIns="0" tIns="0" rIns="0" bIns="0" rtlCol="0" anchor="t"/>
+          <a:lstStyle/>
+          <a:p>
+            <a:pPr marL="342900" indent="-342900">
+              <a:spcAft>
+                <a:spcPts val="600"/>
+              </a:spcAft>
+              <a:buSzPct val="100000"/>
+              <a:buChar char="•"/>
+            </a:pPr>
+            <a:r>
+              <a:rPr lang="en-US" sz="1200" dirty="0">
+                <a:solidFill>
+                  <a:schemeClr val="bg1"/>
+                </a:solidFill>
+              </a:rPr>
+              <a:t>불법 도박 · 토토</a:t>
+            </a:r>
+            <a:endParaRPr lang="en-US" sz="1200" dirty="0"/>
+          </a:p>
+          <a:p>
+            <a:pPr marL="342900" indent="-342900">
+              <a:spcAft>
+                <a:spcPts val="600"/>
+              </a:spcAft>
+              <a:buSzPct val="100000"/>
+              <a:buChar char="•"/>
+            </a:pPr>
+            <a:r>
+              <a:rPr lang="en-US" sz="1200" dirty="0">
+                <a:solidFill>
+                  <a:schemeClr val="bg1"/>
+                </a:solidFill>
+              </a:rPr>
+              <a:t>성인물</a:t>
+            </a:r>
+            <a:endParaRPr lang="en-US" sz="1200" dirty="0"/>
+          </a:p>
+          <a:p>
+            <a:pPr marL="342900" indent="-342900">
+              <a:spcAft>
+                <a:spcPts val="600"/>
+              </a:spcAft>
+              <a:buSzPct val="100000"/>
+              <a:buChar char="•"/>
+            </a:pPr>
+            <a:r>
+              <a:rPr lang="en-US" sz="1200" dirty="0">
+                <a:solidFill>
+                  <a:schemeClr val="bg1"/>
+                </a:solidFill>
+              </a:rPr>
+              <a:t>수익 보장 투자 · 코인</a:t>
+            </a:r>
+            <a:endParaRPr lang="en-US" sz="1200" dirty="0"/>
+          </a:p>
+          <a:p>
+            <a:pPr marL="342900" indent="-342900">
+              <a:spcAft>
+                <a:spcPts val="600"/>
+              </a:spcAft>
+              <a:buSzPct val="100000"/>
+              <a:buChar char="•"/>
+            </a:pPr>
+            <a:r>
+              <a:rPr lang="en-US" sz="1200" dirty="0">
+                <a:solidFill>
+                  <a:schemeClr val="bg1"/>
+                </a:solidFill>
+              </a:rPr>
+              <a:t>의약품 효능</a:t>
+            </a:r>
+            <a:endParaRPr lang="en-US" sz="1200" dirty="0"/>
+          </a:p>
+          <a:p>
+            <a:pPr marL="342900" indent="-342900">
+              <a:spcAft>
+                <a:spcPts val="600"/>
+              </a:spcAft>
+              <a:buSzPct val="100000"/>
+              <a:buChar char="•"/>
+            </a:pPr>
+            <a:r>
+              <a:rPr lang="en-US" sz="1200" dirty="0">
+                <a:solidFill>
+                  <a:schemeClr val="bg1"/>
+                </a:solidFill>
+              </a:rPr>
+              <a:t>광고 표시 없이 해 달라는 요청</a:t>
+            </a:r>
+            <a:endParaRPr lang="en-US" sz="1200" dirty="0"/>
+          </a:p>
+          <a:p>
+            <a:pPr marL="342900" indent="-342900">
+              <a:spcAft>
+                <a:spcPts val="600"/>
+              </a:spcAft>
+              <a:buSzPct val="100000"/>
+              <a:buChar char="•"/>
+            </a:pPr>
+            <a:r>
+              <a:rPr lang="en-US" sz="1200" dirty="0">
+                <a:solidFill>
+                  <a:schemeClr val="bg1"/>
+                </a:solidFill>
+              </a:rPr>
+              <a:t>백링크 판매 · 수상한 첨부 파일</a:t>
+            </a:r>
+            <a:endParaRPr lang="en-US" sz="1200" dirty="0"/>
+          </a:p>
+        </p:txBody>
+      </p:sp>
+      <p:sp>
+        <p:nvSpPr>
+          <p:cNvPr id="25" name="Slide Number Placeholder 0"/>
+          <p:cNvSpPr>
+            <a:spLocks noGrp="1"/>
+          </p:cNvSpPr>
+          <p:nvPr>
+            <p:ph type="sldNum" sz="quarter" idx="4294967295"/>
+          </p:nvPr>
+        </p:nvSpPr>
+        <p:spPr>
+          <a:xfrm>
+            <a:off x="8321040" y="4754880"/>
+            <a:ext cx="457200" cy="274320"/>
+          </a:xfrm>
+          <a:prstGeom prst="rect">
+            <a:avLst/>
+          </a:prstGeom>
+          <a:extLst>
+            <a:ext uri="{C572A759-6A51-4108-AA02-DFA0A04FC94B}">
+              <ma14:wrappingTextBoxFlag xmlns:ma14="http://schemas.microsoft.com/office/mac/drawingml/2011/main" val="0"/>
+            </a:ext>
+          </a:extLst>
+        </p:spPr>
+        <p:txBody>
+          <a:bodyPr/>
+          <a:lstStyle>
+            <a:lvl1pPr>
+              <a:defRPr sz="1000">
+                <a:solidFill>
+                  <a:schemeClr val="accent4"/>
+                </a:solidFill>
+              </a:defRPr>
+            </a:lvl1pPr>
+          </a:lstStyle>
+          <a:p>
+            <a:pPr algn="r"/>
+            <a:fld id="{F7021451-1387-4CA6-816F-3879F97B5CBC}" type="slidenum">
+              <a:rPr b="0" lang="en-US"/>
+              <a:t>41</a:t>
+            </a:fld>
+            <a:endParaRPr lang="en-US"/>
+          </a:p>
+        </p:txBody>
+      </p:sp>
+    </p:spTree>
+  </p:cSld>
+  <p:clrMapOvr>
+    <a:masterClrMapping/>
+  </p:clrMapOvr>
+</p:sld>
+</file>
+
+<file path=ppt/slides/slide42.xml><?xml version="1.0" encoding="utf-8"?>
+<p:sld xmlns:a="http://schemas.openxmlformats.org/drawingml/2006/main" xmlns:r="http://schemas.openxmlformats.org/officeDocument/2006/relationships" xmlns:p="http://schemas.openxmlformats.org/presentationml/2006/main">
+  <p:cSld name="Slide 42">
+    <p:spTree>
+      <p:nvGrpSpPr>
+        <p:cNvPr id="1" name=""/>
+        <p:cNvGrpSpPr/>
+        <p:nvPr/>
+      </p:nvGrpSpPr>
+      <p:grpSpPr>
+        <a:xfrm>
+          <a:off x="0" y="0"/>
+          <a:ext cx="0" cy="0"/>
+          <a:chOff x="0" y="0"/>
+          <a:chExt cx="0" cy="0"/>
+        </a:xfrm>
+      </p:grpSpPr>
+      <p:sp>
+        <p:nvSpPr>
+          <p:cNvPr id="2" name="Text 0"/>
+          <p:cNvSpPr/>
+          <p:nvPr>
+            <p:ph idx="100" type="title" hasCustomPrompt="1"/>
+          </p:nvPr>
+        </p:nvSpPr>
+        <p:spPr>
+          <a:xfrm>
+            <a:off x="548640" y="1371600"/>
+            <a:ext cx="8046720" cy="1280160"/>
+          </a:xfrm>
+          <a:prstGeom prst="rect">
+            <a:avLst/>
+          </a:prstGeom>
+          <a:noFill/>
+          <a:ln/>
+        </p:spPr>
+        <p:txBody>
+          <a:bodyPr wrap="square" lIns="0" tIns="0" rIns="0" bIns="0" rtlCol="0" anchor="b"/>
+          <a:lstStyle/>
+          <a:p>
+            <a:pPr algn="l" indent="0" marL="0">
+              <a:buNone/>
+            </a:pPr>
+            <a:r>
+              <a:rPr lang="en-US" sz="4000" b="1" dirty="0">
+                <a:solidFill>
+                  <a:schemeClr val="bg1"/>
+                </a:solidFill>
+              </a:rPr>
+              <a:t>안전하게, 자주 반복하기</a:t>
+            </a:r>
+            <a:endParaRPr lang="en-US" sz="4000" dirty="0"/>
+          </a:p>
+        </p:txBody>
+      </p:sp>
+      <p:sp>
+        <p:nvSpPr>
+          <p:cNvPr id="3" name="Text 0"/>
+          <p:cNvSpPr/>
+          <p:nvPr>
+            <p:ph idx="101" type="body" hasCustomPrompt="1"/>
+          </p:nvPr>
+        </p:nvSpPr>
+        <p:spPr>
+          <a:xfrm>
+            <a:off x="548640" y="2788920"/>
+            <a:ext cx="8046720" cy="1097280"/>
+          </a:xfrm>
+          <a:prstGeom prst="rect">
+            <a:avLst/>
+          </a:prstGeom>
+          <a:noFill/>
+          <a:ln/>
+        </p:spPr>
+        <p:txBody>
+          <a:bodyPr wrap="square" lIns="0" tIns="0" rIns="0" bIns="0" rtlCol="0" anchor="t"/>
+          <a:lstStyle/>
+          <a:p>
+            <a:pPr algn="l" indent="0" marL="0">
+              <a:buNone/>
+            </a:pPr>
+            <a:r>
+              <a:rPr lang="en-US" sz="1800" dirty="0">
+                <a:solidFill>
+                  <a:schemeClr val="bg2"/>
+                </a:solidFill>
+              </a:rPr>
+              <a:t>기획 → 백업 → 연습용 사이트에서 수정 → 확인 → 배포 → 감시 → 숫자 보기 → 다시 기획</a:t>
+            </a:r>
+            <a:endParaRPr lang="en-US" sz="1800" dirty="0"/>
+          </a:p>
+          <a:p>
+            <a:pPr algn="l" indent="0" marL="0">
+              <a:buNone/>
+            </a:pPr>
+            <a:r>
+              <a:rPr lang="en-US" sz="1800" dirty="0">
+                <a:solidFill>
+                  <a:schemeClr val="bg2"/>
+                </a:solidFill>
+              </a:rPr>
+              <a:t>다음 할 일: docs/13-practice-scenario.md 를 읽고 15장 퀴즈 풀기</a:t>
+            </a:r>
+            <a:endParaRPr lang="en-US" sz="1800" dirty="0"/>
           </a:p>
         </p:txBody>
       </p:sp>

</xml_diff>

<commit_message>
Add chapters on domain names and industry domain knowledge
Chapter 34 covers domain names in practice: reading a URL, choosing
a TLD (.com, .kr, .co.kr), the registry/registrar chain, pricing,
DNS records, the expiry lifecycle, disputes (UDRP), transfers and
buying names. Chapter 35 covers domain knowledge by industry:
commerce order states, card approval/capture/settlement, logistics,
ad tech, games, subscriptions, booking, fintech, plus how to study
a new domain and DDD basics. README, ch5, glossary, quiz, sources
and the deck (now 55 slides) are updated.

Co-Authored-By: Claude Opus 5.5 <noreply@anthropic.com>
Claude-Session: https://claude.ai/code/session_01Tuz8P5EzhzAFozhesRbd5A
</commit_message>
<xml_diff>
--- a/slides/internet-business-101.pptx
+++ b/slides/internet-business-101.pptx
@@ -54,9 +54,15 @@
     <p:sldId id="302" r:id="rId48"/>
     <p:sldId id="303" r:id="rId49"/>
     <p:sldId id="304" r:id="rId50"/>
+    <p:sldId id="305" r:id="rId51"/>
+    <p:sldId id="306" r:id="rId52"/>
+    <p:sldId id="307" r:id="rId53"/>
+    <p:sldId id="308" r:id="rId54"/>
+    <p:sldId id="309" r:id="rId55"/>
+    <p:sldId id="310" r:id="rId56"/>
   </p:sldIdLst>
   <p:notesMasterIdLst>
-    <p:notesMasterId r:id="rId51"/>
+    <p:notesMasterId r:id="rId57"/>
   </p:notesMasterIdLst>
   <p:sldSz cx="9144000" cy="5143500"/>
   <p:notesSz cx="5143500" cy="9144000"/>
@@ -155,13 +161,13 @@
   <p:extLst>
     <p:ext uri="{521415D9-36F7-43E2-AB2F-B90AF26B5E84}">
       <p14:sectionLst xmlns:p14="http://schemas.microsoft.com/office/powerpoint/2010/main">
-        <p14:section name="시작" id="{92378333-d2d1-b9ce-3178-93a32a897fc6}">
+        <p14:section name="시작" id="{364d1b27-e875-43d2-f800-ad6f569d37a0}">
           <p14:sldIdLst>
             <p14:sldId id="256"/>
             <p14:sldId id="257"/>
           </p14:sldIdLst>
         </p14:section>
-        <p14:section name="큰 그림" id="{409d245e-d63d-d1c1-0cfa-994d67e0510f}">
+        <p14:section name="큰 그림" id="{e071abc0-23a6-cf4c-c2d1-81c7679ce33b}">
           <p14:sldIdLst>
             <p14:sldId id="258"/>
             <p14:sldId id="259"/>
@@ -170,13 +176,13 @@
             <p14:sldId id="262"/>
           </p14:sldIdLst>
         </p14:section>
-        <p14:section name="만들기" id="{0dc08d9a-aee0-b602-fc2c-d92142e9d3fa}">
+        <p14:section name="만들기" id="{115e535e-1b65-42d7-bded-e93aa35e3a13}">
           <p14:sldIdLst>
             <p14:sldId id="263"/>
             <p14:sldId id="264"/>
           </p14:sldIdLst>
         </p14:section>
-        <p14:section name="운영하기" id="{ab3a47b9-ef36-865c-c704-acf112ed8b24}">
+        <p14:section name="운영하기" id="{129e2bd1-189b-0265-c3b3-5dc418be27ba}">
           <p14:sldIdLst>
             <p14:sldId id="265"/>
             <p14:sldId id="266"/>
@@ -190,18 +196,18 @@
             <p14:sldId id="274"/>
           </p14:sldIdLst>
         </p14:section>
-        <p14:section name="키우기" id="{04c8a67d-7a86-ca1c-aa35-4676d7ccd5cb}">
+        <p14:section name="키우기" id="{5b97b1e9-03ca-ba8f-672d-0b06925c0c60}">
           <p14:sldIdLst>
             <p14:sldId id="275"/>
             <p14:sldId id="276"/>
           </p14:sldIdLst>
         </p14:section>
-        <p14:section name="실전" id="{11d1d42d-8101-6295-9512-c1bdd0f48013}">
+        <p14:section name="실전" id="{114daad0-c0ef-c9d9-0c2c-9dd128c7d537}">
           <p14:sldIdLst>
             <p14:sldId id="277"/>
           </p14:sldIdLst>
         </p14:section>
-        <p14:section name="여러 가지 사이트 사업" id="{7081f729-0752-8e5d-d07a-5ed32d60d222}">
+        <p14:section name="여러 가지 사이트 사업" id="{d2f9a892-c1b7-9efb-c59a-a63031bfb4e3}">
           <p14:sldIdLst>
             <p14:sldId id="278"/>
             <p14:sldId id="279"/>
@@ -212,7 +218,7 @@
             <p14:sldId id="284"/>
           </p14:sldIdLst>
         </p14:section>
-        <p14:section name="더 넓은 분류" id="{46b14099-68ed-1128-ee0a-e95c26c4b115}">
+        <p14:section name="더 넓은 분류" id="{cb4c38b9-a440-ae2d-71d1-b6609a120cd8}">
           <p14:sldIdLst>
             <p14:sldId id="285"/>
             <p14:sldId id="286"/>
@@ -223,7 +229,7 @@
             <p14:sldId id="291"/>
           </p14:sldIdLst>
         </p14:section>
-        <p14:section name="문의·광고 받기" id="{6084dcc1-3161-c67a-b52f-26f2026a8e56}">
+        <p14:section name="문의·광고 받기" id="{ad54818d-82ad-4777-9d75-001d13456a37}">
           <p14:sldIdLst>
             <p14:sldId id="292"/>
             <p14:sldId id="293"/>
@@ -232,7 +238,7 @@
             <p14:sldId id="296"/>
           </p14:sldIdLst>
         </p14:section>
-        <p14:section name="마케팅 실전" id="{2ec1711a-04c7-598d-dded-c86fc39889e8}">
+        <p14:section name="마케팅 실전" id="{bf20c87b-729e-9cd0-f199-12e7926be614}">
           <p14:sldIdLst>
             <p14:sldId id="297"/>
             <p14:sldId id="298"/>
@@ -241,7 +247,17 @@
             <p14:sldId id="301"/>
             <p14:sldId id="302"/>
             <p14:sldId id="303"/>
+          </p14:sldIdLst>
+        </p14:section>
+        <p14:section name="도메인" id="{88cd1627-b8d8-7286-e544-2dfa163bec9f}">
+          <p14:sldIdLst>
             <p14:sldId id="304"/>
+            <p14:sldId id="305"/>
+            <p14:sldId id="306"/>
+            <p14:sldId id="307"/>
+            <p14:sldId id="308"/>
+            <p14:sldId id="309"/>
+            <p14:sldId id="310"/>
           </p14:sldIdLst>
         </p14:section>
       </p14:sectionLst>
@@ -5488,6 +5504,534 @@
             <a:fld id="{F7021451-1387-4CA6-816F-3879F97B5CBC}" type="slidenum">
               <a:rPr lang="en-US"/>
               <a:t>5</a:t>
+            </a:fld>
+            <a:endParaRPr lang="en-US"/>
+          </a:p>
+        </p:txBody>
+      </p:sp>
+    </p:spTree>
+    <p:extLst>
+      <p:ext uri="{BB962C8B-B14F-4D97-AF65-F5344CB8AC3E}">
+        <p14:creationId xmlns:p14="http://schemas.microsoft.com/office/powerpoint/2010/main" val="1024086991"/>
+      </p:ext>
+    </p:extLst>
+  </p:cSld>
+  <p:clrMapOvr>
+    <a:masterClrMapping/>
+  </p:clrMapOvr>
+</p:notes>
+</file>
+
+<file path=ppt/notesSlides/notesSlide50.xml><?xml version="1.0" encoding="utf-8"?>
+<p:notes xmlns:a="http://schemas.openxmlformats.org/drawingml/2006/main" xmlns:r="http://schemas.openxmlformats.org/officeDocument/2006/relationships" xmlns:p="http://schemas.openxmlformats.org/presentationml/2006/main">
+  <p:cSld>
+    <p:spTree>
+      <p:nvGrpSpPr>
+        <p:cNvPr id="1" name=""/>
+        <p:cNvGrpSpPr/>
+        <p:nvPr/>
+      </p:nvGrpSpPr>
+      <p:grpSpPr>
+        <a:xfrm>
+          <a:off x="0" y="0"/>
+          <a:ext cx="0" cy="0"/>
+          <a:chOff x="0" y="0"/>
+          <a:chExt cx="0" cy="0"/>
+        </a:xfrm>
+      </p:grpSpPr>
+      <p:sp>
+        <p:nvSpPr>
+          <p:cNvPr id="2" name="Slide Image Placeholder 1"/>
+          <p:cNvSpPr>
+            <a:spLocks noGrp="1" noRot="1" noChangeAspect="1"/>
+          </p:cNvSpPr>
+          <p:nvPr>
+            <p:ph type="sldImg"/>
+          </p:nvPr>
+        </p:nvSpPr>
+        <p:spPr/>
+      </p:sp>
+      <p:sp>
+        <p:nvSpPr>
+          <p:cNvPr id="3" name="Notes Placeholder 2"/>
+          <p:cNvSpPr>
+            <a:spLocks noGrp="1"/>
+          </p:cNvSpPr>
+          <p:nvPr>
+            <p:ph type="body" idx="1"/>
+          </p:nvPr>
+        </p:nvSpPr>
+        <p:spPr/>
+        <p:txBody>
+          <a:bodyPr/>
+          <a:lstStyle/>
+          <a:p>
+            <a:r>
+              <a:rPr lang="en-US" dirty="0"/>
+              <a:t/>
+            </a:r>
+            <a:endParaRPr lang="en-US" dirty="0"/>
+          </a:p>
+        </p:txBody>
+      </p:sp>
+      <p:sp>
+        <p:nvSpPr>
+          <p:cNvPr id="4" name="Slide Number Placeholder 3"/>
+          <p:cNvSpPr>
+            <a:spLocks noGrp="1"/>
+          </p:cNvSpPr>
+          <p:nvPr>
+            <p:ph type="sldNum" sz="quarter" idx="10"/>
+          </p:nvPr>
+        </p:nvSpPr>
+        <p:spPr/>
+        <p:txBody>
+          <a:bodyPr/>
+          <a:lstStyle/>
+          <a:p>
+            <a:fld id="{F7021451-1387-4CA6-816F-3879F97B5CBC}" type="slidenum">
+              <a:rPr lang="en-US"/>
+              <a:t>50</a:t>
+            </a:fld>
+            <a:endParaRPr lang="en-US"/>
+          </a:p>
+        </p:txBody>
+      </p:sp>
+    </p:spTree>
+    <p:extLst>
+      <p:ext uri="{BB962C8B-B14F-4D97-AF65-F5344CB8AC3E}">
+        <p14:creationId xmlns:p14="http://schemas.microsoft.com/office/powerpoint/2010/main" val="1024086991"/>
+      </p:ext>
+    </p:extLst>
+  </p:cSld>
+  <p:clrMapOvr>
+    <a:masterClrMapping/>
+  </p:clrMapOvr>
+</p:notes>
+</file>
+
+<file path=ppt/notesSlides/notesSlide51.xml><?xml version="1.0" encoding="utf-8"?>
+<p:notes xmlns:a="http://schemas.openxmlformats.org/drawingml/2006/main" xmlns:r="http://schemas.openxmlformats.org/officeDocument/2006/relationships" xmlns:p="http://schemas.openxmlformats.org/presentationml/2006/main">
+  <p:cSld>
+    <p:spTree>
+      <p:nvGrpSpPr>
+        <p:cNvPr id="1" name=""/>
+        <p:cNvGrpSpPr/>
+        <p:nvPr/>
+      </p:nvGrpSpPr>
+      <p:grpSpPr>
+        <a:xfrm>
+          <a:off x="0" y="0"/>
+          <a:ext cx="0" cy="0"/>
+          <a:chOff x="0" y="0"/>
+          <a:chExt cx="0" cy="0"/>
+        </a:xfrm>
+      </p:grpSpPr>
+      <p:sp>
+        <p:nvSpPr>
+          <p:cNvPr id="2" name="Slide Image Placeholder 1"/>
+          <p:cNvSpPr>
+            <a:spLocks noGrp="1" noRot="1" noChangeAspect="1"/>
+          </p:cNvSpPr>
+          <p:nvPr>
+            <p:ph type="sldImg"/>
+          </p:nvPr>
+        </p:nvSpPr>
+        <p:spPr/>
+      </p:sp>
+      <p:sp>
+        <p:nvSpPr>
+          <p:cNvPr id="3" name="Notes Placeholder 2"/>
+          <p:cNvSpPr>
+            <a:spLocks noGrp="1"/>
+          </p:cNvSpPr>
+          <p:nvPr>
+            <p:ph type="body" idx="1"/>
+          </p:nvPr>
+        </p:nvSpPr>
+        <p:spPr/>
+        <p:txBody>
+          <a:bodyPr/>
+          <a:lstStyle/>
+          <a:p>
+            <a:r>
+              <a:rPr lang="en-US" dirty="0"/>
+              <a:t/>
+            </a:r>
+            <a:endParaRPr lang="en-US" dirty="0"/>
+          </a:p>
+        </p:txBody>
+      </p:sp>
+      <p:sp>
+        <p:nvSpPr>
+          <p:cNvPr id="4" name="Slide Number Placeholder 3"/>
+          <p:cNvSpPr>
+            <a:spLocks noGrp="1"/>
+          </p:cNvSpPr>
+          <p:nvPr>
+            <p:ph type="sldNum" sz="quarter" idx="10"/>
+          </p:nvPr>
+        </p:nvSpPr>
+        <p:spPr/>
+        <p:txBody>
+          <a:bodyPr/>
+          <a:lstStyle/>
+          <a:p>
+            <a:fld id="{F7021451-1387-4CA6-816F-3879F97B5CBC}" type="slidenum">
+              <a:rPr lang="en-US"/>
+              <a:t>51</a:t>
+            </a:fld>
+            <a:endParaRPr lang="en-US"/>
+          </a:p>
+        </p:txBody>
+      </p:sp>
+    </p:spTree>
+    <p:extLst>
+      <p:ext uri="{BB962C8B-B14F-4D97-AF65-F5344CB8AC3E}">
+        <p14:creationId xmlns:p14="http://schemas.microsoft.com/office/powerpoint/2010/main" val="1024086991"/>
+      </p:ext>
+    </p:extLst>
+  </p:cSld>
+  <p:clrMapOvr>
+    <a:masterClrMapping/>
+  </p:clrMapOvr>
+</p:notes>
+</file>
+
+<file path=ppt/notesSlides/notesSlide52.xml><?xml version="1.0" encoding="utf-8"?>
+<p:notes xmlns:a="http://schemas.openxmlformats.org/drawingml/2006/main" xmlns:r="http://schemas.openxmlformats.org/officeDocument/2006/relationships" xmlns:p="http://schemas.openxmlformats.org/presentationml/2006/main">
+  <p:cSld>
+    <p:spTree>
+      <p:nvGrpSpPr>
+        <p:cNvPr id="1" name=""/>
+        <p:cNvGrpSpPr/>
+        <p:nvPr/>
+      </p:nvGrpSpPr>
+      <p:grpSpPr>
+        <a:xfrm>
+          <a:off x="0" y="0"/>
+          <a:ext cx="0" cy="0"/>
+          <a:chOff x="0" y="0"/>
+          <a:chExt cx="0" cy="0"/>
+        </a:xfrm>
+      </p:grpSpPr>
+      <p:sp>
+        <p:nvSpPr>
+          <p:cNvPr id="2" name="Slide Image Placeholder 1"/>
+          <p:cNvSpPr>
+            <a:spLocks noGrp="1" noRot="1" noChangeAspect="1"/>
+          </p:cNvSpPr>
+          <p:nvPr>
+            <p:ph type="sldImg"/>
+          </p:nvPr>
+        </p:nvSpPr>
+        <p:spPr/>
+      </p:sp>
+      <p:sp>
+        <p:nvSpPr>
+          <p:cNvPr id="3" name="Notes Placeholder 2"/>
+          <p:cNvSpPr>
+            <a:spLocks noGrp="1"/>
+          </p:cNvSpPr>
+          <p:nvPr>
+            <p:ph type="body" idx="1"/>
+          </p:nvPr>
+        </p:nvSpPr>
+        <p:spPr/>
+        <p:txBody>
+          <a:bodyPr/>
+          <a:lstStyle/>
+          <a:p>
+            <a:r>
+              <a:rPr lang="en-US" dirty="0"/>
+              <a:t/>
+            </a:r>
+            <a:endParaRPr lang="en-US" dirty="0"/>
+          </a:p>
+        </p:txBody>
+      </p:sp>
+      <p:sp>
+        <p:nvSpPr>
+          <p:cNvPr id="4" name="Slide Number Placeholder 3"/>
+          <p:cNvSpPr>
+            <a:spLocks noGrp="1"/>
+          </p:cNvSpPr>
+          <p:nvPr>
+            <p:ph type="sldNum" sz="quarter" idx="10"/>
+          </p:nvPr>
+        </p:nvSpPr>
+        <p:spPr/>
+        <p:txBody>
+          <a:bodyPr/>
+          <a:lstStyle/>
+          <a:p>
+            <a:fld id="{F7021451-1387-4CA6-816F-3879F97B5CBC}" type="slidenum">
+              <a:rPr lang="en-US"/>
+              <a:t>52</a:t>
+            </a:fld>
+            <a:endParaRPr lang="en-US"/>
+          </a:p>
+        </p:txBody>
+      </p:sp>
+    </p:spTree>
+    <p:extLst>
+      <p:ext uri="{BB962C8B-B14F-4D97-AF65-F5344CB8AC3E}">
+        <p14:creationId xmlns:p14="http://schemas.microsoft.com/office/powerpoint/2010/main" val="1024086991"/>
+      </p:ext>
+    </p:extLst>
+  </p:cSld>
+  <p:clrMapOvr>
+    <a:masterClrMapping/>
+  </p:clrMapOvr>
+</p:notes>
+</file>
+
+<file path=ppt/notesSlides/notesSlide53.xml><?xml version="1.0" encoding="utf-8"?>
+<p:notes xmlns:a="http://schemas.openxmlformats.org/drawingml/2006/main" xmlns:r="http://schemas.openxmlformats.org/officeDocument/2006/relationships" xmlns:p="http://schemas.openxmlformats.org/presentationml/2006/main">
+  <p:cSld>
+    <p:spTree>
+      <p:nvGrpSpPr>
+        <p:cNvPr id="1" name=""/>
+        <p:cNvGrpSpPr/>
+        <p:nvPr/>
+      </p:nvGrpSpPr>
+      <p:grpSpPr>
+        <a:xfrm>
+          <a:off x="0" y="0"/>
+          <a:ext cx="0" cy="0"/>
+          <a:chOff x="0" y="0"/>
+          <a:chExt cx="0" cy="0"/>
+        </a:xfrm>
+      </p:grpSpPr>
+      <p:sp>
+        <p:nvSpPr>
+          <p:cNvPr id="2" name="Slide Image Placeholder 1"/>
+          <p:cNvSpPr>
+            <a:spLocks noGrp="1" noRot="1" noChangeAspect="1"/>
+          </p:cNvSpPr>
+          <p:nvPr>
+            <p:ph type="sldImg"/>
+          </p:nvPr>
+        </p:nvSpPr>
+        <p:spPr/>
+      </p:sp>
+      <p:sp>
+        <p:nvSpPr>
+          <p:cNvPr id="3" name="Notes Placeholder 2"/>
+          <p:cNvSpPr>
+            <a:spLocks noGrp="1"/>
+          </p:cNvSpPr>
+          <p:nvPr>
+            <p:ph type="body" idx="1"/>
+          </p:nvPr>
+        </p:nvSpPr>
+        <p:spPr/>
+        <p:txBody>
+          <a:bodyPr/>
+          <a:lstStyle/>
+          <a:p>
+            <a:r>
+              <a:rPr lang="en-US" dirty="0"/>
+              <a:t/>
+            </a:r>
+            <a:endParaRPr lang="en-US" dirty="0"/>
+          </a:p>
+        </p:txBody>
+      </p:sp>
+      <p:sp>
+        <p:nvSpPr>
+          <p:cNvPr id="4" name="Slide Number Placeholder 3"/>
+          <p:cNvSpPr>
+            <a:spLocks noGrp="1"/>
+          </p:cNvSpPr>
+          <p:nvPr>
+            <p:ph type="sldNum" sz="quarter" idx="10"/>
+          </p:nvPr>
+        </p:nvSpPr>
+        <p:spPr/>
+        <p:txBody>
+          <a:bodyPr/>
+          <a:lstStyle/>
+          <a:p>
+            <a:fld id="{F7021451-1387-4CA6-816F-3879F97B5CBC}" type="slidenum">
+              <a:rPr lang="en-US"/>
+              <a:t>53</a:t>
+            </a:fld>
+            <a:endParaRPr lang="en-US"/>
+          </a:p>
+        </p:txBody>
+      </p:sp>
+    </p:spTree>
+    <p:extLst>
+      <p:ext uri="{BB962C8B-B14F-4D97-AF65-F5344CB8AC3E}">
+        <p14:creationId xmlns:p14="http://schemas.microsoft.com/office/powerpoint/2010/main" val="1024086991"/>
+      </p:ext>
+    </p:extLst>
+  </p:cSld>
+  <p:clrMapOvr>
+    <a:masterClrMapping/>
+  </p:clrMapOvr>
+</p:notes>
+</file>
+
+<file path=ppt/notesSlides/notesSlide54.xml><?xml version="1.0" encoding="utf-8"?>
+<p:notes xmlns:a="http://schemas.openxmlformats.org/drawingml/2006/main" xmlns:r="http://schemas.openxmlformats.org/officeDocument/2006/relationships" xmlns:p="http://schemas.openxmlformats.org/presentationml/2006/main">
+  <p:cSld>
+    <p:spTree>
+      <p:nvGrpSpPr>
+        <p:cNvPr id="1" name=""/>
+        <p:cNvGrpSpPr/>
+        <p:nvPr/>
+      </p:nvGrpSpPr>
+      <p:grpSpPr>
+        <a:xfrm>
+          <a:off x="0" y="0"/>
+          <a:ext cx="0" cy="0"/>
+          <a:chOff x="0" y="0"/>
+          <a:chExt cx="0" cy="0"/>
+        </a:xfrm>
+      </p:grpSpPr>
+      <p:sp>
+        <p:nvSpPr>
+          <p:cNvPr id="2" name="Slide Image Placeholder 1"/>
+          <p:cNvSpPr>
+            <a:spLocks noGrp="1" noRot="1" noChangeAspect="1"/>
+          </p:cNvSpPr>
+          <p:nvPr>
+            <p:ph type="sldImg"/>
+          </p:nvPr>
+        </p:nvSpPr>
+        <p:spPr/>
+      </p:sp>
+      <p:sp>
+        <p:nvSpPr>
+          <p:cNvPr id="3" name="Notes Placeholder 2"/>
+          <p:cNvSpPr>
+            <a:spLocks noGrp="1"/>
+          </p:cNvSpPr>
+          <p:nvPr>
+            <p:ph type="body" idx="1"/>
+          </p:nvPr>
+        </p:nvSpPr>
+        <p:spPr/>
+        <p:txBody>
+          <a:bodyPr/>
+          <a:lstStyle/>
+          <a:p>
+            <a:r>
+              <a:rPr lang="en-US" dirty="0"/>
+              <a:t/>
+            </a:r>
+            <a:endParaRPr lang="en-US" dirty="0"/>
+          </a:p>
+        </p:txBody>
+      </p:sp>
+      <p:sp>
+        <p:nvSpPr>
+          <p:cNvPr id="4" name="Slide Number Placeholder 3"/>
+          <p:cNvSpPr>
+            <a:spLocks noGrp="1"/>
+          </p:cNvSpPr>
+          <p:nvPr>
+            <p:ph type="sldNum" sz="quarter" idx="10"/>
+          </p:nvPr>
+        </p:nvSpPr>
+        <p:spPr/>
+        <p:txBody>
+          <a:bodyPr/>
+          <a:lstStyle/>
+          <a:p>
+            <a:fld id="{F7021451-1387-4CA6-816F-3879F97B5CBC}" type="slidenum">
+              <a:rPr lang="en-US"/>
+              <a:t>54</a:t>
+            </a:fld>
+            <a:endParaRPr lang="en-US"/>
+          </a:p>
+        </p:txBody>
+      </p:sp>
+    </p:spTree>
+    <p:extLst>
+      <p:ext uri="{BB962C8B-B14F-4D97-AF65-F5344CB8AC3E}">
+        <p14:creationId xmlns:p14="http://schemas.microsoft.com/office/powerpoint/2010/main" val="1024086991"/>
+      </p:ext>
+    </p:extLst>
+  </p:cSld>
+  <p:clrMapOvr>
+    <a:masterClrMapping/>
+  </p:clrMapOvr>
+</p:notes>
+</file>
+
+<file path=ppt/notesSlides/notesSlide55.xml><?xml version="1.0" encoding="utf-8"?>
+<p:notes xmlns:a="http://schemas.openxmlformats.org/drawingml/2006/main" xmlns:r="http://schemas.openxmlformats.org/officeDocument/2006/relationships" xmlns:p="http://schemas.openxmlformats.org/presentationml/2006/main">
+  <p:cSld>
+    <p:spTree>
+      <p:nvGrpSpPr>
+        <p:cNvPr id="1" name=""/>
+        <p:cNvGrpSpPr/>
+        <p:nvPr/>
+      </p:nvGrpSpPr>
+      <p:grpSpPr>
+        <a:xfrm>
+          <a:off x="0" y="0"/>
+          <a:ext cx="0" cy="0"/>
+          <a:chOff x="0" y="0"/>
+          <a:chExt cx="0" cy="0"/>
+        </a:xfrm>
+      </p:grpSpPr>
+      <p:sp>
+        <p:nvSpPr>
+          <p:cNvPr id="2" name="Slide Image Placeholder 1"/>
+          <p:cNvSpPr>
+            <a:spLocks noGrp="1" noRot="1" noChangeAspect="1"/>
+          </p:cNvSpPr>
+          <p:nvPr>
+            <p:ph type="sldImg"/>
+          </p:nvPr>
+        </p:nvSpPr>
+        <p:spPr/>
+      </p:sp>
+      <p:sp>
+        <p:nvSpPr>
+          <p:cNvPr id="3" name="Notes Placeholder 2"/>
+          <p:cNvSpPr>
+            <a:spLocks noGrp="1"/>
+          </p:cNvSpPr>
+          <p:nvPr>
+            <p:ph type="body" idx="1"/>
+          </p:nvPr>
+        </p:nvSpPr>
+        <p:spPr/>
+        <p:txBody>
+          <a:bodyPr/>
+          <a:lstStyle/>
+          <a:p>
+            <a:r>
+              <a:rPr lang="en-US" dirty="0"/>
+              <a:t/>
+            </a:r>
+            <a:endParaRPr lang="en-US" dirty="0"/>
+          </a:p>
+        </p:txBody>
+      </p:sp>
+      <p:sp>
+        <p:nvSpPr>
+          <p:cNvPr id="4" name="Slide Number Placeholder 3"/>
+          <p:cNvSpPr>
+            <a:spLocks noGrp="1"/>
+          </p:cNvSpPr>
+          <p:nvPr>
+            <p:ph type="sldNum" sz="quarter" idx="10"/>
+          </p:nvPr>
+        </p:nvSpPr>
+        <p:spPr/>
+        <p:txBody>
+          <a:bodyPr/>
+          <a:lstStyle/>
+          <a:p>
+            <a:fld id="{F7021451-1387-4CA6-816F-3879F97B5CBC}" type="slidenum">
+              <a:rPr lang="en-US"/>
+              <a:t>55</a:t>
             </a:fld>
             <a:endParaRPr lang="en-US"/>
           </a:p>
@@ -38177,7 +38721,7 @@
                   <a:schemeClr val="bg1"/>
                 </a:solidFill>
               </a:rPr>
-              <a:t>안전하게, 자주 반복하기</a:t>
+              <a:t>도메인: 주소와 업계 지식</a:t>
             </a:r>
             <a:endParaRPr lang="en-US" sz="4000" dirty="0"/>
           </a:p>
@@ -38215,21 +38759,7 @@
                   <a:schemeClr val="bg2"/>
                 </a:solidFill>
               </a:rPr>
-              <a:t>기획 → 백업 → 연습용 사이트에서 수정 → 확인 → 배포 → 감시 → 숫자 보기 → 다시 기획</a:t>
-            </a:r>
-            <a:endParaRPr lang="en-US" sz="1800" dirty="0"/>
-          </a:p>
-          <a:p>
-            <a:pPr algn="l" indent="0" marL="0">
-              <a:buNone/>
-            </a:pPr>
-            <a:r>
-              <a:rPr lang="en-US" sz="1800" dirty="0">
-                <a:solidFill>
-                  <a:schemeClr val="bg2"/>
-                </a:solidFill>
-              </a:rPr>
-              <a:t>다음 할 일: docs/13-practice-scenario.md 를 읽고 15장 퀴즈 풀기</a:t>
+              <a:t>도메인 이름(사이트 주소) 고르기·연결·지키기 · 업계 지식(도메인 지식) 분야별 흐름 — 34–35장</a:t>
             </a:r>
             <a:endParaRPr lang="en-US" sz="1800" dirty="0"/>
           </a:p>
@@ -39131,6 +39661,3921 @@
               <a:t>5</a:t>
             </a:fld>
             <a:endParaRPr lang="en-US"/>
+          </a:p>
+        </p:txBody>
+      </p:sp>
+    </p:spTree>
+  </p:cSld>
+  <p:clrMapOvr>
+    <a:masterClrMapping/>
+  </p:clrMapOvr>
+</p:sld>
+</file>
+
+<file path=ppt/slides/slide50.xml><?xml version="1.0" encoding="utf-8"?>
+<p:sld xmlns:a="http://schemas.openxmlformats.org/drawingml/2006/main" xmlns:r="http://schemas.openxmlformats.org/officeDocument/2006/relationships" xmlns:p="http://schemas.openxmlformats.org/presentationml/2006/main">
+  <p:cSld name="Slide 50">
+    <p:spTree>
+      <p:nvGrpSpPr>
+        <p:cNvPr id="1" name=""/>
+        <p:cNvGrpSpPr/>
+        <p:nvPr/>
+      </p:nvGrpSpPr>
+      <p:grpSpPr>
+        <a:xfrm>
+          <a:off x="0" y="0"/>
+          <a:ext cx="0" cy="0"/>
+          <a:chOff x="0" y="0"/>
+          <a:chExt cx="0" cy="0"/>
+        </a:xfrm>
+      </p:grpSpPr>
+      <p:sp>
+        <p:nvSpPr>
+          <p:cNvPr id="2" name="Text 0"/>
+          <p:cNvSpPr/>
+          <p:nvPr>
+            <p:ph idx="100" type="title" hasCustomPrompt="1"/>
+          </p:nvPr>
+        </p:nvSpPr>
+        <p:spPr>
+          <a:xfrm>
+            <a:off x="457200" y="274320"/>
+            <a:ext cx="8229600" cy="685800"/>
+          </a:xfrm>
+          <a:prstGeom prst="rect">
+            <a:avLst/>
+          </a:prstGeom>
+          <a:noFill/>
+          <a:ln/>
+        </p:spPr>
+        <p:txBody>
+          <a:bodyPr wrap="square" lIns="0" tIns="0" rIns="0" bIns="0" rtlCol="0" anchor="ctr"/>
+          <a:lstStyle/>
+          <a:p>
+            <a:pPr indent="0" marL="0">
+              <a:buNone/>
+            </a:pPr>
+            <a:r>
+              <a:rPr lang="en-US" sz="2800" b="1" dirty="0">
+                <a:solidFill>
+                  <a:schemeClr val="tx2"/>
+                </a:solidFill>
+              </a:rPr>
+              <a:t>도메인 주소 읽기와 고르기</a:t>
+            </a:r>
+            <a:endParaRPr lang="en-US" sz="2800" dirty="0"/>
+          </a:p>
+        </p:txBody>
+      </p:sp>
+      <p:sp>
+        <p:nvSpPr>
+          <p:cNvPr id="3" name="urlbar"/>
+          <p:cNvSpPr/>
+          <p:nvPr/>
+        </p:nvSpPr>
+        <p:spPr>
+          <a:xfrm>
+            <a:off x="457200" y="1188720"/>
+            <a:ext cx="8229600" cy="822960"/>
+          </a:xfrm>
+          <a:prstGeom prst="roundRect">
+            <a:avLst>
+              <a:gd name="adj" fmla="val 8889"/>
+            </a:avLst>
+          </a:prstGeom>
+          <a:solidFill>
+            <a:schemeClr val="tx1"/>
+          </a:solidFill>
+          <a:ln/>
+        </p:spPr>
+      </p:sp>
+      <p:sp>
+        <p:nvSpPr>
+          <p:cNvPr id="4" name="Text 2"/>
+          <p:cNvSpPr txBox="1"/>
+          <p:nvPr/>
+        </p:nvSpPr>
+        <p:spPr>
+          <a:xfrm>
+            <a:off x="731520" y="1188720"/>
+            <a:ext cx="7680960" cy="822960"/>
+          </a:xfrm>
+          <a:prstGeom prst="rect">
+            <a:avLst/>
+          </a:prstGeom>
+          <a:noFill/>
+          <a:ln/>
+        </p:spPr>
+        <p:txBody>
+          <a:bodyPr wrap="square" lIns="0" tIns="0" rIns="0" bIns="0" rtlCol="0" anchor="ctr"/>
+          <a:lstStyle/>
+          <a:p>
+            <a:pPr indent="0" marL="0">
+              <a:buNone/>
+            </a:pPr>
+            <a:r>
+              <a:rPr lang="en-US" sz="2400" dirty="0">
+                <a:solidFill>
+                  <a:schemeClr val="accent4"/>
+                </a:solidFill>
+                <a:latin typeface="Courier New" pitchFamily="34" charset="0"/>
+                <a:ea typeface="Courier New" pitchFamily="34" charset="-122"/>
+                <a:cs typeface="Courier New" pitchFamily="34" charset="-120"/>
+              </a:rPr>
+              <a:t>https://</a:t>
+            </a:r>
+            <a:pPr indent="0" marL="0">
+              <a:buNone/>
+            </a:pPr>
+            <a:r>
+              <a:rPr lang="en-US" sz="2400" b="1" dirty="0">
+                <a:solidFill>
+                  <a:schemeClr val="accent6"/>
+                </a:solidFill>
+                <a:latin typeface="Courier New" pitchFamily="34" charset="0"/>
+                <a:ea typeface="Courier New" pitchFamily="34" charset="-122"/>
+                <a:cs typeface="Courier New" pitchFamily="34" charset="-120"/>
+              </a:rPr>
+              <a:t>shop</a:t>
+            </a:r>
+            <a:pPr indent="0" marL="0">
+              <a:buNone/>
+            </a:pPr>
+            <a:r>
+              <a:rPr lang="en-US" sz="2400" dirty="0">
+                <a:solidFill>
+                  <a:schemeClr val="bg1"/>
+                </a:solidFill>
+                <a:latin typeface="Courier New" pitchFamily="34" charset="0"/>
+                <a:ea typeface="Courier New" pitchFamily="34" charset="-122"/>
+                <a:cs typeface="Courier New" pitchFamily="34" charset="-120"/>
+              </a:rPr>
+              <a:t>.</a:t>
+            </a:r>
+            <a:pPr indent="0" marL="0">
+              <a:buNone/>
+            </a:pPr>
+            <a:r>
+              <a:rPr lang="en-US" sz="2400" b="1" dirty="0">
+                <a:solidFill>
+                  <a:schemeClr val="bg1"/>
+                </a:solidFill>
+                <a:latin typeface="Courier New" pitchFamily="34" charset="0"/>
+                <a:ea typeface="Courier New" pitchFamily="34" charset="-122"/>
+                <a:cs typeface="Courier New" pitchFamily="34" charset="-120"/>
+              </a:rPr>
+              <a:t>granolalab</a:t>
+            </a:r>
+            <a:pPr indent="0" marL="0">
+              <a:buNone/>
+            </a:pPr>
+            <a:r>
+              <a:rPr lang="en-US" sz="2400" b="1" dirty="0">
+                <a:solidFill>
+                  <a:schemeClr val="accent2"/>
+                </a:solidFill>
+                <a:latin typeface="Courier New" pitchFamily="34" charset="0"/>
+                <a:ea typeface="Courier New" pitchFamily="34" charset="-122"/>
+                <a:cs typeface="Courier New" pitchFamily="34" charset="-120"/>
+              </a:rPr>
+              <a:t>.co.kr</a:t>
+            </a:r>
+            <a:pPr indent="0" marL="0">
+              <a:buNone/>
+            </a:pPr>
+            <a:r>
+              <a:rPr lang="en-US" sz="2400" dirty="0">
+                <a:solidFill>
+                  <a:schemeClr val="accent4"/>
+                </a:solidFill>
+                <a:latin typeface="Courier New" pitchFamily="34" charset="0"/>
+                <a:ea typeface="Courier New" pitchFamily="34" charset="-122"/>
+                <a:cs typeface="Courier New" pitchFamily="34" charset="-120"/>
+              </a:rPr>
+              <a:t>/products</a:t>
+            </a:r>
+            <a:endParaRPr lang="en-US" sz="2400" dirty="0"/>
+          </a:p>
+        </p:txBody>
+      </p:sp>
+      <p:sp>
+        <p:nvSpPr>
+          <p:cNvPr id="5" name="card"/>
+          <p:cNvSpPr/>
+          <p:nvPr/>
+        </p:nvSpPr>
+        <p:spPr>
+          <a:xfrm>
+            <a:off x="457200" y="2240280"/>
+            <a:ext cx="2606040" cy="914400"/>
+          </a:xfrm>
+          <a:prstGeom prst="roundRect">
+            <a:avLst>
+              <a:gd name="adj" fmla="val 8000"/>
+            </a:avLst>
+          </a:prstGeom>
+          <a:solidFill>
+            <a:schemeClr val="bg2"/>
+          </a:solidFill>
+          <a:ln/>
+        </p:spPr>
+      </p:sp>
+      <p:sp>
+        <p:nvSpPr>
+          <p:cNvPr id="6" name="Text 4"/>
+          <p:cNvSpPr txBox="1"/>
+          <p:nvPr/>
+        </p:nvSpPr>
+        <p:spPr>
+          <a:xfrm>
+            <a:off x="640080" y="2286000"/>
+            <a:ext cx="2286000" cy="822960"/>
+          </a:xfrm>
+          <a:prstGeom prst="rect">
+            <a:avLst/>
+          </a:prstGeom>
+          <a:noFill/>
+          <a:ln/>
+        </p:spPr>
+        <p:txBody>
+          <a:bodyPr wrap="square" lIns="0" tIns="0" rIns="0" bIns="0" rtlCol="0" anchor="ctr"/>
+          <a:lstStyle/>
+          <a:p>
+            <a:pPr indent="0" marL="0">
+              <a:buNone/>
+            </a:pPr>
+            <a:r>
+              <a:rPr lang="en-US" sz="1500" b="1" dirty="0">
+                <a:solidFill>
+                  <a:schemeClr val="accent3"/>
+                </a:solidFill>
+              </a:rPr>
+              <a:t>서브도메인</a:t>
+            </a:r>
+            <a:endParaRPr lang="en-US" sz="1500" dirty="0"/>
+          </a:p>
+          <a:p>
+            <a:pPr indent="0" marL="0">
+              <a:buNone/>
+            </a:pPr>
+            <a:r>
+              <a:rPr lang="en-US" sz="1200" dirty="0">
+                <a:solidFill>
+                  <a:schemeClr val="tx1"/>
+                </a:solidFill>
+              </a:rPr>
+              <a:t>shop — 마음대로 추가</a:t>
+            </a:r>
+            <a:endParaRPr lang="en-US" sz="1500" dirty="0"/>
+          </a:p>
+        </p:txBody>
+      </p:sp>
+      <p:sp>
+        <p:nvSpPr>
+          <p:cNvPr id="7" name="card"/>
+          <p:cNvSpPr/>
+          <p:nvPr/>
+        </p:nvSpPr>
+        <p:spPr>
+          <a:xfrm>
+            <a:off x="3246120" y="2240280"/>
+            <a:ext cx="2606040" cy="914400"/>
+          </a:xfrm>
+          <a:prstGeom prst="roundRect">
+            <a:avLst>
+              <a:gd name="adj" fmla="val 8000"/>
+            </a:avLst>
+          </a:prstGeom>
+          <a:solidFill>
+            <a:schemeClr val="bg2"/>
+          </a:solidFill>
+          <a:ln/>
+        </p:spPr>
+      </p:sp>
+      <p:sp>
+        <p:nvSpPr>
+          <p:cNvPr id="8" name="Text 6"/>
+          <p:cNvSpPr txBox="1"/>
+          <p:nvPr/>
+        </p:nvSpPr>
+        <p:spPr>
+          <a:xfrm>
+            <a:off x="3429000" y="2286000"/>
+            <a:ext cx="2286000" cy="822960"/>
+          </a:xfrm>
+          <a:prstGeom prst="rect">
+            <a:avLst/>
+          </a:prstGeom>
+          <a:noFill/>
+          <a:ln/>
+        </p:spPr>
+        <p:txBody>
+          <a:bodyPr wrap="square" lIns="0" tIns="0" rIns="0" bIns="0" rtlCol="0" anchor="ctr"/>
+          <a:lstStyle/>
+          <a:p>
+            <a:pPr indent="0" marL="0">
+              <a:buNone/>
+            </a:pPr>
+            <a:r>
+              <a:rPr lang="en-US" sz="1500" b="1" dirty="0">
+                <a:solidFill>
+                  <a:schemeClr val="tx2"/>
+                </a:solidFill>
+              </a:rPr>
+              <a:t>도메인 이름</a:t>
+            </a:r>
+            <a:endParaRPr lang="en-US" sz="1500" dirty="0"/>
+          </a:p>
+          <a:p>
+            <a:pPr indent="0" marL="0">
+              <a:buNone/>
+            </a:pPr>
+            <a:r>
+              <a:rPr lang="en-US" sz="1200" dirty="0">
+                <a:solidFill>
+                  <a:schemeClr val="tx1"/>
+                </a:solidFill>
+              </a:rPr>
+              <a:t>granolalab — 내가 빌린 이름</a:t>
+            </a:r>
+            <a:endParaRPr lang="en-US" sz="1500" dirty="0"/>
+          </a:p>
+        </p:txBody>
+      </p:sp>
+      <p:sp>
+        <p:nvSpPr>
+          <p:cNvPr id="9" name="card"/>
+          <p:cNvSpPr/>
+          <p:nvPr/>
+        </p:nvSpPr>
+        <p:spPr>
+          <a:xfrm>
+            <a:off x="6035040" y="2240280"/>
+            <a:ext cx="2606040" cy="914400"/>
+          </a:xfrm>
+          <a:prstGeom prst="roundRect">
+            <a:avLst>
+              <a:gd name="adj" fmla="val 8000"/>
+            </a:avLst>
+          </a:prstGeom>
+          <a:solidFill>
+            <a:schemeClr val="bg2"/>
+          </a:solidFill>
+          <a:ln/>
+        </p:spPr>
+      </p:sp>
+      <p:sp>
+        <p:nvSpPr>
+          <p:cNvPr id="10" name="Text 8"/>
+          <p:cNvSpPr txBox="1"/>
+          <p:nvPr/>
+        </p:nvSpPr>
+        <p:spPr>
+          <a:xfrm>
+            <a:off x="6217920" y="2286000"/>
+            <a:ext cx="2286000" cy="822960"/>
+          </a:xfrm>
+          <a:prstGeom prst="rect">
+            <a:avLst/>
+          </a:prstGeom>
+          <a:noFill/>
+          <a:ln/>
+        </p:spPr>
+        <p:txBody>
+          <a:bodyPr wrap="square" lIns="0" tIns="0" rIns="0" bIns="0" rtlCol="0" anchor="ctr"/>
+          <a:lstStyle/>
+          <a:p>
+            <a:pPr indent="0" marL="0">
+              <a:buNone/>
+            </a:pPr>
+            <a:r>
+              <a:rPr lang="en-US" sz="1500" b="1" dirty="0">
+                <a:solidFill>
+                  <a:schemeClr val="accent2"/>
+                </a:solidFill>
+              </a:rPr>
+              <a:t>TLD</a:t>
+            </a:r>
+            <a:endParaRPr lang="en-US" sz="1500" dirty="0"/>
+          </a:p>
+          <a:p>
+            <a:pPr indent="0" marL="0">
+              <a:buNone/>
+            </a:pPr>
+            <a:r>
+              <a:rPr lang="en-US" sz="1200" dirty="0">
+                <a:solidFill>
+                  <a:schemeClr val="tx1"/>
+                </a:solidFill>
+              </a:rPr>
+              <a:t>.co.kr — 종류·나라</a:t>
+            </a:r>
+            <a:endParaRPr lang="en-US" sz="1500" dirty="0"/>
+          </a:p>
+        </p:txBody>
+      </p:sp>
+      <p:sp>
+        <p:nvSpPr>
+          <p:cNvPr id="11" name="Text 9"/>
+          <p:cNvSpPr txBox="1"/>
+          <p:nvPr/>
+        </p:nvSpPr>
+        <p:spPr>
+          <a:xfrm>
+            <a:off x="457200" y="3383280"/>
+            <a:ext cx="8229600" cy="1097280"/>
+          </a:xfrm>
+          <a:prstGeom prst="rect">
+            <a:avLst/>
+          </a:prstGeom>
+          <a:noFill/>
+          <a:ln/>
+        </p:spPr>
+        <p:txBody>
+          <a:bodyPr wrap="square" lIns="0" tIns="0" rIns="0" bIns="0" rtlCol="0" anchor="t"/>
+          <a:lstStyle/>
+          <a:p>
+            <a:pPr marL="342900" indent="-342900">
+              <a:spcAft>
+                <a:spcPts val="600"/>
+              </a:spcAft>
+              <a:buSzPct val="100000"/>
+              <a:buChar char="•"/>
+            </a:pPr>
+            <a:r>
+              <a:rPr lang="en-US" sz="1300" dirty="0">
+                <a:solidFill>
+                  <a:schemeClr val="tx1"/>
+                </a:solidFill>
+              </a:rPr>
+              <a:t>한국 손님 위주 → .kr / .co.kr, 해외도 → .com</a:t>
+            </a:r>
+            <a:endParaRPr lang="en-US" sz="1300" dirty="0"/>
+          </a:p>
+          <a:p>
+            <a:pPr marL="342900" indent="-342900">
+              <a:spcAft>
+                <a:spcPts val="600"/>
+              </a:spcAft>
+              <a:buSzPct val="100000"/>
+              <a:buChar char="•"/>
+            </a:pPr>
+            <a:r>
+              <a:rPr lang="en-US" sz="1300" dirty="0">
+                <a:solidFill>
+                  <a:schemeClr val="tx1"/>
+                </a:solidFill>
+              </a:rPr>
+              <a:t>짧고 말로 불러도 헷갈리지 않게 (하이픈·숫자 피하기)</a:t>
+            </a:r>
+            <a:endParaRPr lang="en-US" sz="1300" dirty="0"/>
+          </a:p>
+          <a:p>
+            <a:pPr marL="342900" indent="-342900">
+              <a:spcAft>
+                <a:spcPts val="600"/>
+              </a:spcAft>
+              <a:buSzPct val="100000"/>
+              <a:buChar char="•"/>
+            </a:pPr>
+            <a:r>
+              <a:rPr lang="en-US" sz="1300" dirty="0">
+                <a:solidFill>
+                  <a:schemeClr val="tx1"/>
+                </a:solidFill>
+              </a:rPr>
+              <a:t>첫해 할인보다 갱신 가격 확인 · 상표 검색 · 방어 등록</a:t>
+            </a:r>
+            <a:endParaRPr lang="en-US" sz="1300" dirty="0"/>
+          </a:p>
+        </p:txBody>
+      </p:sp>
+      <p:sp>
+        <p:nvSpPr>
+          <p:cNvPr id="25" name="Slide Number Placeholder 0"/>
+          <p:cNvSpPr>
+            <a:spLocks noGrp="1"/>
+          </p:cNvSpPr>
+          <p:nvPr>
+            <p:ph type="sldNum" sz="quarter" idx="4294967295"/>
+          </p:nvPr>
+        </p:nvSpPr>
+        <p:spPr>
+          <a:xfrm>
+            <a:off x="8321040" y="4754880"/>
+            <a:ext cx="457200" cy="274320"/>
+          </a:xfrm>
+          <a:prstGeom prst="rect">
+            <a:avLst/>
+          </a:prstGeom>
+          <a:extLst>
+            <a:ext uri="{C572A759-6A51-4108-AA02-DFA0A04FC94B}">
+              <ma14:wrappingTextBoxFlag xmlns:ma14="http://schemas.microsoft.com/office/mac/drawingml/2011/main" val="0"/>
+            </a:ext>
+          </a:extLst>
+        </p:spPr>
+        <p:txBody>
+          <a:bodyPr/>
+          <a:lstStyle>
+            <a:lvl1pPr>
+              <a:defRPr sz="1000">
+                <a:solidFill>
+                  <a:schemeClr val="accent4"/>
+                </a:solidFill>
+              </a:defRPr>
+            </a:lvl1pPr>
+          </a:lstStyle>
+          <a:p>
+            <a:pPr algn="r"/>
+            <a:fld id="{F7021451-1387-4CA6-816F-3879F97B5CBC}" type="slidenum">
+              <a:rPr b="0" lang="en-US"/>
+              <a:t>50</a:t>
+            </a:fld>
+            <a:endParaRPr lang="en-US"/>
+          </a:p>
+        </p:txBody>
+      </p:sp>
+    </p:spTree>
+  </p:cSld>
+  <p:clrMapOvr>
+    <a:masterClrMapping/>
+  </p:clrMapOvr>
+</p:sld>
+</file>
+
+<file path=ppt/slides/slide51.xml><?xml version="1.0" encoding="utf-8"?>
+<p:sld xmlns:a="http://schemas.openxmlformats.org/drawingml/2006/main" xmlns:r="http://schemas.openxmlformats.org/officeDocument/2006/relationships" xmlns:p="http://schemas.openxmlformats.org/presentationml/2006/main">
+  <p:cSld name="Slide 51">
+    <p:spTree>
+      <p:nvGrpSpPr>
+        <p:cNvPr id="1" name=""/>
+        <p:cNvGrpSpPr/>
+        <p:nvPr/>
+      </p:nvGrpSpPr>
+      <p:grpSpPr>
+        <a:xfrm>
+          <a:off x="0" y="0"/>
+          <a:ext cx="0" cy="0"/>
+          <a:chOff x="0" y="0"/>
+          <a:chExt cx="0" cy="0"/>
+        </a:xfrm>
+      </p:grpSpPr>
+      <p:sp>
+        <p:nvSpPr>
+          <p:cNvPr id="2" name="Text 0"/>
+          <p:cNvSpPr/>
+          <p:nvPr>
+            <p:ph idx="100" type="title" hasCustomPrompt="1"/>
+          </p:nvPr>
+        </p:nvSpPr>
+        <p:spPr>
+          <a:xfrm>
+            <a:off x="457200" y="274320"/>
+            <a:ext cx="8229600" cy="685800"/>
+          </a:xfrm>
+          <a:prstGeom prst="rect">
+            <a:avLst/>
+          </a:prstGeom>
+          <a:noFill/>
+          <a:ln/>
+        </p:spPr>
+        <p:txBody>
+          <a:bodyPr wrap="square" lIns="0" tIns="0" rIns="0" bIns="0" rtlCol="0" anchor="ctr"/>
+          <a:lstStyle/>
+          <a:p>
+            <a:pPr indent="0" marL="0">
+              <a:buNone/>
+            </a:pPr>
+            <a:r>
+              <a:rPr lang="en-US" sz="2800" b="1" dirty="0">
+                <a:solidFill>
+                  <a:schemeClr val="tx2"/>
+                </a:solidFill>
+              </a:rPr>
+              <a:t>도메인은 빌리는 것: 연결하고 지키기</a:t>
+            </a:r>
+            <a:endParaRPr lang="en-US" sz="2800" dirty="0"/>
+          </a:p>
+        </p:txBody>
+      </p:sp>
+      <p:sp>
+        <p:nvSpPr>
+          <p:cNvPr id="3" name="Text 1"/>
+          <p:cNvSpPr txBox="1"/>
+          <p:nvPr/>
+        </p:nvSpPr>
+        <p:spPr>
+          <a:xfrm>
+            <a:off x="457200" y="1188720"/>
+            <a:ext cx="3840480" cy="365760"/>
+          </a:xfrm>
+          <a:prstGeom prst="rect">
+            <a:avLst/>
+          </a:prstGeom>
+          <a:noFill/>
+          <a:ln/>
+        </p:spPr>
+        <p:txBody>
+          <a:bodyPr wrap="square" lIns="0" tIns="0" rIns="0" bIns="0" rtlCol="0" anchor="t"/>
+          <a:lstStyle/>
+          <a:p>
+            <a:pPr indent="0" marL="0">
+              <a:buNone/>
+            </a:pPr>
+            <a:r>
+              <a:rPr lang="en-US" sz="1600" b="1" dirty="0">
+                <a:solidFill>
+                  <a:schemeClr val="accent2"/>
+                </a:solidFill>
+              </a:rPr>
+              <a:t>사자마자 할 일</a:t>
+            </a:r>
+            <a:endParaRPr lang="en-US" sz="1600" dirty="0"/>
+          </a:p>
+        </p:txBody>
+      </p:sp>
+      <p:sp>
+        <p:nvSpPr>
+          <p:cNvPr id="4" name="Text 2"/>
+          <p:cNvSpPr txBox="1"/>
+          <p:nvPr/>
+        </p:nvSpPr>
+        <p:spPr>
+          <a:xfrm>
+            <a:off x="457200" y="1645920"/>
+            <a:ext cx="3931920" cy="2651760"/>
+          </a:xfrm>
+          <a:prstGeom prst="rect">
+            <a:avLst/>
+          </a:prstGeom>
+          <a:noFill/>
+          <a:ln/>
+        </p:spPr>
+        <p:txBody>
+          <a:bodyPr wrap="square" lIns="0" tIns="0" rIns="0" bIns="0" rtlCol="0" anchor="t"/>
+          <a:lstStyle/>
+          <a:p>
+            <a:pPr marL="342900" indent="-342900">
+              <a:spcAft>
+                <a:spcPts val="800"/>
+              </a:spcAft>
+              <a:buSzPct val="100000"/>
+              <a:buChar char="•"/>
+            </a:pPr>
+            <a:r>
+              <a:rPr lang="en-US" sz="1400" dirty="0">
+                <a:solidFill>
+                  <a:schemeClr val="tx1"/>
+                </a:solidFill>
+              </a:rPr>
+              <a:t>내 명의 · 공용 이메일</a:t>
+            </a:r>
+            <a:endParaRPr lang="en-US" sz="1400" dirty="0"/>
+          </a:p>
+          <a:p>
+            <a:pPr marL="342900" indent="-342900">
+              <a:spcAft>
+                <a:spcPts val="800"/>
+              </a:spcAft>
+              <a:buSzPct val="100000"/>
+              <a:buChar char="•"/>
+            </a:pPr>
+            <a:r>
+              <a:rPr lang="en-US" sz="1400" dirty="0">
+                <a:solidFill>
+                  <a:schemeClr val="tx1"/>
+                </a:solidFill>
+              </a:rPr>
+              <a:t>자동 갱신 ON + 카드 만료일 확인</a:t>
+            </a:r>
+            <a:endParaRPr lang="en-US" sz="1400" dirty="0"/>
+          </a:p>
+          <a:p>
+            <a:pPr marL="342900" indent="-342900">
+              <a:spcAft>
+                <a:spcPts val="800"/>
+              </a:spcAft>
+              <a:buSzPct val="100000"/>
+              <a:buChar char="•"/>
+            </a:pPr>
+            <a:r>
+              <a:rPr lang="en-US" sz="1400" dirty="0">
+                <a:solidFill>
+                  <a:schemeClr val="tx1"/>
+                </a:solidFill>
+              </a:rPr>
+              <a:t>등록 업체 2단계 인증 · 도메인 잠금</a:t>
+            </a:r>
+            <a:endParaRPr lang="en-US" sz="1400" dirty="0"/>
+          </a:p>
+          <a:p>
+            <a:pPr marL="342900" indent="-342900">
+              <a:spcAft>
+                <a:spcPts val="800"/>
+              </a:spcAft>
+              <a:buSzPct val="100000"/>
+              <a:buChar char="•"/>
+            </a:pPr>
+            <a:r>
+              <a:rPr lang="en-US" sz="1400" dirty="0">
+                <a:solidFill>
+                  <a:schemeClr val="tx1"/>
+                </a:solidFill>
+              </a:rPr>
+              <a:t>DNS: A · CNAME(사이트), MX · TXT(메일)</a:t>
+            </a:r>
+            <a:endParaRPr lang="en-US" sz="1400" dirty="0"/>
+          </a:p>
+          <a:p>
+            <a:pPr marL="342900" indent="-342900">
+              <a:spcAft>
+                <a:spcPts val="800"/>
+              </a:spcAft>
+              <a:buSzPct val="100000"/>
+              <a:buChar char="•"/>
+            </a:pPr>
+            <a:r>
+              <a:rPr lang="en-US" sz="1400" dirty="0">
+                <a:solidFill>
+                  <a:schemeClr val="tx1"/>
+                </a:solidFill>
+              </a:rPr>
+              <a:t>바꾸기 전 DNS 설정 캡처</a:t>
+            </a:r>
+            <a:endParaRPr lang="en-US" sz="1400" dirty="0"/>
+          </a:p>
+        </p:txBody>
+      </p:sp>
+      <p:sp>
+        <p:nvSpPr>
+          <p:cNvPr id="5" name="card"/>
+          <p:cNvSpPr/>
+          <p:nvPr/>
+        </p:nvSpPr>
+        <p:spPr>
+          <a:xfrm>
+            <a:off x="4572000" y="1188720"/>
+            <a:ext cx="4114800" cy="3200400"/>
+          </a:xfrm>
+          <a:prstGeom prst="roundRect">
+            <a:avLst>
+              <a:gd name="adj" fmla="val 2286"/>
+            </a:avLst>
+          </a:prstGeom>
+          <a:solidFill>
+            <a:schemeClr val="bg2"/>
+          </a:solidFill>
+          <a:ln/>
+        </p:spPr>
+      </p:sp>
+      <p:sp>
+        <p:nvSpPr>
+          <p:cNvPr id="6" name="Text 4"/>
+          <p:cNvSpPr txBox="1"/>
+          <p:nvPr/>
+        </p:nvSpPr>
+        <p:spPr>
+          <a:xfrm>
+            <a:off x="4800600" y="1325880"/>
+            <a:ext cx="3657600" cy="365760"/>
+          </a:xfrm>
+          <a:prstGeom prst="rect">
+            <a:avLst/>
+          </a:prstGeom>
+          <a:noFill/>
+          <a:ln/>
+        </p:spPr>
+        <p:txBody>
+          <a:bodyPr wrap="square" lIns="0" tIns="0" rIns="0" bIns="0" rtlCol="0" anchor="t"/>
+          <a:lstStyle/>
+          <a:p>
+            <a:pPr indent="0" marL="0">
+              <a:buNone/>
+            </a:pPr>
+            <a:r>
+              <a:rPr lang="en-US" sz="1500" b="1" dirty="0">
+                <a:solidFill>
+                  <a:schemeClr val="tx2"/>
+                </a:solidFill>
+              </a:rPr>
+              <a:t>만료되면 (gTLD 기준, 대략)</a:t>
+            </a:r>
+            <a:endParaRPr lang="en-US" sz="1500" dirty="0"/>
+          </a:p>
+        </p:txBody>
+      </p:sp>
+      <p:sp>
+        <p:nvSpPr>
+          <p:cNvPr id="7" name="exp0"/>
+          <p:cNvSpPr/>
+          <p:nvPr/>
+        </p:nvSpPr>
+        <p:spPr>
+          <a:xfrm>
+            <a:off x="4800600" y="1892808"/>
+            <a:ext cx="274320" cy="274320"/>
+          </a:xfrm>
+          <a:prstGeom prst="ellipse">
+            <a:avLst/>
+          </a:prstGeom>
+          <a:solidFill>
+            <a:srgbClr val="3E9B6B"/>
+          </a:solidFill>
+          <a:ln/>
+        </p:spPr>
+      </p:sp>
+      <p:sp>
+        <p:nvSpPr>
+          <p:cNvPr id="8" name="Text 6"/>
+          <p:cNvSpPr txBox="1"/>
+          <p:nvPr/>
+        </p:nvSpPr>
+        <p:spPr>
+          <a:xfrm>
+            <a:off x="5212080" y="1783080"/>
+            <a:ext cx="3383280" cy="548640"/>
+          </a:xfrm>
+          <a:prstGeom prst="rect">
+            <a:avLst/>
+          </a:prstGeom>
+          <a:noFill/>
+          <a:ln/>
+        </p:spPr>
+        <p:txBody>
+          <a:bodyPr wrap="square" lIns="0" tIns="0" rIns="0" bIns="0" rtlCol="0" anchor="ctr"/>
+          <a:lstStyle/>
+          <a:p>
+            <a:pPr indent="0" marL="0">
+              <a:buNone/>
+            </a:pPr>
+            <a:r>
+              <a:rPr lang="en-US" sz="1300" b="1" dirty="0">
+                <a:solidFill>
+                  <a:schemeClr val="tx1"/>
+                </a:solidFill>
+              </a:rPr>
+              <a:t>갱신 유예 ~45일</a:t>
+            </a:r>
+            <a:endParaRPr lang="en-US" sz="1300" dirty="0"/>
+          </a:p>
+          <a:p>
+            <a:pPr indent="0" marL="0">
+              <a:buNone/>
+            </a:pPr>
+            <a:r>
+              <a:rPr lang="en-US" sz="1100" dirty="0">
+                <a:solidFill>
+                  <a:schemeClr val="accent4"/>
+                </a:solidFill>
+              </a:rPr>
+              <a:t>원래 가격 갱신 가능한 경우 많음</a:t>
+            </a:r>
+            <a:endParaRPr lang="en-US" sz="1300" dirty="0"/>
+          </a:p>
+        </p:txBody>
+      </p:sp>
+      <p:sp>
+        <p:nvSpPr>
+          <p:cNvPr id="9" name="exp1"/>
+          <p:cNvSpPr/>
+          <p:nvPr/>
+        </p:nvSpPr>
+        <p:spPr>
+          <a:xfrm>
+            <a:off x="4800600" y="2514600"/>
+            <a:ext cx="274320" cy="274320"/>
+          </a:xfrm>
+          <a:prstGeom prst="ellipse">
+            <a:avLst/>
+          </a:prstGeom>
+          <a:solidFill>
+            <a:srgbClr val="E0A526"/>
+          </a:solidFill>
+          <a:ln/>
+        </p:spPr>
+      </p:sp>
+      <p:sp>
+        <p:nvSpPr>
+          <p:cNvPr id="10" name="Text 8"/>
+          <p:cNvSpPr txBox="1"/>
+          <p:nvPr/>
+        </p:nvSpPr>
+        <p:spPr>
+          <a:xfrm>
+            <a:off x="5212080" y="2404872"/>
+            <a:ext cx="3383280" cy="548640"/>
+          </a:xfrm>
+          <a:prstGeom prst="rect">
+            <a:avLst/>
+          </a:prstGeom>
+          <a:noFill/>
+          <a:ln/>
+        </p:spPr>
+        <p:txBody>
+          <a:bodyPr wrap="square" lIns="0" tIns="0" rIns="0" bIns="0" rtlCol="0" anchor="ctr"/>
+          <a:lstStyle/>
+          <a:p>
+            <a:pPr indent="0" marL="0">
+              <a:buNone/>
+            </a:pPr>
+            <a:r>
+              <a:rPr lang="en-US" sz="1300" b="1" dirty="0">
+                <a:solidFill>
+                  <a:schemeClr val="tx1"/>
+                </a:solidFill>
+              </a:rPr>
+              <a:t>복구 유예 ~30일</a:t>
+            </a:r>
+            <a:endParaRPr lang="en-US" sz="1300" dirty="0"/>
+          </a:p>
+          <a:p>
+            <a:pPr indent="0" marL="0">
+              <a:buNone/>
+            </a:pPr>
+            <a:r>
+              <a:rPr lang="en-US" sz="1100" dirty="0">
+                <a:solidFill>
+                  <a:schemeClr val="accent4"/>
+                </a:solidFill>
+              </a:rPr>
+              <a:t>사이트·메일 멈춤, 비싼 복구비</a:t>
+            </a:r>
+            <a:endParaRPr lang="en-US" sz="1300" dirty="0"/>
+          </a:p>
+        </p:txBody>
+      </p:sp>
+      <p:sp>
+        <p:nvSpPr>
+          <p:cNvPr id="11" name="exp2"/>
+          <p:cNvSpPr/>
+          <p:nvPr/>
+        </p:nvSpPr>
+        <p:spPr>
+          <a:xfrm>
+            <a:off x="4800600" y="3136392"/>
+            <a:ext cx="274320" cy="274320"/>
+          </a:xfrm>
+          <a:prstGeom prst="ellipse">
+            <a:avLst/>
+          </a:prstGeom>
+          <a:solidFill>
+            <a:srgbClr val="D9534F"/>
+          </a:solidFill>
+          <a:ln/>
+        </p:spPr>
+      </p:sp>
+      <p:sp>
+        <p:nvSpPr>
+          <p:cNvPr id="12" name="Text 10"/>
+          <p:cNvSpPr txBox="1"/>
+          <p:nvPr/>
+        </p:nvSpPr>
+        <p:spPr>
+          <a:xfrm>
+            <a:off x="5212080" y="3026664"/>
+            <a:ext cx="3383280" cy="548640"/>
+          </a:xfrm>
+          <a:prstGeom prst="rect">
+            <a:avLst/>
+          </a:prstGeom>
+          <a:noFill/>
+          <a:ln/>
+        </p:spPr>
+        <p:txBody>
+          <a:bodyPr wrap="square" lIns="0" tIns="0" rIns="0" bIns="0" rtlCol="0" anchor="ctr"/>
+          <a:lstStyle/>
+          <a:p>
+            <a:pPr indent="0" marL="0">
+              <a:buNone/>
+            </a:pPr>
+            <a:r>
+              <a:rPr lang="en-US" sz="1300" b="1" dirty="0">
+                <a:solidFill>
+                  <a:schemeClr val="tx1"/>
+                </a:solidFill>
+              </a:rPr>
+              <a:t>삭제 대기 ~5일</a:t>
+            </a:r>
+            <a:endParaRPr lang="en-US" sz="1300" dirty="0"/>
+          </a:p>
+          <a:p>
+            <a:pPr indent="0" marL="0">
+              <a:buNone/>
+            </a:pPr>
+            <a:r>
+              <a:rPr lang="en-US" sz="1100" dirty="0">
+                <a:solidFill>
+                  <a:schemeClr val="accent4"/>
+                </a:solidFill>
+              </a:rPr>
+              <a:t>되살릴 수 없음</a:t>
+            </a:r>
+            <a:endParaRPr lang="en-US" sz="1300" dirty="0"/>
+          </a:p>
+        </p:txBody>
+      </p:sp>
+      <p:sp>
+        <p:nvSpPr>
+          <p:cNvPr id="13" name="exp3"/>
+          <p:cNvSpPr/>
+          <p:nvPr/>
+        </p:nvSpPr>
+        <p:spPr>
+          <a:xfrm>
+            <a:off x="4800600" y="3758184"/>
+            <a:ext cx="274320" cy="274320"/>
+          </a:xfrm>
+          <a:prstGeom prst="ellipse">
+            <a:avLst/>
+          </a:prstGeom>
+          <a:solidFill>
+            <a:srgbClr val="1B2B2E"/>
+          </a:solidFill>
+          <a:ln/>
+        </p:spPr>
+      </p:sp>
+      <p:sp>
+        <p:nvSpPr>
+          <p:cNvPr id="14" name="Text 12"/>
+          <p:cNvSpPr txBox="1"/>
+          <p:nvPr/>
+        </p:nvSpPr>
+        <p:spPr>
+          <a:xfrm>
+            <a:off x="5212080" y="3648456"/>
+            <a:ext cx="3383280" cy="548640"/>
+          </a:xfrm>
+          <a:prstGeom prst="rect">
+            <a:avLst/>
+          </a:prstGeom>
+          <a:noFill/>
+          <a:ln/>
+        </p:spPr>
+        <p:txBody>
+          <a:bodyPr wrap="square" lIns="0" tIns="0" rIns="0" bIns="0" rtlCol="0" anchor="ctr"/>
+          <a:lstStyle/>
+          <a:p>
+            <a:pPr indent="0" marL="0">
+              <a:buNone/>
+            </a:pPr>
+            <a:r>
+              <a:rPr lang="en-US" sz="1300" b="1" dirty="0">
+                <a:solidFill>
+                  <a:schemeClr val="tx1"/>
+                </a:solidFill>
+              </a:rPr>
+              <a:t>공개 </a:t>
+            </a:r>
+            <a:endParaRPr lang="en-US" sz="1300" dirty="0"/>
+          </a:p>
+          <a:p>
+            <a:pPr indent="0" marL="0">
+              <a:buNone/>
+            </a:pPr>
+            <a:r>
+              <a:rPr lang="en-US" sz="1100" dirty="0">
+                <a:solidFill>
+                  <a:schemeClr val="accent4"/>
+                </a:solidFill>
+              </a:rPr>
+              <a:t>누구나 등록 가능</a:t>
+            </a:r>
+            <a:endParaRPr lang="en-US" sz="1300" dirty="0"/>
+          </a:p>
+        </p:txBody>
+      </p:sp>
+      <p:sp>
+        <p:nvSpPr>
+          <p:cNvPr id="25" name="Slide Number Placeholder 0"/>
+          <p:cNvSpPr>
+            <a:spLocks noGrp="1"/>
+          </p:cNvSpPr>
+          <p:nvPr>
+            <p:ph type="sldNum" sz="quarter" idx="4294967295"/>
+          </p:nvPr>
+        </p:nvSpPr>
+        <p:spPr>
+          <a:xfrm>
+            <a:off x="8321040" y="4754880"/>
+            <a:ext cx="457200" cy="274320"/>
+          </a:xfrm>
+          <a:prstGeom prst="rect">
+            <a:avLst/>
+          </a:prstGeom>
+          <a:extLst>
+            <a:ext uri="{C572A759-6A51-4108-AA02-DFA0A04FC94B}">
+              <ma14:wrappingTextBoxFlag xmlns:ma14="http://schemas.microsoft.com/office/mac/drawingml/2011/main" val="0"/>
+            </a:ext>
+          </a:extLst>
+        </p:spPr>
+        <p:txBody>
+          <a:bodyPr/>
+          <a:lstStyle>
+            <a:lvl1pPr>
+              <a:defRPr sz="1000">
+                <a:solidFill>
+                  <a:schemeClr val="accent4"/>
+                </a:solidFill>
+              </a:defRPr>
+            </a:lvl1pPr>
+          </a:lstStyle>
+          <a:p>
+            <a:pPr algn="r"/>
+            <a:fld id="{F7021451-1387-4CA6-816F-3879F97B5CBC}" type="slidenum">
+              <a:rPr b="0" lang="en-US"/>
+              <a:t>51</a:t>
+            </a:fld>
+            <a:endParaRPr lang="en-US"/>
+          </a:p>
+        </p:txBody>
+      </p:sp>
+    </p:spTree>
+  </p:cSld>
+  <p:clrMapOvr>
+    <a:masterClrMapping/>
+  </p:clrMapOvr>
+</p:sld>
+</file>
+
+<file path=ppt/slides/slide52.xml><?xml version="1.0" encoding="utf-8"?>
+<p:sld xmlns:a="http://schemas.openxmlformats.org/drawingml/2006/main" xmlns:r="http://schemas.openxmlformats.org/officeDocument/2006/relationships" xmlns:p="http://schemas.openxmlformats.org/presentationml/2006/main">
+  <p:cSld name="Slide 52">
+    <p:spTree>
+      <p:nvGrpSpPr>
+        <p:cNvPr id="1" name=""/>
+        <p:cNvGrpSpPr/>
+        <p:nvPr/>
+      </p:nvGrpSpPr>
+      <p:grpSpPr>
+        <a:xfrm>
+          <a:off x="0" y="0"/>
+          <a:ext cx="0" cy="0"/>
+          <a:chOff x="0" y="0"/>
+          <a:chExt cx="0" cy="0"/>
+        </a:xfrm>
+      </p:grpSpPr>
+      <p:sp>
+        <p:nvSpPr>
+          <p:cNvPr id="2" name="Text 0"/>
+          <p:cNvSpPr/>
+          <p:nvPr>
+            <p:ph idx="100" type="title" hasCustomPrompt="1"/>
+          </p:nvPr>
+        </p:nvSpPr>
+        <p:spPr>
+          <a:xfrm>
+            <a:off x="457200" y="274320"/>
+            <a:ext cx="8229600" cy="685800"/>
+          </a:xfrm>
+          <a:prstGeom prst="rect">
+            <a:avLst/>
+          </a:prstGeom>
+          <a:noFill/>
+          <a:ln/>
+        </p:spPr>
+        <p:txBody>
+          <a:bodyPr wrap="square" lIns="0" tIns="0" rIns="0" bIns="0" rtlCol="0" anchor="ctr"/>
+          <a:lstStyle/>
+          <a:p>
+            <a:pPr indent="0" marL="0">
+              <a:buNone/>
+            </a:pPr>
+            <a:r>
+              <a:rPr lang="en-US" sz="2800" b="1" dirty="0">
+                <a:solidFill>
+                  <a:schemeClr val="tx2"/>
+                </a:solidFill>
+              </a:rPr>
+              <a:t>업계 지식(도메인 지식)이란</a:t>
+            </a:r>
+            <a:endParaRPr lang="en-US" sz="2800" dirty="0"/>
+          </a:p>
+        </p:txBody>
+      </p:sp>
+      <p:sp>
+        <p:nvSpPr>
+          <p:cNvPr id="3" name="card"/>
+          <p:cNvSpPr/>
+          <p:nvPr/>
+        </p:nvSpPr>
+        <p:spPr>
+          <a:xfrm>
+            <a:off x="457200" y="1188720"/>
+            <a:ext cx="8229600" cy="822960"/>
+          </a:xfrm>
+          <a:prstGeom prst="roundRect">
+            <a:avLst>
+              <a:gd name="adj" fmla="val 8889"/>
+            </a:avLst>
+          </a:prstGeom>
+          <a:solidFill>
+            <a:schemeClr val="tx2"/>
+          </a:solidFill>
+          <a:ln/>
+        </p:spPr>
+      </p:sp>
+      <p:sp>
+        <p:nvSpPr>
+          <p:cNvPr id="4" name="Text 2"/>
+          <p:cNvSpPr txBox="1"/>
+          <p:nvPr/>
+        </p:nvSpPr>
+        <p:spPr>
+          <a:xfrm>
+            <a:off x="731520" y="1188720"/>
+            <a:ext cx="7680960" cy="822960"/>
+          </a:xfrm>
+          <a:prstGeom prst="rect">
+            <a:avLst/>
+          </a:prstGeom>
+          <a:noFill/>
+          <a:ln/>
+        </p:spPr>
+        <p:txBody>
+          <a:bodyPr wrap="square" lIns="0" tIns="0" rIns="0" bIns="0" rtlCol="0" anchor="ctr"/>
+          <a:lstStyle/>
+          <a:p>
+            <a:pPr indent="0" marL="0">
+              <a:buNone/>
+            </a:pPr>
+            <a:r>
+              <a:rPr lang="en-US" sz="1500" b="1" dirty="0">
+                <a:solidFill>
+                  <a:schemeClr val="bg1"/>
+                </a:solidFill>
+              </a:rPr>
+              <a:t>그 분야의 업무 흐름과 단어 — 코딩 실력이 같아도 이걸 아는 사람이 실수 없는 서비스를 만든다</a:t>
+            </a:r>
+            <a:endParaRPr lang="en-US" sz="1500" dirty="0"/>
+          </a:p>
+        </p:txBody>
+      </p:sp>
+      <p:sp>
+        <p:nvSpPr>
+          <p:cNvPr id="5" name="card"/>
+          <p:cNvSpPr/>
+          <p:nvPr/>
+        </p:nvSpPr>
+        <p:spPr>
+          <a:xfrm>
+            <a:off x="457200" y="2240280"/>
+            <a:ext cx="1554480" cy="1325880"/>
+          </a:xfrm>
+          <a:prstGeom prst="roundRect">
+            <a:avLst>
+              <a:gd name="adj" fmla="val 5517"/>
+            </a:avLst>
+          </a:prstGeom>
+          <a:solidFill>
+            <a:schemeClr val="bg2"/>
+          </a:solidFill>
+          <a:ln/>
+        </p:spPr>
+      </p:sp>
+      <p:sp>
+        <p:nvSpPr>
+          <p:cNvPr id="6" name="badge1"/>
+          <p:cNvSpPr/>
+          <p:nvPr/>
+        </p:nvSpPr>
+        <p:spPr>
+          <a:xfrm>
+            <a:off x="594360" y="2377440"/>
+            <a:ext cx="347472" cy="347472"/>
+          </a:xfrm>
+          <a:prstGeom prst="ellipse">
+            <a:avLst/>
+          </a:prstGeom>
+          <a:solidFill>
+            <a:schemeClr val="accent2"/>
+          </a:solidFill>
+          <a:ln/>
+        </p:spPr>
+      </p:sp>
+      <p:sp>
+        <p:nvSpPr>
+          <p:cNvPr id="7" name="Text 5"/>
+          <p:cNvSpPr txBox="1"/>
+          <p:nvPr/>
+        </p:nvSpPr>
+        <p:spPr>
+          <a:xfrm>
+            <a:off x="594360" y="2377440"/>
+            <a:ext cx="347472" cy="347472"/>
+          </a:xfrm>
+          <a:prstGeom prst="rect">
+            <a:avLst/>
+          </a:prstGeom>
+          <a:noFill/>
+          <a:ln/>
+        </p:spPr>
+        <p:txBody>
+          <a:bodyPr wrap="square" lIns="0" tIns="0" rIns="0" bIns="0" rtlCol="0" anchor="ctr"/>
+          <a:lstStyle/>
+          <a:p>
+            <a:pPr algn="ctr" indent="0" marL="0">
+              <a:buNone/>
+            </a:pPr>
+            <a:r>
+              <a:rPr lang="en-US" sz="1400" b="1" dirty="0">
+                <a:solidFill>
+                  <a:schemeClr val="bg1"/>
+                </a:solidFill>
+              </a:rPr>
+              <a:t>1</a:t>
+            </a:r>
+            <a:endParaRPr lang="en-US" sz="1400" dirty="0"/>
+          </a:p>
+        </p:txBody>
+      </p:sp>
+      <p:sp>
+        <p:nvSpPr>
+          <p:cNvPr id="8" name="Text 6"/>
+          <p:cNvSpPr txBox="1"/>
+          <p:nvPr/>
+        </p:nvSpPr>
+        <p:spPr>
+          <a:xfrm>
+            <a:off x="594360" y="2788920"/>
+            <a:ext cx="1325880" cy="731520"/>
+          </a:xfrm>
+          <a:prstGeom prst="rect">
+            <a:avLst/>
+          </a:prstGeom>
+          <a:noFill/>
+          <a:ln/>
+        </p:spPr>
+        <p:txBody>
+          <a:bodyPr wrap="square" lIns="0" tIns="0" rIns="0" bIns="0" rtlCol="0" anchor="t"/>
+          <a:lstStyle/>
+          <a:p>
+            <a:pPr indent="0" marL="0">
+              <a:buNone/>
+            </a:pPr>
+            <a:r>
+              <a:rPr lang="en-US" sz="1300" b="1" dirty="0">
+                <a:solidFill>
+                  <a:schemeClr val="tx1"/>
+                </a:solidFill>
+              </a:rPr>
+              <a:t>용어집</a:t>
+            </a:r>
+            <a:endParaRPr lang="en-US" sz="1300" dirty="0"/>
+          </a:p>
+          <a:p>
+            <a:pPr indent="0" marL="0">
+              <a:buNone/>
+            </a:pPr>
+            <a:r>
+              <a:rPr lang="en-US" sz="1100" dirty="0">
+                <a:solidFill>
+                  <a:schemeClr val="accent4"/>
+                </a:solidFill>
+              </a:rPr>
+              <a:t>내 말로 단어 정리</a:t>
+            </a:r>
+            <a:endParaRPr lang="en-US" sz="1300" dirty="0"/>
+          </a:p>
+        </p:txBody>
+      </p:sp>
+      <p:sp>
+        <p:nvSpPr>
+          <p:cNvPr id="9" name="card"/>
+          <p:cNvSpPr/>
+          <p:nvPr/>
+        </p:nvSpPr>
+        <p:spPr>
+          <a:xfrm>
+            <a:off x="2130552" y="2240280"/>
+            <a:ext cx="1554480" cy="1325880"/>
+          </a:xfrm>
+          <a:prstGeom prst="roundRect">
+            <a:avLst>
+              <a:gd name="adj" fmla="val 5517"/>
+            </a:avLst>
+          </a:prstGeom>
+          <a:solidFill>
+            <a:schemeClr val="bg2"/>
+          </a:solidFill>
+          <a:ln/>
+        </p:spPr>
+      </p:sp>
+      <p:sp>
+        <p:nvSpPr>
+          <p:cNvPr id="10" name="badge2"/>
+          <p:cNvSpPr/>
+          <p:nvPr/>
+        </p:nvSpPr>
+        <p:spPr>
+          <a:xfrm>
+            <a:off x="2267712" y="2377440"/>
+            <a:ext cx="347472" cy="347472"/>
+          </a:xfrm>
+          <a:prstGeom prst="ellipse">
+            <a:avLst/>
+          </a:prstGeom>
+          <a:solidFill>
+            <a:schemeClr val="accent2"/>
+          </a:solidFill>
+          <a:ln/>
+        </p:spPr>
+      </p:sp>
+      <p:sp>
+        <p:nvSpPr>
+          <p:cNvPr id="11" name="Text 9"/>
+          <p:cNvSpPr txBox="1"/>
+          <p:nvPr/>
+        </p:nvSpPr>
+        <p:spPr>
+          <a:xfrm>
+            <a:off x="2267712" y="2377440"/>
+            <a:ext cx="347472" cy="347472"/>
+          </a:xfrm>
+          <a:prstGeom prst="rect">
+            <a:avLst/>
+          </a:prstGeom>
+          <a:noFill/>
+          <a:ln/>
+        </p:spPr>
+        <p:txBody>
+          <a:bodyPr wrap="square" lIns="0" tIns="0" rIns="0" bIns="0" rtlCol="0" anchor="ctr"/>
+          <a:lstStyle/>
+          <a:p>
+            <a:pPr algn="ctr" indent="0" marL="0">
+              <a:buNone/>
+            </a:pPr>
+            <a:r>
+              <a:rPr lang="en-US" sz="1400" b="1" dirty="0">
+                <a:solidFill>
+                  <a:schemeClr val="bg1"/>
+                </a:solidFill>
+              </a:rPr>
+              <a:t>2</a:t>
+            </a:r>
+            <a:endParaRPr lang="en-US" sz="1400" dirty="0"/>
+          </a:p>
+        </p:txBody>
+      </p:sp>
+      <p:sp>
+        <p:nvSpPr>
+          <p:cNvPr id="12" name="Text 10"/>
+          <p:cNvSpPr txBox="1"/>
+          <p:nvPr/>
+        </p:nvSpPr>
+        <p:spPr>
+          <a:xfrm>
+            <a:off x="2267712" y="2788920"/>
+            <a:ext cx="1325880" cy="731520"/>
+          </a:xfrm>
+          <a:prstGeom prst="rect">
+            <a:avLst/>
+          </a:prstGeom>
+          <a:noFill/>
+          <a:ln/>
+        </p:spPr>
+        <p:txBody>
+          <a:bodyPr wrap="square" lIns="0" tIns="0" rIns="0" bIns="0" rtlCol="0" anchor="t"/>
+          <a:lstStyle/>
+          <a:p>
+            <a:pPr indent="0" marL="0">
+              <a:buNone/>
+            </a:pPr>
+            <a:r>
+              <a:rPr lang="en-US" sz="1300" b="1" dirty="0">
+                <a:solidFill>
+                  <a:schemeClr val="tx1"/>
+                </a:solidFill>
+              </a:rPr>
+              <a:t>흐름 그리기</a:t>
+            </a:r>
+            <a:endParaRPr lang="en-US" sz="1300" dirty="0"/>
+          </a:p>
+          <a:p>
+            <a:pPr indent="0" marL="0">
+              <a:buNone/>
+            </a:pPr>
+            <a:r>
+              <a:rPr lang="en-US" sz="1100" dirty="0">
+                <a:solidFill>
+                  <a:schemeClr val="accent4"/>
+                </a:solidFill>
+              </a:rPr>
+              <a:t>돈·물건·정보의 이동</a:t>
+            </a:r>
+            <a:endParaRPr lang="en-US" sz="1300" dirty="0"/>
+          </a:p>
+        </p:txBody>
+      </p:sp>
+      <p:sp>
+        <p:nvSpPr>
+          <p:cNvPr id="13" name="card"/>
+          <p:cNvSpPr/>
+          <p:nvPr/>
+        </p:nvSpPr>
+        <p:spPr>
+          <a:xfrm>
+            <a:off x="3803904" y="2240280"/>
+            <a:ext cx="1554480" cy="1325880"/>
+          </a:xfrm>
+          <a:prstGeom prst="roundRect">
+            <a:avLst>
+              <a:gd name="adj" fmla="val 5517"/>
+            </a:avLst>
+          </a:prstGeom>
+          <a:solidFill>
+            <a:schemeClr val="bg2"/>
+          </a:solidFill>
+          <a:ln/>
+        </p:spPr>
+      </p:sp>
+      <p:sp>
+        <p:nvSpPr>
+          <p:cNvPr id="14" name="badge3"/>
+          <p:cNvSpPr/>
+          <p:nvPr/>
+        </p:nvSpPr>
+        <p:spPr>
+          <a:xfrm>
+            <a:off x="3941064" y="2377440"/>
+            <a:ext cx="347472" cy="347472"/>
+          </a:xfrm>
+          <a:prstGeom prst="ellipse">
+            <a:avLst/>
+          </a:prstGeom>
+          <a:solidFill>
+            <a:schemeClr val="accent2"/>
+          </a:solidFill>
+          <a:ln/>
+        </p:spPr>
+      </p:sp>
+      <p:sp>
+        <p:nvSpPr>
+          <p:cNvPr id="15" name="Text 13"/>
+          <p:cNvSpPr txBox="1"/>
+          <p:nvPr/>
+        </p:nvSpPr>
+        <p:spPr>
+          <a:xfrm>
+            <a:off x="3941064" y="2377440"/>
+            <a:ext cx="347472" cy="347472"/>
+          </a:xfrm>
+          <a:prstGeom prst="rect">
+            <a:avLst/>
+          </a:prstGeom>
+          <a:noFill/>
+          <a:ln/>
+        </p:spPr>
+        <p:txBody>
+          <a:bodyPr wrap="square" lIns="0" tIns="0" rIns="0" bIns="0" rtlCol="0" anchor="ctr"/>
+          <a:lstStyle/>
+          <a:p>
+            <a:pPr algn="ctr" indent="0" marL="0">
+              <a:buNone/>
+            </a:pPr>
+            <a:r>
+              <a:rPr lang="en-US" sz="1400" b="1" dirty="0">
+                <a:solidFill>
+                  <a:schemeClr val="bg1"/>
+                </a:solidFill>
+              </a:rPr>
+              <a:t>3</a:t>
+            </a:r>
+            <a:endParaRPr lang="en-US" sz="1400" dirty="0"/>
+          </a:p>
+        </p:txBody>
+      </p:sp>
+      <p:sp>
+        <p:nvSpPr>
+          <p:cNvPr id="16" name="Text 14"/>
+          <p:cNvSpPr txBox="1"/>
+          <p:nvPr/>
+        </p:nvSpPr>
+        <p:spPr>
+          <a:xfrm>
+            <a:off x="3941064" y="2788920"/>
+            <a:ext cx="1325880" cy="731520"/>
+          </a:xfrm>
+          <a:prstGeom prst="rect">
+            <a:avLst/>
+          </a:prstGeom>
+          <a:noFill/>
+          <a:ln/>
+        </p:spPr>
+        <p:txBody>
+          <a:bodyPr wrap="square" lIns="0" tIns="0" rIns="0" bIns="0" rtlCol="0" anchor="t"/>
+          <a:lstStyle/>
+          <a:p>
+            <a:pPr indent="0" marL="0">
+              <a:buNone/>
+            </a:pPr>
+            <a:r>
+              <a:rPr lang="en-US" sz="1300" b="1" dirty="0">
+                <a:solidFill>
+                  <a:schemeClr val="tx1"/>
+                </a:solidFill>
+              </a:rPr>
+              <a:t>상태 그리기</a:t>
+            </a:r>
+            <a:endParaRPr lang="en-US" sz="1300" dirty="0"/>
+          </a:p>
+          <a:p>
+            <a:pPr indent="0" marL="0">
+              <a:buNone/>
+            </a:pPr>
+            <a:r>
+              <a:rPr lang="en-US" sz="1100" dirty="0">
+                <a:solidFill>
+                  <a:schemeClr val="accent4"/>
+                </a:solidFill>
+              </a:rPr>
+              <a:t>주문이 거치는 모든 상태</a:t>
+            </a:r>
+            <a:endParaRPr lang="en-US" sz="1300" dirty="0"/>
+          </a:p>
+        </p:txBody>
+      </p:sp>
+      <p:sp>
+        <p:nvSpPr>
+          <p:cNvPr id="17" name="card"/>
+          <p:cNvSpPr/>
+          <p:nvPr/>
+        </p:nvSpPr>
+        <p:spPr>
+          <a:xfrm>
+            <a:off x="5477256" y="2240280"/>
+            <a:ext cx="1554480" cy="1325880"/>
+          </a:xfrm>
+          <a:prstGeom prst="roundRect">
+            <a:avLst>
+              <a:gd name="adj" fmla="val 5517"/>
+            </a:avLst>
+          </a:prstGeom>
+          <a:solidFill>
+            <a:schemeClr val="bg2"/>
+          </a:solidFill>
+          <a:ln/>
+        </p:spPr>
+      </p:sp>
+      <p:sp>
+        <p:nvSpPr>
+          <p:cNvPr id="18" name="badge4"/>
+          <p:cNvSpPr/>
+          <p:nvPr/>
+        </p:nvSpPr>
+        <p:spPr>
+          <a:xfrm>
+            <a:off x="5614416" y="2377440"/>
+            <a:ext cx="347472" cy="347472"/>
+          </a:xfrm>
+          <a:prstGeom prst="ellipse">
+            <a:avLst/>
+          </a:prstGeom>
+          <a:solidFill>
+            <a:schemeClr val="accent2"/>
+          </a:solidFill>
+          <a:ln/>
+        </p:spPr>
+      </p:sp>
+      <p:sp>
+        <p:nvSpPr>
+          <p:cNvPr id="19" name="Text 17"/>
+          <p:cNvSpPr txBox="1"/>
+          <p:nvPr/>
+        </p:nvSpPr>
+        <p:spPr>
+          <a:xfrm>
+            <a:off x="5614416" y="2377440"/>
+            <a:ext cx="347472" cy="347472"/>
+          </a:xfrm>
+          <a:prstGeom prst="rect">
+            <a:avLst/>
+          </a:prstGeom>
+          <a:noFill/>
+          <a:ln/>
+        </p:spPr>
+        <p:txBody>
+          <a:bodyPr wrap="square" lIns="0" tIns="0" rIns="0" bIns="0" rtlCol="0" anchor="ctr"/>
+          <a:lstStyle/>
+          <a:p>
+            <a:pPr algn="ctr" indent="0" marL="0">
+              <a:buNone/>
+            </a:pPr>
+            <a:r>
+              <a:rPr lang="en-US" sz="1400" b="1" dirty="0">
+                <a:solidFill>
+                  <a:schemeClr val="bg1"/>
+                </a:solidFill>
+              </a:rPr>
+              <a:t>4</a:t>
+            </a:r>
+            <a:endParaRPr lang="en-US" sz="1400" dirty="0"/>
+          </a:p>
+        </p:txBody>
+      </p:sp>
+      <p:sp>
+        <p:nvSpPr>
+          <p:cNvPr id="20" name="Text 18"/>
+          <p:cNvSpPr txBox="1"/>
+          <p:nvPr/>
+        </p:nvSpPr>
+        <p:spPr>
+          <a:xfrm>
+            <a:off x="5614416" y="2788920"/>
+            <a:ext cx="1325880" cy="731520"/>
+          </a:xfrm>
+          <a:prstGeom prst="rect">
+            <a:avLst/>
+          </a:prstGeom>
+          <a:noFill/>
+          <a:ln/>
+        </p:spPr>
+        <p:txBody>
+          <a:bodyPr wrap="square" lIns="0" tIns="0" rIns="0" bIns="0" rtlCol="0" anchor="t"/>
+          <a:lstStyle/>
+          <a:p>
+            <a:pPr indent="0" marL="0">
+              <a:buNone/>
+            </a:pPr>
+            <a:r>
+              <a:rPr lang="en-US" sz="1300" b="1" dirty="0">
+                <a:solidFill>
+                  <a:schemeClr val="tx1"/>
+                </a:solidFill>
+              </a:rPr>
+              <a:t>예외 찾기</a:t>
+            </a:r>
+            <a:endParaRPr lang="en-US" sz="1300" dirty="0"/>
+          </a:p>
+          <a:p>
+            <a:pPr indent="0" marL="0">
+              <a:buNone/>
+            </a:pPr>
+            <a:r>
+              <a:rPr lang="en-US" sz="1100" dirty="0">
+                <a:solidFill>
+                  <a:schemeClr val="accent4"/>
+                </a:solidFill>
+              </a:rPr>
+              <a:t>중간 취소? 부분 환불?</a:t>
+            </a:r>
+            <a:endParaRPr lang="en-US" sz="1300" dirty="0"/>
+          </a:p>
+        </p:txBody>
+      </p:sp>
+      <p:sp>
+        <p:nvSpPr>
+          <p:cNvPr id="21" name="card"/>
+          <p:cNvSpPr/>
+          <p:nvPr/>
+        </p:nvSpPr>
+        <p:spPr>
+          <a:xfrm>
+            <a:off x="7150608" y="2240280"/>
+            <a:ext cx="1554480" cy="1325880"/>
+          </a:xfrm>
+          <a:prstGeom prst="roundRect">
+            <a:avLst>
+              <a:gd name="adj" fmla="val 5517"/>
+            </a:avLst>
+          </a:prstGeom>
+          <a:solidFill>
+            <a:schemeClr val="bg2"/>
+          </a:solidFill>
+          <a:ln/>
+        </p:spPr>
+      </p:sp>
+      <p:sp>
+        <p:nvSpPr>
+          <p:cNvPr id="22" name="badge5"/>
+          <p:cNvSpPr/>
+          <p:nvPr/>
+        </p:nvSpPr>
+        <p:spPr>
+          <a:xfrm>
+            <a:off x="7287768" y="2377440"/>
+            <a:ext cx="347472" cy="347472"/>
+          </a:xfrm>
+          <a:prstGeom prst="ellipse">
+            <a:avLst/>
+          </a:prstGeom>
+          <a:solidFill>
+            <a:schemeClr val="accent2"/>
+          </a:solidFill>
+          <a:ln/>
+        </p:spPr>
+      </p:sp>
+      <p:sp>
+        <p:nvSpPr>
+          <p:cNvPr id="23" name="Text 21"/>
+          <p:cNvSpPr txBox="1"/>
+          <p:nvPr/>
+        </p:nvSpPr>
+        <p:spPr>
+          <a:xfrm>
+            <a:off x="7287768" y="2377440"/>
+            <a:ext cx="347472" cy="347472"/>
+          </a:xfrm>
+          <a:prstGeom prst="rect">
+            <a:avLst/>
+          </a:prstGeom>
+          <a:noFill/>
+          <a:ln/>
+        </p:spPr>
+        <p:txBody>
+          <a:bodyPr wrap="square" lIns="0" tIns="0" rIns="0" bIns="0" rtlCol="0" anchor="ctr"/>
+          <a:lstStyle/>
+          <a:p>
+            <a:pPr algn="ctr" indent="0" marL="0">
+              <a:buNone/>
+            </a:pPr>
+            <a:r>
+              <a:rPr lang="en-US" sz="1400" b="1" dirty="0">
+                <a:solidFill>
+                  <a:schemeClr val="bg1"/>
+                </a:solidFill>
+              </a:rPr>
+              <a:t>5</a:t>
+            </a:r>
+            <a:endParaRPr lang="en-US" sz="1400" dirty="0"/>
+          </a:p>
+        </p:txBody>
+      </p:sp>
+      <p:sp>
+        <p:nvSpPr>
+          <p:cNvPr id="24" name="Text 22"/>
+          <p:cNvSpPr txBox="1"/>
+          <p:nvPr/>
+        </p:nvSpPr>
+        <p:spPr>
+          <a:xfrm>
+            <a:off x="7287768" y="2788920"/>
+            <a:ext cx="1325880" cy="731520"/>
+          </a:xfrm>
+          <a:prstGeom prst="rect">
+            <a:avLst/>
+          </a:prstGeom>
+          <a:noFill/>
+          <a:ln/>
+        </p:spPr>
+        <p:txBody>
+          <a:bodyPr wrap="square" lIns="0" tIns="0" rIns="0" bIns="0" rtlCol="0" anchor="t"/>
+          <a:lstStyle/>
+          <a:p>
+            <a:pPr indent="0" marL="0">
+              <a:buNone/>
+            </a:pPr>
+            <a:r>
+              <a:rPr lang="en-US" sz="1300" b="1" dirty="0">
+                <a:solidFill>
+                  <a:schemeClr val="tx1"/>
+                </a:solidFill>
+              </a:rPr>
+              <a:t>현장에 묻기</a:t>
+            </a:r>
+            <a:endParaRPr lang="en-US" sz="1300" dirty="0"/>
+          </a:p>
+          <a:p>
+            <a:pPr indent="0" marL="0">
+              <a:buNone/>
+            </a:pPr>
+            <a:r>
+              <a:rPr lang="en-US" sz="1100" dirty="0">
+                <a:solidFill>
+                  <a:schemeClr val="accent4"/>
+                </a:solidFill>
+              </a:rPr>
+              <a:t>CS·정산 담당의 고민</a:t>
+            </a:r>
+            <a:endParaRPr lang="en-US" sz="1300" dirty="0"/>
+          </a:p>
+        </p:txBody>
+      </p:sp>
+      <p:sp>
+        <p:nvSpPr>
+          <p:cNvPr id="25" name="Text 23"/>
+          <p:cNvSpPr txBox="1"/>
+          <p:nvPr/>
+        </p:nvSpPr>
+        <p:spPr>
+          <a:xfrm>
+            <a:off x="457200" y="3794760"/>
+            <a:ext cx="8229600" cy="548640"/>
+          </a:xfrm>
+          <a:prstGeom prst="rect">
+            <a:avLst/>
+          </a:prstGeom>
+          <a:noFill/>
+          <a:ln/>
+        </p:spPr>
+        <p:txBody>
+          <a:bodyPr wrap="square" lIns="0" tIns="0" rIns="0" bIns="0" rtlCol="0" anchor="t"/>
+          <a:lstStyle/>
+          <a:p>
+            <a:pPr indent="0" marL="0">
+              <a:buNone/>
+            </a:pPr>
+            <a:r>
+              <a:rPr lang="en-US" sz="1300" b="1" dirty="0">
+                <a:solidFill>
+                  <a:schemeClr val="accent2"/>
+                </a:solidFill>
+              </a:rPr>
+              <a:t>개발에선 DDD  </a:t>
+            </a:r>
+            <a:pPr indent="0" marL="0">
+              <a:buNone/>
+            </a:pPr>
+            <a:r>
+              <a:rPr lang="en-US" sz="1300" dirty="0">
+                <a:solidFill>
+                  <a:schemeClr val="tx1"/>
+                </a:solidFill>
+              </a:rPr>
+              <a:t>공통 언어(현업과 같은 단어를 코드에) · 영역 나누기(같은 '주문'도 판매팀·물류팀에서 뜻이 다름)</a:t>
+            </a:r>
+            <a:endParaRPr lang="en-US" sz="1300" dirty="0"/>
+          </a:p>
+        </p:txBody>
+      </p:sp>
+      <p:sp>
+        <p:nvSpPr>
+          <p:cNvPr id="25" name="Slide Number Placeholder 0"/>
+          <p:cNvSpPr>
+            <a:spLocks noGrp="1"/>
+          </p:cNvSpPr>
+          <p:nvPr>
+            <p:ph type="sldNum" sz="quarter" idx="4294967295"/>
+          </p:nvPr>
+        </p:nvSpPr>
+        <p:spPr>
+          <a:xfrm>
+            <a:off x="8321040" y="4754880"/>
+            <a:ext cx="457200" cy="274320"/>
+          </a:xfrm>
+          <a:prstGeom prst="rect">
+            <a:avLst/>
+          </a:prstGeom>
+          <a:extLst>
+            <a:ext uri="{C572A759-6A51-4108-AA02-DFA0A04FC94B}">
+              <ma14:wrappingTextBoxFlag xmlns:ma14="http://schemas.microsoft.com/office/mac/drawingml/2011/main" val="0"/>
+            </a:ext>
+          </a:extLst>
+        </p:spPr>
+        <p:txBody>
+          <a:bodyPr/>
+          <a:lstStyle>
+            <a:lvl1pPr>
+              <a:defRPr sz="1000">
+                <a:solidFill>
+                  <a:schemeClr val="accent4"/>
+                </a:solidFill>
+              </a:defRPr>
+            </a:lvl1pPr>
+          </a:lstStyle>
+          <a:p>
+            <a:pPr algn="r"/>
+            <a:fld id="{F7021451-1387-4CA6-816F-3879F97B5CBC}" type="slidenum">
+              <a:rPr b="0" lang="en-US"/>
+              <a:t>52</a:t>
+            </a:fld>
+            <a:endParaRPr lang="en-US"/>
+          </a:p>
+        </p:txBody>
+      </p:sp>
+    </p:spTree>
+  </p:cSld>
+  <p:clrMapOvr>
+    <a:masterClrMapping/>
+  </p:clrMapOvr>
+</p:sld>
+</file>
+
+<file path=ppt/slides/slide53.xml><?xml version="1.0" encoding="utf-8"?>
+<p:sld xmlns:a="http://schemas.openxmlformats.org/drawingml/2006/main" xmlns:r="http://schemas.openxmlformats.org/officeDocument/2006/relationships" xmlns:p="http://schemas.openxmlformats.org/presentationml/2006/main">
+  <p:cSld name="Slide 53">
+    <p:spTree>
+      <p:nvGrpSpPr>
+        <p:cNvPr id="1" name=""/>
+        <p:cNvGrpSpPr/>
+        <p:nvPr/>
+      </p:nvGrpSpPr>
+      <p:grpSpPr>
+        <a:xfrm>
+          <a:off x="0" y="0"/>
+          <a:ext cx="0" cy="0"/>
+          <a:chOff x="0" y="0"/>
+          <a:chExt cx="0" cy="0"/>
+        </a:xfrm>
+      </p:grpSpPr>
+      <p:sp>
+        <p:nvSpPr>
+          <p:cNvPr id="2" name="Text 0"/>
+          <p:cNvSpPr/>
+          <p:nvPr>
+            <p:ph idx="100" type="title" hasCustomPrompt="1"/>
+          </p:nvPr>
+        </p:nvSpPr>
+        <p:spPr>
+          <a:xfrm>
+            <a:off x="457200" y="274320"/>
+            <a:ext cx="8229600" cy="685800"/>
+          </a:xfrm>
+          <a:prstGeom prst="rect">
+            <a:avLst/>
+          </a:prstGeom>
+          <a:noFill/>
+          <a:ln/>
+        </p:spPr>
+        <p:txBody>
+          <a:bodyPr wrap="square" lIns="0" tIns="0" rIns="0" bIns="0" rtlCol="0" anchor="ctr"/>
+          <a:lstStyle/>
+          <a:p>
+            <a:pPr indent="0" marL="0">
+              <a:buNone/>
+            </a:pPr>
+            <a:r>
+              <a:rPr lang="en-US" sz="2800" b="1" dirty="0">
+                <a:solidFill>
+                  <a:schemeClr val="tx2"/>
+                </a:solidFill>
+              </a:rPr>
+              <a:t>핵심 흐름 ①: 주문과 결제</a:t>
+            </a:r>
+            <a:endParaRPr lang="en-US" sz="2800" dirty="0"/>
+          </a:p>
+        </p:txBody>
+      </p:sp>
+      <p:sp>
+        <p:nvSpPr>
+          <p:cNvPr id="3" name="Text 1"/>
+          <p:cNvSpPr txBox="1"/>
+          <p:nvPr/>
+        </p:nvSpPr>
+        <p:spPr>
+          <a:xfrm>
+            <a:off x="457200" y="1188720"/>
+            <a:ext cx="8229600" cy="365760"/>
+          </a:xfrm>
+          <a:prstGeom prst="rect">
+            <a:avLst/>
+          </a:prstGeom>
+          <a:noFill/>
+          <a:ln/>
+        </p:spPr>
+        <p:txBody>
+          <a:bodyPr wrap="square" lIns="0" tIns="0" rIns="0" bIns="0" rtlCol="0" anchor="t"/>
+          <a:lstStyle/>
+          <a:p>
+            <a:pPr indent="0" marL="0">
+              <a:buNone/>
+            </a:pPr>
+            <a:r>
+              <a:rPr lang="en-US" sz="1500" b="1" dirty="0">
+                <a:solidFill>
+                  <a:schemeClr val="tx2"/>
+                </a:solidFill>
+              </a:rPr>
+              <a:t>쇼핑몰 주문 상태</a:t>
+            </a:r>
+            <a:endParaRPr lang="en-US" sz="1500" dirty="0"/>
+          </a:p>
+        </p:txBody>
+      </p:sp>
+      <p:sp>
+        <p:nvSpPr>
+          <p:cNvPr id="4" name="ord0"/>
+          <p:cNvSpPr/>
+          <p:nvPr/>
+        </p:nvSpPr>
+        <p:spPr>
+          <a:xfrm>
+            <a:off x="457200" y="1645920"/>
+            <a:ext cx="1261872" cy="548640"/>
+          </a:xfrm>
+          <a:prstGeom prst="roundRect">
+            <a:avLst>
+              <a:gd name="adj" fmla="val 13333"/>
+            </a:avLst>
+          </a:prstGeom>
+          <a:solidFill>
+            <a:srgbClr val="1F4E4A"/>
+          </a:solidFill>
+          <a:ln/>
+        </p:spPr>
+      </p:sp>
+      <p:sp>
+        <p:nvSpPr>
+          <p:cNvPr id="5" name="Text 3"/>
+          <p:cNvSpPr txBox="1"/>
+          <p:nvPr/>
+        </p:nvSpPr>
+        <p:spPr>
+          <a:xfrm>
+            <a:off x="457200" y="1645920"/>
+            <a:ext cx="1261872" cy="548640"/>
+          </a:xfrm>
+          <a:prstGeom prst="rect">
+            <a:avLst/>
+          </a:prstGeom>
+          <a:noFill/>
+          <a:ln/>
+        </p:spPr>
+        <p:txBody>
+          <a:bodyPr wrap="square" lIns="0" tIns="0" rIns="0" bIns="0" rtlCol="0" anchor="ctr"/>
+          <a:lstStyle/>
+          <a:p>
+            <a:pPr algn="ctr" indent="0" marL="0">
+              <a:buNone/>
+            </a:pPr>
+            <a:r>
+              <a:rPr lang="en-US" sz="1300" b="1" dirty="0">
+                <a:solidFill>
+                  <a:schemeClr val="bg1"/>
+                </a:solidFill>
+              </a:rPr>
+              <a:t>결제 완료</a:t>
+            </a:r>
+            <a:endParaRPr lang="en-US" sz="1300" dirty="0"/>
+          </a:p>
+        </p:txBody>
+      </p:sp>
+      <p:sp>
+        <p:nvSpPr>
+          <p:cNvPr id="6" name="ord1"/>
+          <p:cNvSpPr/>
+          <p:nvPr/>
+        </p:nvSpPr>
+        <p:spPr>
+          <a:xfrm>
+            <a:off x="1847088" y="1645920"/>
+            <a:ext cx="1261872" cy="548640"/>
+          </a:xfrm>
+          <a:prstGeom prst="roundRect">
+            <a:avLst>
+              <a:gd name="adj" fmla="val 13333"/>
+            </a:avLst>
+          </a:prstGeom>
+          <a:solidFill>
+            <a:srgbClr val="1F4E4A"/>
+          </a:solidFill>
+          <a:ln/>
+        </p:spPr>
+      </p:sp>
+      <p:sp>
+        <p:nvSpPr>
+          <p:cNvPr id="7" name="Text 5"/>
+          <p:cNvSpPr txBox="1"/>
+          <p:nvPr/>
+        </p:nvSpPr>
+        <p:spPr>
+          <a:xfrm>
+            <a:off x="1847088" y="1645920"/>
+            <a:ext cx="1261872" cy="548640"/>
+          </a:xfrm>
+          <a:prstGeom prst="rect">
+            <a:avLst/>
+          </a:prstGeom>
+          <a:noFill/>
+          <a:ln/>
+        </p:spPr>
+        <p:txBody>
+          <a:bodyPr wrap="square" lIns="0" tIns="0" rIns="0" bIns="0" rtlCol="0" anchor="ctr"/>
+          <a:lstStyle/>
+          <a:p>
+            <a:pPr algn="ctr" indent="0" marL="0">
+              <a:buNone/>
+            </a:pPr>
+            <a:r>
+              <a:rPr lang="en-US" sz="1300" b="1" dirty="0">
+                <a:solidFill>
+                  <a:schemeClr val="bg1"/>
+                </a:solidFill>
+              </a:rPr>
+              <a:t>상품 준비</a:t>
+            </a:r>
+            <a:endParaRPr lang="en-US" sz="1300" dirty="0"/>
+          </a:p>
+        </p:txBody>
+      </p:sp>
+      <p:sp>
+        <p:nvSpPr>
+          <p:cNvPr id="8" name="ord2"/>
+          <p:cNvSpPr/>
+          <p:nvPr/>
+        </p:nvSpPr>
+        <p:spPr>
+          <a:xfrm>
+            <a:off x="3236976" y="1645920"/>
+            <a:ext cx="1261872" cy="548640"/>
+          </a:xfrm>
+          <a:prstGeom prst="roundRect">
+            <a:avLst>
+              <a:gd name="adj" fmla="val 13333"/>
+            </a:avLst>
+          </a:prstGeom>
+          <a:solidFill>
+            <a:srgbClr val="1F4E4A"/>
+          </a:solidFill>
+          <a:ln/>
+        </p:spPr>
+      </p:sp>
+      <p:sp>
+        <p:nvSpPr>
+          <p:cNvPr id="9" name="Text 7"/>
+          <p:cNvSpPr txBox="1"/>
+          <p:nvPr/>
+        </p:nvSpPr>
+        <p:spPr>
+          <a:xfrm>
+            <a:off x="3236976" y="1645920"/>
+            <a:ext cx="1261872" cy="548640"/>
+          </a:xfrm>
+          <a:prstGeom prst="rect">
+            <a:avLst/>
+          </a:prstGeom>
+          <a:noFill/>
+          <a:ln/>
+        </p:spPr>
+        <p:txBody>
+          <a:bodyPr wrap="square" lIns="0" tIns="0" rIns="0" bIns="0" rtlCol="0" anchor="ctr"/>
+          <a:lstStyle/>
+          <a:p>
+            <a:pPr algn="ctr" indent="0" marL="0">
+              <a:buNone/>
+            </a:pPr>
+            <a:r>
+              <a:rPr lang="en-US" sz="1300" b="1" dirty="0">
+                <a:solidFill>
+                  <a:schemeClr val="bg1"/>
+                </a:solidFill>
+              </a:rPr>
+              <a:t>출고</a:t>
+            </a:r>
+            <a:endParaRPr lang="en-US" sz="1300" dirty="0"/>
+          </a:p>
+        </p:txBody>
+      </p:sp>
+      <p:sp>
+        <p:nvSpPr>
+          <p:cNvPr id="10" name="ord3"/>
+          <p:cNvSpPr/>
+          <p:nvPr/>
+        </p:nvSpPr>
+        <p:spPr>
+          <a:xfrm>
+            <a:off x="4626864" y="1645920"/>
+            <a:ext cx="1261872" cy="548640"/>
+          </a:xfrm>
+          <a:prstGeom prst="roundRect">
+            <a:avLst>
+              <a:gd name="adj" fmla="val 13333"/>
+            </a:avLst>
+          </a:prstGeom>
+          <a:solidFill>
+            <a:srgbClr val="1F4E4A"/>
+          </a:solidFill>
+          <a:ln/>
+        </p:spPr>
+      </p:sp>
+      <p:sp>
+        <p:nvSpPr>
+          <p:cNvPr id="11" name="Text 9"/>
+          <p:cNvSpPr txBox="1"/>
+          <p:nvPr/>
+        </p:nvSpPr>
+        <p:spPr>
+          <a:xfrm>
+            <a:off x="4626864" y="1645920"/>
+            <a:ext cx="1261872" cy="548640"/>
+          </a:xfrm>
+          <a:prstGeom prst="rect">
+            <a:avLst/>
+          </a:prstGeom>
+          <a:noFill/>
+          <a:ln/>
+        </p:spPr>
+        <p:txBody>
+          <a:bodyPr wrap="square" lIns="0" tIns="0" rIns="0" bIns="0" rtlCol="0" anchor="ctr"/>
+          <a:lstStyle/>
+          <a:p>
+            <a:pPr algn="ctr" indent="0" marL="0">
+              <a:buNone/>
+            </a:pPr>
+            <a:r>
+              <a:rPr lang="en-US" sz="1300" b="1" dirty="0">
+                <a:solidFill>
+                  <a:schemeClr val="bg1"/>
+                </a:solidFill>
+              </a:rPr>
+              <a:t>배송 중</a:t>
+            </a:r>
+            <a:endParaRPr lang="en-US" sz="1300" dirty="0"/>
+          </a:p>
+        </p:txBody>
+      </p:sp>
+      <p:sp>
+        <p:nvSpPr>
+          <p:cNvPr id="12" name="ord4"/>
+          <p:cNvSpPr/>
+          <p:nvPr/>
+        </p:nvSpPr>
+        <p:spPr>
+          <a:xfrm>
+            <a:off x="6016752" y="1645920"/>
+            <a:ext cx="1261872" cy="548640"/>
+          </a:xfrm>
+          <a:prstGeom prst="roundRect">
+            <a:avLst>
+              <a:gd name="adj" fmla="val 13333"/>
+            </a:avLst>
+          </a:prstGeom>
+          <a:solidFill>
+            <a:srgbClr val="1F4E4A"/>
+          </a:solidFill>
+          <a:ln/>
+        </p:spPr>
+      </p:sp>
+      <p:sp>
+        <p:nvSpPr>
+          <p:cNvPr id="13" name="Text 11"/>
+          <p:cNvSpPr txBox="1"/>
+          <p:nvPr/>
+        </p:nvSpPr>
+        <p:spPr>
+          <a:xfrm>
+            <a:off x="6016752" y="1645920"/>
+            <a:ext cx="1261872" cy="548640"/>
+          </a:xfrm>
+          <a:prstGeom prst="rect">
+            <a:avLst/>
+          </a:prstGeom>
+          <a:noFill/>
+          <a:ln/>
+        </p:spPr>
+        <p:txBody>
+          <a:bodyPr wrap="square" lIns="0" tIns="0" rIns="0" bIns="0" rtlCol="0" anchor="ctr"/>
+          <a:lstStyle/>
+          <a:p>
+            <a:pPr algn="ctr" indent="0" marL="0">
+              <a:buNone/>
+            </a:pPr>
+            <a:r>
+              <a:rPr lang="en-US" sz="1300" b="1" dirty="0">
+                <a:solidFill>
+                  <a:schemeClr val="bg1"/>
+                </a:solidFill>
+              </a:rPr>
+              <a:t>배송 완료</a:t>
+            </a:r>
+            <a:endParaRPr lang="en-US" sz="1300" dirty="0"/>
+          </a:p>
+        </p:txBody>
+      </p:sp>
+      <p:sp>
+        <p:nvSpPr>
+          <p:cNvPr id="14" name="ord5"/>
+          <p:cNvSpPr/>
+          <p:nvPr/>
+        </p:nvSpPr>
+        <p:spPr>
+          <a:xfrm>
+            <a:off x="7406640" y="1645920"/>
+            <a:ext cx="1261872" cy="548640"/>
+          </a:xfrm>
+          <a:prstGeom prst="roundRect">
+            <a:avLst>
+              <a:gd name="adj" fmla="val 13333"/>
+            </a:avLst>
+          </a:prstGeom>
+          <a:solidFill>
+            <a:srgbClr val="F08A3E"/>
+          </a:solidFill>
+          <a:ln/>
+        </p:spPr>
+      </p:sp>
+      <p:sp>
+        <p:nvSpPr>
+          <p:cNvPr id="15" name="Text 13"/>
+          <p:cNvSpPr txBox="1"/>
+          <p:nvPr/>
+        </p:nvSpPr>
+        <p:spPr>
+          <a:xfrm>
+            <a:off x="7406640" y="1645920"/>
+            <a:ext cx="1261872" cy="548640"/>
+          </a:xfrm>
+          <a:prstGeom prst="rect">
+            <a:avLst/>
+          </a:prstGeom>
+          <a:noFill/>
+          <a:ln/>
+        </p:spPr>
+        <p:txBody>
+          <a:bodyPr wrap="square" lIns="0" tIns="0" rIns="0" bIns="0" rtlCol="0" anchor="ctr"/>
+          <a:lstStyle/>
+          <a:p>
+            <a:pPr algn="ctr" indent="0" marL="0">
+              <a:buNone/>
+            </a:pPr>
+            <a:r>
+              <a:rPr lang="en-US" sz="1300" b="1" dirty="0">
+                <a:solidFill>
+                  <a:schemeClr val="bg1"/>
+                </a:solidFill>
+              </a:rPr>
+              <a:t>구매 확정</a:t>
+            </a:r>
+            <a:endParaRPr lang="en-US" sz="1300" dirty="0"/>
+          </a:p>
+        </p:txBody>
+      </p:sp>
+      <p:sp>
+        <p:nvSpPr>
+          <p:cNvPr id="16" name="Text 14"/>
+          <p:cNvSpPr txBox="1"/>
+          <p:nvPr/>
+        </p:nvSpPr>
+        <p:spPr>
+          <a:xfrm>
+            <a:off x="457200" y="2286000"/>
+            <a:ext cx="8229600" cy="365760"/>
+          </a:xfrm>
+          <a:prstGeom prst="rect">
+            <a:avLst/>
+          </a:prstGeom>
+          <a:noFill/>
+          <a:ln/>
+        </p:spPr>
+        <p:txBody>
+          <a:bodyPr wrap="square" lIns="0" tIns="0" rIns="0" bIns="0" rtlCol="0" anchor="t"/>
+          <a:lstStyle/>
+          <a:p>
+            <a:pPr indent="0" marL="0">
+              <a:buNone/>
+            </a:pPr>
+            <a:r>
+              <a:rPr lang="en-US" sz="1200" dirty="0">
+                <a:solidFill>
+                  <a:schemeClr val="accent4"/>
+                </a:solidFill>
+              </a:rPr>
+              <a:t>예외 규칙 미리: 출고 전 취소 → 즉시 환불 · 출고 후 → 반품 전환 · 부분 반품 시 쿠폰·배송비</a:t>
+            </a:r>
+            <a:endParaRPr lang="en-US" sz="1200" dirty="0"/>
+          </a:p>
+        </p:txBody>
+      </p:sp>
+      <p:sp>
+        <p:nvSpPr>
+          <p:cNvPr id="17" name="Text 15"/>
+          <p:cNvSpPr txBox="1"/>
+          <p:nvPr/>
+        </p:nvSpPr>
+        <p:spPr>
+          <a:xfrm>
+            <a:off x="457200" y="2788920"/>
+            <a:ext cx="8229600" cy="365760"/>
+          </a:xfrm>
+          <a:prstGeom prst="rect">
+            <a:avLst/>
+          </a:prstGeom>
+          <a:noFill/>
+          <a:ln/>
+        </p:spPr>
+        <p:txBody>
+          <a:bodyPr wrap="square" lIns="0" tIns="0" rIns="0" bIns="0" rtlCol="0" anchor="t"/>
+          <a:lstStyle/>
+          <a:p>
+            <a:pPr indent="0" marL="0">
+              <a:buNone/>
+            </a:pPr>
+            <a:r>
+              <a:rPr lang="en-US" sz="1500" b="1" dirty="0">
+                <a:solidFill>
+                  <a:schemeClr val="tx2"/>
+                </a:solidFill>
+              </a:rPr>
+              <a:t>카드 결제</a:t>
+            </a:r>
+            <a:endParaRPr lang="en-US" sz="1500" dirty="0"/>
+          </a:p>
+        </p:txBody>
+      </p:sp>
+      <p:sp>
+        <p:nvSpPr>
+          <p:cNvPr id="18" name="card"/>
+          <p:cNvSpPr/>
+          <p:nvPr/>
+        </p:nvSpPr>
+        <p:spPr>
+          <a:xfrm>
+            <a:off x="457200" y="3200400"/>
+            <a:ext cx="2606040" cy="822960"/>
+          </a:xfrm>
+          <a:prstGeom prst="roundRect">
+            <a:avLst>
+              <a:gd name="adj" fmla="val 8889"/>
+            </a:avLst>
+          </a:prstGeom>
+          <a:solidFill>
+            <a:schemeClr val="bg2"/>
+          </a:solidFill>
+          <a:ln/>
+        </p:spPr>
+      </p:sp>
+      <p:sp>
+        <p:nvSpPr>
+          <p:cNvPr id="19" name="Text 17"/>
+          <p:cNvSpPr txBox="1"/>
+          <p:nvPr/>
+        </p:nvSpPr>
+        <p:spPr>
+          <a:xfrm>
+            <a:off x="640080" y="3200400"/>
+            <a:ext cx="2286000" cy="822960"/>
+          </a:xfrm>
+          <a:prstGeom prst="rect">
+            <a:avLst/>
+          </a:prstGeom>
+          <a:noFill/>
+          <a:ln/>
+        </p:spPr>
+        <p:txBody>
+          <a:bodyPr wrap="square" lIns="0" tIns="0" rIns="0" bIns="0" rtlCol="0" anchor="ctr"/>
+          <a:lstStyle/>
+          <a:p>
+            <a:pPr indent="0" marL="0">
+              <a:buNone/>
+            </a:pPr>
+            <a:r>
+              <a:rPr lang="en-US" sz="1600" b="1" dirty="0">
+                <a:solidFill>
+                  <a:schemeClr val="accent2"/>
+                </a:solidFill>
+              </a:rPr>
+              <a:t>승인</a:t>
+            </a:r>
+            <a:endParaRPr lang="en-US" sz="1600" dirty="0"/>
+          </a:p>
+          <a:p>
+            <a:pPr indent="0" marL="0">
+              <a:buNone/>
+            </a:pPr>
+            <a:r>
+              <a:rPr lang="en-US" sz="1200" dirty="0">
+                <a:solidFill>
+                  <a:schemeClr val="tx1"/>
+                </a:solidFill>
+              </a:rPr>
+              <a:t>결제 가능 확인 (돈은 아직)</a:t>
+            </a:r>
+            <a:endParaRPr lang="en-US" sz="1600" dirty="0"/>
+          </a:p>
+        </p:txBody>
+      </p:sp>
+      <p:sp>
+        <p:nvSpPr>
+          <p:cNvPr id="20" name="card"/>
+          <p:cNvSpPr/>
+          <p:nvPr/>
+        </p:nvSpPr>
+        <p:spPr>
+          <a:xfrm>
+            <a:off x="3246120" y="3200400"/>
+            <a:ext cx="2606040" cy="822960"/>
+          </a:xfrm>
+          <a:prstGeom prst="roundRect">
+            <a:avLst>
+              <a:gd name="adj" fmla="val 8889"/>
+            </a:avLst>
+          </a:prstGeom>
+          <a:solidFill>
+            <a:schemeClr val="bg2"/>
+          </a:solidFill>
+          <a:ln/>
+        </p:spPr>
+      </p:sp>
+      <p:sp>
+        <p:nvSpPr>
+          <p:cNvPr id="21" name="Text 19"/>
+          <p:cNvSpPr txBox="1"/>
+          <p:nvPr/>
+        </p:nvSpPr>
+        <p:spPr>
+          <a:xfrm>
+            <a:off x="3429000" y="3200400"/>
+            <a:ext cx="2286000" cy="822960"/>
+          </a:xfrm>
+          <a:prstGeom prst="rect">
+            <a:avLst/>
+          </a:prstGeom>
+          <a:noFill/>
+          <a:ln/>
+        </p:spPr>
+        <p:txBody>
+          <a:bodyPr wrap="square" lIns="0" tIns="0" rIns="0" bIns="0" rtlCol="0" anchor="ctr"/>
+          <a:lstStyle/>
+          <a:p>
+            <a:pPr indent="0" marL="0">
+              <a:buNone/>
+            </a:pPr>
+            <a:r>
+              <a:rPr lang="en-US" sz="1600" b="1" dirty="0">
+                <a:solidFill>
+                  <a:schemeClr val="accent2"/>
+                </a:solidFill>
+              </a:rPr>
+              <a:t>매입</a:t>
+            </a:r>
+            <a:endParaRPr lang="en-US" sz="1600" dirty="0"/>
+          </a:p>
+          <a:p>
+            <a:pPr indent="0" marL="0">
+              <a:buNone/>
+            </a:pPr>
+            <a:r>
+              <a:rPr lang="en-US" sz="1200" dirty="0">
+                <a:solidFill>
+                  <a:schemeClr val="tx1"/>
+                </a:solidFill>
+              </a:rPr>
+              <a:t>청구 확정</a:t>
+            </a:r>
+            <a:endParaRPr lang="en-US" sz="1600" dirty="0"/>
+          </a:p>
+        </p:txBody>
+      </p:sp>
+      <p:sp>
+        <p:nvSpPr>
+          <p:cNvPr id="22" name="card"/>
+          <p:cNvSpPr/>
+          <p:nvPr/>
+        </p:nvSpPr>
+        <p:spPr>
+          <a:xfrm>
+            <a:off x="6035040" y="3200400"/>
+            <a:ext cx="2606040" cy="822960"/>
+          </a:xfrm>
+          <a:prstGeom prst="roundRect">
+            <a:avLst>
+              <a:gd name="adj" fmla="val 8889"/>
+            </a:avLst>
+          </a:prstGeom>
+          <a:solidFill>
+            <a:schemeClr val="bg2"/>
+          </a:solidFill>
+          <a:ln/>
+        </p:spPr>
+      </p:sp>
+      <p:sp>
+        <p:nvSpPr>
+          <p:cNvPr id="23" name="Text 21"/>
+          <p:cNvSpPr txBox="1"/>
+          <p:nvPr/>
+        </p:nvSpPr>
+        <p:spPr>
+          <a:xfrm>
+            <a:off x="6217920" y="3200400"/>
+            <a:ext cx="2286000" cy="822960"/>
+          </a:xfrm>
+          <a:prstGeom prst="rect">
+            <a:avLst/>
+          </a:prstGeom>
+          <a:noFill/>
+          <a:ln/>
+        </p:spPr>
+        <p:txBody>
+          <a:bodyPr wrap="square" lIns="0" tIns="0" rIns="0" bIns="0" rtlCol="0" anchor="ctr"/>
+          <a:lstStyle/>
+          <a:p>
+            <a:pPr indent="0" marL="0">
+              <a:buNone/>
+            </a:pPr>
+            <a:r>
+              <a:rPr lang="en-US" sz="1600" b="1" dirty="0">
+                <a:solidFill>
+                  <a:schemeClr val="accent2"/>
+                </a:solidFill>
+              </a:rPr>
+              <a:t>정산</a:t>
+            </a:r>
+            <a:endParaRPr lang="en-US" sz="1600" dirty="0"/>
+          </a:p>
+          <a:p>
+            <a:pPr indent="0" marL="0">
+              <a:buNone/>
+            </a:pPr>
+            <a:r>
+              <a:rPr lang="en-US" sz="1200" dirty="0">
+                <a:solidFill>
+                  <a:schemeClr val="tx1"/>
+                </a:solidFill>
+              </a:rPr>
+              <a:t>수수료 빼고 D+N일 입금</a:t>
+            </a:r>
+            <a:endParaRPr lang="en-US" sz="1600" dirty="0"/>
+          </a:p>
+        </p:txBody>
+      </p:sp>
+      <p:sp>
+        <p:nvSpPr>
+          <p:cNvPr id="24" name="Text 22"/>
+          <p:cNvSpPr txBox="1"/>
+          <p:nvPr/>
+        </p:nvSpPr>
+        <p:spPr>
+          <a:xfrm>
+            <a:off x="457200" y="4645152"/>
+            <a:ext cx="7680960" cy="274320"/>
+          </a:xfrm>
+          <a:prstGeom prst="rect">
+            <a:avLst/>
+          </a:prstGeom>
+          <a:noFill/>
+          <a:ln/>
+        </p:spPr>
+        <p:txBody>
+          <a:bodyPr wrap="square" lIns="0" tIns="0" rIns="0" bIns="0" rtlCol="0" anchor="t"/>
+          <a:lstStyle/>
+          <a:p>
+            <a:pPr indent="0" marL="0">
+              <a:buNone/>
+            </a:pPr>
+            <a:r>
+              <a:rPr lang="en-US" sz="1000" dirty="0">
+                <a:solidFill>
+                  <a:schemeClr val="accent4"/>
+                </a:solidFill>
+              </a:rPr>
+              <a:t>결제 핵심 설계: 멱등성(두 번 눌러도 한 번만) · 매일 PG 내역과 주문 대사 (35장)</a:t>
+            </a:r>
+            <a:endParaRPr lang="en-US" sz="1000" dirty="0"/>
+          </a:p>
+        </p:txBody>
+      </p:sp>
+      <p:sp>
+        <p:nvSpPr>
+          <p:cNvPr id="25" name="Slide Number Placeholder 0"/>
+          <p:cNvSpPr>
+            <a:spLocks noGrp="1"/>
+          </p:cNvSpPr>
+          <p:nvPr>
+            <p:ph type="sldNum" sz="quarter" idx="4294967295"/>
+          </p:nvPr>
+        </p:nvSpPr>
+        <p:spPr>
+          <a:xfrm>
+            <a:off x="8321040" y="4754880"/>
+            <a:ext cx="457200" cy="274320"/>
+          </a:xfrm>
+          <a:prstGeom prst="rect">
+            <a:avLst/>
+          </a:prstGeom>
+          <a:extLst>
+            <a:ext uri="{C572A759-6A51-4108-AA02-DFA0A04FC94B}">
+              <ma14:wrappingTextBoxFlag xmlns:ma14="http://schemas.microsoft.com/office/mac/drawingml/2011/main" val="0"/>
+            </a:ext>
+          </a:extLst>
+        </p:spPr>
+        <p:txBody>
+          <a:bodyPr/>
+          <a:lstStyle>
+            <a:lvl1pPr>
+              <a:defRPr sz="1000">
+                <a:solidFill>
+                  <a:schemeClr val="accent4"/>
+                </a:solidFill>
+              </a:defRPr>
+            </a:lvl1pPr>
+          </a:lstStyle>
+          <a:p>
+            <a:pPr algn="r"/>
+            <a:fld id="{F7021451-1387-4CA6-816F-3879F97B5CBC}" type="slidenum">
+              <a:rPr b="0" lang="en-US"/>
+              <a:t>53</a:t>
+            </a:fld>
+            <a:endParaRPr lang="en-US"/>
+          </a:p>
+        </p:txBody>
+      </p:sp>
+    </p:spTree>
+  </p:cSld>
+  <p:clrMapOvr>
+    <a:masterClrMapping/>
+  </p:clrMapOvr>
+</p:sld>
+</file>
+
+<file path=ppt/slides/slide54.xml><?xml version="1.0" encoding="utf-8"?>
+<p:sld xmlns:a="http://schemas.openxmlformats.org/drawingml/2006/main" xmlns:r="http://schemas.openxmlformats.org/officeDocument/2006/relationships" xmlns:p="http://schemas.openxmlformats.org/presentationml/2006/main">
+  <p:cSld name="Slide 54">
+    <p:spTree>
+      <p:nvGrpSpPr>
+        <p:cNvPr id="1" name=""/>
+        <p:cNvGrpSpPr/>
+        <p:nvPr/>
+      </p:nvGrpSpPr>
+      <p:grpSpPr>
+        <a:xfrm>
+          <a:off x="0" y="0"/>
+          <a:ext cx="0" cy="0"/>
+          <a:chOff x="0" y="0"/>
+          <a:chExt cx="0" cy="0"/>
+        </a:xfrm>
+      </p:grpSpPr>
+      <p:sp>
+        <p:nvSpPr>
+          <p:cNvPr id="2" name="Text 0"/>
+          <p:cNvSpPr/>
+          <p:nvPr>
+            <p:ph idx="100" type="title" hasCustomPrompt="1"/>
+          </p:nvPr>
+        </p:nvSpPr>
+        <p:spPr>
+          <a:xfrm>
+            <a:off x="457200" y="274320"/>
+            <a:ext cx="8229600" cy="685800"/>
+          </a:xfrm>
+          <a:prstGeom prst="rect">
+            <a:avLst/>
+          </a:prstGeom>
+          <a:noFill/>
+          <a:ln/>
+        </p:spPr>
+        <p:txBody>
+          <a:bodyPr wrap="square" lIns="0" tIns="0" rIns="0" bIns="0" rtlCol="0" anchor="ctr"/>
+          <a:lstStyle/>
+          <a:p>
+            <a:pPr indent="0" marL="0">
+              <a:buNone/>
+            </a:pPr>
+            <a:r>
+              <a:rPr lang="en-US" sz="2800" b="1" dirty="0">
+                <a:solidFill>
+                  <a:schemeClr val="tx2"/>
+                </a:solidFill>
+              </a:rPr>
+              <a:t>핵심 흐름 ②: 분야별 꼭 알 단어</a:t>
+            </a:r>
+            <a:endParaRPr lang="en-US" sz="2800" dirty="0"/>
+          </a:p>
+        </p:txBody>
+      </p:sp>
+      <p:graphicFrame>
+        <p:nvGraphicFramePr>
+          <p:cNvPr id="55" name="Table 0"/>
+          <p:cNvGraphicFramePr>
+            <a:graphicFrameLocks noGrp="1"/>
+          </p:cNvGraphicFramePr>
+          <p:nvPr>
+            <p:extLst>
+              <p:ext uri="{D42A27DB-BD31-4B8C-83A1-F6EECF244321}">
+                <p14:modId xmlns:p14="http://schemas.microsoft.com/office/powerpoint/2010/main" val="1579011935"/>
+              </p:ext>
+            </p:extLst>
+          </p:nvPr>
+        </p:nvGraphicFramePr>
+        <p:xfrm>
+          <a:off x="457200" y="1143000"/>
+          <a:ext cx="8229600" cy="914400"/>
+        </p:xfrm>
+        <a:graphic>
+          <a:graphicData uri="http://schemas.openxmlformats.org/drawingml/2006/table">
+            <a:tbl>
+              <a:tblPr/>
+              <a:tblGrid>
+                <a:gridCol w="1554480"/>
+                <a:gridCol w="6675120"/>
+              </a:tblGrid>
+              <a:tr h="457200">
+                <a:tc>
+                  <a:txBody>
+                    <a:bodyPr/>
+                    <a:lstStyle/>
+                    <a:p>
+                      <a:pPr indent="0" marL="0">
+                        <a:buNone/>
+                      </a:pPr>
+                      <a:r>
+                        <a:rPr lang="en-US" sz="1200" b="1" dirty="0">
+                          <a:solidFill>
+                            <a:schemeClr val="bg1"/>
+                          </a:solidFill>
+                        </a:rPr>
+                        <a:t>분야</a:t>
+                      </a:r>
+                      <a:endParaRPr lang="en-US" sz="1200" dirty="0"/>
+                    </a:p>
+                  </a:txBody>
+                  <a:tcPr marL="91440" marR="91440" marT="45720" marB="45720" anchor="ctr">
+                    <a:lnL w="12700" cap="flat" cmpd="sng" algn="ctr">
+                      <a:solidFill>
+                        <a:srgbClr val="EEF4F3"/>
+                      </a:solidFill>
+                      <a:prstDash val="solid"/>
+                      <a:round/>
+                      <a:headEnd type="none" w="med" len="med"/>
+                      <a:tailEnd type="none" w="med" len="med"/>
+                    </a:lnL>
+                    <a:lnR w="12700" cap="flat" cmpd="sng" algn="ctr">
+                      <a:solidFill>
+                        <a:srgbClr val="EEF4F3"/>
+                      </a:solidFill>
+                      <a:prstDash val="solid"/>
+                      <a:round/>
+                      <a:headEnd type="none" w="med" len="med"/>
+                      <a:tailEnd type="none" w="med" len="med"/>
+                    </a:lnR>
+                    <a:lnT w="12700" cap="flat" cmpd="sng" algn="ctr">
+                      <a:solidFill>
+                        <a:srgbClr val="EEF4F3"/>
+                      </a:solidFill>
+                      <a:prstDash val="solid"/>
+                      <a:round/>
+                      <a:headEnd type="none" w="med" len="med"/>
+                      <a:tailEnd type="none" w="med" len="med"/>
+                    </a:lnT>
+                    <a:lnB w="12700" cap="flat" cmpd="sng" algn="ctr">
+                      <a:solidFill>
+                        <a:srgbClr val="EEF4F3"/>
+                      </a:solidFill>
+                      <a:prstDash val="solid"/>
+                      <a:round/>
+                      <a:headEnd type="none" w="med" len="med"/>
+                      <a:tailEnd type="none" w="med" len="med"/>
+                    </a:lnB>
+                    <a:solidFill>
+                      <a:schemeClr val="tx2"/>
+                    </a:solidFill>
+                  </a:tcPr>
+                </a:tc>
+                <a:tc>
+                  <a:txBody>
+                    <a:bodyPr/>
+                    <a:lstStyle/>
+                    <a:p>
+                      <a:pPr indent="0" marL="0">
+                        <a:buNone/>
+                      </a:pPr>
+                      <a:r>
+                        <a:rPr lang="en-US" sz="1200" b="1" dirty="0">
+                          <a:solidFill>
+                            <a:schemeClr val="bg1"/>
+                          </a:solidFill>
+                        </a:rPr>
+                        <a:t>꼭 알 흐름·단어</a:t>
+                      </a:r>
+                      <a:endParaRPr lang="en-US" sz="1200" dirty="0"/>
+                    </a:p>
+                  </a:txBody>
+                  <a:tcPr marL="91440" marR="91440" marT="45720" marB="45720" anchor="ctr">
+                    <a:lnL w="12700" cap="flat" cmpd="sng" algn="ctr">
+                      <a:solidFill>
+                        <a:srgbClr val="EEF4F3"/>
+                      </a:solidFill>
+                      <a:prstDash val="solid"/>
+                      <a:round/>
+                      <a:headEnd type="none" w="med" len="med"/>
+                      <a:tailEnd type="none" w="med" len="med"/>
+                    </a:lnL>
+                    <a:lnR w="12700" cap="flat" cmpd="sng" algn="ctr">
+                      <a:solidFill>
+                        <a:srgbClr val="EEF4F3"/>
+                      </a:solidFill>
+                      <a:prstDash val="solid"/>
+                      <a:round/>
+                      <a:headEnd type="none" w="med" len="med"/>
+                      <a:tailEnd type="none" w="med" len="med"/>
+                    </a:lnR>
+                    <a:lnT w="12700" cap="flat" cmpd="sng" algn="ctr">
+                      <a:solidFill>
+                        <a:srgbClr val="EEF4F3"/>
+                      </a:solidFill>
+                      <a:prstDash val="solid"/>
+                      <a:round/>
+                      <a:headEnd type="none" w="med" len="med"/>
+                      <a:tailEnd type="none" w="med" len="med"/>
+                    </a:lnT>
+                    <a:lnB w="12700" cap="flat" cmpd="sng" algn="ctr">
+                      <a:solidFill>
+                        <a:srgbClr val="EEF4F3"/>
+                      </a:solidFill>
+                      <a:prstDash val="solid"/>
+                      <a:round/>
+                      <a:headEnd type="none" w="med" len="med"/>
+                      <a:tailEnd type="none" w="med" len="med"/>
+                    </a:lnB>
+                    <a:solidFill>
+                      <a:schemeClr val="tx2"/>
+                    </a:solidFill>
+                  </a:tcPr>
+                </a:tc>
+              </a:tr>
+              <a:tr h="457200">
+                <a:tc>
+                  <a:txBody>
+                    <a:bodyPr/>
+                    <a:lstStyle/>
+                    <a:p>
+                      <a:pPr indent="0" marL="0">
+                        <a:buNone/>
+                      </a:pPr>
+                      <a:r>
+                        <a:rPr lang="en-US" sz="1200" b="1" dirty="0">
+                          <a:solidFill>
+                            <a:schemeClr val="tx1"/>
+                          </a:solidFill>
+                        </a:rPr>
+                        <a:t>물류</a:t>
+                      </a:r>
+                      <a:endParaRPr lang="en-US" sz="1200" dirty="0"/>
+                    </a:p>
+                  </a:txBody>
+                  <a:tcPr marL="91440" marR="91440" marT="45720" marB="45720" anchor="ctr">
+                    <a:lnL w="12700" cap="flat" cmpd="sng" algn="ctr">
+                      <a:solidFill>
+                        <a:srgbClr val="EEF4F3"/>
+                      </a:solidFill>
+                      <a:prstDash val="solid"/>
+                      <a:round/>
+                      <a:headEnd type="none" w="med" len="med"/>
+                      <a:tailEnd type="none" w="med" len="med"/>
+                    </a:lnL>
+                    <a:lnR w="12700" cap="flat" cmpd="sng" algn="ctr">
+                      <a:solidFill>
+                        <a:srgbClr val="EEF4F3"/>
+                      </a:solidFill>
+                      <a:prstDash val="solid"/>
+                      <a:round/>
+                      <a:headEnd type="none" w="med" len="med"/>
+                      <a:tailEnd type="none" w="med" len="med"/>
+                    </a:lnR>
+                    <a:lnT w="12700" cap="flat" cmpd="sng" algn="ctr">
+                      <a:solidFill>
+                        <a:srgbClr val="EEF4F3"/>
+                      </a:solidFill>
+                      <a:prstDash val="solid"/>
+                      <a:round/>
+                      <a:headEnd type="none" w="med" len="med"/>
+                      <a:tailEnd type="none" w="med" len="med"/>
+                    </a:lnT>
+                    <a:lnB w="12700" cap="flat" cmpd="sng" algn="ctr">
+                      <a:solidFill>
+                        <a:srgbClr val="EEF4F3"/>
+                      </a:solidFill>
+                      <a:prstDash val="solid"/>
+                      <a:round/>
+                      <a:headEnd type="none" w="med" len="med"/>
+                      <a:tailEnd type="none" w="med" len="med"/>
+                    </a:lnB>
+                  </a:tcPr>
+                </a:tc>
+                <a:tc>
+                  <a:txBody>
+                    <a:bodyPr/>
+                    <a:lstStyle/>
+                    <a:p>
+                      <a:pPr indent="0" marL="0">
+                        <a:buNone/>
+                      </a:pPr>
+                      <a:r>
+                        <a:rPr lang="en-US" sz="1200" dirty="0">
+                          <a:solidFill>
+                            <a:schemeClr val="tx1"/>
+                          </a:solidFill>
+                        </a:rPr>
+                        <a:t>입고 → 피킹 → 패킹 → 출고 → 배송 · 송장 · 합포장 · 3PL vs 풀필먼트</a:t>
+                      </a:r>
+                      <a:endParaRPr lang="en-US" sz="1200" dirty="0"/>
+                    </a:p>
+                  </a:txBody>
+                  <a:tcPr marL="91440" marR="91440" marT="45720" marB="45720" anchor="ctr">
+                    <a:lnL w="12700" cap="flat" cmpd="sng" algn="ctr">
+                      <a:solidFill>
+                        <a:srgbClr val="EEF4F3"/>
+                      </a:solidFill>
+                      <a:prstDash val="solid"/>
+                      <a:round/>
+                      <a:headEnd type="none" w="med" len="med"/>
+                      <a:tailEnd type="none" w="med" len="med"/>
+                    </a:lnL>
+                    <a:lnR w="12700" cap="flat" cmpd="sng" algn="ctr">
+                      <a:solidFill>
+                        <a:srgbClr val="EEF4F3"/>
+                      </a:solidFill>
+                      <a:prstDash val="solid"/>
+                      <a:round/>
+                      <a:headEnd type="none" w="med" len="med"/>
+                      <a:tailEnd type="none" w="med" len="med"/>
+                    </a:lnR>
+                    <a:lnT w="12700" cap="flat" cmpd="sng" algn="ctr">
+                      <a:solidFill>
+                        <a:srgbClr val="EEF4F3"/>
+                      </a:solidFill>
+                      <a:prstDash val="solid"/>
+                      <a:round/>
+                      <a:headEnd type="none" w="med" len="med"/>
+                      <a:tailEnd type="none" w="med" len="med"/>
+                    </a:lnT>
+                    <a:lnB w="12700" cap="flat" cmpd="sng" algn="ctr">
+                      <a:solidFill>
+                        <a:srgbClr val="EEF4F3"/>
+                      </a:solidFill>
+                      <a:prstDash val="solid"/>
+                      <a:round/>
+                      <a:headEnd type="none" w="med" len="med"/>
+                      <a:tailEnd type="none" w="med" len="med"/>
+                    </a:lnB>
+                  </a:tcPr>
+                </a:tc>
+              </a:tr>
+              <a:tr h="457200">
+                <a:tc>
+                  <a:txBody>
+                    <a:bodyPr/>
+                    <a:lstStyle/>
+                    <a:p>
+                      <a:pPr indent="0" marL="0">
+                        <a:buNone/>
+                      </a:pPr>
+                      <a:r>
+                        <a:rPr lang="en-US" sz="1200" b="1" dirty="0">
+                          <a:solidFill>
+                            <a:schemeClr val="tx1"/>
+                          </a:solidFill>
+                        </a:rPr>
+                        <a:t>광고</a:t>
+                      </a:r>
+                      <a:endParaRPr lang="en-US" sz="1200" dirty="0"/>
+                    </a:p>
+                  </a:txBody>
+                  <a:tcPr marL="91440" marR="91440" marT="45720" marB="45720" anchor="ctr">
+                    <a:lnL w="12700" cap="flat" cmpd="sng" algn="ctr">
+                      <a:solidFill>
+                        <a:srgbClr val="EEF4F3"/>
+                      </a:solidFill>
+                      <a:prstDash val="solid"/>
+                      <a:round/>
+                      <a:headEnd type="none" w="med" len="med"/>
+                      <a:tailEnd type="none" w="med" len="med"/>
+                    </a:lnL>
+                    <a:lnR w="12700" cap="flat" cmpd="sng" algn="ctr">
+                      <a:solidFill>
+                        <a:srgbClr val="EEF4F3"/>
+                      </a:solidFill>
+                      <a:prstDash val="solid"/>
+                      <a:round/>
+                      <a:headEnd type="none" w="med" len="med"/>
+                      <a:tailEnd type="none" w="med" len="med"/>
+                    </a:lnR>
+                    <a:lnT w="12700" cap="flat" cmpd="sng" algn="ctr">
+                      <a:solidFill>
+                        <a:srgbClr val="EEF4F3"/>
+                      </a:solidFill>
+                      <a:prstDash val="solid"/>
+                      <a:round/>
+                      <a:headEnd type="none" w="med" len="med"/>
+                      <a:tailEnd type="none" w="med" len="med"/>
+                    </a:lnT>
+                    <a:lnB w="12700" cap="flat" cmpd="sng" algn="ctr">
+                      <a:solidFill>
+                        <a:srgbClr val="EEF4F3"/>
+                      </a:solidFill>
+                      <a:prstDash val="solid"/>
+                      <a:round/>
+                      <a:headEnd type="none" w="med" len="med"/>
+                      <a:tailEnd type="none" w="med" len="med"/>
+                    </a:lnB>
+                  </a:tcPr>
+                </a:tc>
+                <a:tc>
+                  <a:txBody>
+                    <a:bodyPr/>
+                    <a:lstStyle/>
+                    <a:p>
+                      <a:pPr indent="0" marL="0">
+                        <a:buNone/>
+                      </a:pPr>
+                      <a:r>
+                        <a:rPr lang="en-US" sz="1200" dirty="0">
+                          <a:solidFill>
+                            <a:schemeClr val="tx1"/>
+                          </a:solidFill>
+                        </a:rPr>
+                        <a:t>광고주 DSP ↔ 익스체인지(RTB 경매) ↔ SSP 퍼블리셔 · 어트리뷰션 · 퍼스트파티 데이터</a:t>
+                      </a:r>
+                      <a:endParaRPr lang="en-US" sz="1200" dirty="0"/>
+                    </a:p>
+                  </a:txBody>
+                  <a:tcPr marL="91440" marR="91440" marT="45720" marB="45720" anchor="ctr">
+                    <a:lnL w="12700" cap="flat" cmpd="sng" algn="ctr">
+                      <a:solidFill>
+                        <a:srgbClr val="EEF4F3"/>
+                      </a:solidFill>
+                      <a:prstDash val="solid"/>
+                      <a:round/>
+                      <a:headEnd type="none" w="med" len="med"/>
+                      <a:tailEnd type="none" w="med" len="med"/>
+                    </a:lnL>
+                    <a:lnR w="12700" cap="flat" cmpd="sng" algn="ctr">
+                      <a:solidFill>
+                        <a:srgbClr val="EEF4F3"/>
+                      </a:solidFill>
+                      <a:prstDash val="solid"/>
+                      <a:round/>
+                      <a:headEnd type="none" w="med" len="med"/>
+                      <a:tailEnd type="none" w="med" len="med"/>
+                    </a:lnR>
+                    <a:lnT w="12700" cap="flat" cmpd="sng" algn="ctr">
+                      <a:solidFill>
+                        <a:srgbClr val="EEF4F3"/>
+                      </a:solidFill>
+                      <a:prstDash val="solid"/>
+                      <a:round/>
+                      <a:headEnd type="none" w="med" len="med"/>
+                      <a:tailEnd type="none" w="med" len="med"/>
+                    </a:lnT>
+                    <a:lnB w="12700" cap="flat" cmpd="sng" algn="ctr">
+                      <a:solidFill>
+                        <a:srgbClr val="EEF4F3"/>
+                      </a:solidFill>
+                      <a:prstDash val="solid"/>
+                      <a:round/>
+                      <a:headEnd type="none" w="med" len="med"/>
+                      <a:tailEnd type="none" w="med" len="med"/>
+                    </a:lnB>
+                  </a:tcPr>
+                </a:tc>
+              </a:tr>
+              <a:tr h="457200">
+                <a:tc>
+                  <a:txBody>
+                    <a:bodyPr/>
+                    <a:lstStyle/>
+                    <a:p>
+                      <a:pPr indent="0" marL="0">
+                        <a:buNone/>
+                      </a:pPr>
+                      <a:r>
+                        <a:rPr lang="en-US" sz="1200" b="1" dirty="0">
+                          <a:solidFill>
+                            <a:schemeClr val="tx1"/>
+                          </a:solidFill>
+                        </a:rPr>
+                        <a:t>게임</a:t>
+                      </a:r>
+                      <a:endParaRPr lang="en-US" sz="1200" dirty="0"/>
+                    </a:p>
+                  </a:txBody>
+                  <a:tcPr marL="91440" marR="91440" marT="45720" marB="45720" anchor="ctr">
+                    <a:lnL w="12700" cap="flat" cmpd="sng" algn="ctr">
+                      <a:solidFill>
+                        <a:srgbClr val="EEF4F3"/>
+                      </a:solidFill>
+                      <a:prstDash val="solid"/>
+                      <a:round/>
+                      <a:headEnd type="none" w="med" len="med"/>
+                      <a:tailEnd type="none" w="med" len="med"/>
+                    </a:lnL>
+                    <a:lnR w="12700" cap="flat" cmpd="sng" algn="ctr">
+                      <a:solidFill>
+                        <a:srgbClr val="EEF4F3"/>
+                      </a:solidFill>
+                      <a:prstDash val="solid"/>
+                      <a:round/>
+                      <a:headEnd type="none" w="med" len="med"/>
+                      <a:tailEnd type="none" w="med" len="med"/>
+                    </a:lnR>
+                    <a:lnT w="12700" cap="flat" cmpd="sng" algn="ctr">
+                      <a:solidFill>
+                        <a:srgbClr val="EEF4F3"/>
+                      </a:solidFill>
+                      <a:prstDash val="solid"/>
+                      <a:round/>
+                      <a:headEnd type="none" w="med" len="med"/>
+                      <a:tailEnd type="none" w="med" len="med"/>
+                    </a:lnT>
+                    <a:lnB w="12700" cap="flat" cmpd="sng" algn="ctr">
+                      <a:solidFill>
+                        <a:srgbClr val="EEF4F3"/>
+                      </a:solidFill>
+                      <a:prstDash val="solid"/>
+                      <a:round/>
+                      <a:headEnd type="none" w="med" len="med"/>
+                      <a:tailEnd type="none" w="med" len="med"/>
+                    </a:lnB>
+                  </a:tcPr>
+                </a:tc>
+                <a:tc>
+                  <a:txBody>
+                    <a:bodyPr/>
+                    <a:lstStyle/>
+                    <a:p>
+                      <a:pPr indent="0" marL="0">
+                        <a:buNone/>
+                      </a:pPr>
+                      <a:r>
+                        <a:rPr lang="en-US" sz="1200" dirty="0">
+                          <a:solidFill>
+                            <a:schemeClr val="tx1"/>
+                          </a:solidFill>
+                        </a:rPr>
+                        <a:t>BM(F2P·패스·가챠) · 라이브 옵스 · ARPPU · 리텐션 · 치팅</a:t>
+                      </a:r>
+                      <a:endParaRPr lang="en-US" sz="1200" dirty="0"/>
+                    </a:p>
+                  </a:txBody>
+                  <a:tcPr marL="91440" marR="91440" marT="45720" marB="45720" anchor="ctr">
+                    <a:lnL w="12700" cap="flat" cmpd="sng" algn="ctr">
+                      <a:solidFill>
+                        <a:srgbClr val="EEF4F3"/>
+                      </a:solidFill>
+                      <a:prstDash val="solid"/>
+                      <a:round/>
+                      <a:headEnd type="none" w="med" len="med"/>
+                      <a:tailEnd type="none" w="med" len="med"/>
+                    </a:lnL>
+                    <a:lnR w="12700" cap="flat" cmpd="sng" algn="ctr">
+                      <a:solidFill>
+                        <a:srgbClr val="EEF4F3"/>
+                      </a:solidFill>
+                      <a:prstDash val="solid"/>
+                      <a:round/>
+                      <a:headEnd type="none" w="med" len="med"/>
+                      <a:tailEnd type="none" w="med" len="med"/>
+                    </a:lnR>
+                    <a:lnT w="12700" cap="flat" cmpd="sng" algn="ctr">
+                      <a:solidFill>
+                        <a:srgbClr val="EEF4F3"/>
+                      </a:solidFill>
+                      <a:prstDash val="solid"/>
+                      <a:round/>
+                      <a:headEnd type="none" w="med" len="med"/>
+                      <a:tailEnd type="none" w="med" len="med"/>
+                    </a:lnT>
+                    <a:lnB w="12700" cap="flat" cmpd="sng" algn="ctr">
+                      <a:solidFill>
+                        <a:srgbClr val="EEF4F3"/>
+                      </a:solidFill>
+                      <a:prstDash val="solid"/>
+                      <a:round/>
+                      <a:headEnd type="none" w="med" len="med"/>
+                      <a:tailEnd type="none" w="med" len="med"/>
+                    </a:lnB>
+                  </a:tcPr>
+                </a:tc>
+              </a:tr>
+              <a:tr h="457200">
+                <a:tc>
+                  <a:txBody>
+                    <a:bodyPr/>
+                    <a:lstStyle/>
+                    <a:p>
+                      <a:pPr indent="0" marL="0">
+                        <a:buNone/>
+                      </a:pPr>
+                      <a:r>
+                        <a:rPr lang="en-US" sz="1200" b="1" dirty="0">
+                          <a:solidFill>
+                            <a:schemeClr val="tx1"/>
+                          </a:solidFill>
+                        </a:rPr>
+                        <a:t>구독·SaaS</a:t>
+                      </a:r>
+                      <a:endParaRPr lang="en-US" sz="1200" dirty="0"/>
+                    </a:p>
+                  </a:txBody>
+                  <a:tcPr marL="91440" marR="91440" marT="45720" marB="45720" anchor="ctr">
+                    <a:lnL w="12700" cap="flat" cmpd="sng" algn="ctr">
+                      <a:solidFill>
+                        <a:srgbClr val="EEF4F3"/>
+                      </a:solidFill>
+                      <a:prstDash val="solid"/>
+                      <a:round/>
+                      <a:headEnd type="none" w="med" len="med"/>
+                      <a:tailEnd type="none" w="med" len="med"/>
+                    </a:lnL>
+                    <a:lnR w="12700" cap="flat" cmpd="sng" algn="ctr">
+                      <a:solidFill>
+                        <a:srgbClr val="EEF4F3"/>
+                      </a:solidFill>
+                      <a:prstDash val="solid"/>
+                      <a:round/>
+                      <a:headEnd type="none" w="med" len="med"/>
+                      <a:tailEnd type="none" w="med" len="med"/>
+                    </a:lnR>
+                    <a:lnT w="12700" cap="flat" cmpd="sng" algn="ctr">
+                      <a:solidFill>
+                        <a:srgbClr val="EEF4F3"/>
+                      </a:solidFill>
+                      <a:prstDash val="solid"/>
+                      <a:round/>
+                      <a:headEnd type="none" w="med" len="med"/>
+                      <a:tailEnd type="none" w="med" len="med"/>
+                    </a:lnT>
+                    <a:lnB w="12700" cap="flat" cmpd="sng" algn="ctr">
+                      <a:solidFill>
+                        <a:srgbClr val="EEF4F3"/>
+                      </a:solidFill>
+                      <a:prstDash val="solid"/>
+                      <a:round/>
+                      <a:headEnd type="none" w="med" len="med"/>
+                      <a:tailEnd type="none" w="med" len="med"/>
+                    </a:lnB>
+                  </a:tcPr>
+                </a:tc>
+                <a:tc>
+                  <a:txBody>
+                    <a:bodyPr/>
+                    <a:lstStyle/>
+                    <a:p>
+                      <a:pPr indent="0" marL="0">
+                        <a:buNone/>
+                      </a:pPr>
+                      <a:r>
+                        <a:rPr lang="en-US" sz="1200" dirty="0">
+                          <a:solidFill>
+                            <a:schemeClr val="tx1"/>
+                          </a:solidFill>
+                        </a:rPr>
+                        <a:t>트라이얼 → 유료 전환 · 프로레이션 · 더닝(결제 실패 재시도) · 멀티 테넌시</a:t>
+                      </a:r>
+                      <a:endParaRPr lang="en-US" sz="1200" dirty="0"/>
+                    </a:p>
+                  </a:txBody>
+                  <a:tcPr marL="91440" marR="91440" marT="45720" marB="45720" anchor="ctr">
+                    <a:lnL w="12700" cap="flat" cmpd="sng" algn="ctr">
+                      <a:solidFill>
+                        <a:srgbClr val="EEF4F3"/>
+                      </a:solidFill>
+                      <a:prstDash val="solid"/>
+                      <a:round/>
+                      <a:headEnd type="none" w="med" len="med"/>
+                      <a:tailEnd type="none" w="med" len="med"/>
+                    </a:lnL>
+                    <a:lnR w="12700" cap="flat" cmpd="sng" algn="ctr">
+                      <a:solidFill>
+                        <a:srgbClr val="EEF4F3"/>
+                      </a:solidFill>
+                      <a:prstDash val="solid"/>
+                      <a:round/>
+                      <a:headEnd type="none" w="med" len="med"/>
+                      <a:tailEnd type="none" w="med" len="med"/>
+                    </a:lnR>
+                    <a:lnT w="12700" cap="flat" cmpd="sng" algn="ctr">
+                      <a:solidFill>
+                        <a:srgbClr val="EEF4F3"/>
+                      </a:solidFill>
+                      <a:prstDash val="solid"/>
+                      <a:round/>
+                      <a:headEnd type="none" w="med" len="med"/>
+                      <a:tailEnd type="none" w="med" len="med"/>
+                    </a:lnT>
+                    <a:lnB w="12700" cap="flat" cmpd="sng" algn="ctr">
+                      <a:solidFill>
+                        <a:srgbClr val="EEF4F3"/>
+                      </a:solidFill>
+                      <a:prstDash val="solid"/>
+                      <a:round/>
+                      <a:headEnd type="none" w="med" len="med"/>
+                      <a:tailEnd type="none" w="med" len="med"/>
+                    </a:lnB>
+                  </a:tcPr>
+                </a:tc>
+              </a:tr>
+              <a:tr h="457200">
+                <a:tc>
+                  <a:txBody>
+                    <a:bodyPr/>
+                    <a:lstStyle/>
+                    <a:p>
+                      <a:pPr indent="0" marL="0">
+                        <a:buNone/>
+                      </a:pPr>
+                      <a:r>
+                        <a:rPr lang="en-US" sz="1200" b="1" dirty="0">
+                          <a:solidFill>
+                            <a:schemeClr val="tx1"/>
+                          </a:solidFill>
+                        </a:rPr>
+                        <a:t>예약·O2O</a:t>
+                      </a:r>
+                      <a:endParaRPr lang="en-US" sz="1200" dirty="0"/>
+                    </a:p>
+                  </a:txBody>
+                  <a:tcPr marL="91440" marR="91440" marT="45720" marB="45720" anchor="ctr">
+                    <a:lnL w="12700" cap="flat" cmpd="sng" algn="ctr">
+                      <a:solidFill>
+                        <a:srgbClr val="EEF4F3"/>
+                      </a:solidFill>
+                      <a:prstDash val="solid"/>
+                      <a:round/>
+                      <a:headEnd type="none" w="med" len="med"/>
+                      <a:tailEnd type="none" w="med" len="med"/>
+                    </a:lnL>
+                    <a:lnR w="12700" cap="flat" cmpd="sng" algn="ctr">
+                      <a:solidFill>
+                        <a:srgbClr val="EEF4F3"/>
+                      </a:solidFill>
+                      <a:prstDash val="solid"/>
+                      <a:round/>
+                      <a:headEnd type="none" w="med" len="med"/>
+                      <a:tailEnd type="none" w="med" len="med"/>
+                    </a:lnR>
+                    <a:lnT w="12700" cap="flat" cmpd="sng" algn="ctr">
+                      <a:solidFill>
+                        <a:srgbClr val="EEF4F3"/>
+                      </a:solidFill>
+                      <a:prstDash val="solid"/>
+                      <a:round/>
+                      <a:headEnd type="none" w="med" len="med"/>
+                      <a:tailEnd type="none" w="med" len="med"/>
+                    </a:lnT>
+                    <a:lnB w="12700" cap="flat" cmpd="sng" algn="ctr">
+                      <a:solidFill>
+                        <a:srgbClr val="EEF4F3"/>
+                      </a:solidFill>
+                      <a:prstDash val="solid"/>
+                      <a:round/>
+                      <a:headEnd type="none" w="med" len="med"/>
+                      <a:tailEnd type="none" w="med" len="med"/>
+                    </a:lnB>
+                  </a:tcPr>
+                </a:tc>
+                <a:tc>
+                  <a:txBody>
+                    <a:bodyPr/>
+                    <a:lstStyle/>
+                    <a:p>
+                      <a:pPr indent="0" marL="0">
+                        <a:buNone/>
+                      </a:pPr>
+                      <a:r>
+                        <a:rPr lang="en-US" sz="1200" dirty="0">
+                          <a:solidFill>
+                            <a:schemeClr val="tx1"/>
+                          </a:solidFill>
+                        </a:rPr>
+                        <a:t>슬롯 = 재고(지나면 소멸) · 노쇼 · 예약금 · 동시 예약 충돌</a:t>
+                      </a:r>
+                      <a:endParaRPr lang="en-US" sz="1200" dirty="0"/>
+                    </a:p>
+                  </a:txBody>
+                  <a:tcPr marL="91440" marR="91440" marT="45720" marB="45720" anchor="ctr">
+                    <a:lnL w="12700" cap="flat" cmpd="sng" algn="ctr">
+                      <a:solidFill>
+                        <a:srgbClr val="EEF4F3"/>
+                      </a:solidFill>
+                      <a:prstDash val="solid"/>
+                      <a:round/>
+                      <a:headEnd type="none" w="med" len="med"/>
+                      <a:tailEnd type="none" w="med" len="med"/>
+                    </a:lnL>
+                    <a:lnR w="12700" cap="flat" cmpd="sng" algn="ctr">
+                      <a:solidFill>
+                        <a:srgbClr val="EEF4F3"/>
+                      </a:solidFill>
+                      <a:prstDash val="solid"/>
+                      <a:round/>
+                      <a:headEnd type="none" w="med" len="med"/>
+                      <a:tailEnd type="none" w="med" len="med"/>
+                    </a:lnR>
+                    <a:lnT w="12700" cap="flat" cmpd="sng" algn="ctr">
+                      <a:solidFill>
+                        <a:srgbClr val="EEF4F3"/>
+                      </a:solidFill>
+                      <a:prstDash val="solid"/>
+                      <a:round/>
+                      <a:headEnd type="none" w="med" len="med"/>
+                      <a:tailEnd type="none" w="med" len="med"/>
+                    </a:lnT>
+                    <a:lnB w="12700" cap="flat" cmpd="sng" algn="ctr">
+                      <a:solidFill>
+                        <a:srgbClr val="EEF4F3"/>
+                      </a:solidFill>
+                      <a:prstDash val="solid"/>
+                      <a:round/>
+                      <a:headEnd type="none" w="med" len="med"/>
+                      <a:tailEnd type="none" w="med" len="med"/>
+                    </a:lnB>
+                  </a:tcPr>
+                </a:tc>
+              </a:tr>
+              <a:tr h="457200">
+                <a:tc>
+                  <a:txBody>
+                    <a:bodyPr/>
+                    <a:lstStyle/>
+                    <a:p>
+                      <a:pPr indent="0" marL="0">
+                        <a:buNone/>
+                      </a:pPr>
+                      <a:r>
+                        <a:rPr lang="en-US" sz="1200" b="1" dirty="0">
+                          <a:solidFill>
+                            <a:schemeClr val="tx1"/>
+                          </a:solidFill>
+                        </a:rPr>
+                        <a:t>금융</a:t>
+                      </a:r>
+                      <a:endParaRPr lang="en-US" sz="1200" dirty="0"/>
+                    </a:p>
+                  </a:txBody>
+                  <a:tcPr marL="91440" marR="91440" marT="45720" marB="45720" anchor="ctr">
+                    <a:lnL w="12700" cap="flat" cmpd="sng" algn="ctr">
+                      <a:solidFill>
+                        <a:srgbClr val="EEF4F3"/>
+                      </a:solidFill>
+                      <a:prstDash val="solid"/>
+                      <a:round/>
+                      <a:headEnd type="none" w="med" len="med"/>
+                      <a:tailEnd type="none" w="med" len="med"/>
+                    </a:lnL>
+                    <a:lnR w="12700" cap="flat" cmpd="sng" algn="ctr">
+                      <a:solidFill>
+                        <a:srgbClr val="EEF4F3"/>
+                      </a:solidFill>
+                      <a:prstDash val="solid"/>
+                      <a:round/>
+                      <a:headEnd type="none" w="med" len="med"/>
+                      <a:tailEnd type="none" w="med" len="med"/>
+                    </a:lnR>
+                    <a:lnT w="12700" cap="flat" cmpd="sng" algn="ctr">
+                      <a:solidFill>
+                        <a:srgbClr val="EEF4F3"/>
+                      </a:solidFill>
+                      <a:prstDash val="solid"/>
+                      <a:round/>
+                      <a:headEnd type="none" w="med" len="med"/>
+                      <a:tailEnd type="none" w="med" len="med"/>
+                    </a:lnT>
+                    <a:lnB w="12700" cap="flat" cmpd="sng" algn="ctr">
+                      <a:solidFill>
+                        <a:srgbClr val="EEF4F3"/>
+                      </a:solidFill>
+                      <a:prstDash val="solid"/>
+                      <a:round/>
+                      <a:headEnd type="none" w="med" len="med"/>
+                      <a:tailEnd type="none" w="med" len="med"/>
+                    </a:lnB>
+                  </a:tcPr>
+                </a:tc>
+                <a:tc>
+                  <a:txBody>
+                    <a:bodyPr/>
+                    <a:lstStyle/>
+                    <a:p>
+                      <a:pPr indent="0" marL="0">
+                        <a:buNone/>
+                      </a:pPr>
+                      <a:r>
+                        <a:rPr lang="en-US" sz="1200" dirty="0">
+                          <a:solidFill>
+                            <a:schemeClr val="tx1"/>
+                          </a:solidFill>
+                        </a:rPr>
+                        <a:t>KYC · AML · 원장(덮어쓰지 않기) · 대사 · 이상 거래 탐지</a:t>
+                      </a:r>
+                      <a:endParaRPr lang="en-US" sz="1200" dirty="0"/>
+                    </a:p>
+                  </a:txBody>
+                  <a:tcPr marL="91440" marR="91440" marT="45720" marB="45720" anchor="ctr">
+                    <a:lnL w="12700" cap="flat" cmpd="sng" algn="ctr">
+                      <a:solidFill>
+                        <a:srgbClr val="EEF4F3"/>
+                      </a:solidFill>
+                      <a:prstDash val="solid"/>
+                      <a:round/>
+                      <a:headEnd type="none" w="med" len="med"/>
+                      <a:tailEnd type="none" w="med" len="med"/>
+                    </a:lnL>
+                    <a:lnR w="12700" cap="flat" cmpd="sng" algn="ctr">
+                      <a:solidFill>
+                        <a:srgbClr val="EEF4F3"/>
+                      </a:solidFill>
+                      <a:prstDash val="solid"/>
+                      <a:round/>
+                      <a:headEnd type="none" w="med" len="med"/>
+                      <a:tailEnd type="none" w="med" len="med"/>
+                    </a:lnR>
+                    <a:lnT w="12700" cap="flat" cmpd="sng" algn="ctr">
+                      <a:solidFill>
+                        <a:srgbClr val="EEF4F3"/>
+                      </a:solidFill>
+                      <a:prstDash val="solid"/>
+                      <a:round/>
+                      <a:headEnd type="none" w="med" len="med"/>
+                      <a:tailEnd type="none" w="med" len="med"/>
+                    </a:lnT>
+                    <a:lnB w="12700" cap="flat" cmpd="sng" algn="ctr">
+                      <a:solidFill>
+                        <a:srgbClr val="EEF4F3"/>
+                      </a:solidFill>
+                      <a:prstDash val="solid"/>
+                      <a:round/>
+                      <a:headEnd type="none" w="med" len="med"/>
+                      <a:tailEnd type="none" w="med" len="med"/>
+                    </a:lnB>
+                  </a:tcPr>
+                </a:tc>
+              </a:tr>
+            </a:tbl>
+          </a:graphicData>
+        </a:graphic>
+      </p:graphicFrame>
+      <p:sp>
+        <p:nvSpPr>
+          <p:cNvPr id="4" name="Text 1"/>
+          <p:cNvSpPr txBox="1"/>
+          <p:nvPr/>
+        </p:nvSpPr>
+        <p:spPr>
+          <a:xfrm>
+            <a:off x="457200" y="4645152"/>
+            <a:ext cx="7680960" cy="274320"/>
+          </a:xfrm>
+          <a:prstGeom prst="rect">
+            <a:avLst/>
+          </a:prstGeom>
+          <a:noFill/>
+          <a:ln/>
+        </p:spPr>
+        <p:txBody>
+          <a:bodyPr wrap="square" lIns="0" tIns="0" rIns="0" bIns="0" rtlCol="0" anchor="t"/>
+          <a:lstStyle/>
+          <a:p>
+            <a:pPr indent="0" marL="0">
+              <a:buNone/>
+            </a:pPr>
+            <a:r>
+              <a:rPr lang="en-US" sz="1000" dirty="0">
+                <a:solidFill>
+                  <a:schemeClr val="accent4"/>
+                </a:solidFill>
+              </a:rPr>
+              <a:t>새 분야는 7칸 표(누가·돈 흐름·상태·예외·지표·규제·용어 20개)를 채우며 공부 (35장)</a:t>
+            </a:r>
+            <a:endParaRPr lang="en-US" sz="1000" dirty="0"/>
+          </a:p>
+        </p:txBody>
+      </p:sp>
+      <p:sp>
+        <p:nvSpPr>
+          <p:cNvPr id="25" name="Slide Number Placeholder 0"/>
+          <p:cNvSpPr>
+            <a:spLocks noGrp="1"/>
+          </p:cNvSpPr>
+          <p:nvPr>
+            <p:ph type="sldNum" sz="quarter" idx="4294967295"/>
+          </p:nvPr>
+        </p:nvSpPr>
+        <p:spPr>
+          <a:xfrm>
+            <a:off x="8321040" y="4754880"/>
+            <a:ext cx="457200" cy="274320"/>
+          </a:xfrm>
+          <a:prstGeom prst="rect">
+            <a:avLst/>
+          </a:prstGeom>
+          <a:extLst>
+            <a:ext uri="{C572A759-6A51-4108-AA02-DFA0A04FC94B}">
+              <ma14:wrappingTextBoxFlag xmlns:ma14="http://schemas.microsoft.com/office/mac/drawingml/2011/main" val="0"/>
+            </a:ext>
+          </a:extLst>
+        </p:spPr>
+        <p:txBody>
+          <a:bodyPr/>
+          <a:lstStyle>
+            <a:lvl1pPr>
+              <a:defRPr sz="1000">
+                <a:solidFill>
+                  <a:schemeClr val="accent4"/>
+                </a:solidFill>
+              </a:defRPr>
+            </a:lvl1pPr>
+          </a:lstStyle>
+          <a:p>
+            <a:pPr algn="r"/>
+            <a:fld id="{F7021451-1387-4CA6-816F-3879F97B5CBC}" type="slidenum">
+              <a:rPr b="0" lang="en-US"/>
+              <a:t>54</a:t>
+            </a:fld>
+            <a:endParaRPr lang="en-US"/>
+          </a:p>
+        </p:txBody>
+      </p:sp>
+    </p:spTree>
+  </p:cSld>
+  <p:clrMapOvr>
+    <a:masterClrMapping/>
+  </p:clrMapOvr>
+</p:sld>
+</file>
+
+<file path=ppt/slides/slide55.xml><?xml version="1.0" encoding="utf-8"?>
+<p:sld xmlns:a="http://schemas.openxmlformats.org/drawingml/2006/main" xmlns:r="http://schemas.openxmlformats.org/officeDocument/2006/relationships" xmlns:p="http://schemas.openxmlformats.org/presentationml/2006/main">
+  <p:cSld name="Slide 55">
+    <p:spTree>
+      <p:nvGrpSpPr>
+        <p:cNvPr id="1" name=""/>
+        <p:cNvGrpSpPr/>
+        <p:nvPr/>
+      </p:nvGrpSpPr>
+      <p:grpSpPr>
+        <a:xfrm>
+          <a:off x="0" y="0"/>
+          <a:ext cx="0" cy="0"/>
+          <a:chOff x="0" y="0"/>
+          <a:chExt cx="0" cy="0"/>
+        </a:xfrm>
+      </p:grpSpPr>
+      <p:sp>
+        <p:nvSpPr>
+          <p:cNvPr id="2" name="Text 0"/>
+          <p:cNvSpPr/>
+          <p:nvPr>
+            <p:ph idx="100" type="title" hasCustomPrompt="1"/>
+          </p:nvPr>
+        </p:nvSpPr>
+        <p:spPr>
+          <a:xfrm>
+            <a:off x="548640" y="1371600"/>
+            <a:ext cx="8046720" cy="1280160"/>
+          </a:xfrm>
+          <a:prstGeom prst="rect">
+            <a:avLst/>
+          </a:prstGeom>
+          <a:noFill/>
+          <a:ln/>
+        </p:spPr>
+        <p:txBody>
+          <a:bodyPr wrap="square" lIns="0" tIns="0" rIns="0" bIns="0" rtlCol="0" anchor="b"/>
+          <a:lstStyle/>
+          <a:p>
+            <a:pPr algn="l" indent="0" marL="0">
+              <a:buNone/>
+            </a:pPr>
+            <a:r>
+              <a:rPr lang="en-US" sz="4000" b="1" dirty="0">
+                <a:solidFill>
+                  <a:schemeClr val="bg1"/>
+                </a:solidFill>
+              </a:rPr>
+              <a:t>안전하게, 자주 반복하기</a:t>
+            </a:r>
+            <a:endParaRPr lang="en-US" sz="4000" dirty="0"/>
+          </a:p>
+        </p:txBody>
+      </p:sp>
+      <p:sp>
+        <p:nvSpPr>
+          <p:cNvPr id="3" name="Text 0"/>
+          <p:cNvSpPr/>
+          <p:nvPr>
+            <p:ph idx="101" type="body" hasCustomPrompt="1"/>
+          </p:nvPr>
+        </p:nvSpPr>
+        <p:spPr>
+          <a:xfrm>
+            <a:off x="548640" y="2788920"/>
+            <a:ext cx="8046720" cy="1097280"/>
+          </a:xfrm>
+          <a:prstGeom prst="rect">
+            <a:avLst/>
+          </a:prstGeom>
+          <a:noFill/>
+          <a:ln/>
+        </p:spPr>
+        <p:txBody>
+          <a:bodyPr wrap="square" lIns="0" tIns="0" rIns="0" bIns="0" rtlCol="0" anchor="t"/>
+          <a:lstStyle/>
+          <a:p>
+            <a:pPr algn="l" indent="0" marL="0">
+              <a:buNone/>
+            </a:pPr>
+            <a:r>
+              <a:rPr lang="en-US" sz="1800" dirty="0">
+                <a:solidFill>
+                  <a:schemeClr val="bg2"/>
+                </a:solidFill>
+              </a:rPr>
+              <a:t>기획 → 백업 → 연습용 사이트에서 수정 → 확인 → 배포 → 감시 → 숫자 보기 → 다시 기획</a:t>
+            </a:r>
+            <a:endParaRPr lang="en-US" sz="1800" dirty="0"/>
+          </a:p>
+          <a:p>
+            <a:pPr algn="l" indent="0" marL="0">
+              <a:buNone/>
+            </a:pPr>
+            <a:r>
+              <a:rPr lang="en-US" sz="1800" dirty="0">
+                <a:solidFill>
+                  <a:schemeClr val="bg2"/>
+                </a:solidFill>
+              </a:rPr>
+              <a:t>다음 할 일: docs/13-practice-scenario.md 를 읽고 15장 퀴즈 풀기</a:t>
+            </a:r>
+            <a:endParaRPr lang="en-US" sz="1800" dirty="0"/>
           </a:p>
         </p:txBody>
       </p:sp>

</xml_diff>

<commit_message>
Add chapters on hosting choice, must-do security and launch checklist
Chapter 36 covers choosing servers and hosting by site type, ten
selection criteria, free-tier pitfalls, region and overseas
transfer of personal data, and cost habits. Chapter 37 covers the
OWASP Top 10 (2025), must-do security for builder users and
developers, Korean safeguard rules for personal data, and incident
response. Chapter 38 lists 30 pre-launch items to ask Claude for
(above-the-fold CTA, sticky mobile CTA, unique titles and
descriptions, alt text, internal links, robots.txt, sitemap,
canonical, structured data, custom 404, OG thumbnails, GA4 key
events, privacy policy, Core Web Vitals, accessibility) with a
copy-paste prompt and verification tools. README, ch10, ch14,
glossary, quiz, sources and the deck (now 60 slides) are updated.

Co-Authored-By: Claude Opus 5.5 <noreply@anthropic.com>
Claude-Session: https://claude.ai/code/session_01Tuz8P5EzhzAFozhesRbd5A
</commit_message>
<xml_diff>
--- a/slides/internet-business-101.pptx
+++ b/slides/internet-business-101.pptx
@@ -60,9 +60,14 @@
     <p:sldId id="308" r:id="rId54"/>
     <p:sldId id="309" r:id="rId55"/>
     <p:sldId id="310" r:id="rId56"/>
+    <p:sldId id="311" r:id="rId57"/>
+    <p:sldId id="312" r:id="rId58"/>
+    <p:sldId id="313" r:id="rId59"/>
+    <p:sldId id="314" r:id="rId60"/>
+    <p:sldId id="315" r:id="rId61"/>
   </p:sldIdLst>
   <p:notesMasterIdLst>
-    <p:notesMasterId r:id="rId57"/>
+    <p:notesMasterId r:id="rId62"/>
   </p:notesMasterIdLst>
   <p:sldSz cx="9144000" cy="5143500"/>
   <p:notesSz cx="5143500" cy="9144000"/>
@@ -161,13 +166,13 @@
   <p:extLst>
     <p:ext uri="{521415D9-36F7-43E2-AB2F-B90AF26B5E84}">
       <p14:sectionLst xmlns:p14="http://schemas.microsoft.com/office/powerpoint/2010/main">
-        <p14:section name="시작" id="{364d1b27-e875-43d2-f800-ad6f569d37a0}">
+        <p14:section name="시작" id="{d62f1d2d-b020-daf7-902a-42ab7d009a70}">
           <p14:sldIdLst>
             <p14:sldId id="256"/>
             <p14:sldId id="257"/>
           </p14:sldIdLst>
         </p14:section>
-        <p14:section name="큰 그림" id="{e071abc0-23a6-cf4c-c2d1-81c7679ce33b}">
+        <p14:section name="큰 그림" id="{ca511d00-fdce-5534-cf04-053994f88586}">
           <p14:sldIdLst>
             <p14:sldId id="258"/>
             <p14:sldId id="259"/>
@@ -176,13 +181,13 @@
             <p14:sldId id="262"/>
           </p14:sldIdLst>
         </p14:section>
-        <p14:section name="만들기" id="{115e535e-1b65-42d7-bded-e93aa35e3a13}">
+        <p14:section name="만들기" id="{c0ab6f67-c53a-a550-5b28-6d19566e9f89}">
           <p14:sldIdLst>
             <p14:sldId id="263"/>
             <p14:sldId id="264"/>
           </p14:sldIdLst>
         </p14:section>
-        <p14:section name="운영하기" id="{129e2bd1-189b-0265-c3b3-5dc418be27ba}">
+        <p14:section name="운영하기" id="{72b97fc9-fe85-a14e-0637-9e0d4b4916c0}">
           <p14:sldIdLst>
             <p14:sldId id="265"/>
             <p14:sldId id="266"/>
@@ -196,18 +201,18 @@
             <p14:sldId id="274"/>
           </p14:sldIdLst>
         </p14:section>
-        <p14:section name="키우기" id="{5b97b1e9-03ca-ba8f-672d-0b06925c0c60}">
+        <p14:section name="키우기" id="{2b160383-9948-a0be-4885-9726f619c0d7}">
           <p14:sldIdLst>
             <p14:sldId id="275"/>
             <p14:sldId id="276"/>
           </p14:sldIdLst>
         </p14:section>
-        <p14:section name="실전" id="{114daad0-c0ef-c9d9-0c2c-9dd128c7d537}">
+        <p14:section name="실전" id="{37311cba-b8de-7d1f-7a39-b28535c5c41c}">
           <p14:sldIdLst>
             <p14:sldId id="277"/>
           </p14:sldIdLst>
         </p14:section>
-        <p14:section name="여러 가지 사이트 사업" id="{d2f9a892-c1b7-9efb-c59a-a63031bfb4e3}">
+        <p14:section name="여러 가지 사이트 사업" id="{97e83ed0-de60-2b70-ddde-cbf260b9f8bc}">
           <p14:sldIdLst>
             <p14:sldId id="278"/>
             <p14:sldId id="279"/>
@@ -218,7 +223,7 @@
             <p14:sldId id="284"/>
           </p14:sldIdLst>
         </p14:section>
-        <p14:section name="더 넓은 분류" id="{cb4c38b9-a440-ae2d-71d1-b6609a120cd8}">
+        <p14:section name="더 넓은 분류" id="{84e699dd-31c9-eb63-e4af-b92f90a8f477}">
           <p14:sldIdLst>
             <p14:sldId id="285"/>
             <p14:sldId id="286"/>
@@ -229,7 +234,7 @@
             <p14:sldId id="291"/>
           </p14:sldIdLst>
         </p14:section>
-        <p14:section name="문의·광고 받기" id="{ad54818d-82ad-4777-9d75-001d13456a37}">
+        <p14:section name="문의·광고 받기" id="{1eeea82e-b56a-1fc9-290e-1b703f55b42d}">
           <p14:sldIdLst>
             <p14:sldId id="292"/>
             <p14:sldId id="293"/>
@@ -238,7 +243,7 @@
             <p14:sldId id="296"/>
           </p14:sldIdLst>
         </p14:section>
-        <p14:section name="마케팅 실전" id="{bf20c87b-729e-9cd0-f199-12e7926be614}">
+        <p14:section name="마케팅 실전" id="{8b979e47-3868-3c2e-70e5-dff5178a69ac}">
           <p14:sldIdLst>
             <p14:sldId id="297"/>
             <p14:sldId id="298"/>
@@ -249,7 +254,7 @@
             <p14:sldId id="303"/>
           </p14:sldIdLst>
         </p14:section>
-        <p14:section name="도메인" id="{88cd1627-b8d8-7286-e544-2dfa163bec9f}">
+        <p14:section name="도메인" id="{c2d031c8-7983-0038-9f5b-d35bc5616fbe}">
           <p14:sldIdLst>
             <p14:sldId id="304"/>
             <p14:sldId id="305"/>
@@ -257,7 +262,16 @@
             <p14:sldId id="307"/>
             <p14:sldId id="308"/>
             <p14:sldId id="309"/>
+          </p14:sldIdLst>
+        </p14:section>
+        <p14:section name="출시 준비" id="{b9777a5d-dec2-0151-15f1-5b57b927ed4e}">
+          <p14:sldIdLst>
             <p14:sldId id="310"/>
+            <p14:sldId id="311"/>
+            <p14:sldId id="312"/>
+            <p14:sldId id="313"/>
+            <p14:sldId id="314"/>
+            <p14:sldId id="315"/>
           </p14:sldIdLst>
         </p14:section>
       </p14:sectionLst>
@@ -6050,6 +6064,358 @@
 </p:notes>
 </file>
 
+<file path=ppt/notesSlides/notesSlide56.xml><?xml version="1.0" encoding="utf-8"?>
+<p:notes xmlns:a="http://schemas.openxmlformats.org/drawingml/2006/main" xmlns:r="http://schemas.openxmlformats.org/officeDocument/2006/relationships" xmlns:p="http://schemas.openxmlformats.org/presentationml/2006/main">
+  <p:cSld>
+    <p:spTree>
+      <p:nvGrpSpPr>
+        <p:cNvPr id="1" name=""/>
+        <p:cNvGrpSpPr/>
+        <p:nvPr/>
+      </p:nvGrpSpPr>
+      <p:grpSpPr>
+        <a:xfrm>
+          <a:off x="0" y="0"/>
+          <a:ext cx="0" cy="0"/>
+          <a:chOff x="0" y="0"/>
+          <a:chExt cx="0" cy="0"/>
+        </a:xfrm>
+      </p:grpSpPr>
+      <p:sp>
+        <p:nvSpPr>
+          <p:cNvPr id="2" name="Slide Image Placeholder 1"/>
+          <p:cNvSpPr>
+            <a:spLocks noGrp="1" noRot="1" noChangeAspect="1"/>
+          </p:cNvSpPr>
+          <p:nvPr>
+            <p:ph type="sldImg"/>
+          </p:nvPr>
+        </p:nvSpPr>
+        <p:spPr/>
+      </p:sp>
+      <p:sp>
+        <p:nvSpPr>
+          <p:cNvPr id="3" name="Notes Placeholder 2"/>
+          <p:cNvSpPr>
+            <a:spLocks noGrp="1"/>
+          </p:cNvSpPr>
+          <p:nvPr>
+            <p:ph type="body" idx="1"/>
+          </p:nvPr>
+        </p:nvSpPr>
+        <p:spPr/>
+        <p:txBody>
+          <a:bodyPr/>
+          <a:lstStyle/>
+          <a:p>
+            <a:r>
+              <a:rPr lang="en-US" dirty="0"/>
+              <a:t/>
+            </a:r>
+            <a:endParaRPr lang="en-US" dirty="0"/>
+          </a:p>
+        </p:txBody>
+      </p:sp>
+      <p:sp>
+        <p:nvSpPr>
+          <p:cNvPr id="4" name="Slide Number Placeholder 3"/>
+          <p:cNvSpPr>
+            <a:spLocks noGrp="1"/>
+          </p:cNvSpPr>
+          <p:nvPr>
+            <p:ph type="sldNum" sz="quarter" idx="10"/>
+          </p:nvPr>
+        </p:nvSpPr>
+        <p:spPr/>
+        <p:txBody>
+          <a:bodyPr/>
+          <a:lstStyle/>
+          <a:p>
+            <a:fld id="{F7021451-1387-4CA6-816F-3879F97B5CBC}" type="slidenum">
+              <a:rPr lang="en-US"/>
+              <a:t>56</a:t>
+            </a:fld>
+            <a:endParaRPr lang="en-US"/>
+          </a:p>
+        </p:txBody>
+      </p:sp>
+    </p:spTree>
+    <p:extLst>
+      <p:ext uri="{BB962C8B-B14F-4D97-AF65-F5344CB8AC3E}">
+        <p14:creationId xmlns:p14="http://schemas.microsoft.com/office/powerpoint/2010/main" val="1024086991"/>
+      </p:ext>
+    </p:extLst>
+  </p:cSld>
+  <p:clrMapOvr>
+    <a:masterClrMapping/>
+  </p:clrMapOvr>
+</p:notes>
+</file>
+
+<file path=ppt/notesSlides/notesSlide57.xml><?xml version="1.0" encoding="utf-8"?>
+<p:notes xmlns:a="http://schemas.openxmlformats.org/drawingml/2006/main" xmlns:r="http://schemas.openxmlformats.org/officeDocument/2006/relationships" xmlns:p="http://schemas.openxmlformats.org/presentationml/2006/main">
+  <p:cSld>
+    <p:spTree>
+      <p:nvGrpSpPr>
+        <p:cNvPr id="1" name=""/>
+        <p:cNvGrpSpPr/>
+        <p:nvPr/>
+      </p:nvGrpSpPr>
+      <p:grpSpPr>
+        <a:xfrm>
+          <a:off x="0" y="0"/>
+          <a:ext cx="0" cy="0"/>
+          <a:chOff x="0" y="0"/>
+          <a:chExt cx="0" cy="0"/>
+        </a:xfrm>
+      </p:grpSpPr>
+      <p:sp>
+        <p:nvSpPr>
+          <p:cNvPr id="2" name="Slide Image Placeholder 1"/>
+          <p:cNvSpPr>
+            <a:spLocks noGrp="1" noRot="1" noChangeAspect="1"/>
+          </p:cNvSpPr>
+          <p:nvPr>
+            <p:ph type="sldImg"/>
+          </p:nvPr>
+        </p:nvSpPr>
+        <p:spPr/>
+      </p:sp>
+      <p:sp>
+        <p:nvSpPr>
+          <p:cNvPr id="3" name="Notes Placeholder 2"/>
+          <p:cNvSpPr>
+            <a:spLocks noGrp="1"/>
+          </p:cNvSpPr>
+          <p:nvPr>
+            <p:ph type="body" idx="1"/>
+          </p:nvPr>
+        </p:nvSpPr>
+        <p:spPr/>
+        <p:txBody>
+          <a:bodyPr/>
+          <a:lstStyle/>
+          <a:p>
+            <a:r>
+              <a:rPr lang="en-US" dirty="0"/>
+              <a:t/>
+            </a:r>
+            <a:endParaRPr lang="en-US" dirty="0"/>
+          </a:p>
+        </p:txBody>
+      </p:sp>
+      <p:sp>
+        <p:nvSpPr>
+          <p:cNvPr id="4" name="Slide Number Placeholder 3"/>
+          <p:cNvSpPr>
+            <a:spLocks noGrp="1"/>
+          </p:cNvSpPr>
+          <p:nvPr>
+            <p:ph type="sldNum" sz="quarter" idx="10"/>
+          </p:nvPr>
+        </p:nvSpPr>
+        <p:spPr/>
+        <p:txBody>
+          <a:bodyPr/>
+          <a:lstStyle/>
+          <a:p>
+            <a:fld id="{F7021451-1387-4CA6-816F-3879F97B5CBC}" type="slidenum">
+              <a:rPr lang="en-US"/>
+              <a:t>57</a:t>
+            </a:fld>
+            <a:endParaRPr lang="en-US"/>
+          </a:p>
+        </p:txBody>
+      </p:sp>
+    </p:spTree>
+    <p:extLst>
+      <p:ext uri="{BB962C8B-B14F-4D97-AF65-F5344CB8AC3E}">
+        <p14:creationId xmlns:p14="http://schemas.microsoft.com/office/powerpoint/2010/main" val="1024086991"/>
+      </p:ext>
+    </p:extLst>
+  </p:cSld>
+  <p:clrMapOvr>
+    <a:masterClrMapping/>
+  </p:clrMapOvr>
+</p:notes>
+</file>
+
+<file path=ppt/notesSlides/notesSlide58.xml><?xml version="1.0" encoding="utf-8"?>
+<p:notes xmlns:a="http://schemas.openxmlformats.org/drawingml/2006/main" xmlns:r="http://schemas.openxmlformats.org/officeDocument/2006/relationships" xmlns:p="http://schemas.openxmlformats.org/presentationml/2006/main">
+  <p:cSld>
+    <p:spTree>
+      <p:nvGrpSpPr>
+        <p:cNvPr id="1" name=""/>
+        <p:cNvGrpSpPr/>
+        <p:nvPr/>
+      </p:nvGrpSpPr>
+      <p:grpSpPr>
+        <a:xfrm>
+          <a:off x="0" y="0"/>
+          <a:ext cx="0" cy="0"/>
+          <a:chOff x="0" y="0"/>
+          <a:chExt cx="0" cy="0"/>
+        </a:xfrm>
+      </p:grpSpPr>
+      <p:sp>
+        <p:nvSpPr>
+          <p:cNvPr id="2" name="Slide Image Placeholder 1"/>
+          <p:cNvSpPr>
+            <a:spLocks noGrp="1" noRot="1" noChangeAspect="1"/>
+          </p:cNvSpPr>
+          <p:nvPr>
+            <p:ph type="sldImg"/>
+          </p:nvPr>
+        </p:nvSpPr>
+        <p:spPr/>
+      </p:sp>
+      <p:sp>
+        <p:nvSpPr>
+          <p:cNvPr id="3" name="Notes Placeholder 2"/>
+          <p:cNvSpPr>
+            <a:spLocks noGrp="1"/>
+          </p:cNvSpPr>
+          <p:nvPr>
+            <p:ph type="body" idx="1"/>
+          </p:nvPr>
+        </p:nvSpPr>
+        <p:spPr/>
+        <p:txBody>
+          <a:bodyPr/>
+          <a:lstStyle/>
+          <a:p>
+            <a:r>
+              <a:rPr lang="en-US" dirty="0"/>
+              <a:t/>
+            </a:r>
+            <a:endParaRPr lang="en-US" dirty="0"/>
+          </a:p>
+        </p:txBody>
+      </p:sp>
+      <p:sp>
+        <p:nvSpPr>
+          <p:cNvPr id="4" name="Slide Number Placeholder 3"/>
+          <p:cNvSpPr>
+            <a:spLocks noGrp="1"/>
+          </p:cNvSpPr>
+          <p:nvPr>
+            <p:ph type="sldNum" sz="quarter" idx="10"/>
+          </p:nvPr>
+        </p:nvSpPr>
+        <p:spPr/>
+        <p:txBody>
+          <a:bodyPr/>
+          <a:lstStyle/>
+          <a:p>
+            <a:fld id="{F7021451-1387-4CA6-816F-3879F97B5CBC}" type="slidenum">
+              <a:rPr lang="en-US"/>
+              <a:t>58</a:t>
+            </a:fld>
+            <a:endParaRPr lang="en-US"/>
+          </a:p>
+        </p:txBody>
+      </p:sp>
+    </p:spTree>
+    <p:extLst>
+      <p:ext uri="{BB962C8B-B14F-4D97-AF65-F5344CB8AC3E}">
+        <p14:creationId xmlns:p14="http://schemas.microsoft.com/office/powerpoint/2010/main" val="1024086991"/>
+      </p:ext>
+    </p:extLst>
+  </p:cSld>
+  <p:clrMapOvr>
+    <a:masterClrMapping/>
+  </p:clrMapOvr>
+</p:notes>
+</file>
+
+<file path=ppt/notesSlides/notesSlide59.xml><?xml version="1.0" encoding="utf-8"?>
+<p:notes xmlns:a="http://schemas.openxmlformats.org/drawingml/2006/main" xmlns:r="http://schemas.openxmlformats.org/officeDocument/2006/relationships" xmlns:p="http://schemas.openxmlformats.org/presentationml/2006/main">
+  <p:cSld>
+    <p:spTree>
+      <p:nvGrpSpPr>
+        <p:cNvPr id="1" name=""/>
+        <p:cNvGrpSpPr/>
+        <p:nvPr/>
+      </p:nvGrpSpPr>
+      <p:grpSpPr>
+        <a:xfrm>
+          <a:off x="0" y="0"/>
+          <a:ext cx="0" cy="0"/>
+          <a:chOff x="0" y="0"/>
+          <a:chExt cx="0" cy="0"/>
+        </a:xfrm>
+      </p:grpSpPr>
+      <p:sp>
+        <p:nvSpPr>
+          <p:cNvPr id="2" name="Slide Image Placeholder 1"/>
+          <p:cNvSpPr>
+            <a:spLocks noGrp="1" noRot="1" noChangeAspect="1"/>
+          </p:cNvSpPr>
+          <p:nvPr>
+            <p:ph type="sldImg"/>
+          </p:nvPr>
+        </p:nvSpPr>
+        <p:spPr/>
+      </p:sp>
+      <p:sp>
+        <p:nvSpPr>
+          <p:cNvPr id="3" name="Notes Placeholder 2"/>
+          <p:cNvSpPr>
+            <a:spLocks noGrp="1"/>
+          </p:cNvSpPr>
+          <p:nvPr>
+            <p:ph type="body" idx="1"/>
+          </p:nvPr>
+        </p:nvSpPr>
+        <p:spPr/>
+        <p:txBody>
+          <a:bodyPr/>
+          <a:lstStyle/>
+          <a:p>
+            <a:r>
+              <a:rPr lang="en-US" dirty="0"/>
+              <a:t/>
+            </a:r>
+            <a:endParaRPr lang="en-US" dirty="0"/>
+          </a:p>
+        </p:txBody>
+      </p:sp>
+      <p:sp>
+        <p:nvSpPr>
+          <p:cNvPr id="4" name="Slide Number Placeholder 3"/>
+          <p:cNvSpPr>
+            <a:spLocks noGrp="1"/>
+          </p:cNvSpPr>
+          <p:nvPr>
+            <p:ph type="sldNum" sz="quarter" idx="10"/>
+          </p:nvPr>
+        </p:nvSpPr>
+        <p:spPr/>
+        <p:txBody>
+          <a:bodyPr/>
+          <a:lstStyle/>
+          <a:p>
+            <a:fld id="{F7021451-1387-4CA6-816F-3879F97B5CBC}" type="slidenum">
+              <a:rPr lang="en-US"/>
+              <a:t>59</a:t>
+            </a:fld>
+            <a:endParaRPr lang="en-US"/>
+          </a:p>
+        </p:txBody>
+      </p:sp>
+    </p:spTree>
+    <p:extLst>
+      <p:ext uri="{BB962C8B-B14F-4D97-AF65-F5344CB8AC3E}">
+        <p14:creationId xmlns:p14="http://schemas.microsoft.com/office/powerpoint/2010/main" val="1024086991"/>
+      </p:ext>
+    </p:extLst>
+  </p:cSld>
+  <p:clrMapOvr>
+    <a:masterClrMapping/>
+  </p:clrMapOvr>
+</p:notes>
+</file>
+
 <file path=ppt/notesSlides/notesSlide6.xml><?xml version="1.0" encoding="utf-8"?>
 <p:notes xmlns:a="http://schemas.openxmlformats.org/drawingml/2006/main" xmlns:r="http://schemas.openxmlformats.org/officeDocument/2006/relationships" xmlns:p="http://schemas.openxmlformats.org/presentationml/2006/main">
   <p:cSld>
@@ -6120,6 +6486,94 @@
             <a:fld id="{F7021451-1387-4CA6-816F-3879F97B5CBC}" type="slidenum">
               <a:rPr lang="en-US"/>
               <a:t>6</a:t>
+            </a:fld>
+            <a:endParaRPr lang="en-US"/>
+          </a:p>
+        </p:txBody>
+      </p:sp>
+    </p:spTree>
+    <p:extLst>
+      <p:ext uri="{BB962C8B-B14F-4D97-AF65-F5344CB8AC3E}">
+        <p14:creationId xmlns:p14="http://schemas.microsoft.com/office/powerpoint/2010/main" val="1024086991"/>
+      </p:ext>
+    </p:extLst>
+  </p:cSld>
+  <p:clrMapOvr>
+    <a:masterClrMapping/>
+  </p:clrMapOvr>
+</p:notes>
+</file>
+
+<file path=ppt/notesSlides/notesSlide60.xml><?xml version="1.0" encoding="utf-8"?>
+<p:notes xmlns:a="http://schemas.openxmlformats.org/drawingml/2006/main" xmlns:r="http://schemas.openxmlformats.org/officeDocument/2006/relationships" xmlns:p="http://schemas.openxmlformats.org/presentationml/2006/main">
+  <p:cSld>
+    <p:spTree>
+      <p:nvGrpSpPr>
+        <p:cNvPr id="1" name=""/>
+        <p:cNvGrpSpPr/>
+        <p:nvPr/>
+      </p:nvGrpSpPr>
+      <p:grpSpPr>
+        <a:xfrm>
+          <a:off x="0" y="0"/>
+          <a:ext cx="0" cy="0"/>
+          <a:chOff x="0" y="0"/>
+          <a:chExt cx="0" cy="0"/>
+        </a:xfrm>
+      </p:grpSpPr>
+      <p:sp>
+        <p:nvSpPr>
+          <p:cNvPr id="2" name="Slide Image Placeholder 1"/>
+          <p:cNvSpPr>
+            <a:spLocks noGrp="1" noRot="1" noChangeAspect="1"/>
+          </p:cNvSpPr>
+          <p:nvPr>
+            <p:ph type="sldImg"/>
+          </p:nvPr>
+        </p:nvSpPr>
+        <p:spPr/>
+      </p:sp>
+      <p:sp>
+        <p:nvSpPr>
+          <p:cNvPr id="3" name="Notes Placeholder 2"/>
+          <p:cNvSpPr>
+            <a:spLocks noGrp="1"/>
+          </p:cNvSpPr>
+          <p:nvPr>
+            <p:ph type="body" idx="1"/>
+          </p:nvPr>
+        </p:nvSpPr>
+        <p:spPr/>
+        <p:txBody>
+          <a:bodyPr/>
+          <a:lstStyle/>
+          <a:p>
+            <a:r>
+              <a:rPr lang="en-US" dirty="0"/>
+              <a:t/>
+            </a:r>
+            <a:endParaRPr lang="en-US" dirty="0"/>
+          </a:p>
+        </p:txBody>
+      </p:sp>
+      <p:sp>
+        <p:nvSpPr>
+          <p:cNvPr id="4" name="Slide Number Placeholder 3"/>
+          <p:cNvSpPr>
+            <a:spLocks noGrp="1"/>
+          </p:cNvSpPr>
+          <p:nvPr>
+            <p:ph type="sldNum" sz="quarter" idx="10"/>
+          </p:nvPr>
+        </p:nvSpPr>
+        <p:spPr/>
+        <p:txBody>
+          <a:bodyPr/>
+          <a:lstStyle/>
+          <a:p>
+            <a:fld id="{F7021451-1387-4CA6-816F-3879F97B5CBC}" type="slidenum">
+              <a:rPr lang="en-US"/>
+              <a:t>60</a:t>
             </a:fld>
             <a:endParaRPr lang="en-US"/>
           </a:p>
@@ -43521,7 +43975,7 @@
                   <a:schemeClr val="bg1"/>
                 </a:solidFill>
               </a:rPr>
-              <a:t>안전하게, 자주 반복하기</a:t>
+              <a:t>출시 준비</a:t>
             </a:r>
             <a:endParaRPr lang="en-US" sz="4000" dirty="0"/>
           </a:p>
@@ -43559,23 +44013,3563 @@
                   <a:schemeClr val="bg2"/>
                 </a:solidFill>
               </a:rPr>
-              <a:t>기획 → 백업 → 연습용 사이트에서 수정 → 확인 → 배포 → 감시 → 숫자 보기 → 다시 기획</a:t>
+              <a:t>서버·호스팅 고르기 · 꼭 해야 하는 보안 · 출시 전 Claude에게 요청할 30가지 — 36–38장</a:t>
             </a:r>
             <a:endParaRPr lang="en-US" sz="1800" dirty="0"/>
           </a:p>
-          <a:p>
-            <a:pPr algn="l" indent="0" marL="0">
-              <a:buNone/>
-            </a:pPr>
-            <a:r>
-              <a:rPr lang="en-US" sz="1800" dirty="0">
-                <a:solidFill>
-                  <a:schemeClr val="bg2"/>
-                </a:solidFill>
-              </a:rPr>
-              <a:t>다음 할 일: docs/13-practice-scenario.md 를 읽고 15장 퀴즈 풀기</a:t>
+        </p:txBody>
+      </p:sp>
+    </p:spTree>
+  </p:cSld>
+  <p:clrMapOvr>
+    <a:masterClrMapping/>
+  </p:clrMapOvr>
+</p:sld>
+</file>
+
+<file path=ppt/slides/slide56.xml><?xml version="1.0" encoding="utf-8"?>
+<p:sld xmlns:a="http://schemas.openxmlformats.org/drawingml/2006/main" xmlns:r="http://schemas.openxmlformats.org/officeDocument/2006/relationships" xmlns:p="http://schemas.openxmlformats.org/presentationml/2006/main">
+  <p:cSld name="Slide 56">
+    <p:spTree>
+      <p:nvGrpSpPr>
+        <p:cNvPr id="1" name=""/>
+        <p:cNvGrpSpPr/>
+        <p:nvPr/>
+      </p:nvGrpSpPr>
+      <p:grpSpPr>
+        <a:xfrm>
+          <a:off x="0" y="0"/>
+          <a:ext cx="0" cy="0"/>
+          <a:chOff x="0" y="0"/>
+          <a:chExt cx="0" cy="0"/>
+        </a:xfrm>
+      </p:grpSpPr>
+      <p:sp>
+        <p:nvSpPr>
+          <p:cNvPr id="2" name="Text 0"/>
+          <p:cNvSpPr/>
+          <p:nvPr>
+            <p:ph idx="100" type="title" hasCustomPrompt="1"/>
+          </p:nvPr>
+        </p:nvSpPr>
+        <p:spPr>
+          <a:xfrm>
+            <a:off x="457200" y="274320"/>
+            <a:ext cx="8229600" cy="685800"/>
+          </a:xfrm>
+          <a:prstGeom prst="rect">
+            <a:avLst/>
+          </a:prstGeom>
+          <a:noFill/>
+          <a:ln/>
+        </p:spPr>
+        <p:txBody>
+          <a:bodyPr wrap="square" lIns="0" tIns="0" rIns="0" bIns="0" rtlCol="0" anchor="ctr"/>
+          <a:lstStyle/>
+          <a:p>
+            <a:pPr indent="0" marL="0">
+              <a:buNone/>
+            </a:pPr>
+            <a:r>
+              <a:rPr lang="en-US" sz="2800" b="1" dirty="0">
+                <a:solidFill>
+                  <a:schemeClr val="tx2"/>
+                </a:solidFill>
+              </a:rPr>
+              <a:t>서버·호스팅: 사이트 종류로 고른다</a:t>
+            </a:r>
+            <a:endParaRPr lang="en-US" sz="2800" dirty="0"/>
+          </a:p>
+        </p:txBody>
+      </p:sp>
+      <p:graphicFrame>
+        <p:nvGraphicFramePr>
+          <p:cNvPr id="57" name="Table 0"/>
+          <p:cNvGraphicFramePr>
+            <a:graphicFrameLocks noGrp="1"/>
+          </p:cNvGraphicFramePr>
+          <p:nvPr>
+            <p:extLst>
+              <p:ext uri="{D42A27DB-BD31-4B8C-83A1-F6EECF244321}">
+                <p14:modId xmlns:p14="http://schemas.microsoft.com/office/powerpoint/2010/main" val="1579011935"/>
+              </p:ext>
+            </p:extLst>
+          </p:nvPr>
+        </p:nvGraphicFramePr>
+        <p:xfrm>
+          <a:off x="457200" y="1143000"/>
+          <a:ext cx="8229600" cy="914400"/>
+        </p:xfrm>
+        <a:graphic>
+          <a:graphicData uri="http://schemas.openxmlformats.org/drawingml/2006/table">
+            <a:tbl>
+              <a:tblPr/>
+              <a:tblGrid>
+                <a:gridCol w="2286000"/>
+                <a:gridCol w="3017520"/>
+                <a:gridCol w="2926080"/>
+              </a:tblGrid>
+              <a:tr h="411480">
+                <a:tc>
+                  <a:txBody>
+                    <a:bodyPr/>
+                    <a:lstStyle/>
+                    <a:p>
+                      <a:pPr indent="0" marL="0">
+                        <a:buNone/>
+                      </a:pPr>
+                      <a:r>
+                        <a:rPr lang="en-US" sz="1200" b="1" dirty="0">
+                          <a:solidFill>
+                            <a:schemeClr val="bg1"/>
+                          </a:solidFill>
+                        </a:rPr>
+                        <a:t>사이트 종류</a:t>
+                      </a:r>
+                      <a:endParaRPr lang="en-US" sz="1200" dirty="0"/>
+                    </a:p>
+                  </a:txBody>
+                  <a:tcPr marL="91440" marR="91440" marT="45720" marB="45720" anchor="ctr">
+                    <a:lnL w="12700" cap="flat" cmpd="sng" algn="ctr">
+                      <a:solidFill>
+                        <a:srgbClr val="EEF4F3"/>
+                      </a:solidFill>
+                      <a:prstDash val="solid"/>
+                      <a:round/>
+                      <a:headEnd type="none" w="med" len="med"/>
+                      <a:tailEnd type="none" w="med" len="med"/>
+                    </a:lnL>
+                    <a:lnR w="12700" cap="flat" cmpd="sng" algn="ctr">
+                      <a:solidFill>
+                        <a:srgbClr val="EEF4F3"/>
+                      </a:solidFill>
+                      <a:prstDash val="solid"/>
+                      <a:round/>
+                      <a:headEnd type="none" w="med" len="med"/>
+                      <a:tailEnd type="none" w="med" len="med"/>
+                    </a:lnR>
+                    <a:lnT w="12700" cap="flat" cmpd="sng" algn="ctr">
+                      <a:solidFill>
+                        <a:srgbClr val="EEF4F3"/>
+                      </a:solidFill>
+                      <a:prstDash val="solid"/>
+                      <a:round/>
+                      <a:headEnd type="none" w="med" len="med"/>
+                      <a:tailEnd type="none" w="med" len="med"/>
+                    </a:lnT>
+                    <a:lnB w="12700" cap="flat" cmpd="sng" algn="ctr">
+                      <a:solidFill>
+                        <a:srgbClr val="EEF4F3"/>
+                      </a:solidFill>
+                      <a:prstDash val="solid"/>
+                      <a:round/>
+                      <a:headEnd type="none" w="med" len="med"/>
+                      <a:tailEnd type="none" w="med" len="med"/>
+                    </a:lnB>
+                    <a:solidFill>
+                      <a:schemeClr val="tx2"/>
+                    </a:solidFill>
+                  </a:tcPr>
+                </a:tc>
+                <a:tc>
+                  <a:txBody>
+                    <a:bodyPr/>
+                    <a:lstStyle/>
+                    <a:p>
+                      <a:pPr indent="0" marL="0">
+                        <a:buNone/>
+                      </a:pPr>
+                      <a:r>
+                        <a:rPr lang="en-US" sz="1200" b="1" dirty="0">
+                          <a:solidFill>
+                            <a:schemeClr val="bg1"/>
+                          </a:solidFill>
+                        </a:rPr>
+                        <a:t>추천 출발점</a:t>
+                      </a:r>
+                      <a:endParaRPr lang="en-US" sz="1200" dirty="0"/>
+                    </a:p>
+                  </a:txBody>
+                  <a:tcPr marL="91440" marR="91440" marT="45720" marB="45720" anchor="ctr">
+                    <a:lnL w="12700" cap="flat" cmpd="sng" algn="ctr">
+                      <a:solidFill>
+                        <a:srgbClr val="EEF4F3"/>
+                      </a:solidFill>
+                      <a:prstDash val="solid"/>
+                      <a:round/>
+                      <a:headEnd type="none" w="med" len="med"/>
+                      <a:tailEnd type="none" w="med" len="med"/>
+                    </a:lnL>
+                    <a:lnR w="12700" cap="flat" cmpd="sng" algn="ctr">
+                      <a:solidFill>
+                        <a:srgbClr val="EEF4F3"/>
+                      </a:solidFill>
+                      <a:prstDash val="solid"/>
+                      <a:round/>
+                      <a:headEnd type="none" w="med" len="med"/>
+                      <a:tailEnd type="none" w="med" len="med"/>
+                    </a:lnR>
+                    <a:lnT w="12700" cap="flat" cmpd="sng" algn="ctr">
+                      <a:solidFill>
+                        <a:srgbClr val="EEF4F3"/>
+                      </a:solidFill>
+                      <a:prstDash val="solid"/>
+                      <a:round/>
+                      <a:headEnd type="none" w="med" len="med"/>
+                      <a:tailEnd type="none" w="med" len="med"/>
+                    </a:lnT>
+                    <a:lnB w="12700" cap="flat" cmpd="sng" algn="ctr">
+                      <a:solidFill>
+                        <a:srgbClr val="EEF4F3"/>
+                      </a:solidFill>
+                      <a:prstDash val="solid"/>
+                      <a:round/>
+                      <a:headEnd type="none" w="med" len="med"/>
+                      <a:tailEnd type="none" w="med" len="med"/>
+                    </a:lnB>
+                    <a:solidFill>
+                      <a:schemeClr val="tx2"/>
+                    </a:solidFill>
+                  </a:tcPr>
+                </a:tc>
+                <a:tc>
+                  <a:txBody>
+                    <a:bodyPr/>
+                    <a:lstStyle/>
+                    <a:p>
+                      <a:pPr indent="0" marL="0">
+                        <a:buNone/>
+                      </a:pPr>
+                      <a:r>
+                        <a:rPr lang="en-US" sz="1200" b="1" dirty="0">
+                          <a:solidFill>
+                            <a:schemeClr val="bg1"/>
+                          </a:solidFill>
+                        </a:rPr>
+                        <a:t>내가 할 일</a:t>
+                      </a:r>
+                      <a:endParaRPr lang="en-US" sz="1200" dirty="0"/>
+                    </a:p>
+                  </a:txBody>
+                  <a:tcPr marL="91440" marR="91440" marT="45720" marB="45720" anchor="ctr">
+                    <a:lnL w="12700" cap="flat" cmpd="sng" algn="ctr">
+                      <a:solidFill>
+                        <a:srgbClr val="EEF4F3"/>
+                      </a:solidFill>
+                      <a:prstDash val="solid"/>
+                      <a:round/>
+                      <a:headEnd type="none" w="med" len="med"/>
+                      <a:tailEnd type="none" w="med" len="med"/>
+                    </a:lnL>
+                    <a:lnR w="12700" cap="flat" cmpd="sng" algn="ctr">
+                      <a:solidFill>
+                        <a:srgbClr val="EEF4F3"/>
+                      </a:solidFill>
+                      <a:prstDash val="solid"/>
+                      <a:round/>
+                      <a:headEnd type="none" w="med" len="med"/>
+                      <a:tailEnd type="none" w="med" len="med"/>
+                    </a:lnR>
+                    <a:lnT w="12700" cap="flat" cmpd="sng" algn="ctr">
+                      <a:solidFill>
+                        <a:srgbClr val="EEF4F3"/>
+                      </a:solidFill>
+                      <a:prstDash val="solid"/>
+                      <a:round/>
+                      <a:headEnd type="none" w="med" len="med"/>
+                      <a:tailEnd type="none" w="med" len="med"/>
+                    </a:lnT>
+                    <a:lnB w="12700" cap="flat" cmpd="sng" algn="ctr">
+                      <a:solidFill>
+                        <a:srgbClr val="EEF4F3"/>
+                      </a:solidFill>
+                      <a:prstDash val="solid"/>
+                      <a:round/>
+                      <a:headEnd type="none" w="med" len="med"/>
+                      <a:tailEnd type="none" w="med" len="med"/>
+                    </a:lnB>
+                    <a:solidFill>
+                      <a:schemeClr val="tx2"/>
+                    </a:solidFill>
+                  </a:tcPr>
+                </a:tc>
+              </a:tr>
+              <a:tr h="411480">
+                <a:tc>
+                  <a:txBody>
+                    <a:bodyPr/>
+                    <a:lstStyle/>
+                    <a:p>
+                      <a:pPr indent="0" marL="0">
+                        <a:buNone/>
+                      </a:pPr>
+                      <a:r>
+                        <a:rPr lang="en-US" sz="1200" b="1" dirty="0">
+                          <a:solidFill>
+                            <a:schemeClr val="tx1"/>
+                          </a:solidFill>
+                        </a:rPr>
+                        <a:t>쇼핑몰</a:t>
+                      </a:r>
+                      <a:endParaRPr lang="en-US" sz="1200" dirty="0"/>
+                    </a:p>
+                  </a:txBody>
+                  <a:tcPr marL="91440" marR="91440" marT="45720" marB="45720" anchor="ctr">
+                    <a:lnL w="12700" cap="flat" cmpd="sng" algn="ctr">
+                      <a:solidFill>
+                        <a:srgbClr val="EEF4F3"/>
+                      </a:solidFill>
+                      <a:prstDash val="solid"/>
+                      <a:round/>
+                      <a:headEnd type="none" w="med" len="med"/>
+                      <a:tailEnd type="none" w="med" len="med"/>
+                    </a:lnL>
+                    <a:lnR w="12700" cap="flat" cmpd="sng" algn="ctr">
+                      <a:solidFill>
+                        <a:srgbClr val="EEF4F3"/>
+                      </a:solidFill>
+                      <a:prstDash val="solid"/>
+                      <a:round/>
+                      <a:headEnd type="none" w="med" len="med"/>
+                      <a:tailEnd type="none" w="med" len="med"/>
+                    </a:lnR>
+                    <a:lnT w="12700" cap="flat" cmpd="sng" algn="ctr">
+                      <a:solidFill>
+                        <a:srgbClr val="EEF4F3"/>
+                      </a:solidFill>
+                      <a:prstDash val="solid"/>
+                      <a:round/>
+                      <a:headEnd type="none" w="med" len="med"/>
+                      <a:tailEnd type="none" w="med" len="med"/>
+                    </a:lnT>
+                    <a:lnB w="12700" cap="flat" cmpd="sng" algn="ctr">
+                      <a:solidFill>
+                        <a:srgbClr val="EEF4F3"/>
+                      </a:solidFill>
+                      <a:prstDash val="solid"/>
+                      <a:round/>
+                      <a:headEnd type="none" w="med" len="med"/>
+                      <a:tailEnd type="none" w="med" len="med"/>
+                    </a:lnB>
+                  </a:tcPr>
+                </a:tc>
+                <a:tc>
+                  <a:txBody>
+                    <a:bodyPr/>
+                    <a:lstStyle/>
+                    <a:p>
+                      <a:pPr indent="0" marL="0">
+                        <a:buNone/>
+                      </a:pPr>
+                      <a:r>
+                        <a:rPr lang="en-US" sz="1200" dirty="0">
+                          <a:solidFill>
+                            <a:schemeClr val="tx1"/>
+                          </a:solidFill>
+                        </a:rPr>
+                        <a:t>국내 쇼핑몰 빌더</a:t>
+                      </a:r>
+                      <a:endParaRPr lang="en-US" sz="1200" dirty="0"/>
+                    </a:p>
+                  </a:txBody>
+                  <a:tcPr marL="91440" marR="91440" marT="45720" marB="45720" anchor="ctr">
+                    <a:lnL w="12700" cap="flat" cmpd="sng" algn="ctr">
+                      <a:solidFill>
+                        <a:srgbClr val="EEF4F3"/>
+                      </a:solidFill>
+                      <a:prstDash val="solid"/>
+                      <a:round/>
+                      <a:headEnd type="none" w="med" len="med"/>
+                      <a:tailEnd type="none" w="med" len="med"/>
+                    </a:lnL>
+                    <a:lnR w="12700" cap="flat" cmpd="sng" algn="ctr">
+                      <a:solidFill>
+                        <a:srgbClr val="EEF4F3"/>
+                      </a:solidFill>
+                      <a:prstDash val="solid"/>
+                      <a:round/>
+                      <a:headEnd type="none" w="med" len="med"/>
+                      <a:tailEnd type="none" w="med" len="med"/>
+                    </a:lnR>
+                    <a:lnT w="12700" cap="flat" cmpd="sng" algn="ctr">
+                      <a:solidFill>
+                        <a:srgbClr val="EEF4F3"/>
+                      </a:solidFill>
+                      <a:prstDash val="solid"/>
+                      <a:round/>
+                      <a:headEnd type="none" w="med" len="med"/>
+                      <a:tailEnd type="none" w="med" len="med"/>
+                    </a:lnT>
+                    <a:lnB w="12700" cap="flat" cmpd="sng" algn="ctr">
+                      <a:solidFill>
+                        <a:srgbClr val="EEF4F3"/>
+                      </a:solidFill>
+                      <a:prstDash val="solid"/>
+                      <a:round/>
+                      <a:headEnd type="none" w="med" len="med"/>
+                      <a:tailEnd type="none" w="med" len="med"/>
+                    </a:lnB>
+                  </a:tcPr>
+                </a:tc>
+                <a:tc>
+                  <a:txBody>
+                    <a:bodyPr/>
+                    <a:lstStyle/>
+                    <a:p>
+                      <a:pPr indent="0" marL="0">
+                        <a:buNone/>
+                      </a:pPr>
+                      <a:r>
+                        <a:rPr lang="en-US" sz="1200" dirty="0">
+                          <a:solidFill>
+                            <a:schemeClr val="tx1"/>
+                          </a:solidFill>
+                        </a:rPr>
+                        <a:t>거의 없음 (업체가 대부분 처리)</a:t>
+                      </a:r>
+                      <a:endParaRPr lang="en-US" sz="1200" dirty="0"/>
+                    </a:p>
+                  </a:txBody>
+                  <a:tcPr marL="91440" marR="91440" marT="45720" marB="45720" anchor="ctr">
+                    <a:lnL w="12700" cap="flat" cmpd="sng" algn="ctr">
+                      <a:solidFill>
+                        <a:srgbClr val="EEF4F3"/>
+                      </a:solidFill>
+                      <a:prstDash val="solid"/>
+                      <a:round/>
+                      <a:headEnd type="none" w="med" len="med"/>
+                      <a:tailEnd type="none" w="med" len="med"/>
+                    </a:lnL>
+                    <a:lnR w="12700" cap="flat" cmpd="sng" algn="ctr">
+                      <a:solidFill>
+                        <a:srgbClr val="EEF4F3"/>
+                      </a:solidFill>
+                      <a:prstDash val="solid"/>
+                      <a:round/>
+                      <a:headEnd type="none" w="med" len="med"/>
+                      <a:tailEnd type="none" w="med" len="med"/>
+                    </a:lnR>
+                    <a:lnT w="12700" cap="flat" cmpd="sng" algn="ctr">
+                      <a:solidFill>
+                        <a:srgbClr val="EEF4F3"/>
+                      </a:solidFill>
+                      <a:prstDash val="solid"/>
+                      <a:round/>
+                      <a:headEnd type="none" w="med" len="med"/>
+                      <a:tailEnd type="none" w="med" len="med"/>
+                    </a:lnT>
+                    <a:lnB w="12700" cap="flat" cmpd="sng" algn="ctr">
+                      <a:solidFill>
+                        <a:srgbClr val="EEF4F3"/>
+                      </a:solidFill>
+                      <a:prstDash val="solid"/>
+                      <a:round/>
+                      <a:headEnd type="none" w="med" len="med"/>
+                      <a:tailEnd type="none" w="med" len="med"/>
+                    </a:lnB>
+                  </a:tcPr>
+                </a:tc>
+              </a:tr>
+              <a:tr h="411480">
+                <a:tc>
+                  <a:txBody>
+                    <a:bodyPr/>
+                    <a:lstStyle/>
+                    <a:p>
+                      <a:pPr indent="0" marL="0">
+                        <a:buNone/>
+                      </a:pPr>
+                      <a:r>
+                        <a:rPr lang="en-US" sz="1200" b="1" dirty="0">
+                          <a:solidFill>
+                            <a:schemeClr val="tx1"/>
+                          </a:solidFill>
+                        </a:rPr>
+                        <a:t>소개·랜딩·계산기</a:t>
+                      </a:r>
+                      <a:endParaRPr lang="en-US" sz="1200" dirty="0"/>
+                    </a:p>
+                  </a:txBody>
+                  <a:tcPr marL="91440" marR="91440" marT="45720" marB="45720" anchor="ctr">
+                    <a:lnL w="12700" cap="flat" cmpd="sng" algn="ctr">
+                      <a:solidFill>
+                        <a:srgbClr val="EEF4F3"/>
+                      </a:solidFill>
+                      <a:prstDash val="solid"/>
+                      <a:round/>
+                      <a:headEnd type="none" w="med" len="med"/>
+                      <a:tailEnd type="none" w="med" len="med"/>
+                    </a:lnL>
+                    <a:lnR w="12700" cap="flat" cmpd="sng" algn="ctr">
+                      <a:solidFill>
+                        <a:srgbClr val="EEF4F3"/>
+                      </a:solidFill>
+                      <a:prstDash val="solid"/>
+                      <a:round/>
+                      <a:headEnd type="none" w="med" len="med"/>
+                      <a:tailEnd type="none" w="med" len="med"/>
+                    </a:lnR>
+                    <a:lnT w="12700" cap="flat" cmpd="sng" algn="ctr">
+                      <a:solidFill>
+                        <a:srgbClr val="EEF4F3"/>
+                      </a:solidFill>
+                      <a:prstDash val="solid"/>
+                      <a:round/>
+                      <a:headEnd type="none" w="med" len="med"/>
+                      <a:tailEnd type="none" w="med" len="med"/>
+                    </a:lnT>
+                    <a:lnB w="12700" cap="flat" cmpd="sng" algn="ctr">
+                      <a:solidFill>
+                        <a:srgbClr val="EEF4F3"/>
+                      </a:solidFill>
+                      <a:prstDash val="solid"/>
+                      <a:round/>
+                      <a:headEnd type="none" w="med" len="med"/>
+                      <a:tailEnd type="none" w="med" len="med"/>
+                    </a:lnB>
+                  </a:tcPr>
+                </a:tc>
+                <a:tc>
+                  <a:txBody>
+                    <a:bodyPr/>
+                    <a:lstStyle/>
+                    <a:p>
+                      <a:pPr indent="0" marL="0">
+                        <a:buNone/>
+                      </a:pPr>
+                      <a:r>
+                        <a:rPr lang="en-US" sz="1200" dirty="0">
+                          <a:solidFill>
+                            <a:schemeClr val="tx1"/>
+                          </a:solidFill>
+                        </a:rPr>
+                        <a:t>정적 호스팅</a:t>
+                      </a:r>
+                      <a:endParaRPr lang="en-US" sz="1200" dirty="0"/>
+                    </a:p>
+                  </a:txBody>
+                  <a:tcPr marL="91440" marR="91440" marT="45720" marB="45720" anchor="ctr">
+                    <a:lnL w="12700" cap="flat" cmpd="sng" algn="ctr">
+                      <a:solidFill>
+                        <a:srgbClr val="EEF4F3"/>
+                      </a:solidFill>
+                      <a:prstDash val="solid"/>
+                      <a:round/>
+                      <a:headEnd type="none" w="med" len="med"/>
+                      <a:tailEnd type="none" w="med" len="med"/>
+                    </a:lnL>
+                    <a:lnR w="12700" cap="flat" cmpd="sng" algn="ctr">
+                      <a:solidFill>
+                        <a:srgbClr val="EEF4F3"/>
+                      </a:solidFill>
+                      <a:prstDash val="solid"/>
+                      <a:round/>
+                      <a:headEnd type="none" w="med" len="med"/>
+                      <a:tailEnd type="none" w="med" len="med"/>
+                    </a:lnR>
+                    <a:lnT w="12700" cap="flat" cmpd="sng" algn="ctr">
+                      <a:solidFill>
+                        <a:srgbClr val="EEF4F3"/>
+                      </a:solidFill>
+                      <a:prstDash val="solid"/>
+                      <a:round/>
+                      <a:headEnd type="none" w="med" len="med"/>
+                      <a:tailEnd type="none" w="med" len="med"/>
+                    </a:lnT>
+                    <a:lnB w="12700" cap="flat" cmpd="sng" algn="ctr">
+                      <a:solidFill>
+                        <a:srgbClr val="EEF4F3"/>
+                      </a:solidFill>
+                      <a:prstDash val="solid"/>
+                      <a:round/>
+                      <a:headEnd type="none" w="med" len="med"/>
+                      <a:tailEnd type="none" w="med" len="med"/>
+                    </a:lnB>
+                  </a:tcPr>
+                </a:tc>
+                <a:tc>
+                  <a:txBody>
+                    <a:bodyPr/>
+                    <a:lstStyle/>
+                    <a:p>
+                      <a:pPr indent="0" marL="0">
+                        <a:buNone/>
+                      </a:pPr>
+                      <a:r>
+                        <a:rPr lang="en-US" sz="1200" dirty="0">
+                          <a:solidFill>
+                            <a:schemeClr val="tx1"/>
+                          </a:solidFill>
+                        </a:rPr>
+                        <a:t>Git에 올리면 자동 배포</a:t>
+                      </a:r>
+                      <a:endParaRPr lang="en-US" sz="1200" dirty="0"/>
+                    </a:p>
+                  </a:txBody>
+                  <a:tcPr marL="91440" marR="91440" marT="45720" marB="45720" anchor="ctr">
+                    <a:lnL w="12700" cap="flat" cmpd="sng" algn="ctr">
+                      <a:solidFill>
+                        <a:srgbClr val="EEF4F3"/>
+                      </a:solidFill>
+                      <a:prstDash val="solid"/>
+                      <a:round/>
+                      <a:headEnd type="none" w="med" len="med"/>
+                      <a:tailEnd type="none" w="med" len="med"/>
+                    </a:lnL>
+                    <a:lnR w="12700" cap="flat" cmpd="sng" algn="ctr">
+                      <a:solidFill>
+                        <a:srgbClr val="EEF4F3"/>
+                      </a:solidFill>
+                      <a:prstDash val="solid"/>
+                      <a:round/>
+                      <a:headEnd type="none" w="med" len="med"/>
+                      <a:tailEnd type="none" w="med" len="med"/>
+                    </a:lnR>
+                    <a:lnT w="12700" cap="flat" cmpd="sng" algn="ctr">
+                      <a:solidFill>
+                        <a:srgbClr val="EEF4F3"/>
+                      </a:solidFill>
+                      <a:prstDash val="solid"/>
+                      <a:round/>
+                      <a:headEnd type="none" w="med" len="med"/>
+                      <a:tailEnd type="none" w="med" len="med"/>
+                    </a:lnT>
+                    <a:lnB w="12700" cap="flat" cmpd="sng" algn="ctr">
+                      <a:solidFill>
+                        <a:srgbClr val="EEF4F3"/>
+                      </a:solidFill>
+                      <a:prstDash val="solid"/>
+                      <a:round/>
+                      <a:headEnd type="none" w="med" len="med"/>
+                      <a:tailEnd type="none" w="med" len="med"/>
+                    </a:lnB>
+                  </a:tcPr>
+                </a:tc>
+              </a:tr>
+              <a:tr h="411480">
+                <a:tc>
+                  <a:txBody>
+                    <a:bodyPr/>
+                    <a:lstStyle/>
+                    <a:p>
+                      <a:pPr indent="0" marL="0">
+                        <a:buNone/>
+                      </a:pPr>
+                      <a:r>
+                        <a:rPr lang="en-US" sz="1200" b="1" dirty="0">
+                          <a:solidFill>
+                            <a:schemeClr val="tx1"/>
+                          </a:solidFill>
+                        </a:rPr>
+                        <a:t>블로그·정보</a:t>
+                      </a:r>
+                      <a:endParaRPr lang="en-US" sz="1200" dirty="0"/>
+                    </a:p>
+                  </a:txBody>
+                  <a:tcPr marL="91440" marR="91440" marT="45720" marB="45720" anchor="ctr">
+                    <a:lnL w="12700" cap="flat" cmpd="sng" algn="ctr">
+                      <a:solidFill>
+                        <a:srgbClr val="EEF4F3"/>
+                      </a:solidFill>
+                      <a:prstDash val="solid"/>
+                      <a:round/>
+                      <a:headEnd type="none" w="med" len="med"/>
+                      <a:tailEnd type="none" w="med" len="med"/>
+                    </a:lnL>
+                    <a:lnR w="12700" cap="flat" cmpd="sng" algn="ctr">
+                      <a:solidFill>
+                        <a:srgbClr val="EEF4F3"/>
+                      </a:solidFill>
+                      <a:prstDash val="solid"/>
+                      <a:round/>
+                      <a:headEnd type="none" w="med" len="med"/>
+                      <a:tailEnd type="none" w="med" len="med"/>
+                    </a:lnR>
+                    <a:lnT w="12700" cap="flat" cmpd="sng" algn="ctr">
+                      <a:solidFill>
+                        <a:srgbClr val="EEF4F3"/>
+                      </a:solidFill>
+                      <a:prstDash val="solid"/>
+                      <a:round/>
+                      <a:headEnd type="none" w="med" len="med"/>
+                      <a:tailEnd type="none" w="med" len="med"/>
+                    </a:lnT>
+                    <a:lnB w="12700" cap="flat" cmpd="sng" algn="ctr">
+                      <a:solidFill>
+                        <a:srgbClr val="EEF4F3"/>
+                      </a:solidFill>
+                      <a:prstDash val="solid"/>
+                      <a:round/>
+                      <a:headEnd type="none" w="med" len="med"/>
+                      <a:tailEnd type="none" w="med" len="med"/>
+                    </a:lnB>
+                  </a:tcPr>
+                </a:tc>
+                <a:tc>
+                  <a:txBody>
+                    <a:bodyPr/>
+                    <a:lstStyle/>
+                    <a:p>
+                      <a:pPr indent="0" marL="0">
+                        <a:buNone/>
+                      </a:pPr>
+                      <a:r>
+                        <a:rPr lang="en-US" sz="1200" dirty="0">
+                          <a:solidFill>
+                            <a:schemeClr val="tx1"/>
+                          </a:solidFill>
+                        </a:rPr>
+                        <a:t>블로그 서비스 · 워드프레스 호스팅</a:t>
+                      </a:r>
+                      <a:endParaRPr lang="en-US" sz="1200" dirty="0"/>
+                    </a:p>
+                  </a:txBody>
+                  <a:tcPr marL="91440" marR="91440" marT="45720" marB="45720" anchor="ctr">
+                    <a:lnL w="12700" cap="flat" cmpd="sng" algn="ctr">
+                      <a:solidFill>
+                        <a:srgbClr val="EEF4F3"/>
+                      </a:solidFill>
+                      <a:prstDash val="solid"/>
+                      <a:round/>
+                      <a:headEnd type="none" w="med" len="med"/>
+                      <a:tailEnd type="none" w="med" len="med"/>
+                    </a:lnL>
+                    <a:lnR w="12700" cap="flat" cmpd="sng" algn="ctr">
+                      <a:solidFill>
+                        <a:srgbClr val="EEF4F3"/>
+                      </a:solidFill>
+                      <a:prstDash val="solid"/>
+                      <a:round/>
+                      <a:headEnd type="none" w="med" len="med"/>
+                      <a:tailEnd type="none" w="med" len="med"/>
+                    </a:lnR>
+                    <a:lnT w="12700" cap="flat" cmpd="sng" algn="ctr">
+                      <a:solidFill>
+                        <a:srgbClr val="EEF4F3"/>
+                      </a:solidFill>
+                      <a:prstDash val="solid"/>
+                      <a:round/>
+                      <a:headEnd type="none" w="med" len="med"/>
+                      <a:tailEnd type="none" w="med" len="med"/>
+                    </a:lnT>
+                    <a:lnB w="12700" cap="flat" cmpd="sng" algn="ctr">
+                      <a:solidFill>
+                        <a:srgbClr val="EEF4F3"/>
+                      </a:solidFill>
+                      <a:prstDash val="solid"/>
+                      <a:round/>
+                      <a:headEnd type="none" w="med" len="med"/>
+                      <a:tailEnd type="none" w="med" len="med"/>
+                    </a:lnB>
+                  </a:tcPr>
+                </a:tc>
+                <a:tc>
+                  <a:txBody>
+                    <a:bodyPr/>
+                    <a:lstStyle/>
+                    <a:p>
+                      <a:pPr indent="0" marL="0">
+                        <a:buNone/>
+                      </a:pPr>
+                      <a:r>
+                        <a:rPr lang="en-US" sz="1200" dirty="0">
+                          <a:solidFill>
+                            <a:schemeClr val="tx1"/>
+                          </a:solidFill>
+                        </a:rPr>
+                        <a:t>플러그인 업데이트</a:t>
+                      </a:r>
+                      <a:endParaRPr lang="en-US" sz="1200" dirty="0"/>
+                    </a:p>
+                  </a:txBody>
+                  <a:tcPr marL="91440" marR="91440" marT="45720" marB="45720" anchor="ctr">
+                    <a:lnL w="12700" cap="flat" cmpd="sng" algn="ctr">
+                      <a:solidFill>
+                        <a:srgbClr val="EEF4F3"/>
+                      </a:solidFill>
+                      <a:prstDash val="solid"/>
+                      <a:round/>
+                      <a:headEnd type="none" w="med" len="med"/>
+                      <a:tailEnd type="none" w="med" len="med"/>
+                    </a:lnL>
+                    <a:lnR w="12700" cap="flat" cmpd="sng" algn="ctr">
+                      <a:solidFill>
+                        <a:srgbClr val="EEF4F3"/>
+                      </a:solidFill>
+                      <a:prstDash val="solid"/>
+                      <a:round/>
+                      <a:headEnd type="none" w="med" len="med"/>
+                      <a:tailEnd type="none" w="med" len="med"/>
+                    </a:lnR>
+                    <a:lnT w="12700" cap="flat" cmpd="sng" algn="ctr">
+                      <a:solidFill>
+                        <a:srgbClr val="EEF4F3"/>
+                      </a:solidFill>
+                      <a:prstDash val="solid"/>
+                      <a:round/>
+                      <a:headEnd type="none" w="med" len="med"/>
+                      <a:tailEnd type="none" w="med" len="med"/>
+                    </a:lnT>
+                    <a:lnB w="12700" cap="flat" cmpd="sng" algn="ctr">
+                      <a:solidFill>
+                        <a:srgbClr val="EEF4F3"/>
+                      </a:solidFill>
+                      <a:prstDash val="solid"/>
+                      <a:round/>
+                      <a:headEnd type="none" w="med" len="med"/>
+                      <a:tailEnd type="none" w="med" len="med"/>
+                    </a:lnB>
+                  </a:tcPr>
+                </a:tc>
+              </a:tr>
+              <a:tr h="411480">
+                <a:tc>
+                  <a:txBody>
+                    <a:bodyPr/>
+                    <a:lstStyle/>
+                    <a:p>
+                      <a:pPr indent="0" marL="0">
+                        <a:buNone/>
+                      </a:pPr>
+                      <a:r>
+                        <a:rPr lang="en-US" sz="1200" b="1" dirty="0">
+                          <a:solidFill>
+                            <a:schemeClr val="tx1"/>
+                          </a:solidFill>
+                        </a:rPr>
+                        <a:t>회원제·AI 서비스 MVP</a:t>
+                      </a:r>
+                      <a:endParaRPr lang="en-US" sz="1200" dirty="0"/>
+                    </a:p>
+                  </a:txBody>
+                  <a:tcPr marL="91440" marR="91440" marT="45720" marB="45720" anchor="ctr">
+                    <a:lnL w="12700" cap="flat" cmpd="sng" algn="ctr">
+                      <a:solidFill>
+                        <a:srgbClr val="EEF4F3"/>
+                      </a:solidFill>
+                      <a:prstDash val="solid"/>
+                      <a:round/>
+                      <a:headEnd type="none" w="med" len="med"/>
+                      <a:tailEnd type="none" w="med" len="med"/>
+                    </a:lnL>
+                    <a:lnR w="12700" cap="flat" cmpd="sng" algn="ctr">
+                      <a:solidFill>
+                        <a:srgbClr val="EEF4F3"/>
+                      </a:solidFill>
+                      <a:prstDash val="solid"/>
+                      <a:round/>
+                      <a:headEnd type="none" w="med" len="med"/>
+                      <a:tailEnd type="none" w="med" len="med"/>
+                    </a:lnR>
+                    <a:lnT w="12700" cap="flat" cmpd="sng" algn="ctr">
+                      <a:solidFill>
+                        <a:srgbClr val="EEF4F3"/>
+                      </a:solidFill>
+                      <a:prstDash val="solid"/>
+                      <a:round/>
+                      <a:headEnd type="none" w="med" len="med"/>
+                      <a:tailEnd type="none" w="med" len="med"/>
+                    </a:lnT>
+                    <a:lnB w="12700" cap="flat" cmpd="sng" algn="ctr">
+                      <a:solidFill>
+                        <a:srgbClr val="EEF4F3"/>
+                      </a:solidFill>
+                      <a:prstDash val="solid"/>
+                      <a:round/>
+                      <a:headEnd type="none" w="med" len="med"/>
+                      <a:tailEnd type="none" w="med" len="med"/>
+                    </a:lnB>
+                  </a:tcPr>
+                </a:tc>
+                <a:tc>
+                  <a:txBody>
+                    <a:bodyPr/>
+                    <a:lstStyle/>
+                    <a:p>
+                      <a:pPr indent="0" marL="0">
+                        <a:buNone/>
+                      </a:pPr>
+                      <a:r>
+                        <a:rPr lang="en-US" sz="1200" dirty="0">
+                          <a:solidFill>
+                            <a:schemeClr val="tx1"/>
+                          </a:solidFill>
+                        </a:rPr>
+                        <a:t>PaaS + 관리형 DB</a:t>
+                      </a:r>
+                      <a:endParaRPr lang="en-US" sz="1200" dirty="0"/>
+                    </a:p>
+                  </a:txBody>
+                  <a:tcPr marL="91440" marR="91440" marT="45720" marB="45720" anchor="ctr">
+                    <a:lnL w="12700" cap="flat" cmpd="sng" algn="ctr">
+                      <a:solidFill>
+                        <a:srgbClr val="EEF4F3"/>
+                      </a:solidFill>
+                      <a:prstDash val="solid"/>
+                      <a:round/>
+                      <a:headEnd type="none" w="med" len="med"/>
+                      <a:tailEnd type="none" w="med" len="med"/>
+                    </a:lnL>
+                    <a:lnR w="12700" cap="flat" cmpd="sng" algn="ctr">
+                      <a:solidFill>
+                        <a:srgbClr val="EEF4F3"/>
+                      </a:solidFill>
+                      <a:prstDash val="solid"/>
+                      <a:round/>
+                      <a:headEnd type="none" w="med" len="med"/>
+                      <a:tailEnd type="none" w="med" len="med"/>
+                    </a:lnR>
+                    <a:lnT w="12700" cap="flat" cmpd="sng" algn="ctr">
+                      <a:solidFill>
+                        <a:srgbClr val="EEF4F3"/>
+                      </a:solidFill>
+                      <a:prstDash val="solid"/>
+                      <a:round/>
+                      <a:headEnd type="none" w="med" len="med"/>
+                      <a:tailEnd type="none" w="med" len="med"/>
+                    </a:lnT>
+                    <a:lnB w="12700" cap="flat" cmpd="sng" algn="ctr">
+                      <a:solidFill>
+                        <a:srgbClr val="EEF4F3"/>
+                      </a:solidFill>
+                      <a:prstDash val="solid"/>
+                      <a:round/>
+                      <a:headEnd type="none" w="med" len="med"/>
+                      <a:tailEnd type="none" w="med" len="med"/>
+                    </a:lnB>
+                  </a:tcPr>
+                </a:tc>
+                <a:tc>
+                  <a:txBody>
+                    <a:bodyPr/>
+                    <a:lstStyle/>
+                    <a:p>
+                      <a:pPr indent="0" marL="0">
+                        <a:buNone/>
+                      </a:pPr>
+                      <a:r>
+                        <a:rPr lang="en-US" sz="1200" dirty="0">
+                          <a:solidFill>
+                            <a:schemeClr val="tx1"/>
+                          </a:solidFill>
+                        </a:rPr>
+                        <a:t>코드만, 서버 관리는 플랫폼</a:t>
+                      </a:r>
+                      <a:endParaRPr lang="en-US" sz="1200" dirty="0"/>
+                    </a:p>
+                  </a:txBody>
+                  <a:tcPr marL="91440" marR="91440" marT="45720" marB="45720" anchor="ctr">
+                    <a:lnL w="12700" cap="flat" cmpd="sng" algn="ctr">
+                      <a:solidFill>
+                        <a:srgbClr val="EEF4F3"/>
+                      </a:solidFill>
+                      <a:prstDash val="solid"/>
+                      <a:round/>
+                      <a:headEnd type="none" w="med" len="med"/>
+                      <a:tailEnd type="none" w="med" len="med"/>
+                    </a:lnL>
+                    <a:lnR w="12700" cap="flat" cmpd="sng" algn="ctr">
+                      <a:solidFill>
+                        <a:srgbClr val="EEF4F3"/>
+                      </a:solidFill>
+                      <a:prstDash val="solid"/>
+                      <a:round/>
+                      <a:headEnd type="none" w="med" len="med"/>
+                      <a:tailEnd type="none" w="med" len="med"/>
+                    </a:lnR>
+                    <a:lnT w="12700" cap="flat" cmpd="sng" algn="ctr">
+                      <a:solidFill>
+                        <a:srgbClr val="EEF4F3"/>
+                      </a:solidFill>
+                      <a:prstDash val="solid"/>
+                      <a:round/>
+                      <a:headEnd type="none" w="med" len="med"/>
+                      <a:tailEnd type="none" w="med" len="med"/>
+                    </a:lnT>
+                    <a:lnB w="12700" cap="flat" cmpd="sng" algn="ctr">
+                      <a:solidFill>
+                        <a:srgbClr val="EEF4F3"/>
+                      </a:solidFill>
+                      <a:prstDash val="solid"/>
+                      <a:round/>
+                      <a:headEnd type="none" w="med" len="med"/>
+                      <a:tailEnd type="none" w="med" len="med"/>
+                    </a:lnB>
+                  </a:tcPr>
+                </a:tc>
+              </a:tr>
+              <a:tr h="411480">
+                <a:tc>
+                  <a:txBody>
+                    <a:bodyPr/>
+                    <a:lstStyle/>
+                    <a:p>
+                      <a:pPr indent="0" marL="0">
+                        <a:buNone/>
+                      </a:pPr>
+                      <a:r>
+                        <a:rPr lang="en-US" sz="1200" b="1" dirty="0">
+                          <a:solidFill>
+                            <a:schemeClr val="tx1"/>
+                          </a:solidFill>
+                        </a:rPr>
+                        <a:t>실시간 게임·큰 서비스</a:t>
+                      </a:r>
+                      <a:endParaRPr lang="en-US" sz="1200" dirty="0"/>
+                    </a:p>
+                  </a:txBody>
+                  <a:tcPr marL="91440" marR="91440" marT="45720" marB="45720" anchor="ctr">
+                    <a:lnL w="12700" cap="flat" cmpd="sng" algn="ctr">
+                      <a:solidFill>
+                        <a:srgbClr val="EEF4F3"/>
+                      </a:solidFill>
+                      <a:prstDash val="solid"/>
+                      <a:round/>
+                      <a:headEnd type="none" w="med" len="med"/>
+                      <a:tailEnd type="none" w="med" len="med"/>
+                    </a:lnL>
+                    <a:lnR w="12700" cap="flat" cmpd="sng" algn="ctr">
+                      <a:solidFill>
+                        <a:srgbClr val="EEF4F3"/>
+                      </a:solidFill>
+                      <a:prstDash val="solid"/>
+                      <a:round/>
+                      <a:headEnd type="none" w="med" len="med"/>
+                      <a:tailEnd type="none" w="med" len="med"/>
+                    </a:lnR>
+                    <a:lnT w="12700" cap="flat" cmpd="sng" algn="ctr">
+                      <a:solidFill>
+                        <a:srgbClr val="EEF4F3"/>
+                      </a:solidFill>
+                      <a:prstDash val="solid"/>
+                      <a:round/>
+                      <a:headEnd type="none" w="med" len="med"/>
+                      <a:tailEnd type="none" w="med" len="med"/>
+                    </a:lnT>
+                    <a:lnB w="12700" cap="flat" cmpd="sng" algn="ctr">
+                      <a:solidFill>
+                        <a:srgbClr val="EEF4F3"/>
+                      </a:solidFill>
+                      <a:prstDash val="solid"/>
+                      <a:round/>
+                      <a:headEnd type="none" w="med" len="med"/>
+                      <a:tailEnd type="none" w="med" len="med"/>
+                    </a:lnB>
+                  </a:tcPr>
+                </a:tc>
+                <a:tc>
+                  <a:txBody>
+                    <a:bodyPr/>
+                    <a:lstStyle/>
+                    <a:p>
+                      <a:pPr indent="0" marL="0">
+                        <a:buNone/>
+                      </a:pPr>
+                      <a:r>
+                        <a:rPr lang="en-US" sz="1200" dirty="0">
+                          <a:solidFill>
+                            <a:schemeClr val="tx1"/>
+                          </a:solidFill>
+                        </a:rPr>
+                        <a:t>VPS · 대형 클라우드 (서울 리전)</a:t>
+                      </a:r>
+                      <a:endParaRPr lang="en-US" sz="1200" dirty="0"/>
+                    </a:p>
+                  </a:txBody>
+                  <a:tcPr marL="91440" marR="91440" marT="45720" marB="45720" anchor="ctr">
+                    <a:lnL w="12700" cap="flat" cmpd="sng" algn="ctr">
+                      <a:solidFill>
+                        <a:srgbClr val="EEF4F3"/>
+                      </a:solidFill>
+                      <a:prstDash val="solid"/>
+                      <a:round/>
+                      <a:headEnd type="none" w="med" len="med"/>
+                      <a:tailEnd type="none" w="med" len="med"/>
+                    </a:lnL>
+                    <a:lnR w="12700" cap="flat" cmpd="sng" algn="ctr">
+                      <a:solidFill>
+                        <a:srgbClr val="EEF4F3"/>
+                      </a:solidFill>
+                      <a:prstDash val="solid"/>
+                      <a:round/>
+                      <a:headEnd type="none" w="med" len="med"/>
+                      <a:tailEnd type="none" w="med" len="med"/>
+                    </a:lnR>
+                    <a:lnT w="12700" cap="flat" cmpd="sng" algn="ctr">
+                      <a:solidFill>
+                        <a:srgbClr val="EEF4F3"/>
+                      </a:solidFill>
+                      <a:prstDash val="solid"/>
+                      <a:round/>
+                      <a:headEnd type="none" w="med" len="med"/>
+                      <a:tailEnd type="none" w="med" len="med"/>
+                    </a:lnT>
+                    <a:lnB w="12700" cap="flat" cmpd="sng" algn="ctr">
+                      <a:solidFill>
+                        <a:srgbClr val="EEF4F3"/>
+                      </a:solidFill>
+                      <a:prstDash val="solid"/>
+                      <a:round/>
+                      <a:headEnd type="none" w="med" len="med"/>
+                      <a:tailEnd type="none" w="med" len="med"/>
+                    </a:lnB>
+                  </a:tcPr>
+                </a:tc>
+                <a:tc>
+                  <a:txBody>
+                    <a:bodyPr/>
+                    <a:lstStyle/>
+                    <a:p>
+                      <a:pPr indent="0" marL="0">
+                        <a:buNone/>
+                      </a:pPr>
+                      <a:r>
+                        <a:rPr lang="en-US" sz="1200" dirty="0">
+                          <a:solidFill>
+                            <a:schemeClr val="tx1"/>
+                          </a:solidFill>
+                        </a:rPr>
+                        <a:t>보안·백업·비용 전부 직접</a:t>
+                      </a:r>
+                      <a:endParaRPr lang="en-US" sz="1200" dirty="0"/>
+                    </a:p>
+                  </a:txBody>
+                  <a:tcPr marL="91440" marR="91440" marT="45720" marB="45720" anchor="ctr">
+                    <a:lnL w="12700" cap="flat" cmpd="sng" algn="ctr">
+                      <a:solidFill>
+                        <a:srgbClr val="EEF4F3"/>
+                      </a:solidFill>
+                      <a:prstDash val="solid"/>
+                      <a:round/>
+                      <a:headEnd type="none" w="med" len="med"/>
+                      <a:tailEnd type="none" w="med" len="med"/>
+                    </a:lnL>
+                    <a:lnR w="12700" cap="flat" cmpd="sng" algn="ctr">
+                      <a:solidFill>
+                        <a:srgbClr val="EEF4F3"/>
+                      </a:solidFill>
+                      <a:prstDash val="solid"/>
+                      <a:round/>
+                      <a:headEnd type="none" w="med" len="med"/>
+                      <a:tailEnd type="none" w="med" len="med"/>
+                    </a:lnR>
+                    <a:lnT w="12700" cap="flat" cmpd="sng" algn="ctr">
+                      <a:solidFill>
+                        <a:srgbClr val="EEF4F3"/>
+                      </a:solidFill>
+                      <a:prstDash val="solid"/>
+                      <a:round/>
+                      <a:headEnd type="none" w="med" len="med"/>
+                      <a:tailEnd type="none" w="med" len="med"/>
+                    </a:lnT>
+                    <a:lnB w="12700" cap="flat" cmpd="sng" algn="ctr">
+                      <a:solidFill>
+                        <a:srgbClr val="EEF4F3"/>
+                      </a:solidFill>
+                      <a:prstDash val="solid"/>
+                      <a:round/>
+                      <a:headEnd type="none" w="med" len="med"/>
+                      <a:tailEnd type="none" w="med" len="med"/>
+                    </a:lnB>
+                  </a:tcPr>
+                </a:tc>
+              </a:tr>
+            </a:tbl>
+          </a:graphicData>
+        </a:graphic>
+      </p:graphicFrame>
+      <p:sp>
+        <p:nvSpPr>
+          <p:cNvPr id="4" name="Text 1"/>
+          <p:cNvSpPr txBox="1"/>
+          <p:nvPr/>
+        </p:nvSpPr>
+        <p:spPr>
+          <a:xfrm>
+            <a:off x="457200" y="3703320"/>
+            <a:ext cx="8229600" cy="777240"/>
+          </a:xfrm>
+          <a:prstGeom prst="rect">
+            <a:avLst/>
+          </a:prstGeom>
+          <a:noFill/>
+          <a:ln/>
+        </p:spPr>
+        <p:txBody>
+          <a:bodyPr wrap="square" lIns="0" tIns="0" rIns="0" bIns="0" rtlCol="0" anchor="t"/>
+          <a:lstStyle/>
+          <a:p>
+            <a:pPr indent="0" marL="0">
+              <a:spcAft>
+                <a:spcPts val="600"/>
+              </a:spcAft>
+              <a:buNone/>
+            </a:pPr>
+            <a:r>
+              <a:rPr lang="en-US" sz="1300" b="1" dirty="0">
+                <a:solidFill>
+                  <a:schemeClr val="accent5"/>
+                </a:solidFill>
+              </a:rPr>
+              <a:t>무료 요금제 함정  </a:t>
+            </a:r>
+            <a:pPr indent="0" marL="0">
+              <a:spcAft>
+                <a:spcPts val="600"/>
+              </a:spcAft>
+              <a:buNone/>
+            </a:pPr>
+            <a:r>
+              <a:rPr lang="en-US" sz="1300" dirty="0">
+                <a:solidFill>
+                  <a:schemeClr val="tx1"/>
+                </a:solidFill>
+              </a:rPr>
+              <a:t>상업 사용 금지 · 잠자는 서버 · 한도 초과 정지 · 유료는 요금 폭탄 → 예산 알림</a:t>
+            </a:r>
+            <a:endParaRPr lang="en-US" sz="1300" dirty="0"/>
+          </a:p>
+          <a:p>
+            <a:pPr indent="0" marL="0">
+              <a:spcAft>
+                <a:spcPts val="600"/>
+              </a:spcAft>
+              <a:buNone/>
+            </a:pPr>
+            <a:r>
+              <a:rPr lang="en-US" sz="1300" b="1" dirty="0">
+                <a:solidFill>
+                  <a:schemeClr val="accent2"/>
+                </a:solidFill>
+              </a:rPr>
+              <a:t>개인정보  </a:t>
+            </a:r>
+            <a:pPr indent="0" marL="0">
+              <a:spcAft>
+                <a:spcPts val="600"/>
+              </a:spcAft>
+              <a:buNone/>
+            </a:pPr>
+            <a:r>
+              <a:rPr lang="en-US" sz="1300" dirty="0">
+                <a:solidFill>
+                  <a:schemeClr val="tx1"/>
+                </a:solidFill>
+              </a:rPr>
+              <a:t>해외 서버에 회원 정보 → 처리방침에 국외 이전 고지가 필요할 수 있음</a:t>
+            </a:r>
+            <a:endParaRPr lang="en-US" sz="1300" dirty="0"/>
+          </a:p>
+        </p:txBody>
+      </p:sp>
+      <p:sp>
+        <p:nvSpPr>
+          <p:cNvPr id="25" name="Slide Number Placeholder 0"/>
+          <p:cNvSpPr>
+            <a:spLocks noGrp="1"/>
+          </p:cNvSpPr>
+          <p:nvPr>
+            <p:ph type="sldNum" sz="quarter" idx="4294967295"/>
+          </p:nvPr>
+        </p:nvSpPr>
+        <p:spPr>
+          <a:xfrm>
+            <a:off x="8321040" y="4754880"/>
+            <a:ext cx="457200" cy="274320"/>
+          </a:xfrm>
+          <a:prstGeom prst="rect">
+            <a:avLst/>
+          </a:prstGeom>
+          <a:extLst>
+            <a:ext uri="{C572A759-6A51-4108-AA02-DFA0A04FC94B}">
+              <ma14:wrappingTextBoxFlag xmlns:ma14="http://schemas.microsoft.com/office/mac/drawingml/2011/main" val="0"/>
+            </a:ext>
+          </a:extLst>
+        </p:spPr>
+        <p:txBody>
+          <a:bodyPr/>
+          <a:lstStyle>
+            <a:lvl1pPr>
+              <a:defRPr sz="1000">
+                <a:solidFill>
+                  <a:schemeClr val="accent4"/>
+                </a:solidFill>
+              </a:defRPr>
+            </a:lvl1pPr>
+          </a:lstStyle>
+          <a:p>
+            <a:pPr algn="r"/>
+            <a:fld id="{F7021451-1387-4CA6-816F-3879F97B5CBC}" type="slidenum">
+              <a:rPr b="0" lang="en-US"/>
+              <a:t>56</a:t>
+            </a:fld>
+            <a:endParaRPr lang="en-US"/>
+          </a:p>
+        </p:txBody>
+      </p:sp>
+    </p:spTree>
+  </p:cSld>
+  <p:clrMapOvr>
+    <a:masterClrMapping/>
+  </p:clrMapOvr>
+</p:sld>
+</file>
+
+<file path=ppt/slides/slide57.xml><?xml version="1.0" encoding="utf-8"?>
+<p:sld xmlns:a="http://schemas.openxmlformats.org/drawingml/2006/main" xmlns:r="http://schemas.openxmlformats.org/officeDocument/2006/relationships" xmlns:p="http://schemas.openxmlformats.org/presentationml/2006/main">
+  <p:cSld name="Slide 57">
+    <p:spTree>
+      <p:nvGrpSpPr>
+        <p:cNvPr id="1" name=""/>
+        <p:cNvGrpSpPr/>
+        <p:nvPr/>
+      </p:nvGrpSpPr>
+      <p:grpSpPr>
+        <a:xfrm>
+          <a:off x="0" y="0"/>
+          <a:ext cx="0" cy="0"/>
+          <a:chOff x="0" y="0"/>
+          <a:chExt cx="0" cy="0"/>
+        </a:xfrm>
+      </p:grpSpPr>
+      <p:sp>
+        <p:nvSpPr>
+          <p:cNvPr id="2" name="Text 0"/>
+          <p:cNvSpPr/>
+          <p:nvPr>
+            <p:ph idx="100" type="title" hasCustomPrompt="1"/>
+          </p:nvPr>
+        </p:nvSpPr>
+        <p:spPr>
+          <a:xfrm>
+            <a:off x="457200" y="274320"/>
+            <a:ext cx="8229600" cy="685800"/>
+          </a:xfrm>
+          <a:prstGeom prst="rect">
+            <a:avLst/>
+          </a:prstGeom>
+          <a:noFill/>
+          <a:ln/>
+        </p:spPr>
+        <p:txBody>
+          <a:bodyPr wrap="square" lIns="0" tIns="0" rIns="0" bIns="0" rtlCol="0" anchor="ctr"/>
+          <a:lstStyle/>
+          <a:p>
+            <a:pPr indent="0" marL="0">
+              <a:buNone/>
+            </a:pPr>
+            <a:r>
+              <a:rPr lang="en-US" sz="2800" b="1" dirty="0">
+                <a:solidFill>
+                  <a:schemeClr val="tx2"/>
+                </a:solidFill>
+              </a:rPr>
+              <a:t>꼭 해야 하는 보안</a:t>
+            </a:r>
+            <a:endParaRPr lang="en-US" sz="2800" dirty="0"/>
+          </a:p>
+        </p:txBody>
+      </p:sp>
+      <p:sp>
+        <p:nvSpPr>
+          <p:cNvPr id="3" name="card"/>
+          <p:cNvSpPr/>
+          <p:nvPr/>
+        </p:nvSpPr>
+        <p:spPr>
+          <a:xfrm>
+            <a:off x="457200" y="1188720"/>
+            <a:ext cx="4023360" cy="3200400"/>
+          </a:xfrm>
+          <a:prstGeom prst="roundRect">
+            <a:avLst>
+              <a:gd name="adj" fmla="val 2286"/>
+            </a:avLst>
+          </a:prstGeom>
+          <a:solidFill>
+            <a:schemeClr val="tx2"/>
+          </a:solidFill>
+          <a:ln/>
+        </p:spPr>
+      </p:sp>
+      <p:sp>
+        <p:nvSpPr>
+          <p:cNvPr id="4" name="Text 2"/>
+          <p:cNvSpPr txBox="1"/>
+          <p:nvPr/>
+        </p:nvSpPr>
+        <p:spPr>
+          <a:xfrm>
+            <a:off x="685800" y="1325880"/>
+            <a:ext cx="3566160" cy="365760"/>
+          </a:xfrm>
+          <a:prstGeom prst="rect">
+            <a:avLst/>
+          </a:prstGeom>
+          <a:noFill/>
+          <a:ln/>
+        </p:spPr>
+        <p:txBody>
+          <a:bodyPr wrap="square" lIns="0" tIns="0" rIns="0" bIns="0" rtlCol="0" anchor="t"/>
+          <a:lstStyle/>
+          <a:p>
+            <a:pPr indent="0" marL="0">
+              <a:buNone/>
+            </a:pPr>
+            <a:r>
+              <a:rPr lang="en-US" sz="1500" b="1" dirty="0">
+                <a:solidFill>
+                  <a:schemeClr val="accent6"/>
+                </a:solidFill>
+              </a:rPr>
+              <a:t>OWASP Top 10 (2025) 상위</a:t>
+            </a:r>
+            <a:endParaRPr lang="en-US" sz="1500" dirty="0"/>
+          </a:p>
+        </p:txBody>
+      </p:sp>
+      <p:sp>
+        <p:nvSpPr>
+          <p:cNvPr id="5" name="Text 3"/>
+          <p:cNvSpPr txBox="1"/>
+          <p:nvPr/>
+        </p:nvSpPr>
+        <p:spPr>
+          <a:xfrm>
+            <a:off x="685800" y="1783080"/>
+            <a:ext cx="457200" cy="548640"/>
+          </a:xfrm>
+          <a:prstGeom prst="rect">
+            <a:avLst/>
+          </a:prstGeom>
+          <a:noFill/>
+          <a:ln/>
+        </p:spPr>
+        <p:txBody>
+          <a:bodyPr wrap="square" lIns="0" tIns="0" rIns="0" bIns="0" rtlCol="0" anchor="ctr"/>
+          <a:lstStyle/>
+          <a:p>
+            <a:pPr indent="0" marL="0">
+              <a:buNone/>
+            </a:pPr>
+            <a:r>
+              <a:rPr lang="en-US" sz="1800" b="1" dirty="0">
+                <a:solidFill>
+                  <a:schemeClr val="accent2"/>
+                </a:solidFill>
+              </a:rPr>
+              <a:t>1</a:t>
             </a:r>
             <a:endParaRPr lang="en-US" sz="1800" dirty="0"/>
+          </a:p>
+        </p:txBody>
+      </p:sp>
+      <p:sp>
+        <p:nvSpPr>
+          <p:cNvPr id="6" name="Text 4"/>
+          <p:cNvSpPr txBox="1"/>
+          <p:nvPr/>
+        </p:nvSpPr>
+        <p:spPr>
+          <a:xfrm>
+            <a:off x="1188720" y="1783080"/>
+            <a:ext cx="3200400" cy="548640"/>
+          </a:xfrm>
+          <a:prstGeom prst="rect">
+            <a:avLst/>
+          </a:prstGeom>
+          <a:noFill/>
+          <a:ln/>
+        </p:spPr>
+        <p:txBody>
+          <a:bodyPr wrap="square" lIns="0" tIns="0" rIns="0" bIns="0" rtlCol="0" anchor="ctr"/>
+          <a:lstStyle/>
+          <a:p>
+            <a:pPr indent="0" marL="0">
+              <a:buNone/>
+            </a:pPr>
+            <a:r>
+              <a:rPr lang="en-US" sz="1300" b="1" dirty="0">
+                <a:solidFill>
+                  <a:schemeClr val="bg1"/>
+                </a:solidFill>
+              </a:rPr>
+              <a:t>접근 권한 실패</a:t>
+            </a:r>
+            <a:endParaRPr lang="en-US" sz="1300" dirty="0"/>
+          </a:p>
+          <a:p>
+            <a:pPr indent="0" marL="0">
+              <a:buNone/>
+            </a:pPr>
+            <a:r>
+              <a:rPr lang="en-US" sz="1100" dirty="0">
+                <a:solidFill>
+                  <a:schemeClr val="bg1"/>
+                </a:solidFill>
+              </a:rPr>
+              <a:t>남의 주문이 주소만 바꿔 보임</a:t>
+            </a:r>
+            <a:endParaRPr lang="en-US" sz="1300" dirty="0"/>
+          </a:p>
+        </p:txBody>
+      </p:sp>
+      <p:sp>
+        <p:nvSpPr>
+          <p:cNvPr id="7" name="Text 5"/>
+          <p:cNvSpPr txBox="1"/>
+          <p:nvPr/>
+        </p:nvSpPr>
+        <p:spPr>
+          <a:xfrm>
+            <a:off x="685800" y="2404872"/>
+            <a:ext cx="457200" cy="548640"/>
+          </a:xfrm>
+          <a:prstGeom prst="rect">
+            <a:avLst/>
+          </a:prstGeom>
+          <a:noFill/>
+          <a:ln/>
+        </p:spPr>
+        <p:txBody>
+          <a:bodyPr wrap="square" lIns="0" tIns="0" rIns="0" bIns="0" rtlCol="0" anchor="ctr"/>
+          <a:lstStyle/>
+          <a:p>
+            <a:pPr indent="0" marL="0">
+              <a:buNone/>
+            </a:pPr>
+            <a:r>
+              <a:rPr lang="en-US" sz="1800" b="1" dirty="0">
+                <a:solidFill>
+                  <a:schemeClr val="accent2"/>
+                </a:solidFill>
+              </a:rPr>
+              <a:t>2</a:t>
+            </a:r>
+            <a:endParaRPr lang="en-US" sz="1800" dirty="0"/>
+          </a:p>
+        </p:txBody>
+      </p:sp>
+      <p:sp>
+        <p:nvSpPr>
+          <p:cNvPr id="8" name="Text 6"/>
+          <p:cNvSpPr txBox="1"/>
+          <p:nvPr/>
+        </p:nvSpPr>
+        <p:spPr>
+          <a:xfrm>
+            <a:off x="1188720" y="2404872"/>
+            <a:ext cx="3200400" cy="548640"/>
+          </a:xfrm>
+          <a:prstGeom prst="rect">
+            <a:avLst/>
+          </a:prstGeom>
+          <a:noFill/>
+          <a:ln/>
+        </p:spPr>
+        <p:txBody>
+          <a:bodyPr wrap="square" lIns="0" tIns="0" rIns="0" bIns="0" rtlCol="0" anchor="ctr"/>
+          <a:lstStyle/>
+          <a:p>
+            <a:pPr indent="0" marL="0">
+              <a:buNone/>
+            </a:pPr>
+            <a:r>
+              <a:rPr lang="en-US" sz="1300" b="1" dirty="0">
+                <a:solidFill>
+                  <a:schemeClr val="bg1"/>
+                </a:solidFill>
+              </a:rPr>
+              <a:t>보안 설정 오류</a:t>
+            </a:r>
+            <a:endParaRPr lang="en-US" sz="1300" dirty="0"/>
+          </a:p>
+          <a:p>
+            <a:pPr indent="0" marL="0">
+              <a:buNone/>
+            </a:pPr>
+            <a:r>
+              <a:rPr lang="en-US" sz="1100" dirty="0">
+                <a:solidFill>
+                  <a:schemeClr val="bg1"/>
+                </a:solidFill>
+              </a:rPr>
+              <a:t>기본 비번·디버그 모드</a:t>
+            </a:r>
+            <a:endParaRPr lang="en-US" sz="1300" dirty="0"/>
+          </a:p>
+        </p:txBody>
+      </p:sp>
+      <p:sp>
+        <p:nvSpPr>
+          <p:cNvPr id="9" name="Text 7"/>
+          <p:cNvSpPr txBox="1"/>
+          <p:nvPr/>
+        </p:nvSpPr>
+        <p:spPr>
+          <a:xfrm>
+            <a:off x="685800" y="3026664"/>
+            <a:ext cx="457200" cy="548640"/>
+          </a:xfrm>
+          <a:prstGeom prst="rect">
+            <a:avLst/>
+          </a:prstGeom>
+          <a:noFill/>
+          <a:ln/>
+        </p:spPr>
+        <p:txBody>
+          <a:bodyPr wrap="square" lIns="0" tIns="0" rIns="0" bIns="0" rtlCol="0" anchor="ctr"/>
+          <a:lstStyle/>
+          <a:p>
+            <a:pPr indent="0" marL="0">
+              <a:buNone/>
+            </a:pPr>
+            <a:r>
+              <a:rPr lang="en-US" sz="1800" b="1" dirty="0">
+                <a:solidFill>
+                  <a:schemeClr val="accent2"/>
+                </a:solidFill>
+              </a:rPr>
+              <a:t>3</a:t>
+            </a:r>
+            <a:endParaRPr lang="en-US" sz="1800" dirty="0"/>
+          </a:p>
+        </p:txBody>
+      </p:sp>
+      <p:sp>
+        <p:nvSpPr>
+          <p:cNvPr id="10" name="Text 8"/>
+          <p:cNvSpPr txBox="1"/>
+          <p:nvPr/>
+        </p:nvSpPr>
+        <p:spPr>
+          <a:xfrm>
+            <a:off x="1188720" y="3026664"/>
+            <a:ext cx="3200400" cy="548640"/>
+          </a:xfrm>
+          <a:prstGeom prst="rect">
+            <a:avLst/>
+          </a:prstGeom>
+          <a:noFill/>
+          <a:ln/>
+        </p:spPr>
+        <p:txBody>
+          <a:bodyPr wrap="square" lIns="0" tIns="0" rIns="0" bIns="0" rtlCol="0" anchor="ctr"/>
+          <a:lstStyle/>
+          <a:p>
+            <a:pPr indent="0" marL="0">
+              <a:buNone/>
+            </a:pPr>
+            <a:r>
+              <a:rPr lang="en-US" sz="1300" b="1" dirty="0">
+                <a:solidFill>
+                  <a:schemeClr val="bg1"/>
+                </a:solidFill>
+              </a:rPr>
+              <a:t>공급망 실패 (신규)</a:t>
+            </a:r>
+            <a:endParaRPr lang="en-US" sz="1300" dirty="0"/>
+          </a:p>
+          <a:p>
+            <a:pPr indent="0" marL="0">
+              <a:buNone/>
+            </a:pPr>
+            <a:r>
+              <a:rPr lang="en-US" sz="1100" dirty="0">
+                <a:solidFill>
+                  <a:schemeClr val="bg1"/>
+                </a:solidFill>
+              </a:rPr>
+              <a:t>오염·오래된 라이브러리</a:t>
+            </a:r>
+            <a:endParaRPr lang="en-US" sz="1300" dirty="0"/>
+          </a:p>
+        </p:txBody>
+      </p:sp>
+      <p:sp>
+        <p:nvSpPr>
+          <p:cNvPr id="11" name="Text 9"/>
+          <p:cNvSpPr txBox="1"/>
+          <p:nvPr/>
+        </p:nvSpPr>
+        <p:spPr>
+          <a:xfrm>
+            <a:off x="685800" y="3648456"/>
+            <a:ext cx="457200" cy="548640"/>
+          </a:xfrm>
+          <a:prstGeom prst="rect">
+            <a:avLst/>
+          </a:prstGeom>
+          <a:noFill/>
+          <a:ln/>
+        </p:spPr>
+        <p:txBody>
+          <a:bodyPr wrap="square" lIns="0" tIns="0" rIns="0" bIns="0" rtlCol="0" anchor="ctr"/>
+          <a:lstStyle/>
+          <a:p>
+            <a:pPr indent="0" marL="0">
+              <a:buNone/>
+            </a:pPr>
+            <a:r>
+              <a:rPr lang="en-US" sz="1800" b="1" dirty="0">
+                <a:solidFill>
+                  <a:schemeClr val="accent2"/>
+                </a:solidFill>
+              </a:rPr>
+              <a:t>10</a:t>
+            </a:r>
+            <a:endParaRPr lang="en-US" sz="1800" dirty="0"/>
+          </a:p>
+        </p:txBody>
+      </p:sp>
+      <p:sp>
+        <p:nvSpPr>
+          <p:cNvPr id="12" name="Text 10"/>
+          <p:cNvSpPr txBox="1"/>
+          <p:nvPr/>
+        </p:nvSpPr>
+        <p:spPr>
+          <a:xfrm>
+            <a:off x="1188720" y="3648456"/>
+            <a:ext cx="3200400" cy="548640"/>
+          </a:xfrm>
+          <a:prstGeom prst="rect">
+            <a:avLst/>
+          </a:prstGeom>
+          <a:noFill/>
+          <a:ln/>
+        </p:spPr>
+        <p:txBody>
+          <a:bodyPr wrap="square" lIns="0" tIns="0" rIns="0" bIns="0" rtlCol="0" anchor="ctr"/>
+          <a:lstStyle/>
+          <a:p>
+            <a:pPr indent="0" marL="0">
+              <a:buNone/>
+            </a:pPr>
+            <a:r>
+              <a:rPr lang="en-US" sz="1300" b="1" dirty="0">
+                <a:solidFill>
+                  <a:schemeClr val="bg1"/>
+                </a:solidFill>
+              </a:rPr>
+              <a:t>예외 처리 실패 (신규)</a:t>
+            </a:r>
+            <a:endParaRPr lang="en-US" sz="1300" dirty="0"/>
+          </a:p>
+          <a:p>
+            <a:pPr indent="0" marL="0">
+              <a:buNone/>
+            </a:pPr>
+            <a:r>
+              <a:rPr lang="en-US" sz="1100" dirty="0">
+                <a:solidFill>
+                  <a:schemeClr val="bg1"/>
+                </a:solidFill>
+              </a:rPr>
+              <a:t>오류 화면에 내부 정보</a:t>
+            </a:r>
+            <a:endParaRPr lang="en-US" sz="1300" dirty="0"/>
+          </a:p>
+        </p:txBody>
+      </p:sp>
+      <p:sp>
+        <p:nvSpPr>
+          <p:cNvPr id="13" name="Text 11"/>
+          <p:cNvSpPr txBox="1"/>
+          <p:nvPr/>
+        </p:nvSpPr>
+        <p:spPr>
+          <a:xfrm>
+            <a:off x="4754880" y="1188720"/>
+            <a:ext cx="3931920" cy="365760"/>
+          </a:xfrm>
+          <a:prstGeom prst="rect">
+            <a:avLst/>
+          </a:prstGeom>
+          <a:noFill/>
+          <a:ln/>
+        </p:spPr>
+        <p:txBody>
+          <a:bodyPr wrap="square" lIns="0" tIns="0" rIns="0" bIns="0" rtlCol="0" anchor="t"/>
+          <a:lstStyle/>
+          <a:p>
+            <a:pPr indent="0" marL="0">
+              <a:buNone/>
+            </a:pPr>
+            <a:r>
+              <a:rPr lang="en-US" sz="1500" b="1" dirty="0">
+                <a:solidFill>
+                  <a:schemeClr val="accent2"/>
+                </a:solidFill>
+              </a:rPr>
+              <a:t>누구나</a:t>
+            </a:r>
+            <a:endParaRPr lang="en-US" sz="1500" dirty="0"/>
+          </a:p>
+        </p:txBody>
+      </p:sp>
+      <p:sp>
+        <p:nvSpPr>
+          <p:cNvPr id="14" name="Text 12"/>
+          <p:cNvSpPr txBox="1"/>
+          <p:nvPr/>
+        </p:nvSpPr>
+        <p:spPr>
+          <a:xfrm>
+            <a:off x="4754880" y="1600200"/>
+            <a:ext cx="3931920" cy="1097280"/>
+          </a:xfrm>
+          <a:prstGeom prst="rect">
+            <a:avLst/>
+          </a:prstGeom>
+          <a:noFill/>
+          <a:ln/>
+        </p:spPr>
+        <p:txBody>
+          <a:bodyPr wrap="square" lIns="0" tIns="0" rIns="0" bIns="0" rtlCol="0" anchor="t"/>
+          <a:lstStyle/>
+          <a:p>
+            <a:pPr marL="342900" indent="-342900">
+              <a:spcAft>
+                <a:spcPts val="400"/>
+              </a:spcAft>
+              <a:buSzPct val="100000"/>
+              <a:buChar char="•"/>
+            </a:pPr>
+            <a:r>
+              <a:rPr lang="en-US" sz="1300" dirty="0">
+                <a:solidFill>
+                  <a:schemeClr val="tx1"/>
+                </a:solidFill>
+              </a:rPr>
+              <a:t>모든 관리자 계정 2단계 인증</a:t>
+            </a:r>
+            <a:endParaRPr lang="en-US" sz="1300" dirty="0"/>
+          </a:p>
+          <a:p>
+            <a:pPr marL="342900" indent="-342900">
+              <a:spcAft>
+                <a:spcPts val="400"/>
+              </a:spcAft>
+              <a:buSzPct val="100000"/>
+              <a:buChar char="•"/>
+            </a:pPr>
+            <a:r>
+              <a:rPr lang="en-US" sz="1300" dirty="0">
+                <a:solidFill>
+                  <a:schemeClr val="tx1"/>
+                </a:solidFill>
+              </a:rPr>
+              <a:t>공유 계정 금지 · 필요한 권한만</a:t>
+            </a:r>
+            <a:endParaRPr lang="en-US" sz="1300" dirty="0"/>
+          </a:p>
+          <a:p>
+            <a:pPr marL="342900" indent="-342900">
+              <a:spcAft>
+                <a:spcPts val="400"/>
+              </a:spcAft>
+              <a:buSzPct val="100000"/>
+              <a:buChar char="•"/>
+            </a:pPr>
+            <a:r>
+              <a:rPr lang="en-US" sz="1300" dirty="0">
+                <a:solidFill>
+                  <a:schemeClr val="tx1"/>
+                </a:solidFill>
+              </a:rPr>
+              <a:t>HTTPS · 업데이트 · 백업 · 도메인 잠금</a:t>
+            </a:r>
+            <a:endParaRPr lang="en-US" sz="1300" dirty="0"/>
+          </a:p>
+        </p:txBody>
+      </p:sp>
+      <p:sp>
+        <p:nvSpPr>
+          <p:cNvPr id="15" name="Text 13"/>
+          <p:cNvSpPr txBox="1"/>
+          <p:nvPr/>
+        </p:nvSpPr>
+        <p:spPr>
+          <a:xfrm>
+            <a:off x="4754880" y="2743200"/>
+            <a:ext cx="3931920" cy="365760"/>
+          </a:xfrm>
+          <a:prstGeom prst="rect">
+            <a:avLst/>
+          </a:prstGeom>
+          <a:noFill/>
+          <a:ln/>
+        </p:spPr>
+        <p:txBody>
+          <a:bodyPr wrap="square" lIns="0" tIns="0" rIns="0" bIns="0" rtlCol="0" anchor="t"/>
+          <a:lstStyle/>
+          <a:p>
+            <a:pPr indent="0" marL="0">
+              <a:buNone/>
+            </a:pPr>
+            <a:r>
+              <a:rPr lang="en-US" sz="1500" b="1" dirty="0">
+                <a:solidFill>
+                  <a:schemeClr val="tx2"/>
+                </a:solidFill>
+              </a:rPr>
+              <a:t>직접 개발이면 추가로</a:t>
+            </a:r>
+            <a:endParaRPr lang="en-US" sz="1500" dirty="0"/>
+          </a:p>
+        </p:txBody>
+      </p:sp>
+      <p:sp>
+        <p:nvSpPr>
+          <p:cNvPr id="16" name="Text 14"/>
+          <p:cNvSpPr txBox="1"/>
+          <p:nvPr/>
+        </p:nvSpPr>
+        <p:spPr>
+          <a:xfrm>
+            <a:off x="4754880" y="3154680"/>
+            <a:ext cx="3931920" cy="1188720"/>
+          </a:xfrm>
+          <a:prstGeom prst="rect">
+            <a:avLst/>
+          </a:prstGeom>
+          <a:noFill/>
+          <a:ln/>
+        </p:spPr>
+        <p:txBody>
+          <a:bodyPr wrap="square" lIns="0" tIns="0" rIns="0" bIns="0" rtlCol="0" anchor="t"/>
+          <a:lstStyle/>
+          <a:p>
+            <a:pPr marL="342900" indent="-342900">
+              <a:spcAft>
+                <a:spcPts val="400"/>
+              </a:spcAft>
+              <a:buSzPct val="100000"/>
+              <a:buChar char="•"/>
+            </a:pPr>
+            <a:r>
+              <a:rPr lang="en-US" sz="1300" dirty="0">
+                <a:solidFill>
+                  <a:schemeClr val="tx1"/>
+                </a:solidFill>
+              </a:rPr>
+              <a:t>매 요청 주인 확인 · 금액은 서버에서 계산</a:t>
+            </a:r>
+            <a:endParaRPr lang="en-US" sz="1300" dirty="0"/>
+          </a:p>
+          <a:p>
+            <a:pPr marL="342900" indent="-342900">
+              <a:spcAft>
+                <a:spcPts val="400"/>
+              </a:spcAft>
+              <a:buSzPct val="100000"/>
+              <a:buChar char="•"/>
+            </a:pPr>
+            <a:r>
+              <a:rPr lang="en-US" sz="1300" dirty="0">
+                <a:solidFill>
+                  <a:schemeClr val="tx1"/>
+                </a:solidFill>
+              </a:rPr>
+              <a:t>해시 · 자리표시자 · 보안 헤더</a:t>
+            </a:r>
+            <a:endParaRPr lang="en-US" sz="1300" dirty="0"/>
+          </a:p>
+          <a:p>
+            <a:pPr marL="342900" indent="-342900">
+              <a:spcAft>
+                <a:spcPts val="400"/>
+              </a:spcAft>
+              <a:buSzPct val="100000"/>
+              <a:buChar char="•"/>
+            </a:pPr>
+            <a:r>
+              <a:rPr lang="en-US" sz="1300" dirty="0">
+                <a:solidFill>
+                  <a:schemeClr val="tx1"/>
+                </a:solidFill>
+              </a:rPr>
+              <a:t>비밀 키는 환경 변수 · 로그와 알림</a:t>
+            </a:r>
+            <a:endParaRPr lang="en-US" sz="1300" dirty="0"/>
+          </a:p>
+        </p:txBody>
+      </p:sp>
+      <p:sp>
+        <p:nvSpPr>
+          <p:cNvPr id="17" name="Text 15"/>
+          <p:cNvSpPr txBox="1"/>
+          <p:nvPr/>
+        </p:nvSpPr>
+        <p:spPr>
+          <a:xfrm>
+            <a:off x="457200" y="4645152"/>
+            <a:ext cx="7680960" cy="274320"/>
+          </a:xfrm>
+          <a:prstGeom prst="rect">
+            <a:avLst/>
+          </a:prstGeom>
+          <a:noFill/>
+          <a:ln/>
+        </p:spPr>
+        <p:txBody>
+          <a:bodyPr wrap="square" lIns="0" tIns="0" rIns="0" bIns="0" rtlCol="0" anchor="t"/>
+          <a:lstStyle/>
+          <a:p>
+            <a:pPr indent="0" marL="0">
+              <a:buNone/>
+            </a:pPr>
+            <a:r>
+              <a:rPr lang="en-US" sz="1000" dirty="0">
+                <a:solidFill>
+                  <a:schemeClr val="accent4"/>
+                </a:solidFill>
+              </a:rPr>
+              <a:t>개인정보 접속기록은 원칙 1년 이상(조건에 따라 2년) 보관 · 유출 의심 시 확산 차단 → 증거 보존 → 신고 (37장)</a:t>
+            </a:r>
+            <a:endParaRPr lang="en-US" sz="1000" dirty="0"/>
+          </a:p>
+        </p:txBody>
+      </p:sp>
+      <p:sp>
+        <p:nvSpPr>
+          <p:cNvPr id="25" name="Slide Number Placeholder 0"/>
+          <p:cNvSpPr>
+            <a:spLocks noGrp="1"/>
+          </p:cNvSpPr>
+          <p:nvPr>
+            <p:ph type="sldNum" sz="quarter" idx="4294967295"/>
+          </p:nvPr>
+        </p:nvSpPr>
+        <p:spPr>
+          <a:xfrm>
+            <a:off x="8321040" y="4754880"/>
+            <a:ext cx="457200" cy="274320"/>
+          </a:xfrm>
+          <a:prstGeom prst="rect">
+            <a:avLst/>
+          </a:prstGeom>
+          <a:extLst>
+            <a:ext uri="{C572A759-6A51-4108-AA02-DFA0A04FC94B}">
+              <ma14:wrappingTextBoxFlag xmlns:ma14="http://schemas.microsoft.com/office/mac/drawingml/2011/main" val="0"/>
+            </a:ext>
+          </a:extLst>
+        </p:spPr>
+        <p:txBody>
+          <a:bodyPr/>
+          <a:lstStyle>
+            <a:lvl1pPr>
+              <a:defRPr sz="1000">
+                <a:solidFill>
+                  <a:schemeClr val="accent4"/>
+                </a:solidFill>
+              </a:defRPr>
+            </a:lvl1pPr>
+          </a:lstStyle>
+          <a:p>
+            <a:pPr algn="r"/>
+            <a:fld id="{F7021451-1387-4CA6-816F-3879F97B5CBC}" type="slidenum">
+              <a:rPr b="0" lang="en-US"/>
+              <a:t>57</a:t>
+            </a:fld>
+            <a:endParaRPr lang="en-US"/>
+          </a:p>
+        </p:txBody>
+      </p:sp>
+    </p:spTree>
+  </p:cSld>
+  <p:clrMapOvr>
+    <a:masterClrMapping/>
+  </p:clrMapOvr>
+</p:sld>
+</file>
+
+<file path=ppt/slides/slide58.xml><?xml version="1.0" encoding="utf-8"?>
+<p:sld xmlns:a="http://schemas.openxmlformats.org/drawingml/2006/main" xmlns:r="http://schemas.openxmlformats.org/officeDocument/2006/relationships" xmlns:p="http://schemas.openxmlformats.org/presentationml/2006/main">
+  <p:cSld name="Slide 58">
+    <p:spTree>
+      <p:nvGrpSpPr>
+        <p:cNvPr id="1" name=""/>
+        <p:cNvGrpSpPr/>
+        <p:nvPr/>
+      </p:nvGrpSpPr>
+      <p:grpSpPr>
+        <a:xfrm>
+          <a:off x="0" y="0"/>
+          <a:ext cx="0" cy="0"/>
+          <a:chOff x="0" y="0"/>
+          <a:chExt cx="0" cy="0"/>
+        </a:xfrm>
+      </p:grpSpPr>
+      <p:sp>
+        <p:nvSpPr>
+          <p:cNvPr id="2" name="Text 0"/>
+          <p:cNvSpPr/>
+          <p:nvPr>
+            <p:ph idx="100" type="title" hasCustomPrompt="1"/>
+          </p:nvPr>
+        </p:nvSpPr>
+        <p:spPr>
+          <a:xfrm>
+            <a:off x="457200" y="274320"/>
+            <a:ext cx="8229600" cy="685800"/>
+          </a:xfrm>
+          <a:prstGeom prst="rect">
+            <a:avLst/>
+          </a:prstGeom>
+          <a:noFill/>
+          <a:ln/>
+        </p:spPr>
+        <p:txBody>
+          <a:bodyPr wrap="square" lIns="0" tIns="0" rIns="0" bIns="0" rtlCol="0" anchor="ctr"/>
+          <a:lstStyle/>
+          <a:p>
+            <a:pPr indent="0" marL="0">
+              <a:buNone/>
+            </a:pPr>
+            <a:r>
+              <a:rPr lang="en-US" sz="2800" b="1" dirty="0">
+                <a:solidFill>
+                  <a:schemeClr val="tx2"/>
+                </a:solidFill>
+              </a:rPr>
+              <a:t>출시 전 Claude에게 요청할 30가지</a:t>
+            </a:r>
+            <a:endParaRPr lang="en-US" sz="2800" dirty="0"/>
+          </a:p>
+        </p:txBody>
+      </p:sp>
+      <p:sp>
+        <p:nvSpPr>
+          <p:cNvPr id="3" name="card"/>
+          <p:cNvSpPr/>
+          <p:nvPr/>
+        </p:nvSpPr>
+        <p:spPr>
+          <a:xfrm>
+            <a:off x="457200" y="1188720"/>
+            <a:ext cx="1920240" cy="2834640"/>
+          </a:xfrm>
+          <a:prstGeom prst="roundRect">
+            <a:avLst>
+              <a:gd name="adj" fmla="val 3810"/>
+            </a:avLst>
+          </a:prstGeom>
+          <a:solidFill>
+            <a:schemeClr val="bg2"/>
+          </a:solidFill>
+          <a:ln/>
+        </p:spPr>
+      </p:sp>
+      <p:sp>
+        <p:nvSpPr>
+          <p:cNvPr id="4" name="Text 2"/>
+          <p:cNvSpPr txBox="1"/>
+          <p:nvPr/>
+        </p:nvSpPr>
+        <p:spPr>
+          <a:xfrm>
+            <a:off x="621792" y="1325880"/>
+            <a:ext cx="1645920" cy="411480"/>
+          </a:xfrm>
+          <a:prstGeom prst="rect">
+            <a:avLst/>
+          </a:prstGeom>
+          <a:noFill/>
+          <a:ln/>
+        </p:spPr>
+        <p:txBody>
+          <a:bodyPr wrap="square" lIns="0" tIns="0" rIns="0" bIns="0" rtlCol="0" anchor="t"/>
+          <a:lstStyle/>
+          <a:p>
+            <a:pPr indent="0" marL="0">
+              <a:buNone/>
+            </a:pPr>
+            <a:r>
+              <a:rPr lang="en-US" sz="1500" b="1" dirty="0">
+                <a:solidFill>
+                  <a:schemeClr val="accent2"/>
+                </a:solidFill>
+              </a:rPr>
+              <a:t>첫인상·전환</a:t>
+            </a:r>
+            <a:endParaRPr lang="en-US" sz="1500" dirty="0"/>
+          </a:p>
+        </p:txBody>
+      </p:sp>
+      <p:sp>
+        <p:nvSpPr>
+          <p:cNvPr id="5" name="Text 3"/>
+          <p:cNvSpPr txBox="1"/>
+          <p:nvPr/>
+        </p:nvSpPr>
+        <p:spPr>
+          <a:xfrm>
+            <a:off x="621792" y="1783080"/>
+            <a:ext cx="1691640" cy="2103120"/>
+          </a:xfrm>
+          <a:prstGeom prst="rect">
+            <a:avLst/>
+          </a:prstGeom>
+          <a:noFill/>
+          <a:ln/>
+        </p:spPr>
+        <p:txBody>
+          <a:bodyPr wrap="square" lIns="0" tIns="0" rIns="0" bIns="0" rtlCol="0" anchor="t"/>
+          <a:lstStyle/>
+          <a:p>
+            <a:pPr marL="342900" indent="-342900">
+              <a:spcAft>
+                <a:spcPts val="600"/>
+              </a:spcAft>
+              <a:buSzPct val="100000"/>
+              <a:buChar char="•"/>
+            </a:pPr>
+            <a:r>
+              <a:rPr lang="en-US" sz="1200" dirty="0">
+                <a:solidFill>
+                  <a:schemeClr val="tx1"/>
+                </a:solidFill>
+              </a:rPr>
+              <a:t>첫 화면 CTA 1개</a:t>
+            </a:r>
+            <a:endParaRPr lang="en-US" sz="1200" dirty="0"/>
+          </a:p>
+          <a:p>
+            <a:pPr marL="342900" indent="-342900">
+              <a:spcAft>
+                <a:spcPts val="600"/>
+              </a:spcAft>
+              <a:buSzPct val="100000"/>
+              <a:buChar char="•"/>
+            </a:pPr>
+            <a:r>
+              <a:rPr lang="en-US" sz="1200" dirty="0">
+                <a:solidFill>
+                  <a:schemeClr val="tx1"/>
+                </a:solidFill>
+              </a:rPr>
+              <a:t>모바일 고정 버튼</a:t>
+            </a:r>
+            <a:endParaRPr lang="en-US" sz="1200" dirty="0"/>
+          </a:p>
+          <a:p>
+            <a:pPr marL="342900" indent="-342900">
+              <a:spcAft>
+                <a:spcPts val="600"/>
+              </a:spcAft>
+              <a:buSzPct val="100000"/>
+              <a:buChar char="•"/>
+            </a:pPr>
+            <a:r>
+              <a:rPr lang="en-US" sz="1200" dirty="0">
+                <a:solidFill>
+                  <a:schemeClr val="tx1"/>
+                </a:solidFill>
+              </a:rPr>
+              <a:t>신뢰 요소 · FAQ</a:t>
+            </a:r>
+            <a:endParaRPr lang="en-US" sz="1200" dirty="0"/>
+          </a:p>
+          <a:p>
+            <a:pPr marL="342900" indent="-342900">
+              <a:spcAft>
+                <a:spcPts val="600"/>
+              </a:spcAft>
+              <a:buSzPct val="100000"/>
+              <a:buChar char="•"/>
+            </a:pPr>
+            <a:r>
+              <a:rPr lang="en-US" sz="1200" dirty="0">
+                <a:solidFill>
+                  <a:schemeClr val="tx1"/>
+                </a:solidFill>
+              </a:rPr>
+              <a:t>문의 답변 시간 표시</a:t>
+            </a:r>
+            <a:endParaRPr lang="en-US" sz="1200" dirty="0"/>
+          </a:p>
+        </p:txBody>
+      </p:sp>
+      <p:sp>
+        <p:nvSpPr>
+          <p:cNvPr id="6" name="card"/>
+          <p:cNvSpPr/>
+          <p:nvPr/>
+        </p:nvSpPr>
+        <p:spPr>
+          <a:xfrm>
+            <a:off x="2560320" y="1188720"/>
+            <a:ext cx="1920240" cy="2834640"/>
+          </a:xfrm>
+          <a:prstGeom prst="roundRect">
+            <a:avLst>
+              <a:gd name="adj" fmla="val 3810"/>
+            </a:avLst>
+          </a:prstGeom>
+          <a:solidFill>
+            <a:schemeClr val="tx2"/>
+          </a:solidFill>
+          <a:ln/>
+        </p:spPr>
+      </p:sp>
+      <p:sp>
+        <p:nvSpPr>
+          <p:cNvPr id="7" name="Text 5"/>
+          <p:cNvSpPr txBox="1"/>
+          <p:nvPr/>
+        </p:nvSpPr>
+        <p:spPr>
+          <a:xfrm>
+            <a:off x="2724912" y="1325880"/>
+            <a:ext cx="1645920" cy="411480"/>
+          </a:xfrm>
+          <a:prstGeom prst="rect">
+            <a:avLst/>
+          </a:prstGeom>
+          <a:noFill/>
+          <a:ln/>
+        </p:spPr>
+        <p:txBody>
+          <a:bodyPr wrap="square" lIns="0" tIns="0" rIns="0" bIns="0" rtlCol="0" anchor="t"/>
+          <a:lstStyle/>
+          <a:p>
+            <a:pPr indent="0" marL="0">
+              <a:buNone/>
+            </a:pPr>
+            <a:r>
+              <a:rPr lang="en-US" sz="1500" b="1" dirty="0">
+                <a:solidFill>
+                  <a:schemeClr val="accent6"/>
+                </a:solidFill>
+              </a:rPr>
+              <a:t>검색 노출</a:t>
+            </a:r>
+            <a:endParaRPr lang="en-US" sz="1500" dirty="0"/>
+          </a:p>
+        </p:txBody>
+      </p:sp>
+      <p:sp>
+        <p:nvSpPr>
+          <p:cNvPr id="8" name="Text 6"/>
+          <p:cNvSpPr txBox="1"/>
+          <p:nvPr/>
+        </p:nvSpPr>
+        <p:spPr>
+          <a:xfrm>
+            <a:off x="2724912" y="1783080"/>
+            <a:ext cx="1691640" cy="2103120"/>
+          </a:xfrm>
+          <a:prstGeom prst="rect">
+            <a:avLst/>
+          </a:prstGeom>
+          <a:noFill/>
+          <a:ln/>
+        </p:spPr>
+        <p:txBody>
+          <a:bodyPr wrap="square" lIns="0" tIns="0" rIns="0" bIns="0" rtlCol="0" anchor="t"/>
+          <a:lstStyle/>
+          <a:p>
+            <a:pPr marL="342900" indent="-342900">
+              <a:spcAft>
+                <a:spcPts val="600"/>
+              </a:spcAft>
+              <a:buSzPct val="100000"/>
+              <a:buChar char="•"/>
+            </a:pPr>
+            <a:r>
+              <a:rPr lang="en-US" sz="1200" dirty="0">
+                <a:solidFill>
+                  <a:schemeClr val="bg1"/>
+                </a:solidFill>
+              </a:rPr>
+              <a:t>페이지마다 다른 제목·설명</a:t>
+            </a:r>
+            <a:endParaRPr lang="en-US" sz="1200" dirty="0"/>
+          </a:p>
+          <a:p>
+            <a:pPr marL="342900" indent="-342900">
+              <a:spcAft>
+                <a:spcPts val="600"/>
+              </a:spcAft>
+              <a:buSzPct val="100000"/>
+              <a:buChar char="•"/>
+            </a:pPr>
+            <a:r>
+              <a:rPr lang="en-US" sz="1200" dirty="0">
+                <a:solidFill>
+                  <a:schemeClr val="bg1"/>
+                </a:solidFill>
+              </a:rPr>
+              <a:t>h1 · alt · 내부 링크</a:t>
+            </a:r>
+            <a:endParaRPr lang="en-US" sz="1200" dirty="0"/>
+          </a:p>
+          <a:p>
+            <a:pPr marL="342900" indent="-342900">
+              <a:spcAft>
+                <a:spcPts val="600"/>
+              </a:spcAft>
+              <a:buSzPct val="100000"/>
+              <a:buChar char="•"/>
+            </a:pPr>
+            <a:r>
+              <a:rPr lang="en-US" sz="1200" dirty="0">
+                <a:solidFill>
+                  <a:schemeClr val="bg1"/>
+                </a:solidFill>
+              </a:rPr>
+              <a:t>robots.txt · 사이트맵</a:t>
+            </a:r>
+            <a:endParaRPr lang="en-US" sz="1200" dirty="0"/>
+          </a:p>
+          <a:p>
+            <a:pPr marL="342900" indent="-342900">
+              <a:spcAft>
+                <a:spcPts val="600"/>
+              </a:spcAft>
+              <a:buSzPct val="100000"/>
+              <a:buChar char="•"/>
+            </a:pPr>
+            <a:r>
+              <a:rPr lang="en-US" sz="1200" dirty="0">
+                <a:solidFill>
+                  <a:schemeClr val="bg1"/>
+                </a:solidFill>
+              </a:rPr>
+              <a:t>구조화된 데이터 · 404</a:t>
+            </a:r>
+            <a:endParaRPr lang="en-US" sz="1200" dirty="0"/>
+          </a:p>
+        </p:txBody>
+      </p:sp>
+      <p:sp>
+        <p:nvSpPr>
+          <p:cNvPr id="9" name="card"/>
+          <p:cNvSpPr/>
+          <p:nvPr/>
+        </p:nvSpPr>
+        <p:spPr>
+          <a:xfrm>
+            <a:off x="4663440" y="1188720"/>
+            <a:ext cx="1920240" cy="2834640"/>
+          </a:xfrm>
+          <a:prstGeom prst="roundRect">
+            <a:avLst>
+              <a:gd name="adj" fmla="val 3810"/>
+            </a:avLst>
+          </a:prstGeom>
+          <a:solidFill>
+            <a:schemeClr val="bg2"/>
+          </a:solidFill>
+          <a:ln/>
+        </p:spPr>
+      </p:sp>
+      <p:sp>
+        <p:nvSpPr>
+          <p:cNvPr id="10" name="Text 8"/>
+          <p:cNvSpPr txBox="1"/>
+          <p:nvPr/>
+        </p:nvSpPr>
+        <p:spPr>
+          <a:xfrm>
+            <a:off x="4828032" y="1325880"/>
+            <a:ext cx="1645920" cy="411480"/>
+          </a:xfrm>
+          <a:prstGeom prst="rect">
+            <a:avLst/>
+          </a:prstGeom>
+          <a:noFill/>
+          <a:ln/>
+        </p:spPr>
+        <p:txBody>
+          <a:bodyPr wrap="square" lIns="0" tIns="0" rIns="0" bIns="0" rtlCol="0" anchor="t"/>
+          <a:lstStyle/>
+          <a:p>
+            <a:pPr indent="0" marL="0">
+              <a:buNone/>
+            </a:pPr>
+            <a:r>
+              <a:rPr lang="en-US" sz="1500" b="1" dirty="0">
+                <a:solidFill>
+                  <a:schemeClr val="accent2"/>
+                </a:solidFill>
+              </a:rPr>
+              <a:t>공유·측정</a:t>
+            </a:r>
+            <a:endParaRPr lang="en-US" sz="1500" dirty="0"/>
+          </a:p>
+        </p:txBody>
+      </p:sp>
+      <p:sp>
+        <p:nvSpPr>
+          <p:cNvPr id="11" name="Text 9"/>
+          <p:cNvSpPr txBox="1"/>
+          <p:nvPr/>
+        </p:nvSpPr>
+        <p:spPr>
+          <a:xfrm>
+            <a:off x="4828032" y="1783080"/>
+            <a:ext cx="1691640" cy="2103120"/>
+          </a:xfrm>
+          <a:prstGeom prst="rect">
+            <a:avLst/>
+          </a:prstGeom>
+          <a:noFill/>
+          <a:ln/>
+        </p:spPr>
+        <p:txBody>
+          <a:bodyPr wrap="square" lIns="0" tIns="0" rIns="0" bIns="0" rtlCol="0" anchor="t"/>
+          <a:lstStyle/>
+          <a:p>
+            <a:pPr marL="342900" indent="-342900">
+              <a:spcAft>
+                <a:spcPts val="600"/>
+              </a:spcAft>
+              <a:buSzPct val="100000"/>
+              <a:buChar char="•"/>
+            </a:pPr>
+            <a:r>
+              <a:rPr lang="en-US" sz="1200" dirty="0">
+                <a:solidFill>
+                  <a:schemeClr val="tx1"/>
+                </a:solidFill>
+              </a:rPr>
+              <a:t>OG 태그 썸네일</a:t>
+            </a:r>
+            <a:endParaRPr lang="en-US" sz="1200" dirty="0"/>
+          </a:p>
+          <a:p>
+            <a:pPr marL="342900" indent="-342900">
+              <a:spcAft>
+                <a:spcPts val="600"/>
+              </a:spcAft>
+              <a:buSzPct val="100000"/>
+              <a:buChar char="•"/>
+            </a:pPr>
+            <a:r>
+              <a:rPr lang="en-US" sz="1200" dirty="0">
+                <a:solidFill>
+                  <a:schemeClr val="tx1"/>
+                </a:solidFill>
+              </a:rPr>
+              <a:t>파비콘 · 공유 버튼</a:t>
+            </a:r>
+            <a:endParaRPr lang="en-US" sz="1200" dirty="0"/>
+          </a:p>
+          <a:p>
+            <a:pPr marL="342900" indent="-342900">
+              <a:spcAft>
+                <a:spcPts val="600"/>
+              </a:spcAft>
+              <a:buSzPct val="100000"/>
+              <a:buChar char="•"/>
+            </a:pPr>
+            <a:r>
+              <a:rPr lang="en-US" sz="1200" dirty="0">
+                <a:solidFill>
+                  <a:schemeClr val="tx1"/>
+                </a:solidFill>
+              </a:rPr>
+              <a:t>GA4 핵심 이벤트 · UTM</a:t>
+            </a:r>
+            <a:endParaRPr lang="en-US" sz="1200" dirty="0"/>
+          </a:p>
+          <a:p>
+            <a:pPr marL="342900" indent="-342900">
+              <a:spcAft>
+                <a:spcPts val="600"/>
+              </a:spcAft>
+              <a:buSzPct val="100000"/>
+              <a:buChar char="•"/>
+            </a:pPr>
+            <a:r>
+              <a:rPr lang="en-US" sz="1200" dirty="0">
+                <a:solidFill>
+                  <a:schemeClr val="tx1"/>
+                </a:solidFill>
+              </a:rPr>
+              <a:t>서치 콘솔 · 서치어드바이저</a:t>
+            </a:r>
+            <a:endParaRPr lang="en-US" sz="1200" dirty="0"/>
+          </a:p>
+        </p:txBody>
+      </p:sp>
+      <p:sp>
+        <p:nvSpPr>
+          <p:cNvPr id="12" name="card"/>
+          <p:cNvSpPr/>
+          <p:nvPr/>
+        </p:nvSpPr>
+        <p:spPr>
+          <a:xfrm>
+            <a:off x="6766560" y="1188720"/>
+            <a:ext cx="1920240" cy="2834640"/>
+          </a:xfrm>
+          <a:prstGeom prst="roundRect">
+            <a:avLst>
+              <a:gd name="adj" fmla="val 3810"/>
+            </a:avLst>
+          </a:prstGeom>
+          <a:solidFill>
+            <a:schemeClr val="bg2"/>
+          </a:solidFill>
+          <a:ln/>
+        </p:spPr>
+      </p:sp>
+      <p:sp>
+        <p:nvSpPr>
+          <p:cNvPr id="13" name="Text 11"/>
+          <p:cNvSpPr txBox="1"/>
+          <p:nvPr/>
+        </p:nvSpPr>
+        <p:spPr>
+          <a:xfrm>
+            <a:off x="6931152" y="1325880"/>
+            <a:ext cx="1645920" cy="411480"/>
+          </a:xfrm>
+          <a:prstGeom prst="rect">
+            <a:avLst/>
+          </a:prstGeom>
+          <a:noFill/>
+          <a:ln/>
+        </p:spPr>
+        <p:txBody>
+          <a:bodyPr wrap="square" lIns="0" tIns="0" rIns="0" bIns="0" rtlCol="0" anchor="t"/>
+          <a:lstStyle/>
+          <a:p>
+            <a:pPr indent="0" marL="0">
+              <a:buNone/>
+            </a:pPr>
+            <a:r>
+              <a:rPr lang="en-US" sz="1500" b="1" dirty="0">
+                <a:solidFill>
+                  <a:schemeClr val="accent2"/>
+                </a:solidFill>
+              </a:rPr>
+              <a:t>법·품질</a:t>
+            </a:r>
+            <a:endParaRPr lang="en-US" sz="1500" dirty="0"/>
+          </a:p>
+        </p:txBody>
+      </p:sp>
+      <p:sp>
+        <p:nvSpPr>
+          <p:cNvPr id="14" name="Text 12"/>
+          <p:cNvSpPr txBox="1"/>
+          <p:nvPr/>
+        </p:nvSpPr>
+        <p:spPr>
+          <a:xfrm>
+            <a:off x="6931152" y="1783080"/>
+            <a:ext cx="1691640" cy="2103120"/>
+          </a:xfrm>
+          <a:prstGeom prst="rect">
+            <a:avLst/>
+          </a:prstGeom>
+          <a:noFill/>
+          <a:ln/>
+        </p:spPr>
+        <p:txBody>
+          <a:bodyPr wrap="square" lIns="0" tIns="0" rIns="0" bIns="0" rtlCol="0" anchor="t"/>
+          <a:lstStyle/>
+          <a:p>
+            <a:pPr marL="342900" indent="-342900">
+              <a:spcAft>
+                <a:spcPts val="600"/>
+              </a:spcAft>
+              <a:buSzPct val="100000"/>
+              <a:buChar char="•"/>
+            </a:pPr>
+            <a:r>
+              <a:rPr lang="en-US" sz="1200" dirty="0">
+                <a:solidFill>
+                  <a:schemeClr val="tx1"/>
+                </a:solidFill>
+              </a:rPr>
+              <a:t>처리방침 · 사업자 푸터</a:t>
+            </a:r>
+            <a:endParaRPr lang="en-US" sz="1200" dirty="0"/>
+          </a:p>
+          <a:p>
+            <a:pPr marL="342900" indent="-342900">
+              <a:spcAft>
+                <a:spcPts val="600"/>
+              </a:spcAft>
+              <a:buSzPct val="100000"/>
+              <a:buChar char="•"/>
+            </a:pPr>
+            <a:r>
+              <a:rPr lang="en-US" sz="1200" dirty="0">
+                <a:solidFill>
+                  <a:schemeClr val="tx1"/>
+                </a:solidFill>
+              </a:rPr>
+              <a:t>동의 분리</a:t>
+            </a:r>
+            <a:endParaRPr lang="en-US" sz="1200" dirty="0"/>
+          </a:p>
+          <a:p>
+            <a:pPr marL="342900" indent="-342900">
+              <a:spcAft>
+                <a:spcPts val="600"/>
+              </a:spcAft>
+              <a:buSzPct val="100000"/>
+              <a:buChar char="•"/>
+            </a:pPr>
+            <a:r>
+              <a:rPr lang="en-US" sz="1200" dirty="0">
+                <a:solidFill>
+                  <a:schemeClr val="tx1"/>
+                </a:solidFill>
+              </a:rPr>
+              <a:t>코어 웹 바이탈 · 접근성</a:t>
+            </a:r>
+            <a:endParaRPr lang="en-US" sz="1200" dirty="0"/>
+          </a:p>
+          <a:p>
+            <a:pPr marL="342900" indent="-342900">
+              <a:spcAft>
+                <a:spcPts val="600"/>
+              </a:spcAft>
+              <a:buSzPct val="100000"/>
+              <a:buChar char="•"/>
+            </a:pPr>
+            <a:r>
+              <a:rPr lang="en-US" sz="1200" dirty="0">
+                <a:solidFill>
+                  <a:schemeClr val="tx1"/>
+                </a:solidFill>
+              </a:rPr>
+              <a:t>보안 · 스팸 방지 · 모니터링</a:t>
+            </a:r>
+            <a:endParaRPr lang="en-US" sz="1200" dirty="0"/>
+          </a:p>
+        </p:txBody>
+      </p:sp>
+      <p:sp>
+        <p:nvSpPr>
+          <p:cNvPr id="15" name="Text 13"/>
+          <p:cNvSpPr txBox="1"/>
+          <p:nvPr/>
+        </p:nvSpPr>
+        <p:spPr>
+          <a:xfrm>
+            <a:off x="457200" y="4160520"/>
+            <a:ext cx="8229600" cy="411480"/>
+          </a:xfrm>
+          <a:prstGeom prst="rect">
+            <a:avLst/>
+          </a:prstGeom>
+          <a:noFill/>
+          <a:ln/>
+        </p:spPr>
+        <p:txBody>
+          <a:bodyPr wrap="square" lIns="0" tIns="0" rIns="0" bIns="0" rtlCol="0" anchor="t"/>
+          <a:lstStyle/>
+          <a:p>
+            <a:pPr indent="0" marL="0">
+              <a:buNone/>
+            </a:pPr>
+            <a:r>
+              <a:rPr lang="en-US" sz="1300" b="1" dirty="0">
+                <a:solidFill>
+                  <a:schemeClr val="tx2"/>
+                </a:solidFill>
+              </a:rPr>
+              <a:t>38장 요청문을 복사해 보내고, PageSpeed · 리치 결과 테스트 · 서치 콘솔 · 카카오 디버거로 확인</a:t>
+            </a:r>
+            <a:endParaRPr lang="en-US" sz="1300" dirty="0"/>
+          </a:p>
+        </p:txBody>
+      </p:sp>
+      <p:sp>
+        <p:nvSpPr>
+          <p:cNvPr id="25" name="Slide Number Placeholder 0"/>
+          <p:cNvSpPr>
+            <a:spLocks noGrp="1"/>
+          </p:cNvSpPr>
+          <p:nvPr>
+            <p:ph type="sldNum" sz="quarter" idx="4294967295"/>
+          </p:nvPr>
+        </p:nvSpPr>
+        <p:spPr>
+          <a:xfrm>
+            <a:off x="8321040" y="4754880"/>
+            <a:ext cx="457200" cy="274320"/>
+          </a:xfrm>
+          <a:prstGeom prst="rect">
+            <a:avLst/>
+          </a:prstGeom>
+          <a:extLst>
+            <a:ext uri="{C572A759-6A51-4108-AA02-DFA0A04FC94B}">
+              <ma14:wrappingTextBoxFlag xmlns:ma14="http://schemas.microsoft.com/office/mac/drawingml/2011/main" val="0"/>
+            </a:ext>
+          </a:extLst>
+        </p:spPr>
+        <p:txBody>
+          <a:bodyPr/>
+          <a:lstStyle>
+            <a:lvl1pPr>
+              <a:defRPr sz="1000">
+                <a:solidFill>
+                  <a:schemeClr val="accent4"/>
+                </a:solidFill>
+              </a:defRPr>
+            </a:lvl1pPr>
+          </a:lstStyle>
+          <a:p>
+            <a:pPr algn="r"/>
+            <a:fld id="{F7021451-1387-4CA6-816F-3879F97B5CBC}" type="slidenum">
+              <a:rPr b="0" lang="en-US"/>
+              <a:t>58</a:t>
+            </a:fld>
+            <a:endParaRPr lang="en-US"/>
+          </a:p>
+        </p:txBody>
+      </p:sp>
+    </p:spTree>
+  </p:cSld>
+  <p:clrMapOvr>
+    <a:masterClrMapping/>
+  </p:clrMapOvr>
+</p:sld>
+</file>
+
+<file path=ppt/slides/slide59.xml><?xml version="1.0" encoding="utf-8"?>
+<p:sld xmlns:a="http://schemas.openxmlformats.org/drawingml/2006/main" xmlns:r="http://schemas.openxmlformats.org/officeDocument/2006/relationships" xmlns:p="http://schemas.openxmlformats.org/presentationml/2006/main">
+  <p:cSld name="Slide 59">
+    <p:spTree>
+      <p:nvGrpSpPr>
+        <p:cNvPr id="1" name=""/>
+        <p:cNvGrpSpPr/>
+        <p:nvPr/>
+      </p:nvGrpSpPr>
+      <p:grpSpPr>
+        <a:xfrm>
+          <a:off x="0" y="0"/>
+          <a:ext cx="0" cy="0"/>
+          <a:chOff x="0" y="0"/>
+          <a:chExt cx="0" cy="0"/>
+        </a:xfrm>
+      </p:grpSpPr>
+      <p:sp>
+        <p:nvSpPr>
+          <p:cNvPr id="2" name="Text 0"/>
+          <p:cNvSpPr/>
+          <p:nvPr>
+            <p:ph idx="100" type="title" hasCustomPrompt="1"/>
+          </p:nvPr>
+        </p:nvSpPr>
+        <p:spPr>
+          <a:xfrm>
+            <a:off x="457200" y="274320"/>
+            <a:ext cx="8229600" cy="685800"/>
+          </a:xfrm>
+          <a:prstGeom prst="rect">
+            <a:avLst/>
+          </a:prstGeom>
+          <a:noFill/>
+          <a:ln/>
+        </p:spPr>
+        <p:txBody>
+          <a:bodyPr wrap="square" lIns="0" tIns="0" rIns="0" bIns="0" rtlCol="0" anchor="ctr"/>
+          <a:lstStyle/>
+          <a:p>
+            <a:pPr indent="0" marL="0">
+              <a:buNone/>
+            </a:pPr>
+            <a:r>
+              <a:rPr lang="en-US" sz="2800" b="1" dirty="0">
+                <a:solidFill>
+                  <a:schemeClr val="tx2"/>
+                </a:solidFill>
+              </a:rPr>
+              <a:t>출시 직전 자주 하는 실수 4가지</a:t>
+            </a:r>
+            <a:endParaRPr lang="en-US" sz="2800" dirty="0"/>
+          </a:p>
+        </p:txBody>
+      </p:sp>
+      <p:sp>
+        <p:nvSpPr>
+          <p:cNvPr id="3" name="card"/>
+          <p:cNvSpPr/>
+          <p:nvPr/>
+        </p:nvSpPr>
+        <p:spPr>
+          <a:xfrm>
+            <a:off x="457200" y="1143000"/>
+            <a:ext cx="8229600" cy="713232"/>
+          </a:xfrm>
+          <a:prstGeom prst="roundRect">
+            <a:avLst>
+              <a:gd name="adj" fmla="val 10256"/>
+            </a:avLst>
+          </a:prstGeom>
+          <a:solidFill>
+            <a:schemeClr val="bg2"/>
+          </a:solidFill>
+          <a:ln/>
+        </p:spPr>
+      </p:sp>
+      <p:sp>
+        <p:nvSpPr>
+          <p:cNvPr id="4" name="badge1"/>
+          <p:cNvSpPr/>
+          <p:nvPr/>
+        </p:nvSpPr>
+        <p:spPr>
+          <a:xfrm>
+            <a:off x="594360" y="1307592"/>
+            <a:ext cx="384048" cy="384048"/>
+          </a:xfrm>
+          <a:prstGeom prst="ellipse">
+            <a:avLst/>
+          </a:prstGeom>
+          <a:solidFill>
+            <a:schemeClr val="accent5"/>
+          </a:solidFill>
+          <a:ln/>
+        </p:spPr>
+      </p:sp>
+      <p:sp>
+        <p:nvSpPr>
+          <p:cNvPr id="5" name="Text 3"/>
+          <p:cNvSpPr txBox="1"/>
+          <p:nvPr/>
+        </p:nvSpPr>
+        <p:spPr>
+          <a:xfrm>
+            <a:off x="594360" y="1307592"/>
+            <a:ext cx="384048" cy="384048"/>
+          </a:xfrm>
+          <a:prstGeom prst="rect">
+            <a:avLst/>
+          </a:prstGeom>
+          <a:noFill/>
+          <a:ln/>
+        </p:spPr>
+        <p:txBody>
+          <a:bodyPr wrap="square" lIns="0" tIns="0" rIns="0" bIns="0" rtlCol="0" anchor="ctr"/>
+          <a:lstStyle/>
+          <a:p>
+            <a:pPr algn="ctr" indent="0" marL="0">
+              <a:buNone/>
+            </a:pPr>
+            <a:r>
+              <a:rPr lang="en-US" sz="1400" b="1" dirty="0">
+                <a:solidFill>
+                  <a:schemeClr val="bg1"/>
+                </a:solidFill>
+              </a:rPr>
+              <a:t>1</a:t>
+            </a:r>
+            <a:endParaRPr lang="en-US" sz="1400" dirty="0"/>
+          </a:p>
+        </p:txBody>
+      </p:sp>
+      <p:sp>
+        <p:nvSpPr>
+          <p:cNvPr id="6" name="Text 4"/>
+          <p:cNvSpPr txBox="1"/>
+          <p:nvPr/>
+        </p:nvSpPr>
+        <p:spPr>
+          <a:xfrm>
+            <a:off x="1143000" y="1143000"/>
+            <a:ext cx="2560320" cy="713232"/>
+          </a:xfrm>
+          <a:prstGeom prst="rect">
+            <a:avLst/>
+          </a:prstGeom>
+          <a:noFill/>
+          <a:ln/>
+        </p:spPr>
+        <p:txBody>
+          <a:bodyPr wrap="square" lIns="0" tIns="0" rIns="0" bIns="0" rtlCol="0" anchor="ctr"/>
+          <a:lstStyle/>
+          <a:p>
+            <a:pPr indent="0" marL="0">
+              <a:buNone/>
+            </a:pPr>
+            <a:r>
+              <a:rPr lang="en-US" sz="1500" b="1" dirty="0">
+                <a:solidFill>
+                  <a:schemeClr val="tx1"/>
+                </a:solidFill>
+              </a:rPr>
+              <a:t>robots.txt로 숨기기</a:t>
+            </a:r>
+            <a:endParaRPr lang="en-US" sz="1500" dirty="0"/>
+          </a:p>
+        </p:txBody>
+      </p:sp>
+      <p:sp>
+        <p:nvSpPr>
+          <p:cNvPr id="7" name="Text 5"/>
+          <p:cNvSpPr txBox="1"/>
+          <p:nvPr/>
+        </p:nvSpPr>
+        <p:spPr>
+          <a:xfrm>
+            <a:off x="3749040" y="1143000"/>
+            <a:ext cx="4800600" cy="713232"/>
+          </a:xfrm>
+          <a:prstGeom prst="rect">
+            <a:avLst/>
+          </a:prstGeom>
+          <a:noFill/>
+          <a:ln/>
+        </p:spPr>
+        <p:txBody>
+          <a:bodyPr wrap="square" lIns="0" tIns="0" rIns="0" bIns="0" rtlCol="0" anchor="ctr"/>
+          <a:lstStyle/>
+          <a:p>
+            <a:pPr indent="0" marL="0">
+              <a:buNone/>
+            </a:pPr>
+            <a:r>
+              <a:rPr lang="en-US" sz="1200" dirty="0">
+                <a:solidFill>
+                  <a:schemeClr val="accent4"/>
+                </a:solidFill>
+              </a:rPr>
+              <a:t>숨기기 도구가 아님 → noindex 또는 비밀번호. 운영 사이트 전체 Disallow 실수 확인</a:t>
+            </a:r>
+            <a:endParaRPr lang="en-US" sz="1200" dirty="0"/>
+          </a:p>
+        </p:txBody>
+      </p:sp>
+      <p:sp>
+        <p:nvSpPr>
+          <p:cNvPr id="8" name="card"/>
+          <p:cNvSpPr/>
+          <p:nvPr/>
+        </p:nvSpPr>
+        <p:spPr>
+          <a:xfrm>
+            <a:off x="457200" y="1965960"/>
+            <a:ext cx="8229600" cy="713232"/>
+          </a:xfrm>
+          <a:prstGeom prst="roundRect">
+            <a:avLst>
+              <a:gd name="adj" fmla="val 10256"/>
+            </a:avLst>
+          </a:prstGeom>
+          <a:solidFill>
+            <a:schemeClr val="bg2"/>
+          </a:solidFill>
+          <a:ln/>
+        </p:spPr>
+      </p:sp>
+      <p:sp>
+        <p:nvSpPr>
+          <p:cNvPr id="9" name="badge2"/>
+          <p:cNvSpPr/>
+          <p:nvPr/>
+        </p:nvSpPr>
+        <p:spPr>
+          <a:xfrm>
+            <a:off x="594360" y="2130552"/>
+            <a:ext cx="384048" cy="384048"/>
+          </a:xfrm>
+          <a:prstGeom prst="ellipse">
+            <a:avLst/>
+          </a:prstGeom>
+          <a:solidFill>
+            <a:schemeClr val="accent5"/>
+          </a:solidFill>
+          <a:ln/>
+        </p:spPr>
+      </p:sp>
+      <p:sp>
+        <p:nvSpPr>
+          <p:cNvPr id="10" name="Text 8"/>
+          <p:cNvSpPr txBox="1"/>
+          <p:nvPr/>
+        </p:nvSpPr>
+        <p:spPr>
+          <a:xfrm>
+            <a:off x="594360" y="2130552"/>
+            <a:ext cx="384048" cy="384048"/>
+          </a:xfrm>
+          <a:prstGeom prst="rect">
+            <a:avLst/>
+          </a:prstGeom>
+          <a:noFill/>
+          <a:ln/>
+        </p:spPr>
+        <p:txBody>
+          <a:bodyPr wrap="square" lIns="0" tIns="0" rIns="0" bIns="0" rtlCol="0" anchor="ctr"/>
+          <a:lstStyle/>
+          <a:p>
+            <a:pPr algn="ctr" indent="0" marL="0">
+              <a:buNone/>
+            </a:pPr>
+            <a:r>
+              <a:rPr lang="en-US" sz="1400" b="1" dirty="0">
+                <a:solidFill>
+                  <a:schemeClr val="bg1"/>
+                </a:solidFill>
+              </a:rPr>
+              <a:t>2</a:t>
+            </a:r>
+            <a:endParaRPr lang="en-US" sz="1400" dirty="0"/>
+          </a:p>
+        </p:txBody>
+      </p:sp>
+      <p:sp>
+        <p:nvSpPr>
+          <p:cNvPr id="11" name="Text 9"/>
+          <p:cNvSpPr txBox="1"/>
+          <p:nvPr/>
+        </p:nvSpPr>
+        <p:spPr>
+          <a:xfrm>
+            <a:off x="1143000" y="1965960"/>
+            <a:ext cx="2560320" cy="713232"/>
+          </a:xfrm>
+          <a:prstGeom prst="rect">
+            <a:avLst/>
+          </a:prstGeom>
+          <a:noFill/>
+          <a:ln/>
+        </p:spPr>
+        <p:txBody>
+          <a:bodyPr wrap="square" lIns="0" tIns="0" rIns="0" bIns="0" rtlCol="0" anchor="ctr"/>
+          <a:lstStyle/>
+          <a:p>
+            <a:pPr indent="0" marL="0">
+              <a:buNone/>
+            </a:pPr>
+            <a:r>
+              <a:rPr lang="en-US" sz="1500" b="1" dirty="0">
+                <a:solidFill>
+                  <a:schemeClr val="tx1"/>
+                </a:solidFill>
+              </a:rPr>
+              <a:t>가짜 404</a:t>
+            </a:r>
+            <a:endParaRPr lang="en-US" sz="1500" dirty="0"/>
+          </a:p>
+        </p:txBody>
+      </p:sp>
+      <p:sp>
+        <p:nvSpPr>
+          <p:cNvPr id="12" name="Text 10"/>
+          <p:cNvSpPr txBox="1"/>
+          <p:nvPr/>
+        </p:nvSpPr>
+        <p:spPr>
+          <a:xfrm>
+            <a:off x="3749040" y="1965960"/>
+            <a:ext cx="4800600" cy="713232"/>
+          </a:xfrm>
+          <a:prstGeom prst="rect">
+            <a:avLst/>
+          </a:prstGeom>
+          <a:noFill/>
+          <a:ln/>
+        </p:spPr>
+        <p:txBody>
+          <a:bodyPr wrap="square" lIns="0" tIns="0" rIns="0" bIns="0" rtlCol="0" anchor="ctr"/>
+          <a:lstStyle/>
+          <a:p>
+            <a:pPr indent="0" marL="0">
+              <a:buNone/>
+            </a:pPr>
+            <a:r>
+              <a:rPr lang="en-US" sz="1200" dirty="0">
+                <a:solidFill>
+                  <a:schemeClr val="accent4"/>
+                </a:solidFill>
+              </a:rPr>
+              <a:t>화면만 404, 상태 코드는 200 (소프트 404) → 실제 404 코드로</a:t>
+            </a:r>
+            <a:endParaRPr lang="en-US" sz="1200" dirty="0"/>
+          </a:p>
+        </p:txBody>
+      </p:sp>
+      <p:sp>
+        <p:nvSpPr>
+          <p:cNvPr id="13" name="card"/>
+          <p:cNvSpPr/>
+          <p:nvPr/>
+        </p:nvSpPr>
+        <p:spPr>
+          <a:xfrm>
+            <a:off x="457200" y="2788920"/>
+            <a:ext cx="8229600" cy="713232"/>
+          </a:xfrm>
+          <a:prstGeom prst="roundRect">
+            <a:avLst>
+              <a:gd name="adj" fmla="val 10256"/>
+            </a:avLst>
+          </a:prstGeom>
+          <a:solidFill>
+            <a:schemeClr val="bg2"/>
+          </a:solidFill>
+          <a:ln/>
+        </p:spPr>
+      </p:sp>
+      <p:sp>
+        <p:nvSpPr>
+          <p:cNvPr id="14" name="badge3"/>
+          <p:cNvSpPr/>
+          <p:nvPr/>
+        </p:nvSpPr>
+        <p:spPr>
+          <a:xfrm>
+            <a:off x="594360" y="2953512"/>
+            <a:ext cx="384048" cy="384048"/>
+          </a:xfrm>
+          <a:prstGeom prst="ellipse">
+            <a:avLst/>
+          </a:prstGeom>
+          <a:solidFill>
+            <a:schemeClr val="accent5"/>
+          </a:solidFill>
+          <a:ln/>
+        </p:spPr>
+      </p:sp>
+      <p:sp>
+        <p:nvSpPr>
+          <p:cNvPr id="15" name="Text 13"/>
+          <p:cNvSpPr txBox="1"/>
+          <p:nvPr/>
+        </p:nvSpPr>
+        <p:spPr>
+          <a:xfrm>
+            <a:off x="594360" y="2953512"/>
+            <a:ext cx="384048" cy="384048"/>
+          </a:xfrm>
+          <a:prstGeom prst="rect">
+            <a:avLst/>
+          </a:prstGeom>
+          <a:noFill/>
+          <a:ln/>
+        </p:spPr>
+        <p:txBody>
+          <a:bodyPr wrap="square" lIns="0" tIns="0" rIns="0" bIns="0" rtlCol="0" anchor="ctr"/>
+          <a:lstStyle/>
+          <a:p>
+            <a:pPr algn="ctr" indent="0" marL="0">
+              <a:buNone/>
+            </a:pPr>
+            <a:r>
+              <a:rPr lang="en-US" sz="1400" b="1" dirty="0">
+                <a:solidFill>
+                  <a:schemeClr val="bg1"/>
+                </a:solidFill>
+              </a:rPr>
+              <a:t>3</a:t>
+            </a:r>
+            <a:endParaRPr lang="en-US" sz="1400" dirty="0"/>
+          </a:p>
+        </p:txBody>
+      </p:sp>
+      <p:sp>
+        <p:nvSpPr>
+          <p:cNvPr id="16" name="Text 14"/>
+          <p:cNvSpPr txBox="1"/>
+          <p:nvPr/>
+        </p:nvSpPr>
+        <p:spPr>
+          <a:xfrm>
+            <a:off x="1143000" y="2788920"/>
+            <a:ext cx="2560320" cy="713232"/>
+          </a:xfrm>
+          <a:prstGeom prst="rect">
+            <a:avLst/>
+          </a:prstGeom>
+          <a:noFill/>
+          <a:ln/>
+        </p:spPr>
+        <p:txBody>
+          <a:bodyPr wrap="square" lIns="0" tIns="0" rIns="0" bIns="0" rtlCol="0" anchor="ctr"/>
+          <a:lstStyle/>
+          <a:p>
+            <a:pPr indent="0" marL="0">
+              <a:buNone/>
+            </a:pPr>
+            <a:r>
+              <a:rPr lang="en-US" sz="1500" b="1" dirty="0">
+                <a:solidFill>
+                  <a:schemeClr val="tx1"/>
+                </a:solidFill>
+              </a:rPr>
+              <a:t>카톡 썸네일이 안 바뀜</a:t>
+            </a:r>
+            <a:endParaRPr lang="en-US" sz="1500" dirty="0"/>
+          </a:p>
+        </p:txBody>
+      </p:sp>
+      <p:sp>
+        <p:nvSpPr>
+          <p:cNvPr id="17" name="Text 15"/>
+          <p:cNvSpPr txBox="1"/>
+          <p:nvPr/>
+        </p:nvSpPr>
+        <p:spPr>
+          <a:xfrm>
+            <a:off x="3749040" y="2788920"/>
+            <a:ext cx="4800600" cy="713232"/>
+          </a:xfrm>
+          <a:prstGeom prst="rect">
+            <a:avLst/>
+          </a:prstGeom>
+          <a:noFill/>
+          <a:ln/>
+        </p:spPr>
+        <p:txBody>
+          <a:bodyPr wrap="square" lIns="0" tIns="0" rIns="0" bIns="0" rtlCol="0" anchor="ctr"/>
+          <a:lstStyle/>
+          <a:p>
+            <a:pPr indent="0" marL="0">
+              <a:buNone/>
+            </a:pPr>
+            <a:r>
+              <a:rPr lang="en-US" sz="1200" dirty="0">
+                <a:solidFill>
+                  <a:schemeClr val="accent4"/>
+                </a:solidFill>
+              </a:rPr>
+              <a:t>카카오 캐시 → 공유 디버거 초기화, 이미지 주소에 ?v=2</a:t>
+            </a:r>
+            <a:endParaRPr lang="en-US" sz="1200" dirty="0"/>
+          </a:p>
+        </p:txBody>
+      </p:sp>
+      <p:sp>
+        <p:nvSpPr>
+          <p:cNvPr id="18" name="card"/>
+          <p:cNvSpPr/>
+          <p:nvPr/>
+        </p:nvSpPr>
+        <p:spPr>
+          <a:xfrm>
+            <a:off x="457200" y="3611880"/>
+            <a:ext cx="8229600" cy="713232"/>
+          </a:xfrm>
+          <a:prstGeom prst="roundRect">
+            <a:avLst>
+              <a:gd name="adj" fmla="val 10256"/>
+            </a:avLst>
+          </a:prstGeom>
+          <a:solidFill>
+            <a:schemeClr val="bg2"/>
+          </a:solidFill>
+          <a:ln/>
+        </p:spPr>
+      </p:sp>
+      <p:sp>
+        <p:nvSpPr>
+          <p:cNvPr id="19" name="badge4"/>
+          <p:cNvSpPr/>
+          <p:nvPr/>
+        </p:nvSpPr>
+        <p:spPr>
+          <a:xfrm>
+            <a:off x="594360" y="3776472"/>
+            <a:ext cx="384048" cy="384048"/>
+          </a:xfrm>
+          <a:prstGeom prst="ellipse">
+            <a:avLst/>
+          </a:prstGeom>
+          <a:solidFill>
+            <a:schemeClr val="accent5"/>
+          </a:solidFill>
+          <a:ln/>
+        </p:spPr>
+      </p:sp>
+      <p:sp>
+        <p:nvSpPr>
+          <p:cNvPr id="20" name="Text 18"/>
+          <p:cNvSpPr txBox="1"/>
+          <p:nvPr/>
+        </p:nvSpPr>
+        <p:spPr>
+          <a:xfrm>
+            <a:off x="594360" y="3776472"/>
+            <a:ext cx="384048" cy="384048"/>
+          </a:xfrm>
+          <a:prstGeom prst="rect">
+            <a:avLst/>
+          </a:prstGeom>
+          <a:noFill/>
+          <a:ln/>
+        </p:spPr>
+        <p:txBody>
+          <a:bodyPr wrap="square" lIns="0" tIns="0" rIns="0" bIns="0" rtlCol="0" anchor="ctr"/>
+          <a:lstStyle/>
+          <a:p>
+            <a:pPr algn="ctr" indent="0" marL="0">
+              <a:buNone/>
+            </a:pPr>
+            <a:r>
+              <a:rPr lang="en-US" sz="1400" b="1" dirty="0">
+                <a:solidFill>
+                  <a:schemeClr val="bg1"/>
+                </a:solidFill>
+              </a:rPr>
+              <a:t>4</a:t>
+            </a:r>
+            <a:endParaRPr lang="en-US" sz="1400" dirty="0"/>
+          </a:p>
+        </p:txBody>
+      </p:sp>
+      <p:sp>
+        <p:nvSpPr>
+          <p:cNvPr id="21" name="Text 19"/>
+          <p:cNvSpPr txBox="1"/>
+          <p:nvPr/>
+        </p:nvSpPr>
+        <p:spPr>
+          <a:xfrm>
+            <a:off x="1143000" y="3611880"/>
+            <a:ext cx="2560320" cy="713232"/>
+          </a:xfrm>
+          <a:prstGeom prst="rect">
+            <a:avLst/>
+          </a:prstGeom>
+          <a:noFill/>
+          <a:ln/>
+        </p:spPr>
+        <p:txBody>
+          <a:bodyPr wrap="square" lIns="0" tIns="0" rIns="0" bIns="0" rtlCol="0" anchor="ctr"/>
+          <a:lstStyle/>
+          <a:p>
+            <a:pPr indent="0" marL="0">
+              <a:buNone/>
+            </a:pPr>
+            <a:r>
+              <a:rPr lang="en-US" sz="1500" b="1" dirty="0">
+                <a:solidFill>
+                  <a:schemeClr val="tx1"/>
+                </a:solidFill>
+              </a:rPr>
+              <a:t>화면과 다른 구조화된 데이터</a:t>
+            </a:r>
+            <a:endParaRPr lang="en-US" sz="1500" dirty="0"/>
+          </a:p>
+        </p:txBody>
+      </p:sp>
+      <p:sp>
+        <p:nvSpPr>
+          <p:cNvPr id="22" name="Text 20"/>
+          <p:cNvSpPr txBox="1"/>
+          <p:nvPr/>
+        </p:nvSpPr>
+        <p:spPr>
+          <a:xfrm>
+            <a:off x="3749040" y="3611880"/>
+            <a:ext cx="4800600" cy="713232"/>
+          </a:xfrm>
+          <a:prstGeom prst="rect">
+            <a:avLst/>
+          </a:prstGeom>
+          <a:noFill/>
+          <a:ln/>
+        </p:spPr>
+        <p:txBody>
+          <a:bodyPr wrap="square" lIns="0" tIns="0" rIns="0" bIns="0" rtlCol="0" anchor="ctr"/>
+          <a:lstStyle/>
+          <a:p>
+            <a:pPr indent="0" marL="0">
+              <a:buNone/>
+            </a:pPr>
+            <a:r>
+              <a:rPr lang="en-US" sz="1200" dirty="0">
+                <a:solidFill>
+                  <a:schemeClr val="accent4"/>
+                </a:solidFill>
+              </a:rPr>
+              <a:t>가짜 별점·없는 정보 표시는 스팸 정책 위반</a:t>
+            </a:r>
+            <a:endParaRPr lang="en-US" sz="1200" dirty="0"/>
+          </a:p>
+        </p:txBody>
+      </p:sp>
+      <p:sp>
+        <p:nvSpPr>
+          <p:cNvPr id="23" name="Text 21"/>
+          <p:cNvSpPr txBox="1"/>
+          <p:nvPr/>
+        </p:nvSpPr>
+        <p:spPr>
+          <a:xfrm>
+            <a:off x="457200" y="4645152"/>
+            <a:ext cx="7680960" cy="274320"/>
+          </a:xfrm>
+          <a:prstGeom prst="rect">
+            <a:avLst/>
+          </a:prstGeom>
+          <a:noFill/>
+          <a:ln/>
+        </p:spPr>
+        <p:txBody>
+          <a:bodyPr wrap="square" lIns="0" tIns="0" rIns="0" bIns="0" rtlCol="0" anchor="t"/>
+          <a:lstStyle/>
+          <a:p>
+            <a:pPr indent="0" marL="0">
+              <a:buNone/>
+            </a:pPr>
+            <a:r>
+              <a:rPr lang="en-US" sz="1000" dirty="0">
+                <a:solidFill>
+                  <a:schemeClr val="accent4"/>
+                </a:solidFill>
+              </a:rPr>
+              <a:t>코어 웹 바이탈 좋음 기준: LCP ≤ 2.5초 · INP ≤ 200ms · CLS ≤ 0.1</a:t>
+            </a:r>
+            <a:endParaRPr lang="en-US" sz="1000" dirty="0"/>
+          </a:p>
+        </p:txBody>
+      </p:sp>
+      <p:sp>
+        <p:nvSpPr>
+          <p:cNvPr id="25" name="Slide Number Placeholder 0"/>
+          <p:cNvSpPr>
+            <a:spLocks noGrp="1"/>
+          </p:cNvSpPr>
+          <p:nvPr>
+            <p:ph type="sldNum" sz="quarter" idx="4294967295"/>
+          </p:nvPr>
+        </p:nvSpPr>
+        <p:spPr>
+          <a:xfrm>
+            <a:off x="8321040" y="4754880"/>
+            <a:ext cx="457200" cy="274320"/>
+          </a:xfrm>
+          <a:prstGeom prst="rect">
+            <a:avLst/>
+          </a:prstGeom>
+          <a:extLst>
+            <a:ext uri="{C572A759-6A51-4108-AA02-DFA0A04FC94B}">
+              <ma14:wrappingTextBoxFlag xmlns:ma14="http://schemas.microsoft.com/office/mac/drawingml/2011/main" val="0"/>
+            </a:ext>
+          </a:extLst>
+        </p:spPr>
+        <p:txBody>
+          <a:bodyPr/>
+          <a:lstStyle>
+            <a:lvl1pPr>
+              <a:defRPr sz="1000">
+                <a:solidFill>
+                  <a:schemeClr val="accent4"/>
+                </a:solidFill>
+              </a:defRPr>
+            </a:lvl1pPr>
+          </a:lstStyle>
+          <a:p>
+            <a:pPr algn="r"/>
+            <a:fld id="{F7021451-1387-4CA6-816F-3879F97B5CBC}" type="slidenum">
+              <a:rPr b="0" lang="en-US"/>
+              <a:t>59</a:t>
+            </a:fld>
+            <a:endParaRPr lang="en-US"/>
           </a:p>
         </p:txBody>
       </p:sp>
@@ -43866,6 +47860,121 @@
               <a:t>6</a:t>
             </a:fld>
             <a:endParaRPr lang="en-US"/>
+          </a:p>
+        </p:txBody>
+      </p:sp>
+    </p:spTree>
+  </p:cSld>
+  <p:clrMapOvr>
+    <a:masterClrMapping/>
+  </p:clrMapOvr>
+</p:sld>
+</file>
+
+<file path=ppt/slides/slide60.xml><?xml version="1.0" encoding="utf-8"?>
+<p:sld xmlns:a="http://schemas.openxmlformats.org/drawingml/2006/main" xmlns:r="http://schemas.openxmlformats.org/officeDocument/2006/relationships" xmlns:p="http://schemas.openxmlformats.org/presentationml/2006/main">
+  <p:cSld name="Slide 60">
+    <p:spTree>
+      <p:nvGrpSpPr>
+        <p:cNvPr id="1" name=""/>
+        <p:cNvGrpSpPr/>
+        <p:nvPr/>
+      </p:nvGrpSpPr>
+      <p:grpSpPr>
+        <a:xfrm>
+          <a:off x="0" y="0"/>
+          <a:ext cx="0" cy="0"/>
+          <a:chOff x="0" y="0"/>
+          <a:chExt cx="0" cy="0"/>
+        </a:xfrm>
+      </p:grpSpPr>
+      <p:sp>
+        <p:nvSpPr>
+          <p:cNvPr id="2" name="Text 0"/>
+          <p:cNvSpPr/>
+          <p:nvPr>
+            <p:ph idx="100" type="title" hasCustomPrompt="1"/>
+          </p:nvPr>
+        </p:nvSpPr>
+        <p:spPr>
+          <a:xfrm>
+            <a:off x="548640" y="1371600"/>
+            <a:ext cx="8046720" cy="1280160"/>
+          </a:xfrm>
+          <a:prstGeom prst="rect">
+            <a:avLst/>
+          </a:prstGeom>
+          <a:noFill/>
+          <a:ln/>
+        </p:spPr>
+        <p:txBody>
+          <a:bodyPr wrap="square" lIns="0" tIns="0" rIns="0" bIns="0" rtlCol="0" anchor="b"/>
+          <a:lstStyle/>
+          <a:p>
+            <a:pPr algn="l" indent="0" marL="0">
+              <a:buNone/>
+            </a:pPr>
+            <a:r>
+              <a:rPr lang="en-US" sz="4000" b="1" dirty="0">
+                <a:solidFill>
+                  <a:schemeClr val="bg1"/>
+                </a:solidFill>
+              </a:rPr>
+              <a:t>안전하게, 자주 반복하기</a:t>
+            </a:r>
+            <a:endParaRPr lang="en-US" sz="4000" dirty="0"/>
+          </a:p>
+        </p:txBody>
+      </p:sp>
+      <p:sp>
+        <p:nvSpPr>
+          <p:cNvPr id="3" name="Text 0"/>
+          <p:cNvSpPr/>
+          <p:nvPr>
+            <p:ph idx="101" type="body" hasCustomPrompt="1"/>
+          </p:nvPr>
+        </p:nvSpPr>
+        <p:spPr>
+          <a:xfrm>
+            <a:off x="548640" y="2788920"/>
+            <a:ext cx="8046720" cy="1097280"/>
+          </a:xfrm>
+          <a:prstGeom prst="rect">
+            <a:avLst/>
+          </a:prstGeom>
+          <a:noFill/>
+          <a:ln/>
+        </p:spPr>
+        <p:txBody>
+          <a:bodyPr wrap="square" lIns="0" tIns="0" rIns="0" bIns="0" rtlCol="0" anchor="t"/>
+          <a:lstStyle/>
+          <a:p>
+            <a:pPr algn="l" indent="0" marL="0">
+              <a:buNone/>
+            </a:pPr>
+            <a:r>
+              <a:rPr lang="en-US" sz="1800" dirty="0">
+                <a:solidFill>
+                  <a:schemeClr val="bg2"/>
+                </a:solidFill>
+              </a:rPr>
+              <a:t>기획 → 백업 → 연습용 사이트에서 수정 → 확인 → 배포 → 감시 → 숫자 보기 → 다시 기획</a:t>
+            </a:r>
+            <a:endParaRPr lang="en-US" sz="1800" dirty="0"/>
+          </a:p>
+          <a:p>
+            <a:pPr algn="l" indent="0" marL="0">
+              <a:buNone/>
+            </a:pPr>
+            <a:r>
+              <a:rPr lang="en-US" sz="1800" dirty="0">
+                <a:solidFill>
+                  <a:schemeClr val="bg2"/>
+                </a:solidFill>
+              </a:rPr>
+              <a:t>다음 할 일: docs/13-practice-scenario.md 를 읽고 15장 퀴즈 풀기</a:t>
+            </a:r>
+            <a:endParaRPr lang="en-US" sz="1800" dirty="0"/>
           </a:p>
         </p:txBody>
       </p:sp>

</xml_diff>

<commit_message>
Add chapters on payments, multiplayer game servers and abuse prevention
Chapter 39 covers payment integration and settlement: PG contracts,
server-side amount verification and confirmation, webhooks,
exception handling, daily reconciliation, seller payouts, the
post-TMON settlement rules and basic tax handling. Chapter 40
explains how real-time multiplayer games like LoL and PUBG are
built: backend services, dedicated authoritative servers, tick
rate, client prediction, reconciliation, interpolation, lag
compensation, UDP, matchmaking and server orchestration.
Chapter 41 covers abuse and cheat prevention for services and
games. README, cross-links, glossary, quiz, sources and the deck
(now 66 slides) are updated.

Co-Authored-By: Claude Opus 5.5 <noreply@anthropic.com>
Claude-Session: https://claude.ai/code/session_01Tuz8P5EzhzAFozhesRbd5A
</commit_message>
<xml_diff>
--- a/slides/internet-business-101.pptx
+++ b/slides/internet-business-101.pptx
@@ -65,9 +65,15 @@
     <p:sldId id="313" r:id="rId59"/>
     <p:sldId id="314" r:id="rId60"/>
     <p:sldId id="315" r:id="rId61"/>
+    <p:sldId id="316" r:id="rId62"/>
+    <p:sldId id="317" r:id="rId63"/>
+    <p:sldId id="318" r:id="rId64"/>
+    <p:sldId id="319" r:id="rId65"/>
+    <p:sldId id="320" r:id="rId66"/>
+    <p:sldId id="321" r:id="rId67"/>
   </p:sldIdLst>
   <p:notesMasterIdLst>
-    <p:notesMasterId r:id="rId62"/>
+    <p:notesMasterId r:id="rId68"/>
   </p:notesMasterIdLst>
   <p:sldSz cx="9144000" cy="5143500"/>
   <p:notesSz cx="5143500" cy="9144000"/>
@@ -166,13 +172,13 @@
   <p:extLst>
     <p:ext uri="{521415D9-36F7-43E2-AB2F-B90AF26B5E84}">
       <p14:sectionLst xmlns:p14="http://schemas.microsoft.com/office/powerpoint/2010/main">
-        <p14:section name="시작" id="{d62f1d2d-b020-daf7-902a-42ab7d009a70}">
+        <p14:section name="시작" id="{663d94e9-4a95-2e85-edec-b3671973b1a0}">
           <p14:sldIdLst>
             <p14:sldId id="256"/>
             <p14:sldId id="257"/>
           </p14:sldIdLst>
         </p14:section>
-        <p14:section name="큰 그림" id="{ca511d00-fdce-5534-cf04-053994f88586}">
+        <p14:section name="큰 그림" id="{0b072d4d-56cf-87ea-f403-bf4c236c7128}">
           <p14:sldIdLst>
             <p14:sldId id="258"/>
             <p14:sldId id="259"/>
@@ -181,13 +187,13 @@
             <p14:sldId id="262"/>
           </p14:sldIdLst>
         </p14:section>
-        <p14:section name="만들기" id="{c0ab6f67-c53a-a550-5b28-6d19566e9f89}">
+        <p14:section name="만들기" id="{e6c96a71-0871-48e5-512f-396aad435835}">
           <p14:sldIdLst>
             <p14:sldId id="263"/>
             <p14:sldId id="264"/>
           </p14:sldIdLst>
         </p14:section>
-        <p14:section name="운영하기" id="{72b97fc9-fe85-a14e-0637-9e0d4b4916c0}">
+        <p14:section name="운영하기" id="{953460ff-844e-9abc-739e-22819b577e6c}">
           <p14:sldIdLst>
             <p14:sldId id="265"/>
             <p14:sldId id="266"/>
@@ -201,18 +207,18 @@
             <p14:sldId id="274"/>
           </p14:sldIdLst>
         </p14:section>
-        <p14:section name="키우기" id="{2b160383-9948-a0be-4885-9726f619c0d7}">
+        <p14:section name="키우기" id="{9b91fadc-bde1-b8fc-79bf-505f14c232ea}">
           <p14:sldIdLst>
             <p14:sldId id="275"/>
             <p14:sldId id="276"/>
           </p14:sldIdLst>
         </p14:section>
-        <p14:section name="실전" id="{37311cba-b8de-7d1f-7a39-b28535c5c41c}">
+        <p14:section name="실전" id="{165d80f5-ec1e-2806-c201-d19ad1e3ed62}">
           <p14:sldIdLst>
             <p14:sldId id="277"/>
           </p14:sldIdLst>
         </p14:section>
-        <p14:section name="여러 가지 사이트 사업" id="{97e83ed0-de60-2b70-ddde-cbf260b9f8bc}">
+        <p14:section name="여러 가지 사이트 사업" id="{51993a81-8948-d3a8-9dcf-3856a9f03a0e}">
           <p14:sldIdLst>
             <p14:sldId id="278"/>
             <p14:sldId id="279"/>
@@ -223,7 +229,7 @@
             <p14:sldId id="284"/>
           </p14:sldIdLst>
         </p14:section>
-        <p14:section name="더 넓은 분류" id="{84e699dd-31c9-eb63-e4af-b92f90a8f477}">
+        <p14:section name="더 넓은 분류" id="{86a4f48e-e476-9a25-4735-a198b168010a}">
           <p14:sldIdLst>
             <p14:sldId id="285"/>
             <p14:sldId id="286"/>
@@ -234,7 +240,7 @@
             <p14:sldId id="291"/>
           </p14:sldIdLst>
         </p14:section>
-        <p14:section name="문의·광고 받기" id="{1eeea82e-b56a-1fc9-290e-1b703f55b42d}">
+        <p14:section name="문의·광고 받기" id="{a7530f15-cf24-a070-51b1-f9130aa415ff}">
           <p14:sldIdLst>
             <p14:sldId id="292"/>
             <p14:sldId id="293"/>
@@ -243,7 +249,7 @@
             <p14:sldId id="296"/>
           </p14:sldIdLst>
         </p14:section>
-        <p14:section name="마케팅 실전" id="{8b979e47-3868-3c2e-70e5-dff5178a69ac}">
+        <p14:section name="마케팅 실전" id="{6dcba8fd-61b7-497d-573a-7663acc80897}">
           <p14:sldIdLst>
             <p14:sldId id="297"/>
             <p14:sldId id="298"/>
@@ -254,7 +260,7 @@
             <p14:sldId id="303"/>
           </p14:sldIdLst>
         </p14:section>
-        <p14:section name="도메인" id="{c2d031c8-7983-0038-9f5b-d35bc5616fbe}">
+        <p14:section name="도메인" id="{b29d9cc2-bdb5-968b-8b58-4e572547416b}">
           <p14:sldIdLst>
             <p14:sldId id="304"/>
             <p14:sldId id="305"/>
@@ -264,14 +270,24 @@
             <p14:sldId id="309"/>
           </p14:sldIdLst>
         </p14:section>
-        <p14:section name="출시 준비" id="{b9777a5d-dec2-0151-15f1-5b57b927ed4e}">
+        <p14:section name="출시 준비" id="{7b81c9d1-99cf-3c73-5bbe-ce5c25c03add}">
           <p14:sldIdLst>
             <p14:sldId id="310"/>
             <p14:sldId id="311"/>
             <p14:sldId id="312"/>
             <p14:sldId id="313"/>
             <p14:sldId id="314"/>
+          </p14:sldIdLst>
+        </p14:section>
+        <p14:section name="결제·게임 서버·어뷰징" id="{d2754472-b531-cdb4-fa12-7c1176adf165}">
+          <p14:sldIdLst>
             <p14:sldId id="315"/>
+            <p14:sldId id="316"/>
+            <p14:sldId id="317"/>
+            <p14:sldId id="318"/>
+            <p14:sldId id="319"/>
+            <p14:sldId id="320"/>
+            <p14:sldId id="321"/>
           </p14:sldIdLst>
         </p14:section>
       </p14:sectionLst>
@@ -6574,6 +6590,534 @@
             <a:fld id="{F7021451-1387-4CA6-816F-3879F97B5CBC}" type="slidenum">
               <a:rPr lang="en-US"/>
               <a:t>60</a:t>
+            </a:fld>
+            <a:endParaRPr lang="en-US"/>
+          </a:p>
+        </p:txBody>
+      </p:sp>
+    </p:spTree>
+    <p:extLst>
+      <p:ext uri="{BB962C8B-B14F-4D97-AF65-F5344CB8AC3E}">
+        <p14:creationId xmlns:p14="http://schemas.microsoft.com/office/powerpoint/2010/main" val="1024086991"/>
+      </p:ext>
+    </p:extLst>
+  </p:cSld>
+  <p:clrMapOvr>
+    <a:masterClrMapping/>
+  </p:clrMapOvr>
+</p:notes>
+</file>
+
+<file path=ppt/notesSlides/notesSlide61.xml><?xml version="1.0" encoding="utf-8"?>
+<p:notes xmlns:a="http://schemas.openxmlformats.org/drawingml/2006/main" xmlns:r="http://schemas.openxmlformats.org/officeDocument/2006/relationships" xmlns:p="http://schemas.openxmlformats.org/presentationml/2006/main">
+  <p:cSld>
+    <p:spTree>
+      <p:nvGrpSpPr>
+        <p:cNvPr id="1" name=""/>
+        <p:cNvGrpSpPr/>
+        <p:nvPr/>
+      </p:nvGrpSpPr>
+      <p:grpSpPr>
+        <a:xfrm>
+          <a:off x="0" y="0"/>
+          <a:ext cx="0" cy="0"/>
+          <a:chOff x="0" y="0"/>
+          <a:chExt cx="0" cy="0"/>
+        </a:xfrm>
+      </p:grpSpPr>
+      <p:sp>
+        <p:nvSpPr>
+          <p:cNvPr id="2" name="Slide Image Placeholder 1"/>
+          <p:cNvSpPr>
+            <a:spLocks noGrp="1" noRot="1" noChangeAspect="1"/>
+          </p:cNvSpPr>
+          <p:nvPr>
+            <p:ph type="sldImg"/>
+          </p:nvPr>
+        </p:nvSpPr>
+        <p:spPr/>
+      </p:sp>
+      <p:sp>
+        <p:nvSpPr>
+          <p:cNvPr id="3" name="Notes Placeholder 2"/>
+          <p:cNvSpPr>
+            <a:spLocks noGrp="1"/>
+          </p:cNvSpPr>
+          <p:nvPr>
+            <p:ph type="body" idx="1"/>
+          </p:nvPr>
+        </p:nvSpPr>
+        <p:spPr/>
+        <p:txBody>
+          <a:bodyPr/>
+          <a:lstStyle/>
+          <a:p>
+            <a:r>
+              <a:rPr lang="en-US" dirty="0"/>
+              <a:t/>
+            </a:r>
+            <a:endParaRPr lang="en-US" dirty="0"/>
+          </a:p>
+        </p:txBody>
+      </p:sp>
+      <p:sp>
+        <p:nvSpPr>
+          <p:cNvPr id="4" name="Slide Number Placeholder 3"/>
+          <p:cNvSpPr>
+            <a:spLocks noGrp="1"/>
+          </p:cNvSpPr>
+          <p:nvPr>
+            <p:ph type="sldNum" sz="quarter" idx="10"/>
+          </p:nvPr>
+        </p:nvSpPr>
+        <p:spPr/>
+        <p:txBody>
+          <a:bodyPr/>
+          <a:lstStyle/>
+          <a:p>
+            <a:fld id="{F7021451-1387-4CA6-816F-3879F97B5CBC}" type="slidenum">
+              <a:rPr lang="en-US"/>
+              <a:t>61</a:t>
+            </a:fld>
+            <a:endParaRPr lang="en-US"/>
+          </a:p>
+        </p:txBody>
+      </p:sp>
+    </p:spTree>
+    <p:extLst>
+      <p:ext uri="{BB962C8B-B14F-4D97-AF65-F5344CB8AC3E}">
+        <p14:creationId xmlns:p14="http://schemas.microsoft.com/office/powerpoint/2010/main" val="1024086991"/>
+      </p:ext>
+    </p:extLst>
+  </p:cSld>
+  <p:clrMapOvr>
+    <a:masterClrMapping/>
+  </p:clrMapOvr>
+</p:notes>
+</file>
+
+<file path=ppt/notesSlides/notesSlide62.xml><?xml version="1.0" encoding="utf-8"?>
+<p:notes xmlns:a="http://schemas.openxmlformats.org/drawingml/2006/main" xmlns:r="http://schemas.openxmlformats.org/officeDocument/2006/relationships" xmlns:p="http://schemas.openxmlformats.org/presentationml/2006/main">
+  <p:cSld>
+    <p:spTree>
+      <p:nvGrpSpPr>
+        <p:cNvPr id="1" name=""/>
+        <p:cNvGrpSpPr/>
+        <p:nvPr/>
+      </p:nvGrpSpPr>
+      <p:grpSpPr>
+        <a:xfrm>
+          <a:off x="0" y="0"/>
+          <a:ext cx="0" cy="0"/>
+          <a:chOff x="0" y="0"/>
+          <a:chExt cx="0" cy="0"/>
+        </a:xfrm>
+      </p:grpSpPr>
+      <p:sp>
+        <p:nvSpPr>
+          <p:cNvPr id="2" name="Slide Image Placeholder 1"/>
+          <p:cNvSpPr>
+            <a:spLocks noGrp="1" noRot="1" noChangeAspect="1"/>
+          </p:cNvSpPr>
+          <p:nvPr>
+            <p:ph type="sldImg"/>
+          </p:nvPr>
+        </p:nvSpPr>
+        <p:spPr/>
+      </p:sp>
+      <p:sp>
+        <p:nvSpPr>
+          <p:cNvPr id="3" name="Notes Placeholder 2"/>
+          <p:cNvSpPr>
+            <a:spLocks noGrp="1"/>
+          </p:cNvSpPr>
+          <p:nvPr>
+            <p:ph type="body" idx="1"/>
+          </p:nvPr>
+        </p:nvSpPr>
+        <p:spPr/>
+        <p:txBody>
+          <a:bodyPr/>
+          <a:lstStyle/>
+          <a:p>
+            <a:r>
+              <a:rPr lang="en-US" dirty="0"/>
+              <a:t/>
+            </a:r>
+            <a:endParaRPr lang="en-US" dirty="0"/>
+          </a:p>
+        </p:txBody>
+      </p:sp>
+      <p:sp>
+        <p:nvSpPr>
+          <p:cNvPr id="4" name="Slide Number Placeholder 3"/>
+          <p:cNvSpPr>
+            <a:spLocks noGrp="1"/>
+          </p:cNvSpPr>
+          <p:nvPr>
+            <p:ph type="sldNum" sz="quarter" idx="10"/>
+          </p:nvPr>
+        </p:nvSpPr>
+        <p:spPr/>
+        <p:txBody>
+          <a:bodyPr/>
+          <a:lstStyle/>
+          <a:p>
+            <a:fld id="{F7021451-1387-4CA6-816F-3879F97B5CBC}" type="slidenum">
+              <a:rPr lang="en-US"/>
+              <a:t>62</a:t>
+            </a:fld>
+            <a:endParaRPr lang="en-US"/>
+          </a:p>
+        </p:txBody>
+      </p:sp>
+    </p:spTree>
+    <p:extLst>
+      <p:ext uri="{BB962C8B-B14F-4D97-AF65-F5344CB8AC3E}">
+        <p14:creationId xmlns:p14="http://schemas.microsoft.com/office/powerpoint/2010/main" val="1024086991"/>
+      </p:ext>
+    </p:extLst>
+  </p:cSld>
+  <p:clrMapOvr>
+    <a:masterClrMapping/>
+  </p:clrMapOvr>
+</p:notes>
+</file>
+
+<file path=ppt/notesSlides/notesSlide63.xml><?xml version="1.0" encoding="utf-8"?>
+<p:notes xmlns:a="http://schemas.openxmlformats.org/drawingml/2006/main" xmlns:r="http://schemas.openxmlformats.org/officeDocument/2006/relationships" xmlns:p="http://schemas.openxmlformats.org/presentationml/2006/main">
+  <p:cSld>
+    <p:spTree>
+      <p:nvGrpSpPr>
+        <p:cNvPr id="1" name=""/>
+        <p:cNvGrpSpPr/>
+        <p:nvPr/>
+      </p:nvGrpSpPr>
+      <p:grpSpPr>
+        <a:xfrm>
+          <a:off x="0" y="0"/>
+          <a:ext cx="0" cy="0"/>
+          <a:chOff x="0" y="0"/>
+          <a:chExt cx="0" cy="0"/>
+        </a:xfrm>
+      </p:grpSpPr>
+      <p:sp>
+        <p:nvSpPr>
+          <p:cNvPr id="2" name="Slide Image Placeholder 1"/>
+          <p:cNvSpPr>
+            <a:spLocks noGrp="1" noRot="1" noChangeAspect="1"/>
+          </p:cNvSpPr>
+          <p:nvPr>
+            <p:ph type="sldImg"/>
+          </p:nvPr>
+        </p:nvSpPr>
+        <p:spPr/>
+      </p:sp>
+      <p:sp>
+        <p:nvSpPr>
+          <p:cNvPr id="3" name="Notes Placeholder 2"/>
+          <p:cNvSpPr>
+            <a:spLocks noGrp="1"/>
+          </p:cNvSpPr>
+          <p:nvPr>
+            <p:ph type="body" idx="1"/>
+          </p:nvPr>
+        </p:nvSpPr>
+        <p:spPr/>
+        <p:txBody>
+          <a:bodyPr/>
+          <a:lstStyle/>
+          <a:p>
+            <a:r>
+              <a:rPr lang="en-US" dirty="0"/>
+              <a:t/>
+            </a:r>
+            <a:endParaRPr lang="en-US" dirty="0"/>
+          </a:p>
+        </p:txBody>
+      </p:sp>
+      <p:sp>
+        <p:nvSpPr>
+          <p:cNvPr id="4" name="Slide Number Placeholder 3"/>
+          <p:cNvSpPr>
+            <a:spLocks noGrp="1"/>
+          </p:cNvSpPr>
+          <p:nvPr>
+            <p:ph type="sldNum" sz="quarter" idx="10"/>
+          </p:nvPr>
+        </p:nvSpPr>
+        <p:spPr/>
+        <p:txBody>
+          <a:bodyPr/>
+          <a:lstStyle/>
+          <a:p>
+            <a:fld id="{F7021451-1387-4CA6-816F-3879F97B5CBC}" type="slidenum">
+              <a:rPr lang="en-US"/>
+              <a:t>63</a:t>
+            </a:fld>
+            <a:endParaRPr lang="en-US"/>
+          </a:p>
+        </p:txBody>
+      </p:sp>
+    </p:spTree>
+    <p:extLst>
+      <p:ext uri="{BB962C8B-B14F-4D97-AF65-F5344CB8AC3E}">
+        <p14:creationId xmlns:p14="http://schemas.microsoft.com/office/powerpoint/2010/main" val="1024086991"/>
+      </p:ext>
+    </p:extLst>
+  </p:cSld>
+  <p:clrMapOvr>
+    <a:masterClrMapping/>
+  </p:clrMapOvr>
+</p:notes>
+</file>
+
+<file path=ppt/notesSlides/notesSlide64.xml><?xml version="1.0" encoding="utf-8"?>
+<p:notes xmlns:a="http://schemas.openxmlformats.org/drawingml/2006/main" xmlns:r="http://schemas.openxmlformats.org/officeDocument/2006/relationships" xmlns:p="http://schemas.openxmlformats.org/presentationml/2006/main">
+  <p:cSld>
+    <p:spTree>
+      <p:nvGrpSpPr>
+        <p:cNvPr id="1" name=""/>
+        <p:cNvGrpSpPr/>
+        <p:nvPr/>
+      </p:nvGrpSpPr>
+      <p:grpSpPr>
+        <a:xfrm>
+          <a:off x="0" y="0"/>
+          <a:ext cx="0" cy="0"/>
+          <a:chOff x="0" y="0"/>
+          <a:chExt cx="0" cy="0"/>
+        </a:xfrm>
+      </p:grpSpPr>
+      <p:sp>
+        <p:nvSpPr>
+          <p:cNvPr id="2" name="Slide Image Placeholder 1"/>
+          <p:cNvSpPr>
+            <a:spLocks noGrp="1" noRot="1" noChangeAspect="1"/>
+          </p:cNvSpPr>
+          <p:nvPr>
+            <p:ph type="sldImg"/>
+          </p:nvPr>
+        </p:nvSpPr>
+        <p:spPr/>
+      </p:sp>
+      <p:sp>
+        <p:nvSpPr>
+          <p:cNvPr id="3" name="Notes Placeholder 2"/>
+          <p:cNvSpPr>
+            <a:spLocks noGrp="1"/>
+          </p:cNvSpPr>
+          <p:nvPr>
+            <p:ph type="body" idx="1"/>
+          </p:nvPr>
+        </p:nvSpPr>
+        <p:spPr/>
+        <p:txBody>
+          <a:bodyPr/>
+          <a:lstStyle/>
+          <a:p>
+            <a:r>
+              <a:rPr lang="en-US" dirty="0"/>
+              <a:t/>
+            </a:r>
+            <a:endParaRPr lang="en-US" dirty="0"/>
+          </a:p>
+        </p:txBody>
+      </p:sp>
+      <p:sp>
+        <p:nvSpPr>
+          <p:cNvPr id="4" name="Slide Number Placeholder 3"/>
+          <p:cNvSpPr>
+            <a:spLocks noGrp="1"/>
+          </p:cNvSpPr>
+          <p:nvPr>
+            <p:ph type="sldNum" sz="quarter" idx="10"/>
+          </p:nvPr>
+        </p:nvSpPr>
+        <p:spPr/>
+        <p:txBody>
+          <a:bodyPr/>
+          <a:lstStyle/>
+          <a:p>
+            <a:fld id="{F7021451-1387-4CA6-816F-3879F97B5CBC}" type="slidenum">
+              <a:rPr lang="en-US"/>
+              <a:t>64</a:t>
+            </a:fld>
+            <a:endParaRPr lang="en-US"/>
+          </a:p>
+        </p:txBody>
+      </p:sp>
+    </p:spTree>
+    <p:extLst>
+      <p:ext uri="{BB962C8B-B14F-4D97-AF65-F5344CB8AC3E}">
+        <p14:creationId xmlns:p14="http://schemas.microsoft.com/office/powerpoint/2010/main" val="1024086991"/>
+      </p:ext>
+    </p:extLst>
+  </p:cSld>
+  <p:clrMapOvr>
+    <a:masterClrMapping/>
+  </p:clrMapOvr>
+</p:notes>
+</file>
+
+<file path=ppt/notesSlides/notesSlide65.xml><?xml version="1.0" encoding="utf-8"?>
+<p:notes xmlns:a="http://schemas.openxmlformats.org/drawingml/2006/main" xmlns:r="http://schemas.openxmlformats.org/officeDocument/2006/relationships" xmlns:p="http://schemas.openxmlformats.org/presentationml/2006/main">
+  <p:cSld>
+    <p:spTree>
+      <p:nvGrpSpPr>
+        <p:cNvPr id="1" name=""/>
+        <p:cNvGrpSpPr/>
+        <p:nvPr/>
+      </p:nvGrpSpPr>
+      <p:grpSpPr>
+        <a:xfrm>
+          <a:off x="0" y="0"/>
+          <a:ext cx="0" cy="0"/>
+          <a:chOff x="0" y="0"/>
+          <a:chExt cx="0" cy="0"/>
+        </a:xfrm>
+      </p:grpSpPr>
+      <p:sp>
+        <p:nvSpPr>
+          <p:cNvPr id="2" name="Slide Image Placeholder 1"/>
+          <p:cNvSpPr>
+            <a:spLocks noGrp="1" noRot="1" noChangeAspect="1"/>
+          </p:cNvSpPr>
+          <p:nvPr>
+            <p:ph type="sldImg"/>
+          </p:nvPr>
+        </p:nvSpPr>
+        <p:spPr/>
+      </p:sp>
+      <p:sp>
+        <p:nvSpPr>
+          <p:cNvPr id="3" name="Notes Placeholder 2"/>
+          <p:cNvSpPr>
+            <a:spLocks noGrp="1"/>
+          </p:cNvSpPr>
+          <p:nvPr>
+            <p:ph type="body" idx="1"/>
+          </p:nvPr>
+        </p:nvSpPr>
+        <p:spPr/>
+        <p:txBody>
+          <a:bodyPr/>
+          <a:lstStyle/>
+          <a:p>
+            <a:r>
+              <a:rPr lang="en-US" dirty="0"/>
+              <a:t/>
+            </a:r>
+            <a:endParaRPr lang="en-US" dirty="0"/>
+          </a:p>
+        </p:txBody>
+      </p:sp>
+      <p:sp>
+        <p:nvSpPr>
+          <p:cNvPr id="4" name="Slide Number Placeholder 3"/>
+          <p:cNvSpPr>
+            <a:spLocks noGrp="1"/>
+          </p:cNvSpPr>
+          <p:nvPr>
+            <p:ph type="sldNum" sz="quarter" idx="10"/>
+          </p:nvPr>
+        </p:nvSpPr>
+        <p:spPr/>
+        <p:txBody>
+          <a:bodyPr/>
+          <a:lstStyle/>
+          <a:p>
+            <a:fld id="{F7021451-1387-4CA6-816F-3879F97B5CBC}" type="slidenum">
+              <a:rPr lang="en-US"/>
+              <a:t>65</a:t>
+            </a:fld>
+            <a:endParaRPr lang="en-US"/>
+          </a:p>
+        </p:txBody>
+      </p:sp>
+    </p:spTree>
+    <p:extLst>
+      <p:ext uri="{BB962C8B-B14F-4D97-AF65-F5344CB8AC3E}">
+        <p14:creationId xmlns:p14="http://schemas.microsoft.com/office/powerpoint/2010/main" val="1024086991"/>
+      </p:ext>
+    </p:extLst>
+  </p:cSld>
+  <p:clrMapOvr>
+    <a:masterClrMapping/>
+  </p:clrMapOvr>
+</p:notes>
+</file>
+
+<file path=ppt/notesSlides/notesSlide66.xml><?xml version="1.0" encoding="utf-8"?>
+<p:notes xmlns:a="http://schemas.openxmlformats.org/drawingml/2006/main" xmlns:r="http://schemas.openxmlformats.org/officeDocument/2006/relationships" xmlns:p="http://schemas.openxmlformats.org/presentationml/2006/main">
+  <p:cSld>
+    <p:spTree>
+      <p:nvGrpSpPr>
+        <p:cNvPr id="1" name=""/>
+        <p:cNvGrpSpPr/>
+        <p:nvPr/>
+      </p:nvGrpSpPr>
+      <p:grpSpPr>
+        <a:xfrm>
+          <a:off x="0" y="0"/>
+          <a:ext cx="0" cy="0"/>
+          <a:chOff x="0" y="0"/>
+          <a:chExt cx="0" cy="0"/>
+        </a:xfrm>
+      </p:grpSpPr>
+      <p:sp>
+        <p:nvSpPr>
+          <p:cNvPr id="2" name="Slide Image Placeholder 1"/>
+          <p:cNvSpPr>
+            <a:spLocks noGrp="1" noRot="1" noChangeAspect="1"/>
+          </p:cNvSpPr>
+          <p:nvPr>
+            <p:ph type="sldImg"/>
+          </p:nvPr>
+        </p:nvSpPr>
+        <p:spPr/>
+      </p:sp>
+      <p:sp>
+        <p:nvSpPr>
+          <p:cNvPr id="3" name="Notes Placeholder 2"/>
+          <p:cNvSpPr>
+            <a:spLocks noGrp="1"/>
+          </p:cNvSpPr>
+          <p:nvPr>
+            <p:ph type="body" idx="1"/>
+          </p:nvPr>
+        </p:nvSpPr>
+        <p:spPr/>
+        <p:txBody>
+          <a:bodyPr/>
+          <a:lstStyle/>
+          <a:p>
+            <a:r>
+              <a:rPr lang="en-US" dirty="0"/>
+              <a:t/>
+            </a:r>
+            <a:endParaRPr lang="en-US" dirty="0"/>
+          </a:p>
+        </p:txBody>
+      </p:sp>
+      <p:sp>
+        <p:nvSpPr>
+          <p:cNvPr id="4" name="Slide Number Placeholder 3"/>
+          <p:cNvSpPr>
+            <a:spLocks noGrp="1"/>
+          </p:cNvSpPr>
+          <p:nvPr>
+            <p:ph type="sldNum" sz="quarter" idx="10"/>
+          </p:nvPr>
+        </p:nvSpPr>
+        <p:spPr/>
+        <p:txBody>
+          <a:bodyPr/>
+          <a:lstStyle/>
+          <a:p>
+            <a:fld id="{F7021451-1387-4CA6-816F-3879F97B5CBC}" type="slidenum">
+              <a:rPr lang="en-US"/>
+              <a:t>66</a:t>
             </a:fld>
             <a:endParaRPr lang="en-US"/>
           </a:p>
@@ -47920,6 +48464,3223 @@
                   <a:schemeClr val="bg1"/>
                 </a:solidFill>
               </a:rPr>
+              <a:t>결제·게임 서버·어뷰징</a:t>
+            </a:r>
+            <a:endParaRPr lang="en-US" sz="4000" dirty="0"/>
+          </a:p>
+        </p:txBody>
+      </p:sp>
+      <p:sp>
+        <p:nvSpPr>
+          <p:cNvPr id="3" name="Text 0"/>
+          <p:cNvSpPr/>
+          <p:nvPr>
+            <p:ph idx="101" type="body" hasCustomPrompt="1"/>
+          </p:nvPr>
+        </p:nvSpPr>
+        <p:spPr>
+          <a:xfrm>
+            <a:off x="548640" y="2788920"/>
+            <a:ext cx="8046720" cy="1097280"/>
+          </a:xfrm>
+          <a:prstGeom prst="rect">
+            <a:avLst/>
+          </a:prstGeom>
+          <a:noFill/>
+          <a:ln/>
+        </p:spPr>
+        <p:txBody>
+          <a:bodyPr wrap="square" lIns="0" tIns="0" rIns="0" bIns="0" rtlCol="0" anchor="t"/>
+          <a:lstStyle/>
+          <a:p>
+            <a:pPr algn="l" indent="0" marL="0">
+              <a:buNone/>
+            </a:pPr>
+            <a:r>
+              <a:rPr lang="en-US" sz="1800" dirty="0">
+                <a:solidFill>
+                  <a:schemeClr val="bg2"/>
+                </a:solidFill>
+              </a:rPr>
+              <a:t>결제 연동과 정산 · 롤·배그 같은 멀티플레이 서버 · 어뷰징·핵 대응 — 39–41장</a:t>
+            </a:r>
+            <a:endParaRPr lang="en-US" sz="1800" dirty="0"/>
+          </a:p>
+        </p:txBody>
+      </p:sp>
+    </p:spTree>
+  </p:cSld>
+  <p:clrMapOvr>
+    <a:masterClrMapping/>
+  </p:clrMapOvr>
+</p:sld>
+</file>
+
+<file path=ppt/slides/slide61.xml><?xml version="1.0" encoding="utf-8"?>
+<p:sld xmlns:a="http://schemas.openxmlformats.org/drawingml/2006/main" xmlns:r="http://schemas.openxmlformats.org/officeDocument/2006/relationships" xmlns:p="http://schemas.openxmlformats.org/presentationml/2006/main">
+  <p:cSld name="Slide 61">
+    <p:spTree>
+      <p:nvGrpSpPr>
+        <p:cNvPr id="1" name=""/>
+        <p:cNvGrpSpPr/>
+        <p:nvPr/>
+      </p:nvGrpSpPr>
+      <p:grpSpPr>
+        <a:xfrm>
+          <a:off x="0" y="0"/>
+          <a:ext cx="0" cy="0"/>
+          <a:chOff x="0" y="0"/>
+          <a:chExt cx="0" cy="0"/>
+        </a:xfrm>
+      </p:grpSpPr>
+      <p:sp>
+        <p:nvSpPr>
+          <p:cNvPr id="2" name="Text 0"/>
+          <p:cNvSpPr/>
+          <p:nvPr>
+            <p:ph idx="100" type="title" hasCustomPrompt="1"/>
+          </p:nvPr>
+        </p:nvSpPr>
+        <p:spPr>
+          <a:xfrm>
+            <a:off x="457200" y="274320"/>
+            <a:ext cx="8229600" cy="685800"/>
+          </a:xfrm>
+          <a:prstGeom prst="rect">
+            <a:avLst/>
+          </a:prstGeom>
+          <a:noFill/>
+          <a:ln/>
+        </p:spPr>
+        <p:txBody>
+          <a:bodyPr wrap="square" lIns="0" tIns="0" rIns="0" bIns="0" rtlCol="0" anchor="ctr"/>
+          <a:lstStyle/>
+          <a:p>
+            <a:pPr indent="0" marL="0">
+              <a:buNone/>
+            </a:pPr>
+            <a:r>
+              <a:rPr lang="en-US" sz="2800" b="1" dirty="0">
+                <a:solidFill>
+                  <a:schemeClr val="tx2"/>
+                </a:solidFill>
+              </a:rPr>
+              <a:t>결제 연동: 서버에서 검증하고 승인한다</a:t>
+            </a:r>
+            <a:endParaRPr lang="en-US" sz="2800" dirty="0"/>
+          </a:p>
+        </p:txBody>
+      </p:sp>
+      <p:sp>
+        <p:nvSpPr>
+          <p:cNvPr id="3" name="pay0"/>
+          <p:cNvSpPr/>
+          <p:nvPr/>
+        </p:nvSpPr>
+        <p:spPr>
+          <a:xfrm>
+            <a:off x="457200" y="1188720"/>
+            <a:ext cx="1261872" cy="685800"/>
+          </a:xfrm>
+          <a:prstGeom prst="roundRect">
+            <a:avLst>
+              <a:gd name="adj" fmla="val 10667"/>
+            </a:avLst>
+          </a:prstGeom>
+          <a:solidFill>
+            <a:srgbClr val="1F4E4A"/>
+          </a:solidFill>
+          <a:ln/>
+        </p:spPr>
+      </p:sp>
+      <p:sp>
+        <p:nvSpPr>
+          <p:cNvPr id="4" name="Text 2"/>
+          <p:cNvSpPr txBox="1"/>
+          <p:nvPr/>
+        </p:nvSpPr>
+        <p:spPr>
+          <a:xfrm>
+            <a:off x="457200" y="1188720"/>
+            <a:ext cx="1261872" cy="685800"/>
+          </a:xfrm>
+          <a:prstGeom prst="rect">
+            <a:avLst/>
+          </a:prstGeom>
+          <a:noFill/>
+          <a:ln/>
+        </p:spPr>
+        <p:txBody>
+          <a:bodyPr wrap="square" lIns="0" tIns="0" rIns="0" bIns="0" rtlCol="0" anchor="ctr"/>
+          <a:lstStyle/>
+          <a:p>
+            <a:pPr algn="ctr" indent="0" marL="0">
+              <a:buNone/>
+            </a:pPr>
+            <a:r>
+              <a:rPr lang="en-US" sz="1300" b="1" dirty="0">
+                <a:solidFill>
+                  <a:schemeClr val="bg1"/>
+                </a:solidFill>
+              </a:rPr>
+              <a:t>주문 저장</a:t>
+            </a:r>
+            <a:endParaRPr lang="en-US" sz="1300" dirty="0"/>
+          </a:p>
+        </p:txBody>
+      </p:sp>
+      <p:sp>
+        <p:nvSpPr>
+          <p:cNvPr id="5" name="pay1"/>
+          <p:cNvSpPr/>
+          <p:nvPr/>
+        </p:nvSpPr>
+        <p:spPr>
+          <a:xfrm>
+            <a:off x="1847088" y="1188720"/>
+            <a:ext cx="1261872" cy="685800"/>
+          </a:xfrm>
+          <a:prstGeom prst="roundRect">
+            <a:avLst>
+              <a:gd name="adj" fmla="val 10667"/>
+            </a:avLst>
+          </a:prstGeom>
+          <a:solidFill>
+            <a:srgbClr val="1F4E4A"/>
+          </a:solidFill>
+          <a:ln/>
+        </p:spPr>
+      </p:sp>
+      <p:sp>
+        <p:nvSpPr>
+          <p:cNvPr id="6" name="Text 4"/>
+          <p:cNvSpPr txBox="1"/>
+          <p:nvPr/>
+        </p:nvSpPr>
+        <p:spPr>
+          <a:xfrm>
+            <a:off x="1847088" y="1188720"/>
+            <a:ext cx="1261872" cy="685800"/>
+          </a:xfrm>
+          <a:prstGeom prst="rect">
+            <a:avLst/>
+          </a:prstGeom>
+          <a:noFill/>
+          <a:ln/>
+        </p:spPr>
+        <p:txBody>
+          <a:bodyPr wrap="square" lIns="0" tIns="0" rIns="0" bIns="0" rtlCol="0" anchor="ctr"/>
+          <a:lstStyle/>
+          <a:p>
+            <a:pPr algn="ctr" indent="0" marL="0">
+              <a:buNone/>
+            </a:pPr>
+            <a:r>
+              <a:rPr lang="en-US" sz="1300" b="1" dirty="0">
+                <a:solidFill>
+                  <a:schemeClr val="bg1"/>
+                </a:solidFill>
+              </a:rPr>
+              <a:t>결제창</a:t>
+            </a:r>
+            <a:endParaRPr lang="en-US" sz="1300" dirty="0"/>
+          </a:p>
+        </p:txBody>
+      </p:sp>
+      <p:sp>
+        <p:nvSpPr>
+          <p:cNvPr id="7" name="pay2"/>
+          <p:cNvSpPr/>
+          <p:nvPr/>
+        </p:nvSpPr>
+        <p:spPr>
+          <a:xfrm>
+            <a:off x="3236976" y="1188720"/>
+            <a:ext cx="1261872" cy="685800"/>
+          </a:xfrm>
+          <a:prstGeom prst="roundRect">
+            <a:avLst>
+              <a:gd name="adj" fmla="val 10667"/>
+            </a:avLst>
+          </a:prstGeom>
+          <a:solidFill>
+            <a:srgbClr val="1F4E4A"/>
+          </a:solidFill>
+          <a:ln/>
+        </p:spPr>
+      </p:sp>
+      <p:sp>
+        <p:nvSpPr>
+          <p:cNvPr id="8" name="Text 6"/>
+          <p:cNvSpPr txBox="1"/>
+          <p:nvPr/>
+        </p:nvSpPr>
+        <p:spPr>
+          <a:xfrm>
+            <a:off x="3236976" y="1188720"/>
+            <a:ext cx="1261872" cy="685800"/>
+          </a:xfrm>
+          <a:prstGeom prst="rect">
+            <a:avLst/>
+          </a:prstGeom>
+          <a:noFill/>
+          <a:ln/>
+        </p:spPr>
+        <p:txBody>
+          <a:bodyPr wrap="square" lIns="0" tIns="0" rIns="0" bIns="0" rtlCol="0" anchor="ctr"/>
+          <a:lstStyle/>
+          <a:p>
+            <a:pPr algn="ctr" indent="0" marL="0">
+              <a:buNone/>
+            </a:pPr>
+            <a:r>
+              <a:rPr lang="en-US" sz="1300" b="1" dirty="0">
+                <a:solidFill>
+                  <a:schemeClr val="bg1"/>
+                </a:solidFill>
+              </a:rPr>
+              <a:t>성공 주소</a:t>
+            </a:r>
+            <a:endParaRPr lang="en-US" sz="1300" dirty="0"/>
+          </a:p>
+        </p:txBody>
+      </p:sp>
+      <p:sp>
+        <p:nvSpPr>
+          <p:cNvPr id="9" name="pay3"/>
+          <p:cNvSpPr/>
+          <p:nvPr/>
+        </p:nvSpPr>
+        <p:spPr>
+          <a:xfrm>
+            <a:off x="4626864" y="1188720"/>
+            <a:ext cx="1261872" cy="685800"/>
+          </a:xfrm>
+          <a:prstGeom prst="roundRect">
+            <a:avLst>
+              <a:gd name="adj" fmla="val 10667"/>
+            </a:avLst>
+          </a:prstGeom>
+          <a:solidFill>
+            <a:srgbClr val="F08A3E"/>
+          </a:solidFill>
+          <a:ln/>
+        </p:spPr>
+      </p:sp>
+      <p:sp>
+        <p:nvSpPr>
+          <p:cNvPr id="10" name="Text 8"/>
+          <p:cNvSpPr txBox="1"/>
+          <p:nvPr/>
+        </p:nvSpPr>
+        <p:spPr>
+          <a:xfrm>
+            <a:off x="4626864" y="1188720"/>
+            <a:ext cx="1261872" cy="685800"/>
+          </a:xfrm>
+          <a:prstGeom prst="rect">
+            <a:avLst/>
+          </a:prstGeom>
+          <a:noFill/>
+          <a:ln/>
+        </p:spPr>
+        <p:txBody>
+          <a:bodyPr wrap="square" lIns="0" tIns="0" rIns="0" bIns="0" rtlCol="0" anchor="ctr"/>
+          <a:lstStyle/>
+          <a:p>
+            <a:pPr algn="ctr" indent="0" marL="0">
+              <a:buNone/>
+            </a:pPr>
+            <a:r>
+              <a:rPr lang="en-US" sz="1300" b="1" dirty="0">
+                <a:solidFill>
+                  <a:schemeClr val="bg1"/>
+                </a:solidFill>
+              </a:rPr>
+              <a:t>★ 금액 검증</a:t>
+            </a:r>
+            <a:endParaRPr lang="en-US" sz="1300" dirty="0"/>
+          </a:p>
+        </p:txBody>
+      </p:sp>
+      <p:sp>
+        <p:nvSpPr>
+          <p:cNvPr id="11" name="pay4"/>
+          <p:cNvSpPr/>
+          <p:nvPr/>
+        </p:nvSpPr>
+        <p:spPr>
+          <a:xfrm>
+            <a:off x="6016752" y="1188720"/>
+            <a:ext cx="1261872" cy="685800"/>
+          </a:xfrm>
+          <a:prstGeom prst="roundRect">
+            <a:avLst>
+              <a:gd name="adj" fmla="val 10667"/>
+            </a:avLst>
+          </a:prstGeom>
+          <a:solidFill>
+            <a:srgbClr val="F08A3E"/>
+          </a:solidFill>
+          <a:ln/>
+        </p:spPr>
+      </p:sp>
+      <p:sp>
+        <p:nvSpPr>
+          <p:cNvPr id="12" name="Text 10"/>
+          <p:cNvSpPr txBox="1"/>
+          <p:nvPr/>
+        </p:nvSpPr>
+        <p:spPr>
+          <a:xfrm>
+            <a:off x="6016752" y="1188720"/>
+            <a:ext cx="1261872" cy="685800"/>
+          </a:xfrm>
+          <a:prstGeom prst="rect">
+            <a:avLst/>
+          </a:prstGeom>
+          <a:noFill/>
+          <a:ln/>
+        </p:spPr>
+        <p:txBody>
+          <a:bodyPr wrap="square" lIns="0" tIns="0" rIns="0" bIns="0" rtlCol="0" anchor="ctr"/>
+          <a:lstStyle/>
+          <a:p>
+            <a:pPr algn="ctr" indent="0" marL="0">
+              <a:buNone/>
+            </a:pPr>
+            <a:r>
+              <a:rPr lang="en-US" sz="1300" b="1" dirty="0">
+                <a:solidFill>
+                  <a:schemeClr val="bg1"/>
+                </a:solidFill>
+              </a:rPr>
+              <a:t>★ 서버 승인</a:t>
+            </a:r>
+            <a:endParaRPr lang="en-US" sz="1300" dirty="0"/>
+          </a:p>
+        </p:txBody>
+      </p:sp>
+      <p:sp>
+        <p:nvSpPr>
+          <p:cNvPr id="13" name="pay5"/>
+          <p:cNvSpPr/>
+          <p:nvPr/>
+        </p:nvSpPr>
+        <p:spPr>
+          <a:xfrm>
+            <a:off x="7406640" y="1188720"/>
+            <a:ext cx="1261872" cy="685800"/>
+          </a:xfrm>
+          <a:prstGeom prst="roundRect">
+            <a:avLst>
+              <a:gd name="adj" fmla="val 10667"/>
+            </a:avLst>
+          </a:prstGeom>
+          <a:solidFill>
+            <a:srgbClr val="1F4E4A"/>
+          </a:solidFill>
+          <a:ln/>
+        </p:spPr>
+      </p:sp>
+      <p:sp>
+        <p:nvSpPr>
+          <p:cNvPr id="14" name="Text 12"/>
+          <p:cNvSpPr txBox="1"/>
+          <p:nvPr/>
+        </p:nvSpPr>
+        <p:spPr>
+          <a:xfrm>
+            <a:off x="7406640" y="1188720"/>
+            <a:ext cx="1261872" cy="685800"/>
+          </a:xfrm>
+          <a:prstGeom prst="rect">
+            <a:avLst/>
+          </a:prstGeom>
+          <a:noFill/>
+          <a:ln/>
+        </p:spPr>
+        <p:txBody>
+          <a:bodyPr wrap="square" lIns="0" tIns="0" rIns="0" bIns="0" rtlCol="0" anchor="ctr"/>
+          <a:lstStyle/>
+          <a:p>
+            <a:pPr algn="ctr" indent="0" marL="0">
+              <a:buNone/>
+            </a:pPr>
+            <a:r>
+              <a:rPr lang="en-US" sz="1300" b="1" dirty="0">
+                <a:solidFill>
+                  <a:schemeClr val="bg1"/>
+                </a:solidFill>
+              </a:rPr>
+              <a:t>결과 저장</a:t>
+            </a:r>
+            <a:endParaRPr lang="en-US" sz="1300" dirty="0"/>
+          </a:p>
+        </p:txBody>
+      </p:sp>
+      <p:sp>
+        <p:nvSpPr>
+          <p:cNvPr id="15" name="card"/>
+          <p:cNvSpPr/>
+          <p:nvPr/>
+        </p:nvSpPr>
+        <p:spPr>
+          <a:xfrm>
+            <a:off x="457200" y="2148840"/>
+            <a:ext cx="4023360" cy="960120"/>
+          </a:xfrm>
+          <a:prstGeom prst="roundRect">
+            <a:avLst>
+              <a:gd name="adj" fmla="val 7619"/>
+            </a:avLst>
+          </a:prstGeom>
+          <a:solidFill>
+            <a:schemeClr val="bg2"/>
+          </a:solidFill>
+          <a:ln/>
+        </p:spPr>
+      </p:sp>
+      <p:sp>
+        <p:nvSpPr>
+          <p:cNvPr id="16" name="Text 14"/>
+          <p:cNvSpPr txBox="1"/>
+          <p:nvPr/>
+        </p:nvSpPr>
+        <p:spPr>
+          <a:xfrm>
+            <a:off x="640080" y="2148840"/>
+            <a:ext cx="3657600" cy="960120"/>
+          </a:xfrm>
+          <a:prstGeom prst="rect">
+            <a:avLst/>
+          </a:prstGeom>
+          <a:noFill/>
+          <a:ln/>
+        </p:spPr>
+        <p:txBody>
+          <a:bodyPr wrap="square" lIns="0" tIns="0" rIns="0" bIns="0" rtlCol="0" anchor="ctr"/>
+          <a:lstStyle/>
+          <a:p>
+            <a:pPr indent="0" marL="0">
+              <a:buNone/>
+            </a:pPr>
+            <a:r>
+              <a:rPr lang="en-US" sz="1500" b="1" dirty="0">
+                <a:solidFill>
+                  <a:schemeClr val="tx2"/>
+                </a:solidFill>
+              </a:rPr>
+              <a:t>금액 검증</a:t>
+            </a:r>
+            <a:endParaRPr lang="en-US" sz="1500" dirty="0"/>
+          </a:p>
+          <a:p>
+            <a:pPr indent="0" marL="0">
+              <a:buNone/>
+            </a:pPr>
+            <a:r>
+              <a:rPr lang="en-US" sz="1200" dirty="0">
+                <a:solidFill>
+                  <a:schemeClr val="tx1"/>
+                </a:solidFill>
+              </a:rPr>
+              <a:t>브라우저 값은 조작 가능 → DB 금액과 같을 때만 승인</a:t>
+            </a:r>
+            <a:endParaRPr lang="en-US" sz="1500" dirty="0"/>
+          </a:p>
+        </p:txBody>
+      </p:sp>
+      <p:sp>
+        <p:nvSpPr>
+          <p:cNvPr id="17" name="card"/>
+          <p:cNvSpPr/>
+          <p:nvPr/>
+        </p:nvSpPr>
+        <p:spPr>
+          <a:xfrm>
+            <a:off x="4663440" y="2148840"/>
+            <a:ext cx="4023360" cy="960120"/>
+          </a:xfrm>
+          <a:prstGeom prst="roundRect">
+            <a:avLst>
+              <a:gd name="adj" fmla="val 7619"/>
+            </a:avLst>
+          </a:prstGeom>
+          <a:solidFill>
+            <a:schemeClr val="bg2"/>
+          </a:solidFill>
+          <a:ln/>
+        </p:spPr>
+      </p:sp>
+      <p:sp>
+        <p:nvSpPr>
+          <p:cNvPr id="18" name="Text 16"/>
+          <p:cNvSpPr txBox="1"/>
+          <p:nvPr/>
+        </p:nvSpPr>
+        <p:spPr>
+          <a:xfrm>
+            <a:off x="4846320" y="2148840"/>
+            <a:ext cx="3657600" cy="960120"/>
+          </a:xfrm>
+          <a:prstGeom prst="rect">
+            <a:avLst/>
+          </a:prstGeom>
+          <a:noFill/>
+          <a:ln/>
+        </p:spPr>
+        <p:txBody>
+          <a:bodyPr wrap="square" lIns="0" tIns="0" rIns="0" bIns="0" rtlCol="0" anchor="ctr"/>
+          <a:lstStyle/>
+          <a:p>
+            <a:pPr indent="0" marL="0">
+              <a:buNone/>
+            </a:pPr>
+            <a:r>
+              <a:rPr lang="en-US" sz="1500" b="1" dirty="0">
+                <a:solidFill>
+                  <a:schemeClr val="tx2"/>
+                </a:solidFill>
+              </a:rPr>
+              <a:t>비밀 키</a:t>
+            </a:r>
+            <a:endParaRPr lang="en-US" sz="1500" dirty="0"/>
+          </a:p>
+          <a:p>
+            <a:pPr indent="0" marL="0">
+              <a:buNone/>
+            </a:pPr>
+            <a:r>
+              <a:rPr lang="en-US" sz="1200" dirty="0">
+                <a:solidFill>
+                  <a:schemeClr val="tx1"/>
+                </a:solidFill>
+              </a:rPr>
+              <a:t>승인은 서버에서, 시크릿 키는 환경 변수에만</a:t>
+            </a:r>
+            <a:endParaRPr lang="en-US" sz="1500" dirty="0"/>
+          </a:p>
+        </p:txBody>
+      </p:sp>
+      <p:sp>
+        <p:nvSpPr>
+          <p:cNvPr id="19" name="card"/>
+          <p:cNvSpPr/>
+          <p:nvPr/>
+        </p:nvSpPr>
+        <p:spPr>
+          <a:xfrm>
+            <a:off x="457200" y="3246120"/>
+            <a:ext cx="4023360" cy="960120"/>
+          </a:xfrm>
+          <a:prstGeom prst="roundRect">
+            <a:avLst>
+              <a:gd name="adj" fmla="val 7619"/>
+            </a:avLst>
+          </a:prstGeom>
+          <a:solidFill>
+            <a:schemeClr val="bg2"/>
+          </a:solidFill>
+          <a:ln/>
+        </p:spPr>
+      </p:sp>
+      <p:sp>
+        <p:nvSpPr>
+          <p:cNvPr id="20" name="Text 18"/>
+          <p:cNvSpPr txBox="1"/>
+          <p:nvPr/>
+        </p:nvSpPr>
+        <p:spPr>
+          <a:xfrm>
+            <a:off x="640080" y="3246120"/>
+            <a:ext cx="3657600" cy="960120"/>
+          </a:xfrm>
+          <a:prstGeom prst="rect">
+            <a:avLst/>
+          </a:prstGeom>
+          <a:noFill/>
+          <a:ln/>
+        </p:spPr>
+        <p:txBody>
+          <a:bodyPr wrap="square" lIns="0" tIns="0" rIns="0" bIns="0" rtlCol="0" anchor="ctr"/>
+          <a:lstStyle/>
+          <a:p>
+            <a:pPr indent="0" marL="0">
+              <a:buNone/>
+            </a:pPr>
+            <a:r>
+              <a:rPr lang="en-US" sz="1500" b="1" dirty="0">
+                <a:solidFill>
+                  <a:schemeClr val="tx2"/>
+                </a:solidFill>
+              </a:rPr>
+              <a:t>웹훅</a:t>
+            </a:r>
+            <a:endParaRPr lang="en-US" sz="1500" dirty="0"/>
+          </a:p>
+          <a:p>
+            <a:pPr indent="0" marL="0">
+              <a:buNone/>
+            </a:pPr>
+            <a:r>
+              <a:rPr lang="en-US" sz="1200" dirty="0">
+                <a:solidFill>
+                  <a:schemeClr val="tx1"/>
+                </a:solidFill>
+              </a:rPr>
+              <a:t>출처 확인 · 같은 알림 한 번만 · 빨리 200 응답</a:t>
+            </a:r>
+            <a:endParaRPr lang="en-US" sz="1500" dirty="0"/>
+          </a:p>
+        </p:txBody>
+      </p:sp>
+      <p:sp>
+        <p:nvSpPr>
+          <p:cNvPr id="21" name="card"/>
+          <p:cNvSpPr/>
+          <p:nvPr/>
+        </p:nvSpPr>
+        <p:spPr>
+          <a:xfrm>
+            <a:off x="4663440" y="3246120"/>
+            <a:ext cx="4023360" cy="960120"/>
+          </a:xfrm>
+          <a:prstGeom prst="roundRect">
+            <a:avLst>
+              <a:gd name="adj" fmla="val 7619"/>
+            </a:avLst>
+          </a:prstGeom>
+          <a:solidFill>
+            <a:schemeClr val="bg2"/>
+          </a:solidFill>
+          <a:ln/>
+        </p:spPr>
+      </p:sp>
+      <p:sp>
+        <p:nvSpPr>
+          <p:cNvPr id="22" name="Text 20"/>
+          <p:cNvSpPr txBox="1"/>
+          <p:nvPr/>
+        </p:nvSpPr>
+        <p:spPr>
+          <a:xfrm>
+            <a:off x="4846320" y="3246120"/>
+            <a:ext cx="3657600" cy="960120"/>
+          </a:xfrm>
+          <a:prstGeom prst="rect">
+            <a:avLst/>
+          </a:prstGeom>
+          <a:noFill/>
+          <a:ln/>
+        </p:spPr>
+        <p:txBody>
+          <a:bodyPr wrap="square" lIns="0" tIns="0" rIns="0" bIns="0" rtlCol="0" anchor="ctr"/>
+          <a:lstStyle/>
+          <a:p>
+            <a:pPr indent="0" marL="0">
+              <a:buNone/>
+            </a:pPr>
+            <a:r>
+              <a:rPr lang="en-US" sz="1500" b="1" dirty="0">
+                <a:solidFill>
+                  <a:schemeClr val="tx2"/>
+                </a:solidFill>
+              </a:rPr>
+              <a:t>예외</a:t>
+            </a:r>
+            <a:endParaRPr lang="en-US" sz="1500" dirty="0"/>
+          </a:p>
+          <a:p>
+            <a:pPr indent="0" marL="0">
+              <a:buNone/>
+            </a:pPr>
+            <a:r>
+              <a:rPr lang="en-US" sz="1200" dirty="0">
+                <a:solidFill>
+                  <a:schemeClr val="tx1"/>
+                </a:solidFill>
+              </a:rPr>
+              <a:t>두 번 클릭 · DB 저장 실패 시 자동 취소 · 부분 취소</a:t>
+            </a:r>
+            <a:endParaRPr lang="en-US" sz="1500" dirty="0"/>
+          </a:p>
+        </p:txBody>
+      </p:sp>
+      <p:sp>
+        <p:nvSpPr>
+          <p:cNvPr id="23" name="Text 21"/>
+          <p:cNvSpPr txBox="1"/>
+          <p:nvPr/>
+        </p:nvSpPr>
+        <p:spPr>
+          <a:xfrm>
+            <a:off x="457200" y="4645152"/>
+            <a:ext cx="7680960" cy="274320"/>
+          </a:xfrm>
+          <a:prstGeom prst="rect">
+            <a:avLst/>
+          </a:prstGeom>
+          <a:noFill/>
+          <a:ln/>
+        </p:spPr>
+        <p:txBody>
+          <a:bodyPr wrap="square" lIns="0" tIns="0" rIns="0" bIns="0" rtlCol="0" anchor="t"/>
+          <a:lstStyle/>
+          <a:p>
+            <a:pPr indent="0" marL="0">
+              <a:buNone/>
+            </a:pPr>
+            <a:r>
+              <a:rPr lang="en-US" sz="1000" dirty="0">
+                <a:solidFill>
+                  <a:schemeClr val="accent4"/>
+                </a:solidFill>
+              </a:rPr>
+              <a:t>PG 계약은 업종 심사가 먼저 · 개발은 테스트 키로 먼저 (39장)</a:t>
+            </a:r>
+            <a:endParaRPr lang="en-US" sz="1000" dirty="0"/>
+          </a:p>
+        </p:txBody>
+      </p:sp>
+      <p:sp>
+        <p:nvSpPr>
+          <p:cNvPr id="25" name="Slide Number Placeholder 0"/>
+          <p:cNvSpPr>
+            <a:spLocks noGrp="1"/>
+          </p:cNvSpPr>
+          <p:nvPr>
+            <p:ph type="sldNum" sz="quarter" idx="4294967295"/>
+          </p:nvPr>
+        </p:nvSpPr>
+        <p:spPr>
+          <a:xfrm>
+            <a:off x="8321040" y="4754880"/>
+            <a:ext cx="457200" cy="274320"/>
+          </a:xfrm>
+          <a:prstGeom prst="rect">
+            <a:avLst/>
+          </a:prstGeom>
+          <a:extLst>
+            <a:ext uri="{C572A759-6A51-4108-AA02-DFA0A04FC94B}">
+              <ma14:wrappingTextBoxFlag xmlns:ma14="http://schemas.microsoft.com/office/mac/drawingml/2011/main" val="0"/>
+            </a:ext>
+          </a:extLst>
+        </p:spPr>
+        <p:txBody>
+          <a:bodyPr/>
+          <a:lstStyle>
+            <a:lvl1pPr>
+              <a:defRPr sz="1000">
+                <a:solidFill>
+                  <a:schemeClr val="accent4"/>
+                </a:solidFill>
+              </a:defRPr>
+            </a:lvl1pPr>
+          </a:lstStyle>
+          <a:p>
+            <a:pPr algn="r"/>
+            <a:fld id="{F7021451-1387-4CA6-816F-3879F97B5CBC}" type="slidenum">
+              <a:rPr b="0" lang="en-US"/>
+              <a:t>61</a:t>
+            </a:fld>
+            <a:endParaRPr lang="en-US"/>
+          </a:p>
+        </p:txBody>
+      </p:sp>
+    </p:spTree>
+  </p:cSld>
+  <p:clrMapOvr>
+    <a:masterClrMapping/>
+  </p:clrMapOvr>
+</p:sld>
+</file>
+
+<file path=ppt/slides/slide62.xml><?xml version="1.0" encoding="utf-8"?>
+<p:sld xmlns:a="http://schemas.openxmlformats.org/drawingml/2006/main" xmlns:r="http://schemas.openxmlformats.org/officeDocument/2006/relationships" xmlns:p="http://schemas.openxmlformats.org/presentationml/2006/main">
+  <p:cSld name="Slide 62">
+    <p:spTree>
+      <p:nvGrpSpPr>
+        <p:cNvPr id="1" name=""/>
+        <p:cNvGrpSpPr/>
+        <p:nvPr/>
+      </p:nvGrpSpPr>
+      <p:grpSpPr>
+        <a:xfrm>
+          <a:off x="0" y="0"/>
+          <a:ext cx="0" cy="0"/>
+          <a:chOff x="0" y="0"/>
+          <a:chExt cx="0" cy="0"/>
+        </a:xfrm>
+      </p:grpSpPr>
+      <p:sp>
+        <p:nvSpPr>
+          <p:cNvPr id="2" name="Text 0"/>
+          <p:cNvSpPr/>
+          <p:nvPr>
+            <p:ph idx="100" type="title" hasCustomPrompt="1"/>
+          </p:nvPr>
+        </p:nvSpPr>
+        <p:spPr>
+          <a:xfrm>
+            <a:off x="457200" y="274320"/>
+            <a:ext cx="8229600" cy="685800"/>
+          </a:xfrm>
+          <a:prstGeom prst="rect">
+            <a:avLst/>
+          </a:prstGeom>
+          <a:noFill/>
+          <a:ln/>
+        </p:spPr>
+        <p:txBody>
+          <a:bodyPr wrap="square" lIns="0" tIns="0" rIns="0" bIns="0" rtlCol="0" anchor="ctr"/>
+          <a:lstStyle/>
+          <a:p>
+            <a:pPr indent="0" marL="0">
+              <a:buNone/>
+            </a:pPr>
+            <a:r>
+              <a:rPr lang="en-US" sz="2800" b="1" dirty="0">
+                <a:solidFill>
+                  <a:schemeClr val="tx2"/>
+                </a:solidFill>
+              </a:rPr>
+              <a:t>대사와 정산: 돈을 매일 맞춰 본다</a:t>
+            </a:r>
+            <a:endParaRPr lang="en-US" sz="2800" dirty="0"/>
+          </a:p>
+        </p:txBody>
+      </p:sp>
+      <p:sp>
+        <p:nvSpPr>
+          <p:cNvPr id="3" name="card"/>
+          <p:cNvSpPr/>
+          <p:nvPr/>
+        </p:nvSpPr>
+        <p:spPr>
+          <a:xfrm>
+            <a:off x="457200" y="1188720"/>
+            <a:ext cx="4023360" cy="3200400"/>
+          </a:xfrm>
+          <a:prstGeom prst="roundRect">
+            <a:avLst>
+              <a:gd name="adj" fmla="val 2286"/>
+            </a:avLst>
+          </a:prstGeom>
+          <a:solidFill>
+            <a:schemeClr val="tx2"/>
+          </a:solidFill>
+          <a:ln/>
+        </p:spPr>
+      </p:sp>
+      <p:sp>
+        <p:nvSpPr>
+          <p:cNvPr id="4" name="Text 2"/>
+          <p:cNvSpPr txBox="1"/>
+          <p:nvPr/>
+        </p:nvSpPr>
+        <p:spPr>
+          <a:xfrm>
+            <a:off x="685800" y="1325880"/>
+            <a:ext cx="3566160" cy="365760"/>
+          </a:xfrm>
+          <a:prstGeom prst="rect">
+            <a:avLst/>
+          </a:prstGeom>
+          <a:noFill/>
+          <a:ln/>
+        </p:spPr>
+        <p:txBody>
+          <a:bodyPr wrap="square" lIns="0" tIns="0" rIns="0" bIns="0" rtlCol="0" anchor="t"/>
+          <a:lstStyle/>
+          <a:p>
+            <a:pPr indent="0" marL="0">
+              <a:buNone/>
+            </a:pPr>
+            <a:r>
+              <a:rPr lang="en-US" sz="1600" b="1" dirty="0">
+                <a:solidFill>
+                  <a:schemeClr val="accent6"/>
+                </a:solidFill>
+              </a:rPr>
+              <a:t>매일 대사</a:t>
+            </a:r>
+            <a:endParaRPr lang="en-US" sz="1600" dirty="0"/>
+          </a:p>
+        </p:txBody>
+      </p:sp>
+      <p:sp>
+        <p:nvSpPr>
+          <p:cNvPr id="5" name="Text 3"/>
+          <p:cNvSpPr txBox="1"/>
+          <p:nvPr/>
+        </p:nvSpPr>
+        <p:spPr>
+          <a:xfrm>
+            <a:off x="685800" y="1783080"/>
+            <a:ext cx="3657600" cy="2468880"/>
+          </a:xfrm>
+          <a:prstGeom prst="rect">
+            <a:avLst/>
+          </a:prstGeom>
+          <a:noFill/>
+          <a:ln/>
+        </p:spPr>
+        <p:txBody>
+          <a:bodyPr wrap="square" lIns="0" tIns="0" rIns="0" bIns="0" rtlCol="0" anchor="t"/>
+          <a:lstStyle/>
+          <a:p>
+            <a:pPr marL="342900" indent="-342900">
+              <a:spcAft>
+                <a:spcPts val="800"/>
+              </a:spcAft>
+              <a:buSzPct val="100000"/>
+              <a:buChar char="•"/>
+            </a:pPr>
+            <a:r>
+              <a:rPr lang="en-US" sz="1300" dirty="0">
+                <a:solidFill>
+                  <a:schemeClr val="bg1"/>
+                </a:solidFill>
+              </a:rPr>
+              <a:t>PG 거래 내역 vs 우리 DB를 주문번호로 짝 맞추기</a:t>
+            </a:r>
+            <a:endParaRPr lang="en-US" sz="1300" dirty="0"/>
+          </a:p>
+          <a:p>
+            <a:pPr marL="342900" indent="-342900">
+              <a:spcAft>
+                <a:spcPts val="800"/>
+              </a:spcAft>
+              <a:buSzPct val="100000"/>
+              <a:buChar char="•"/>
+            </a:pPr>
+            <a:r>
+              <a:rPr lang="en-US" sz="1300" dirty="0">
+                <a:solidFill>
+                  <a:schemeClr val="bg1"/>
+                </a:solidFill>
+              </a:rPr>
+              <a:t>PG엔 있고 DB엔 없음 = 돈 받고 주문 누락 (가장 위험)</a:t>
+            </a:r>
+            <a:endParaRPr lang="en-US" sz="1300" dirty="0"/>
+          </a:p>
+          <a:p>
+            <a:pPr marL="342900" indent="-342900">
+              <a:spcAft>
+                <a:spcPts val="800"/>
+              </a:spcAft>
+              <a:buSzPct val="100000"/>
+              <a:buChar char="•"/>
+            </a:pPr>
+            <a:r>
+              <a:rPr lang="en-US" sz="1300" dirty="0">
+                <a:solidFill>
+                  <a:schemeClr val="bg1"/>
+                </a:solidFill>
+              </a:rPr>
+              <a:t>DB엔 있고 PG엔 없음 = 돈 안 들어온 주문</a:t>
+            </a:r>
+            <a:endParaRPr lang="en-US" sz="1300" dirty="0"/>
+          </a:p>
+          <a:p>
+            <a:pPr marL="342900" indent="-342900">
+              <a:spcAft>
+                <a:spcPts val="800"/>
+              </a:spcAft>
+              <a:buSzPct val="100000"/>
+              <a:buChar char="•"/>
+            </a:pPr>
+            <a:r>
+              <a:rPr lang="en-US" sz="1300" dirty="0">
+                <a:solidFill>
+                  <a:schemeClr val="bg1"/>
+                </a:solidFill>
+              </a:rPr>
+              <a:t>정산일엔 매출 − 취소 − 수수료 확인</a:t>
+            </a:r>
+            <a:endParaRPr lang="en-US" sz="1300" dirty="0"/>
+          </a:p>
+        </p:txBody>
+      </p:sp>
+      <p:sp>
+        <p:nvSpPr>
+          <p:cNvPr id="6" name="Text 4"/>
+          <p:cNvSpPr txBox="1"/>
+          <p:nvPr/>
+        </p:nvSpPr>
+        <p:spPr>
+          <a:xfrm>
+            <a:off x="4754880" y="1188720"/>
+            <a:ext cx="3931920" cy="365760"/>
+          </a:xfrm>
+          <a:prstGeom prst="rect">
+            <a:avLst/>
+          </a:prstGeom>
+          <a:noFill/>
+          <a:ln/>
+        </p:spPr>
+        <p:txBody>
+          <a:bodyPr wrap="square" lIns="0" tIns="0" rIns="0" bIns="0" rtlCol="0" anchor="t"/>
+          <a:lstStyle/>
+          <a:p>
+            <a:pPr indent="0" marL="0">
+              <a:buNone/>
+            </a:pPr>
+            <a:r>
+              <a:rPr lang="en-US" sz="1600" b="1" dirty="0">
+                <a:solidFill>
+                  <a:schemeClr val="accent2"/>
+                </a:solidFill>
+              </a:rPr>
+              <a:t>플랫폼이라면</a:t>
+            </a:r>
+            <a:endParaRPr lang="en-US" sz="1600" dirty="0"/>
+          </a:p>
+        </p:txBody>
+      </p:sp>
+      <p:sp>
+        <p:nvSpPr>
+          <p:cNvPr id="7" name="Text 5"/>
+          <p:cNvSpPr txBox="1"/>
+          <p:nvPr/>
+        </p:nvSpPr>
+        <p:spPr>
+          <a:xfrm>
+            <a:off x="4754880" y="1600200"/>
+            <a:ext cx="3931920" cy="1371600"/>
+          </a:xfrm>
+          <a:prstGeom prst="rect">
+            <a:avLst/>
+          </a:prstGeom>
+          <a:noFill/>
+          <a:ln/>
+        </p:spPr>
+        <p:txBody>
+          <a:bodyPr wrap="square" lIns="0" tIns="0" rIns="0" bIns="0" rtlCol="0" anchor="t"/>
+          <a:lstStyle/>
+          <a:p>
+            <a:pPr marL="342900" indent="-342900">
+              <a:spcAft>
+                <a:spcPts val="600"/>
+              </a:spcAft>
+              <a:buSzPct val="100000"/>
+              <a:buChar char="•"/>
+            </a:pPr>
+            <a:r>
+              <a:rPr lang="en-US" sz="1300" dirty="0">
+                <a:solidFill>
+                  <a:schemeClr val="tx1"/>
+                </a:solidFill>
+              </a:rPr>
+              <a:t>판매자별 정산 원장 (덮어쓰지 않고 추가만)</a:t>
+            </a:r>
+            <a:endParaRPr lang="en-US" sz="1300" dirty="0"/>
+          </a:p>
+          <a:p>
+            <a:pPr marL="342900" indent="-342900">
+              <a:spcAft>
+                <a:spcPts val="600"/>
+              </a:spcAft>
+              <a:buSzPct val="100000"/>
+              <a:buChar char="•"/>
+            </a:pPr>
+            <a:r>
+              <a:rPr lang="en-US" sz="1300" dirty="0">
+                <a:solidFill>
+                  <a:schemeClr val="tx1"/>
+                </a:solidFill>
+              </a:rPr>
+              <a:t>PG 지급대행으로 판매자에게 지급</a:t>
+            </a:r>
+            <a:endParaRPr lang="en-US" sz="1300" dirty="0"/>
+          </a:p>
+          <a:p>
+            <a:pPr marL="342900" indent="-342900">
+              <a:spcAft>
+                <a:spcPts val="600"/>
+              </a:spcAft>
+              <a:buSzPct val="100000"/>
+              <a:buChar char="•"/>
+            </a:pPr>
+            <a:r>
+              <a:rPr lang="en-US" sz="1300" dirty="0">
+                <a:solidFill>
+                  <a:schemeClr val="tx1"/>
+                </a:solidFill>
+              </a:rPr>
+              <a:t>약속한 정산일은 반드시</a:t>
+            </a:r>
+            <a:endParaRPr lang="en-US" sz="1300" dirty="0"/>
+          </a:p>
+        </p:txBody>
+      </p:sp>
+      <p:sp>
+        <p:nvSpPr>
+          <p:cNvPr id="8" name="card"/>
+          <p:cNvSpPr/>
+          <p:nvPr/>
+        </p:nvSpPr>
+        <p:spPr>
+          <a:xfrm>
+            <a:off x="4754880" y="3063240"/>
+            <a:ext cx="3931920" cy="1325880"/>
+          </a:xfrm>
+          <a:prstGeom prst="roundRect">
+            <a:avLst>
+              <a:gd name="adj" fmla="val 5517"/>
+            </a:avLst>
+          </a:prstGeom>
+          <a:solidFill>
+            <a:schemeClr val="bg2"/>
+          </a:solidFill>
+          <a:ln/>
+        </p:spPr>
+      </p:sp>
+      <p:sp>
+        <p:nvSpPr>
+          <p:cNvPr id="9" name="Text 7"/>
+          <p:cNvSpPr txBox="1"/>
+          <p:nvPr/>
+        </p:nvSpPr>
+        <p:spPr>
+          <a:xfrm>
+            <a:off x="4937760" y="3108960"/>
+            <a:ext cx="3611880" cy="1234440"/>
+          </a:xfrm>
+          <a:prstGeom prst="rect">
+            <a:avLst/>
+          </a:prstGeom>
+          <a:noFill/>
+          <a:ln/>
+        </p:spPr>
+        <p:txBody>
+          <a:bodyPr wrap="square" lIns="0" tIns="0" rIns="0" bIns="0" rtlCol="0" anchor="ctr"/>
+          <a:lstStyle/>
+          <a:p>
+            <a:pPr indent="0" marL="0">
+              <a:buNone/>
+            </a:pPr>
+            <a:r>
+              <a:rPr lang="en-US" sz="1300" b="1" dirty="0">
+                <a:solidFill>
+                  <a:schemeClr val="tx2"/>
+                </a:solidFill>
+              </a:rPr>
+              <a:t>티메프 사태 이후 정부 확정안 (2024.10)</a:t>
+            </a:r>
+            <a:endParaRPr lang="en-US" sz="1300" dirty="0"/>
+          </a:p>
+          <a:p>
+            <a:pPr indent="0" marL="0">
+              <a:buNone/>
+            </a:pPr>
+            <a:r>
+              <a:rPr lang="en-US" sz="1100" dirty="0">
+                <a:solidFill>
+                  <a:schemeClr val="tx1"/>
+                </a:solidFill>
+              </a:rPr>
+              <a:t>대형 중개 플랫폼: 구매 확정 후 20일 내 정산, 판매대금 50% 이상 별도 관리 (시행일은 확인 필요)</a:t>
+            </a:r>
+            <a:endParaRPr lang="en-US" sz="1300" dirty="0"/>
+          </a:p>
+        </p:txBody>
+      </p:sp>
+      <p:sp>
+        <p:nvSpPr>
+          <p:cNvPr id="25" name="Slide Number Placeholder 0"/>
+          <p:cNvSpPr>
+            <a:spLocks noGrp="1"/>
+          </p:cNvSpPr>
+          <p:nvPr>
+            <p:ph type="sldNum" sz="quarter" idx="4294967295"/>
+          </p:nvPr>
+        </p:nvSpPr>
+        <p:spPr>
+          <a:xfrm>
+            <a:off x="8321040" y="4754880"/>
+            <a:ext cx="457200" cy="274320"/>
+          </a:xfrm>
+          <a:prstGeom prst="rect">
+            <a:avLst/>
+          </a:prstGeom>
+          <a:extLst>
+            <a:ext uri="{C572A759-6A51-4108-AA02-DFA0A04FC94B}">
+              <ma14:wrappingTextBoxFlag xmlns:ma14="http://schemas.microsoft.com/office/mac/drawingml/2011/main" val="0"/>
+            </a:ext>
+          </a:extLst>
+        </p:spPr>
+        <p:txBody>
+          <a:bodyPr/>
+          <a:lstStyle>
+            <a:lvl1pPr>
+              <a:defRPr sz="1000">
+                <a:solidFill>
+                  <a:schemeClr val="accent4"/>
+                </a:solidFill>
+              </a:defRPr>
+            </a:lvl1pPr>
+          </a:lstStyle>
+          <a:p>
+            <a:pPr algn="r"/>
+            <a:fld id="{F7021451-1387-4CA6-816F-3879F97B5CBC}" type="slidenum">
+              <a:rPr b="0" lang="en-US"/>
+              <a:t>62</a:t>
+            </a:fld>
+            <a:endParaRPr lang="en-US"/>
+          </a:p>
+        </p:txBody>
+      </p:sp>
+    </p:spTree>
+  </p:cSld>
+  <p:clrMapOvr>
+    <a:masterClrMapping/>
+  </p:clrMapOvr>
+</p:sld>
+</file>
+
+<file path=ppt/slides/slide63.xml><?xml version="1.0" encoding="utf-8"?>
+<p:sld xmlns:a="http://schemas.openxmlformats.org/drawingml/2006/main" xmlns:r="http://schemas.openxmlformats.org/officeDocument/2006/relationships" xmlns:p="http://schemas.openxmlformats.org/presentationml/2006/main">
+  <p:cSld name="Slide 63">
+    <p:spTree>
+      <p:nvGrpSpPr>
+        <p:cNvPr id="1" name=""/>
+        <p:cNvGrpSpPr/>
+        <p:nvPr/>
+      </p:nvGrpSpPr>
+      <p:grpSpPr>
+        <a:xfrm>
+          <a:off x="0" y="0"/>
+          <a:ext cx="0" cy="0"/>
+          <a:chOff x="0" y="0"/>
+          <a:chExt cx="0" cy="0"/>
+        </a:xfrm>
+      </p:grpSpPr>
+      <p:sp>
+        <p:nvSpPr>
+          <p:cNvPr id="2" name="Text 0"/>
+          <p:cNvSpPr/>
+          <p:nvPr>
+            <p:ph idx="100" type="title" hasCustomPrompt="1"/>
+          </p:nvPr>
+        </p:nvSpPr>
+        <p:spPr>
+          <a:xfrm>
+            <a:off x="457200" y="274320"/>
+            <a:ext cx="8229600" cy="685800"/>
+          </a:xfrm>
+          <a:prstGeom prst="rect">
+            <a:avLst/>
+          </a:prstGeom>
+          <a:noFill/>
+          <a:ln/>
+        </p:spPr>
+        <p:txBody>
+          <a:bodyPr wrap="square" lIns="0" tIns="0" rIns="0" bIns="0" rtlCol="0" anchor="ctr"/>
+          <a:lstStyle/>
+          <a:p>
+            <a:pPr indent="0" marL="0">
+              <a:buNone/>
+            </a:pPr>
+            <a:r>
+              <a:rPr lang="en-US" sz="2800" b="1" dirty="0">
+                <a:solidFill>
+                  <a:schemeClr val="tx2"/>
+                </a:solidFill>
+              </a:rPr>
+              <a:t>멀티플레이 게임 뒤의 서버들</a:t>
+            </a:r>
+            <a:endParaRPr lang="en-US" sz="2800" dirty="0"/>
+          </a:p>
+        </p:txBody>
+      </p:sp>
+      <p:sp>
+        <p:nvSpPr>
+          <p:cNvPr id="3" name="gs0"/>
+          <p:cNvSpPr/>
+          <p:nvPr/>
+        </p:nvSpPr>
+        <p:spPr>
+          <a:xfrm>
+            <a:off x="457200" y="1188720"/>
+            <a:ext cx="2606040" cy="640080"/>
+          </a:xfrm>
+          <a:prstGeom prst="roundRect">
+            <a:avLst>
+              <a:gd name="adj" fmla="val 11429"/>
+            </a:avLst>
+          </a:prstGeom>
+          <a:solidFill>
+            <a:srgbClr val="1F4E4A"/>
+          </a:solidFill>
+          <a:ln/>
+        </p:spPr>
+      </p:sp>
+      <p:sp>
+        <p:nvSpPr>
+          <p:cNvPr id="4" name="Text 2"/>
+          <p:cNvSpPr txBox="1"/>
+          <p:nvPr/>
+        </p:nvSpPr>
+        <p:spPr>
+          <a:xfrm>
+            <a:off x="640080" y="1188720"/>
+            <a:ext cx="2240280" cy="640080"/>
+          </a:xfrm>
+          <a:prstGeom prst="rect">
+            <a:avLst/>
+          </a:prstGeom>
+          <a:noFill/>
+          <a:ln/>
+        </p:spPr>
+        <p:txBody>
+          <a:bodyPr wrap="square" lIns="0" tIns="0" rIns="0" bIns="0" rtlCol="0" anchor="ctr"/>
+          <a:lstStyle/>
+          <a:p>
+            <a:pPr indent="0" marL="0">
+              <a:buNone/>
+            </a:pPr>
+            <a:r>
+              <a:rPr lang="en-US" sz="1700" b="1" dirty="0">
+                <a:solidFill>
+                  <a:schemeClr val="bg1"/>
+                </a:solidFill>
+              </a:rPr>
+              <a:t>백엔드 서비스</a:t>
+            </a:r>
+            <a:endParaRPr lang="en-US" sz="1700" dirty="0"/>
+          </a:p>
+        </p:txBody>
+      </p:sp>
+      <p:sp>
+        <p:nvSpPr>
+          <p:cNvPr id="5" name="card"/>
+          <p:cNvSpPr/>
+          <p:nvPr/>
+        </p:nvSpPr>
+        <p:spPr>
+          <a:xfrm>
+            <a:off x="457200" y="1920240"/>
+            <a:ext cx="2606040" cy="1463040"/>
+          </a:xfrm>
+          <a:prstGeom prst="roundRect">
+            <a:avLst>
+              <a:gd name="adj" fmla="val 5000"/>
+            </a:avLst>
+          </a:prstGeom>
+          <a:solidFill>
+            <a:schemeClr val="bg2"/>
+          </a:solidFill>
+          <a:ln/>
+        </p:spPr>
+      </p:sp>
+      <p:sp>
+        <p:nvSpPr>
+          <p:cNvPr id="6" name="Text 4"/>
+          <p:cNvSpPr txBox="1"/>
+          <p:nvPr/>
+        </p:nvSpPr>
+        <p:spPr>
+          <a:xfrm>
+            <a:off x="640080" y="2011680"/>
+            <a:ext cx="2240280" cy="1280160"/>
+          </a:xfrm>
+          <a:prstGeom prst="rect">
+            <a:avLst/>
+          </a:prstGeom>
+          <a:noFill/>
+          <a:ln/>
+        </p:spPr>
+        <p:txBody>
+          <a:bodyPr wrap="square" lIns="0" tIns="0" rIns="0" bIns="0" rtlCol="0" anchor="t"/>
+          <a:lstStyle/>
+          <a:p>
+            <a:pPr indent="0" marL="0">
+              <a:buNone/>
+            </a:pPr>
+            <a:r>
+              <a:rPr lang="en-US" sz="1300" dirty="0">
+                <a:solidFill>
+                  <a:schemeClr val="tx1"/>
+                </a:solidFill>
+              </a:rPr>
+              <a:t>로그인 · 친구 · 채팅 · 상점 · 전적 · 매치메이킹</a:t>
+            </a:r>
+            <a:endParaRPr lang="en-US" sz="1300" dirty="0"/>
+          </a:p>
+          <a:p>
+            <a:pPr indent="0" marL="0">
+              <a:buNone/>
+            </a:pPr>
+            <a:r>
+              <a:rPr lang="en-US" sz="1100" dirty="0">
+                <a:solidFill>
+                  <a:schemeClr val="accent4"/>
+                </a:solidFill>
+              </a:rPr>
+              <a:t>일반 웹처럼, 조금 늦어도 OK</a:t>
+            </a:r>
+            <a:endParaRPr lang="en-US" sz="1300" dirty="0"/>
+          </a:p>
+        </p:txBody>
+      </p:sp>
+      <p:sp>
+        <p:nvSpPr>
+          <p:cNvPr id="7" name="gs1"/>
+          <p:cNvSpPr/>
+          <p:nvPr/>
+        </p:nvSpPr>
+        <p:spPr>
+          <a:xfrm>
+            <a:off x="3246120" y="1188720"/>
+            <a:ext cx="2606040" cy="640080"/>
+          </a:xfrm>
+          <a:prstGeom prst="roundRect">
+            <a:avLst>
+              <a:gd name="adj" fmla="val 11429"/>
+            </a:avLst>
+          </a:prstGeom>
+          <a:solidFill>
+            <a:srgbClr val="F08A3E"/>
+          </a:solidFill>
+          <a:ln/>
+        </p:spPr>
+      </p:sp>
+      <p:sp>
+        <p:nvSpPr>
+          <p:cNvPr id="8" name="Text 6"/>
+          <p:cNvSpPr txBox="1"/>
+          <p:nvPr/>
+        </p:nvSpPr>
+        <p:spPr>
+          <a:xfrm>
+            <a:off x="3429000" y="1188720"/>
+            <a:ext cx="2240280" cy="640080"/>
+          </a:xfrm>
+          <a:prstGeom prst="rect">
+            <a:avLst/>
+          </a:prstGeom>
+          <a:noFill/>
+          <a:ln/>
+        </p:spPr>
+        <p:txBody>
+          <a:bodyPr wrap="square" lIns="0" tIns="0" rIns="0" bIns="0" rtlCol="0" anchor="ctr"/>
+          <a:lstStyle/>
+          <a:p>
+            <a:pPr indent="0" marL="0">
+              <a:buNone/>
+            </a:pPr>
+            <a:r>
+              <a:rPr lang="en-US" sz="1700" b="1" dirty="0">
+                <a:solidFill>
+                  <a:schemeClr val="bg1"/>
+                </a:solidFill>
+              </a:rPr>
+              <a:t>전용 게임 서버</a:t>
+            </a:r>
+            <a:endParaRPr lang="en-US" sz="1700" dirty="0"/>
+          </a:p>
+        </p:txBody>
+      </p:sp>
+      <p:sp>
+        <p:nvSpPr>
+          <p:cNvPr id="9" name="card"/>
+          <p:cNvSpPr/>
+          <p:nvPr/>
+        </p:nvSpPr>
+        <p:spPr>
+          <a:xfrm>
+            <a:off x="3246120" y="1920240"/>
+            <a:ext cx="2606040" cy="1463040"/>
+          </a:xfrm>
+          <a:prstGeom prst="roundRect">
+            <a:avLst>
+              <a:gd name="adj" fmla="val 5000"/>
+            </a:avLst>
+          </a:prstGeom>
+          <a:solidFill>
+            <a:schemeClr val="bg2"/>
+          </a:solidFill>
+          <a:ln/>
+        </p:spPr>
+      </p:sp>
+      <p:sp>
+        <p:nvSpPr>
+          <p:cNvPr id="10" name="Text 8"/>
+          <p:cNvSpPr txBox="1"/>
+          <p:nvPr/>
+        </p:nvSpPr>
+        <p:spPr>
+          <a:xfrm>
+            <a:off x="3429000" y="2011680"/>
+            <a:ext cx="2240280" cy="1280160"/>
+          </a:xfrm>
+          <a:prstGeom prst="rect">
+            <a:avLst/>
+          </a:prstGeom>
+          <a:noFill/>
+          <a:ln/>
+        </p:spPr>
+        <p:txBody>
+          <a:bodyPr wrap="square" lIns="0" tIns="0" rIns="0" bIns="0" rtlCol="0" anchor="t"/>
+          <a:lstStyle/>
+          <a:p>
+            <a:pPr indent="0" marL="0">
+              <a:buNone/>
+            </a:pPr>
+            <a:r>
+              <a:rPr lang="en-US" sz="1300" dirty="0">
+                <a:solidFill>
+                  <a:schemeClr val="tx1"/>
+                </a:solidFill>
+              </a:rPr>
+              <a:t>한 판의 실제 게임 진행 · 서버가 모든 판정</a:t>
+            </a:r>
+            <a:endParaRPr lang="en-US" sz="1300" dirty="0"/>
+          </a:p>
+          <a:p>
+            <a:pPr indent="0" marL="0">
+              <a:buNone/>
+            </a:pPr>
+            <a:r>
+              <a:rPr lang="en-US" sz="1100" dirty="0">
+                <a:solidFill>
+                  <a:schemeClr val="accent4"/>
+                </a:solidFill>
+              </a:rPr>
+              <a:t>초당 수십~128번 계산 · UDP</a:t>
+            </a:r>
+            <a:endParaRPr lang="en-US" sz="1300" dirty="0"/>
+          </a:p>
+        </p:txBody>
+      </p:sp>
+      <p:sp>
+        <p:nvSpPr>
+          <p:cNvPr id="11" name="gs2"/>
+          <p:cNvSpPr/>
+          <p:nvPr/>
+        </p:nvSpPr>
+        <p:spPr>
+          <a:xfrm>
+            <a:off x="6035040" y="1188720"/>
+            <a:ext cx="2606040" cy="640080"/>
+          </a:xfrm>
+          <a:prstGeom prst="roundRect">
+            <a:avLst>
+              <a:gd name="adj" fmla="val 11429"/>
+            </a:avLst>
+          </a:prstGeom>
+          <a:solidFill>
+            <a:srgbClr val="2E9C8F"/>
+          </a:solidFill>
+          <a:ln/>
+        </p:spPr>
+      </p:sp>
+      <p:sp>
+        <p:nvSpPr>
+          <p:cNvPr id="12" name="Text 10"/>
+          <p:cNvSpPr txBox="1"/>
+          <p:nvPr/>
+        </p:nvSpPr>
+        <p:spPr>
+          <a:xfrm>
+            <a:off x="6217920" y="1188720"/>
+            <a:ext cx="2240280" cy="640080"/>
+          </a:xfrm>
+          <a:prstGeom prst="rect">
+            <a:avLst/>
+          </a:prstGeom>
+          <a:noFill/>
+          <a:ln/>
+        </p:spPr>
+        <p:txBody>
+          <a:bodyPr wrap="square" lIns="0" tIns="0" rIns="0" bIns="0" rtlCol="0" anchor="ctr"/>
+          <a:lstStyle/>
+          <a:p>
+            <a:pPr indent="0" marL="0">
+              <a:buNone/>
+            </a:pPr>
+            <a:r>
+              <a:rPr lang="en-US" sz="1700" b="1" dirty="0">
+                <a:solidFill>
+                  <a:schemeClr val="bg1"/>
+                </a:solidFill>
+              </a:rPr>
+              <a:t>오케스트레이션</a:t>
+            </a:r>
+            <a:endParaRPr lang="en-US" sz="1700" dirty="0"/>
+          </a:p>
+        </p:txBody>
+      </p:sp>
+      <p:sp>
+        <p:nvSpPr>
+          <p:cNvPr id="13" name="card"/>
+          <p:cNvSpPr/>
+          <p:nvPr/>
+        </p:nvSpPr>
+        <p:spPr>
+          <a:xfrm>
+            <a:off x="6035040" y="1920240"/>
+            <a:ext cx="2606040" cy="1463040"/>
+          </a:xfrm>
+          <a:prstGeom prst="roundRect">
+            <a:avLst>
+              <a:gd name="adj" fmla="val 5000"/>
+            </a:avLst>
+          </a:prstGeom>
+          <a:solidFill>
+            <a:schemeClr val="bg2"/>
+          </a:solidFill>
+          <a:ln/>
+        </p:spPr>
+      </p:sp>
+      <p:sp>
+        <p:nvSpPr>
+          <p:cNvPr id="14" name="Text 12"/>
+          <p:cNvSpPr txBox="1"/>
+          <p:nvPr/>
+        </p:nvSpPr>
+        <p:spPr>
+          <a:xfrm>
+            <a:off x="6217920" y="2011680"/>
+            <a:ext cx="2240280" cy="1280160"/>
+          </a:xfrm>
+          <a:prstGeom prst="rect">
+            <a:avLst/>
+          </a:prstGeom>
+          <a:noFill/>
+          <a:ln/>
+        </p:spPr>
+        <p:txBody>
+          <a:bodyPr wrap="square" lIns="0" tIns="0" rIns="0" bIns="0" rtlCol="0" anchor="t"/>
+          <a:lstStyle/>
+          <a:p>
+            <a:pPr indent="0" marL="0">
+              <a:buNone/>
+            </a:pPr>
+            <a:r>
+              <a:rPr lang="en-US" sz="1300" dirty="0">
+                <a:solidFill>
+                  <a:schemeClr val="tx1"/>
+                </a:solidFill>
+              </a:rPr>
+              <a:t>필요한 만큼 게임 서버 켜고 끄고 배정</a:t>
+            </a:r>
+            <a:endParaRPr lang="en-US" sz="1300" dirty="0"/>
+          </a:p>
+          <a:p>
+            <a:pPr indent="0" marL="0">
+              <a:buNone/>
+            </a:pPr>
+            <a:r>
+              <a:rPr lang="en-US" sz="1100" dirty="0">
+                <a:solidFill>
+                  <a:schemeClr val="accent4"/>
+                </a:solidFill>
+              </a:rPr>
+              <a:t>Agones · GameLift 등</a:t>
+            </a:r>
+            <a:endParaRPr lang="en-US" sz="1300" dirty="0"/>
+          </a:p>
+        </p:txBody>
+      </p:sp>
+      <p:sp>
+        <p:nvSpPr>
+          <p:cNvPr id="15" name="Text 13"/>
+          <p:cNvSpPr txBox="1"/>
+          <p:nvPr/>
+        </p:nvSpPr>
+        <p:spPr>
+          <a:xfrm>
+            <a:off x="457200" y="3611880"/>
+            <a:ext cx="8229600" cy="731520"/>
+          </a:xfrm>
+          <a:prstGeom prst="rect">
+            <a:avLst/>
+          </a:prstGeom>
+          <a:noFill/>
+          <a:ln/>
+        </p:spPr>
+        <p:txBody>
+          <a:bodyPr wrap="square" lIns="0" tIns="0" rIns="0" bIns="0" rtlCol="0" anchor="t"/>
+          <a:lstStyle/>
+          <a:p>
+            <a:pPr indent="0" marL="0">
+              <a:buNone/>
+            </a:pPr>
+            <a:r>
+              <a:rPr lang="en-US" sz="1300" b="1" dirty="0">
+                <a:solidFill>
+                  <a:schemeClr val="accent2"/>
+                </a:solidFill>
+              </a:rPr>
+              <a:t>틱 레이트는 비용  </a:t>
+            </a:r>
+            <a:pPr indent="0" marL="0">
+              <a:buNone/>
+            </a:pPr>
+            <a:r>
+              <a:rPr lang="en-US" sz="1300" dirty="0">
+                <a:solidFill>
+                  <a:schemeClr val="tx1"/>
+                </a:solidFill>
+              </a:rPr>
+              <a:t>발로란트 128틱 = 7.8ms마다 계산 · 틱을 2배로 = 서버 비용도 약 2배</a:t>
+            </a:r>
+            <a:endParaRPr lang="en-US" sz="1300" dirty="0"/>
+          </a:p>
+        </p:txBody>
+      </p:sp>
+      <p:sp>
+        <p:nvSpPr>
+          <p:cNvPr id="25" name="Slide Number Placeholder 0"/>
+          <p:cNvSpPr>
+            <a:spLocks noGrp="1"/>
+          </p:cNvSpPr>
+          <p:nvPr>
+            <p:ph type="sldNum" sz="quarter" idx="4294967295"/>
+          </p:nvPr>
+        </p:nvSpPr>
+        <p:spPr>
+          <a:xfrm>
+            <a:off x="8321040" y="4754880"/>
+            <a:ext cx="457200" cy="274320"/>
+          </a:xfrm>
+          <a:prstGeom prst="rect">
+            <a:avLst/>
+          </a:prstGeom>
+          <a:extLst>
+            <a:ext uri="{C572A759-6A51-4108-AA02-DFA0A04FC94B}">
+              <ma14:wrappingTextBoxFlag xmlns:ma14="http://schemas.microsoft.com/office/mac/drawingml/2011/main" val="0"/>
+            </a:ext>
+          </a:extLst>
+        </p:spPr>
+        <p:txBody>
+          <a:bodyPr/>
+          <a:lstStyle>
+            <a:lvl1pPr>
+              <a:defRPr sz="1000">
+                <a:solidFill>
+                  <a:schemeClr val="accent4"/>
+                </a:solidFill>
+              </a:defRPr>
+            </a:lvl1pPr>
+          </a:lstStyle>
+          <a:p>
+            <a:pPr algn="r"/>
+            <a:fld id="{F7021451-1387-4CA6-816F-3879F97B5CBC}" type="slidenum">
+              <a:rPr b="0" lang="en-US"/>
+              <a:t>63</a:t>
+            </a:fld>
+            <a:endParaRPr lang="en-US"/>
+          </a:p>
+        </p:txBody>
+      </p:sp>
+    </p:spTree>
+  </p:cSld>
+  <p:clrMapOvr>
+    <a:masterClrMapping/>
+  </p:clrMapOvr>
+</p:sld>
+</file>
+
+<file path=ppt/slides/slide64.xml><?xml version="1.0" encoding="utf-8"?>
+<p:sld xmlns:a="http://schemas.openxmlformats.org/drawingml/2006/main" xmlns:r="http://schemas.openxmlformats.org/officeDocument/2006/relationships" xmlns:p="http://schemas.openxmlformats.org/presentationml/2006/main">
+  <p:cSld name="Slide 64">
+    <p:spTree>
+      <p:nvGrpSpPr>
+        <p:cNvPr id="1" name=""/>
+        <p:cNvGrpSpPr/>
+        <p:nvPr/>
+      </p:nvGrpSpPr>
+      <p:grpSpPr>
+        <a:xfrm>
+          <a:off x="0" y="0"/>
+          <a:ext cx="0" cy="0"/>
+          <a:chOff x="0" y="0"/>
+          <a:chExt cx="0" cy="0"/>
+        </a:xfrm>
+      </p:grpSpPr>
+      <p:sp>
+        <p:nvSpPr>
+          <p:cNvPr id="2" name="Text 0"/>
+          <p:cNvSpPr/>
+          <p:nvPr>
+            <p:ph idx="100" type="title" hasCustomPrompt="1"/>
+          </p:nvPr>
+        </p:nvSpPr>
+        <p:spPr>
+          <a:xfrm>
+            <a:off x="457200" y="274320"/>
+            <a:ext cx="8229600" cy="685800"/>
+          </a:xfrm>
+          <a:prstGeom prst="rect">
+            <a:avLst/>
+          </a:prstGeom>
+          <a:noFill/>
+          <a:ln/>
+        </p:spPr>
+        <p:txBody>
+          <a:bodyPr wrap="square" lIns="0" tIns="0" rIns="0" bIns="0" rtlCol="0" anchor="ctr"/>
+          <a:lstStyle/>
+          <a:p>
+            <a:pPr indent="0" marL="0">
+              <a:buNone/>
+            </a:pPr>
+            <a:r>
+              <a:rPr lang="en-US" sz="2800" b="1" dirty="0">
+                <a:solidFill>
+                  <a:schemeClr val="tx2"/>
+                </a:solidFill>
+              </a:rPr>
+              <a:t>지연을 숨기는 4가지 기술</a:t>
+            </a:r>
+            <a:endParaRPr lang="en-US" sz="2800" dirty="0"/>
+          </a:p>
+        </p:txBody>
+      </p:sp>
+      <p:sp>
+        <p:nvSpPr>
+          <p:cNvPr id="3" name="card"/>
+          <p:cNvSpPr/>
+          <p:nvPr/>
+        </p:nvSpPr>
+        <p:spPr>
+          <a:xfrm>
+            <a:off x="457200" y="1188720"/>
+            <a:ext cx="4023360" cy="1005840"/>
+          </a:xfrm>
+          <a:prstGeom prst="roundRect">
+            <a:avLst>
+              <a:gd name="adj" fmla="val 7273"/>
+            </a:avLst>
+          </a:prstGeom>
+          <a:solidFill>
+            <a:schemeClr val="bg2"/>
+          </a:solidFill>
+          <a:ln/>
+        </p:spPr>
+      </p:sp>
+      <p:sp>
+        <p:nvSpPr>
+          <p:cNvPr id="4" name="badge1"/>
+          <p:cNvSpPr/>
+          <p:nvPr/>
+        </p:nvSpPr>
+        <p:spPr>
+          <a:xfrm>
+            <a:off x="640080" y="1490472"/>
+            <a:ext cx="384048" cy="384048"/>
+          </a:xfrm>
+          <a:prstGeom prst="ellipse">
+            <a:avLst/>
+          </a:prstGeom>
+          <a:solidFill>
+            <a:schemeClr val="accent2"/>
+          </a:solidFill>
+          <a:ln/>
+        </p:spPr>
+      </p:sp>
+      <p:sp>
+        <p:nvSpPr>
+          <p:cNvPr id="5" name="Text 3"/>
+          <p:cNvSpPr txBox="1"/>
+          <p:nvPr/>
+        </p:nvSpPr>
+        <p:spPr>
+          <a:xfrm>
+            <a:off x="640080" y="1490472"/>
+            <a:ext cx="384048" cy="384048"/>
+          </a:xfrm>
+          <a:prstGeom prst="rect">
+            <a:avLst/>
+          </a:prstGeom>
+          <a:noFill/>
+          <a:ln/>
+        </p:spPr>
+        <p:txBody>
+          <a:bodyPr wrap="square" lIns="0" tIns="0" rIns="0" bIns="0" rtlCol="0" anchor="ctr"/>
+          <a:lstStyle/>
+          <a:p>
+            <a:pPr algn="ctr" indent="0" marL="0">
+              <a:buNone/>
+            </a:pPr>
+            <a:r>
+              <a:rPr lang="en-US" sz="1400" b="1" dirty="0">
+                <a:solidFill>
+                  <a:schemeClr val="bg1"/>
+                </a:solidFill>
+              </a:rPr>
+              <a:t>1</a:t>
+            </a:r>
+            <a:endParaRPr lang="en-US" sz="1400" dirty="0"/>
+          </a:p>
+        </p:txBody>
+      </p:sp>
+      <p:sp>
+        <p:nvSpPr>
+          <p:cNvPr id="6" name="Text 4"/>
+          <p:cNvSpPr txBox="1"/>
+          <p:nvPr/>
+        </p:nvSpPr>
+        <p:spPr>
+          <a:xfrm>
+            <a:off x="1188720" y="1188720"/>
+            <a:ext cx="3200400" cy="1005840"/>
+          </a:xfrm>
+          <a:prstGeom prst="rect">
+            <a:avLst/>
+          </a:prstGeom>
+          <a:noFill/>
+          <a:ln/>
+        </p:spPr>
+        <p:txBody>
+          <a:bodyPr wrap="square" lIns="0" tIns="0" rIns="0" bIns="0" rtlCol="0" anchor="ctr"/>
+          <a:lstStyle/>
+          <a:p>
+            <a:pPr indent="0" marL="0">
+              <a:buNone/>
+            </a:pPr>
+            <a:r>
+              <a:rPr lang="en-US" sz="1500" b="1" dirty="0">
+                <a:solidFill>
+                  <a:schemeClr val="tx1"/>
+                </a:solidFill>
+              </a:rPr>
+              <a:t>클라이언트 예측</a:t>
+            </a:r>
+            <a:endParaRPr lang="en-US" sz="1500" dirty="0"/>
+          </a:p>
+          <a:p>
+            <a:pPr indent="0" marL="0">
+              <a:buNone/>
+            </a:pPr>
+            <a:r>
+              <a:rPr lang="en-US" sz="1200" dirty="0">
+                <a:solidFill>
+                  <a:schemeClr val="accent4"/>
+                </a:solidFill>
+              </a:rPr>
+              <a:t>내 입력을 서버 답 전에 화면에 바로 반영</a:t>
+            </a:r>
+            <a:endParaRPr lang="en-US" sz="1500" dirty="0"/>
+          </a:p>
+        </p:txBody>
+      </p:sp>
+      <p:sp>
+        <p:nvSpPr>
+          <p:cNvPr id="7" name="card"/>
+          <p:cNvSpPr/>
+          <p:nvPr/>
+        </p:nvSpPr>
+        <p:spPr>
+          <a:xfrm>
+            <a:off x="4663440" y="1188720"/>
+            <a:ext cx="4023360" cy="1005840"/>
+          </a:xfrm>
+          <a:prstGeom prst="roundRect">
+            <a:avLst>
+              <a:gd name="adj" fmla="val 7273"/>
+            </a:avLst>
+          </a:prstGeom>
+          <a:solidFill>
+            <a:schemeClr val="bg2"/>
+          </a:solidFill>
+          <a:ln/>
+        </p:spPr>
+      </p:sp>
+      <p:sp>
+        <p:nvSpPr>
+          <p:cNvPr id="8" name="badge2"/>
+          <p:cNvSpPr/>
+          <p:nvPr/>
+        </p:nvSpPr>
+        <p:spPr>
+          <a:xfrm>
+            <a:off x="4846320" y="1490472"/>
+            <a:ext cx="384048" cy="384048"/>
+          </a:xfrm>
+          <a:prstGeom prst="ellipse">
+            <a:avLst/>
+          </a:prstGeom>
+          <a:solidFill>
+            <a:schemeClr val="accent2"/>
+          </a:solidFill>
+          <a:ln/>
+        </p:spPr>
+      </p:sp>
+      <p:sp>
+        <p:nvSpPr>
+          <p:cNvPr id="9" name="Text 7"/>
+          <p:cNvSpPr txBox="1"/>
+          <p:nvPr/>
+        </p:nvSpPr>
+        <p:spPr>
+          <a:xfrm>
+            <a:off x="4846320" y="1490472"/>
+            <a:ext cx="384048" cy="384048"/>
+          </a:xfrm>
+          <a:prstGeom prst="rect">
+            <a:avLst/>
+          </a:prstGeom>
+          <a:noFill/>
+          <a:ln/>
+        </p:spPr>
+        <p:txBody>
+          <a:bodyPr wrap="square" lIns="0" tIns="0" rIns="0" bIns="0" rtlCol="0" anchor="ctr"/>
+          <a:lstStyle/>
+          <a:p>
+            <a:pPr algn="ctr" indent="0" marL="0">
+              <a:buNone/>
+            </a:pPr>
+            <a:r>
+              <a:rPr lang="en-US" sz="1400" b="1" dirty="0">
+                <a:solidFill>
+                  <a:schemeClr val="bg1"/>
+                </a:solidFill>
+              </a:rPr>
+              <a:t>2</a:t>
+            </a:r>
+            <a:endParaRPr lang="en-US" sz="1400" dirty="0"/>
+          </a:p>
+        </p:txBody>
+      </p:sp>
+      <p:sp>
+        <p:nvSpPr>
+          <p:cNvPr id="10" name="Text 8"/>
+          <p:cNvSpPr txBox="1"/>
+          <p:nvPr/>
+        </p:nvSpPr>
+        <p:spPr>
+          <a:xfrm>
+            <a:off x="5394960" y="1188720"/>
+            <a:ext cx="3200400" cy="1005840"/>
+          </a:xfrm>
+          <a:prstGeom prst="rect">
+            <a:avLst/>
+          </a:prstGeom>
+          <a:noFill/>
+          <a:ln/>
+        </p:spPr>
+        <p:txBody>
+          <a:bodyPr wrap="square" lIns="0" tIns="0" rIns="0" bIns="0" rtlCol="0" anchor="ctr"/>
+          <a:lstStyle/>
+          <a:p>
+            <a:pPr indent="0" marL="0">
+              <a:buNone/>
+            </a:pPr>
+            <a:r>
+              <a:rPr lang="en-US" sz="1500" b="1" dirty="0">
+                <a:solidFill>
+                  <a:schemeClr val="tx1"/>
+                </a:solidFill>
+              </a:rPr>
+              <a:t>서버 보정</a:t>
+            </a:r>
+            <a:endParaRPr lang="en-US" sz="1500" dirty="0"/>
+          </a:p>
+          <a:p>
+            <a:pPr indent="0" marL="0">
+              <a:buNone/>
+            </a:pPr>
+            <a:r>
+              <a:rPr lang="en-US" sz="1200" dirty="0">
+                <a:solidFill>
+                  <a:schemeClr val="accent4"/>
+                </a:solidFill>
+              </a:rPr>
+              <a:t>서버 결과와 다르면 맞추고 남은 입력 다시 적용</a:t>
+            </a:r>
+            <a:endParaRPr lang="en-US" sz="1500" dirty="0"/>
+          </a:p>
+        </p:txBody>
+      </p:sp>
+      <p:sp>
+        <p:nvSpPr>
+          <p:cNvPr id="11" name="card"/>
+          <p:cNvSpPr/>
+          <p:nvPr/>
+        </p:nvSpPr>
+        <p:spPr>
+          <a:xfrm>
+            <a:off x="457200" y="2331720"/>
+            <a:ext cx="4023360" cy="1005840"/>
+          </a:xfrm>
+          <a:prstGeom prst="roundRect">
+            <a:avLst>
+              <a:gd name="adj" fmla="val 7273"/>
+            </a:avLst>
+          </a:prstGeom>
+          <a:solidFill>
+            <a:schemeClr val="bg2"/>
+          </a:solidFill>
+          <a:ln/>
+        </p:spPr>
+      </p:sp>
+      <p:sp>
+        <p:nvSpPr>
+          <p:cNvPr id="12" name="badge3"/>
+          <p:cNvSpPr/>
+          <p:nvPr/>
+        </p:nvSpPr>
+        <p:spPr>
+          <a:xfrm>
+            <a:off x="640080" y="2633472"/>
+            <a:ext cx="384048" cy="384048"/>
+          </a:xfrm>
+          <a:prstGeom prst="ellipse">
+            <a:avLst/>
+          </a:prstGeom>
+          <a:solidFill>
+            <a:schemeClr val="accent2"/>
+          </a:solidFill>
+          <a:ln/>
+        </p:spPr>
+      </p:sp>
+      <p:sp>
+        <p:nvSpPr>
+          <p:cNvPr id="13" name="Text 11"/>
+          <p:cNvSpPr txBox="1"/>
+          <p:nvPr/>
+        </p:nvSpPr>
+        <p:spPr>
+          <a:xfrm>
+            <a:off x="640080" y="2633472"/>
+            <a:ext cx="384048" cy="384048"/>
+          </a:xfrm>
+          <a:prstGeom prst="rect">
+            <a:avLst/>
+          </a:prstGeom>
+          <a:noFill/>
+          <a:ln/>
+        </p:spPr>
+        <p:txBody>
+          <a:bodyPr wrap="square" lIns="0" tIns="0" rIns="0" bIns="0" rtlCol="0" anchor="ctr"/>
+          <a:lstStyle/>
+          <a:p>
+            <a:pPr algn="ctr" indent="0" marL="0">
+              <a:buNone/>
+            </a:pPr>
+            <a:r>
+              <a:rPr lang="en-US" sz="1400" b="1" dirty="0">
+                <a:solidFill>
+                  <a:schemeClr val="bg1"/>
+                </a:solidFill>
+              </a:rPr>
+              <a:t>3</a:t>
+            </a:r>
+            <a:endParaRPr lang="en-US" sz="1400" dirty="0"/>
+          </a:p>
+        </p:txBody>
+      </p:sp>
+      <p:sp>
+        <p:nvSpPr>
+          <p:cNvPr id="14" name="Text 12"/>
+          <p:cNvSpPr txBox="1"/>
+          <p:nvPr/>
+        </p:nvSpPr>
+        <p:spPr>
+          <a:xfrm>
+            <a:off x="1188720" y="2331720"/>
+            <a:ext cx="3200400" cy="1005840"/>
+          </a:xfrm>
+          <a:prstGeom prst="rect">
+            <a:avLst/>
+          </a:prstGeom>
+          <a:noFill/>
+          <a:ln/>
+        </p:spPr>
+        <p:txBody>
+          <a:bodyPr wrap="square" lIns="0" tIns="0" rIns="0" bIns="0" rtlCol="0" anchor="ctr"/>
+          <a:lstStyle/>
+          <a:p>
+            <a:pPr indent="0" marL="0">
+              <a:buNone/>
+            </a:pPr>
+            <a:r>
+              <a:rPr lang="en-US" sz="1500" b="1" dirty="0">
+                <a:solidFill>
+                  <a:schemeClr val="tx1"/>
+                </a:solidFill>
+              </a:rPr>
+              <a:t>엔티티 보간</a:t>
+            </a:r>
+            <a:endParaRPr lang="en-US" sz="1500" dirty="0"/>
+          </a:p>
+          <a:p>
+            <a:pPr indent="0" marL="0">
+              <a:buNone/>
+            </a:pPr>
+            <a:r>
+              <a:rPr lang="en-US" sz="1200" dirty="0">
+                <a:solidFill>
+                  <a:schemeClr val="accent4"/>
+                </a:solidFill>
+              </a:rPr>
+              <a:t>다른 플레이어는 약간 과거 위치를 부드럽게</a:t>
+            </a:r>
+            <a:endParaRPr lang="en-US" sz="1500" dirty="0"/>
+          </a:p>
+        </p:txBody>
+      </p:sp>
+      <p:sp>
+        <p:nvSpPr>
+          <p:cNvPr id="15" name="card"/>
+          <p:cNvSpPr/>
+          <p:nvPr/>
+        </p:nvSpPr>
+        <p:spPr>
+          <a:xfrm>
+            <a:off x="4663440" y="2331720"/>
+            <a:ext cx="4023360" cy="1005840"/>
+          </a:xfrm>
+          <a:prstGeom prst="roundRect">
+            <a:avLst>
+              <a:gd name="adj" fmla="val 7273"/>
+            </a:avLst>
+          </a:prstGeom>
+          <a:solidFill>
+            <a:schemeClr val="bg2"/>
+          </a:solidFill>
+          <a:ln/>
+        </p:spPr>
+      </p:sp>
+      <p:sp>
+        <p:nvSpPr>
+          <p:cNvPr id="16" name="badge4"/>
+          <p:cNvSpPr/>
+          <p:nvPr/>
+        </p:nvSpPr>
+        <p:spPr>
+          <a:xfrm>
+            <a:off x="4846320" y="2633472"/>
+            <a:ext cx="384048" cy="384048"/>
+          </a:xfrm>
+          <a:prstGeom prst="ellipse">
+            <a:avLst/>
+          </a:prstGeom>
+          <a:solidFill>
+            <a:schemeClr val="accent2"/>
+          </a:solidFill>
+          <a:ln/>
+        </p:spPr>
+      </p:sp>
+      <p:sp>
+        <p:nvSpPr>
+          <p:cNvPr id="17" name="Text 15"/>
+          <p:cNvSpPr txBox="1"/>
+          <p:nvPr/>
+        </p:nvSpPr>
+        <p:spPr>
+          <a:xfrm>
+            <a:off x="4846320" y="2633472"/>
+            <a:ext cx="384048" cy="384048"/>
+          </a:xfrm>
+          <a:prstGeom prst="rect">
+            <a:avLst/>
+          </a:prstGeom>
+          <a:noFill/>
+          <a:ln/>
+        </p:spPr>
+        <p:txBody>
+          <a:bodyPr wrap="square" lIns="0" tIns="0" rIns="0" bIns="0" rtlCol="0" anchor="ctr"/>
+          <a:lstStyle/>
+          <a:p>
+            <a:pPr algn="ctr" indent="0" marL="0">
+              <a:buNone/>
+            </a:pPr>
+            <a:r>
+              <a:rPr lang="en-US" sz="1400" b="1" dirty="0">
+                <a:solidFill>
+                  <a:schemeClr val="bg1"/>
+                </a:solidFill>
+              </a:rPr>
+              <a:t>4</a:t>
+            </a:r>
+            <a:endParaRPr lang="en-US" sz="1400" dirty="0"/>
+          </a:p>
+        </p:txBody>
+      </p:sp>
+      <p:sp>
+        <p:nvSpPr>
+          <p:cNvPr id="18" name="Text 16"/>
+          <p:cNvSpPr txBox="1"/>
+          <p:nvPr/>
+        </p:nvSpPr>
+        <p:spPr>
+          <a:xfrm>
+            <a:off x="5394960" y="2331720"/>
+            <a:ext cx="3200400" cy="1005840"/>
+          </a:xfrm>
+          <a:prstGeom prst="rect">
+            <a:avLst/>
+          </a:prstGeom>
+          <a:noFill/>
+          <a:ln/>
+        </p:spPr>
+        <p:txBody>
+          <a:bodyPr wrap="square" lIns="0" tIns="0" rIns="0" bIns="0" rtlCol="0" anchor="ctr"/>
+          <a:lstStyle/>
+          <a:p>
+            <a:pPr indent="0" marL="0">
+              <a:buNone/>
+            </a:pPr>
+            <a:r>
+              <a:rPr lang="en-US" sz="1500" b="1" dirty="0">
+                <a:solidFill>
+                  <a:schemeClr val="tx1"/>
+                </a:solidFill>
+              </a:rPr>
+              <a:t>지연 보상</a:t>
+            </a:r>
+            <a:endParaRPr lang="en-US" sz="1500" dirty="0"/>
+          </a:p>
+          <a:p>
+            <a:pPr indent="0" marL="0">
+              <a:buNone/>
+            </a:pPr>
+            <a:r>
+              <a:rPr lang="en-US" sz="1200" dirty="0">
+                <a:solidFill>
+                  <a:schemeClr val="accent4"/>
+                </a:solidFill>
+              </a:rPr>
+              <a:t>쏜 순간으로 시간을 되감아 명중 판정</a:t>
+            </a:r>
+            <a:endParaRPr lang="en-US" sz="1500" dirty="0"/>
+          </a:p>
+        </p:txBody>
+      </p:sp>
+      <p:sp>
+        <p:nvSpPr>
+          <p:cNvPr id="19" name="Text 17"/>
+          <p:cNvSpPr txBox="1"/>
+          <p:nvPr/>
+        </p:nvSpPr>
+        <p:spPr>
+          <a:xfrm>
+            <a:off x="457200" y="3611880"/>
+            <a:ext cx="8229600" cy="731520"/>
+          </a:xfrm>
+          <a:prstGeom prst="rect">
+            <a:avLst/>
+          </a:prstGeom>
+          <a:noFill/>
+          <a:ln/>
+        </p:spPr>
+        <p:txBody>
+          <a:bodyPr wrap="square" lIns="0" tIns="0" rIns="0" bIns="0" rtlCol="0" anchor="t"/>
+          <a:lstStyle/>
+          <a:p>
+            <a:pPr indent="0" marL="0">
+              <a:buNone/>
+            </a:pPr>
+            <a:r>
+              <a:rPr lang="en-US" sz="1300" b="1" dirty="0">
+                <a:solidFill>
+                  <a:schemeClr val="tx2"/>
+                </a:solidFill>
+              </a:rPr>
+              <a:t>기본 원칙  </a:t>
+            </a:r>
+            <a:pPr indent="0" marL="0">
+              <a:buNone/>
+            </a:pPr>
+            <a:r>
+              <a:rPr lang="en-US" sz="1300" dirty="0">
+                <a:solidFill>
+                  <a:schemeClr val="tx1"/>
+                </a:solidFill>
+              </a:rPr>
+              <a:t>서버 권위 — 클라이언트는 입력만 보내고 판정은 서버가 · 격투 게임은 롤백 넷코드, MOBA는 결정론적 시뮬레이션</a:t>
+            </a:r>
+            <a:endParaRPr lang="en-US" sz="1300" dirty="0"/>
+          </a:p>
+        </p:txBody>
+      </p:sp>
+      <p:sp>
+        <p:nvSpPr>
+          <p:cNvPr id="25" name="Slide Number Placeholder 0"/>
+          <p:cNvSpPr>
+            <a:spLocks noGrp="1"/>
+          </p:cNvSpPr>
+          <p:nvPr>
+            <p:ph type="sldNum" sz="quarter" idx="4294967295"/>
+          </p:nvPr>
+        </p:nvSpPr>
+        <p:spPr>
+          <a:xfrm>
+            <a:off x="8321040" y="4754880"/>
+            <a:ext cx="457200" cy="274320"/>
+          </a:xfrm>
+          <a:prstGeom prst="rect">
+            <a:avLst/>
+          </a:prstGeom>
+          <a:extLst>
+            <a:ext uri="{C572A759-6A51-4108-AA02-DFA0A04FC94B}">
+              <ma14:wrappingTextBoxFlag xmlns:ma14="http://schemas.microsoft.com/office/mac/drawingml/2011/main" val="0"/>
+            </a:ext>
+          </a:extLst>
+        </p:spPr>
+        <p:txBody>
+          <a:bodyPr/>
+          <a:lstStyle>
+            <a:lvl1pPr>
+              <a:defRPr sz="1000">
+                <a:solidFill>
+                  <a:schemeClr val="accent4"/>
+                </a:solidFill>
+              </a:defRPr>
+            </a:lvl1pPr>
+          </a:lstStyle>
+          <a:p>
+            <a:pPr algn="r"/>
+            <a:fld id="{F7021451-1387-4CA6-816F-3879F97B5CBC}" type="slidenum">
+              <a:rPr b="0" lang="en-US"/>
+              <a:t>64</a:t>
+            </a:fld>
+            <a:endParaRPr lang="en-US"/>
+          </a:p>
+        </p:txBody>
+      </p:sp>
+    </p:spTree>
+  </p:cSld>
+  <p:clrMapOvr>
+    <a:masterClrMapping/>
+  </p:clrMapOvr>
+</p:sld>
+</file>
+
+<file path=ppt/slides/slide65.xml><?xml version="1.0" encoding="utf-8"?>
+<p:sld xmlns:a="http://schemas.openxmlformats.org/drawingml/2006/main" xmlns:r="http://schemas.openxmlformats.org/officeDocument/2006/relationships" xmlns:p="http://schemas.openxmlformats.org/presentationml/2006/main">
+  <p:cSld name="Slide 65">
+    <p:spTree>
+      <p:nvGrpSpPr>
+        <p:cNvPr id="1" name=""/>
+        <p:cNvGrpSpPr/>
+        <p:nvPr/>
+      </p:nvGrpSpPr>
+      <p:grpSpPr>
+        <a:xfrm>
+          <a:off x="0" y="0"/>
+          <a:ext cx="0" cy="0"/>
+          <a:chOff x="0" y="0"/>
+          <a:chExt cx="0" cy="0"/>
+        </a:xfrm>
+      </p:grpSpPr>
+      <p:sp>
+        <p:nvSpPr>
+          <p:cNvPr id="2" name="Text 0"/>
+          <p:cNvSpPr/>
+          <p:nvPr>
+            <p:ph idx="100" type="title" hasCustomPrompt="1"/>
+          </p:nvPr>
+        </p:nvSpPr>
+        <p:spPr>
+          <a:xfrm>
+            <a:off x="457200" y="274320"/>
+            <a:ext cx="8229600" cy="685800"/>
+          </a:xfrm>
+          <a:prstGeom prst="rect">
+            <a:avLst/>
+          </a:prstGeom>
+          <a:noFill/>
+          <a:ln/>
+        </p:spPr>
+        <p:txBody>
+          <a:bodyPr wrap="square" lIns="0" tIns="0" rIns="0" bIns="0" rtlCol="0" anchor="ctr"/>
+          <a:lstStyle/>
+          <a:p>
+            <a:pPr indent="0" marL="0">
+              <a:buNone/>
+            </a:pPr>
+            <a:r>
+              <a:rPr lang="en-US" sz="2800" b="1" dirty="0">
+                <a:solidFill>
+                  <a:schemeClr val="tx2"/>
+                </a:solidFill>
+              </a:rPr>
+              <a:t>어뷰징·핵: 4단계로 대응</a:t>
+            </a:r>
+            <a:endParaRPr lang="en-US" sz="2800" dirty="0"/>
+          </a:p>
+        </p:txBody>
+      </p:sp>
+      <p:sp>
+        <p:nvSpPr>
+          <p:cNvPr id="3" name="ab0"/>
+          <p:cNvSpPr/>
+          <p:nvPr/>
+        </p:nvSpPr>
+        <p:spPr>
+          <a:xfrm>
+            <a:off x="457200" y="1188720"/>
+            <a:ext cx="1920240" cy="548640"/>
+          </a:xfrm>
+          <a:prstGeom prst="roundRect">
+            <a:avLst>
+              <a:gd name="adj" fmla="val 13333"/>
+            </a:avLst>
+          </a:prstGeom>
+          <a:solidFill>
+            <a:srgbClr val="F08A3E"/>
+          </a:solidFill>
+          <a:ln/>
+        </p:spPr>
+      </p:sp>
+      <p:sp>
+        <p:nvSpPr>
+          <p:cNvPr id="4" name="Text 2"/>
+          <p:cNvSpPr txBox="1"/>
+          <p:nvPr/>
+        </p:nvSpPr>
+        <p:spPr>
+          <a:xfrm>
+            <a:off x="457200" y="1188720"/>
+            <a:ext cx="1920240" cy="548640"/>
+          </a:xfrm>
+          <a:prstGeom prst="rect">
+            <a:avLst/>
+          </a:prstGeom>
+          <a:noFill/>
+          <a:ln/>
+        </p:spPr>
+        <p:txBody>
+          <a:bodyPr wrap="square" lIns="0" tIns="0" rIns="0" bIns="0" rtlCol="0" anchor="ctr"/>
+          <a:lstStyle/>
+          <a:p>
+            <a:pPr algn="ctr" indent="0" marL="0">
+              <a:buNone/>
+            </a:pPr>
+            <a:r>
+              <a:rPr lang="en-US" sz="1400" b="1" dirty="0">
+                <a:solidFill>
+                  <a:schemeClr val="bg1"/>
+                </a:solidFill>
+              </a:rPr>
+              <a:t>1. 설계로 막기</a:t>
+            </a:r>
+            <a:endParaRPr lang="en-US" sz="1400" dirty="0"/>
+          </a:p>
+        </p:txBody>
+      </p:sp>
+      <p:sp>
+        <p:nvSpPr>
+          <p:cNvPr id="5" name="ab1"/>
+          <p:cNvSpPr/>
+          <p:nvPr/>
+        </p:nvSpPr>
+        <p:spPr>
+          <a:xfrm>
+            <a:off x="2560320" y="1188720"/>
+            <a:ext cx="1920240" cy="548640"/>
+          </a:xfrm>
+          <a:prstGeom prst="roundRect">
+            <a:avLst>
+              <a:gd name="adj" fmla="val 13333"/>
+            </a:avLst>
+          </a:prstGeom>
+          <a:solidFill>
+            <a:srgbClr val="1F4E4A"/>
+          </a:solidFill>
+          <a:ln/>
+        </p:spPr>
+      </p:sp>
+      <p:sp>
+        <p:nvSpPr>
+          <p:cNvPr id="6" name="Text 4"/>
+          <p:cNvSpPr txBox="1"/>
+          <p:nvPr/>
+        </p:nvSpPr>
+        <p:spPr>
+          <a:xfrm>
+            <a:off x="2560320" y="1188720"/>
+            <a:ext cx="1920240" cy="548640"/>
+          </a:xfrm>
+          <a:prstGeom prst="rect">
+            <a:avLst/>
+          </a:prstGeom>
+          <a:noFill/>
+          <a:ln/>
+        </p:spPr>
+        <p:txBody>
+          <a:bodyPr wrap="square" lIns="0" tIns="0" rIns="0" bIns="0" rtlCol="0" anchor="ctr"/>
+          <a:lstStyle/>
+          <a:p>
+            <a:pPr algn="ctr" indent="0" marL="0">
+              <a:buNone/>
+            </a:pPr>
+            <a:r>
+              <a:rPr lang="en-US" sz="1400" b="1" dirty="0">
+                <a:solidFill>
+                  <a:schemeClr val="bg1"/>
+                </a:solidFill>
+              </a:rPr>
+              <a:t>2. 입구에서 막기</a:t>
+            </a:r>
+            <a:endParaRPr lang="en-US" sz="1400" dirty="0"/>
+          </a:p>
+        </p:txBody>
+      </p:sp>
+      <p:sp>
+        <p:nvSpPr>
+          <p:cNvPr id="7" name="ab2"/>
+          <p:cNvSpPr/>
+          <p:nvPr/>
+        </p:nvSpPr>
+        <p:spPr>
+          <a:xfrm>
+            <a:off x="4663440" y="1188720"/>
+            <a:ext cx="1920240" cy="548640"/>
+          </a:xfrm>
+          <a:prstGeom prst="roundRect">
+            <a:avLst>
+              <a:gd name="adj" fmla="val 13333"/>
+            </a:avLst>
+          </a:prstGeom>
+          <a:solidFill>
+            <a:srgbClr val="1F4E4A"/>
+          </a:solidFill>
+          <a:ln/>
+        </p:spPr>
+      </p:sp>
+      <p:sp>
+        <p:nvSpPr>
+          <p:cNvPr id="8" name="Text 6"/>
+          <p:cNvSpPr txBox="1"/>
+          <p:nvPr/>
+        </p:nvSpPr>
+        <p:spPr>
+          <a:xfrm>
+            <a:off x="4663440" y="1188720"/>
+            <a:ext cx="1920240" cy="548640"/>
+          </a:xfrm>
+          <a:prstGeom prst="rect">
+            <a:avLst/>
+          </a:prstGeom>
+          <a:noFill/>
+          <a:ln/>
+        </p:spPr>
+        <p:txBody>
+          <a:bodyPr wrap="square" lIns="0" tIns="0" rIns="0" bIns="0" rtlCol="0" anchor="ctr"/>
+          <a:lstStyle/>
+          <a:p>
+            <a:pPr algn="ctr" indent="0" marL="0">
+              <a:buNone/>
+            </a:pPr>
+            <a:r>
+              <a:rPr lang="en-US" sz="1400" b="1" dirty="0">
+                <a:solidFill>
+                  <a:schemeClr val="bg1"/>
+                </a:solidFill>
+              </a:rPr>
+              <a:t>3. 운영 중 찾기</a:t>
+            </a:r>
+            <a:endParaRPr lang="en-US" sz="1400" dirty="0"/>
+          </a:p>
+        </p:txBody>
+      </p:sp>
+      <p:sp>
+        <p:nvSpPr>
+          <p:cNvPr id="9" name="ab3"/>
+          <p:cNvSpPr/>
+          <p:nvPr/>
+        </p:nvSpPr>
+        <p:spPr>
+          <a:xfrm>
+            <a:off x="6766560" y="1188720"/>
+            <a:ext cx="1920240" cy="548640"/>
+          </a:xfrm>
+          <a:prstGeom prst="roundRect">
+            <a:avLst>
+              <a:gd name="adj" fmla="val 13333"/>
+            </a:avLst>
+          </a:prstGeom>
+          <a:solidFill>
+            <a:srgbClr val="1F4E4A"/>
+          </a:solidFill>
+          <a:ln/>
+        </p:spPr>
+      </p:sp>
+      <p:sp>
+        <p:nvSpPr>
+          <p:cNvPr id="10" name="Text 8"/>
+          <p:cNvSpPr txBox="1"/>
+          <p:nvPr/>
+        </p:nvSpPr>
+        <p:spPr>
+          <a:xfrm>
+            <a:off x="6766560" y="1188720"/>
+            <a:ext cx="1920240" cy="548640"/>
+          </a:xfrm>
+          <a:prstGeom prst="rect">
+            <a:avLst/>
+          </a:prstGeom>
+          <a:noFill/>
+          <a:ln/>
+        </p:spPr>
+        <p:txBody>
+          <a:bodyPr wrap="square" lIns="0" tIns="0" rIns="0" bIns="0" rtlCol="0" anchor="ctr"/>
+          <a:lstStyle/>
+          <a:p>
+            <a:pPr algn="ctr" indent="0" marL="0">
+              <a:buNone/>
+            </a:pPr>
+            <a:r>
+              <a:rPr lang="en-US" sz="1400" b="1" dirty="0">
+                <a:solidFill>
+                  <a:schemeClr val="bg1"/>
+                </a:solidFill>
+              </a:rPr>
+              <a:t>4. 제재·개선</a:t>
+            </a:r>
+            <a:endParaRPr lang="en-US" sz="1400" dirty="0"/>
+          </a:p>
+        </p:txBody>
+      </p:sp>
+      <p:sp>
+        <p:nvSpPr>
+          <p:cNvPr id="11" name="card"/>
+          <p:cNvSpPr/>
+          <p:nvPr/>
+        </p:nvSpPr>
+        <p:spPr>
+          <a:xfrm>
+            <a:off x="457200" y="1965960"/>
+            <a:ext cx="4023360" cy="2423160"/>
+          </a:xfrm>
+          <a:prstGeom prst="roundRect">
+            <a:avLst>
+              <a:gd name="adj" fmla="val 3019"/>
+            </a:avLst>
+          </a:prstGeom>
+          <a:solidFill>
+            <a:schemeClr val="bg2"/>
+          </a:solidFill>
+          <a:ln/>
+        </p:spPr>
+      </p:sp>
+      <p:sp>
+        <p:nvSpPr>
+          <p:cNvPr id="12" name="Text 10"/>
+          <p:cNvSpPr txBox="1"/>
+          <p:nvPr/>
+        </p:nvSpPr>
+        <p:spPr>
+          <a:xfrm>
+            <a:off x="685800" y="2057400"/>
+            <a:ext cx="3566160" cy="365760"/>
+          </a:xfrm>
+          <a:prstGeom prst="rect">
+            <a:avLst/>
+          </a:prstGeom>
+          <a:noFill/>
+          <a:ln/>
+        </p:spPr>
+        <p:txBody>
+          <a:bodyPr wrap="square" lIns="0" tIns="0" rIns="0" bIns="0" rtlCol="0" anchor="t"/>
+          <a:lstStyle/>
+          <a:p>
+            <a:pPr indent="0" marL="0">
+              <a:buNone/>
+            </a:pPr>
+            <a:r>
+              <a:rPr lang="en-US" sz="1600" b="1" dirty="0">
+                <a:solidFill>
+                  <a:schemeClr val="accent2"/>
+                </a:solidFill>
+              </a:rPr>
+              <a:t>서비스</a:t>
+            </a:r>
+            <a:endParaRPr lang="en-US" sz="1600" dirty="0"/>
+          </a:p>
+        </p:txBody>
+      </p:sp>
+      <p:sp>
+        <p:nvSpPr>
+          <p:cNvPr id="13" name="Text 11"/>
+          <p:cNvSpPr txBox="1"/>
+          <p:nvPr/>
+        </p:nvSpPr>
+        <p:spPr>
+          <a:xfrm>
+            <a:off x="685800" y="2468880"/>
+            <a:ext cx="3657600" cy="1828800"/>
+          </a:xfrm>
+          <a:prstGeom prst="rect">
+            <a:avLst/>
+          </a:prstGeom>
+          <a:noFill/>
+          <a:ln/>
+        </p:spPr>
+        <p:txBody>
+          <a:bodyPr wrap="square" lIns="0" tIns="0" rIns="0" bIns="0" rtlCol="0" anchor="t"/>
+          <a:lstStyle/>
+          <a:p>
+            <a:pPr marL="342900" indent="-342900">
+              <a:spcAft>
+                <a:spcPts val="600"/>
+              </a:spcAft>
+              <a:buSzPct val="100000"/>
+              <a:buChar char="•"/>
+            </a:pPr>
+            <a:r>
+              <a:rPr lang="en-US" sz="1200" dirty="0">
+                <a:solidFill>
+                  <a:schemeClr val="tx1"/>
+                </a:solidFill>
+              </a:rPr>
+              <a:t>혜택은 첫 구매 확정 후 · 1인(본인인증) 기준</a:t>
+            </a:r>
+            <a:endParaRPr lang="en-US" sz="1200" dirty="0"/>
+          </a:p>
+          <a:p>
+            <a:pPr marL="342900" indent="-342900">
+              <a:spcAft>
+                <a:spcPts val="600"/>
+              </a:spcAft>
+              <a:buSzPct val="100000"/>
+              <a:buChar char="•"/>
+            </a:pPr>
+            <a:r>
+              <a:rPr lang="en-US" sz="1200" dirty="0">
+                <a:solidFill>
+                  <a:schemeClr val="tx1"/>
+                </a:solidFill>
+              </a:rPr>
+              <a:t>봇 차단 · 속도 제한 · 유출 비번 거절</a:t>
+            </a:r>
+            <a:endParaRPr lang="en-US" sz="1200" dirty="0"/>
+          </a:p>
+          <a:p>
+            <a:pPr marL="342900" indent="-342900">
+              <a:spcAft>
+                <a:spcPts val="600"/>
+              </a:spcAft>
+              <a:buSzPct val="100000"/>
+              <a:buChar char="•"/>
+            </a:pPr>
+            <a:r>
+              <a:rPr lang="en-US" sz="1200" dirty="0">
+                <a:solidFill>
+                  <a:schemeClr val="tx1"/>
+                </a:solidFill>
+              </a:rPr>
+              <a:t>계정 탈취엔 2단계 인증이 최고 (OWASP)</a:t>
+            </a:r>
+            <a:endParaRPr lang="en-US" sz="1200" dirty="0"/>
+          </a:p>
+          <a:p>
+            <a:pPr marL="342900" indent="-342900">
+              <a:spcAft>
+                <a:spcPts val="600"/>
+              </a:spcAft>
+              <a:buSzPct val="100000"/>
+              <a:buChar char="•"/>
+            </a:pPr>
+            <a:r>
+              <a:rPr lang="en-US" sz="1200" dirty="0">
+                <a:solidFill>
+                  <a:schemeClr val="tx1"/>
+                </a:solidFill>
+              </a:rPr>
+              <a:t>같은 기기·결제수단·주소 묶음 탐지</a:t>
+            </a:r>
+            <a:endParaRPr lang="en-US" sz="1200" dirty="0"/>
+          </a:p>
+        </p:txBody>
+      </p:sp>
+      <p:sp>
+        <p:nvSpPr>
+          <p:cNvPr id="14" name="card"/>
+          <p:cNvSpPr/>
+          <p:nvPr/>
+        </p:nvSpPr>
+        <p:spPr>
+          <a:xfrm>
+            <a:off x="4663440" y="1965960"/>
+            <a:ext cx="4023360" cy="2423160"/>
+          </a:xfrm>
+          <a:prstGeom prst="roundRect">
+            <a:avLst>
+              <a:gd name="adj" fmla="val 3019"/>
+            </a:avLst>
+          </a:prstGeom>
+          <a:solidFill>
+            <a:schemeClr val="bg2"/>
+          </a:solidFill>
+          <a:ln/>
+        </p:spPr>
+      </p:sp>
+      <p:sp>
+        <p:nvSpPr>
+          <p:cNvPr id="15" name="Text 13"/>
+          <p:cNvSpPr txBox="1"/>
+          <p:nvPr/>
+        </p:nvSpPr>
+        <p:spPr>
+          <a:xfrm>
+            <a:off x="4892040" y="2057400"/>
+            <a:ext cx="3566160" cy="365760"/>
+          </a:xfrm>
+          <a:prstGeom prst="rect">
+            <a:avLst/>
+          </a:prstGeom>
+          <a:noFill/>
+          <a:ln/>
+        </p:spPr>
+        <p:txBody>
+          <a:bodyPr wrap="square" lIns="0" tIns="0" rIns="0" bIns="0" rtlCol="0" anchor="t"/>
+          <a:lstStyle/>
+          <a:p>
+            <a:pPr indent="0" marL="0">
+              <a:buNone/>
+            </a:pPr>
+            <a:r>
+              <a:rPr lang="en-US" sz="1600" b="1" dirty="0">
+                <a:solidFill>
+                  <a:schemeClr val="accent2"/>
+                </a:solidFill>
+              </a:rPr>
+              <a:t>게임</a:t>
+            </a:r>
+            <a:endParaRPr lang="en-US" sz="1600" dirty="0"/>
+          </a:p>
+        </p:txBody>
+      </p:sp>
+      <p:sp>
+        <p:nvSpPr>
+          <p:cNvPr id="16" name="Text 14"/>
+          <p:cNvSpPr txBox="1"/>
+          <p:nvPr/>
+        </p:nvSpPr>
+        <p:spPr>
+          <a:xfrm>
+            <a:off x="4892040" y="2468880"/>
+            <a:ext cx="3657600" cy="1828800"/>
+          </a:xfrm>
+          <a:prstGeom prst="rect">
+            <a:avLst/>
+          </a:prstGeom>
+          <a:noFill/>
+          <a:ln/>
+        </p:spPr>
+        <p:txBody>
+          <a:bodyPr wrap="square" lIns="0" tIns="0" rIns="0" bIns="0" rtlCol="0" anchor="t"/>
+          <a:lstStyle/>
+          <a:p>
+            <a:pPr marL="342900" indent="-342900">
+              <a:spcAft>
+                <a:spcPts val="600"/>
+              </a:spcAft>
+              <a:buSzPct val="100000"/>
+              <a:buChar char="•"/>
+            </a:pPr>
+            <a:r>
+              <a:rPr lang="en-US" sz="1200" dirty="0">
+                <a:solidFill>
+                  <a:schemeClr val="tx1"/>
+                </a:solidFill>
+              </a:rPr>
+              <a:t>서버 권위 · 보이는 정보만 전송</a:t>
+            </a:r>
+            <a:endParaRPr lang="en-US" sz="1200" dirty="0"/>
+          </a:p>
+          <a:p>
+            <a:pPr marL="342900" indent="-342900">
+              <a:spcAft>
+                <a:spcPts val="600"/>
+              </a:spcAft>
+              <a:buSzPct val="100000"/>
+              <a:buChar char="•"/>
+            </a:pPr>
+            <a:r>
+              <a:rPr lang="en-US" sz="1200" dirty="0">
+                <a:solidFill>
+                  <a:schemeClr val="tx1"/>
+                </a:solidFill>
+              </a:rPr>
+              <a:t>안티치트 (예: Riot 뱅가드, 부팅 시 시작)</a:t>
+            </a:r>
+            <a:endParaRPr lang="en-US" sz="1200" dirty="0"/>
+          </a:p>
+          <a:p>
+            <a:pPr marL="342900" indent="-342900">
+              <a:spcAft>
+                <a:spcPts val="600"/>
+              </a:spcAft>
+              <a:buSzPct val="100000"/>
+              <a:buChar char="•"/>
+            </a:pPr>
+            <a:r>
+              <a:rPr lang="en-US" sz="1200" dirty="0">
+                <a:solidFill>
+                  <a:schemeClr val="tx1"/>
+                </a:solidFill>
+              </a:rPr>
+              <a:t>비정상 명중률·재화 증가 탐지 · 신고·리플레이</a:t>
+            </a:r>
+            <a:endParaRPr lang="en-US" sz="1200" dirty="0"/>
+          </a:p>
+          <a:p>
+            <a:pPr marL="342900" indent="-342900">
+              <a:spcAft>
+                <a:spcPts val="600"/>
+              </a:spcAft>
+              <a:buSzPct val="100000"/>
+              <a:buChar char="•"/>
+            </a:pPr>
+            <a:r>
+              <a:rPr lang="en-US" sz="1200" dirty="0">
+                <a:solidFill>
+                  <a:schemeClr val="tx1"/>
+                </a:solidFill>
+              </a:rPr>
+              <a:t>핵 제작·유통, 대리 게임 업은 법적 처벌</a:t>
+            </a:r>
+            <a:endParaRPr lang="en-US" sz="1200" dirty="0"/>
+          </a:p>
+        </p:txBody>
+      </p:sp>
+      <p:sp>
+        <p:nvSpPr>
+          <p:cNvPr id="17" name="Text 15"/>
+          <p:cNvSpPr txBox="1"/>
+          <p:nvPr/>
+        </p:nvSpPr>
+        <p:spPr>
+          <a:xfrm>
+            <a:off x="457200" y="4645152"/>
+            <a:ext cx="7680960" cy="274320"/>
+          </a:xfrm>
+          <a:prstGeom prst="rect">
+            <a:avLst/>
+          </a:prstGeom>
+          <a:noFill/>
+          <a:ln/>
+        </p:spPr>
+        <p:txBody>
+          <a:bodyPr wrap="square" lIns="0" tIns="0" rIns="0" bIns="0" rtlCol="0" anchor="t"/>
+          <a:lstStyle/>
+          <a:p>
+            <a:pPr indent="0" marL="0">
+              <a:buNone/>
+            </a:pPr>
+            <a:r>
+              <a:rPr lang="en-US" sz="1000" dirty="0">
+                <a:solidFill>
+                  <a:schemeClr val="accent4"/>
+                </a:solidFill>
+              </a:rPr>
+              <a:t>목표는 완벽 차단이 아니라 "악용 비용 &gt; 얻는 이익" · 억울한 제재를 위한 이의 제기 창구 (41장)</a:t>
+            </a:r>
+            <a:endParaRPr lang="en-US" sz="1000" dirty="0"/>
+          </a:p>
+        </p:txBody>
+      </p:sp>
+      <p:sp>
+        <p:nvSpPr>
+          <p:cNvPr id="25" name="Slide Number Placeholder 0"/>
+          <p:cNvSpPr>
+            <a:spLocks noGrp="1"/>
+          </p:cNvSpPr>
+          <p:nvPr>
+            <p:ph type="sldNum" sz="quarter" idx="4294967295"/>
+          </p:nvPr>
+        </p:nvSpPr>
+        <p:spPr>
+          <a:xfrm>
+            <a:off x="8321040" y="4754880"/>
+            <a:ext cx="457200" cy="274320"/>
+          </a:xfrm>
+          <a:prstGeom prst="rect">
+            <a:avLst/>
+          </a:prstGeom>
+          <a:extLst>
+            <a:ext uri="{C572A759-6A51-4108-AA02-DFA0A04FC94B}">
+              <ma14:wrappingTextBoxFlag xmlns:ma14="http://schemas.microsoft.com/office/mac/drawingml/2011/main" val="0"/>
+            </a:ext>
+          </a:extLst>
+        </p:spPr>
+        <p:txBody>
+          <a:bodyPr/>
+          <a:lstStyle>
+            <a:lvl1pPr>
+              <a:defRPr sz="1000">
+                <a:solidFill>
+                  <a:schemeClr val="accent4"/>
+                </a:solidFill>
+              </a:defRPr>
+            </a:lvl1pPr>
+          </a:lstStyle>
+          <a:p>
+            <a:pPr algn="r"/>
+            <a:fld id="{F7021451-1387-4CA6-816F-3879F97B5CBC}" type="slidenum">
+              <a:rPr b="0" lang="en-US"/>
+              <a:t>65</a:t>
+            </a:fld>
+            <a:endParaRPr lang="en-US"/>
+          </a:p>
+        </p:txBody>
+      </p:sp>
+    </p:spTree>
+  </p:cSld>
+  <p:clrMapOvr>
+    <a:masterClrMapping/>
+  </p:clrMapOvr>
+</p:sld>
+</file>
+
+<file path=ppt/slides/slide66.xml><?xml version="1.0" encoding="utf-8"?>
+<p:sld xmlns:a="http://schemas.openxmlformats.org/drawingml/2006/main" xmlns:r="http://schemas.openxmlformats.org/officeDocument/2006/relationships" xmlns:p="http://schemas.openxmlformats.org/presentationml/2006/main">
+  <p:cSld name="Slide 66">
+    <p:spTree>
+      <p:nvGrpSpPr>
+        <p:cNvPr id="1" name=""/>
+        <p:cNvGrpSpPr/>
+        <p:nvPr/>
+      </p:nvGrpSpPr>
+      <p:grpSpPr>
+        <a:xfrm>
+          <a:off x="0" y="0"/>
+          <a:ext cx="0" cy="0"/>
+          <a:chOff x="0" y="0"/>
+          <a:chExt cx="0" cy="0"/>
+        </a:xfrm>
+      </p:grpSpPr>
+      <p:sp>
+        <p:nvSpPr>
+          <p:cNvPr id="2" name="Text 0"/>
+          <p:cNvSpPr/>
+          <p:nvPr>
+            <p:ph idx="100" type="title" hasCustomPrompt="1"/>
+          </p:nvPr>
+        </p:nvSpPr>
+        <p:spPr>
+          <a:xfrm>
+            <a:off x="548640" y="1371600"/>
+            <a:ext cx="8046720" cy="1280160"/>
+          </a:xfrm>
+          <a:prstGeom prst="rect">
+            <a:avLst/>
+          </a:prstGeom>
+          <a:noFill/>
+          <a:ln/>
+        </p:spPr>
+        <p:txBody>
+          <a:bodyPr wrap="square" lIns="0" tIns="0" rIns="0" bIns="0" rtlCol="0" anchor="b"/>
+          <a:lstStyle/>
+          <a:p>
+            <a:pPr algn="l" indent="0" marL="0">
+              <a:buNone/>
+            </a:pPr>
+            <a:r>
+              <a:rPr lang="en-US" sz="4000" b="1" dirty="0">
+                <a:solidFill>
+                  <a:schemeClr val="bg1"/>
+                </a:solidFill>
+              </a:rPr>
               <a:t>안전하게, 자주 반복하기</a:t>
             </a:r>
             <a:endParaRPr lang="en-US" sz="4000" dirty="0"/>

</xml_diff>